<commit_message>
Update wolfson.pptx with architecture slides; add architecture.pdf
Co-Authored-By: Claude Sonnet 4.6 <noreply@anthropic.com>
</commit_message>
<xml_diff>
--- a/docs/wolfson.pptx
+++ b/docs/wolfson.pptx
@@ -3,17 +3,20 @@
 <p:presentation xmlns:a="http://schemas.openxmlformats.org/drawingml/2006/main" xmlns:r="http://schemas.openxmlformats.org/officeDocument/2006/relationships" xmlns:p="http://schemas.openxmlformats.org/presentationml/2006/main" saveSubsetFonts="1" autoCompressPictures="0">
   <p:sldMasterIdLst>
     <p:sldMasterId id="2147483648" r:id="rId1"/>
+    <p:sldMasterId id="2147483660" r:id="rId2"/>
   </p:sldMasterIdLst>
   <p:notesMasterIdLst>
-    <p:notesMasterId r:id="rId8"/>
+    <p:notesMasterId r:id="rId11"/>
   </p:notesMasterIdLst>
   <p:sldIdLst>
-    <p:sldId id="256" r:id="rId2"/>
-    <p:sldId id="257" r:id="rId3"/>
-    <p:sldId id="259" r:id="rId4"/>
-    <p:sldId id="258" r:id="rId5"/>
-    <p:sldId id="260" r:id="rId6"/>
-    <p:sldId id="261" r:id="rId7"/>
+    <p:sldId id="256" r:id="rId3"/>
+    <p:sldId id="257" r:id="rId4"/>
+    <p:sldId id="259" r:id="rId5"/>
+    <p:sldId id="258" r:id="rId6"/>
+    <p:sldId id="262" r:id="rId7"/>
+    <p:sldId id="263" r:id="rId8"/>
+    <p:sldId id="260" r:id="rId9"/>
+    <p:sldId id="261" r:id="rId10"/>
   </p:sldIdLst>
   <p:sldSz cx="12192000" cy="6858000"/>
   <p:notesSz cx="6858000" cy="9144000"/>
@@ -845,7 +848,7 @@
           <a:bodyPr/>
           <a:lstStyle/>
           <a:p>
-            <a:endParaRPr lang="en-US"/>
+            <a:endParaRPr lang="en-US" dirty="0"/>
           </a:p>
         </p:txBody>
       </p:sp>
@@ -856,7 +859,7 @@
             <a:spLocks noGrp="1"/>
           </p:cNvSpPr>
           <p:nvPr>
-            <p:ph type="sldNum" sz="quarter" idx="5"/>
+            <p:ph type="sldNum" sz="quarter" idx="10"/>
           </p:nvPr>
         </p:nvSpPr>
         <p:spPr/>
@@ -864,18 +867,78 @@
           <a:bodyPr/>
           <a:lstStyle/>
           <a:p>
-            <a:fld id="{F4125BD8-DB9E-B04B-ACC5-175F26D74AAD}" type="slidenum">
-              <a:rPr lang="en-US" smtClean="0"/>
+            <a:pPr marL="0" marR="0" lvl="0" indent="0" algn="l" defTabSz="914400" rtl="0" eaLnBrk="1" fontAlgn="auto" latinLnBrk="0" hangingPunct="1">
+              <a:lnSpc>
+                <a:spcPct val="100000"/>
+              </a:lnSpc>
+              <a:spcBef>
+                <a:spcPts val="0"/>
+              </a:spcBef>
+              <a:spcAft>
+                <a:spcPts val="0"/>
+              </a:spcAft>
+              <a:buClrTx/>
+              <a:buSzTx/>
+              <a:buFontTx/>
+              <a:buNone/>
+              <a:tabLst/>
+              <a:defRPr/>
+            </a:pPr>
+            <a:fld id="{F7021451-1387-4CA6-816F-3879F97B5CBC}" type="slidenum">
+              <a:rPr kumimoji="0" lang="en-US" sz="1800" b="0" i="0" u="none" strike="noStrike" kern="1200" cap="none" spc="0" normalizeH="0" baseline="0" noProof="0">
+                <a:ln>
+                  <a:noFill/>
+                </a:ln>
+                <a:solidFill>
+                  <a:prstClr val="black"/>
+                </a:solidFill>
+                <a:effectLst/>
+                <a:uLnTx/>
+                <a:uFillTx/>
+                <a:latin typeface="Aptos" panose="02110004020202020204"/>
+                <a:ea typeface="+mn-ea"/>
+                <a:cs typeface="+mn-cs"/>
+              </a:rPr>
+              <a:pPr marL="0" marR="0" lvl="0" indent="0" algn="l" defTabSz="914400" rtl="0" eaLnBrk="1" fontAlgn="auto" latinLnBrk="0" hangingPunct="1">
+                <a:lnSpc>
+                  <a:spcPct val="100000"/>
+                </a:lnSpc>
+                <a:spcBef>
+                  <a:spcPts val="0"/>
+                </a:spcBef>
+                <a:spcAft>
+                  <a:spcPts val="0"/>
+                </a:spcAft>
+                <a:buClrTx/>
+                <a:buSzTx/>
+                <a:buFontTx/>
+                <a:buNone/>
+                <a:tabLst/>
+                <a:defRPr/>
+              </a:pPr>
               <a:t>5</a:t>
             </a:fld>
-            <a:endParaRPr lang="en-US"/>
+            <a:endParaRPr kumimoji="0" lang="en-US" sz="1800" b="0" i="0" u="none" strike="noStrike" kern="1200" cap="none" spc="0" normalizeH="0" baseline="0" noProof="0">
+              <a:ln>
+                <a:noFill/>
+              </a:ln>
+              <a:solidFill>
+                <a:prstClr val="black"/>
+              </a:solidFill>
+              <a:effectLst/>
+              <a:uLnTx/>
+              <a:uFillTx/>
+              <a:latin typeface="Aptos" panose="02110004020202020204"/>
+              <a:ea typeface="+mn-ea"/>
+              <a:cs typeface="+mn-cs"/>
+            </a:endParaRPr>
           </a:p>
         </p:txBody>
       </p:sp>
     </p:spTree>
     <p:extLst>
       <p:ext uri="{BB962C8B-B14F-4D97-AF65-F5344CB8AC3E}">
-        <p14:creationId xmlns:p14="http://schemas.microsoft.com/office/powerpoint/2010/main" val="2170957319"/>
+        <p14:creationId xmlns:p14="http://schemas.microsoft.com/office/powerpoint/2010/main" val="1024086991"/>
       </p:ext>
     </p:extLst>
   </p:cSld>
@@ -929,6 +992,150 @@
           <a:bodyPr/>
           <a:lstStyle/>
           <a:p>
+            <a:endParaRPr lang="en-US" dirty="0"/>
+          </a:p>
+        </p:txBody>
+      </p:sp>
+      <p:sp>
+        <p:nvSpPr>
+          <p:cNvPr id="4" name="Slide Number Placeholder 3"/>
+          <p:cNvSpPr>
+            <a:spLocks noGrp="1"/>
+          </p:cNvSpPr>
+          <p:nvPr>
+            <p:ph type="sldNum" sz="quarter" idx="10"/>
+          </p:nvPr>
+        </p:nvSpPr>
+        <p:spPr/>
+        <p:txBody>
+          <a:bodyPr/>
+          <a:lstStyle/>
+          <a:p>
+            <a:pPr marL="0" marR="0" lvl="0" indent="0" algn="l" defTabSz="914400" rtl="0" eaLnBrk="1" fontAlgn="auto" latinLnBrk="0" hangingPunct="1">
+              <a:lnSpc>
+                <a:spcPct val="100000"/>
+              </a:lnSpc>
+              <a:spcBef>
+                <a:spcPts val="0"/>
+              </a:spcBef>
+              <a:spcAft>
+                <a:spcPts val="0"/>
+              </a:spcAft>
+              <a:buClrTx/>
+              <a:buSzTx/>
+              <a:buFontTx/>
+              <a:buNone/>
+              <a:tabLst/>
+              <a:defRPr/>
+            </a:pPr>
+            <a:fld id="{F7021451-1387-4CA6-816F-3879F97B5CBC}" type="slidenum">
+              <a:rPr kumimoji="0" lang="en-US" sz="1800" b="0" i="0" u="none" strike="noStrike" kern="1200" cap="none" spc="0" normalizeH="0" baseline="0" noProof="0">
+                <a:ln>
+                  <a:noFill/>
+                </a:ln>
+                <a:solidFill>
+                  <a:prstClr val="black"/>
+                </a:solidFill>
+                <a:effectLst/>
+                <a:uLnTx/>
+                <a:uFillTx/>
+                <a:latin typeface="Aptos" panose="02110004020202020204"/>
+                <a:ea typeface="+mn-ea"/>
+                <a:cs typeface="+mn-cs"/>
+              </a:rPr>
+              <a:pPr marL="0" marR="0" lvl="0" indent="0" algn="l" defTabSz="914400" rtl="0" eaLnBrk="1" fontAlgn="auto" latinLnBrk="0" hangingPunct="1">
+                <a:lnSpc>
+                  <a:spcPct val="100000"/>
+                </a:lnSpc>
+                <a:spcBef>
+                  <a:spcPts val="0"/>
+                </a:spcBef>
+                <a:spcAft>
+                  <a:spcPts val="0"/>
+                </a:spcAft>
+                <a:buClrTx/>
+                <a:buSzTx/>
+                <a:buFontTx/>
+                <a:buNone/>
+                <a:tabLst/>
+                <a:defRPr/>
+              </a:pPr>
+              <a:t>6</a:t>
+            </a:fld>
+            <a:endParaRPr kumimoji="0" lang="en-US" sz="1800" b="0" i="0" u="none" strike="noStrike" kern="1200" cap="none" spc="0" normalizeH="0" baseline="0" noProof="0">
+              <a:ln>
+                <a:noFill/>
+              </a:ln>
+              <a:solidFill>
+                <a:prstClr val="black"/>
+              </a:solidFill>
+              <a:effectLst/>
+              <a:uLnTx/>
+              <a:uFillTx/>
+              <a:latin typeface="Aptos" panose="02110004020202020204"/>
+              <a:ea typeface="+mn-ea"/>
+              <a:cs typeface="+mn-cs"/>
+            </a:endParaRPr>
+          </a:p>
+        </p:txBody>
+      </p:sp>
+    </p:spTree>
+    <p:extLst>
+      <p:ext uri="{BB962C8B-B14F-4D97-AF65-F5344CB8AC3E}">
+        <p14:creationId xmlns:p14="http://schemas.microsoft.com/office/powerpoint/2010/main" val="1024086991"/>
+      </p:ext>
+    </p:extLst>
+  </p:cSld>
+  <p:clrMapOvr>
+    <a:masterClrMapping/>
+  </p:clrMapOvr>
+</p:notes>
+</file>
+
+<file path=ppt/notesSlides/notesSlide7.xml><?xml version="1.0" encoding="utf-8"?>
+<p:notes xmlns:a="http://schemas.openxmlformats.org/drawingml/2006/main" xmlns:r="http://schemas.openxmlformats.org/officeDocument/2006/relationships" xmlns:p="http://schemas.openxmlformats.org/presentationml/2006/main">
+  <p:cSld>
+    <p:spTree>
+      <p:nvGrpSpPr>
+        <p:cNvPr id="1" name=""/>
+        <p:cNvGrpSpPr/>
+        <p:nvPr/>
+      </p:nvGrpSpPr>
+      <p:grpSpPr>
+        <a:xfrm>
+          <a:off x="0" y="0"/>
+          <a:ext cx="0" cy="0"/>
+          <a:chOff x="0" y="0"/>
+          <a:chExt cx="0" cy="0"/>
+        </a:xfrm>
+      </p:grpSpPr>
+      <p:sp>
+        <p:nvSpPr>
+          <p:cNvPr id="2" name="Slide Image Placeholder 1"/>
+          <p:cNvSpPr>
+            <a:spLocks noGrp="1" noRot="1" noChangeAspect="1"/>
+          </p:cNvSpPr>
+          <p:nvPr>
+            <p:ph type="sldImg"/>
+          </p:nvPr>
+        </p:nvSpPr>
+        <p:spPr/>
+      </p:sp>
+      <p:sp>
+        <p:nvSpPr>
+          <p:cNvPr id="3" name="Notes Placeholder 2"/>
+          <p:cNvSpPr>
+            <a:spLocks noGrp="1"/>
+          </p:cNvSpPr>
+          <p:nvPr>
+            <p:ph type="body" idx="1"/>
+          </p:nvPr>
+        </p:nvSpPr>
+        <p:spPr/>
+        <p:txBody>
+          <a:bodyPr/>
+          <a:lstStyle/>
+          <a:p>
             <a:endParaRPr lang="en-US"/>
           </a:p>
         </p:txBody>
@@ -950,7 +1157,91 @@
           <a:p>
             <a:fld id="{F4125BD8-DB9E-B04B-ACC5-175F26D74AAD}" type="slidenum">
               <a:rPr lang="en-US" smtClean="0"/>
-              <a:t>6</a:t>
+              <a:t>7</a:t>
+            </a:fld>
+            <a:endParaRPr lang="en-US"/>
+          </a:p>
+        </p:txBody>
+      </p:sp>
+    </p:spTree>
+    <p:extLst>
+      <p:ext uri="{BB962C8B-B14F-4D97-AF65-F5344CB8AC3E}">
+        <p14:creationId xmlns:p14="http://schemas.microsoft.com/office/powerpoint/2010/main" val="2170957319"/>
+      </p:ext>
+    </p:extLst>
+  </p:cSld>
+  <p:clrMapOvr>
+    <a:masterClrMapping/>
+  </p:clrMapOvr>
+</p:notes>
+</file>
+
+<file path=ppt/notesSlides/notesSlide8.xml><?xml version="1.0" encoding="utf-8"?>
+<p:notes xmlns:a="http://schemas.openxmlformats.org/drawingml/2006/main" xmlns:r="http://schemas.openxmlformats.org/officeDocument/2006/relationships" xmlns:p="http://schemas.openxmlformats.org/presentationml/2006/main">
+  <p:cSld>
+    <p:spTree>
+      <p:nvGrpSpPr>
+        <p:cNvPr id="1" name=""/>
+        <p:cNvGrpSpPr/>
+        <p:nvPr/>
+      </p:nvGrpSpPr>
+      <p:grpSpPr>
+        <a:xfrm>
+          <a:off x="0" y="0"/>
+          <a:ext cx="0" cy="0"/>
+          <a:chOff x="0" y="0"/>
+          <a:chExt cx="0" cy="0"/>
+        </a:xfrm>
+      </p:grpSpPr>
+      <p:sp>
+        <p:nvSpPr>
+          <p:cNvPr id="2" name="Slide Image Placeholder 1"/>
+          <p:cNvSpPr>
+            <a:spLocks noGrp="1" noRot="1" noChangeAspect="1"/>
+          </p:cNvSpPr>
+          <p:nvPr>
+            <p:ph type="sldImg"/>
+          </p:nvPr>
+        </p:nvSpPr>
+        <p:spPr/>
+      </p:sp>
+      <p:sp>
+        <p:nvSpPr>
+          <p:cNvPr id="3" name="Notes Placeholder 2"/>
+          <p:cNvSpPr>
+            <a:spLocks noGrp="1"/>
+          </p:cNvSpPr>
+          <p:nvPr>
+            <p:ph type="body" idx="1"/>
+          </p:nvPr>
+        </p:nvSpPr>
+        <p:spPr/>
+        <p:txBody>
+          <a:bodyPr/>
+          <a:lstStyle/>
+          <a:p>
+            <a:endParaRPr lang="en-US"/>
+          </a:p>
+        </p:txBody>
+      </p:sp>
+      <p:sp>
+        <p:nvSpPr>
+          <p:cNvPr id="4" name="Slide Number Placeholder 3"/>
+          <p:cNvSpPr>
+            <a:spLocks noGrp="1"/>
+          </p:cNvSpPr>
+          <p:nvPr>
+            <p:ph type="sldNum" sz="quarter" idx="5"/>
+          </p:nvPr>
+        </p:nvSpPr>
+        <p:spPr/>
+        <p:txBody>
+          <a:bodyPr/>
+          <a:lstStyle/>
+          <a:p>
+            <a:fld id="{F4125BD8-DB9E-B04B-ACC5-175F26D74AAD}" type="slidenum">
+              <a:rPr lang="en-US" smtClean="0"/>
+              <a:t>8</a:t>
             </a:fld>
             <a:endParaRPr lang="en-US"/>
           </a:p>
@@ -1592,6 +1883,41 @@
     <p:extLst>
       <p:ext uri="{BB962C8B-B14F-4D97-AF65-F5344CB8AC3E}">
         <p14:creationId xmlns:p14="http://schemas.microsoft.com/office/powerpoint/2010/main" val="944070570"/>
+      </p:ext>
+    </p:extLst>
+  </p:cSld>
+  <p:clrMapOvr>
+    <a:masterClrMapping/>
+  </p:clrMapOvr>
+</p:sldLayout>
+</file>
+
+<file path=ppt/slideLayouts/slideLayout12.xml><?xml version="1.0" encoding="utf-8"?>
+<p:sldLayout xmlns:a="http://schemas.openxmlformats.org/drawingml/2006/main" xmlns:r="http://schemas.openxmlformats.org/officeDocument/2006/relationships" xmlns:p="http://schemas.openxmlformats.org/presentationml/2006/main" preserve="1">
+  <p:cSld name="DEFAULT">
+    <p:bg>
+      <p:bgRef idx="1001">
+        <a:schemeClr val="bg1"/>
+      </p:bgRef>
+    </p:bg>
+    <p:spTree>
+      <p:nvGrpSpPr>
+        <p:cNvPr id="1" name=""/>
+        <p:cNvGrpSpPr/>
+        <p:nvPr/>
+      </p:nvGrpSpPr>
+      <p:grpSpPr>
+        <a:xfrm>
+          <a:off x="0" y="0"/>
+          <a:ext cx="0" cy="0"/>
+          <a:chOff x="0" y="0"/>
+          <a:chExt cx="0" cy="0"/>
+        </a:xfrm>
+      </p:grpSpPr>
+    </p:spTree>
+    <p:extLst>
+      <p:ext uri="{BB962C8B-B14F-4D97-AF65-F5344CB8AC3E}">
+        <p14:creationId xmlns:p14="http://schemas.microsoft.com/office/powerpoint/2010/main" val="3418577878"/>
       </p:ext>
     </p:extLst>
   </p:cSld>
@@ -4187,6 +4513,293 @@
 </p:sldMaster>
 </file>
 
+<file path=ppt/slideMasters/slideMaster2.xml><?xml version="1.0" encoding="utf-8"?>
+<p:sldMaster xmlns:a="http://schemas.openxmlformats.org/drawingml/2006/main" xmlns:r="http://schemas.openxmlformats.org/officeDocument/2006/relationships" xmlns:p="http://schemas.openxmlformats.org/presentationml/2006/main">
+  <p:cSld>
+    <p:bg>
+      <p:bgRef idx="1001">
+        <a:schemeClr val="bg1"/>
+      </p:bgRef>
+    </p:bg>
+    <p:spTree>
+      <p:nvGrpSpPr>
+        <p:cNvPr id="1" name=""/>
+        <p:cNvGrpSpPr/>
+        <p:nvPr/>
+      </p:nvGrpSpPr>
+      <p:grpSpPr>
+        <a:xfrm>
+          <a:off x="0" y="0"/>
+          <a:ext cx="0" cy="0"/>
+          <a:chOff x="0" y="0"/>
+          <a:chExt cx="0" cy="0"/>
+        </a:xfrm>
+      </p:grpSpPr>
+    </p:spTree>
+    <p:extLst>
+      <p:ext uri="{BB962C8B-B14F-4D97-AF65-F5344CB8AC3E}">
+        <p14:creationId xmlns:p14="http://schemas.microsoft.com/office/powerpoint/2010/main" val="3598793217"/>
+      </p:ext>
+    </p:extLst>
+  </p:cSld>
+  <p:clrMap bg1="lt1" tx1="dk1" bg2="lt2" tx2="dk2" accent1="accent1" accent2="accent2" accent3="accent3" accent4="accent4" accent5="accent5" accent6="accent6" hlink="hlink" folHlink="folHlink"/>
+  <p:sldLayoutIdLst>
+    <p:sldLayoutId id="2147483661" r:id="rId1"/>
+  </p:sldLayoutIdLst>
+  <p:hf sldNum="0" hdr="0" ftr="0" dt="0"/>
+  <p:txStyles>
+    <p:titleStyle>
+      <a:lvl1pPr algn="ctr" defTabSz="1219170" rtl="0" eaLnBrk="1" latinLnBrk="0" hangingPunct="1">
+        <a:spcBef>
+          <a:spcPct val="0"/>
+        </a:spcBef>
+        <a:buNone/>
+        <a:defRPr sz="5867" kern="1200">
+          <a:solidFill>
+            <a:schemeClr val="tx1"/>
+          </a:solidFill>
+          <a:latin typeface="+mj-lt"/>
+          <a:ea typeface="+mj-ea"/>
+          <a:cs typeface="+mj-cs"/>
+        </a:defRPr>
+      </a:lvl1pPr>
+    </p:titleStyle>
+    <p:bodyStyle>
+      <a:lvl1pPr marL="457189" indent="-457189" algn="l" defTabSz="1219170" rtl="0" eaLnBrk="1" latinLnBrk="0" hangingPunct="1">
+        <a:spcBef>
+          <a:spcPct val="20000"/>
+        </a:spcBef>
+        <a:buFont typeface="Arial" pitchFamily="34" charset="0"/>
+        <a:buChar char="•"/>
+        <a:defRPr sz="4267" kern="1200">
+          <a:solidFill>
+            <a:schemeClr val="tx1"/>
+          </a:solidFill>
+          <a:latin typeface="+mn-lt"/>
+          <a:ea typeface="+mn-ea"/>
+          <a:cs typeface="+mn-cs"/>
+        </a:defRPr>
+      </a:lvl1pPr>
+      <a:lvl2pPr marL="990575" indent="-380990" algn="l" defTabSz="1219170" rtl="0" eaLnBrk="1" latinLnBrk="0" hangingPunct="1">
+        <a:spcBef>
+          <a:spcPct val="20000"/>
+        </a:spcBef>
+        <a:buFont typeface="Arial" pitchFamily="34" charset="0"/>
+        <a:buChar char="–"/>
+        <a:defRPr sz="3733" kern="1200">
+          <a:solidFill>
+            <a:schemeClr val="tx1"/>
+          </a:solidFill>
+          <a:latin typeface="+mn-lt"/>
+          <a:ea typeface="+mn-ea"/>
+          <a:cs typeface="+mn-cs"/>
+        </a:defRPr>
+      </a:lvl2pPr>
+      <a:lvl3pPr marL="1523962" indent="-304792" algn="l" defTabSz="1219170" rtl="0" eaLnBrk="1" latinLnBrk="0" hangingPunct="1">
+        <a:spcBef>
+          <a:spcPct val="20000"/>
+        </a:spcBef>
+        <a:buFont typeface="Arial" pitchFamily="34" charset="0"/>
+        <a:buChar char="•"/>
+        <a:defRPr sz="3200" kern="1200">
+          <a:solidFill>
+            <a:schemeClr val="tx1"/>
+          </a:solidFill>
+          <a:latin typeface="+mn-lt"/>
+          <a:ea typeface="+mn-ea"/>
+          <a:cs typeface="+mn-cs"/>
+        </a:defRPr>
+      </a:lvl3pPr>
+      <a:lvl4pPr marL="2133547" indent="-304792" algn="l" defTabSz="1219170" rtl="0" eaLnBrk="1" latinLnBrk="0" hangingPunct="1">
+        <a:spcBef>
+          <a:spcPct val="20000"/>
+        </a:spcBef>
+        <a:buFont typeface="Arial" pitchFamily="34" charset="0"/>
+        <a:buChar char="–"/>
+        <a:defRPr sz="2667" kern="1200">
+          <a:solidFill>
+            <a:schemeClr val="tx1"/>
+          </a:solidFill>
+          <a:latin typeface="+mn-lt"/>
+          <a:ea typeface="+mn-ea"/>
+          <a:cs typeface="+mn-cs"/>
+        </a:defRPr>
+      </a:lvl4pPr>
+      <a:lvl5pPr marL="2743131" indent="-304792" algn="l" defTabSz="1219170" rtl="0" eaLnBrk="1" latinLnBrk="0" hangingPunct="1">
+        <a:spcBef>
+          <a:spcPct val="20000"/>
+        </a:spcBef>
+        <a:buFont typeface="Arial" pitchFamily="34" charset="0"/>
+        <a:buChar char="»"/>
+        <a:defRPr sz="2667" kern="1200">
+          <a:solidFill>
+            <a:schemeClr val="tx1"/>
+          </a:solidFill>
+          <a:latin typeface="+mn-lt"/>
+          <a:ea typeface="+mn-ea"/>
+          <a:cs typeface="+mn-cs"/>
+        </a:defRPr>
+      </a:lvl5pPr>
+      <a:lvl6pPr marL="3352716" indent="-304792" algn="l" defTabSz="1219170" rtl="0" eaLnBrk="1" latinLnBrk="0" hangingPunct="1">
+        <a:spcBef>
+          <a:spcPct val="20000"/>
+        </a:spcBef>
+        <a:buFont typeface="Arial" pitchFamily="34" charset="0"/>
+        <a:buChar char="•"/>
+        <a:defRPr sz="2667" kern="1200">
+          <a:solidFill>
+            <a:schemeClr val="tx1"/>
+          </a:solidFill>
+          <a:latin typeface="+mn-lt"/>
+          <a:ea typeface="+mn-ea"/>
+          <a:cs typeface="+mn-cs"/>
+        </a:defRPr>
+      </a:lvl6pPr>
+      <a:lvl7pPr marL="3962301" indent="-304792" algn="l" defTabSz="1219170" rtl="0" eaLnBrk="1" latinLnBrk="0" hangingPunct="1">
+        <a:spcBef>
+          <a:spcPct val="20000"/>
+        </a:spcBef>
+        <a:buFont typeface="Arial" pitchFamily="34" charset="0"/>
+        <a:buChar char="•"/>
+        <a:defRPr sz="2667" kern="1200">
+          <a:solidFill>
+            <a:schemeClr val="tx1"/>
+          </a:solidFill>
+          <a:latin typeface="+mn-lt"/>
+          <a:ea typeface="+mn-ea"/>
+          <a:cs typeface="+mn-cs"/>
+        </a:defRPr>
+      </a:lvl7pPr>
+      <a:lvl8pPr marL="4571886" indent="-304792" algn="l" defTabSz="1219170" rtl="0" eaLnBrk="1" latinLnBrk="0" hangingPunct="1">
+        <a:spcBef>
+          <a:spcPct val="20000"/>
+        </a:spcBef>
+        <a:buFont typeface="Arial" pitchFamily="34" charset="0"/>
+        <a:buChar char="•"/>
+        <a:defRPr sz="2667" kern="1200">
+          <a:solidFill>
+            <a:schemeClr val="tx1"/>
+          </a:solidFill>
+          <a:latin typeface="+mn-lt"/>
+          <a:ea typeface="+mn-ea"/>
+          <a:cs typeface="+mn-cs"/>
+        </a:defRPr>
+      </a:lvl8pPr>
+      <a:lvl9pPr marL="5181470" indent="-304792" algn="l" defTabSz="1219170" rtl="0" eaLnBrk="1" latinLnBrk="0" hangingPunct="1">
+        <a:spcBef>
+          <a:spcPct val="20000"/>
+        </a:spcBef>
+        <a:buFont typeface="Arial" pitchFamily="34" charset="0"/>
+        <a:buChar char="•"/>
+        <a:defRPr sz="2667" kern="1200">
+          <a:solidFill>
+            <a:schemeClr val="tx1"/>
+          </a:solidFill>
+          <a:latin typeface="+mn-lt"/>
+          <a:ea typeface="+mn-ea"/>
+          <a:cs typeface="+mn-cs"/>
+        </a:defRPr>
+      </a:lvl9pPr>
+    </p:bodyStyle>
+    <p:otherStyle>
+      <a:defPPr>
+        <a:defRPr lang="en-US"/>
+      </a:defPPr>
+      <a:lvl1pPr marL="0" algn="l" defTabSz="1219170" rtl="0" eaLnBrk="1" latinLnBrk="0" hangingPunct="1">
+        <a:defRPr sz="2400" kern="1200">
+          <a:solidFill>
+            <a:schemeClr val="tx1"/>
+          </a:solidFill>
+          <a:latin typeface="+mn-lt"/>
+          <a:ea typeface="+mn-ea"/>
+          <a:cs typeface="+mn-cs"/>
+        </a:defRPr>
+      </a:lvl1pPr>
+      <a:lvl2pPr marL="609585" algn="l" defTabSz="1219170" rtl="0" eaLnBrk="1" latinLnBrk="0" hangingPunct="1">
+        <a:defRPr sz="2400" kern="1200">
+          <a:solidFill>
+            <a:schemeClr val="tx1"/>
+          </a:solidFill>
+          <a:latin typeface="+mn-lt"/>
+          <a:ea typeface="+mn-ea"/>
+          <a:cs typeface="+mn-cs"/>
+        </a:defRPr>
+      </a:lvl2pPr>
+      <a:lvl3pPr marL="1219170" algn="l" defTabSz="1219170" rtl="0" eaLnBrk="1" latinLnBrk="0" hangingPunct="1">
+        <a:defRPr sz="2400" kern="1200">
+          <a:solidFill>
+            <a:schemeClr val="tx1"/>
+          </a:solidFill>
+          <a:latin typeface="+mn-lt"/>
+          <a:ea typeface="+mn-ea"/>
+          <a:cs typeface="+mn-cs"/>
+        </a:defRPr>
+      </a:lvl3pPr>
+      <a:lvl4pPr marL="1828754" algn="l" defTabSz="1219170" rtl="0" eaLnBrk="1" latinLnBrk="0" hangingPunct="1">
+        <a:defRPr sz="2400" kern="1200">
+          <a:solidFill>
+            <a:schemeClr val="tx1"/>
+          </a:solidFill>
+          <a:latin typeface="+mn-lt"/>
+          <a:ea typeface="+mn-ea"/>
+          <a:cs typeface="+mn-cs"/>
+        </a:defRPr>
+      </a:lvl4pPr>
+      <a:lvl5pPr marL="2438339" algn="l" defTabSz="1219170" rtl="0" eaLnBrk="1" latinLnBrk="0" hangingPunct="1">
+        <a:defRPr sz="2400" kern="1200">
+          <a:solidFill>
+            <a:schemeClr val="tx1"/>
+          </a:solidFill>
+          <a:latin typeface="+mn-lt"/>
+          <a:ea typeface="+mn-ea"/>
+          <a:cs typeface="+mn-cs"/>
+        </a:defRPr>
+      </a:lvl5pPr>
+      <a:lvl6pPr marL="3047924" algn="l" defTabSz="1219170" rtl="0" eaLnBrk="1" latinLnBrk="0" hangingPunct="1">
+        <a:defRPr sz="2400" kern="1200">
+          <a:solidFill>
+            <a:schemeClr val="tx1"/>
+          </a:solidFill>
+          <a:latin typeface="+mn-lt"/>
+          <a:ea typeface="+mn-ea"/>
+          <a:cs typeface="+mn-cs"/>
+        </a:defRPr>
+      </a:lvl6pPr>
+      <a:lvl7pPr marL="3657509" algn="l" defTabSz="1219170" rtl="0" eaLnBrk="1" latinLnBrk="0" hangingPunct="1">
+        <a:defRPr sz="2400" kern="1200">
+          <a:solidFill>
+            <a:schemeClr val="tx1"/>
+          </a:solidFill>
+          <a:latin typeface="+mn-lt"/>
+          <a:ea typeface="+mn-ea"/>
+          <a:cs typeface="+mn-cs"/>
+        </a:defRPr>
+      </a:lvl7pPr>
+      <a:lvl8pPr marL="4267093" algn="l" defTabSz="1219170" rtl="0" eaLnBrk="1" latinLnBrk="0" hangingPunct="1">
+        <a:defRPr sz="2400" kern="1200">
+          <a:solidFill>
+            <a:schemeClr val="tx1"/>
+          </a:solidFill>
+          <a:latin typeface="+mn-lt"/>
+          <a:ea typeface="+mn-ea"/>
+          <a:cs typeface="+mn-cs"/>
+        </a:defRPr>
+      </a:lvl8pPr>
+      <a:lvl9pPr marL="4876678" algn="l" defTabSz="1219170" rtl="0" eaLnBrk="1" latinLnBrk="0" hangingPunct="1">
+        <a:defRPr sz="2400" kern="1200">
+          <a:solidFill>
+            <a:schemeClr val="tx1"/>
+          </a:solidFill>
+          <a:latin typeface="+mn-lt"/>
+          <a:ea typeface="+mn-ea"/>
+          <a:cs typeface="+mn-cs"/>
+        </a:defRPr>
+      </a:lvl9pPr>
+    </p:otherStyle>
+  </p:txStyles>
+</p:sldMaster>
+</file>
+
 <file path=ppt/slides/slide1.xml><?xml version="1.0" encoding="utf-8"?>
 <p:sld xmlns:a="http://schemas.openxmlformats.org/drawingml/2006/main" xmlns:r="http://schemas.openxmlformats.org/officeDocument/2006/relationships" xmlns:p="http://schemas.openxmlformats.org/presentationml/2006/main">
   <p:cSld>
@@ -5326,6 +5939,2901 @@
 <file path=ppt/slides/slide5.xml><?xml version="1.0" encoding="utf-8"?>
 <p:sld xmlns:a="http://schemas.openxmlformats.org/drawingml/2006/main" xmlns:r="http://schemas.openxmlformats.org/officeDocument/2006/relationships" xmlns:p="http://schemas.openxmlformats.org/presentationml/2006/main">
   <p:cSld>
+    <p:bg>
+      <p:bgPr>
+        <a:solidFill>
+          <a:srgbClr val="00B0F0"/>
+        </a:solidFill>
+        <a:effectLst/>
+      </p:bgPr>
+    </p:bg>
+    <p:spTree>
+      <p:nvGrpSpPr>
+        <p:cNvPr id="1" name=""/>
+        <p:cNvGrpSpPr/>
+        <p:nvPr/>
+      </p:nvGrpSpPr>
+      <p:grpSpPr>
+        <a:xfrm>
+          <a:off x="0" y="0"/>
+          <a:ext cx="0" cy="0"/>
+          <a:chOff x="0" y="0"/>
+          <a:chExt cx="0" cy="0"/>
+        </a:xfrm>
+      </p:grpSpPr>
+      <p:sp>
+        <p:nvSpPr>
+          <p:cNvPr id="3" name="Text 1"/>
+          <p:cNvSpPr/>
+          <p:nvPr/>
+        </p:nvSpPr>
+        <p:spPr>
+          <a:xfrm>
+            <a:off x="600862" y="3743623"/>
+            <a:ext cx="2264263" cy="1662546"/>
+          </a:xfrm>
+          <a:prstGeom prst="rect">
+            <a:avLst/>
+          </a:prstGeom>
+          <a:noFill/>
+          <a:ln/>
+        </p:spPr>
+        <p:txBody>
+          <a:bodyPr wrap="square" lIns="0" tIns="0" rIns="0" bIns="0" rtlCol="0" anchor="ctr"/>
+          <a:lstStyle/>
+          <a:p>
+            <a:pPr defTabSz="1219170"/>
+            <a:r>
+              <a:rPr lang="en-US" sz="4000" b="1" dirty="0">
+                <a:solidFill>
+                  <a:srgbClr val="FFFFFF"/>
+                </a:solidFill>
+                <a:latin typeface="Calibri" pitchFamily="34" charset="0"/>
+                <a:ea typeface="Calibri" pitchFamily="34" charset="-122"/>
+                <a:cs typeface="Calibri" pitchFamily="34" charset="-120"/>
+              </a:rPr>
+              <a:t>Input Pipeline</a:t>
+            </a:r>
+            <a:endParaRPr lang="en-US" sz="4000" dirty="0">
+              <a:solidFill>
+                <a:prstClr val="black"/>
+              </a:solidFill>
+              <a:latin typeface="Calibri" panose="020F0502020204030204"/>
+            </a:endParaRPr>
+          </a:p>
+        </p:txBody>
+      </p:sp>
+      <p:sp>
+        <p:nvSpPr>
+          <p:cNvPr id="4" name="Shape 2"/>
+          <p:cNvSpPr/>
+          <p:nvPr/>
+        </p:nvSpPr>
+        <p:spPr>
+          <a:xfrm>
+            <a:off x="365760" y="761879"/>
+            <a:ext cx="1889760" cy="755904"/>
+          </a:xfrm>
+          <a:prstGeom prst="roundRect">
+            <a:avLst>
+              <a:gd name="adj" fmla="val 16667"/>
+            </a:avLst>
+          </a:prstGeom>
+          <a:solidFill>
+            <a:srgbClr val="2A3570"/>
+          </a:solidFill>
+          <a:ln w="19050">
+            <a:solidFill>
+              <a:srgbClr val="CADCFC"/>
+            </a:solidFill>
+            <a:prstDash val="solid"/>
+          </a:ln>
+        </p:spPr>
+        <p:txBody>
+          <a:bodyPr/>
+          <a:lstStyle/>
+          <a:p>
+            <a:pPr defTabSz="1219170"/>
+            <a:endParaRPr lang="en-US" sz="2400">
+              <a:solidFill>
+                <a:prstClr val="black"/>
+              </a:solidFill>
+              <a:latin typeface="Calibri" panose="020F0502020204030204"/>
+            </a:endParaRPr>
+          </a:p>
+        </p:txBody>
+      </p:sp>
+      <p:sp>
+        <p:nvSpPr>
+          <p:cNvPr id="5" name="Text 3"/>
+          <p:cNvSpPr/>
+          <p:nvPr/>
+        </p:nvSpPr>
+        <p:spPr>
+          <a:xfrm>
+            <a:off x="365760" y="761879"/>
+            <a:ext cx="1889760" cy="667900"/>
+          </a:xfrm>
+          <a:prstGeom prst="rect">
+            <a:avLst/>
+          </a:prstGeom>
+          <a:noFill/>
+          <a:ln/>
+        </p:spPr>
+        <p:txBody>
+          <a:bodyPr wrap="square" lIns="67733" tIns="67733" rIns="67733" bIns="67733" rtlCol="0" anchor="ctr"/>
+          <a:lstStyle/>
+          <a:p>
+            <a:pPr algn="ctr" defTabSz="1219170"/>
+            <a:r>
+              <a:rPr lang="en-US" sz="2400" b="1" dirty="0">
+                <a:solidFill>
+                  <a:srgbClr val="FFFFFF"/>
+                </a:solidFill>
+                <a:latin typeface="Calibri" pitchFamily="34" charset="0"/>
+                <a:ea typeface="Calibri" pitchFamily="34" charset="-122"/>
+                <a:cs typeface="Calibri" pitchFamily="34" charset="-120"/>
+              </a:rPr>
+              <a:t>Bass</a:t>
+            </a:r>
+            <a:br>
+              <a:rPr lang="en-US" sz="2400" b="1" dirty="0">
+                <a:solidFill>
+                  <a:srgbClr val="FFFFFF"/>
+                </a:solidFill>
+                <a:latin typeface="Calibri" pitchFamily="34" charset="0"/>
+                <a:ea typeface="Calibri" pitchFamily="34" charset="-122"/>
+                <a:cs typeface="Calibri" pitchFamily="34" charset="-120"/>
+              </a:rPr>
+            </a:br>
+            <a:r>
+              <a:rPr lang="en-US" sz="2000" b="1" dirty="0">
+                <a:solidFill>
+                  <a:srgbClr val="FFFFFF"/>
+                </a:solidFill>
+                <a:latin typeface="Calibri" pitchFamily="34" charset="0"/>
+                <a:ea typeface="Calibri" pitchFamily="34" charset="-122"/>
+                <a:cs typeface="Calibri" pitchFamily="34" charset="-120"/>
+              </a:rPr>
+              <a:t>(pitch-to-MIDI)</a:t>
+            </a:r>
+            <a:endParaRPr lang="en-US" sz="2400" dirty="0">
+              <a:solidFill>
+                <a:prstClr val="black"/>
+              </a:solidFill>
+              <a:latin typeface="Calibri" panose="020F0502020204030204"/>
+            </a:endParaRPr>
+          </a:p>
+        </p:txBody>
+      </p:sp>
+      <p:sp>
+        <p:nvSpPr>
+          <p:cNvPr id="6" name="Shape 4"/>
+          <p:cNvSpPr/>
+          <p:nvPr/>
+        </p:nvSpPr>
+        <p:spPr>
+          <a:xfrm>
+            <a:off x="2865125" y="846690"/>
+            <a:ext cx="1889760" cy="585216"/>
+          </a:xfrm>
+          <a:prstGeom prst="roundRect">
+            <a:avLst>
+              <a:gd name="adj" fmla="val 16667"/>
+            </a:avLst>
+          </a:prstGeom>
+          <a:solidFill>
+            <a:srgbClr val="2A3570"/>
+          </a:solidFill>
+          <a:ln w="19050">
+            <a:solidFill>
+              <a:srgbClr val="CADCFC"/>
+            </a:solidFill>
+            <a:prstDash val="solid"/>
+          </a:ln>
+        </p:spPr>
+        <p:txBody>
+          <a:bodyPr/>
+          <a:lstStyle/>
+          <a:p>
+            <a:pPr defTabSz="1219170"/>
+            <a:endParaRPr lang="en-US" sz="2400">
+              <a:solidFill>
+                <a:prstClr val="black"/>
+              </a:solidFill>
+              <a:latin typeface="Calibri" panose="020F0502020204030204"/>
+            </a:endParaRPr>
+          </a:p>
+        </p:txBody>
+      </p:sp>
+      <p:sp>
+        <p:nvSpPr>
+          <p:cNvPr id="7" name="Text 5"/>
+          <p:cNvSpPr/>
+          <p:nvPr/>
+        </p:nvSpPr>
+        <p:spPr>
+          <a:xfrm>
+            <a:off x="2865125" y="846690"/>
+            <a:ext cx="1889760" cy="585216"/>
+          </a:xfrm>
+          <a:prstGeom prst="rect">
+            <a:avLst/>
+          </a:prstGeom>
+          <a:noFill/>
+          <a:ln/>
+        </p:spPr>
+        <p:txBody>
+          <a:bodyPr wrap="square" lIns="67733" tIns="67733" rIns="67733" bIns="67733" rtlCol="0" anchor="ctr"/>
+          <a:lstStyle/>
+          <a:p>
+            <a:pPr algn="ctr" defTabSz="1219170"/>
+            <a:r>
+              <a:rPr lang="en-US" sz="2400" b="1" dirty="0">
+                <a:solidFill>
+                  <a:srgbClr val="FFFFFF"/>
+                </a:solidFill>
+                <a:latin typeface="Calibri" pitchFamily="34" charset="0"/>
+                <a:ea typeface="Calibri" pitchFamily="34" charset="-122"/>
+                <a:cs typeface="Calibri" pitchFamily="34" charset="-120"/>
+              </a:rPr>
+              <a:t>MidiListener</a:t>
+            </a:r>
+            <a:endParaRPr lang="en-US" sz="2400" dirty="0">
+              <a:solidFill>
+                <a:prstClr val="black"/>
+              </a:solidFill>
+              <a:latin typeface="Calibri" panose="020F0502020204030204"/>
+            </a:endParaRPr>
+          </a:p>
+        </p:txBody>
+      </p:sp>
+      <p:sp>
+        <p:nvSpPr>
+          <p:cNvPr id="8" name="Shape 6"/>
+          <p:cNvSpPr/>
+          <p:nvPr/>
+        </p:nvSpPr>
+        <p:spPr>
+          <a:xfrm>
+            <a:off x="5416430" y="846690"/>
+            <a:ext cx="2291561" cy="585216"/>
+          </a:xfrm>
+          <a:prstGeom prst="roundRect">
+            <a:avLst>
+              <a:gd name="adj" fmla="val 16667"/>
+            </a:avLst>
+          </a:prstGeom>
+          <a:solidFill>
+            <a:srgbClr val="2A3570"/>
+          </a:solidFill>
+          <a:ln w="19050">
+            <a:solidFill>
+              <a:srgbClr val="CADCFC"/>
+            </a:solidFill>
+            <a:prstDash val="solid"/>
+          </a:ln>
+        </p:spPr>
+        <p:txBody>
+          <a:bodyPr/>
+          <a:lstStyle/>
+          <a:p>
+            <a:pPr defTabSz="1219170"/>
+            <a:endParaRPr lang="en-US" sz="2400">
+              <a:solidFill>
+                <a:prstClr val="black"/>
+              </a:solidFill>
+              <a:latin typeface="Calibri" panose="020F0502020204030204"/>
+            </a:endParaRPr>
+          </a:p>
+        </p:txBody>
+      </p:sp>
+      <p:sp>
+        <p:nvSpPr>
+          <p:cNvPr id="9" name="Text 7"/>
+          <p:cNvSpPr/>
+          <p:nvPr/>
+        </p:nvSpPr>
+        <p:spPr>
+          <a:xfrm>
+            <a:off x="5477390" y="846690"/>
+            <a:ext cx="2197479" cy="585216"/>
+          </a:xfrm>
+          <a:prstGeom prst="rect">
+            <a:avLst/>
+          </a:prstGeom>
+          <a:noFill/>
+          <a:ln/>
+        </p:spPr>
+        <p:txBody>
+          <a:bodyPr wrap="square" lIns="67733" tIns="67733" rIns="67733" bIns="67733" rtlCol="0" anchor="ctr"/>
+          <a:lstStyle/>
+          <a:p>
+            <a:pPr algn="ctr" defTabSz="1219170"/>
+            <a:r>
+              <a:rPr lang="en-US" sz="2400" b="1" dirty="0">
+                <a:solidFill>
+                  <a:srgbClr val="FFFFFF"/>
+                </a:solidFill>
+                <a:latin typeface="Calibri" pitchFamily="34" charset="0"/>
+                <a:ea typeface="Calibri" pitchFamily="34" charset="-122"/>
+                <a:cs typeface="Calibri" pitchFamily="34" charset="-120"/>
+              </a:rPr>
+              <a:t>PhraseDetector</a:t>
+            </a:r>
+            <a:endParaRPr lang="en-US" sz="2400" dirty="0">
+              <a:solidFill>
+                <a:prstClr val="black"/>
+              </a:solidFill>
+              <a:latin typeface="Calibri" panose="020F0502020204030204"/>
+            </a:endParaRPr>
+          </a:p>
+        </p:txBody>
+      </p:sp>
+      <p:sp>
+        <p:nvSpPr>
+          <p:cNvPr id="10" name="Shape 8"/>
+          <p:cNvSpPr/>
+          <p:nvPr/>
+        </p:nvSpPr>
+        <p:spPr>
+          <a:xfrm>
+            <a:off x="8473440" y="664343"/>
+            <a:ext cx="3413760" cy="1828800"/>
+          </a:xfrm>
+          <a:prstGeom prst="roundRect">
+            <a:avLst>
+              <a:gd name="adj" fmla="val 5333"/>
+            </a:avLst>
+          </a:prstGeom>
+          <a:solidFill>
+            <a:srgbClr val="253880"/>
+          </a:solidFill>
+          <a:ln w="25400">
+            <a:solidFill>
+              <a:srgbClr val="CADCFC"/>
+            </a:solidFill>
+            <a:prstDash val="solid"/>
+          </a:ln>
+        </p:spPr>
+        <p:txBody>
+          <a:bodyPr/>
+          <a:lstStyle/>
+          <a:p>
+            <a:pPr defTabSz="1219170"/>
+            <a:endParaRPr lang="en-US" sz="2400">
+              <a:solidFill>
+                <a:prstClr val="black"/>
+              </a:solidFill>
+              <a:latin typeface="Calibri" panose="020F0502020204030204"/>
+            </a:endParaRPr>
+          </a:p>
+        </p:txBody>
+      </p:sp>
+      <p:sp>
+        <p:nvSpPr>
+          <p:cNvPr id="11" name="Text 9"/>
+          <p:cNvSpPr/>
+          <p:nvPr/>
+        </p:nvSpPr>
+        <p:spPr>
+          <a:xfrm>
+            <a:off x="8534400" y="706749"/>
+            <a:ext cx="3291840" cy="316992"/>
+          </a:xfrm>
+          <a:prstGeom prst="rect">
+            <a:avLst/>
+          </a:prstGeom>
+          <a:noFill/>
+          <a:ln/>
+        </p:spPr>
+        <p:txBody>
+          <a:bodyPr wrap="square" lIns="0" tIns="0" rIns="0" bIns="0" rtlCol="0" anchor="ctr"/>
+          <a:lstStyle/>
+          <a:p>
+            <a:pPr algn="ctr" defTabSz="1219170"/>
+            <a:r>
+              <a:rPr lang="en-US" sz="2400" b="1" dirty="0">
+                <a:solidFill>
+                  <a:srgbClr val="FFFFFF"/>
+                </a:solidFill>
+                <a:latin typeface="Calibri" pitchFamily="34" charset="0"/>
+                <a:ea typeface="Calibri" pitchFamily="34" charset="-122"/>
+                <a:cs typeface="Calibri" pitchFamily="34" charset="-120"/>
+              </a:rPr>
+              <a:t>PhraseAnalyzer</a:t>
+            </a:r>
+            <a:endParaRPr lang="en-US" sz="2400" dirty="0">
+              <a:solidFill>
+                <a:prstClr val="black"/>
+              </a:solidFill>
+              <a:latin typeface="Calibri" panose="020F0502020204030204"/>
+            </a:endParaRPr>
+          </a:p>
+        </p:txBody>
+      </p:sp>
+      <p:sp>
+        <p:nvSpPr>
+          <p:cNvPr id="12" name="Text 10"/>
+          <p:cNvSpPr/>
+          <p:nvPr/>
+        </p:nvSpPr>
+        <p:spPr>
+          <a:xfrm>
+            <a:off x="8839200" y="1030103"/>
+            <a:ext cx="2950464" cy="1463040"/>
+          </a:xfrm>
+          <a:prstGeom prst="rect">
+            <a:avLst/>
+          </a:prstGeom>
+          <a:noFill/>
+          <a:ln/>
+        </p:spPr>
+        <p:txBody>
+          <a:bodyPr wrap="square" lIns="33867" tIns="33867" rIns="33867" bIns="33867" rtlCol="0" anchor="t"/>
+          <a:lstStyle/>
+          <a:p>
+            <a:pPr defTabSz="1219170"/>
+            <a:r>
+              <a:rPr lang="en-US" sz="1600" dirty="0">
+                <a:solidFill>
+                  <a:srgbClr val="CADCFC"/>
+                </a:solidFill>
+                <a:latin typeface="Calibri" pitchFamily="34" charset="0"/>
+                <a:ea typeface="Calibri" pitchFamily="34" charset="-122"/>
+                <a:cs typeface="Calibri" pitchFamily="34" charset="-120"/>
+              </a:rPr>
+              <a:t>contour, density</a:t>
+            </a:r>
+            <a:endParaRPr lang="en-US" sz="1600" dirty="0">
+              <a:solidFill>
+                <a:prstClr val="black"/>
+              </a:solidFill>
+              <a:latin typeface="Calibri" panose="020F0502020204030204"/>
+            </a:endParaRPr>
+          </a:p>
+          <a:p>
+            <a:pPr defTabSz="1219170"/>
+            <a:r>
+              <a:rPr lang="en-US" sz="1600" dirty="0">
+                <a:solidFill>
+                  <a:srgbClr val="CADCFC"/>
+                </a:solidFill>
+                <a:latin typeface="Calibri" pitchFamily="34" charset="0"/>
+                <a:ea typeface="Calibri" pitchFamily="34" charset="-122"/>
+                <a:cs typeface="Calibri" pitchFamily="34" charset="-120"/>
+              </a:rPr>
+              <a:t>Q&amp;A type, swing</a:t>
+            </a:r>
+            <a:endParaRPr lang="en-US" sz="1600" dirty="0">
+              <a:solidFill>
+                <a:prstClr val="black"/>
+              </a:solidFill>
+              <a:latin typeface="Calibri" panose="020F0502020204030204"/>
+            </a:endParaRPr>
+          </a:p>
+          <a:p>
+            <a:pPr defTabSz="1219170"/>
+            <a:r>
+              <a:rPr lang="en-US" sz="1600" dirty="0">
+                <a:solidFill>
+                  <a:srgbClr val="CADCFC"/>
+                </a:solidFill>
+                <a:latin typeface="Calibri" pitchFamily="34" charset="0"/>
+                <a:ea typeface="Calibri" pitchFamily="34" charset="-122"/>
+                <a:cs typeface="Calibri" pitchFamily="34" charset="-120"/>
+              </a:rPr>
+              <a:t>dynamics, energy profile</a:t>
+            </a:r>
+            <a:endParaRPr lang="en-US" sz="1600" dirty="0">
+              <a:solidFill>
+                <a:prstClr val="black"/>
+              </a:solidFill>
+              <a:latin typeface="Calibri" panose="020F0502020204030204"/>
+            </a:endParaRPr>
+          </a:p>
+          <a:p>
+            <a:pPr defTabSz="1219170"/>
+            <a:r>
+              <a:rPr lang="en-US" sz="1600" dirty="0">
+                <a:solidFill>
+                  <a:srgbClr val="CADCFC"/>
+                </a:solidFill>
+                <a:latin typeface="Calibri" pitchFamily="34" charset="0"/>
+                <a:ea typeface="Calibri" pitchFamily="34" charset="-122"/>
+                <a:cs typeface="Calibri" pitchFamily="34" charset="-120"/>
+              </a:rPr>
+              <a:t>pitch classes</a:t>
+            </a:r>
+            <a:endParaRPr lang="en-US" sz="1600" dirty="0">
+              <a:solidFill>
+                <a:prstClr val="black"/>
+              </a:solidFill>
+              <a:latin typeface="Calibri" panose="020F0502020204030204"/>
+            </a:endParaRPr>
+          </a:p>
+          <a:p>
+            <a:pPr defTabSz="1219170"/>
+            <a:r>
+              <a:rPr lang="en-US" sz="1600" dirty="0">
+                <a:solidFill>
+                  <a:srgbClr val="CADCFC"/>
+                </a:solidFill>
+                <a:latin typeface="Calibri" pitchFamily="34" charset="0"/>
+                <a:ea typeface="Calibri" pitchFamily="34" charset="-122"/>
+                <a:cs typeface="Calibri" pitchFamily="34" charset="-120"/>
+              </a:rPr>
+              <a:t>interval motifs, lyrical motifs</a:t>
+            </a:r>
+            <a:endParaRPr lang="en-US" sz="1600" dirty="0">
+              <a:solidFill>
+                <a:prstClr val="black"/>
+              </a:solidFill>
+              <a:latin typeface="Calibri" panose="020F0502020204030204"/>
+            </a:endParaRPr>
+          </a:p>
+        </p:txBody>
+      </p:sp>
+      <p:sp>
+        <p:nvSpPr>
+          <p:cNvPr id="15" name="Shape 13"/>
+          <p:cNvSpPr/>
+          <p:nvPr/>
+        </p:nvSpPr>
+        <p:spPr>
+          <a:xfrm>
+            <a:off x="7805528" y="1139298"/>
+            <a:ext cx="497224" cy="1"/>
+          </a:xfrm>
+          <a:prstGeom prst="line">
+            <a:avLst/>
+          </a:prstGeom>
+          <a:noFill/>
+          <a:ln w="50800">
+            <a:solidFill>
+              <a:srgbClr val="CADCFC"/>
+            </a:solidFill>
+            <a:prstDash val="solid"/>
+            <a:tailEnd type="arrow"/>
+          </a:ln>
+        </p:spPr>
+        <p:txBody>
+          <a:bodyPr/>
+          <a:lstStyle/>
+          <a:p>
+            <a:pPr defTabSz="1219170"/>
+            <a:endParaRPr lang="en-US" sz="2400">
+              <a:solidFill>
+                <a:prstClr val="black"/>
+              </a:solidFill>
+              <a:latin typeface="Calibri" panose="020F0502020204030204"/>
+            </a:endParaRPr>
+          </a:p>
+        </p:txBody>
+      </p:sp>
+      <p:sp>
+        <p:nvSpPr>
+          <p:cNvPr id="16" name="Shape 14"/>
+          <p:cNvSpPr/>
+          <p:nvPr/>
+        </p:nvSpPr>
+        <p:spPr>
+          <a:xfrm>
+            <a:off x="2389639" y="1999634"/>
+            <a:ext cx="2292087" cy="585216"/>
+          </a:xfrm>
+          <a:prstGeom prst="roundRect">
+            <a:avLst>
+              <a:gd name="adj" fmla="val 16667"/>
+            </a:avLst>
+          </a:prstGeom>
+          <a:solidFill>
+            <a:srgbClr val="2A3570"/>
+          </a:solidFill>
+          <a:ln w="19050">
+            <a:solidFill>
+              <a:srgbClr val="CADCFC"/>
+            </a:solidFill>
+            <a:prstDash val="solid"/>
+          </a:ln>
+        </p:spPr>
+        <p:txBody>
+          <a:bodyPr/>
+          <a:lstStyle/>
+          <a:p>
+            <a:pPr defTabSz="1219170"/>
+            <a:endParaRPr lang="en-US" sz="2400">
+              <a:solidFill>
+                <a:prstClr val="black"/>
+              </a:solidFill>
+              <a:latin typeface="Calibri" panose="020F0502020204030204"/>
+            </a:endParaRPr>
+          </a:p>
+        </p:txBody>
+      </p:sp>
+      <p:sp>
+        <p:nvSpPr>
+          <p:cNvPr id="17" name="Text 15"/>
+          <p:cNvSpPr/>
+          <p:nvPr/>
+        </p:nvSpPr>
+        <p:spPr>
+          <a:xfrm>
+            <a:off x="2389637" y="1999633"/>
+            <a:ext cx="2292087" cy="342371"/>
+          </a:xfrm>
+          <a:prstGeom prst="rect">
+            <a:avLst/>
+          </a:prstGeom>
+          <a:noFill/>
+          <a:ln/>
+        </p:spPr>
+        <p:txBody>
+          <a:bodyPr wrap="square" lIns="0" tIns="0" rIns="0" bIns="0" rtlCol="0" anchor="ctr"/>
+          <a:lstStyle/>
+          <a:p>
+            <a:pPr algn="ctr" defTabSz="1219170"/>
+            <a:r>
+              <a:rPr lang="en-US" sz="2400" b="1" dirty="0">
+                <a:solidFill>
+                  <a:srgbClr val="FFFFFF"/>
+                </a:solidFill>
+                <a:latin typeface="Calibri" pitchFamily="34" charset="0"/>
+                <a:ea typeface="Calibri" pitchFamily="34" charset="-122"/>
+                <a:cs typeface="Calibri" pitchFamily="34" charset="-120"/>
+              </a:rPr>
+              <a:t>BeatEstimator</a:t>
+            </a:r>
+            <a:endParaRPr lang="en-US" sz="2400" dirty="0">
+              <a:solidFill>
+                <a:prstClr val="black"/>
+              </a:solidFill>
+              <a:latin typeface="Calibri" panose="020F0502020204030204"/>
+            </a:endParaRPr>
+          </a:p>
+        </p:txBody>
+      </p:sp>
+      <p:sp>
+        <p:nvSpPr>
+          <p:cNvPr id="18" name="Text 16"/>
+          <p:cNvSpPr/>
+          <p:nvPr/>
+        </p:nvSpPr>
+        <p:spPr>
+          <a:xfrm>
+            <a:off x="2987040" y="2273325"/>
+            <a:ext cx="1694688" cy="219456"/>
+          </a:xfrm>
+          <a:prstGeom prst="rect">
+            <a:avLst/>
+          </a:prstGeom>
+          <a:noFill/>
+          <a:ln/>
+        </p:spPr>
+        <p:txBody>
+          <a:bodyPr wrap="square" lIns="33867" tIns="33867" rIns="33867" bIns="33867" rtlCol="0" anchor="t"/>
+          <a:lstStyle/>
+          <a:p>
+            <a:pPr defTabSz="1219170"/>
+            <a:r>
+              <a:rPr lang="en-US" sz="1600" dirty="0">
+                <a:solidFill>
+                  <a:srgbClr val="CADCFC"/>
+                </a:solidFill>
+                <a:latin typeface="Calibri" pitchFamily="34" charset="0"/>
+                <a:ea typeface="Calibri" pitchFamily="34" charset="-122"/>
+                <a:cs typeface="Calibri" pitchFamily="34" charset="-120"/>
+              </a:rPr>
+              <a:t>live tempo</a:t>
+            </a:r>
+            <a:endParaRPr lang="en-US" sz="1600" dirty="0">
+              <a:solidFill>
+                <a:prstClr val="black"/>
+              </a:solidFill>
+              <a:latin typeface="Calibri" panose="020F0502020204030204"/>
+            </a:endParaRPr>
+          </a:p>
+        </p:txBody>
+      </p:sp>
+      <p:sp>
+        <p:nvSpPr>
+          <p:cNvPr id="19" name="Shape 17"/>
+          <p:cNvSpPr/>
+          <p:nvPr/>
+        </p:nvSpPr>
+        <p:spPr>
+          <a:xfrm>
+            <a:off x="3566160" y="1560191"/>
+            <a:ext cx="0" cy="353568"/>
+          </a:xfrm>
+          <a:prstGeom prst="line">
+            <a:avLst/>
+          </a:prstGeom>
+          <a:noFill/>
+          <a:ln w="50800">
+            <a:solidFill>
+              <a:srgbClr val="CADCFC"/>
+            </a:solidFill>
+            <a:prstDash val="solid"/>
+            <a:tailEnd type="arrow"/>
+          </a:ln>
+        </p:spPr>
+        <p:txBody>
+          <a:bodyPr/>
+          <a:lstStyle/>
+          <a:p>
+            <a:pPr defTabSz="1219170"/>
+            <a:endParaRPr lang="en-US" sz="2400">
+              <a:solidFill>
+                <a:prstClr val="black"/>
+              </a:solidFill>
+              <a:latin typeface="Calibri" panose="020F0502020204030204"/>
+            </a:endParaRPr>
+          </a:p>
+        </p:txBody>
+      </p:sp>
+      <p:sp>
+        <p:nvSpPr>
+          <p:cNvPr id="20" name="Shape 18"/>
+          <p:cNvSpPr/>
+          <p:nvPr/>
+        </p:nvSpPr>
+        <p:spPr>
+          <a:xfrm>
+            <a:off x="4513688" y="2755535"/>
+            <a:ext cx="3291840" cy="1287592"/>
+          </a:xfrm>
+          <a:prstGeom prst="roundRect">
+            <a:avLst>
+              <a:gd name="adj" fmla="val 8421"/>
+            </a:avLst>
+          </a:prstGeom>
+          <a:solidFill>
+            <a:srgbClr val="162050"/>
+          </a:solidFill>
+          <a:ln w="19050">
+            <a:solidFill>
+              <a:srgbClr val="CADCFC"/>
+            </a:solidFill>
+            <a:prstDash val="solid"/>
+          </a:ln>
+        </p:spPr>
+        <p:txBody>
+          <a:bodyPr/>
+          <a:lstStyle/>
+          <a:p>
+            <a:pPr defTabSz="1219170"/>
+            <a:endParaRPr lang="en-US" sz="2400">
+              <a:solidFill>
+                <a:prstClr val="black"/>
+              </a:solidFill>
+              <a:latin typeface="Calibri" panose="020F0502020204030204"/>
+            </a:endParaRPr>
+          </a:p>
+        </p:txBody>
+      </p:sp>
+      <p:sp>
+        <p:nvSpPr>
+          <p:cNvPr id="21" name="Text 19"/>
+          <p:cNvSpPr/>
+          <p:nvPr/>
+        </p:nvSpPr>
+        <p:spPr>
+          <a:xfrm>
+            <a:off x="4574648" y="2842482"/>
+            <a:ext cx="3169920" cy="316992"/>
+          </a:xfrm>
+          <a:prstGeom prst="rect">
+            <a:avLst/>
+          </a:prstGeom>
+          <a:noFill/>
+          <a:ln/>
+        </p:spPr>
+        <p:txBody>
+          <a:bodyPr wrap="square" lIns="0" tIns="0" rIns="0" bIns="0" rtlCol="0" anchor="ctr"/>
+          <a:lstStyle/>
+          <a:p>
+            <a:pPr algn="ctr" defTabSz="1219170"/>
+            <a:r>
+              <a:rPr lang="en-US" sz="2400" b="1" dirty="0">
+                <a:solidFill>
+                  <a:srgbClr val="FFFFFF"/>
+                </a:solidFill>
+                <a:latin typeface="Calibri" pitchFamily="34" charset="0"/>
+                <a:ea typeface="Calibri" pitchFamily="34" charset="-122"/>
+                <a:cs typeface="Calibri" pitchFamily="34" charset="-120"/>
+              </a:rPr>
+              <a:t>PhraseMemory</a:t>
+            </a:r>
+            <a:endParaRPr lang="en-US" sz="2400" dirty="0">
+              <a:solidFill>
+                <a:prstClr val="black"/>
+              </a:solidFill>
+              <a:latin typeface="Calibri" panose="020F0502020204030204"/>
+            </a:endParaRPr>
+          </a:p>
+        </p:txBody>
+      </p:sp>
+      <p:sp>
+        <p:nvSpPr>
+          <p:cNvPr id="22" name="Text 20"/>
+          <p:cNvSpPr/>
+          <p:nvPr/>
+        </p:nvSpPr>
+        <p:spPr>
+          <a:xfrm>
+            <a:off x="4940408" y="3198094"/>
+            <a:ext cx="2767584" cy="792480"/>
+          </a:xfrm>
+          <a:prstGeom prst="rect">
+            <a:avLst/>
+          </a:prstGeom>
+          <a:noFill/>
+          <a:ln/>
+        </p:spPr>
+        <p:txBody>
+          <a:bodyPr wrap="square" lIns="33867" tIns="33867" rIns="33867" bIns="33867" rtlCol="0" anchor="t"/>
+          <a:lstStyle/>
+          <a:p>
+            <a:pPr defTabSz="1219170"/>
+            <a:r>
+              <a:rPr lang="en-US" sz="1600" dirty="0">
+                <a:solidFill>
+                  <a:srgbClr val="CADCFC"/>
+                </a:solidFill>
+                <a:latin typeface="Calibri" pitchFamily="34" charset="0"/>
+                <a:ea typeface="Calibri" pitchFamily="34" charset="-122"/>
+                <a:cs typeface="Calibri" pitchFamily="34" charset="-120"/>
+              </a:rPr>
+              <a:t>stores phrases + motifs</a:t>
+            </a:r>
+            <a:endParaRPr lang="en-US" sz="1600" dirty="0">
+              <a:solidFill>
+                <a:prstClr val="black"/>
+              </a:solidFill>
+              <a:latin typeface="Calibri" panose="020F0502020204030204"/>
+            </a:endParaRPr>
+          </a:p>
+          <a:p>
+            <a:pPr defTabSz="1219170"/>
+            <a:r>
+              <a:rPr lang="en-US" sz="1600" dirty="0">
+                <a:solidFill>
+                  <a:srgbClr val="CADCFC"/>
+                </a:solidFill>
+                <a:latin typeface="Calibri" pitchFamily="34" charset="0"/>
+                <a:ea typeface="Calibri" pitchFamily="34" charset="-122"/>
+                <a:cs typeface="Calibri" pitchFamily="34" charset="-120"/>
+              </a:rPr>
+              <a:t>stores lyrical motifs</a:t>
+            </a:r>
+            <a:endParaRPr lang="en-US" sz="1600" dirty="0">
+              <a:solidFill>
+                <a:prstClr val="black"/>
+              </a:solidFill>
+              <a:latin typeface="Calibri" panose="020F0502020204030204"/>
+            </a:endParaRPr>
+          </a:p>
+          <a:p>
+            <a:pPr defTabSz="1219170"/>
+            <a:r>
+              <a:rPr lang="en-US" sz="1600" dirty="0">
+                <a:solidFill>
+                  <a:srgbClr val="CADCFC"/>
+                </a:solidFill>
+                <a:latin typeface="Calibri" pitchFamily="34" charset="0"/>
+                <a:ea typeface="Calibri" pitchFamily="34" charset="-122"/>
+                <a:cs typeface="Calibri" pitchFamily="34" charset="-120"/>
+              </a:rPr>
+              <a:t>both voices (bass + sax)</a:t>
+            </a:r>
+            <a:endParaRPr lang="en-US" sz="1600" dirty="0">
+              <a:solidFill>
+                <a:prstClr val="black"/>
+              </a:solidFill>
+              <a:latin typeface="Calibri" panose="020F0502020204030204"/>
+            </a:endParaRPr>
+          </a:p>
+        </p:txBody>
+      </p:sp>
+      <p:sp>
+        <p:nvSpPr>
+          <p:cNvPr id="23" name="Shape 21"/>
+          <p:cNvSpPr/>
+          <p:nvPr/>
+        </p:nvSpPr>
+        <p:spPr>
+          <a:xfrm>
+            <a:off x="8839200" y="2610826"/>
+            <a:ext cx="0" cy="821376"/>
+          </a:xfrm>
+          <a:prstGeom prst="line">
+            <a:avLst/>
+          </a:prstGeom>
+          <a:noFill/>
+          <a:ln w="50800">
+            <a:solidFill>
+              <a:srgbClr val="CADCFC"/>
+            </a:solidFill>
+            <a:prstDash val="solid"/>
+          </a:ln>
+        </p:spPr>
+        <p:txBody>
+          <a:bodyPr/>
+          <a:lstStyle/>
+          <a:p>
+            <a:pPr defTabSz="1219170"/>
+            <a:endParaRPr lang="en-US" sz="2400">
+              <a:solidFill>
+                <a:prstClr val="black"/>
+              </a:solidFill>
+              <a:latin typeface="Calibri" panose="020F0502020204030204"/>
+            </a:endParaRPr>
+          </a:p>
+        </p:txBody>
+      </p:sp>
+      <p:sp>
+        <p:nvSpPr>
+          <p:cNvPr id="24" name="Shape 22"/>
+          <p:cNvSpPr/>
+          <p:nvPr/>
+        </p:nvSpPr>
+        <p:spPr>
+          <a:xfrm>
+            <a:off x="7912608" y="3432201"/>
+            <a:ext cx="926592" cy="0"/>
+          </a:xfrm>
+          <a:prstGeom prst="line">
+            <a:avLst/>
+          </a:prstGeom>
+          <a:noFill/>
+          <a:ln w="50800">
+            <a:solidFill>
+              <a:srgbClr val="CADCFC"/>
+            </a:solidFill>
+            <a:prstDash val="solid"/>
+            <a:headEnd type="arrow"/>
+          </a:ln>
+        </p:spPr>
+        <p:txBody>
+          <a:bodyPr/>
+          <a:lstStyle/>
+          <a:p>
+            <a:pPr defTabSz="1219170"/>
+            <a:endParaRPr lang="en-US" sz="2400">
+              <a:solidFill>
+                <a:prstClr val="black"/>
+              </a:solidFill>
+              <a:latin typeface="Calibri" panose="020F0502020204030204"/>
+            </a:endParaRPr>
+          </a:p>
+        </p:txBody>
+      </p:sp>
+      <p:sp>
+        <p:nvSpPr>
+          <p:cNvPr id="25" name="Shape 23"/>
+          <p:cNvSpPr/>
+          <p:nvPr/>
+        </p:nvSpPr>
+        <p:spPr>
+          <a:xfrm>
+            <a:off x="3566160" y="2734336"/>
+            <a:ext cx="0" cy="697865"/>
+          </a:xfrm>
+          <a:prstGeom prst="line">
+            <a:avLst/>
+          </a:prstGeom>
+          <a:noFill/>
+          <a:ln w="50800">
+            <a:solidFill>
+              <a:srgbClr val="CADCFC"/>
+            </a:solidFill>
+            <a:prstDash val="solid"/>
+          </a:ln>
+        </p:spPr>
+        <p:txBody>
+          <a:bodyPr/>
+          <a:lstStyle/>
+          <a:p>
+            <a:pPr defTabSz="1219170"/>
+            <a:endParaRPr lang="en-US" sz="2400">
+              <a:solidFill>
+                <a:prstClr val="black"/>
+              </a:solidFill>
+              <a:latin typeface="Calibri" panose="020F0502020204030204"/>
+            </a:endParaRPr>
+          </a:p>
+        </p:txBody>
+      </p:sp>
+      <p:sp>
+        <p:nvSpPr>
+          <p:cNvPr id="26" name="Shape 24"/>
+          <p:cNvSpPr/>
+          <p:nvPr/>
+        </p:nvSpPr>
+        <p:spPr>
+          <a:xfrm>
+            <a:off x="3566160" y="3432201"/>
+            <a:ext cx="883920" cy="0"/>
+          </a:xfrm>
+          <a:prstGeom prst="line">
+            <a:avLst/>
+          </a:prstGeom>
+          <a:noFill/>
+          <a:ln w="50800">
+            <a:solidFill>
+              <a:srgbClr val="CADCFC"/>
+            </a:solidFill>
+            <a:prstDash val="solid"/>
+            <a:tailEnd type="arrow"/>
+          </a:ln>
+        </p:spPr>
+        <p:txBody>
+          <a:bodyPr/>
+          <a:lstStyle/>
+          <a:p>
+            <a:pPr defTabSz="1219170"/>
+            <a:endParaRPr lang="en-US" sz="2400">
+              <a:solidFill>
+                <a:prstClr val="black"/>
+              </a:solidFill>
+              <a:latin typeface="Calibri" panose="020F0502020204030204"/>
+            </a:endParaRPr>
+          </a:p>
+        </p:txBody>
+      </p:sp>
+      <p:sp>
+        <p:nvSpPr>
+          <p:cNvPr id="27" name="Shape 25"/>
+          <p:cNvSpPr/>
+          <p:nvPr/>
+        </p:nvSpPr>
+        <p:spPr>
+          <a:xfrm>
+            <a:off x="3352800" y="4522399"/>
+            <a:ext cx="5486400" cy="1489456"/>
+          </a:xfrm>
+          <a:prstGeom prst="roundRect">
+            <a:avLst>
+              <a:gd name="adj" fmla="val 8000"/>
+            </a:avLst>
+          </a:prstGeom>
+          <a:solidFill>
+            <a:srgbClr val="253880"/>
+          </a:solidFill>
+          <a:ln w="25400">
+            <a:solidFill>
+              <a:srgbClr val="CADCFC"/>
+            </a:solidFill>
+            <a:prstDash val="solid"/>
+          </a:ln>
+        </p:spPr>
+        <p:txBody>
+          <a:bodyPr/>
+          <a:lstStyle/>
+          <a:p>
+            <a:pPr defTabSz="1219170"/>
+            <a:endParaRPr lang="en-US" sz="2400">
+              <a:solidFill>
+                <a:prstClr val="black"/>
+              </a:solidFill>
+              <a:latin typeface="Calibri" panose="020F0502020204030204"/>
+            </a:endParaRPr>
+          </a:p>
+        </p:txBody>
+      </p:sp>
+      <p:sp>
+        <p:nvSpPr>
+          <p:cNvPr id="28" name="Text 26"/>
+          <p:cNvSpPr/>
+          <p:nvPr/>
+        </p:nvSpPr>
+        <p:spPr>
+          <a:xfrm>
+            <a:off x="3413760" y="4574896"/>
+            <a:ext cx="5364480" cy="315309"/>
+          </a:xfrm>
+          <a:prstGeom prst="rect">
+            <a:avLst/>
+          </a:prstGeom>
+          <a:noFill/>
+          <a:ln/>
+        </p:spPr>
+        <p:txBody>
+          <a:bodyPr wrap="square" lIns="0" tIns="0" rIns="0" bIns="0" rtlCol="0" anchor="ctr"/>
+          <a:lstStyle/>
+          <a:p>
+            <a:pPr algn="ctr" defTabSz="1219170"/>
+            <a:r>
+              <a:rPr lang="en-US" sz="2400" b="1" dirty="0">
+                <a:solidFill>
+                  <a:srgbClr val="FFFFFF"/>
+                </a:solidFill>
+                <a:latin typeface="Calibri" pitchFamily="34" charset="0"/>
+                <a:ea typeface="Calibri" pitchFamily="34" charset="-122"/>
+                <a:cs typeface="Calibri" pitchFamily="34" charset="-120"/>
+              </a:rPr>
+              <a:t>ArcController</a:t>
+            </a:r>
+            <a:endParaRPr lang="en-US" sz="2400" dirty="0">
+              <a:solidFill>
+                <a:prstClr val="black"/>
+              </a:solidFill>
+              <a:latin typeface="Calibri" panose="020F0502020204030204"/>
+            </a:endParaRPr>
+          </a:p>
+        </p:txBody>
+      </p:sp>
+      <p:sp>
+        <p:nvSpPr>
+          <p:cNvPr id="29" name="Text 27"/>
+          <p:cNvSpPr/>
+          <p:nvPr/>
+        </p:nvSpPr>
+        <p:spPr>
+          <a:xfrm>
+            <a:off x="3450336" y="4886419"/>
+            <a:ext cx="5291328" cy="853440"/>
+          </a:xfrm>
+          <a:prstGeom prst="rect">
+            <a:avLst/>
+          </a:prstGeom>
+          <a:noFill/>
+          <a:ln/>
+        </p:spPr>
+        <p:txBody>
+          <a:bodyPr wrap="square" lIns="33867" tIns="33867" rIns="33867" bIns="33867" rtlCol="0" anchor="t"/>
+          <a:lstStyle/>
+          <a:p>
+            <a:pPr defTabSz="1219170"/>
+            <a:r>
+              <a:rPr lang="en-US" sz="1600" dirty="0">
+                <a:solidFill>
+                  <a:srgbClr val="CADCFC"/>
+                </a:solidFill>
+                <a:latin typeface="Calibri" pitchFamily="34" charset="0"/>
+                <a:ea typeface="Calibri" pitchFamily="34" charset="-122"/>
+                <a:cs typeface="Calibri" pitchFamily="34" charset="-120"/>
+              </a:rPr>
+              <a:t>5-min performance arc  ·  leadership &amp; proactive mode</a:t>
+            </a:r>
+            <a:endParaRPr lang="en-US" sz="1600" dirty="0">
+              <a:solidFill>
+                <a:prstClr val="black"/>
+              </a:solidFill>
+              <a:latin typeface="Calibri" panose="020F0502020204030204"/>
+            </a:endParaRPr>
+          </a:p>
+          <a:p>
+            <a:pPr defTabSz="1219170"/>
+            <a:r>
+              <a:rPr lang="en-US" sz="1600" dirty="0">
+                <a:solidFill>
+                  <a:srgbClr val="CADCFC"/>
+                </a:solidFill>
+                <a:latin typeface="Calibri" pitchFamily="34" charset="0"/>
+                <a:ea typeface="Calibri" pitchFamily="34" charset="-122"/>
+                <a:cs typeface="Calibri" pitchFamily="34" charset="-120"/>
+              </a:rPr>
+              <a:t>bass pitch-class tracking  ·  energy arc selection</a:t>
+            </a:r>
+            <a:endParaRPr lang="en-US" sz="1600" dirty="0">
+              <a:solidFill>
+                <a:prstClr val="black"/>
+              </a:solidFill>
+              <a:latin typeface="Calibri" panose="020F0502020204030204"/>
+            </a:endParaRPr>
+          </a:p>
+          <a:p>
+            <a:pPr defTabSz="1219170"/>
+            <a:r>
+              <a:rPr lang="en-US" sz="1600" dirty="0">
+                <a:solidFill>
+                  <a:srgbClr val="CADCFC"/>
+                </a:solidFill>
+                <a:latin typeface="Calibri" pitchFamily="34" charset="0"/>
+                <a:ea typeface="Calibri" pitchFamily="34" charset="-122"/>
+                <a:cs typeface="Calibri" pitchFamily="34" charset="-120"/>
+              </a:rPr>
+              <a:t>motif + lyrical motif selection  ·  register contrast scheduling</a:t>
+            </a:r>
+            <a:endParaRPr lang="en-US" sz="1600" dirty="0">
+              <a:solidFill>
+                <a:prstClr val="black"/>
+              </a:solidFill>
+              <a:latin typeface="Calibri" panose="020F0502020204030204"/>
+            </a:endParaRPr>
+          </a:p>
+          <a:p>
+            <a:pPr defTabSz="1219170"/>
+            <a:r>
+              <a:rPr lang="en-US" sz="1600" dirty="0">
+                <a:solidFill>
+                  <a:srgbClr val="CADCFC"/>
+                </a:solidFill>
+                <a:latin typeface="Calibri" pitchFamily="34" charset="0"/>
+                <a:ea typeface="Calibri" pitchFamily="34" charset="-122"/>
+                <a:cs typeface="Calibri" pitchFamily="34" charset="-120"/>
+              </a:rPr>
+              <a:t>rhythmic density + complementarity  ·  stage swing baseline</a:t>
+            </a:r>
+            <a:endParaRPr lang="en-US" sz="1600" dirty="0">
+              <a:solidFill>
+                <a:prstClr val="black"/>
+              </a:solidFill>
+              <a:latin typeface="Calibri" panose="020F0502020204030204"/>
+            </a:endParaRPr>
+          </a:p>
+        </p:txBody>
+      </p:sp>
+      <p:sp>
+        <p:nvSpPr>
+          <p:cNvPr id="30" name="Shape 28"/>
+          <p:cNvSpPr/>
+          <p:nvPr/>
+        </p:nvSpPr>
+        <p:spPr>
+          <a:xfrm>
+            <a:off x="6096000" y="4125109"/>
+            <a:ext cx="0" cy="315309"/>
+          </a:xfrm>
+          <a:prstGeom prst="line">
+            <a:avLst/>
+          </a:prstGeom>
+          <a:noFill/>
+          <a:ln w="50800">
+            <a:solidFill>
+              <a:srgbClr val="CADCFC"/>
+            </a:solidFill>
+            <a:prstDash val="solid"/>
+            <a:tailEnd type="arrow"/>
+          </a:ln>
+        </p:spPr>
+        <p:txBody>
+          <a:bodyPr/>
+          <a:lstStyle/>
+          <a:p>
+            <a:pPr defTabSz="1219170"/>
+            <a:endParaRPr lang="en-US" sz="2400">
+              <a:solidFill>
+                <a:prstClr val="black"/>
+              </a:solidFill>
+              <a:latin typeface="Calibri" panose="020F0502020204030204"/>
+            </a:endParaRPr>
+          </a:p>
+        </p:txBody>
+      </p:sp>
+      <p:sp>
+        <p:nvSpPr>
+          <p:cNvPr id="32" name="Shape 28">
+            <a:extLst>
+              <a:ext uri="{FF2B5EF4-FFF2-40B4-BE49-F238E27FC236}">
+                <a16:creationId xmlns:a16="http://schemas.microsoft.com/office/drawing/2014/main" id="{82A67C06-F31C-A34E-B75C-378998F00D80}"/>
+              </a:ext>
+            </a:extLst>
+          </p:cNvPr>
+          <p:cNvSpPr/>
+          <p:nvPr/>
+        </p:nvSpPr>
+        <p:spPr>
+          <a:xfrm>
+            <a:off x="5991749" y="6173273"/>
+            <a:ext cx="0" cy="476909"/>
+          </a:xfrm>
+          <a:prstGeom prst="line">
+            <a:avLst/>
+          </a:prstGeom>
+          <a:noFill/>
+          <a:ln w="50800">
+            <a:solidFill>
+              <a:srgbClr val="FFC000"/>
+            </a:solidFill>
+            <a:prstDash val="solid"/>
+            <a:tailEnd type="arrow"/>
+          </a:ln>
+        </p:spPr>
+        <p:txBody>
+          <a:bodyPr/>
+          <a:lstStyle/>
+          <a:p>
+            <a:pPr defTabSz="1219170"/>
+            <a:endParaRPr lang="en-US" sz="2400" dirty="0">
+              <a:solidFill>
+                <a:prstClr val="black"/>
+              </a:solidFill>
+              <a:latin typeface="Calibri" panose="020F0502020204030204"/>
+            </a:endParaRPr>
+          </a:p>
+        </p:txBody>
+      </p:sp>
+      <p:sp>
+        <p:nvSpPr>
+          <p:cNvPr id="33" name="Shape 13">
+            <a:extLst>
+              <a:ext uri="{FF2B5EF4-FFF2-40B4-BE49-F238E27FC236}">
+                <a16:creationId xmlns:a16="http://schemas.microsoft.com/office/drawing/2014/main" id="{BE87611D-8695-346E-CD03-8723D7EC6F13}"/>
+              </a:ext>
+            </a:extLst>
+          </p:cNvPr>
+          <p:cNvSpPr/>
+          <p:nvPr/>
+        </p:nvSpPr>
+        <p:spPr>
+          <a:xfrm>
+            <a:off x="4834130" y="1139298"/>
+            <a:ext cx="582300" cy="0"/>
+          </a:xfrm>
+          <a:prstGeom prst="line">
+            <a:avLst/>
+          </a:prstGeom>
+          <a:noFill/>
+          <a:ln w="50800">
+            <a:solidFill>
+              <a:srgbClr val="CADCFC"/>
+            </a:solidFill>
+            <a:prstDash val="solid"/>
+            <a:tailEnd type="arrow"/>
+          </a:ln>
+        </p:spPr>
+        <p:txBody>
+          <a:bodyPr/>
+          <a:lstStyle/>
+          <a:p>
+            <a:pPr defTabSz="1219170"/>
+            <a:endParaRPr lang="en-US" sz="2400">
+              <a:solidFill>
+                <a:prstClr val="black"/>
+              </a:solidFill>
+              <a:latin typeface="Calibri" panose="020F0502020204030204"/>
+            </a:endParaRPr>
+          </a:p>
+        </p:txBody>
+      </p:sp>
+      <p:sp>
+        <p:nvSpPr>
+          <p:cNvPr id="34" name="Shape 13">
+            <a:extLst>
+              <a:ext uri="{FF2B5EF4-FFF2-40B4-BE49-F238E27FC236}">
+                <a16:creationId xmlns:a16="http://schemas.microsoft.com/office/drawing/2014/main" id="{7493AAE1-3A41-2F24-A433-15942ED6887C}"/>
+              </a:ext>
+            </a:extLst>
+          </p:cNvPr>
+          <p:cNvSpPr/>
+          <p:nvPr/>
+        </p:nvSpPr>
+        <p:spPr>
+          <a:xfrm>
+            <a:off x="2389639" y="1108553"/>
+            <a:ext cx="377951" cy="0"/>
+          </a:xfrm>
+          <a:prstGeom prst="line">
+            <a:avLst/>
+          </a:prstGeom>
+          <a:noFill/>
+          <a:ln w="50800">
+            <a:solidFill>
+              <a:srgbClr val="CADCFC"/>
+            </a:solidFill>
+            <a:prstDash val="solid"/>
+            <a:tailEnd type="arrow"/>
+          </a:ln>
+        </p:spPr>
+        <p:txBody>
+          <a:bodyPr/>
+          <a:lstStyle/>
+          <a:p>
+            <a:pPr defTabSz="1219170"/>
+            <a:endParaRPr lang="en-US" sz="2400">
+              <a:solidFill>
+                <a:prstClr val="black"/>
+              </a:solidFill>
+              <a:latin typeface="Calibri" panose="020F0502020204030204"/>
+            </a:endParaRPr>
+          </a:p>
+        </p:txBody>
+      </p:sp>
+    </p:spTree>
+  </p:cSld>
+  <p:clrMapOvr>
+    <a:masterClrMapping/>
+  </p:clrMapOvr>
+</p:sld>
+</file>
+
+<file path=ppt/slides/slide6.xml><?xml version="1.0" encoding="utf-8"?>
+<p:sld xmlns:a="http://schemas.openxmlformats.org/drawingml/2006/main" xmlns:r="http://schemas.openxmlformats.org/officeDocument/2006/relationships" xmlns:p="http://schemas.openxmlformats.org/presentationml/2006/main">
+  <p:cSld>
+    <p:bg>
+      <p:bgPr>
+        <a:solidFill>
+          <a:srgbClr val="00B0F0"/>
+        </a:solidFill>
+        <a:effectLst/>
+      </p:bgPr>
+    </p:bg>
+    <p:spTree>
+      <p:nvGrpSpPr>
+        <p:cNvPr id="1" name=""/>
+        <p:cNvGrpSpPr/>
+        <p:nvPr/>
+      </p:nvGrpSpPr>
+      <p:grpSpPr>
+        <a:xfrm>
+          <a:off x="0" y="0"/>
+          <a:ext cx="0" cy="0"/>
+          <a:chOff x="0" y="0"/>
+          <a:chExt cx="0" cy="0"/>
+        </a:xfrm>
+      </p:grpSpPr>
+      <p:sp>
+        <p:nvSpPr>
+          <p:cNvPr id="3" name="Text 1"/>
+          <p:cNvSpPr/>
+          <p:nvPr/>
+        </p:nvSpPr>
+        <p:spPr>
+          <a:xfrm>
+            <a:off x="8847152" y="620973"/>
+            <a:ext cx="2628677" cy="1394410"/>
+          </a:xfrm>
+          <a:prstGeom prst="rect">
+            <a:avLst/>
+          </a:prstGeom>
+          <a:noFill/>
+          <a:ln/>
+        </p:spPr>
+        <p:txBody>
+          <a:bodyPr wrap="square" lIns="0" tIns="0" rIns="0" bIns="0" rtlCol="0" anchor="ctr"/>
+          <a:lstStyle/>
+          <a:p>
+            <a:pPr defTabSz="1219170"/>
+            <a:r>
+              <a:rPr lang="en-US" sz="4000" b="1" dirty="0">
+                <a:solidFill>
+                  <a:srgbClr val="FFFFFF"/>
+                </a:solidFill>
+                <a:latin typeface="Calibri" pitchFamily="34" charset="0"/>
+                <a:ea typeface="Calibri" pitchFamily="34" charset="-122"/>
+                <a:cs typeface="Calibri" pitchFamily="34" charset="-120"/>
+              </a:rPr>
+              <a:t>Generation</a:t>
+            </a:r>
+            <a:endParaRPr lang="en-US" sz="4000" dirty="0">
+              <a:solidFill>
+                <a:prstClr val="black"/>
+              </a:solidFill>
+              <a:latin typeface="Calibri" panose="020F0502020204030204"/>
+            </a:endParaRPr>
+          </a:p>
+        </p:txBody>
+      </p:sp>
+      <p:sp>
+        <p:nvSpPr>
+          <p:cNvPr id="4" name="Shape 2"/>
+          <p:cNvSpPr/>
+          <p:nvPr/>
+        </p:nvSpPr>
+        <p:spPr>
+          <a:xfrm>
+            <a:off x="3573266" y="877825"/>
+            <a:ext cx="2767053" cy="536448"/>
+          </a:xfrm>
+          <a:prstGeom prst="roundRect">
+            <a:avLst>
+              <a:gd name="adj" fmla="val 18182"/>
+            </a:avLst>
+          </a:prstGeom>
+          <a:solidFill>
+            <a:srgbClr val="253880"/>
+          </a:solidFill>
+          <a:ln w="25400">
+            <a:solidFill>
+              <a:srgbClr val="CADCFC"/>
+            </a:solidFill>
+            <a:prstDash val="solid"/>
+          </a:ln>
+        </p:spPr>
+        <p:txBody>
+          <a:bodyPr/>
+          <a:lstStyle/>
+          <a:p>
+            <a:pPr defTabSz="1219170"/>
+            <a:endParaRPr lang="en-US" sz="3200">
+              <a:solidFill>
+                <a:prstClr val="black"/>
+              </a:solidFill>
+              <a:latin typeface="Calibri" panose="020F0502020204030204"/>
+            </a:endParaRPr>
+          </a:p>
+        </p:txBody>
+      </p:sp>
+      <p:sp>
+        <p:nvSpPr>
+          <p:cNvPr id="5" name="Text 3"/>
+          <p:cNvSpPr/>
+          <p:nvPr/>
+        </p:nvSpPr>
+        <p:spPr>
+          <a:xfrm>
+            <a:off x="2762232" y="877825"/>
+            <a:ext cx="4389120" cy="536448"/>
+          </a:xfrm>
+          <a:prstGeom prst="rect">
+            <a:avLst/>
+          </a:prstGeom>
+          <a:noFill/>
+          <a:ln/>
+        </p:spPr>
+        <p:txBody>
+          <a:bodyPr wrap="square" lIns="67733" tIns="67733" rIns="67733" bIns="67733" rtlCol="0" anchor="ctr"/>
+          <a:lstStyle/>
+          <a:p>
+            <a:pPr algn="ctr" defTabSz="1219170"/>
+            <a:r>
+              <a:rPr lang="en-US" sz="2400" b="1" dirty="0" err="1">
+                <a:solidFill>
+                  <a:srgbClr val="FFFFFF"/>
+                </a:solidFill>
+                <a:latin typeface="Calibri" pitchFamily="34" charset="0"/>
+                <a:ea typeface="Calibri" pitchFamily="34" charset="-122"/>
+                <a:cs typeface="Calibri" pitchFamily="34" charset="-120"/>
+              </a:rPr>
+              <a:t>ArcController</a:t>
+            </a:r>
+            <a:endParaRPr lang="en-US" sz="2400" dirty="0">
+              <a:solidFill>
+                <a:prstClr val="black"/>
+              </a:solidFill>
+              <a:latin typeface="Calibri" panose="020F0502020204030204"/>
+            </a:endParaRPr>
+          </a:p>
+        </p:txBody>
+      </p:sp>
+      <p:sp>
+        <p:nvSpPr>
+          <p:cNvPr id="6" name="Shape 4"/>
+          <p:cNvSpPr/>
+          <p:nvPr/>
+        </p:nvSpPr>
+        <p:spPr>
+          <a:xfrm>
+            <a:off x="2730957" y="1775399"/>
+            <a:ext cx="4420393" cy="717212"/>
+          </a:xfrm>
+          <a:prstGeom prst="roundRect">
+            <a:avLst>
+              <a:gd name="adj" fmla="val 15385"/>
+            </a:avLst>
+          </a:prstGeom>
+          <a:solidFill>
+            <a:srgbClr val="2A3570"/>
+          </a:solidFill>
+          <a:ln w="19050">
+            <a:solidFill>
+              <a:srgbClr val="CADCFC"/>
+            </a:solidFill>
+            <a:prstDash val="solid"/>
+          </a:ln>
+        </p:spPr>
+        <p:txBody>
+          <a:bodyPr/>
+          <a:lstStyle/>
+          <a:p>
+            <a:pPr defTabSz="1219170"/>
+            <a:endParaRPr lang="en-US" sz="3200">
+              <a:solidFill>
+                <a:prstClr val="black"/>
+              </a:solidFill>
+              <a:latin typeface="Calibri" panose="020F0502020204030204"/>
+            </a:endParaRPr>
+          </a:p>
+        </p:txBody>
+      </p:sp>
+      <p:sp>
+        <p:nvSpPr>
+          <p:cNvPr id="7" name="Text 5"/>
+          <p:cNvSpPr/>
+          <p:nvPr/>
+        </p:nvSpPr>
+        <p:spPr>
+          <a:xfrm>
+            <a:off x="3188952" y="1858626"/>
+            <a:ext cx="3535680" cy="316992"/>
+          </a:xfrm>
+          <a:prstGeom prst="rect">
+            <a:avLst/>
+          </a:prstGeom>
+          <a:noFill/>
+          <a:ln/>
+        </p:spPr>
+        <p:txBody>
+          <a:bodyPr wrap="square" lIns="0" tIns="0" rIns="0" bIns="0" rtlCol="0" anchor="ctr"/>
+          <a:lstStyle/>
+          <a:p>
+            <a:pPr algn="ctr" defTabSz="1219170"/>
+            <a:r>
+              <a:rPr lang="en-US" sz="2400" b="1" dirty="0">
+                <a:solidFill>
+                  <a:srgbClr val="FFFFFF"/>
+                </a:solidFill>
+                <a:latin typeface="Calibri" pitchFamily="34" charset="0"/>
+                <a:ea typeface="Calibri" pitchFamily="34" charset="-122"/>
+                <a:cs typeface="Calibri" pitchFamily="34" charset="-120"/>
+              </a:rPr>
+              <a:t>HarmonyController</a:t>
+            </a:r>
+            <a:endParaRPr lang="en-US" sz="2400" dirty="0">
+              <a:solidFill>
+                <a:prstClr val="black"/>
+              </a:solidFill>
+              <a:latin typeface="Calibri" panose="020F0502020204030204"/>
+            </a:endParaRPr>
+          </a:p>
+        </p:txBody>
+      </p:sp>
+      <p:sp>
+        <p:nvSpPr>
+          <p:cNvPr id="8" name="Text 6"/>
+          <p:cNvSpPr/>
+          <p:nvPr/>
+        </p:nvSpPr>
+        <p:spPr>
+          <a:xfrm>
+            <a:off x="2862951" y="2175089"/>
+            <a:ext cx="4187683" cy="268224"/>
+          </a:xfrm>
+          <a:prstGeom prst="rect">
+            <a:avLst/>
+          </a:prstGeom>
+          <a:noFill/>
+          <a:ln/>
+        </p:spPr>
+        <p:txBody>
+          <a:bodyPr wrap="square" lIns="33867" tIns="33867" rIns="33867" bIns="33867" rtlCol="0" anchor="t"/>
+          <a:lstStyle/>
+          <a:p>
+            <a:pPr defTabSz="1219170"/>
+            <a:r>
+              <a:rPr lang="en-US" sz="1600" dirty="0">
+                <a:solidFill>
+                  <a:srgbClr val="CADCFC"/>
+                </a:solidFill>
+                <a:latin typeface="Calibri" pitchFamily="34" charset="0"/>
+                <a:ea typeface="Calibri" pitchFamily="34" charset="-122"/>
+                <a:cs typeface="Calibri" pitchFamily="34" charset="-120"/>
+              </a:rPr>
+              <a:t>mode, progression, pedal  ·  tritone substitution</a:t>
+            </a:r>
+            <a:endParaRPr lang="en-US" sz="1600" dirty="0">
+              <a:solidFill>
+                <a:prstClr val="black"/>
+              </a:solidFill>
+              <a:latin typeface="Calibri" panose="020F0502020204030204"/>
+            </a:endParaRPr>
+          </a:p>
+        </p:txBody>
+      </p:sp>
+      <p:sp>
+        <p:nvSpPr>
+          <p:cNvPr id="10" name="Shape 8"/>
+          <p:cNvSpPr/>
+          <p:nvPr/>
+        </p:nvSpPr>
+        <p:spPr>
+          <a:xfrm>
+            <a:off x="1177272" y="2920754"/>
+            <a:ext cx="7559040" cy="2022280"/>
+          </a:xfrm>
+          <a:prstGeom prst="roundRect">
+            <a:avLst>
+              <a:gd name="adj" fmla="val 6780"/>
+            </a:avLst>
+          </a:prstGeom>
+          <a:solidFill>
+            <a:srgbClr val="253880"/>
+          </a:solidFill>
+          <a:ln w="25400">
+            <a:solidFill>
+              <a:srgbClr val="CADCFC"/>
+            </a:solidFill>
+            <a:prstDash val="solid"/>
+          </a:ln>
+        </p:spPr>
+        <p:txBody>
+          <a:bodyPr/>
+          <a:lstStyle/>
+          <a:p>
+            <a:pPr defTabSz="1219170"/>
+            <a:endParaRPr lang="en-US" sz="3200">
+              <a:solidFill>
+                <a:prstClr val="black"/>
+              </a:solidFill>
+              <a:latin typeface="Calibri" panose="020F0502020204030204"/>
+            </a:endParaRPr>
+          </a:p>
+        </p:txBody>
+      </p:sp>
+      <p:sp>
+        <p:nvSpPr>
+          <p:cNvPr id="11" name="Text 9"/>
+          <p:cNvSpPr/>
+          <p:nvPr/>
+        </p:nvSpPr>
+        <p:spPr>
+          <a:xfrm>
+            <a:off x="1238232" y="2989129"/>
+            <a:ext cx="7437120" cy="316992"/>
+          </a:xfrm>
+          <a:prstGeom prst="rect">
+            <a:avLst/>
+          </a:prstGeom>
+          <a:noFill/>
+          <a:ln/>
+        </p:spPr>
+        <p:txBody>
+          <a:bodyPr wrap="square" lIns="0" tIns="0" rIns="0" bIns="0" rtlCol="0" anchor="ctr"/>
+          <a:lstStyle/>
+          <a:p>
+            <a:pPr algn="ctr" defTabSz="1219170"/>
+            <a:r>
+              <a:rPr lang="en-US" sz="2400" b="1" dirty="0">
+                <a:solidFill>
+                  <a:srgbClr val="FFFFFF"/>
+                </a:solidFill>
+                <a:latin typeface="Calibri" pitchFamily="34" charset="0"/>
+                <a:ea typeface="Calibri" pitchFamily="34" charset="-122"/>
+                <a:cs typeface="Calibri" pitchFamily="34" charset="-120"/>
+              </a:rPr>
+              <a:t>PhraseGenerator (LSTM)</a:t>
+            </a:r>
+            <a:endParaRPr lang="en-US" sz="2400" dirty="0">
+              <a:solidFill>
+                <a:prstClr val="black"/>
+              </a:solidFill>
+              <a:latin typeface="Calibri" panose="020F0502020204030204"/>
+            </a:endParaRPr>
+          </a:p>
+        </p:txBody>
+      </p:sp>
+      <p:sp>
+        <p:nvSpPr>
+          <p:cNvPr id="12" name="Text 10"/>
+          <p:cNvSpPr/>
+          <p:nvPr/>
+        </p:nvSpPr>
+        <p:spPr>
+          <a:xfrm>
+            <a:off x="2073118" y="3354889"/>
+            <a:ext cx="6565657" cy="1072896"/>
+          </a:xfrm>
+          <a:prstGeom prst="rect">
+            <a:avLst/>
+          </a:prstGeom>
+          <a:noFill/>
+          <a:ln/>
+        </p:spPr>
+        <p:txBody>
+          <a:bodyPr wrap="square" lIns="33867" tIns="33867" rIns="33867" bIns="33867" rtlCol="0" anchor="t"/>
+          <a:lstStyle/>
+          <a:p>
+            <a:pPr defTabSz="1219170"/>
+            <a:r>
+              <a:rPr lang="en-US" sz="1600" dirty="0">
+                <a:solidFill>
+                  <a:srgbClr val="CADCFC"/>
+                </a:solidFill>
+                <a:latin typeface="Calibri" pitchFamily="34" charset="0"/>
+                <a:ea typeface="Calibri" pitchFamily="34" charset="-122"/>
+                <a:cs typeface="Calibri" pitchFamily="34" charset="-120"/>
+              </a:rPr>
+              <a:t>LSTM + chord conditioning  ·  pitch range limits + register gravity</a:t>
+            </a:r>
+            <a:endParaRPr lang="en-US" sz="1600" dirty="0">
+              <a:solidFill>
+                <a:prstClr val="black"/>
+              </a:solidFill>
+              <a:latin typeface="Calibri" panose="020F0502020204030204"/>
+            </a:endParaRPr>
+          </a:p>
+          <a:p>
+            <a:pPr defTabSz="1219170"/>
+            <a:r>
+              <a:rPr lang="en-US" sz="1600" dirty="0">
+                <a:solidFill>
+                  <a:srgbClr val="CADCFC"/>
+                </a:solidFill>
+                <a:latin typeface="Calibri" pitchFamily="34" charset="0"/>
+                <a:ea typeface="Calibri" pitchFamily="34" charset="-122"/>
+                <a:cs typeface="Calibri" pitchFamily="34" charset="-120"/>
+              </a:rPr>
+              <a:t>register contrast  ·  scale pitch bias  ·  contour steering</a:t>
+            </a:r>
+            <a:endParaRPr lang="en-US" sz="1600" dirty="0">
+              <a:solidFill>
+                <a:prstClr val="black"/>
+              </a:solidFill>
+              <a:latin typeface="Calibri" panose="020F0502020204030204"/>
+            </a:endParaRPr>
+          </a:p>
+          <a:p>
+            <a:pPr defTabSz="1219170"/>
+            <a:r>
+              <a:rPr lang="en-US" sz="1600" dirty="0">
+                <a:solidFill>
+                  <a:srgbClr val="CADCFC"/>
+                </a:solidFill>
+                <a:latin typeface="Calibri" pitchFamily="34" charset="0"/>
+                <a:ea typeface="Calibri" pitchFamily="34" charset="-122"/>
+                <a:cs typeface="Calibri" pitchFamily="34" charset="-120"/>
+              </a:rPr>
+              <a:t>swing/triplet bias  ·  energy arc shaping</a:t>
+            </a:r>
+            <a:endParaRPr lang="en-US" sz="1600" dirty="0">
+              <a:solidFill>
+                <a:prstClr val="black"/>
+              </a:solidFill>
+              <a:latin typeface="Calibri" panose="020F0502020204030204"/>
+            </a:endParaRPr>
+          </a:p>
+          <a:p>
+            <a:pPr defTabSz="1219170"/>
+            <a:r>
+              <a:rPr lang="en-US" sz="1600" dirty="0">
+                <a:solidFill>
+                  <a:srgbClr val="CADCFC"/>
+                </a:solidFill>
+                <a:latin typeface="Calibri" pitchFamily="34" charset="0"/>
+                <a:ea typeface="Calibri" pitchFamily="34" charset="-122"/>
+                <a:cs typeface="Calibri" pitchFamily="34" charset="-120"/>
+              </a:rPr>
+              <a:t>long-note penalty + singable duration bias  ·  motivic development</a:t>
+            </a:r>
+            <a:endParaRPr lang="en-US" sz="1600" dirty="0">
+              <a:solidFill>
+                <a:prstClr val="black"/>
+              </a:solidFill>
+              <a:latin typeface="Calibri" panose="020F0502020204030204"/>
+            </a:endParaRPr>
+          </a:p>
+          <a:p>
+            <a:pPr defTabSz="1219170"/>
+            <a:r>
+              <a:rPr lang="en-US" sz="1600" dirty="0">
+                <a:solidFill>
+                  <a:srgbClr val="CADCFC"/>
+                </a:solidFill>
+                <a:latin typeface="Calibri" pitchFamily="34" charset="0"/>
+                <a:ea typeface="Calibri" pitchFamily="34" charset="-122"/>
+                <a:cs typeface="Calibri" pitchFamily="34" charset="-120"/>
+              </a:rPr>
+              <a:t>voice leading  ·  modal leap bonus (P4/P5)  ·  repetition penalty</a:t>
+            </a:r>
+            <a:endParaRPr lang="en-US" sz="1600" dirty="0">
+              <a:solidFill>
+                <a:prstClr val="black"/>
+              </a:solidFill>
+              <a:latin typeface="Calibri" panose="020F0502020204030204"/>
+            </a:endParaRPr>
+          </a:p>
+          <a:p>
+            <a:pPr defTabSz="1219170"/>
+            <a:r>
+              <a:rPr lang="en-US" sz="1600" dirty="0">
+                <a:solidFill>
+                  <a:srgbClr val="CADCFC"/>
+                </a:solidFill>
+                <a:latin typeface="Calibri" pitchFamily="34" charset="0"/>
+                <a:ea typeface="Calibri" pitchFamily="34" charset="-122"/>
+                <a:cs typeface="Calibri" pitchFamily="34" charset="-120"/>
+              </a:rPr>
+              <a:t>rest injection  ·  beat accumulator</a:t>
+            </a:r>
+            <a:endParaRPr lang="en-US" sz="1600" dirty="0">
+              <a:solidFill>
+                <a:prstClr val="black"/>
+              </a:solidFill>
+              <a:latin typeface="Calibri" panose="020F0502020204030204"/>
+            </a:endParaRPr>
+          </a:p>
+        </p:txBody>
+      </p:sp>
+      <p:sp>
+        <p:nvSpPr>
+          <p:cNvPr id="14" name="Shape 12"/>
+          <p:cNvSpPr/>
+          <p:nvPr/>
+        </p:nvSpPr>
+        <p:spPr>
+          <a:xfrm>
+            <a:off x="644533" y="5446620"/>
+            <a:ext cx="2129360" cy="1114235"/>
+          </a:xfrm>
+          <a:prstGeom prst="roundRect">
+            <a:avLst>
+              <a:gd name="adj" fmla="val 12308"/>
+            </a:avLst>
+          </a:prstGeom>
+          <a:solidFill>
+            <a:srgbClr val="2A3570"/>
+          </a:solidFill>
+          <a:ln w="19050">
+            <a:solidFill>
+              <a:srgbClr val="CADCFC"/>
+            </a:solidFill>
+            <a:prstDash val="solid"/>
+          </a:ln>
+        </p:spPr>
+        <p:txBody>
+          <a:bodyPr/>
+          <a:lstStyle/>
+          <a:p>
+            <a:pPr defTabSz="1219170"/>
+            <a:endParaRPr lang="en-US" sz="3200">
+              <a:solidFill>
+                <a:prstClr val="black"/>
+              </a:solidFill>
+              <a:latin typeface="Calibri" panose="020F0502020204030204"/>
+            </a:endParaRPr>
+          </a:p>
+        </p:txBody>
+      </p:sp>
+      <p:sp>
+        <p:nvSpPr>
+          <p:cNvPr id="15" name="Text 13"/>
+          <p:cNvSpPr/>
+          <p:nvPr/>
+        </p:nvSpPr>
+        <p:spPr>
+          <a:xfrm>
+            <a:off x="438329" y="5541193"/>
+            <a:ext cx="2560320" cy="316992"/>
+          </a:xfrm>
+          <a:prstGeom prst="rect">
+            <a:avLst/>
+          </a:prstGeom>
+          <a:noFill/>
+          <a:ln/>
+        </p:spPr>
+        <p:txBody>
+          <a:bodyPr wrap="square" lIns="0" tIns="0" rIns="0" bIns="0" rtlCol="0" anchor="ctr"/>
+          <a:lstStyle/>
+          <a:p>
+            <a:pPr algn="ctr" defTabSz="1219170"/>
+            <a:r>
+              <a:rPr lang="en-US" sz="2400" b="1" dirty="0">
+                <a:solidFill>
+                  <a:srgbClr val="FFFFFF"/>
+                </a:solidFill>
+                <a:latin typeface="Calibri" pitchFamily="34" charset="0"/>
+                <a:ea typeface="Calibri" pitchFamily="34" charset="-122"/>
+                <a:cs typeface="Calibri" pitchFamily="34" charset="-120"/>
+              </a:rPr>
+              <a:t>PhraseMemory</a:t>
+            </a:r>
+            <a:endParaRPr lang="en-US" sz="2400" dirty="0">
+              <a:solidFill>
+                <a:prstClr val="black"/>
+              </a:solidFill>
+              <a:latin typeface="Calibri" panose="020F0502020204030204"/>
+            </a:endParaRPr>
+          </a:p>
+        </p:txBody>
+      </p:sp>
+      <p:sp>
+        <p:nvSpPr>
+          <p:cNvPr id="16" name="Text 14"/>
+          <p:cNvSpPr/>
+          <p:nvPr/>
+        </p:nvSpPr>
+        <p:spPr>
+          <a:xfrm>
+            <a:off x="832714" y="5906953"/>
+            <a:ext cx="2129359" cy="560832"/>
+          </a:xfrm>
+          <a:prstGeom prst="rect">
+            <a:avLst/>
+          </a:prstGeom>
+          <a:noFill/>
+          <a:ln/>
+        </p:spPr>
+        <p:txBody>
+          <a:bodyPr wrap="square" lIns="33867" tIns="33867" rIns="33867" bIns="33867" rtlCol="0" anchor="t"/>
+          <a:lstStyle/>
+          <a:p>
+            <a:pPr defTabSz="1219170"/>
+            <a:r>
+              <a:rPr lang="en-US" sz="1600" dirty="0">
+                <a:solidFill>
+                  <a:srgbClr val="CADCFC"/>
+                </a:solidFill>
+                <a:latin typeface="Calibri" pitchFamily="34" charset="0"/>
+                <a:ea typeface="Calibri" pitchFamily="34" charset="-122"/>
+                <a:cs typeface="Calibri" pitchFamily="34" charset="-120"/>
+              </a:rPr>
+              <a:t>motifs, recall,</a:t>
+            </a:r>
+            <a:endParaRPr lang="en-US" sz="1600" dirty="0">
+              <a:solidFill>
+                <a:prstClr val="black"/>
+              </a:solidFill>
+              <a:latin typeface="Calibri" panose="020F0502020204030204"/>
+            </a:endParaRPr>
+          </a:p>
+          <a:p>
+            <a:pPr defTabSz="1219170"/>
+            <a:r>
+              <a:rPr lang="en-US" sz="1600" dirty="0">
+                <a:solidFill>
+                  <a:srgbClr val="CADCFC"/>
+                </a:solidFill>
+                <a:latin typeface="Calibri" pitchFamily="34" charset="0"/>
+                <a:ea typeface="Calibri" pitchFamily="34" charset="-122"/>
+                <a:cs typeface="Calibri" pitchFamily="34" charset="-120"/>
+              </a:rPr>
+              <a:t>self-play seed</a:t>
+            </a:r>
+            <a:endParaRPr lang="en-US" sz="1600" dirty="0">
+              <a:solidFill>
+                <a:prstClr val="black"/>
+              </a:solidFill>
+              <a:latin typeface="Calibri" panose="020F0502020204030204"/>
+            </a:endParaRPr>
+          </a:p>
+        </p:txBody>
+      </p:sp>
+      <p:sp>
+        <p:nvSpPr>
+          <p:cNvPr id="17" name="Shape 15"/>
+          <p:cNvSpPr/>
+          <p:nvPr/>
+        </p:nvSpPr>
+        <p:spPr>
+          <a:xfrm>
+            <a:off x="3310872" y="5436019"/>
+            <a:ext cx="3291840" cy="1193225"/>
+          </a:xfrm>
+          <a:prstGeom prst="roundRect">
+            <a:avLst>
+              <a:gd name="adj" fmla="val 12308"/>
+            </a:avLst>
+          </a:prstGeom>
+          <a:solidFill>
+            <a:srgbClr val="2A3570"/>
+          </a:solidFill>
+          <a:ln w="19050">
+            <a:solidFill>
+              <a:srgbClr val="CADCFC"/>
+            </a:solidFill>
+            <a:prstDash val="solid"/>
+          </a:ln>
+        </p:spPr>
+        <p:txBody>
+          <a:bodyPr/>
+          <a:lstStyle/>
+          <a:p>
+            <a:pPr defTabSz="1219170"/>
+            <a:endParaRPr lang="en-US" sz="3200">
+              <a:solidFill>
+                <a:prstClr val="black"/>
+              </a:solidFill>
+              <a:latin typeface="Calibri" panose="020F0502020204030204"/>
+            </a:endParaRPr>
+          </a:p>
+        </p:txBody>
+      </p:sp>
+      <p:sp>
+        <p:nvSpPr>
+          <p:cNvPr id="18" name="Text 16"/>
+          <p:cNvSpPr/>
+          <p:nvPr/>
+        </p:nvSpPr>
+        <p:spPr>
+          <a:xfrm>
+            <a:off x="3371832" y="5695449"/>
+            <a:ext cx="3169920" cy="316992"/>
+          </a:xfrm>
+          <a:prstGeom prst="rect">
+            <a:avLst/>
+          </a:prstGeom>
+          <a:noFill/>
+          <a:ln/>
+        </p:spPr>
+        <p:txBody>
+          <a:bodyPr wrap="square" lIns="0" tIns="0" rIns="0" bIns="0" rtlCol="0" anchor="ctr"/>
+          <a:lstStyle/>
+          <a:p>
+            <a:pPr algn="ctr" defTabSz="1219170"/>
+            <a:r>
+              <a:rPr lang="en-US" sz="2400" b="1" dirty="0">
+                <a:solidFill>
+                  <a:srgbClr val="FFFFFF"/>
+                </a:solidFill>
+                <a:latin typeface="Calibri" pitchFamily="34" charset="0"/>
+                <a:ea typeface="Calibri" pitchFamily="34" charset="-122"/>
+                <a:cs typeface="Calibri" pitchFamily="34" charset="-120"/>
+              </a:rPr>
+              <a:t>WebAudienceDisplay / OscOutput</a:t>
+            </a:r>
+            <a:endParaRPr lang="en-US" sz="2400" dirty="0">
+              <a:solidFill>
+                <a:prstClr val="black"/>
+              </a:solidFill>
+              <a:latin typeface="Calibri" panose="020F0502020204030204"/>
+            </a:endParaRPr>
+          </a:p>
+        </p:txBody>
+      </p:sp>
+      <p:sp>
+        <p:nvSpPr>
+          <p:cNvPr id="19" name="Text 17"/>
+          <p:cNvSpPr/>
+          <p:nvPr/>
+        </p:nvSpPr>
+        <p:spPr>
+          <a:xfrm>
+            <a:off x="3495872" y="6222668"/>
+            <a:ext cx="2921840" cy="426720"/>
+          </a:xfrm>
+          <a:prstGeom prst="rect">
+            <a:avLst/>
+          </a:prstGeom>
+          <a:noFill/>
+          <a:ln/>
+        </p:spPr>
+        <p:txBody>
+          <a:bodyPr wrap="square" lIns="33867" tIns="33867" rIns="33867" bIns="33867" rtlCol="0" anchor="t"/>
+          <a:lstStyle/>
+          <a:p>
+            <a:pPr defTabSz="1219170"/>
+            <a:r>
+              <a:rPr lang="en-US" sz="1600" dirty="0">
+                <a:solidFill>
+                  <a:srgbClr val="CADCFC"/>
+                </a:solidFill>
+                <a:latin typeface="Calibri" pitchFamily="34" charset="0"/>
+                <a:ea typeface="Calibri" pitchFamily="34" charset="-122"/>
+                <a:cs typeface="Calibri" pitchFamily="34" charset="-120"/>
+              </a:rPr>
+              <a:t>always sees full intended phrase</a:t>
+            </a:r>
+            <a:endParaRPr lang="en-US" sz="1600" dirty="0">
+              <a:solidFill>
+                <a:prstClr val="black"/>
+              </a:solidFill>
+              <a:latin typeface="Calibri" panose="020F0502020204030204"/>
+            </a:endParaRPr>
+          </a:p>
+        </p:txBody>
+      </p:sp>
+      <p:sp>
+        <p:nvSpPr>
+          <p:cNvPr id="20" name="Shape 18"/>
+          <p:cNvSpPr/>
+          <p:nvPr/>
+        </p:nvSpPr>
+        <p:spPr>
+          <a:xfrm>
+            <a:off x="9334831" y="2920754"/>
+            <a:ext cx="2316480" cy="1288382"/>
+          </a:xfrm>
+          <a:prstGeom prst="roundRect">
+            <a:avLst>
+              <a:gd name="adj" fmla="val 12308"/>
+            </a:avLst>
+          </a:prstGeom>
+          <a:solidFill>
+            <a:srgbClr val="2A3570"/>
+          </a:solidFill>
+          <a:ln w="19050">
+            <a:solidFill>
+              <a:srgbClr val="CADCFC"/>
+            </a:solidFill>
+            <a:prstDash val="solid"/>
+          </a:ln>
+        </p:spPr>
+        <p:txBody>
+          <a:bodyPr/>
+          <a:lstStyle/>
+          <a:p>
+            <a:pPr defTabSz="1219170"/>
+            <a:endParaRPr lang="en-US" sz="3200">
+              <a:solidFill>
+                <a:prstClr val="black"/>
+              </a:solidFill>
+              <a:latin typeface="Calibri" panose="020F0502020204030204"/>
+            </a:endParaRPr>
+          </a:p>
+        </p:txBody>
+      </p:sp>
+      <p:sp>
+        <p:nvSpPr>
+          <p:cNvPr id="21" name="Text 19"/>
+          <p:cNvSpPr/>
+          <p:nvPr/>
+        </p:nvSpPr>
+        <p:spPr>
+          <a:xfrm>
+            <a:off x="9391815" y="3110921"/>
+            <a:ext cx="2194560" cy="469393"/>
+          </a:xfrm>
+          <a:prstGeom prst="rect">
+            <a:avLst/>
+          </a:prstGeom>
+          <a:noFill/>
+          <a:ln/>
+        </p:spPr>
+        <p:txBody>
+          <a:bodyPr wrap="square" lIns="0" tIns="0" rIns="0" bIns="0" rtlCol="0" anchor="ctr"/>
+          <a:lstStyle/>
+          <a:p>
+            <a:pPr algn="ctr" defTabSz="1219170"/>
+            <a:r>
+              <a:rPr lang="en-US" sz="2400" b="1" dirty="0">
+                <a:solidFill>
+                  <a:srgbClr val="FFFFFF"/>
+                </a:solidFill>
+                <a:latin typeface="Calibri" pitchFamily="34" charset="0"/>
+                <a:ea typeface="Calibri" pitchFamily="34" charset="-122"/>
+                <a:cs typeface="Calibri" pitchFamily="34" charset="-120"/>
+              </a:rPr>
+              <a:t>Performance thinning</a:t>
+            </a:r>
+            <a:endParaRPr lang="en-US" sz="2400" dirty="0">
+              <a:solidFill>
+                <a:prstClr val="black"/>
+              </a:solidFill>
+              <a:latin typeface="Calibri" panose="020F0502020204030204"/>
+            </a:endParaRPr>
+          </a:p>
+        </p:txBody>
+      </p:sp>
+      <p:sp>
+        <p:nvSpPr>
+          <p:cNvPr id="22" name="Text 20"/>
+          <p:cNvSpPr/>
+          <p:nvPr/>
+        </p:nvSpPr>
+        <p:spPr>
+          <a:xfrm>
+            <a:off x="9432367" y="3656791"/>
+            <a:ext cx="2121408" cy="627889"/>
+          </a:xfrm>
+          <a:prstGeom prst="rect">
+            <a:avLst/>
+          </a:prstGeom>
+          <a:noFill/>
+          <a:ln/>
+        </p:spPr>
+        <p:txBody>
+          <a:bodyPr wrap="square" lIns="33867" tIns="33867" rIns="33867" bIns="33867" rtlCol="0" anchor="t"/>
+          <a:lstStyle/>
+          <a:p>
+            <a:pPr defTabSz="1219170"/>
+            <a:r>
+              <a:rPr lang="en-US" sz="1600" dirty="0">
+                <a:solidFill>
+                  <a:srgbClr val="CADCFC"/>
+                </a:solidFill>
+                <a:latin typeface="Calibri" pitchFamily="34" charset="0"/>
+                <a:ea typeface="Calibri" pitchFamily="34" charset="-122"/>
+                <a:cs typeface="Calibri" pitchFamily="34" charset="-120"/>
+              </a:rPr>
+              <a:t>short notes dropped</a:t>
+            </a:r>
+            <a:endParaRPr lang="en-US" sz="1600" dirty="0">
+              <a:solidFill>
+                <a:prstClr val="black"/>
+              </a:solidFill>
+              <a:latin typeface="Calibri" panose="020F0502020204030204"/>
+            </a:endParaRPr>
+          </a:p>
+          <a:p>
+            <a:pPr defTabSz="1219170"/>
+            <a:r>
+              <a:rPr lang="en-US" sz="1600" dirty="0">
+                <a:solidFill>
+                  <a:srgbClr val="CADCFC"/>
+                </a:solidFill>
+                <a:latin typeface="Calibri" pitchFamily="34" charset="0"/>
+                <a:ea typeface="Calibri" pitchFamily="34" charset="-122"/>
+                <a:cs typeface="Calibri" pitchFamily="34" charset="-120"/>
+              </a:rPr>
+              <a:t>stochastically</a:t>
+            </a:r>
+            <a:endParaRPr lang="en-US" sz="1600" dirty="0">
+              <a:solidFill>
+                <a:prstClr val="black"/>
+              </a:solidFill>
+              <a:latin typeface="Calibri" panose="020F0502020204030204"/>
+            </a:endParaRPr>
+          </a:p>
+        </p:txBody>
+      </p:sp>
+      <p:sp>
+        <p:nvSpPr>
+          <p:cNvPr id="23" name="Shape 21"/>
+          <p:cNvSpPr/>
+          <p:nvPr/>
+        </p:nvSpPr>
+        <p:spPr>
+          <a:xfrm>
+            <a:off x="9334831" y="4699726"/>
+            <a:ext cx="2316480" cy="998153"/>
+          </a:xfrm>
+          <a:prstGeom prst="roundRect">
+            <a:avLst>
+              <a:gd name="adj" fmla="val 17391"/>
+            </a:avLst>
+          </a:prstGeom>
+          <a:solidFill>
+            <a:srgbClr val="2A3570"/>
+          </a:solidFill>
+          <a:ln w="19050">
+            <a:solidFill>
+              <a:srgbClr val="CADCFC"/>
+            </a:solidFill>
+            <a:prstDash val="solid"/>
+          </a:ln>
+        </p:spPr>
+        <p:txBody>
+          <a:bodyPr/>
+          <a:lstStyle/>
+          <a:p>
+            <a:pPr defTabSz="1219170"/>
+            <a:endParaRPr lang="en-US" sz="3200">
+              <a:solidFill>
+                <a:prstClr val="black"/>
+              </a:solidFill>
+              <a:latin typeface="Calibri" panose="020F0502020204030204"/>
+            </a:endParaRPr>
+          </a:p>
+        </p:txBody>
+      </p:sp>
+      <p:sp>
+        <p:nvSpPr>
+          <p:cNvPr id="24" name="Text 22"/>
+          <p:cNvSpPr/>
+          <p:nvPr/>
+        </p:nvSpPr>
+        <p:spPr>
+          <a:xfrm>
+            <a:off x="9395791" y="4794298"/>
+            <a:ext cx="2194560" cy="316992"/>
+          </a:xfrm>
+          <a:prstGeom prst="rect">
+            <a:avLst/>
+          </a:prstGeom>
+          <a:noFill/>
+          <a:ln/>
+        </p:spPr>
+        <p:txBody>
+          <a:bodyPr wrap="square" lIns="0" tIns="0" rIns="0" bIns="0" rtlCol="0" anchor="ctr"/>
+          <a:lstStyle/>
+          <a:p>
+            <a:pPr algn="ctr" defTabSz="1219170"/>
+            <a:r>
+              <a:rPr lang="en-US" sz="2400" b="1" dirty="0">
+                <a:solidFill>
+                  <a:srgbClr val="FFFFFF"/>
+                </a:solidFill>
+                <a:latin typeface="Calibri" pitchFamily="34" charset="0"/>
+                <a:ea typeface="Calibri" pitchFamily="34" charset="-122"/>
+                <a:cs typeface="Calibri" pitchFamily="34" charset="-120"/>
+              </a:rPr>
+              <a:t>MidiOutput</a:t>
+            </a:r>
+            <a:endParaRPr lang="en-US" sz="2400" dirty="0">
+              <a:solidFill>
+                <a:prstClr val="black"/>
+              </a:solidFill>
+              <a:latin typeface="Calibri" panose="020F0502020204030204"/>
+            </a:endParaRPr>
+          </a:p>
+        </p:txBody>
+      </p:sp>
+      <p:sp>
+        <p:nvSpPr>
+          <p:cNvPr id="25" name="Text 23"/>
+          <p:cNvSpPr/>
+          <p:nvPr/>
+        </p:nvSpPr>
+        <p:spPr>
+          <a:xfrm>
+            <a:off x="9432367" y="5118493"/>
+            <a:ext cx="2121408" cy="195072"/>
+          </a:xfrm>
+          <a:prstGeom prst="rect">
+            <a:avLst/>
+          </a:prstGeom>
+          <a:noFill/>
+          <a:ln/>
+        </p:spPr>
+        <p:txBody>
+          <a:bodyPr wrap="square" lIns="33867" tIns="33867" rIns="33867" bIns="33867" rtlCol="0" anchor="t"/>
+          <a:lstStyle/>
+          <a:p>
+            <a:pPr defTabSz="1219170"/>
+            <a:r>
+              <a:rPr lang="en-US" sz="1600" dirty="0">
+                <a:solidFill>
+                  <a:srgbClr val="CADCFC"/>
+                </a:solidFill>
+                <a:latin typeface="Calibri" pitchFamily="34" charset="0"/>
+                <a:ea typeface="Calibri" pitchFamily="34" charset="-122"/>
+                <a:cs typeface="Calibri" pitchFamily="34" charset="-120"/>
+              </a:rPr>
+              <a:t>energy arc × peak × end taper</a:t>
+            </a:r>
+            <a:endParaRPr lang="en-US" sz="1600" dirty="0">
+              <a:solidFill>
+                <a:prstClr val="black"/>
+              </a:solidFill>
+              <a:latin typeface="Calibri" panose="020F0502020204030204"/>
+            </a:endParaRPr>
+          </a:p>
+        </p:txBody>
+      </p:sp>
+      <p:sp>
+        <p:nvSpPr>
+          <p:cNvPr id="27" name="Shape 25"/>
+          <p:cNvSpPr/>
+          <p:nvPr/>
+        </p:nvSpPr>
+        <p:spPr>
+          <a:xfrm>
+            <a:off x="9330061" y="6121942"/>
+            <a:ext cx="2316479" cy="438912"/>
+          </a:xfrm>
+          <a:prstGeom prst="roundRect">
+            <a:avLst>
+              <a:gd name="adj" fmla="val 22222"/>
+            </a:avLst>
+          </a:prstGeom>
+          <a:solidFill>
+            <a:srgbClr val="2A3570"/>
+          </a:solidFill>
+          <a:ln w="19050">
+            <a:solidFill>
+              <a:srgbClr val="CADCFC"/>
+            </a:solidFill>
+            <a:prstDash val="solid"/>
+          </a:ln>
+        </p:spPr>
+        <p:txBody>
+          <a:bodyPr/>
+          <a:lstStyle/>
+          <a:p>
+            <a:pPr defTabSz="1219170"/>
+            <a:endParaRPr lang="en-US" sz="3200">
+              <a:solidFill>
+                <a:prstClr val="black"/>
+              </a:solidFill>
+              <a:latin typeface="Calibri" panose="020F0502020204030204"/>
+            </a:endParaRPr>
+          </a:p>
+        </p:txBody>
+      </p:sp>
+      <p:sp>
+        <p:nvSpPr>
+          <p:cNvPr id="28" name="Text 26"/>
+          <p:cNvSpPr/>
+          <p:nvPr/>
+        </p:nvSpPr>
+        <p:spPr>
+          <a:xfrm>
+            <a:off x="9330061" y="6121942"/>
+            <a:ext cx="2435219" cy="438912"/>
+          </a:xfrm>
+          <a:prstGeom prst="rect">
+            <a:avLst/>
+          </a:prstGeom>
+          <a:noFill/>
+          <a:ln/>
+        </p:spPr>
+        <p:txBody>
+          <a:bodyPr wrap="square" lIns="67733" tIns="67733" rIns="67733" bIns="67733" rtlCol="0" anchor="ctr"/>
+          <a:lstStyle/>
+          <a:p>
+            <a:pPr algn="ctr" defTabSz="1219170"/>
+            <a:r>
+              <a:rPr lang="en-US" sz="2400" b="1" dirty="0">
+                <a:solidFill>
+                  <a:srgbClr val="FFFFFF"/>
+                </a:solidFill>
+                <a:latin typeface="Calibri" pitchFamily="34" charset="0"/>
+                <a:ea typeface="Calibri" pitchFamily="34" charset="-122"/>
+                <a:cs typeface="Calibri" pitchFamily="34" charset="-120"/>
+              </a:rPr>
+              <a:t>Synth (sax voice)</a:t>
+            </a:r>
+            <a:endParaRPr lang="en-US" sz="2400" dirty="0">
+              <a:solidFill>
+                <a:prstClr val="black"/>
+              </a:solidFill>
+              <a:latin typeface="Calibri" panose="020F0502020204030204"/>
+            </a:endParaRPr>
+          </a:p>
+        </p:txBody>
+      </p:sp>
+      <p:sp>
+        <p:nvSpPr>
+          <p:cNvPr id="30" name="Shape 28"/>
+          <p:cNvSpPr/>
+          <p:nvPr/>
+        </p:nvSpPr>
+        <p:spPr>
+          <a:xfrm>
+            <a:off x="4956792" y="5186874"/>
+            <a:ext cx="0" cy="60960"/>
+          </a:xfrm>
+          <a:prstGeom prst="line">
+            <a:avLst/>
+          </a:prstGeom>
+          <a:noFill/>
+          <a:ln w="19050">
+            <a:solidFill>
+              <a:srgbClr val="CADCFC"/>
+            </a:solidFill>
+            <a:prstDash val="solid"/>
+          </a:ln>
+        </p:spPr>
+        <p:txBody>
+          <a:bodyPr/>
+          <a:lstStyle/>
+          <a:p>
+            <a:pPr defTabSz="1219170"/>
+            <a:endParaRPr lang="en-US" sz="3200">
+              <a:solidFill>
+                <a:prstClr val="black"/>
+              </a:solidFill>
+              <a:latin typeface="Calibri" panose="020F0502020204030204"/>
+            </a:endParaRPr>
+          </a:p>
+        </p:txBody>
+      </p:sp>
+      <p:sp>
+        <p:nvSpPr>
+          <p:cNvPr id="32" name="Shape 30"/>
+          <p:cNvSpPr/>
+          <p:nvPr/>
+        </p:nvSpPr>
+        <p:spPr>
+          <a:xfrm>
+            <a:off x="1808074" y="5043753"/>
+            <a:ext cx="1" cy="335547"/>
+          </a:xfrm>
+          <a:prstGeom prst="line">
+            <a:avLst/>
+          </a:prstGeom>
+          <a:noFill/>
+          <a:ln w="50800">
+            <a:solidFill>
+              <a:srgbClr val="CADCFC"/>
+            </a:solidFill>
+            <a:prstDash val="solid"/>
+            <a:tailEnd type="arrow"/>
+          </a:ln>
+        </p:spPr>
+        <p:txBody>
+          <a:bodyPr/>
+          <a:lstStyle/>
+          <a:p>
+            <a:pPr defTabSz="1219170"/>
+            <a:endParaRPr lang="en-US" sz="3200">
+              <a:solidFill>
+                <a:prstClr val="black"/>
+              </a:solidFill>
+              <a:latin typeface="Calibri" panose="020F0502020204030204"/>
+            </a:endParaRPr>
+          </a:p>
+        </p:txBody>
+      </p:sp>
+      <p:sp>
+        <p:nvSpPr>
+          <p:cNvPr id="33" name="Shape 31"/>
+          <p:cNvSpPr/>
+          <p:nvPr/>
+        </p:nvSpPr>
+        <p:spPr>
+          <a:xfrm>
+            <a:off x="4956792" y="5043754"/>
+            <a:ext cx="0" cy="305332"/>
+          </a:xfrm>
+          <a:prstGeom prst="line">
+            <a:avLst/>
+          </a:prstGeom>
+          <a:noFill/>
+          <a:ln w="50800">
+            <a:solidFill>
+              <a:srgbClr val="CADCFC"/>
+            </a:solidFill>
+            <a:prstDash val="solid"/>
+            <a:tailEnd type="arrow"/>
+          </a:ln>
+        </p:spPr>
+        <p:txBody>
+          <a:bodyPr/>
+          <a:lstStyle/>
+          <a:p>
+            <a:pPr defTabSz="1219170"/>
+            <a:endParaRPr lang="en-US" sz="3200">
+              <a:solidFill>
+                <a:prstClr val="black"/>
+              </a:solidFill>
+              <a:latin typeface="Calibri" panose="020F0502020204030204"/>
+            </a:endParaRPr>
+          </a:p>
+        </p:txBody>
+      </p:sp>
+      <p:sp>
+        <p:nvSpPr>
+          <p:cNvPr id="36" name="Shape 31">
+            <a:extLst>
+              <a:ext uri="{FF2B5EF4-FFF2-40B4-BE49-F238E27FC236}">
+                <a16:creationId xmlns:a16="http://schemas.microsoft.com/office/drawing/2014/main" id="{BF73742D-C58B-745E-C84B-09469BF39C30}"/>
+              </a:ext>
+            </a:extLst>
+          </p:cNvPr>
+          <p:cNvSpPr/>
+          <p:nvPr/>
+        </p:nvSpPr>
+        <p:spPr>
+          <a:xfrm flipH="1">
+            <a:off x="10388467" y="4311169"/>
+            <a:ext cx="7600" cy="323365"/>
+          </a:xfrm>
+          <a:prstGeom prst="line">
+            <a:avLst/>
+          </a:prstGeom>
+          <a:noFill/>
+          <a:ln w="50800">
+            <a:solidFill>
+              <a:srgbClr val="CADCFC"/>
+            </a:solidFill>
+            <a:prstDash val="solid"/>
+            <a:tailEnd type="arrow"/>
+          </a:ln>
+        </p:spPr>
+        <p:txBody>
+          <a:bodyPr/>
+          <a:lstStyle/>
+          <a:p>
+            <a:pPr defTabSz="1219170"/>
+            <a:endParaRPr lang="en-US" sz="3200">
+              <a:solidFill>
+                <a:prstClr val="black"/>
+              </a:solidFill>
+              <a:latin typeface="Calibri" panose="020F0502020204030204"/>
+            </a:endParaRPr>
+          </a:p>
+        </p:txBody>
+      </p:sp>
+      <p:sp>
+        <p:nvSpPr>
+          <p:cNvPr id="37" name="Shape 31">
+            <a:extLst>
+              <a:ext uri="{FF2B5EF4-FFF2-40B4-BE49-F238E27FC236}">
+                <a16:creationId xmlns:a16="http://schemas.microsoft.com/office/drawing/2014/main" id="{D564B4AF-489C-043B-EABE-47C335D52D83}"/>
+              </a:ext>
+            </a:extLst>
+          </p:cNvPr>
+          <p:cNvSpPr/>
+          <p:nvPr/>
+        </p:nvSpPr>
+        <p:spPr>
+          <a:xfrm>
+            <a:off x="10388468" y="5772088"/>
+            <a:ext cx="0" cy="340838"/>
+          </a:xfrm>
+          <a:prstGeom prst="line">
+            <a:avLst/>
+          </a:prstGeom>
+          <a:noFill/>
+          <a:ln w="50800">
+            <a:solidFill>
+              <a:srgbClr val="CADCFC"/>
+            </a:solidFill>
+            <a:prstDash val="solid"/>
+            <a:tailEnd type="arrow"/>
+          </a:ln>
+        </p:spPr>
+        <p:txBody>
+          <a:bodyPr/>
+          <a:lstStyle/>
+          <a:p>
+            <a:pPr defTabSz="1219170"/>
+            <a:endParaRPr lang="en-US" sz="3200">
+              <a:solidFill>
+                <a:prstClr val="black"/>
+              </a:solidFill>
+              <a:latin typeface="Calibri" panose="020F0502020204030204"/>
+            </a:endParaRPr>
+          </a:p>
+        </p:txBody>
+      </p:sp>
+      <p:sp>
+        <p:nvSpPr>
+          <p:cNvPr id="39" name="Shape 31">
+            <a:extLst>
+              <a:ext uri="{FF2B5EF4-FFF2-40B4-BE49-F238E27FC236}">
+                <a16:creationId xmlns:a16="http://schemas.microsoft.com/office/drawing/2014/main" id="{75C8DDBB-FB84-20C6-A810-B200A3A2F6C0}"/>
+              </a:ext>
+            </a:extLst>
+          </p:cNvPr>
+          <p:cNvSpPr/>
+          <p:nvPr/>
+        </p:nvSpPr>
+        <p:spPr>
+          <a:xfrm>
+            <a:off x="4956792" y="1414273"/>
+            <a:ext cx="0" cy="310630"/>
+          </a:xfrm>
+          <a:prstGeom prst="line">
+            <a:avLst/>
+          </a:prstGeom>
+          <a:noFill/>
+          <a:ln w="50800">
+            <a:solidFill>
+              <a:srgbClr val="CADCFC"/>
+            </a:solidFill>
+            <a:prstDash val="solid"/>
+            <a:tailEnd type="arrow"/>
+          </a:ln>
+        </p:spPr>
+        <p:txBody>
+          <a:bodyPr/>
+          <a:lstStyle/>
+          <a:p>
+            <a:pPr defTabSz="1219170"/>
+            <a:endParaRPr lang="en-US" sz="3200">
+              <a:solidFill>
+                <a:prstClr val="black"/>
+              </a:solidFill>
+              <a:latin typeface="Calibri" panose="020F0502020204030204"/>
+            </a:endParaRPr>
+          </a:p>
+        </p:txBody>
+      </p:sp>
+      <p:sp>
+        <p:nvSpPr>
+          <p:cNvPr id="40" name="Shape 31">
+            <a:extLst>
+              <a:ext uri="{FF2B5EF4-FFF2-40B4-BE49-F238E27FC236}">
+                <a16:creationId xmlns:a16="http://schemas.microsoft.com/office/drawing/2014/main" id="{87FC4B10-340A-6F3B-E434-9066D920521B}"/>
+              </a:ext>
+            </a:extLst>
+          </p:cNvPr>
+          <p:cNvSpPr/>
+          <p:nvPr/>
+        </p:nvSpPr>
+        <p:spPr>
+          <a:xfrm>
+            <a:off x="4956792" y="2561886"/>
+            <a:ext cx="0" cy="298611"/>
+          </a:xfrm>
+          <a:prstGeom prst="line">
+            <a:avLst/>
+          </a:prstGeom>
+          <a:noFill/>
+          <a:ln w="50800">
+            <a:solidFill>
+              <a:srgbClr val="CADCFC"/>
+            </a:solidFill>
+            <a:prstDash val="solid"/>
+            <a:tailEnd type="arrow"/>
+          </a:ln>
+        </p:spPr>
+        <p:txBody>
+          <a:bodyPr/>
+          <a:lstStyle/>
+          <a:p>
+            <a:pPr defTabSz="1219170"/>
+            <a:endParaRPr lang="en-US" sz="3200">
+              <a:solidFill>
+                <a:prstClr val="black"/>
+              </a:solidFill>
+              <a:latin typeface="Calibri" panose="020F0502020204030204"/>
+            </a:endParaRPr>
+          </a:p>
+        </p:txBody>
+      </p:sp>
+      <p:sp>
+        <p:nvSpPr>
+          <p:cNvPr id="41" name="Shape 28">
+            <a:extLst>
+              <a:ext uri="{FF2B5EF4-FFF2-40B4-BE49-F238E27FC236}">
+                <a16:creationId xmlns:a16="http://schemas.microsoft.com/office/drawing/2014/main" id="{4AF251FC-3F52-BB0D-6527-22ED0889C44F}"/>
+              </a:ext>
+            </a:extLst>
+          </p:cNvPr>
+          <p:cNvSpPr/>
+          <p:nvPr/>
+        </p:nvSpPr>
+        <p:spPr>
+          <a:xfrm>
+            <a:off x="4956792" y="221674"/>
+            <a:ext cx="0" cy="504184"/>
+          </a:xfrm>
+          <a:prstGeom prst="line">
+            <a:avLst/>
+          </a:prstGeom>
+          <a:noFill/>
+          <a:ln w="50800">
+            <a:solidFill>
+              <a:srgbClr val="FFC000"/>
+            </a:solidFill>
+            <a:prstDash val="solid"/>
+            <a:tailEnd type="arrow"/>
+          </a:ln>
+        </p:spPr>
+        <p:txBody>
+          <a:bodyPr/>
+          <a:lstStyle/>
+          <a:p>
+            <a:pPr defTabSz="1219170"/>
+            <a:endParaRPr lang="en-US" sz="2400" dirty="0">
+              <a:solidFill>
+                <a:prstClr val="black"/>
+              </a:solidFill>
+              <a:latin typeface="Calibri" panose="020F0502020204030204"/>
+            </a:endParaRPr>
+          </a:p>
+        </p:txBody>
+      </p:sp>
+      <p:sp>
+        <p:nvSpPr>
+          <p:cNvPr id="2" name="Shape 13">
+            <a:extLst>
+              <a:ext uri="{FF2B5EF4-FFF2-40B4-BE49-F238E27FC236}">
+                <a16:creationId xmlns:a16="http://schemas.microsoft.com/office/drawing/2014/main" id="{C7B5150A-7B3C-0DF6-D272-7A58E5994619}"/>
+              </a:ext>
+            </a:extLst>
+          </p:cNvPr>
+          <p:cNvSpPr/>
+          <p:nvPr/>
+        </p:nvSpPr>
+        <p:spPr>
+          <a:xfrm>
+            <a:off x="8847152" y="3580314"/>
+            <a:ext cx="377951" cy="0"/>
+          </a:xfrm>
+          <a:prstGeom prst="line">
+            <a:avLst/>
+          </a:prstGeom>
+          <a:noFill/>
+          <a:ln w="50800">
+            <a:solidFill>
+              <a:srgbClr val="CADCFC"/>
+            </a:solidFill>
+            <a:prstDash val="solid"/>
+            <a:tailEnd type="arrow"/>
+          </a:ln>
+        </p:spPr>
+        <p:txBody>
+          <a:bodyPr/>
+          <a:lstStyle/>
+          <a:p>
+            <a:pPr defTabSz="1219170"/>
+            <a:endParaRPr lang="en-US" sz="2400">
+              <a:solidFill>
+                <a:prstClr val="black"/>
+              </a:solidFill>
+              <a:latin typeface="Calibri" panose="020F0502020204030204"/>
+            </a:endParaRPr>
+          </a:p>
+        </p:txBody>
+      </p:sp>
+    </p:spTree>
+  </p:cSld>
+  <p:clrMapOvr>
+    <a:masterClrMapping/>
+  </p:clrMapOvr>
+</p:sld>
+</file>
+
+<file path=ppt/slides/slide7.xml><?xml version="1.0" encoding="utf-8"?>
+<p:sld xmlns:a="http://schemas.openxmlformats.org/drawingml/2006/main" xmlns:r="http://schemas.openxmlformats.org/officeDocument/2006/relationships" xmlns:p="http://schemas.openxmlformats.org/presentationml/2006/main">
+  <p:cSld>
     <p:spTree>
       <p:nvGrpSpPr>
         <p:cNvPr id="1" name="">
@@ -5713,7 +9221,7 @@
 </p:sld>
 </file>
 
-<file path=ppt/slides/slide6.xml><?xml version="1.0" encoding="utf-8"?>
+<file path=ppt/slides/slide8.xml><?xml version="1.0" encoding="utf-8"?>
 <p:sld xmlns:a="http://schemas.openxmlformats.org/drawingml/2006/main" xmlns:r="http://schemas.openxmlformats.org/officeDocument/2006/relationships" xmlns:p="http://schemas.openxmlformats.org/presentationml/2006/main">
   <p:cSld>
     <p:spTree>
@@ -6174,6 +9682,301 @@
 </file>
 
 <file path=ppt/theme/theme2.xml><?xml version="1.0" encoding="utf-8"?>
+<a:theme xmlns:a="http://schemas.openxmlformats.org/drawingml/2006/main" name="1_Office Theme">
+  <a:themeElements>
+    <a:clrScheme name="Office">
+      <a:dk1>
+        <a:sysClr val="windowText" lastClr="000000"/>
+      </a:dk1>
+      <a:lt1>
+        <a:sysClr val="window" lastClr="FFFFFF"/>
+      </a:lt1>
+      <a:dk2>
+        <a:srgbClr val="44546A"/>
+      </a:dk2>
+      <a:lt2>
+        <a:srgbClr val="E7E6E6"/>
+      </a:lt2>
+      <a:accent1>
+        <a:srgbClr val="4472C4"/>
+      </a:accent1>
+      <a:accent2>
+        <a:srgbClr val="ED7D31"/>
+      </a:accent2>
+      <a:accent3>
+        <a:srgbClr val="A5A5A5"/>
+      </a:accent3>
+      <a:accent4>
+        <a:srgbClr val="FFC000"/>
+      </a:accent4>
+      <a:accent5>
+        <a:srgbClr val="5B9BD5"/>
+      </a:accent5>
+      <a:accent6>
+        <a:srgbClr val="70AD47"/>
+      </a:accent6>
+      <a:hlink>
+        <a:srgbClr val="0563C1"/>
+      </a:hlink>
+      <a:folHlink>
+        <a:srgbClr val="954F72"/>
+      </a:folHlink>
+    </a:clrScheme>
+    <a:fontScheme name="Office">
+      <a:majorFont>
+        <a:latin typeface="Calibri Light" panose="020F0302020204030204"/>
+        <a:ea typeface=""/>
+        <a:cs typeface=""/>
+        <a:font script="Jpan" typeface="游ゴシック Light"/>
+        <a:font script="Hang" typeface="맑은 고딕"/>
+        <a:font script="Hans" typeface="等线 Light"/>
+        <a:font script="Hant" typeface="新細明體"/>
+        <a:font script="Arab" typeface="Times New Roman"/>
+        <a:font script="Hebr" typeface="Times New Roman"/>
+        <a:font script="Thai" typeface="Angsana New"/>
+        <a:font script="Ethi" typeface="Nyala"/>
+        <a:font script="Beng" typeface="Vrinda"/>
+        <a:font script="Gujr" typeface="Shruti"/>
+        <a:font script="Khmr" typeface="MoolBoran"/>
+        <a:font script="Knda" typeface="Tunga"/>
+        <a:font script="Guru" typeface="Raavi"/>
+        <a:font script="Cans" typeface="Euphemia"/>
+        <a:font script="Cher" typeface="Plantagenet Cherokee"/>
+        <a:font script="Yiii" typeface="Microsoft Yi Baiti"/>
+        <a:font script="Tibt" typeface="Microsoft Himalaya"/>
+        <a:font script="Thaa" typeface="MV Boli"/>
+        <a:font script="Deva" typeface="Mangal"/>
+        <a:font script="Telu" typeface="Gautami"/>
+        <a:font script="Taml" typeface="Latha"/>
+        <a:font script="Syrc" typeface="Estrangelo Edessa"/>
+        <a:font script="Orya" typeface="Kalinga"/>
+        <a:font script="Mlym" typeface="Kartika"/>
+        <a:font script="Laoo" typeface="DokChampa"/>
+        <a:font script="Sinh" typeface="Iskoola Pota"/>
+        <a:font script="Mong" typeface="Mongolian Baiti"/>
+        <a:font script="Viet" typeface="Times New Roman"/>
+        <a:font script="Uigh" typeface="Microsoft Uighur"/>
+        <a:font script="Geor" typeface="Sylfaen"/>
+        <a:font script="Armn" typeface="Arial"/>
+        <a:font script="Bugi" typeface="Leelawadee UI"/>
+        <a:font script="Bopo" typeface="Microsoft JhengHei"/>
+        <a:font script="Java" typeface="Javanese Text"/>
+        <a:font script="Lisu" typeface="Segoe UI"/>
+        <a:font script="Mymr" typeface="Myanmar Text"/>
+        <a:font script="Nkoo" typeface="Ebrima"/>
+        <a:font script="Olck" typeface="Nirmala UI"/>
+        <a:font script="Osma" typeface="Ebrima"/>
+        <a:font script="Phag" typeface="Phagspa"/>
+        <a:font script="Syrn" typeface="Estrangelo Edessa"/>
+        <a:font script="Syrj" typeface="Estrangelo Edessa"/>
+        <a:font script="Syre" typeface="Estrangelo Edessa"/>
+        <a:font script="Sora" typeface="Nirmala UI"/>
+        <a:font script="Tale" typeface="Microsoft Tai Le"/>
+        <a:font script="Talu" typeface="Microsoft New Tai Lue"/>
+        <a:font script="Tfng" typeface="Ebrima"/>
+      </a:majorFont>
+      <a:minorFont>
+        <a:latin typeface="Calibri" panose="020F0502020204030204"/>
+        <a:ea typeface=""/>
+        <a:cs typeface=""/>
+        <a:font script="Jpan" typeface="游ゴシック"/>
+        <a:font script="Hang" typeface="맑은 고딕"/>
+        <a:font script="Hans" typeface="等线"/>
+        <a:font script="Hant" typeface="新細明體"/>
+        <a:font script="Arab" typeface="Arial"/>
+        <a:font script="Hebr" typeface="Arial"/>
+        <a:font script="Thai" typeface="Cordia New"/>
+        <a:font script="Ethi" typeface="Nyala"/>
+        <a:font script="Beng" typeface="Vrinda"/>
+        <a:font script="Gujr" typeface="Shruti"/>
+        <a:font script="Khmr" typeface="DaunPenh"/>
+        <a:font script="Knda" typeface="Tunga"/>
+        <a:font script="Guru" typeface="Raavi"/>
+        <a:font script="Cans" typeface="Euphemia"/>
+        <a:font script="Cher" typeface="Plantagenet Cherokee"/>
+        <a:font script="Yiii" typeface="Microsoft Yi Baiti"/>
+        <a:font script="Tibt" typeface="Microsoft Himalaya"/>
+        <a:font script="Thaa" typeface="MV Boli"/>
+        <a:font script="Deva" typeface="Mangal"/>
+        <a:font script="Telu" typeface="Gautami"/>
+        <a:font script="Taml" typeface="Latha"/>
+        <a:font script="Syrc" typeface="Estrangelo Edessa"/>
+        <a:font script="Orya" typeface="Kalinga"/>
+        <a:font script="Mlym" typeface="Kartika"/>
+        <a:font script="Laoo" typeface="DokChampa"/>
+        <a:font script="Sinh" typeface="Iskoola Pota"/>
+        <a:font script="Mong" typeface="Mongolian Baiti"/>
+        <a:font script="Viet" typeface="Arial"/>
+        <a:font script="Uigh" typeface="Microsoft Uighur"/>
+        <a:font script="Geor" typeface="Sylfaen"/>
+        <a:font script="Armn" typeface="Arial"/>
+        <a:font script="Bugi" typeface="Leelawadee UI"/>
+        <a:font script="Bopo" typeface="Microsoft JhengHei"/>
+        <a:font script="Java" typeface="Javanese Text"/>
+        <a:font script="Lisu" typeface="Segoe UI"/>
+        <a:font script="Mymr" typeface="Myanmar Text"/>
+        <a:font script="Nkoo" typeface="Ebrima"/>
+        <a:font script="Olck" typeface="Nirmala UI"/>
+        <a:font script="Osma" typeface="Ebrima"/>
+        <a:font script="Phag" typeface="Phagspa"/>
+        <a:font script="Syrn" typeface="Estrangelo Edessa"/>
+        <a:font script="Syrj" typeface="Estrangelo Edessa"/>
+        <a:font script="Syre" typeface="Estrangelo Edessa"/>
+        <a:font script="Sora" typeface="Nirmala UI"/>
+        <a:font script="Tale" typeface="Microsoft Tai Le"/>
+        <a:font script="Talu" typeface="Microsoft New Tai Lue"/>
+        <a:font script="Tfng" typeface="Ebrima"/>
+      </a:minorFont>
+    </a:fontScheme>
+    <a:fmtScheme name="Office">
+      <a:fillStyleLst>
+        <a:solidFill>
+          <a:schemeClr val="phClr"/>
+        </a:solidFill>
+        <a:gradFill rotWithShape="1">
+          <a:gsLst>
+            <a:gs pos="0">
+              <a:schemeClr val="phClr">
+                <a:lumMod val="110000"/>
+                <a:satMod val="105000"/>
+                <a:tint val="67000"/>
+              </a:schemeClr>
+            </a:gs>
+            <a:gs pos="50000">
+              <a:schemeClr val="phClr">
+                <a:lumMod val="105000"/>
+                <a:satMod val="103000"/>
+                <a:tint val="73000"/>
+              </a:schemeClr>
+            </a:gs>
+            <a:gs pos="100000">
+              <a:schemeClr val="phClr">
+                <a:lumMod val="105000"/>
+                <a:satMod val="109000"/>
+                <a:tint val="81000"/>
+              </a:schemeClr>
+            </a:gs>
+          </a:gsLst>
+          <a:lin ang="5400000" scaled="0"/>
+        </a:gradFill>
+        <a:gradFill rotWithShape="1">
+          <a:gsLst>
+            <a:gs pos="0">
+              <a:schemeClr val="phClr">
+                <a:satMod val="103000"/>
+                <a:lumMod val="102000"/>
+                <a:tint val="94000"/>
+              </a:schemeClr>
+            </a:gs>
+            <a:gs pos="50000">
+              <a:schemeClr val="phClr">
+                <a:satMod val="110000"/>
+                <a:lumMod val="100000"/>
+                <a:shade val="100000"/>
+              </a:schemeClr>
+            </a:gs>
+            <a:gs pos="100000">
+              <a:schemeClr val="phClr">
+                <a:lumMod val="99000"/>
+                <a:satMod val="120000"/>
+                <a:shade val="78000"/>
+              </a:schemeClr>
+            </a:gs>
+          </a:gsLst>
+          <a:lin ang="5400000" scaled="0"/>
+        </a:gradFill>
+      </a:fillStyleLst>
+      <a:lnStyleLst>
+        <a:ln w="6350" cap="flat" cmpd="sng" algn="ctr">
+          <a:solidFill>
+            <a:schemeClr val="phClr"/>
+          </a:solidFill>
+          <a:prstDash val="solid"/>
+          <a:miter lim="800000"/>
+        </a:ln>
+        <a:ln w="12700" cap="flat" cmpd="sng" algn="ctr">
+          <a:solidFill>
+            <a:schemeClr val="phClr"/>
+          </a:solidFill>
+          <a:prstDash val="solid"/>
+          <a:miter lim="800000"/>
+        </a:ln>
+        <a:ln w="19050" cap="flat" cmpd="sng" algn="ctr">
+          <a:solidFill>
+            <a:schemeClr val="phClr"/>
+          </a:solidFill>
+          <a:prstDash val="solid"/>
+          <a:miter lim="800000"/>
+        </a:ln>
+      </a:lnStyleLst>
+      <a:effectStyleLst>
+        <a:effectStyle>
+          <a:effectLst/>
+        </a:effectStyle>
+        <a:effectStyle>
+          <a:effectLst/>
+        </a:effectStyle>
+        <a:effectStyle>
+          <a:effectLst>
+            <a:outerShdw blurRad="57150" dist="19050" dir="5400000" algn="ctr" rotWithShape="0">
+              <a:srgbClr val="000000">
+                <a:alpha val="63000"/>
+              </a:srgbClr>
+            </a:outerShdw>
+          </a:effectLst>
+        </a:effectStyle>
+      </a:effectStyleLst>
+      <a:bgFillStyleLst>
+        <a:solidFill>
+          <a:schemeClr val="phClr"/>
+        </a:solidFill>
+        <a:solidFill>
+          <a:schemeClr val="phClr">
+            <a:tint val="95000"/>
+            <a:satMod val="170000"/>
+          </a:schemeClr>
+        </a:solidFill>
+        <a:gradFill rotWithShape="1">
+          <a:gsLst>
+            <a:gs pos="0">
+              <a:schemeClr val="phClr">
+                <a:tint val="93000"/>
+                <a:satMod val="150000"/>
+                <a:shade val="98000"/>
+                <a:lumMod val="102000"/>
+              </a:schemeClr>
+            </a:gs>
+            <a:gs pos="50000">
+              <a:schemeClr val="phClr">
+                <a:tint val="98000"/>
+                <a:satMod val="130000"/>
+                <a:shade val="90000"/>
+                <a:lumMod val="103000"/>
+              </a:schemeClr>
+            </a:gs>
+            <a:gs pos="100000">
+              <a:schemeClr val="phClr">
+                <a:shade val="63000"/>
+                <a:satMod val="120000"/>
+              </a:schemeClr>
+            </a:gs>
+          </a:gsLst>
+          <a:lin ang="5400000" scaled="0"/>
+        </a:gradFill>
+      </a:bgFillStyleLst>
+    </a:fmtScheme>
+  </a:themeElements>
+  <a:objectDefaults/>
+  <a:extraClrSchemeLst/>
+  <a:extLst>
+    <a:ext uri="{05A4C25C-085E-4340-85A3-A5531E510DB2}">
+      <thm15:themeFamily xmlns:thm15="http://schemas.microsoft.com/office/thememl/2012/main" name="Office Theme" id="{62F939B6-93AF-4DB8-9C6B-D6C7DFDC589F}" vid="{4A3C46E8-61CC-4603-A589-7422A47A8E4A}"/>
+    </a:ext>
+  </a:extLst>
+</a:theme>
+</file>
+
+<file path=ppt/theme/theme3.xml><?xml version="1.0" encoding="utf-8"?>
 <a:theme xmlns:a="http://schemas.openxmlformats.org/drawingml/2006/main" name="Office Theme">
   <a:themeElements>
     <a:clrScheme name="Office">

</xml_diff>

<commit_message>
Update presentation slides with modal/tonal content
Co-Authored-By: Claude Sonnet 4.6 <noreply@anthropic.com>
</commit_message>
<xml_diff>
--- a/docs/wolfson.pptx
+++ b/docs/wolfson.pptx
@@ -6,17 +6,18 @@
     <p:sldMasterId id="2147483660" r:id="rId2"/>
   </p:sldMasterIdLst>
   <p:notesMasterIdLst>
-    <p:notesMasterId r:id="rId11"/>
+    <p:notesMasterId r:id="rId12"/>
   </p:notesMasterIdLst>
   <p:sldIdLst>
     <p:sldId id="256" r:id="rId3"/>
     <p:sldId id="257" r:id="rId4"/>
     <p:sldId id="259" r:id="rId5"/>
     <p:sldId id="258" r:id="rId6"/>
-    <p:sldId id="262" r:id="rId7"/>
-    <p:sldId id="263" r:id="rId8"/>
-    <p:sldId id="260" r:id="rId9"/>
-    <p:sldId id="261" r:id="rId10"/>
+    <p:sldId id="264" r:id="rId7"/>
+    <p:sldId id="262" r:id="rId8"/>
+    <p:sldId id="263" r:id="rId9"/>
+    <p:sldId id="260" r:id="rId10"/>
+    <p:sldId id="261" r:id="rId11"/>
   </p:sldIdLst>
   <p:sldSz cx="12192000" cy="6858000"/>
   <p:notesSz cx="6858000" cy="9144000"/>
@@ -115,6 +116,11 @@
       </a:defRPr>
     </a:lvl9pPr>
   </p:defaultTextStyle>
+  <p:extLst>
+    <p:ext uri="{EFAFB233-063F-42B5-8137-9DF3F51BA10A}">
+      <p15:sldGuideLst xmlns:p15="http://schemas.microsoft.com/office/powerpoint/2012/main"/>
+    </p:ext>
+  </p:extLst>
 </p:presentation>
 </file>
 
@@ -200,7 +206,7 @@
           <a:p>
             <a:fld id="{4C323DB7-7F8E-0241-8824-58FDBBD2EE98}" type="datetimeFigureOut">
               <a:rPr lang="en-US" smtClean="0"/>
-              <a:t>3/31/26</a:t>
+              <a:t>4/1/26</a:t>
             </a:fld>
             <a:endParaRPr lang="en-US"/>
           </a:p>
@@ -809,7 +815,13 @@
   <p:cSld>
     <p:spTree>
       <p:nvGrpSpPr>
-        <p:cNvPr id="1" name=""/>
+        <p:cNvPr id="1" name="">
+          <a:extLst>
+            <a:ext uri="{FF2B5EF4-FFF2-40B4-BE49-F238E27FC236}">
+              <a16:creationId xmlns:a16="http://schemas.microsoft.com/office/drawing/2014/main" id="{E754EE45-609D-D677-B43A-1B23ED1C71DA}"/>
+            </a:ext>
+          </a:extLst>
+        </p:cNvPr>
         <p:cNvGrpSpPr/>
         <p:nvPr/>
       </p:nvGrpSpPr>
@@ -823,7 +835,13 @@
       </p:grpSpPr>
       <p:sp>
         <p:nvSpPr>
-          <p:cNvPr id="2" name="Slide Image Placeholder 1"/>
+          <p:cNvPr id="2" name="Slide Image Placeholder 1">
+            <a:extLst>
+              <a:ext uri="{FF2B5EF4-FFF2-40B4-BE49-F238E27FC236}">
+                <a16:creationId xmlns:a16="http://schemas.microsoft.com/office/drawing/2014/main" id="{EEE766DD-6C9D-4F48-DE19-C2C90B38D1B0}"/>
+              </a:ext>
+            </a:extLst>
+          </p:cNvPr>
           <p:cNvSpPr>
             <a:spLocks noGrp="1" noRot="1" noChangeAspect="1"/>
           </p:cNvSpPr>
@@ -835,7 +853,13 @@
       </p:sp>
       <p:sp>
         <p:nvSpPr>
-          <p:cNvPr id="3" name="Notes Placeholder 2"/>
+          <p:cNvPr id="3" name="Notes Placeholder 2">
+            <a:extLst>
+              <a:ext uri="{FF2B5EF4-FFF2-40B4-BE49-F238E27FC236}">
+                <a16:creationId xmlns:a16="http://schemas.microsoft.com/office/drawing/2014/main" id="{3F4DCF14-5DDD-BC52-2EC2-7F5531F58D3E}"/>
+              </a:ext>
+            </a:extLst>
+          </p:cNvPr>
           <p:cNvSpPr>
             <a:spLocks noGrp="1"/>
           </p:cNvSpPr>
@@ -848,18 +872,24 @@
           <a:bodyPr/>
           <a:lstStyle/>
           <a:p>
-            <a:endParaRPr lang="en-US" dirty="0"/>
-          </a:p>
-        </p:txBody>
-      </p:sp>
-      <p:sp>
-        <p:nvSpPr>
-          <p:cNvPr id="4" name="Slide Number Placeholder 3"/>
+            <a:endParaRPr lang="en-US"/>
+          </a:p>
+        </p:txBody>
+      </p:sp>
+      <p:sp>
+        <p:nvSpPr>
+          <p:cNvPr id="4" name="Slide Number Placeholder 3">
+            <a:extLst>
+              <a:ext uri="{FF2B5EF4-FFF2-40B4-BE49-F238E27FC236}">
+                <a16:creationId xmlns:a16="http://schemas.microsoft.com/office/drawing/2014/main" id="{13D2C179-DB8F-F062-1E98-FE92A957E4F8}"/>
+              </a:ext>
+            </a:extLst>
+          </p:cNvPr>
           <p:cNvSpPr>
             <a:spLocks noGrp="1"/>
           </p:cNvSpPr>
           <p:nvPr>
-            <p:ph type="sldNum" sz="quarter" idx="10"/>
+            <p:ph type="sldNum" sz="quarter" idx="5"/>
           </p:nvPr>
         </p:nvSpPr>
         <p:spPr/>
@@ -867,78 +897,18 @@
           <a:bodyPr/>
           <a:lstStyle/>
           <a:p>
-            <a:pPr marL="0" marR="0" lvl="0" indent="0" algn="l" defTabSz="914400" rtl="0" eaLnBrk="1" fontAlgn="auto" latinLnBrk="0" hangingPunct="1">
-              <a:lnSpc>
-                <a:spcPct val="100000"/>
-              </a:lnSpc>
-              <a:spcBef>
-                <a:spcPts val="0"/>
-              </a:spcBef>
-              <a:spcAft>
-                <a:spcPts val="0"/>
-              </a:spcAft>
-              <a:buClrTx/>
-              <a:buSzTx/>
-              <a:buFontTx/>
-              <a:buNone/>
-              <a:tabLst/>
-              <a:defRPr/>
-            </a:pPr>
-            <a:fld id="{F7021451-1387-4CA6-816F-3879F97B5CBC}" type="slidenum">
-              <a:rPr kumimoji="0" lang="en-US" sz="1800" b="0" i="0" u="none" strike="noStrike" kern="1200" cap="none" spc="0" normalizeH="0" baseline="0" noProof="0">
-                <a:ln>
-                  <a:noFill/>
-                </a:ln>
-                <a:solidFill>
-                  <a:prstClr val="black"/>
-                </a:solidFill>
-                <a:effectLst/>
-                <a:uLnTx/>
-                <a:uFillTx/>
-                <a:latin typeface="Aptos" panose="02110004020202020204"/>
-                <a:ea typeface="+mn-ea"/>
-                <a:cs typeface="+mn-cs"/>
-              </a:rPr>
-              <a:pPr marL="0" marR="0" lvl="0" indent="0" algn="l" defTabSz="914400" rtl="0" eaLnBrk="1" fontAlgn="auto" latinLnBrk="0" hangingPunct="1">
-                <a:lnSpc>
-                  <a:spcPct val="100000"/>
-                </a:lnSpc>
-                <a:spcBef>
-                  <a:spcPts val="0"/>
-                </a:spcBef>
-                <a:spcAft>
-                  <a:spcPts val="0"/>
-                </a:spcAft>
-                <a:buClrTx/>
-                <a:buSzTx/>
-                <a:buFontTx/>
-                <a:buNone/>
-                <a:tabLst/>
-                <a:defRPr/>
-              </a:pPr>
+            <a:fld id="{F4125BD8-DB9E-B04B-ACC5-175F26D74AAD}" type="slidenum">
+              <a:rPr lang="en-US" smtClean="0"/>
               <a:t>5</a:t>
             </a:fld>
-            <a:endParaRPr kumimoji="0" lang="en-US" sz="1800" b="0" i="0" u="none" strike="noStrike" kern="1200" cap="none" spc="0" normalizeH="0" baseline="0" noProof="0">
-              <a:ln>
-                <a:noFill/>
-              </a:ln>
-              <a:solidFill>
-                <a:prstClr val="black"/>
-              </a:solidFill>
-              <a:effectLst/>
-              <a:uLnTx/>
-              <a:uFillTx/>
-              <a:latin typeface="Aptos" panose="02110004020202020204"/>
-              <a:ea typeface="+mn-ea"/>
-              <a:cs typeface="+mn-cs"/>
-            </a:endParaRPr>
+            <a:endParaRPr lang="en-US"/>
           </a:p>
         </p:txBody>
       </p:sp>
     </p:spTree>
     <p:extLst>
       <p:ext uri="{BB962C8B-B14F-4D97-AF65-F5344CB8AC3E}">
-        <p14:creationId xmlns:p14="http://schemas.microsoft.com/office/powerpoint/2010/main" val="1024086991"/>
+        <p14:creationId xmlns:p14="http://schemas.microsoft.com/office/powerpoint/2010/main" val="1563014781"/>
       </p:ext>
     </p:extLst>
   </p:cSld>
@@ -1136,7 +1106,7 @@
           <a:bodyPr/>
           <a:lstStyle/>
           <a:p>
-            <a:endParaRPr lang="en-US"/>
+            <a:endParaRPr lang="en-US" dirty="0"/>
           </a:p>
         </p:txBody>
       </p:sp>
@@ -1147,7 +1117,7 @@
             <a:spLocks noGrp="1"/>
           </p:cNvSpPr>
           <p:nvPr>
-            <p:ph type="sldNum" sz="quarter" idx="5"/>
+            <p:ph type="sldNum" sz="quarter" idx="10"/>
           </p:nvPr>
         </p:nvSpPr>
         <p:spPr/>
@@ -1155,18 +1125,78 @@
           <a:bodyPr/>
           <a:lstStyle/>
           <a:p>
-            <a:fld id="{F4125BD8-DB9E-B04B-ACC5-175F26D74AAD}" type="slidenum">
-              <a:rPr lang="en-US" smtClean="0"/>
+            <a:pPr marL="0" marR="0" lvl="0" indent="0" algn="l" defTabSz="914400" rtl="0" eaLnBrk="1" fontAlgn="auto" latinLnBrk="0" hangingPunct="1">
+              <a:lnSpc>
+                <a:spcPct val="100000"/>
+              </a:lnSpc>
+              <a:spcBef>
+                <a:spcPts val="0"/>
+              </a:spcBef>
+              <a:spcAft>
+                <a:spcPts val="0"/>
+              </a:spcAft>
+              <a:buClrTx/>
+              <a:buSzTx/>
+              <a:buFontTx/>
+              <a:buNone/>
+              <a:tabLst/>
+              <a:defRPr/>
+            </a:pPr>
+            <a:fld id="{F7021451-1387-4CA6-816F-3879F97B5CBC}" type="slidenum">
+              <a:rPr kumimoji="0" lang="en-US" sz="1800" b="0" i="0" u="none" strike="noStrike" kern="1200" cap="none" spc="0" normalizeH="0" baseline="0" noProof="0">
+                <a:ln>
+                  <a:noFill/>
+                </a:ln>
+                <a:solidFill>
+                  <a:prstClr val="black"/>
+                </a:solidFill>
+                <a:effectLst/>
+                <a:uLnTx/>
+                <a:uFillTx/>
+                <a:latin typeface="Aptos" panose="02110004020202020204"/>
+                <a:ea typeface="+mn-ea"/>
+                <a:cs typeface="+mn-cs"/>
+              </a:rPr>
+              <a:pPr marL="0" marR="0" lvl="0" indent="0" algn="l" defTabSz="914400" rtl="0" eaLnBrk="1" fontAlgn="auto" latinLnBrk="0" hangingPunct="1">
+                <a:lnSpc>
+                  <a:spcPct val="100000"/>
+                </a:lnSpc>
+                <a:spcBef>
+                  <a:spcPts val="0"/>
+                </a:spcBef>
+                <a:spcAft>
+                  <a:spcPts val="0"/>
+                </a:spcAft>
+                <a:buClrTx/>
+                <a:buSzTx/>
+                <a:buFontTx/>
+                <a:buNone/>
+                <a:tabLst/>
+                <a:defRPr/>
+              </a:pPr>
               <a:t>7</a:t>
             </a:fld>
-            <a:endParaRPr lang="en-US"/>
+            <a:endParaRPr kumimoji="0" lang="en-US" sz="1800" b="0" i="0" u="none" strike="noStrike" kern="1200" cap="none" spc="0" normalizeH="0" baseline="0" noProof="0">
+              <a:ln>
+                <a:noFill/>
+              </a:ln>
+              <a:solidFill>
+                <a:prstClr val="black"/>
+              </a:solidFill>
+              <a:effectLst/>
+              <a:uLnTx/>
+              <a:uFillTx/>
+              <a:latin typeface="Aptos" panose="02110004020202020204"/>
+              <a:ea typeface="+mn-ea"/>
+              <a:cs typeface="+mn-cs"/>
+            </a:endParaRPr>
           </a:p>
         </p:txBody>
       </p:sp>
     </p:spTree>
     <p:extLst>
       <p:ext uri="{BB962C8B-B14F-4D97-AF65-F5344CB8AC3E}">
-        <p14:creationId xmlns:p14="http://schemas.microsoft.com/office/powerpoint/2010/main" val="2170957319"/>
+        <p14:creationId xmlns:p14="http://schemas.microsoft.com/office/powerpoint/2010/main" val="1024086991"/>
       </p:ext>
     </p:extLst>
   </p:cSld>
@@ -1242,6 +1272,90 @@
             <a:fld id="{F4125BD8-DB9E-B04B-ACC5-175F26D74AAD}" type="slidenum">
               <a:rPr lang="en-US" smtClean="0"/>
               <a:t>8</a:t>
+            </a:fld>
+            <a:endParaRPr lang="en-US"/>
+          </a:p>
+        </p:txBody>
+      </p:sp>
+    </p:spTree>
+    <p:extLst>
+      <p:ext uri="{BB962C8B-B14F-4D97-AF65-F5344CB8AC3E}">
+        <p14:creationId xmlns:p14="http://schemas.microsoft.com/office/powerpoint/2010/main" val="2170957319"/>
+      </p:ext>
+    </p:extLst>
+  </p:cSld>
+  <p:clrMapOvr>
+    <a:masterClrMapping/>
+  </p:clrMapOvr>
+</p:notes>
+</file>
+
+<file path=ppt/notesSlides/notesSlide9.xml><?xml version="1.0" encoding="utf-8"?>
+<p:notes xmlns:a="http://schemas.openxmlformats.org/drawingml/2006/main" xmlns:r="http://schemas.openxmlformats.org/officeDocument/2006/relationships" xmlns:p="http://schemas.openxmlformats.org/presentationml/2006/main">
+  <p:cSld>
+    <p:spTree>
+      <p:nvGrpSpPr>
+        <p:cNvPr id="1" name=""/>
+        <p:cNvGrpSpPr/>
+        <p:nvPr/>
+      </p:nvGrpSpPr>
+      <p:grpSpPr>
+        <a:xfrm>
+          <a:off x="0" y="0"/>
+          <a:ext cx="0" cy="0"/>
+          <a:chOff x="0" y="0"/>
+          <a:chExt cx="0" cy="0"/>
+        </a:xfrm>
+      </p:grpSpPr>
+      <p:sp>
+        <p:nvSpPr>
+          <p:cNvPr id="2" name="Slide Image Placeholder 1"/>
+          <p:cNvSpPr>
+            <a:spLocks noGrp="1" noRot="1" noChangeAspect="1"/>
+          </p:cNvSpPr>
+          <p:nvPr>
+            <p:ph type="sldImg"/>
+          </p:nvPr>
+        </p:nvSpPr>
+        <p:spPr/>
+      </p:sp>
+      <p:sp>
+        <p:nvSpPr>
+          <p:cNvPr id="3" name="Notes Placeholder 2"/>
+          <p:cNvSpPr>
+            <a:spLocks noGrp="1"/>
+          </p:cNvSpPr>
+          <p:nvPr>
+            <p:ph type="body" idx="1"/>
+          </p:nvPr>
+        </p:nvSpPr>
+        <p:spPr/>
+        <p:txBody>
+          <a:bodyPr/>
+          <a:lstStyle/>
+          <a:p>
+            <a:endParaRPr lang="en-US"/>
+          </a:p>
+        </p:txBody>
+      </p:sp>
+      <p:sp>
+        <p:nvSpPr>
+          <p:cNvPr id="4" name="Slide Number Placeholder 3"/>
+          <p:cNvSpPr>
+            <a:spLocks noGrp="1"/>
+          </p:cNvSpPr>
+          <p:nvPr>
+            <p:ph type="sldNum" sz="quarter" idx="5"/>
+          </p:nvPr>
+        </p:nvSpPr>
+        <p:spPr/>
+        <p:txBody>
+          <a:bodyPr/>
+          <a:lstStyle/>
+          <a:p>
+            <a:fld id="{F4125BD8-DB9E-B04B-ACC5-175F26D74AAD}" type="slidenum">
+              <a:rPr lang="en-US" smtClean="0"/>
+              <a:t>9</a:t>
             </a:fld>
             <a:endParaRPr lang="en-US"/>
           </a:p>
@@ -1409,7 +1523,7 @@
           <a:p>
             <a:fld id="{B0887482-337B-0C49-8B44-90FE2531483D}" type="datetimeFigureOut">
               <a:rPr lang="en-US" smtClean="0"/>
-              <a:t>3/31/26</a:t>
+              <a:t>4/1/26</a:t>
             </a:fld>
             <a:endParaRPr lang="en-US"/>
           </a:p>
@@ -1609,7 +1723,7 @@
           <a:p>
             <a:fld id="{B0887482-337B-0C49-8B44-90FE2531483D}" type="datetimeFigureOut">
               <a:rPr lang="en-US" smtClean="0"/>
-              <a:t>3/31/26</a:t>
+              <a:t>4/1/26</a:t>
             </a:fld>
             <a:endParaRPr lang="en-US"/>
           </a:p>
@@ -1819,7 +1933,7 @@
           <a:p>
             <a:fld id="{B0887482-337B-0C49-8B44-90FE2531483D}" type="datetimeFigureOut">
               <a:rPr lang="en-US" smtClean="0"/>
-              <a:t>3/31/26</a:t>
+              <a:t>4/1/26</a:t>
             </a:fld>
             <a:endParaRPr lang="en-US"/>
           </a:p>
@@ -2054,7 +2168,7 @@
           <a:p>
             <a:fld id="{B0887482-337B-0C49-8B44-90FE2531483D}" type="datetimeFigureOut">
               <a:rPr lang="en-US" smtClean="0"/>
-              <a:t>3/31/26</a:t>
+              <a:t>4/1/26</a:t>
             </a:fld>
             <a:endParaRPr lang="en-US"/>
           </a:p>
@@ -2330,7 +2444,7 @@
           <a:p>
             <a:fld id="{B0887482-337B-0C49-8B44-90FE2531483D}" type="datetimeFigureOut">
               <a:rPr lang="en-US" smtClean="0"/>
-              <a:t>3/31/26</a:t>
+              <a:t>4/1/26</a:t>
             </a:fld>
             <a:endParaRPr lang="en-US"/>
           </a:p>
@@ -2598,7 +2712,7 @@
           <a:p>
             <a:fld id="{B0887482-337B-0C49-8B44-90FE2531483D}" type="datetimeFigureOut">
               <a:rPr lang="en-US" smtClean="0"/>
-              <a:t>3/31/26</a:t>
+              <a:t>4/1/26</a:t>
             </a:fld>
             <a:endParaRPr lang="en-US"/>
           </a:p>
@@ -3013,7 +3127,7 @@
           <a:p>
             <a:fld id="{B0887482-337B-0C49-8B44-90FE2531483D}" type="datetimeFigureOut">
               <a:rPr lang="en-US" smtClean="0"/>
-              <a:t>3/31/26</a:t>
+              <a:t>4/1/26</a:t>
             </a:fld>
             <a:endParaRPr lang="en-US"/>
           </a:p>
@@ -3155,7 +3269,7 @@
           <a:p>
             <a:fld id="{B0887482-337B-0C49-8B44-90FE2531483D}" type="datetimeFigureOut">
               <a:rPr lang="en-US" smtClean="0"/>
-              <a:t>3/31/26</a:t>
+              <a:t>4/1/26</a:t>
             </a:fld>
             <a:endParaRPr lang="en-US"/>
           </a:p>
@@ -3268,7 +3382,7 @@
           <a:p>
             <a:fld id="{B0887482-337B-0C49-8B44-90FE2531483D}" type="datetimeFigureOut">
               <a:rPr lang="en-US" smtClean="0"/>
-              <a:t>3/31/26</a:t>
+              <a:t>4/1/26</a:t>
             </a:fld>
             <a:endParaRPr lang="en-US"/>
           </a:p>
@@ -3581,7 +3695,7 @@
           <a:p>
             <a:fld id="{B0887482-337B-0C49-8B44-90FE2531483D}" type="datetimeFigureOut">
               <a:rPr lang="en-US" smtClean="0"/>
-              <a:t>3/31/26</a:t>
+              <a:t>4/1/26</a:t>
             </a:fld>
             <a:endParaRPr lang="en-US"/>
           </a:p>
@@ -3870,7 +3984,7 @@
           <a:p>
             <a:fld id="{B0887482-337B-0C49-8B44-90FE2531483D}" type="datetimeFigureOut">
               <a:rPr lang="en-US" smtClean="0"/>
-              <a:t>3/31/26</a:t>
+              <a:t>4/1/26</a:t>
             </a:fld>
             <a:endParaRPr lang="en-US"/>
           </a:p>
@@ -4113,7 +4227,7 @@
           <a:p>
             <a:fld id="{B0887482-337B-0C49-8B44-90FE2531483D}" type="datetimeFigureOut">
               <a:rPr lang="en-US" smtClean="0"/>
-              <a:t>3/31/26</a:t>
+              <a:t>4/1/26</a:t>
             </a:fld>
             <a:endParaRPr lang="en-US"/>
           </a:p>
@@ -5939,17 +6053,15 @@
 <file path=ppt/slides/slide5.xml><?xml version="1.0" encoding="utf-8"?>
 <p:sld xmlns:a="http://schemas.openxmlformats.org/drawingml/2006/main" xmlns:r="http://schemas.openxmlformats.org/officeDocument/2006/relationships" xmlns:p="http://schemas.openxmlformats.org/presentationml/2006/main">
   <p:cSld>
-    <p:bg>
-      <p:bgPr>
-        <a:solidFill>
-          <a:srgbClr val="00B0F0"/>
-        </a:solidFill>
-        <a:effectLst/>
-      </p:bgPr>
-    </p:bg>
     <p:spTree>
       <p:nvGrpSpPr>
-        <p:cNvPr id="1" name=""/>
+        <p:cNvPr id="1" name="">
+          <a:extLst>
+            <a:ext uri="{FF2B5EF4-FFF2-40B4-BE49-F238E27FC236}">
+              <a16:creationId xmlns:a16="http://schemas.microsoft.com/office/drawing/2014/main" id="{7AA4156B-7C53-A98E-A12C-E6740C138E14}"/>
+            </a:ext>
+          </a:extLst>
+        </p:cNvPr>
         <p:cNvGrpSpPr/>
         <p:nvPr/>
       </p:nvGrpSpPr>
@@ -5963,1376 +6075,195 @@
       </p:grpSpPr>
       <p:sp>
         <p:nvSpPr>
-          <p:cNvPr id="3" name="Text 1"/>
-          <p:cNvSpPr/>
+          <p:cNvPr id="2" name="Title 1">
+            <a:extLst>
+              <a:ext uri="{FF2B5EF4-FFF2-40B4-BE49-F238E27FC236}">
+                <a16:creationId xmlns:a16="http://schemas.microsoft.com/office/drawing/2014/main" id="{6BB1D851-7C60-ACEB-5BC2-3F020AB5E057}"/>
+              </a:ext>
+            </a:extLst>
+          </p:cNvPr>
+          <p:cNvSpPr>
+            <a:spLocks noGrp="1"/>
+          </p:cNvSpPr>
+          <p:nvPr>
+            <p:ph type="title"/>
+          </p:nvPr>
+        </p:nvSpPr>
+        <p:spPr>
+          <a:xfrm>
+            <a:off x="838200" y="365125"/>
+            <a:ext cx="10515600" cy="805753"/>
+          </a:xfrm>
+        </p:spPr>
+        <p:txBody>
+          <a:bodyPr/>
+          <a:lstStyle/>
+          <a:p>
+            <a:r>
+              <a:rPr lang="en-US" dirty="0"/>
+              <a:t>What’s going on musically?</a:t>
+            </a:r>
+          </a:p>
+        </p:txBody>
+      </p:sp>
+      <p:sp>
+        <p:nvSpPr>
+          <p:cNvPr id="3" name="Content Placeholder 2">
+            <a:extLst>
+              <a:ext uri="{FF2B5EF4-FFF2-40B4-BE49-F238E27FC236}">
+                <a16:creationId xmlns:a16="http://schemas.microsoft.com/office/drawing/2014/main" id="{061E25AC-6F63-9883-F3FF-5941FD625AAF}"/>
+              </a:ext>
+            </a:extLst>
+          </p:cNvPr>
+          <p:cNvSpPr>
+            <a:spLocks noGrp="1"/>
+          </p:cNvSpPr>
+          <p:nvPr>
+            <p:ph idx="1"/>
+          </p:nvPr>
+        </p:nvSpPr>
+        <p:spPr>
+          <a:xfrm>
+            <a:off x="838200" y="1393902"/>
+            <a:ext cx="10078844" cy="5018049"/>
+          </a:xfrm>
+        </p:spPr>
+        <p:txBody>
+          <a:bodyPr>
+            <a:normAutofit/>
+          </a:bodyPr>
+          <a:lstStyle/>
+          <a:p>
+            <a:pPr marL="0" indent="0">
+              <a:buNone/>
+            </a:pPr>
+            <a:r>
+              <a:rPr lang="en-US" dirty="0"/>
+              <a:t>This is inspired by:</a:t>
+            </a:r>
+          </a:p>
+          <a:p>
+            <a:r>
+              <a:rPr lang="en-GB" i="1" dirty="0"/>
+              <a:t>Post-bop modal-tonal hybrids </a:t>
+            </a:r>
+            <a:r>
+              <a:rPr lang="en-GB" dirty="0"/>
+              <a:t>like </a:t>
+            </a:r>
+            <a:r>
+              <a:rPr lang="en-GB" b="1" dirty="0"/>
+              <a:t>Milestones</a:t>
+            </a:r>
+            <a:r>
+              <a:rPr lang="en-GB" dirty="0"/>
+              <a:t> (Miles Davis), </a:t>
+            </a:r>
+            <a:r>
+              <a:rPr lang="en-GB" b="1" dirty="0"/>
+              <a:t>Little Sunflower</a:t>
+            </a:r>
+            <a:r>
+              <a:rPr lang="en-GB" dirty="0"/>
+              <a:t> (Freddie Hubbard), </a:t>
+            </a:r>
+            <a:r>
+              <a:rPr lang="en-GB" b="1" dirty="0"/>
+              <a:t>Maiden Voyage</a:t>
+            </a:r>
+            <a:r>
+              <a:rPr lang="en-GB" dirty="0"/>
+              <a:t> (Herbie Hancock), </a:t>
+            </a:r>
+            <a:r>
+              <a:rPr lang="en-GB" b="1" dirty="0"/>
+              <a:t>Footprints</a:t>
+            </a:r>
+            <a:r>
+              <a:rPr lang="en-GB" dirty="0"/>
+              <a:t> (Wayne Shorter). These songs are my favourite things*.</a:t>
+            </a:r>
+          </a:p>
+          <a:p>
+            <a:r>
+              <a:rPr lang="en-GB" dirty="0"/>
+              <a:t>A journey through jazz:</a:t>
+            </a:r>
+          </a:p>
+          <a:p>
+            <a:pPr lvl="1"/>
+            <a:r>
+              <a:rPr lang="en-GB" dirty="0"/>
+              <a:t>Sparse opening resembles the chromatic freedom of free jazz,</a:t>
+            </a:r>
+          </a:p>
+          <a:p>
+            <a:pPr lvl="1"/>
+            <a:r>
+              <a:rPr lang="en-GB" dirty="0"/>
+              <a:t>Modal building stage reflects the Miles/Coltrane modal period,</a:t>
+            </a:r>
+          </a:p>
+          <a:p>
+            <a:pPr lvl="1"/>
+            <a:r>
+              <a:rPr lang="en-GB" dirty="0"/>
+              <a:t>Peak progression echoes hard bop,</a:t>
+            </a:r>
+          </a:p>
+          <a:p>
+            <a:pPr lvl="1"/>
+            <a:r>
+              <a:rPr lang="en-GB" dirty="0"/>
+              <a:t>Pedal resolution has the meditative quality of late Coltrane.</a:t>
+            </a:r>
+          </a:p>
+        </p:txBody>
+      </p:sp>
+      <p:sp>
+        <p:nvSpPr>
+          <p:cNvPr id="5" name="TextBox 4">
+            <a:extLst>
+              <a:ext uri="{FF2B5EF4-FFF2-40B4-BE49-F238E27FC236}">
+                <a16:creationId xmlns:a16="http://schemas.microsoft.com/office/drawing/2014/main" id="{FC70B48D-CD4E-B22D-68E4-0BAC398292EB}"/>
+              </a:ext>
+            </a:extLst>
+          </p:cNvPr>
+          <p:cNvSpPr txBox="1"/>
           <p:nvPr/>
         </p:nvSpPr>
         <p:spPr>
           <a:xfrm>
-            <a:off x="600862" y="3743623"/>
-            <a:ext cx="2264263" cy="1662546"/>
+            <a:off x="964580" y="5950286"/>
+            <a:ext cx="6099716" cy="461665"/>
           </a:xfrm>
           <a:prstGeom prst="rect">
             <a:avLst/>
           </a:prstGeom>
           <a:noFill/>
-          <a:ln/>
-        </p:spPr>
-        <p:txBody>
-          <a:bodyPr wrap="square" lIns="0" tIns="0" rIns="0" bIns="0" rtlCol="0" anchor="ctr"/>
-          <a:lstStyle/>
-          <a:p>
-            <a:pPr defTabSz="1219170"/>
-            <a:r>
-              <a:rPr lang="en-US" sz="4000" b="1" dirty="0">
-                <a:solidFill>
-                  <a:srgbClr val="FFFFFF"/>
-                </a:solidFill>
-                <a:latin typeface="Calibri" pitchFamily="34" charset="0"/>
-                <a:ea typeface="Calibri" pitchFamily="34" charset="-122"/>
-                <a:cs typeface="Calibri" pitchFamily="34" charset="-120"/>
-              </a:rPr>
-              <a:t>Input Pipeline</a:t>
-            </a:r>
-            <a:endParaRPr lang="en-US" sz="4000" dirty="0">
-              <a:solidFill>
-                <a:prstClr val="black"/>
-              </a:solidFill>
-              <a:latin typeface="Calibri" panose="020F0502020204030204"/>
-            </a:endParaRPr>
-          </a:p>
-        </p:txBody>
-      </p:sp>
-      <p:sp>
-        <p:nvSpPr>
-          <p:cNvPr id="4" name="Shape 2"/>
-          <p:cNvSpPr/>
-          <p:nvPr/>
-        </p:nvSpPr>
-        <p:spPr>
-          <a:xfrm>
-            <a:off x="365760" y="761879"/>
-            <a:ext cx="1889760" cy="755904"/>
-          </a:xfrm>
-          <a:prstGeom prst="roundRect">
-            <a:avLst>
-              <a:gd name="adj" fmla="val 16667"/>
-            </a:avLst>
-          </a:prstGeom>
-          <a:solidFill>
-            <a:srgbClr val="2A3570"/>
-          </a:solidFill>
-          <a:ln w="19050">
-            <a:solidFill>
-              <a:srgbClr val="CADCFC"/>
-            </a:solidFill>
-            <a:prstDash val="solid"/>
-          </a:ln>
-        </p:spPr>
-        <p:txBody>
-          <a:bodyPr/>
-          <a:lstStyle/>
-          <a:p>
-            <a:pPr defTabSz="1219170"/>
-            <a:endParaRPr lang="en-US" sz="2400">
-              <a:solidFill>
-                <a:prstClr val="black"/>
-              </a:solidFill>
-              <a:latin typeface="Calibri" panose="020F0502020204030204"/>
-            </a:endParaRPr>
-          </a:p>
-        </p:txBody>
-      </p:sp>
-      <p:sp>
-        <p:nvSpPr>
-          <p:cNvPr id="5" name="Text 3"/>
-          <p:cNvSpPr/>
-          <p:nvPr/>
-        </p:nvSpPr>
-        <p:spPr>
-          <a:xfrm>
-            <a:off x="365760" y="761879"/>
-            <a:ext cx="1889760" cy="667900"/>
-          </a:xfrm>
-          <a:prstGeom prst="rect">
-            <a:avLst/>
-          </a:prstGeom>
-          <a:noFill/>
-          <a:ln/>
-        </p:spPr>
-        <p:txBody>
-          <a:bodyPr wrap="square" lIns="67733" tIns="67733" rIns="67733" bIns="67733" rtlCol="0" anchor="ctr"/>
-          <a:lstStyle/>
-          <a:p>
-            <a:pPr algn="ctr" defTabSz="1219170"/>
-            <a:r>
-              <a:rPr lang="en-US" sz="2400" b="1" dirty="0">
-                <a:solidFill>
-                  <a:srgbClr val="FFFFFF"/>
-                </a:solidFill>
-                <a:latin typeface="Calibri" pitchFamily="34" charset="0"/>
-                <a:ea typeface="Calibri" pitchFamily="34" charset="-122"/>
-                <a:cs typeface="Calibri" pitchFamily="34" charset="-120"/>
-              </a:rPr>
-              <a:t>Bass</a:t>
-            </a:r>
-            <a:br>
-              <a:rPr lang="en-US" sz="2400" b="1" dirty="0">
-                <a:solidFill>
-                  <a:srgbClr val="FFFFFF"/>
-                </a:solidFill>
-                <a:latin typeface="Calibri" pitchFamily="34" charset="0"/>
-                <a:ea typeface="Calibri" pitchFamily="34" charset="-122"/>
-                <a:cs typeface="Calibri" pitchFamily="34" charset="-120"/>
-              </a:rPr>
-            </a:br>
-            <a:r>
-              <a:rPr lang="en-US" sz="2000" b="1" dirty="0">
-                <a:solidFill>
-                  <a:srgbClr val="FFFFFF"/>
-                </a:solidFill>
-                <a:latin typeface="Calibri" pitchFamily="34" charset="0"/>
-                <a:ea typeface="Calibri" pitchFamily="34" charset="-122"/>
-                <a:cs typeface="Calibri" pitchFamily="34" charset="-120"/>
-              </a:rPr>
-              <a:t>(pitch-to-MIDI)</a:t>
-            </a:r>
-            <a:endParaRPr lang="en-US" sz="2400" dirty="0">
-              <a:solidFill>
-                <a:prstClr val="black"/>
-              </a:solidFill>
-              <a:latin typeface="Calibri" panose="020F0502020204030204"/>
-            </a:endParaRPr>
-          </a:p>
-        </p:txBody>
-      </p:sp>
-      <p:sp>
-        <p:nvSpPr>
-          <p:cNvPr id="6" name="Shape 4"/>
-          <p:cNvSpPr/>
-          <p:nvPr/>
-        </p:nvSpPr>
-        <p:spPr>
-          <a:xfrm>
-            <a:off x="2865125" y="846690"/>
-            <a:ext cx="1889760" cy="585216"/>
-          </a:xfrm>
-          <a:prstGeom prst="roundRect">
-            <a:avLst>
-              <a:gd name="adj" fmla="val 16667"/>
-            </a:avLst>
-          </a:prstGeom>
-          <a:solidFill>
-            <a:srgbClr val="2A3570"/>
-          </a:solidFill>
-          <a:ln w="19050">
-            <a:solidFill>
-              <a:srgbClr val="CADCFC"/>
-            </a:solidFill>
-            <a:prstDash val="solid"/>
-          </a:ln>
-        </p:spPr>
-        <p:txBody>
-          <a:bodyPr/>
-          <a:lstStyle/>
-          <a:p>
-            <a:pPr defTabSz="1219170"/>
-            <a:endParaRPr lang="en-US" sz="2400">
-              <a:solidFill>
-                <a:prstClr val="black"/>
-              </a:solidFill>
-              <a:latin typeface="Calibri" panose="020F0502020204030204"/>
-            </a:endParaRPr>
-          </a:p>
-        </p:txBody>
-      </p:sp>
-      <p:sp>
-        <p:nvSpPr>
-          <p:cNvPr id="7" name="Text 5"/>
-          <p:cNvSpPr/>
-          <p:nvPr/>
-        </p:nvSpPr>
-        <p:spPr>
-          <a:xfrm>
-            <a:off x="2865125" y="846690"/>
-            <a:ext cx="1889760" cy="585216"/>
-          </a:xfrm>
-          <a:prstGeom prst="rect">
-            <a:avLst/>
-          </a:prstGeom>
-          <a:noFill/>
-          <a:ln/>
-        </p:spPr>
-        <p:txBody>
-          <a:bodyPr wrap="square" lIns="67733" tIns="67733" rIns="67733" bIns="67733" rtlCol="0" anchor="ctr"/>
-          <a:lstStyle/>
-          <a:p>
-            <a:pPr algn="ctr" defTabSz="1219170"/>
-            <a:r>
-              <a:rPr lang="en-US" sz="2400" b="1" dirty="0">
-                <a:solidFill>
-                  <a:srgbClr val="FFFFFF"/>
-                </a:solidFill>
-                <a:latin typeface="Calibri" pitchFamily="34" charset="0"/>
-                <a:ea typeface="Calibri" pitchFamily="34" charset="-122"/>
-                <a:cs typeface="Calibri" pitchFamily="34" charset="-120"/>
-              </a:rPr>
-              <a:t>MidiListener</a:t>
-            </a:r>
-            <a:endParaRPr lang="en-US" sz="2400" dirty="0">
-              <a:solidFill>
-                <a:prstClr val="black"/>
-              </a:solidFill>
-              <a:latin typeface="Calibri" panose="020F0502020204030204"/>
-            </a:endParaRPr>
-          </a:p>
-        </p:txBody>
-      </p:sp>
-      <p:sp>
-        <p:nvSpPr>
-          <p:cNvPr id="8" name="Shape 6"/>
-          <p:cNvSpPr/>
-          <p:nvPr/>
-        </p:nvSpPr>
-        <p:spPr>
-          <a:xfrm>
-            <a:off x="5416430" y="846690"/>
-            <a:ext cx="2291561" cy="585216"/>
-          </a:xfrm>
-          <a:prstGeom prst="roundRect">
-            <a:avLst>
-              <a:gd name="adj" fmla="val 16667"/>
-            </a:avLst>
-          </a:prstGeom>
-          <a:solidFill>
-            <a:srgbClr val="2A3570"/>
-          </a:solidFill>
-          <a:ln w="19050">
-            <a:solidFill>
-              <a:srgbClr val="CADCFC"/>
-            </a:solidFill>
-            <a:prstDash val="solid"/>
-          </a:ln>
-        </p:spPr>
-        <p:txBody>
-          <a:bodyPr/>
-          <a:lstStyle/>
-          <a:p>
-            <a:pPr defTabSz="1219170"/>
-            <a:endParaRPr lang="en-US" sz="2400">
-              <a:solidFill>
-                <a:prstClr val="black"/>
-              </a:solidFill>
-              <a:latin typeface="Calibri" panose="020F0502020204030204"/>
-            </a:endParaRPr>
-          </a:p>
-        </p:txBody>
-      </p:sp>
-      <p:sp>
-        <p:nvSpPr>
-          <p:cNvPr id="9" name="Text 7"/>
-          <p:cNvSpPr/>
-          <p:nvPr/>
-        </p:nvSpPr>
-        <p:spPr>
-          <a:xfrm>
-            <a:off x="5477390" y="846690"/>
-            <a:ext cx="2197479" cy="585216"/>
-          </a:xfrm>
-          <a:prstGeom prst="rect">
-            <a:avLst/>
-          </a:prstGeom>
-          <a:noFill/>
-          <a:ln/>
-        </p:spPr>
-        <p:txBody>
-          <a:bodyPr wrap="square" lIns="67733" tIns="67733" rIns="67733" bIns="67733" rtlCol="0" anchor="ctr"/>
-          <a:lstStyle/>
-          <a:p>
-            <a:pPr algn="ctr" defTabSz="1219170"/>
-            <a:r>
-              <a:rPr lang="en-US" sz="2400" b="1" dirty="0">
-                <a:solidFill>
-                  <a:srgbClr val="FFFFFF"/>
-                </a:solidFill>
-                <a:latin typeface="Calibri" pitchFamily="34" charset="0"/>
-                <a:ea typeface="Calibri" pitchFamily="34" charset="-122"/>
-                <a:cs typeface="Calibri" pitchFamily="34" charset="-120"/>
-              </a:rPr>
-              <a:t>PhraseDetector</a:t>
-            </a:r>
-            <a:endParaRPr lang="en-US" sz="2400" dirty="0">
-              <a:solidFill>
-                <a:prstClr val="black"/>
-              </a:solidFill>
-              <a:latin typeface="Calibri" panose="020F0502020204030204"/>
-            </a:endParaRPr>
-          </a:p>
-        </p:txBody>
-      </p:sp>
-      <p:sp>
-        <p:nvSpPr>
-          <p:cNvPr id="10" name="Shape 8"/>
-          <p:cNvSpPr/>
-          <p:nvPr/>
-        </p:nvSpPr>
-        <p:spPr>
-          <a:xfrm>
-            <a:off x="8473440" y="664343"/>
-            <a:ext cx="3413760" cy="1828800"/>
-          </a:xfrm>
-          <a:prstGeom prst="roundRect">
-            <a:avLst>
-              <a:gd name="adj" fmla="val 5333"/>
-            </a:avLst>
-          </a:prstGeom>
-          <a:solidFill>
-            <a:srgbClr val="253880"/>
-          </a:solidFill>
-          <a:ln w="25400">
-            <a:solidFill>
-              <a:srgbClr val="CADCFC"/>
-            </a:solidFill>
-            <a:prstDash val="solid"/>
-          </a:ln>
-        </p:spPr>
-        <p:txBody>
-          <a:bodyPr/>
-          <a:lstStyle/>
-          <a:p>
-            <a:pPr defTabSz="1219170"/>
-            <a:endParaRPr lang="en-US" sz="2400">
-              <a:solidFill>
-                <a:prstClr val="black"/>
-              </a:solidFill>
-              <a:latin typeface="Calibri" panose="020F0502020204030204"/>
-            </a:endParaRPr>
-          </a:p>
-        </p:txBody>
-      </p:sp>
-      <p:sp>
-        <p:nvSpPr>
-          <p:cNvPr id="11" name="Text 9"/>
-          <p:cNvSpPr/>
-          <p:nvPr/>
-        </p:nvSpPr>
-        <p:spPr>
-          <a:xfrm>
-            <a:off x="8534400" y="706749"/>
-            <a:ext cx="3291840" cy="316992"/>
-          </a:xfrm>
-          <a:prstGeom prst="rect">
-            <a:avLst/>
-          </a:prstGeom>
-          <a:noFill/>
-          <a:ln/>
-        </p:spPr>
-        <p:txBody>
-          <a:bodyPr wrap="square" lIns="0" tIns="0" rIns="0" bIns="0" rtlCol="0" anchor="ctr"/>
-          <a:lstStyle/>
-          <a:p>
-            <a:pPr algn="ctr" defTabSz="1219170"/>
-            <a:r>
-              <a:rPr lang="en-US" sz="2400" b="1" dirty="0">
-                <a:solidFill>
-                  <a:srgbClr val="FFFFFF"/>
-                </a:solidFill>
-                <a:latin typeface="Calibri" pitchFamily="34" charset="0"/>
-                <a:ea typeface="Calibri" pitchFamily="34" charset="-122"/>
-                <a:cs typeface="Calibri" pitchFamily="34" charset="-120"/>
-              </a:rPr>
-              <a:t>PhraseAnalyzer</a:t>
-            </a:r>
-            <a:endParaRPr lang="en-US" sz="2400" dirty="0">
-              <a:solidFill>
-                <a:prstClr val="black"/>
-              </a:solidFill>
-              <a:latin typeface="Calibri" panose="020F0502020204030204"/>
-            </a:endParaRPr>
-          </a:p>
-        </p:txBody>
-      </p:sp>
-      <p:sp>
-        <p:nvSpPr>
-          <p:cNvPr id="12" name="Text 10"/>
-          <p:cNvSpPr/>
-          <p:nvPr/>
-        </p:nvSpPr>
-        <p:spPr>
-          <a:xfrm>
-            <a:off x="8839200" y="1030103"/>
-            <a:ext cx="2950464" cy="1463040"/>
-          </a:xfrm>
-          <a:prstGeom prst="rect">
-            <a:avLst/>
-          </a:prstGeom>
-          <a:noFill/>
-          <a:ln/>
-        </p:spPr>
-        <p:txBody>
-          <a:bodyPr wrap="square" lIns="33867" tIns="33867" rIns="33867" bIns="33867" rtlCol="0" anchor="t"/>
-          <a:lstStyle/>
-          <a:p>
-            <a:pPr defTabSz="1219170"/>
-            <a:r>
-              <a:rPr lang="en-US" sz="1600" dirty="0">
-                <a:solidFill>
-                  <a:srgbClr val="CADCFC"/>
-                </a:solidFill>
-                <a:latin typeface="Calibri" pitchFamily="34" charset="0"/>
-                <a:ea typeface="Calibri" pitchFamily="34" charset="-122"/>
-                <a:cs typeface="Calibri" pitchFamily="34" charset="-120"/>
-              </a:rPr>
-              <a:t>contour, density</a:t>
-            </a:r>
-            <a:endParaRPr lang="en-US" sz="1600" dirty="0">
-              <a:solidFill>
-                <a:prstClr val="black"/>
-              </a:solidFill>
-              <a:latin typeface="Calibri" panose="020F0502020204030204"/>
-            </a:endParaRPr>
-          </a:p>
-          <a:p>
-            <a:pPr defTabSz="1219170"/>
-            <a:r>
-              <a:rPr lang="en-US" sz="1600" dirty="0">
-                <a:solidFill>
-                  <a:srgbClr val="CADCFC"/>
-                </a:solidFill>
-                <a:latin typeface="Calibri" pitchFamily="34" charset="0"/>
-                <a:ea typeface="Calibri" pitchFamily="34" charset="-122"/>
-                <a:cs typeface="Calibri" pitchFamily="34" charset="-120"/>
-              </a:rPr>
-              <a:t>Q&amp;A type, swing</a:t>
-            </a:r>
-            <a:endParaRPr lang="en-US" sz="1600" dirty="0">
-              <a:solidFill>
-                <a:prstClr val="black"/>
-              </a:solidFill>
-              <a:latin typeface="Calibri" panose="020F0502020204030204"/>
-            </a:endParaRPr>
-          </a:p>
-          <a:p>
-            <a:pPr defTabSz="1219170"/>
-            <a:r>
-              <a:rPr lang="en-US" sz="1600" dirty="0">
-                <a:solidFill>
-                  <a:srgbClr val="CADCFC"/>
-                </a:solidFill>
-                <a:latin typeface="Calibri" pitchFamily="34" charset="0"/>
-                <a:ea typeface="Calibri" pitchFamily="34" charset="-122"/>
-                <a:cs typeface="Calibri" pitchFamily="34" charset="-120"/>
-              </a:rPr>
-              <a:t>dynamics, energy profile</a:t>
-            </a:r>
-            <a:endParaRPr lang="en-US" sz="1600" dirty="0">
-              <a:solidFill>
-                <a:prstClr val="black"/>
-              </a:solidFill>
-              <a:latin typeface="Calibri" panose="020F0502020204030204"/>
-            </a:endParaRPr>
-          </a:p>
-          <a:p>
-            <a:pPr defTabSz="1219170"/>
-            <a:r>
-              <a:rPr lang="en-US" sz="1600" dirty="0">
-                <a:solidFill>
-                  <a:srgbClr val="CADCFC"/>
-                </a:solidFill>
-                <a:latin typeface="Calibri" pitchFamily="34" charset="0"/>
-                <a:ea typeface="Calibri" pitchFamily="34" charset="-122"/>
-                <a:cs typeface="Calibri" pitchFamily="34" charset="-120"/>
-              </a:rPr>
-              <a:t>pitch classes</a:t>
-            </a:r>
-            <a:endParaRPr lang="en-US" sz="1600" dirty="0">
-              <a:solidFill>
-                <a:prstClr val="black"/>
-              </a:solidFill>
-              <a:latin typeface="Calibri" panose="020F0502020204030204"/>
-            </a:endParaRPr>
-          </a:p>
-          <a:p>
-            <a:pPr defTabSz="1219170"/>
-            <a:r>
-              <a:rPr lang="en-US" sz="1600" dirty="0">
-                <a:solidFill>
-                  <a:srgbClr val="CADCFC"/>
-                </a:solidFill>
-                <a:latin typeface="Calibri" pitchFamily="34" charset="0"/>
-                <a:ea typeface="Calibri" pitchFamily="34" charset="-122"/>
-                <a:cs typeface="Calibri" pitchFamily="34" charset="-120"/>
-              </a:rPr>
-              <a:t>interval motifs, lyrical motifs</a:t>
-            </a:r>
-            <a:endParaRPr lang="en-US" sz="1600" dirty="0">
-              <a:solidFill>
-                <a:prstClr val="black"/>
-              </a:solidFill>
-              <a:latin typeface="Calibri" panose="020F0502020204030204"/>
-            </a:endParaRPr>
-          </a:p>
-        </p:txBody>
-      </p:sp>
-      <p:sp>
-        <p:nvSpPr>
-          <p:cNvPr id="15" name="Shape 13"/>
-          <p:cNvSpPr/>
-          <p:nvPr/>
-        </p:nvSpPr>
-        <p:spPr>
-          <a:xfrm>
-            <a:off x="7805528" y="1139298"/>
-            <a:ext cx="497224" cy="1"/>
-          </a:xfrm>
-          <a:prstGeom prst="line">
-            <a:avLst/>
-          </a:prstGeom>
-          <a:noFill/>
-          <a:ln w="50800">
-            <a:solidFill>
-              <a:srgbClr val="CADCFC"/>
-            </a:solidFill>
-            <a:prstDash val="solid"/>
-            <a:tailEnd type="arrow"/>
-          </a:ln>
-        </p:spPr>
-        <p:txBody>
-          <a:bodyPr/>
-          <a:lstStyle/>
-          <a:p>
-            <a:pPr defTabSz="1219170"/>
-            <a:endParaRPr lang="en-US" sz="2400">
-              <a:solidFill>
-                <a:prstClr val="black"/>
-              </a:solidFill>
-              <a:latin typeface="Calibri" panose="020F0502020204030204"/>
-            </a:endParaRPr>
-          </a:p>
-        </p:txBody>
-      </p:sp>
-      <p:sp>
-        <p:nvSpPr>
-          <p:cNvPr id="16" name="Shape 14"/>
-          <p:cNvSpPr/>
-          <p:nvPr/>
-        </p:nvSpPr>
-        <p:spPr>
-          <a:xfrm>
-            <a:off x="2389639" y="1999634"/>
-            <a:ext cx="2292087" cy="585216"/>
-          </a:xfrm>
-          <a:prstGeom prst="roundRect">
-            <a:avLst>
-              <a:gd name="adj" fmla="val 16667"/>
-            </a:avLst>
-          </a:prstGeom>
-          <a:solidFill>
-            <a:srgbClr val="2A3570"/>
-          </a:solidFill>
-          <a:ln w="19050">
-            <a:solidFill>
-              <a:srgbClr val="CADCFC"/>
-            </a:solidFill>
-            <a:prstDash val="solid"/>
-          </a:ln>
-        </p:spPr>
-        <p:txBody>
-          <a:bodyPr/>
-          <a:lstStyle/>
-          <a:p>
-            <a:pPr defTabSz="1219170"/>
-            <a:endParaRPr lang="en-US" sz="2400">
-              <a:solidFill>
-                <a:prstClr val="black"/>
-              </a:solidFill>
-              <a:latin typeface="Calibri" panose="020F0502020204030204"/>
-            </a:endParaRPr>
-          </a:p>
-        </p:txBody>
-      </p:sp>
-      <p:sp>
-        <p:nvSpPr>
-          <p:cNvPr id="17" name="Text 15"/>
-          <p:cNvSpPr/>
-          <p:nvPr/>
-        </p:nvSpPr>
-        <p:spPr>
-          <a:xfrm>
-            <a:off x="2389637" y="1999633"/>
-            <a:ext cx="2292087" cy="342371"/>
-          </a:xfrm>
-          <a:prstGeom prst="rect">
-            <a:avLst/>
-          </a:prstGeom>
-          <a:noFill/>
-          <a:ln/>
-        </p:spPr>
-        <p:txBody>
-          <a:bodyPr wrap="square" lIns="0" tIns="0" rIns="0" bIns="0" rtlCol="0" anchor="ctr"/>
-          <a:lstStyle/>
-          <a:p>
-            <a:pPr algn="ctr" defTabSz="1219170"/>
-            <a:r>
-              <a:rPr lang="en-US" sz="2400" b="1" dirty="0">
-                <a:solidFill>
-                  <a:srgbClr val="FFFFFF"/>
-                </a:solidFill>
-                <a:latin typeface="Calibri" pitchFamily="34" charset="0"/>
-                <a:ea typeface="Calibri" pitchFamily="34" charset="-122"/>
-                <a:cs typeface="Calibri" pitchFamily="34" charset="-120"/>
-              </a:rPr>
-              <a:t>BeatEstimator</a:t>
-            </a:r>
-            <a:endParaRPr lang="en-US" sz="2400" dirty="0">
-              <a:solidFill>
-                <a:prstClr val="black"/>
-              </a:solidFill>
-              <a:latin typeface="Calibri" panose="020F0502020204030204"/>
-            </a:endParaRPr>
-          </a:p>
-        </p:txBody>
-      </p:sp>
-      <p:sp>
-        <p:nvSpPr>
-          <p:cNvPr id="18" name="Text 16"/>
-          <p:cNvSpPr/>
-          <p:nvPr/>
-        </p:nvSpPr>
-        <p:spPr>
-          <a:xfrm>
-            <a:off x="2987040" y="2273325"/>
-            <a:ext cx="1694688" cy="219456"/>
-          </a:xfrm>
-          <a:prstGeom prst="rect">
-            <a:avLst/>
-          </a:prstGeom>
-          <a:noFill/>
-          <a:ln/>
-        </p:spPr>
-        <p:txBody>
-          <a:bodyPr wrap="square" lIns="33867" tIns="33867" rIns="33867" bIns="33867" rtlCol="0" anchor="t"/>
-          <a:lstStyle/>
-          <a:p>
-            <a:pPr defTabSz="1219170"/>
-            <a:r>
-              <a:rPr lang="en-US" sz="1600" dirty="0">
-                <a:solidFill>
-                  <a:srgbClr val="CADCFC"/>
-                </a:solidFill>
-                <a:latin typeface="Calibri" pitchFamily="34" charset="0"/>
-                <a:ea typeface="Calibri" pitchFamily="34" charset="-122"/>
-                <a:cs typeface="Calibri" pitchFamily="34" charset="-120"/>
-              </a:rPr>
-              <a:t>live tempo</a:t>
-            </a:r>
-            <a:endParaRPr lang="en-US" sz="1600" dirty="0">
-              <a:solidFill>
-                <a:prstClr val="black"/>
-              </a:solidFill>
-              <a:latin typeface="Calibri" panose="020F0502020204030204"/>
-            </a:endParaRPr>
-          </a:p>
-        </p:txBody>
-      </p:sp>
-      <p:sp>
-        <p:nvSpPr>
-          <p:cNvPr id="19" name="Shape 17"/>
-          <p:cNvSpPr/>
-          <p:nvPr/>
-        </p:nvSpPr>
-        <p:spPr>
-          <a:xfrm>
-            <a:off x="3566160" y="1560191"/>
-            <a:ext cx="0" cy="353568"/>
-          </a:xfrm>
-          <a:prstGeom prst="line">
-            <a:avLst/>
-          </a:prstGeom>
-          <a:noFill/>
-          <a:ln w="50800">
-            <a:solidFill>
-              <a:srgbClr val="CADCFC"/>
-            </a:solidFill>
-            <a:prstDash val="solid"/>
-            <a:tailEnd type="arrow"/>
-          </a:ln>
-        </p:spPr>
-        <p:txBody>
-          <a:bodyPr/>
-          <a:lstStyle/>
-          <a:p>
-            <a:pPr defTabSz="1219170"/>
-            <a:endParaRPr lang="en-US" sz="2400">
-              <a:solidFill>
-                <a:prstClr val="black"/>
-              </a:solidFill>
-              <a:latin typeface="Calibri" panose="020F0502020204030204"/>
-            </a:endParaRPr>
-          </a:p>
-        </p:txBody>
-      </p:sp>
-      <p:sp>
-        <p:nvSpPr>
-          <p:cNvPr id="20" name="Shape 18"/>
-          <p:cNvSpPr/>
-          <p:nvPr/>
-        </p:nvSpPr>
-        <p:spPr>
-          <a:xfrm>
-            <a:off x="4513688" y="2755535"/>
-            <a:ext cx="3291840" cy="1287592"/>
-          </a:xfrm>
-          <a:prstGeom prst="roundRect">
-            <a:avLst>
-              <a:gd name="adj" fmla="val 8421"/>
-            </a:avLst>
-          </a:prstGeom>
-          <a:solidFill>
-            <a:srgbClr val="162050"/>
-          </a:solidFill>
-          <a:ln w="19050">
-            <a:solidFill>
-              <a:srgbClr val="CADCFC"/>
-            </a:solidFill>
-            <a:prstDash val="solid"/>
-          </a:ln>
-        </p:spPr>
-        <p:txBody>
-          <a:bodyPr/>
-          <a:lstStyle/>
-          <a:p>
-            <a:pPr defTabSz="1219170"/>
-            <a:endParaRPr lang="en-US" sz="2400">
-              <a:solidFill>
-                <a:prstClr val="black"/>
-              </a:solidFill>
-              <a:latin typeface="Calibri" panose="020F0502020204030204"/>
-            </a:endParaRPr>
-          </a:p>
-        </p:txBody>
-      </p:sp>
-      <p:sp>
-        <p:nvSpPr>
-          <p:cNvPr id="21" name="Text 19"/>
-          <p:cNvSpPr/>
-          <p:nvPr/>
-        </p:nvSpPr>
-        <p:spPr>
-          <a:xfrm>
-            <a:off x="4574648" y="2842482"/>
-            <a:ext cx="3169920" cy="316992"/>
-          </a:xfrm>
-          <a:prstGeom prst="rect">
-            <a:avLst/>
-          </a:prstGeom>
-          <a:noFill/>
-          <a:ln/>
-        </p:spPr>
-        <p:txBody>
-          <a:bodyPr wrap="square" lIns="0" tIns="0" rIns="0" bIns="0" rtlCol="0" anchor="ctr"/>
-          <a:lstStyle/>
-          <a:p>
-            <a:pPr algn="ctr" defTabSz="1219170"/>
-            <a:r>
-              <a:rPr lang="en-US" sz="2400" b="1" dirty="0">
-                <a:solidFill>
-                  <a:srgbClr val="FFFFFF"/>
-                </a:solidFill>
-                <a:latin typeface="Calibri" pitchFamily="34" charset="0"/>
-                <a:ea typeface="Calibri" pitchFamily="34" charset="-122"/>
-                <a:cs typeface="Calibri" pitchFamily="34" charset="-120"/>
-              </a:rPr>
-              <a:t>PhraseMemory</a:t>
-            </a:r>
-            <a:endParaRPr lang="en-US" sz="2400" dirty="0">
-              <a:solidFill>
-                <a:prstClr val="black"/>
-              </a:solidFill>
-              <a:latin typeface="Calibri" panose="020F0502020204030204"/>
-            </a:endParaRPr>
-          </a:p>
-        </p:txBody>
-      </p:sp>
-      <p:sp>
-        <p:nvSpPr>
-          <p:cNvPr id="22" name="Text 20"/>
-          <p:cNvSpPr/>
-          <p:nvPr/>
-        </p:nvSpPr>
-        <p:spPr>
-          <a:xfrm>
-            <a:off x="4940408" y="3198094"/>
-            <a:ext cx="2767584" cy="792480"/>
-          </a:xfrm>
-          <a:prstGeom prst="rect">
-            <a:avLst/>
-          </a:prstGeom>
-          <a:noFill/>
-          <a:ln/>
-        </p:spPr>
-        <p:txBody>
-          <a:bodyPr wrap="square" lIns="33867" tIns="33867" rIns="33867" bIns="33867" rtlCol="0" anchor="t"/>
-          <a:lstStyle/>
-          <a:p>
-            <a:pPr defTabSz="1219170"/>
-            <a:r>
-              <a:rPr lang="en-US" sz="1600" dirty="0">
-                <a:solidFill>
-                  <a:srgbClr val="CADCFC"/>
-                </a:solidFill>
-                <a:latin typeface="Calibri" pitchFamily="34" charset="0"/>
-                <a:ea typeface="Calibri" pitchFamily="34" charset="-122"/>
-                <a:cs typeface="Calibri" pitchFamily="34" charset="-120"/>
-              </a:rPr>
-              <a:t>stores phrases + motifs</a:t>
-            </a:r>
-            <a:endParaRPr lang="en-US" sz="1600" dirty="0">
-              <a:solidFill>
-                <a:prstClr val="black"/>
-              </a:solidFill>
-              <a:latin typeface="Calibri" panose="020F0502020204030204"/>
-            </a:endParaRPr>
-          </a:p>
-          <a:p>
-            <a:pPr defTabSz="1219170"/>
-            <a:r>
-              <a:rPr lang="en-US" sz="1600" dirty="0">
-                <a:solidFill>
-                  <a:srgbClr val="CADCFC"/>
-                </a:solidFill>
-                <a:latin typeface="Calibri" pitchFamily="34" charset="0"/>
-                <a:ea typeface="Calibri" pitchFamily="34" charset="-122"/>
-                <a:cs typeface="Calibri" pitchFamily="34" charset="-120"/>
-              </a:rPr>
-              <a:t>stores lyrical motifs</a:t>
-            </a:r>
-            <a:endParaRPr lang="en-US" sz="1600" dirty="0">
-              <a:solidFill>
-                <a:prstClr val="black"/>
-              </a:solidFill>
-              <a:latin typeface="Calibri" panose="020F0502020204030204"/>
-            </a:endParaRPr>
-          </a:p>
-          <a:p>
-            <a:pPr defTabSz="1219170"/>
-            <a:r>
-              <a:rPr lang="en-US" sz="1600" dirty="0">
-                <a:solidFill>
-                  <a:srgbClr val="CADCFC"/>
-                </a:solidFill>
-                <a:latin typeface="Calibri" pitchFamily="34" charset="0"/>
-                <a:ea typeface="Calibri" pitchFamily="34" charset="-122"/>
-                <a:cs typeface="Calibri" pitchFamily="34" charset="-120"/>
-              </a:rPr>
-              <a:t>both voices (bass + sax)</a:t>
-            </a:r>
-            <a:endParaRPr lang="en-US" sz="1600" dirty="0">
-              <a:solidFill>
-                <a:prstClr val="black"/>
-              </a:solidFill>
-              <a:latin typeface="Calibri" panose="020F0502020204030204"/>
-            </a:endParaRPr>
-          </a:p>
-        </p:txBody>
-      </p:sp>
-      <p:sp>
-        <p:nvSpPr>
-          <p:cNvPr id="23" name="Shape 21"/>
-          <p:cNvSpPr/>
-          <p:nvPr/>
-        </p:nvSpPr>
-        <p:spPr>
-          <a:xfrm>
-            <a:off x="8839200" y="2610826"/>
-            <a:ext cx="0" cy="821376"/>
-          </a:xfrm>
-          <a:prstGeom prst="line">
-            <a:avLst/>
-          </a:prstGeom>
-          <a:noFill/>
-          <a:ln w="50800">
-            <a:solidFill>
-              <a:srgbClr val="CADCFC"/>
-            </a:solidFill>
-            <a:prstDash val="solid"/>
-          </a:ln>
-        </p:spPr>
-        <p:txBody>
-          <a:bodyPr/>
-          <a:lstStyle/>
-          <a:p>
-            <a:pPr defTabSz="1219170"/>
-            <a:endParaRPr lang="en-US" sz="2400">
-              <a:solidFill>
-                <a:prstClr val="black"/>
-              </a:solidFill>
-              <a:latin typeface="Calibri" panose="020F0502020204030204"/>
-            </a:endParaRPr>
-          </a:p>
-        </p:txBody>
-      </p:sp>
-      <p:sp>
-        <p:nvSpPr>
-          <p:cNvPr id="24" name="Shape 22"/>
-          <p:cNvSpPr/>
-          <p:nvPr/>
-        </p:nvSpPr>
-        <p:spPr>
-          <a:xfrm>
-            <a:off x="7912608" y="3432201"/>
-            <a:ext cx="926592" cy="0"/>
-          </a:xfrm>
-          <a:prstGeom prst="line">
-            <a:avLst/>
-          </a:prstGeom>
-          <a:noFill/>
-          <a:ln w="50800">
-            <a:solidFill>
-              <a:srgbClr val="CADCFC"/>
-            </a:solidFill>
-            <a:prstDash val="solid"/>
-            <a:headEnd type="arrow"/>
-          </a:ln>
-        </p:spPr>
-        <p:txBody>
-          <a:bodyPr/>
-          <a:lstStyle/>
-          <a:p>
-            <a:pPr defTabSz="1219170"/>
-            <a:endParaRPr lang="en-US" sz="2400">
-              <a:solidFill>
-                <a:prstClr val="black"/>
-              </a:solidFill>
-              <a:latin typeface="Calibri" panose="020F0502020204030204"/>
-            </a:endParaRPr>
-          </a:p>
-        </p:txBody>
-      </p:sp>
-      <p:sp>
-        <p:nvSpPr>
-          <p:cNvPr id="25" name="Shape 23"/>
-          <p:cNvSpPr/>
-          <p:nvPr/>
-        </p:nvSpPr>
-        <p:spPr>
-          <a:xfrm>
-            <a:off x="3566160" y="2734336"/>
-            <a:ext cx="0" cy="697865"/>
-          </a:xfrm>
-          <a:prstGeom prst="line">
-            <a:avLst/>
-          </a:prstGeom>
-          <a:noFill/>
-          <a:ln w="50800">
-            <a:solidFill>
-              <a:srgbClr val="CADCFC"/>
-            </a:solidFill>
-            <a:prstDash val="solid"/>
-          </a:ln>
-        </p:spPr>
-        <p:txBody>
-          <a:bodyPr/>
-          <a:lstStyle/>
-          <a:p>
-            <a:pPr defTabSz="1219170"/>
-            <a:endParaRPr lang="en-US" sz="2400">
-              <a:solidFill>
-                <a:prstClr val="black"/>
-              </a:solidFill>
-              <a:latin typeface="Calibri" panose="020F0502020204030204"/>
-            </a:endParaRPr>
-          </a:p>
-        </p:txBody>
-      </p:sp>
-      <p:sp>
-        <p:nvSpPr>
-          <p:cNvPr id="26" name="Shape 24"/>
-          <p:cNvSpPr/>
-          <p:nvPr/>
-        </p:nvSpPr>
-        <p:spPr>
-          <a:xfrm>
-            <a:off x="3566160" y="3432201"/>
-            <a:ext cx="883920" cy="0"/>
-          </a:xfrm>
-          <a:prstGeom prst="line">
-            <a:avLst/>
-          </a:prstGeom>
-          <a:noFill/>
-          <a:ln w="50800">
-            <a:solidFill>
-              <a:srgbClr val="CADCFC"/>
-            </a:solidFill>
-            <a:prstDash val="solid"/>
-            <a:tailEnd type="arrow"/>
-          </a:ln>
-        </p:spPr>
-        <p:txBody>
-          <a:bodyPr/>
-          <a:lstStyle/>
-          <a:p>
-            <a:pPr defTabSz="1219170"/>
-            <a:endParaRPr lang="en-US" sz="2400">
-              <a:solidFill>
-                <a:prstClr val="black"/>
-              </a:solidFill>
-              <a:latin typeface="Calibri" panose="020F0502020204030204"/>
-            </a:endParaRPr>
-          </a:p>
-        </p:txBody>
-      </p:sp>
-      <p:sp>
-        <p:nvSpPr>
-          <p:cNvPr id="27" name="Shape 25"/>
-          <p:cNvSpPr/>
-          <p:nvPr/>
-        </p:nvSpPr>
-        <p:spPr>
-          <a:xfrm>
-            <a:off x="3352800" y="4522399"/>
-            <a:ext cx="5486400" cy="1489456"/>
-          </a:xfrm>
-          <a:prstGeom prst="roundRect">
-            <a:avLst>
-              <a:gd name="adj" fmla="val 8000"/>
-            </a:avLst>
-          </a:prstGeom>
-          <a:solidFill>
-            <a:srgbClr val="253880"/>
-          </a:solidFill>
-          <a:ln w="25400">
-            <a:solidFill>
-              <a:srgbClr val="CADCFC"/>
-            </a:solidFill>
-            <a:prstDash val="solid"/>
-          </a:ln>
-        </p:spPr>
-        <p:txBody>
-          <a:bodyPr/>
-          <a:lstStyle/>
-          <a:p>
-            <a:pPr defTabSz="1219170"/>
-            <a:endParaRPr lang="en-US" sz="2400">
-              <a:solidFill>
-                <a:prstClr val="black"/>
-              </a:solidFill>
-              <a:latin typeface="Calibri" panose="020F0502020204030204"/>
-            </a:endParaRPr>
-          </a:p>
-        </p:txBody>
-      </p:sp>
-      <p:sp>
-        <p:nvSpPr>
-          <p:cNvPr id="28" name="Text 26"/>
-          <p:cNvSpPr/>
-          <p:nvPr/>
-        </p:nvSpPr>
-        <p:spPr>
-          <a:xfrm>
-            <a:off x="3413760" y="4574896"/>
-            <a:ext cx="5364480" cy="315309"/>
-          </a:xfrm>
-          <a:prstGeom prst="rect">
-            <a:avLst/>
-          </a:prstGeom>
-          <a:noFill/>
-          <a:ln/>
-        </p:spPr>
-        <p:txBody>
-          <a:bodyPr wrap="square" lIns="0" tIns="0" rIns="0" bIns="0" rtlCol="0" anchor="ctr"/>
-          <a:lstStyle/>
-          <a:p>
-            <a:pPr algn="ctr" defTabSz="1219170"/>
-            <a:r>
-              <a:rPr lang="en-US" sz="2400" b="1" dirty="0">
-                <a:solidFill>
-                  <a:srgbClr val="FFFFFF"/>
-                </a:solidFill>
-                <a:latin typeface="Calibri" pitchFamily="34" charset="0"/>
-                <a:ea typeface="Calibri" pitchFamily="34" charset="-122"/>
-                <a:cs typeface="Calibri" pitchFamily="34" charset="-120"/>
-              </a:rPr>
-              <a:t>ArcController</a:t>
-            </a:r>
-            <a:endParaRPr lang="en-US" sz="2400" dirty="0">
-              <a:solidFill>
-                <a:prstClr val="black"/>
-              </a:solidFill>
-              <a:latin typeface="Calibri" panose="020F0502020204030204"/>
-            </a:endParaRPr>
-          </a:p>
-        </p:txBody>
-      </p:sp>
-      <p:sp>
-        <p:nvSpPr>
-          <p:cNvPr id="29" name="Text 27"/>
-          <p:cNvSpPr/>
-          <p:nvPr/>
-        </p:nvSpPr>
-        <p:spPr>
-          <a:xfrm>
-            <a:off x="3450336" y="4886419"/>
-            <a:ext cx="5291328" cy="853440"/>
-          </a:xfrm>
-          <a:prstGeom prst="rect">
-            <a:avLst/>
-          </a:prstGeom>
-          <a:noFill/>
-          <a:ln/>
-        </p:spPr>
-        <p:txBody>
-          <a:bodyPr wrap="square" lIns="33867" tIns="33867" rIns="33867" bIns="33867" rtlCol="0" anchor="t"/>
-          <a:lstStyle/>
-          <a:p>
-            <a:pPr defTabSz="1219170"/>
-            <a:r>
-              <a:rPr lang="en-US" sz="1600" dirty="0">
-                <a:solidFill>
-                  <a:srgbClr val="CADCFC"/>
-                </a:solidFill>
-                <a:latin typeface="Calibri" pitchFamily="34" charset="0"/>
-                <a:ea typeface="Calibri" pitchFamily="34" charset="-122"/>
-                <a:cs typeface="Calibri" pitchFamily="34" charset="-120"/>
-              </a:rPr>
-              <a:t>5-min performance arc  ·  leadership &amp; proactive mode</a:t>
-            </a:r>
-            <a:endParaRPr lang="en-US" sz="1600" dirty="0">
-              <a:solidFill>
-                <a:prstClr val="black"/>
-              </a:solidFill>
-              <a:latin typeface="Calibri" panose="020F0502020204030204"/>
-            </a:endParaRPr>
-          </a:p>
-          <a:p>
-            <a:pPr defTabSz="1219170"/>
-            <a:r>
-              <a:rPr lang="en-US" sz="1600" dirty="0">
-                <a:solidFill>
-                  <a:srgbClr val="CADCFC"/>
-                </a:solidFill>
-                <a:latin typeface="Calibri" pitchFamily="34" charset="0"/>
-                <a:ea typeface="Calibri" pitchFamily="34" charset="-122"/>
-                <a:cs typeface="Calibri" pitchFamily="34" charset="-120"/>
-              </a:rPr>
-              <a:t>bass pitch-class tracking  ·  energy arc selection</a:t>
-            </a:r>
-            <a:endParaRPr lang="en-US" sz="1600" dirty="0">
-              <a:solidFill>
-                <a:prstClr val="black"/>
-              </a:solidFill>
-              <a:latin typeface="Calibri" panose="020F0502020204030204"/>
-            </a:endParaRPr>
-          </a:p>
-          <a:p>
-            <a:pPr defTabSz="1219170"/>
-            <a:r>
-              <a:rPr lang="en-US" sz="1600" dirty="0">
-                <a:solidFill>
-                  <a:srgbClr val="CADCFC"/>
-                </a:solidFill>
-                <a:latin typeface="Calibri" pitchFamily="34" charset="0"/>
-                <a:ea typeface="Calibri" pitchFamily="34" charset="-122"/>
-                <a:cs typeface="Calibri" pitchFamily="34" charset="-120"/>
-              </a:rPr>
-              <a:t>motif + lyrical motif selection  ·  register contrast scheduling</a:t>
-            </a:r>
-            <a:endParaRPr lang="en-US" sz="1600" dirty="0">
-              <a:solidFill>
-                <a:prstClr val="black"/>
-              </a:solidFill>
-              <a:latin typeface="Calibri" panose="020F0502020204030204"/>
-            </a:endParaRPr>
-          </a:p>
-          <a:p>
-            <a:pPr defTabSz="1219170"/>
-            <a:r>
-              <a:rPr lang="en-US" sz="1600" dirty="0">
-                <a:solidFill>
-                  <a:srgbClr val="CADCFC"/>
-                </a:solidFill>
-                <a:latin typeface="Calibri" pitchFamily="34" charset="0"/>
-                <a:ea typeface="Calibri" pitchFamily="34" charset="-122"/>
-                <a:cs typeface="Calibri" pitchFamily="34" charset="-120"/>
-              </a:rPr>
-              <a:t>rhythmic density + complementarity  ·  stage swing baseline</a:t>
-            </a:r>
-            <a:endParaRPr lang="en-US" sz="1600" dirty="0">
-              <a:solidFill>
-                <a:prstClr val="black"/>
-              </a:solidFill>
-              <a:latin typeface="Calibri" panose="020F0502020204030204"/>
-            </a:endParaRPr>
-          </a:p>
-        </p:txBody>
-      </p:sp>
-      <p:sp>
-        <p:nvSpPr>
-          <p:cNvPr id="30" name="Shape 28"/>
-          <p:cNvSpPr/>
-          <p:nvPr/>
-        </p:nvSpPr>
-        <p:spPr>
-          <a:xfrm>
-            <a:off x="6096000" y="4125109"/>
-            <a:ext cx="0" cy="315309"/>
-          </a:xfrm>
-          <a:prstGeom prst="line">
-            <a:avLst/>
-          </a:prstGeom>
-          <a:noFill/>
-          <a:ln w="50800">
-            <a:solidFill>
-              <a:srgbClr val="CADCFC"/>
-            </a:solidFill>
-            <a:prstDash val="solid"/>
-            <a:tailEnd type="arrow"/>
-          </a:ln>
-        </p:spPr>
-        <p:txBody>
-          <a:bodyPr/>
-          <a:lstStyle/>
-          <a:p>
-            <a:pPr defTabSz="1219170"/>
-            <a:endParaRPr lang="en-US" sz="2400">
-              <a:solidFill>
-                <a:prstClr val="black"/>
-              </a:solidFill>
-              <a:latin typeface="Calibri" panose="020F0502020204030204"/>
-            </a:endParaRPr>
-          </a:p>
-        </p:txBody>
-      </p:sp>
-      <p:sp>
-        <p:nvSpPr>
-          <p:cNvPr id="32" name="Shape 28">
-            <a:extLst>
-              <a:ext uri="{FF2B5EF4-FFF2-40B4-BE49-F238E27FC236}">
-                <a16:creationId xmlns:a16="http://schemas.microsoft.com/office/drawing/2014/main" id="{82A67C06-F31C-A34E-B75C-378998F00D80}"/>
-              </a:ext>
-            </a:extLst>
-          </p:cNvPr>
-          <p:cNvSpPr/>
-          <p:nvPr/>
-        </p:nvSpPr>
-        <p:spPr>
-          <a:xfrm>
-            <a:off x="5991749" y="6173273"/>
-            <a:ext cx="0" cy="476909"/>
-          </a:xfrm>
-          <a:prstGeom prst="line">
-            <a:avLst/>
-          </a:prstGeom>
-          <a:noFill/>
-          <a:ln w="50800">
-            <a:solidFill>
-              <a:srgbClr val="FFC000"/>
-            </a:solidFill>
-            <a:prstDash val="solid"/>
-            <a:tailEnd type="arrow"/>
-          </a:ln>
-        </p:spPr>
-        <p:txBody>
-          <a:bodyPr/>
-          <a:lstStyle/>
-          <a:p>
-            <a:pPr defTabSz="1219170"/>
-            <a:endParaRPr lang="en-US" sz="2400" dirty="0">
-              <a:solidFill>
-                <a:prstClr val="black"/>
-              </a:solidFill>
-              <a:latin typeface="Calibri" panose="020F0502020204030204"/>
-            </a:endParaRPr>
-          </a:p>
-        </p:txBody>
-      </p:sp>
-      <p:sp>
-        <p:nvSpPr>
-          <p:cNvPr id="33" name="Shape 13">
-            <a:extLst>
-              <a:ext uri="{FF2B5EF4-FFF2-40B4-BE49-F238E27FC236}">
-                <a16:creationId xmlns:a16="http://schemas.microsoft.com/office/drawing/2014/main" id="{BE87611D-8695-346E-CD03-8723D7EC6F13}"/>
-              </a:ext>
-            </a:extLst>
-          </p:cNvPr>
-          <p:cNvSpPr/>
-          <p:nvPr/>
-        </p:nvSpPr>
-        <p:spPr>
-          <a:xfrm>
-            <a:off x="4834130" y="1139298"/>
-            <a:ext cx="582300" cy="0"/>
-          </a:xfrm>
-          <a:prstGeom prst="line">
-            <a:avLst/>
-          </a:prstGeom>
-          <a:noFill/>
-          <a:ln w="50800">
-            <a:solidFill>
-              <a:srgbClr val="CADCFC"/>
-            </a:solidFill>
-            <a:prstDash val="solid"/>
-            <a:tailEnd type="arrow"/>
-          </a:ln>
-        </p:spPr>
-        <p:txBody>
-          <a:bodyPr/>
-          <a:lstStyle/>
-          <a:p>
-            <a:pPr defTabSz="1219170"/>
-            <a:endParaRPr lang="en-US" sz="2400">
-              <a:solidFill>
-                <a:prstClr val="black"/>
-              </a:solidFill>
-              <a:latin typeface="Calibri" panose="020F0502020204030204"/>
-            </a:endParaRPr>
-          </a:p>
-        </p:txBody>
-      </p:sp>
-      <p:sp>
-        <p:nvSpPr>
-          <p:cNvPr id="34" name="Shape 13">
-            <a:extLst>
-              <a:ext uri="{FF2B5EF4-FFF2-40B4-BE49-F238E27FC236}">
-                <a16:creationId xmlns:a16="http://schemas.microsoft.com/office/drawing/2014/main" id="{7493AAE1-3A41-2F24-A433-15942ED6887C}"/>
-              </a:ext>
-            </a:extLst>
-          </p:cNvPr>
-          <p:cNvSpPr/>
-          <p:nvPr/>
-        </p:nvSpPr>
-        <p:spPr>
-          <a:xfrm>
-            <a:off x="2389639" y="1108553"/>
-            <a:ext cx="377951" cy="0"/>
-          </a:xfrm>
-          <a:prstGeom prst="line">
-            <a:avLst/>
-          </a:prstGeom>
-          <a:noFill/>
-          <a:ln w="50800">
-            <a:solidFill>
-              <a:srgbClr val="CADCFC"/>
-            </a:solidFill>
-            <a:prstDash val="solid"/>
-            <a:tailEnd type="arrow"/>
-          </a:ln>
-        </p:spPr>
-        <p:txBody>
-          <a:bodyPr/>
-          <a:lstStyle/>
-          <a:p>
-            <a:pPr defTabSz="1219170"/>
-            <a:endParaRPr lang="en-US" sz="2400">
-              <a:solidFill>
-                <a:prstClr val="black"/>
-              </a:solidFill>
-              <a:latin typeface="Calibri" panose="020F0502020204030204"/>
-            </a:endParaRPr>
+        </p:spPr>
+        <p:txBody>
+          <a:bodyPr wrap="square">
+            <a:spAutoFit/>
+          </a:bodyPr>
+          <a:lstStyle/>
+          <a:p>
+            <a:pPr marL="0" indent="0">
+              <a:buNone/>
+            </a:pPr>
+            <a:r>
+              <a:rPr lang="en-GB" sz="2400" dirty="0"/>
+              <a:t>* John Coltrane</a:t>
+            </a:r>
           </a:p>
         </p:txBody>
       </p:sp>
     </p:spTree>
+    <p:extLst>
+      <p:ext uri="{BB962C8B-B14F-4D97-AF65-F5344CB8AC3E}">
+        <p14:creationId xmlns:p14="http://schemas.microsoft.com/office/powerpoint/2010/main" val="3638156006"/>
+      </p:ext>
+    </p:extLst>
   </p:cSld>
   <p:clrMapOvr>
     <a:masterClrMapping/>
@@ -7373,6 +6304,1410 @@
         </p:nvSpPr>
         <p:spPr>
           <a:xfrm>
+            <a:off x="600862" y="3743623"/>
+            <a:ext cx="2264263" cy="1662546"/>
+          </a:xfrm>
+          <a:prstGeom prst="rect">
+            <a:avLst/>
+          </a:prstGeom>
+          <a:noFill/>
+          <a:ln/>
+        </p:spPr>
+        <p:txBody>
+          <a:bodyPr wrap="square" lIns="0" tIns="0" rIns="0" bIns="0" rtlCol="0" anchor="ctr"/>
+          <a:lstStyle/>
+          <a:p>
+            <a:pPr defTabSz="1219170"/>
+            <a:r>
+              <a:rPr lang="en-US" sz="4000" b="1" dirty="0">
+                <a:solidFill>
+                  <a:srgbClr val="FFFFFF"/>
+                </a:solidFill>
+                <a:latin typeface="Calibri" pitchFamily="34" charset="0"/>
+                <a:ea typeface="Calibri" pitchFamily="34" charset="-122"/>
+                <a:cs typeface="Calibri" pitchFamily="34" charset="-120"/>
+              </a:rPr>
+              <a:t>Input Pipeline</a:t>
+            </a:r>
+            <a:endParaRPr lang="en-US" sz="4000" dirty="0">
+              <a:solidFill>
+                <a:prstClr val="black"/>
+              </a:solidFill>
+              <a:latin typeface="Calibri" panose="020F0502020204030204"/>
+            </a:endParaRPr>
+          </a:p>
+        </p:txBody>
+      </p:sp>
+      <p:sp>
+        <p:nvSpPr>
+          <p:cNvPr id="4" name="Shape 2"/>
+          <p:cNvSpPr/>
+          <p:nvPr/>
+        </p:nvSpPr>
+        <p:spPr>
+          <a:xfrm>
+            <a:off x="365760" y="761879"/>
+            <a:ext cx="1889760" cy="755904"/>
+          </a:xfrm>
+          <a:prstGeom prst="roundRect">
+            <a:avLst>
+              <a:gd name="adj" fmla="val 16667"/>
+            </a:avLst>
+          </a:prstGeom>
+          <a:solidFill>
+            <a:srgbClr val="2A3570"/>
+          </a:solidFill>
+          <a:ln w="19050">
+            <a:solidFill>
+              <a:srgbClr val="CADCFC"/>
+            </a:solidFill>
+            <a:prstDash val="solid"/>
+          </a:ln>
+        </p:spPr>
+        <p:txBody>
+          <a:bodyPr/>
+          <a:lstStyle/>
+          <a:p>
+            <a:pPr defTabSz="1219170"/>
+            <a:endParaRPr lang="en-US" sz="2400">
+              <a:solidFill>
+                <a:prstClr val="black"/>
+              </a:solidFill>
+              <a:latin typeface="Calibri" panose="020F0502020204030204"/>
+            </a:endParaRPr>
+          </a:p>
+        </p:txBody>
+      </p:sp>
+      <p:sp>
+        <p:nvSpPr>
+          <p:cNvPr id="5" name="Text 3"/>
+          <p:cNvSpPr/>
+          <p:nvPr/>
+        </p:nvSpPr>
+        <p:spPr>
+          <a:xfrm>
+            <a:off x="365760" y="761879"/>
+            <a:ext cx="1889760" cy="667900"/>
+          </a:xfrm>
+          <a:prstGeom prst="rect">
+            <a:avLst/>
+          </a:prstGeom>
+          <a:noFill/>
+          <a:ln/>
+        </p:spPr>
+        <p:txBody>
+          <a:bodyPr wrap="square" lIns="67733" tIns="67733" rIns="67733" bIns="67733" rtlCol="0" anchor="ctr"/>
+          <a:lstStyle/>
+          <a:p>
+            <a:pPr algn="ctr" defTabSz="1219170"/>
+            <a:r>
+              <a:rPr lang="en-US" sz="2400" b="1" dirty="0">
+                <a:solidFill>
+                  <a:srgbClr val="FFFFFF"/>
+                </a:solidFill>
+                <a:latin typeface="Calibri" pitchFamily="34" charset="0"/>
+                <a:ea typeface="Calibri" pitchFamily="34" charset="-122"/>
+                <a:cs typeface="Calibri" pitchFamily="34" charset="-120"/>
+              </a:rPr>
+              <a:t>Bass</a:t>
+            </a:r>
+            <a:br>
+              <a:rPr lang="en-US" sz="2400" b="1" dirty="0">
+                <a:solidFill>
+                  <a:srgbClr val="FFFFFF"/>
+                </a:solidFill>
+                <a:latin typeface="Calibri" pitchFamily="34" charset="0"/>
+                <a:ea typeface="Calibri" pitchFamily="34" charset="-122"/>
+                <a:cs typeface="Calibri" pitchFamily="34" charset="-120"/>
+              </a:rPr>
+            </a:br>
+            <a:r>
+              <a:rPr lang="en-US" sz="2000" b="1" dirty="0">
+                <a:solidFill>
+                  <a:srgbClr val="FFFFFF"/>
+                </a:solidFill>
+                <a:latin typeface="Calibri" pitchFamily="34" charset="0"/>
+                <a:ea typeface="Calibri" pitchFamily="34" charset="-122"/>
+                <a:cs typeface="Calibri" pitchFamily="34" charset="-120"/>
+              </a:rPr>
+              <a:t>(pitch-to-MIDI)</a:t>
+            </a:r>
+            <a:endParaRPr lang="en-US" sz="2400" dirty="0">
+              <a:solidFill>
+                <a:prstClr val="black"/>
+              </a:solidFill>
+              <a:latin typeface="Calibri" panose="020F0502020204030204"/>
+            </a:endParaRPr>
+          </a:p>
+        </p:txBody>
+      </p:sp>
+      <p:sp>
+        <p:nvSpPr>
+          <p:cNvPr id="6" name="Shape 4"/>
+          <p:cNvSpPr/>
+          <p:nvPr/>
+        </p:nvSpPr>
+        <p:spPr>
+          <a:xfrm>
+            <a:off x="2865125" y="846690"/>
+            <a:ext cx="1889760" cy="585216"/>
+          </a:xfrm>
+          <a:prstGeom prst="roundRect">
+            <a:avLst>
+              <a:gd name="adj" fmla="val 16667"/>
+            </a:avLst>
+          </a:prstGeom>
+          <a:solidFill>
+            <a:srgbClr val="2A3570"/>
+          </a:solidFill>
+          <a:ln w="19050">
+            <a:solidFill>
+              <a:srgbClr val="CADCFC"/>
+            </a:solidFill>
+            <a:prstDash val="solid"/>
+          </a:ln>
+        </p:spPr>
+        <p:txBody>
+          <a:bodyPr/>
+          <a:lstStyle/>
+          <a:p>
+            <a:pPr defTabSz="1219170"/>
+            <a:endParaRPr lang="en-US" sz="2400">
+              <a:solidFill>
+                <a:prstClr val="black"/>
+              </a:solidFill>
+              <a:latin typeface="Calibri" panose="020F0502020204030204"/>
+            </a:endParaRPr>
+          </a:p>
+        </p:txBody>
+      </p:sp>
+      <p:sp>
+        <p:nvSpPr>
+          <p:cNvPr id="7" name="Text 5"/>
+          <p:cNvSpPr/>
+          <p:nvPr/>
+        </p:nvSpPr>
+        <p:spPr>
+          <a:xfrm>
+            <a:off x="2865125" y="846690"/>
+            <a:ext cx="1889760" cy="585216"/>
+          </a:xfrm>
+          <a:prstGeom prst="rect">
+            <a:avLst/>
+          </a:prstGeom>
+          <a:noFill/>
+          <a:ln/>
+        </p:spPr>
+        <p:txBody>
+          <a:bodyPr wrap="square" lIns="67733" tIns="67733" rIns="67733" bIns="67733" rtlCol="0" anchor="ctr"/>
+          <a:lstStyle/>
+          <a:p>
+            <a:pPr algn="ctr" defTabSz="1219170"/>
+            <a:r>
+              <a:rPr lang="en-US" sz="2400" b="1" dirty="0">
+                <a:solidFill>
+                  <a:srgbClr val="FFFFFF"/>
+                </a:solidFill>
+                <a:latin typeface="Calibri" pitchFamily="34" charset="0"/>
+                <a:ea typeface="Calibri" pitchFamily="34" charset="-122"/>
+                <a:cs typeface="Calibri" pitchFamily="34" charset="-120"/>
+              </a:rPr>
+              <a:t>MidiListener</a:t>
+            </a:r>
+            <a:endParaRPr lang="en-US" sz="2400" dirty="0">
+              <a:solidFill>
+                <a:prstClr val="black"/>
+              </a:solidFill>
+              <a:latin typeface="Calibri" panose="020F0502020204030204"/>
+            </a:endParaRPr>
+          </a:p>
+        </p:txBody>
+      </p:sp>
+      <p:sp>
+        <p:nvSpPr>
+          <p:cNvPr id="8" name="Shape 6"/>
+          <p:cNvSpPr/>
+          <p:nvPr/>
+        </p:nvSpPr>
+        <p:spPr>
+          <a:xfrm>
+            <a:off x="5416430" y="846690"/>
+            <a:ext cx="2291561" cy="585216"/>
+          </a:xfrm>
+          <a:prstGeom prst="roundRect">
+            <a:avLst>
+              <a:gd name="adj" fmla="val 16667"/>
+            </a:avLst>
+          </a:prstGeom>
+          <a:solidFill>
+            <a:srgbClr val="2A3570"/>
+          </a:solidFill>
+          <a:ln w="19050">
+            <a:solidFill>
+              <a:srgbClr val="CADCFC"/>
+            </a:solidFill>
+            <a:prstDash val="solid"/>
+          </a:ln>
+        </p:spPr>
+        <p:txBody>
+          <a:bodyPr/>
+          <a:lstStyle/>
+          <a:p>
+            <a:pPr defTabSz="1219170"/>
+            <a:endParaRPr lang="en-US" sz="2400">
+              <a:solidFill>
+                <a:prstClr val="black"/>
+              </a:solidFill>
+              <a:latin typeface="Calibri" panose="020F0502020204030204"/>
+            </a:endParaRPr>
+          </a:p>
+        </p:txBody>
+      </p:sp>
+      <p:sp>
+        <p:nvSpPr>
+          <p:cNvPr id="9" name="Text 7"/>
+          <p:cNvSpPr/>
+          <p:nvPr/>
+        </p:nvSpPr>
+        <p:spPr>
+          <a:xfrm>
+            <a:off x="5477390" y="846690"/>
+            <a:ext cx="2197479" cy="585216"/>
+          </a:xfrm>
+          <a:prstGeom prst="rect">
+            <a:avLst/>
+          </a:prstGeom>
+          <a:noFill/>
+          <a:ln/>
+        </p:spPr>
+        <p:txBody>
+          <a:bodyPr wrap="square" lIns="67733" tIns="67733" rIns="67733" bIns="67733" rtlCol="0" anchor="ctr"/>
+          <a:lstStyle/>
+          <a:p>
+            <a:pPr algn="ctr" defTabSz="1219170"/>
+            <a:r>
+              <a:rPr lang="en-US" sz="2400" b="1" dirty="0">
+                <a:solidFill>
+                  <a:srgbClr val="FFFFFF"/>
+                </a:solidFill>
+                <a:latin typeface="Calibri" pitchFamily="34" charset="0"/>
+                <a:ea typeface="Calibri" pitchFamily="34" charset="-122"/>
+                <a:cs typeface="Calibri" pitchFamily="34" charset="-120"/>
+              </a:rPr>
+              <a:t>PhraseDetector</a:t>
+            </a:r>
+            <a:endParaRPr lang="en-US" sz="2400" dirty="0">
+              <a:solidFill>
+                <a:prstClr val="black"/>
+              </a:solidFill>
+              <a:latin typeface="Calibri" panose="020F0502020204030204"/>
+            </a:endParaRPr>
+          </a:p>
+        </p:txBody>
+      </p:sp>
+      <p:sp>
+        <p:nvSpPr>
+          <p:cNvPr id="10" name="Shape 8"/>
+          <p:cNvSpPr/>
+          <p:nvPr/>
+        </p:nvSpPr>
+        <p:spPr>
+          <a:xfrm>
+            <a:off x="8473440" y="664343"/>
+            <a:ext cx="3413760" cy="1828800"/>
+          </a:xfrm>
+          <a:prstGeom prst="roundRect">
+            <a:avLst>
+              <a:gd name="adj" fmla="val 5333"/>
+            </a:avLst>
+          </a:prstGeom>
+          <a:solidFill>
+            <a:srgbClr val="253880"/>
+          </a:solidFill>
+          <a:ln w="25400">
+            <a:solidFill>
+              <a:srgbClr val="CADCFC"/>
+            </a:solidFill>
+            <a:prstDash val="solid"/>
+          </a:ln>
+        </p:spPr>
+        <p:txBody>
+          <a:bodyPr/>
+          <a:lstStyle/>
+          <a:p>
+            <a:pPr defTabSz="1219170"/>
+            <a:endParaRPr lang="en-US" sz="2400">
+              <a:solidFill>
+                <a:prstClr val="black"/>
+              </a:solidFill>
+              <a:latin typeface="Calibri" panose="020F0502020204030204"/>
+            </a:endParaRPr>
+          </a:p>
+        </p:txBody>
+      </p:sp>
+      <p:sp>
+        <p:nvSpPr>
+          <p:cNvPr id="11" name="Text 9"/>
+          <p:cNvSpPr/>
+          <p:nvPr/>
+        </p:nvSpPr>
+        <p:spPr>
+          <a:xfrm>
+            <a:off x="8534400" y="706749"/>
+            <a:ext cx="3291840" cy="316992"/>
+          </a:xfrm>
+          <a:prstGeom prst="rect">
+            <a:avLst/>
+          </a:prstGeom>
+          <a:noFill/>
+          <a:ln/>
+        </p:spPr>
+        <p:txBody>
+          <a:bodyPr wrap="square" lIns="0" tIns="0" rIns="0" bIns="0" rtlCol="0" anchor="ctr"/>
+          <a:lstStyle/>
+          <a:p>
+            <a:pPr algn="ctr" defTabSz="1219170"/>
+            <a:r>
+              <a:rPr lang="en-US" sz="2400" b="1" dirty="0">
+                <a:solidFill>
+                  <a:srgbClr val="FFFFFF"/>
+                </a:solidFill>
+                <a:latin typeface="Calibri" pitchFamily="34" charset="0"/>
+                <a:ea typeface="Calibri" pitchFamily="34" charset="-122"/>
+                <a:cs typeface="Calibri" pitchFamily="34" charset="-120"/>
+              </a:rPr>
+              <a:t>PhraseAnalyzer</a:t>
+            </a:r>
+            <a:endParaRPr lang="en-US" sz="2400" dirty="0">
+              <a:solidFill>
+                <a:prstClr val="black"/>
+              </a:solidFill>
+              <a:latin typeface="Calibri" panose="020F0502020204030204"/>
+            </a:endParaRPr>
+          </a:p>
+        </p:txBody>
+      </p:sp>
+      <p:sp>
+        <p:nvSpPr>
+          <p:cNvPr id="12" name="Text 10"/>
+          <p:cNvSpPr/>
+          <p:nvPr/>
+        </p:nvSpPr>
+        <p:spPr>
+          <a:xfrm>
+            <a:off x="8839200" y="1030103"/>
+            <a:ext cx="2950464" cy="1463040"/>
+          </a:xfrm>
+          <a:prstGeom prst="rect">
+            <a:avLst/>
+          </a:prstGeom>
+          <a:noFill/>
+          <a:ln/>
+        </p:spPr>
+        <p:txBody>
+          <a:bodyPr wrap="square" lIns="33867" tIns="33867" rIns="33867" bIns="33867" rtlCol="0" anchor="t"/>
+          <a:lstStyle/>
+          <a:p>
+            <a:pPr defTabSz="1219170"/>
+            <a:r>
+              <a:rPr lang="en-US" sz="1600" dirty="0">
+                <a:solidFill>
+                  <a:srgbClr val="CADCFC"/>
+                </a:solidFill>
+                <a:latin typeface="Calibri" pitchFamily="34" charset="0"/>
+                <a:ea typeface="Calibri" pitchFamily="34" charset="-122"/>
+                <a:cs typeface="Calibri" pitchFamily="34" charset="-120"/>
+              </a:rPr>
+              <a:t>contour, density</a:t>
+            </a:r>
+            <a:endParaRPr lang="en-US" sz="1600" dirty="0">
+              <a:solidFill>
+                <a:prstClr val="black"/>
+              </a:solidFill>
+              <a:latin typeface="Calibri" panose="020F0502020204030204"/>
+            </a:endParaRPr>
+          </a:p>
+          <a:p>
+            <a:pPr defTabSz="1219170"/>
+            <a:r>
+              <a:rPr lang="en-US" sz="1600" dirty="0">
+                <a:solidFill>
+                  <a:srgbClr val="CADCFC"/>
+                </a:solidFill>
+                <a:latin typeface="Calibri" pitchFamily="34" charset="0"/>
+                <a:ea typeface="Calibri" pitchFamily="34" charset="-122"/>
+                <a:cs typeface="Calibri" pitchFamily="34" charset="-120"/>
+              </a:rPr>
+              <a:t>Q&amp;A type, swing</a:t>
+            </a:r>
+            <a:endParaRPr lang="en-US" sz="1600" dirty="0">
+              <a:solidFill>
+                <a:prstClr val="black"/>
+              </a:solidFill>
+              <a:latin typeface="Calibri" panose="020F0502020204030204"/>
+            </a:endParaRPr>
+          </a:p>
+          <a:p>
+            <a:pPr defTabSz="1219170"/>
+            <a:r>
+              <a:rPr lang="en-US" sz="1600" dirty="0">
+                <a:solidFill>
+                  <a:srgbClr val="CADCFC"/>
+                </a:solidFill>
+                <a:latin typeface="Calibri" pitchFamily="34" charset="0"/>
+                <a:ea typeface="Calibri" pitchFamily="34" charset="-122"/>
+                <a:cs typeface="Calibri" pitchFamily="34" charset="-120"/>
+              </a:rPr>
+              <a:t>dynamics, energy profile</a:t>
+            </a:r>
+            <a:endParaRPr lang="en-US" sz="1600" dirty="0">
+              <a:solidFill>
+                <a:prstClr val="black"/>
+              </a:solidFill>
+              <a:latin typeface="Calibri" panose="020F0502020204030204"/>
+            </a:endParaRPr>
+          </a:p>
+          <a:p>
+            <a:pPr defTabSz="1219170"/>
+            <a:r>
+              <a:rPr lang="en-US" sz="1600" dirty="0">
+                <a:solidFill>
+                  <a:srgbClr val="CADCFC"/>
+                </a:solidFill>
+                <a:latin typeface="Calibri" pitchFamily="34" charset="0"/>
+                <a:ea typeface="Calibri" pitchFamily="34" charset="-122"/>
+                <a:cs typeface="Calibri" pitchFamily="34" charset="-120"/>
+              </a:rPr>
+              <a:t>pitch classes</a:t>
+            </a:r>
+            <a:endParaRPr lang="en-US" sz="1600" dirty="0">
+              <a:solidFill>
+                <a:prstClr val="black"/>
+              </a:solidFill>
+              <a:latin typeface="Calibri" panose="020F0502020204030204"/>
+            </a:endParaRPr>
+          </a:p>
+          <a:p>
+            <a:pPr defTabSz="1219170"/>
+            <a:r>
+              <a:rPr lang="en-US" sz="1600" dirty="0">
+                <a:solidFill>
+                  <a:srgbClr val="CADCFC"/>
+                </a:solidFill>
+                <a:latin typeface="Calibri" pitchFamily="34" charset="0"/>
+                <a:ea typeface="Calibri" pitchFamily="34" charset="-122"/>
+                <a:cs typeface="Calibri" pitchFamily="34" charset="-120"/>
+              </a:rPr>
+              <a:t>interval motifs, lyrical motifs</a:t>
+            </a:r>
+            <a:endParaRPr lang="en-US" sz="1600" dirty="0">
+              <a:solidFill>
+                <a:prstClr val="black"/>
+              </a:solidFill>
+              <a:latin typeface="Calibri" panose="020F0502020204030204"/>
+            </a:endParaRPr>
+          </a:p>
+        </p:txBody>
+      </p:sp>
+      <p:sp>
+        <p:nvSpPr>
+          <p:cNvPr id="15" name="Shape 13"/>
+          <p:cNvSpPr/>
+          <p:nvPr/>
+        </p:nvSpPr>
+        <p:spPr>
+          <a:xfrm>
+            <a:off x="7805528" y="1139298"/>
+            <a:ext cx="497224" cy="1"/>
+          </a:xfrm>
+          <a:prstGeom prst="line">
+            <a:avLst/>
+          </a:prstGeom>
+          <a:noFill/>
+          <a:ln w="50800">
+            <a:solidFill>
+              <a:srgbClr val="CADCFC"/>
+            </a:solidFill>
+            <a:prstDash val="solid"/>
+            <a:tailEnd type="arrow"/>
+          </a:ln>
+        </p:spPr>
+        <p:txBody>
+          <a:bodyPr/>
+          <a:lstStyle/>
+          <a:p>
+            <a:pPr defTabSz="1219170"/>
+            <a:endParaRPr lang="en-US" sz="2400">
+              <a:solidFill>
+                <a:prstClr val="black"/>
+              </a:solidFill>
+              <a:latin typeface="Calibri" panose="020F0502020204030204"/>
+            </a:endParaRPr>
+          </a:p>
+        </p:txBody>
+      </p:sp>
+      <p:sp>
+        <p:nvSpPr>
+          <p:cNvPr id="16" name="Shape 14"/>
+          <p:cNvSpPr/>
+          <p:nvPr/>
+        </p:nvSpPr>
+        <p:spPr>
+          <a:xfrm>
+            <a:off x="2389639" y="1999634"/>
+            <a:ext cx="2292087" cy="585216"/>
+          </a:xfrm>
+          <a:prstGeom prst="roundRect">
+            <a:avLst>
+              <a:gd name="adj" fmla="val 16667"/>
+            </a:avLst>
+          </a:prstGeom>
+          <a:solidFill>
+            <a:srgbClr val="2A3570"/>
+          </a:solidFill>
+          <a:ln w="19050">
+            <a:solidFill>
+              <a:srgbClr val="CADCFC"/>
+            </a:solidFill>
+            <a:prstDash val="solid"/>
+          </a:ln>
+        </p:spPr>
+        <p:txBody>
+          <a:bodyPr/>
+          <a:lstStyle/>
+          <a:p>
+            <a:pPr defTabSz="1219170"/>
+            <a:endParaRPr lang="en-US" sz="2400">
+              <a:solidFill>
+                <a:prstClr val="black"/>
+              </a:solidFill>
+              <a:latin typeface="Calibri" panose="020F0502020204030204"/>
+            </a:endParaRPr>
+          </a:p>
+        </p:txBody>
+      </p:sp>
+      <p:sp>
+        <p:nvSpPr>
+          <p:cNvPr id="17" name="Text 15"/>
+          <p:cNvSpPr/>
+          <p:nvPr/>
+        </p:nvSpPr>
+        <p:spPr>
+          <a:xfrm>
+            <a:off x="2389637" y="1999633"/>
+            <a:ext cx="2292087" cy="342371"/>
+          </a:xfrm>
+          <a:prstGeom prst="rect">
+            <a:avLst/>
+          </a:prstGeom>
+          <a:noFill/>
+          <a:ln/>
+        </p:spPr>
+        <p:txBody>
+          <a:bodyPr wrap="square" lIns="0" tIns="0" rIns="0" bIns="0" rtlCol="0" anchor="ctr"/>
+          <a:lstStyle/>
+          <a:p>
+            <a:pPr algn="ctr" defTabSz="1219170"/>
+            <a:r>
+              <a:rPr lang="en-US" sz="2400" b="1" dirty="0">
+                <a:solidFill>
+                  <a:srgbClr val="FFFFFF"/>
+                </a:solidFill>
+                <a:latin typeface="Calibri" pitchFamily="34" charset="0"/>
+                <a:ea typeface="Calibri" pitchFamily="34" charset="-122"/>
+                <a:cs typeface="Calibri" pitchFamily="34" charset="-120"/>
+              </a:rPr>
+              <a:t>BeatEstimator</a:t>
+            </a:r>
+            <a:endParaRPr lang="en-US" sz="2400" dirty="0">
+              <a:solidFill>
+                <a:prstClr val="black"/>
+              </a:solidFill>
+              <a:latin typeface="Calibri" panose="020F0502020204030204"/>
+            </a:endParaRPr>
+          </a:p>
+        </p:txBody>
+      </p:sp>
+      <p:sp>
+        <p:nvSpPr>
+          <p:cNvPr id="18" name="Text 16"/>
+          <p:cNvSpPr/>
+          <p:nvPr/>
+        </p:nvSpPr>
+        <p:spPr>
+          <a:xfrm>
+            <a:off x="2987040" y="2273325"/>
+            <a:ext cx="1694688" cy="219456"/>
+          </a:xfrm>
+          <a:prstGeom prst="rect">
+            <a:avLst/>
+          </a:prstGeom>
+          <a:noFill/>
+          <a:ln/>
+        </p:spPr>
+        <p:txBody>
+          <a:bodyPr wrap="square" lIns="33867" tIns="33867" rIns="33867" bIns="33867" rtlCol="0" anchor="t"/>
+          <a:lstStyle/>
+          <a:p>
+            <a:pPr defTabSz="1219170"/>
+            <a:r>
+              <a:rPr lang="en-US" sz="1600" dirty="0">
+                <a:solidFill>
+                  <a:srgbClr val="CADCFC"/>
+                </a:solidFill>
+                <a:latin typeface="Calibri" pitchFamily="34" charset="0"/>
+                <a:ea typeface="Calibri" pitchFamily="34" charset="-122"/>
+                <a:cs typeface="Calibri" pitchFamily="34" charset="-120"/>
+              </a:rPr>
+              <a:t>live tempo</a:t>
+            </a:r>
+            <a:endParaRPr lang="en-US" sz="1600" dirty="0">
+              <a:solidFill>
+                <a:prstClr val="black"/>
+              </a:solidFill>
+              <a:latin typeface="Calibri" panose="020F0502020204030204"/>
+            </a:endParaRPr>
+          </a:p>
+        </p:txBody>
+      </p:sp>
+      <p:sp>
+        <p:nvSpPr>
+          <p:cNvPr id="19" name="Shape 17"/>
+          <p:cNvSpPr/>
+          <p:nvPr/>
+        </p:nvSpPr>
+        <p:spPr>
+          <a:xfrm>
+            <a:off x="3566160" y="1560191"/>
+            <a:ext cx="0" cy="353568"/>
+          </a:xfrm>
+          <a:prstGeom prst="line">
+            <a:avLst/>
+          </a:prstGeom>
+          <a:noFill/>
+          <a:ln w="50800">
+            <a:solidFill>
+              <a:srgbClr val="CADCFC"/>
+            </a:solidFill>
+            <a:prstDash val="solid"/>
+            <a:tailEnd type="arrow"/>
+          </a:ln>
+        </p:spPr>
+        <p:txBody>
+          <a:bodyPr/>
+          <a:lstStyle/>
+          <a:p>
+            <a:pPr defTabSz="1219170"/>
+            <a:endParaRPr lang="en-US" sz="2400">
+              <a:solidFill>
+                <a:prstClr val="black"/>
+              </a:solidFill>
+              <a:latin typeface="Calibri" panose="020F0502020204030204"/>
+            </a:endParaRPr>
+          </a:p>
+        </p:txBody>
+      </p:sp>
+      <p:sp>
+        <p:nvSpPr>
+          <p:cNvPr id="20" name="Shape 18"/>
+          <p:cNvSpPr/>
+          <p:nvPr/>
+        </p:nvSpPr>
+        <p:spPr>
+          <a:xfrm>
+            <a:off x="4513688" y="2755535"/>
+            <a:ext cx="3291840" cy="1287592"/>
+          </a:xfrm>
+          <a:prstGeom prst="roundRect">
+            <a:avLst>
+              <a:gd name="adj" fmla="val 8421"/>
+            </a:avLst>
+          </a:prstGeom>
+          <a:solidFill>
+            <a:srgbClr val="162050"/>
+          </a:solidFill>
+          <a:ln w="19050">
+            <a:solidFill>
+              <a:srgbClr val="CADCFC"/>
+            </a:solidFill>
+            <a:prstDash val="solid"/>
+          </a:ln>
+        </p:spPr>
+        <p:txBody>
+          <a:bodyPr/>
+          <a:lstStyle/>
+          <a:p>
+            <a:pPr defTabSz="1219170"/>
+            <a:endParaRPr lang="en-US" sz="2400">
+              <a:solidFill>
+                <a:prstClr val="black"/>
+              </a:solidFill>
+              <a:latin typeface="Calibri" panose="020F0502020204030204"/>
+            </a:endParaRPr>
+          </a:p>
+        </p:txBody>
+      </p:sp>
+      <p:sp>
+        <p:nvSpPr>
+          <p:cNvPr id="21" name="Text 19"/>
+          <p:cNvSpPr/>
+          <p:nvPr/>
+        </p:nvSpPr>
+        <p:spPr>
+          <a:xfrm>
+            <a:off x="4574648" y="2842482"/>
+            <a:ext cx="3169920" cy="316992"/>
+          </a:xfrm>
+          <a:prstGeom prst="rect">
+            <a:avLst/>
+          </a:prstGeom>
+          <a:noFill/>
+          <a:ln/>
+        </p:spPr>
+        <p:txBody>
+          <a:bodyPr wrap="square" lIns="0" tIns="0" rIns="0" bIns="0" rtlCol="0" anchor="ctr"/>
+          <a:lstStyle/>
+          <a:p>
+            <a:pPr algn="ctr" defTabSz="1219170"/>
+            <a:r>
+              <a:rPr lang="en-US" sz="2400" b="1" dirty="0">
+                <a:solidFill>
+                  <a:srgbClr val="FFFFFF"/>
+                </a:solidFill>
+                <a:latin typeface="Calibri" pitchFamily="34" charset="0"/>
+                <a:ea typeface="Calibri" pitchFamily="34" charset="-122"/>
+                <a:cs typeface="Calibri" pitchFamily="34" charset="-120"/>
+              </a:rPr>
+              <a:t>PhraseMemory</a:t>
+            </a:r>
+            <a:endParaRPr lang="en-US" sz="2400" dirty="0">
+              <a:solidFill>
+                <a:prstClr val="black"/>
+              </a:solidFill>
+              <a:latin typeface="Calibri" panose="020F0502020204030204"/>
+            </a:endParaRPr>
+          </a:p>
+        </p:txBody>
+      </p:sp>
+      <p:sp>
+        <p:nvSpPr>
+          <p:cNvPr id="22" name="Text 20"/>
+          <p:cNvSpPr/>
+          <p:nvPr/>
+        </p:nvSpPr>
+        <p:spPr>
+          <a:xfrm>
+            <a:off x="4940408" y="3198094"/>
+            <a:ext cx="2767584" cy="792480"/>
+          </a:xfrm>
+          <a:prstGeom prst="rect">
+            <a:avLst/>
+          </a:prstGeom>
+          <a:noFill/>
+          <a:ln/>
+        </p:spPr>
+        <p:txBody>
+          <a:bodyPr wrap="square" lIns="33867" tIns="33867" rIns="33867" bIns="33867" rtlCol="0" anchor="t"/>
+          <a:lstStyle/>
+          <a:p>
+            <a:pPr defTabSz="1219170"/>
+            <a:r>
+              <a:rPr lang="en-US" sz="1600" dirty="0">
+                <a:solidFill>
+                  <a:srgbClr val="CADCFC"/>
+                </a:solidFill>
+                <a:latin typeface="Calibri" pitchFamily="34" charset="0"/>
+                <a:ea typeface="Calibri" pitchFamily="34" charset="-122"/>
+                <a:cs typeface="Calibri" pitchFamily="34" charset="-120"/>
+              </a:rPr>
+              <a:t>stores phrases + motifs</a:t>
+            </a:r>
+            <a:endParaRPr lang="en-US" sz="1600" dirty="0">
+              <a:solidFill>
+                <a:prstClr val="black"/>
+              </a:solidFill>
+              <a:latin typeface="Calibri" panose="020F0502020204030204"/>
+            </a:endParaRPr>
+          </a:p>
+          <a:p>
+            <a:pPr defTabSz="1219170"/>
+            <a:r>
+              <a:rPr lang="en-US" sz="1600" dirty="0">
+                <a:solidFill>
+                  <a:srgbClr val="CADCFC"/>
+                </a:solidFill>
+                <a:latin typeface="Calibri" pitchFamily="34" charset="0"/>
+                <a:ea typeface="Calibri" pitchFamily="34" charset="-122"/>
+                <a:cs typeface="Calibri" pitchFamily="34" charset="-120"/>
+              </a:rPr>
+              <a:t>stores lyrical motifs</a:t>
+            </a:r>
+            <a:endParaRPr lang="en-US" sz="1600" dirty="0">
+              <a:solidFill>
+                <a:prstClr val="black"/>
+              </a:solidFill>
+              <a:latin typeface="Calibri" panose="020F0502020204030204"/>
+            </a:endParaRPr>
+          </a:p>
+          <a:p>
+            <a:pPr defTabSz="1219170"/>
+            <a:r>
+              <a:rPr lang="en-US" sz="1600" dirty="0">
+                <a:solidFill>
+                  <a:srgbClr val="CADCFC"/>
+                </a:solidFill>
+                <a:latin typeface="Calibri" pitchFamily="34" charset="0"/>
+                <a:ea typeface="Calibri" pitchFamily="34" charset="-122"/>
+                <a:cs typeface="Calibri" pitchFamily="34" charset="-120"/>
+              </a:rPr>
+              <a:t>both voices (bass + sax)</a:t>
+            </a:r>
+            <a:endParaRPr lang="en-US" sz="1600" dirty="0">
+              <a:solidFill>
+                <a:prstClr val="black"/>
+              </a:solidFill>
+              <a:latin typeface="Calibri" panose="020F0502020204030204"/>
+            </a:endParaRPr>
+          </a:p>
+        </p:txBody>
+      </p:sp>
+      <p:sp>
+        <p:nvSpPr>
+          <p:cNvPr id="23" name="Shape 21"/>
+          <p:cNvSpPr/>
+          <p:nvPr/>
+        </p:nvSpPr>
+        <p:spPr>
+          <a:xfrm>
+            <a:off x="8839200" y="2610826"/>
+            <a:ext cx="0" cy="821376"/>
+          </a:xfrm>
+          <a:prstGeom prst="line">
+            <a:avLst/>
+          </a:prstGeom>
+          <a:noFill/>
+          <a:ln w="50800">
+            <a:solidFill>
+              <a:srgbClr val="CADCFC"/>
+            </a:solidFill>
+            <a:prstDash val="solid"/>
+          </a:ln>
+        </p:spPr>
+        <p:txBody>
+          <a:bodyPr/>
+          <a:lstStyle/>
+          <a:p>
+            <a:pPr defTabSz="1219170"/>
+            <a:endParaRPr lang="en-US" sz="2400">
+              <a:solidFill>
+                <a:prstClr val="black"/>
+              </a:solidFill>
+              <a:latin typeface="Calibri" panose="020F0502020204030204"/>
+            </a:endParaRPr>
+          </a:p>
+        </p:txBody>
+      </p:sp>
+      <p:sp>
+        <p:nvSpPr>
+          <p:cNvPr id="24" name="Shape 22"/>
+          <p:cNvSpPr/>
+          <p:nvPr/>
+        </p:nvSpPr>
+        <p:spPr>
+          <a:xfrm>
+            <a:off x="7912608" y="3432201"/>
+            <a:ext cx="926592" cy="0"/>
+          </a:xfrm>
+          <a:prstGeom prst="line">
+            <a:avLst/>
+          </a:prstGeom>
+          <a:noFill/>
+          <a:ln w="50800">
+            <a:solidFill>
+              <a:srgbClr val="CADCFC"/>
+            </a:solidFill>
+            <a:prstDash val="solid"/>
+            <a:headEnd type="arrow"/>
+          </a:ln>
+        </p:spPr>
+        <p:txBody>
+          <a:bodyPr/>
+          <a:lstStyle/>
+          <a:p>
+            <a:pPr defTabSz="1219170"/>
+            <a:endParaRPr lang="en-US" sz="2400">
+              <a:solidFill>
+                <a:prstClr val="black"/>
+              </a:solidFill>
+              <a:latin typeface="Calibri" panose="020F0502020204030204"/>
+            </a:endParaRPr>
+          </a:p>
+        </p:txBody>
+      </p:sp>
+      <p:sp>
+        <p:nvSpPr>
+          <p:cNvPr id="25" name="Shape 23"/>
+          <p:cNvSpPr/>
+          <p:nvPr/>
+        </p:nvSpPr>
+        <p:spPr>
+          <a:xfrm>
+            <a:off x="3566160" y="2734336"/>
+            <a:ext cx="0" cy="697865"/>
+          </a:xfrm>
+          <a:prstGeom prst="line">
+            <a:avLst/>
+          </a:prstGeom>
+          <a:noFill/>
+          <a:ln w="50800">
+            <a:solidFill>
+              <a:srgbClr val="CADCFC"/>
+            </a:solidFill>
+            <a:prstDash val="solid"/>
+          </a:ln>
+        </p:spPr>
+        <p:txBody>
+          <a:bodyPr/>
+          <a:lstStyle/>
+          <a:p>
+            <a:pPr defTabSz="1219170"/>
+            <a:endParaRPr lang="en-US" sz="2400">
+              <a:solidFill>
+                <a:prstClr val="black"/>
+              </a:solidFill>
+              <a:latin typeface="Calibri" panose="020F0502020204030204"/>
+            </a:endParaRPr>
+          </a:p>
+        </p:txBody>
+      </p:sp>
+      <p:sp>
+        <p:nvSpPr>
+          <p:cNvPr id="26" name="Shape 24"/>
+          <p:cNvSpPr/>
+          <p:nvPr/>
+        </p:nvSpPr>
+        <p:spPr>
+          <a:xfrm>
+            <a:off x="3566160" y="3432201"/>
+            <a:ext cx="883920" cy="0"/>
+          </a:xfrm>
+          <a:prstGeom prst="line">
+            <a:avLst/>
+          </a:prstGeom>
+          <a:noFill/>
+          <a:ln w="50800">
+            <a:solidFill>
+              <a:srgbClr val="CADCFC"/>
+            </a:solidFill>
+            <a:prstDash val="solid"/>
+            <a:tailEnd type="arrow"/>
+          </a:ln>
+        </p:spPr>
+        <p:txBody>
+          <a:bodyPr/>
+          <a:lstStyle/>
+          <a:p>
+            <a:pPr defTabSz="1219170"/>
+            <a:endParaRPr lang="en-US" sz="2400">
+              <a:solidFill>
+                <a:prstClr val="black"/>
+              </a:solidFill>
+              <a:latin typeface="Calibri" panose="020F0502020204030204"/>
+            </a:endParaRPr>
+          </a:p>
+        </p:txBody>
+      </p:sp>
+      <p:sp>
+        <p:nvSpPr>
+          <p:cNvPr id="27" name="Shape 25"/>
+          <p:cNvSpPr/>
+          <p:nvPr/>
+        </p:nvSpPr>
+        <p:spPr>
+          <a:xfrm>
+            <a:off x="3352800" y="4522399"/>
+            <a:ext cx="5486400" cy="1489456"/>
+          </a:xfrm>
+          <a:prstGeom prst="roundRect">
+            <a:avLst>
+              <a:gd name="adj" fmla="val 8000"/>
+            </a:avLst>
+          </a:prstGeom>
+          <a:solidFill>
+            <a:srgbClr val="253880"/>
+          </a:solidFill>
+          <a:ln w="25400">
+            <a:solidFill>
+              <a:srgbClr val="CADCFC"/>
+            </a:solidFill>
+            <a:prstDash val="solid"/>
+          </a:ln>
+        </p:spPr>
+        <p:txBody>
+          <a:bodyPr/>
+          <a:lstStyle/>
+          <a:p>
+            <a:pPr defTabSz="1219170"/>
+            <a:endParaRPr lang="en-US" sz="2400">
+              <a:solidFill>
+                <a:prstClr val="black"/>
+              </a:solidFill>
+              <a:latin typeface="Calibri" panose="020F0502020204030204"/>
+            </a:endParaRPr>
+          </a:p>
+        </p:txBody>
+      </p:sp>
+      <p:sp>
+        <p:nvSpPr>
+          <p:cNvPr id="28" name="Text 26"/>
+          <p:cNvSpPr/>
+          <p:nvPr/>
+        </p:nvSpPr>
+        <p:spPr>
+          <a:xfrm>
+            <a:off x="3413760" y="4574896"/>
+            <a:ext cx="5364480" cy="315309"/>
+          </a:xfrm>
+          <a:prstGeom prst="rect">
+            <a:avLst/>
+          </a:prstGeom>
+          <a:noFill/>
+          <a:ln/>
+        </p:spPr>
+        <p:txBody>
+          <a:bodyPr wrap="square" lIns="0" tIns="0" rIns="0" bIns="0" rtlCol="0" anchor="ctr"/>
+          <a:lstStyle/>
+          <a:p>
+            <a:pPr algn="ctr" defTabSz="1219170"/>
+            <a:r>
+              <a:rPr lang="en-US" sz="2400" b="1" dirty="0">
+                <a:solidFill>
+                  <a:srgbClr val="FFFFFF"/>
+                </a:solidFill>
+                <a:latin typeface="Calibri" pitchFamily="34" charset="0"/>
+                <a:ea typeface="Calibri" pitchFamily="34" charset="-122"/>
+                <a:cs typeface="Calibri" pitchFamily="34" charset="-120"/>
+              </a:rPr>
+              <a:t>ArcController</a:t>
+            </a:r>
+            <a:endParaRPr lang="en-US" sz="2400" dirty="0">
+              <a:solidFill>
+                <a:prstClr val="black"/>
+              </a:solidFill>
+              <a:latin typeface="Calibri" panose="020F0502020204030204"/>
+            </a:endParaRPr>
+          </a:p>
+        </p:txBody>
+      </p:sp>
+      <p:sp>
+        <p:nvSpPr>
+          <p:cNvPr id="29" name="Text 27"/>
+          <p:cNvSpPr/>
+          <p:nvPr/>
+        </p:nvSpPr>
+        <p:spPr>
+          <a:xfrm>
+            <a:off x="3450336" y="4886419"/>
+            <a:ext cx="5291328" cy="853440"/>
+          </a:xfrm>
+          <a:prstGeom prst="rect">
+            <a:avLst/>
+          </a:prstGeom>
+          <a:noFill/>
+          <a:ln/>
+        </p:spPr>
+        <p:txBody>
+          <a:bodyPr wrap="square" lIns="33867" tIns="33867" rIns="33867" bIns="33867" rtlCol="0" anchor="t"/>
+          <a:lstStyle/>
+          <a:p>
+            <a:pPr defTabSz="1219170"/>
+            <a:r>
+              <a:rPr lang="en-US" sz="1600" dirty="0">
+                <a:solidFill>
+                  <a:srgbClr val="CADCFC"/>
+                </a:solidFill>
+                <a:latin typeface="Calibri" pitchFamily="34" charset="0"/>
+                <a:ea typeface="Calibri" pitchFamily="34" charset="-122"/>
+                <a:cs typeface="Calibri" pitchFamily="34" charset="-120"/>
+              </a:rPr>
+              <a:t>5-min performance arc  ·  leadership &amp; proactive mode</a:t>
+            </a:r>
+            <a:endParaRPr lang="en-US" sz="1600" dirty="0">
+              <a:solidFill>
+                <a:prstClr val="black"/>
+              </a:solidFill>
+              <a:latin typeface="Calibri" panose="020F0502020204030204"/>
+            </a:endParaRPr>
+          </a:p>
+          <a:p>
+            <a:pPr defTabSz="1219170"/>
+            <a:r>
+              <a:rPr lang="en-US" sz="1600" dirty="0">
+                <a:solidFill>
+                  <a:srgbClr val="CADCFC"/>
+                </a:solidFill>
+                <a:latin typeface="Calibri" pitchFamily="34" charset="0"/>
+                <a:ea typeface="Calibri" pitchFamily="34" charset="-122"/>
+                <a:cs typeface="Calibri" pitchFamily="34" charset="-120"/>
+              </a:rPr>
+              <a:t>bass pitch-class tracking  ·  energy arc selection</a:t>
+            </a:r>
+            <a:endParaRPr lang="en-US" sz="1600" dirty="0">
+              <a:solidFill>
+                <a:prstClr val="black"/>
+              </a:solidFill>
+              <a:latin typeface="Calibri" panose="020F0502020204030204"/>
+            </a:endParaRPr>
+          </a:p>
+          <a:p>
+            <a:pPr defTabSz="1219170"/>
+            <a:r>
+              <a:rPr lang="en-US" sz="1600" dirty="0">
+                <a:solidFill>
+                  <a:srgbClr val="CADCFC"/>
+                </a:solidFill>
+                <a:latin typeface="Calibri" pitchFamily="34" charset="0"/>
+                <a:ea typeface="Calibri" pitchFamily="34" charset="-122"/>
+                <a:cs typeface="Calibri" pitchFamily="34" charset="-120"/>
+              </a:rPr>
+              <a:t>motif + lyrical motif selection  ·  register contrast scheduling</a:t>
+            </a:r>
+            <a:endParaRPr lang="en-US" sz="1600" dirty="0">
+              <a:solidFill>
+                <a:prstClr val="black"/>
+              </a:solidFill>
+              <a:latin typeface="Calibri" panose="020F0502020204030204"/>
+            </a:endParaRPr>
+          </a:p>
+          <a:p>
+            <a:pPr defTabSz="1219170"/>
+            <a:r>
+              <a:rPr lang="en-US" sz="1600" dirty="0">
+                <a:solidFill>
+                  <a:srgbClr val="CADCFC"/>
+                </a:solidFill>
+                <a:latin typeface="Calibri" pitchFamily="34" charset="0"/>
+                <a:ea typeface="Calibri" pitchFamily="34" charset="-122"/>
+                <a:cs typeface="Calibri" pitchFamily="34" charset="-120"/>
+              </a:rPr>
+              <a:t>rhythmic density + complementarity  ·  stage swing baseline</a:t>
+            </a:r>
+            <a:endParaRPr lang="en-US" sz="1600" dirty="0">
+              <a:solidFill>
+                <a:prstClr val="black"/>
+              </a:solidFill>
+              <a:latin typeface="Calibri" panose="020F0502020204030204"/>
+            </a:endParaRPr>
+          </a:p>
+        </p:txBody>
+      </p:sp>
+      <p:sp>
+        <p:nvSpPr>
+          <p:cNvPr id="30" name="Shape 28"/>
+          <p:cNvSpPr/>
+          <p:nvPr/>
+        </p:nvSpPr>
+        <p:spPr>
+          <a:xfrm>
+            <a:off x="6096000" y="4125109"/>
+            <a:ext cx="0" cy="315309"/>
+          </a:xfrm>
+          <a:prstGeom prst="line">
+            <a:avLst/>
+          </a:prstGeom>
+          <a:noFill/>
+          <a:ln w="50800">
+            <a:solidFill>
+              <a:srgbClr val="CADCFC"/>
+            </a:solidFill>
+            <a:prstDash val="solid"/>
+            <a:tailEnd type="arrow"/>
+          </a:ln>
+        </p:spPr>
+        <p:txBody>
+          <a:bodyPr/>
+          <a:lstStyle/>
+          <a:p>
+            <a:pPr defTabSz="1219170"/>
+            <a:endParaRPr lang="en-US" sz="2400">
+              <a:solidFill>
+                <a:prstClr val="black"/>
+              </a:solidFill>
+              <a:latin typeface="Calibri" panose="020F0502020204030204"/>
+            </a:endParaRPr>
+          </a:p>
+        </p:txBody>
+      </p:sp>
+      <p:sp>
+        <p:nvSpPr>
+          <p:cNvPr id="32" name="Shape 28">
+            <a:extLst>
+              <a:ext uri="{FF2B5EF4-FFF2-40B4-BE49-F238E27FC236}">
+                <a16:creationId xmlns:a16="http://schemas.microsoft.com/office/drawing/2014/main" id="{82A67C06-F31C-A34E-B75C-378998F00D80}"/>
+              </a:ext>
+            </a:extLst>
+          </p:cNvPr>
+          <p:cNvSpPr/>
+          <p:nvPr/>
+        </p:nvSpPr>
+        <p:spPr>
+          <a:xfrm>
+            <a:off x="5991749" y="6173273"/>
+            <a:ext cx="0" cy="476909"/>
+          </a:xfrm>
+          <a:prstGeom prst="line">
+            <a:avLst/>
+          </a:prstGeom>
+          <a:noFill/>
+          <a:ln w="50800">
+            <a:solidFill>
+              <a:srgbClr val="FFC000"/>
+            </a:solidFill>
+            <a:prstDash val="solid"/>
+            <a:tailEnd type="arrow"/>
+          </a:ln>
+        </p:spPr>
+        <p:txBody>
+          <a:bodyPr/>
+          <a:lstStyle/>
+          <a:p>
+            <a:pPr defTabSz="1219170"/>
+            <a:endParaRPr lang="en-US" sz="2400" dirty="0">
+              <a:solidFill>
+                <a:prstClr val="black"/>
+              </a:solidFill>
+              <a:latin typeface="Calibri" panose="020F0502020204030204"/>
+            </a:endParaRPr>
+          </a:p>
+        </p:txBody>
+      </p:sp>
+      <p:sp>
+        <p:nvSpPr>
+          <p:cNvPr id="33" name="Shape 13">
+            <a:extLst>
+              <a:ext uri="{FF2B5EF4-FFF2-40B4-BE49-F238E27FC236}">
+                <a16:creationId xmlns:a16="http://schemas.microsoft.com/office/drawing/2014/main" id="{BE87611D-8695-346E-CD03-8723D7EC6F13}"/>
+              </a:ext>
+            </a:extLst>
+          </p:cNvPr>
+          <p:cNvSpPr/>
+          <p:nvPr/>
+        </p:nvSpPr>
+        <p:spPr>
+          <a:xfrm>
+            <a:off x="4834130" y="1139298"/>
+            <a:ext cx="582300" cy="0"/>
+          </a:xfrm>
+          <a:prstGeom prst="line">
+            <a:avLst/>
+          </a:prstGeom>
+          <a:noFill/>
+          <a:ln w="50800">
+            <a:solidFill>
+              <a:srgbClr val="CADCFC"/>
+            </a:solidFill>
+            <a:prstDash val="solid"/>
+            <a:tailEnd type="arrow"/>
+          </a:ln>
+        </p:spPr>
+        <p:txBody>
+          <a:bodyPr/>
+          <a:lstStyle/>
+          <a:p>
+            <a:pPr defTabSz="1219170"/>
+            <a:endParaRPr lang="en-US" sz="2400">
+              <a:solidFill>
+                <a:prstClr val="black"/>
+              </a:solidFill>
+              <a:latin typeface="Calibri" panose="020F0502020204030204"/>
+            </a:endParaRPr>
+          </a:p>
+        </p:txBody>
+      </p:sp>
+      <p:sp>
+        <p:nvSpPr>
+          <p:cNvPr id="34" name="Shape 13">
+            <a:extLst>
+              <a:ext uri="{FF2B5EF4-FFF2-40B4-BE49-F238E27FC236}">
+                <a16:creationId xmlns:a16="http://schemas.microsoft.com/office/drawing/2014/main" id="{7493AAE1-3A41-2F24-A433-15942ED6887C}"/>
+              </a:ext>
+            </a:extLst>
+          </p:cNvPr>
+          <p:cNvSpPr/>
+          <p:nvPr/>
+        </p:nvSpPr>
+        <p:spPr>
+          <a:xfrm>
+            <a:off x="2389639" y="1108553"/>
+            <a:ext cx="377951" cy="0"/>
+          </a:xfrm>
+          <a:prstGeom prst="line">
+            <a:avLst/>
+          </a:prstGeom>
+          <a:noFill/>
+          <a:ln w="50800">
+            <a:solidFill>
+              <a:srgbClr val="CADCFC"/>
+            </a:solidFill>
+            <a:prstDash val="solid"/>
+            <a:tailEnd type="arrow"/>
+          </a:ln>
+        </p:spPr>
+        <p:txBody>
+          <a:bodyPr/>
+          <a:lstStyle/>
+          <a:p>
+            <a:pPr defTabSz="1219170"/>
+            <a:endParaRPr lang="en-US" sz="2400">
+              <a:solidFill>
+                <a:prstClr val="black"/>
+              </a:solidFill>
+              <a:latin typeface="Calibri" panose="020F0502020204030204"/>
+            </a:endParaRPr>
+          </a:p>
+        </p:txBody>
+      </p:sp>
+    </p:spTree>
+  </p:cSld>
+  <p:clrMapOvr>
+    <a:masterClrMapping/>
+  </p:clrMapOvr>
+</p:sld>
+</file>
+
+<file path=ppt/slides/slide7.xml><?xml version="1.0" encoding="utf-8"?>
+<p:sld xmlns:a="http://schemas.openxmlformats.org/drawingml/2006/main" xmlns:r="http://schemas.openxmlformats.org/officeDocument/2006/relationships" xmlns:p="http://schemas.openxmlformats.org/presentationml/2006/main">
+  <p:cSld>
+    <p:bg>
+      <p:bgPr>
+        <a:solidFill>
+          <a:srgbClr val="00B0F0"/>
+        </a:solidFill>
+        <a:effectLst/>
+      </p:bgPr>
+    </p:bg>
+    <p:spTree>
+      <p:nvGrpSpPr>
+        <p:cNvPr id="1" name=""/>
+        <p:cNvGrpSpPr/>
+        <p:nvPr/>
+      </p:nvGrpSpPr>
+      <p:grpSpPr>
+        <a:xfrm>
+          <a:off x="0" y="0"/>
+          <a:ext cx="0" cy="0"/>
+          <a:chOff x="0" y="0"/>
+          <a:chExt cx="0" cy="0"/>
+        </a:xfrm>
+      </p:grpSpPr>
+      <p:sp>
+        <p:nvSpPr>
+          <p:cNvPr id="3" name="Text 1"/>
+          <p:cNvSpPr/>
+          <p:nvPr/>
+        </p:nvSpPr>
+        <p:spPr>
+          <a:xfrm>
             <a:off x="8847152" y="620973"/>
             <a:ext cx="2628677" cy="1394410"/>
           </a:xfrm>
@@ -8831,7 +9166,7 @@
 </p:sld>
 </file>
 
-<file path=ppt/slides/slide7.xml><?xml version="1.0" encoding="utf-8"?>
+<file path=ppt/slides/slide8.xml><?xml version="1.0" encoding="utf-8"?>
 <p:sld xmlns:a="http://schemas.openxmlformats.org/drawingml/2006/main" xmlns:r="http://schemas.openxmlformats.org/officeDocument/2006/relationships" xmlns:p="http://schemas.openxmlformats.org/presentationml/2006/main">
   <p:cSld>
     <p:spTree>
@@ -9221,7 +9556,7 @@
 </p:sld>
 </file>
 
-<file path=ppt/slides/slide8.xml><?xml version="1.0" encoding="utf-8"?>
+<file path=ppt/slides/slide9.xml><?xml version="1.0" encoding="utf-8"?>
 <p:sld xmlns:a="http://schemas.openxmlformats.org/drawingml/2006/main" xmlns:r="http://schemas.openxmlformats.org/officeDocument/2006/relationships" xmlns:p="http://schemas.openxmlformats.org/presentationml/2006/main">
   <p:cSld>
     <p:spTree>
@@ -9301,7 +9636,7 @@
         </p:spPr>
         <p:txBody>
           <a:bodyPr>
-            <a:normAutofit/>
+            <a:normAutofit lnSpcReduction="10000"/>
           </a:bodyPr>
           <a:lstStyle/>
           <a:p>
@@ -9313,18 +9648,21 @@
               <a:rPr lang="en-GB" dirty="0" err="1"/>
               <a:t>microtiming</a:t>
             </a:r>
-            <a:endParaRPr lang="en-GB" dirty="0"/>
-          </a:p>
-          <a:p>
             <a:r>
               <a:rPr lang="en-GB" dirty="0"/>
-              <a:t>Conversation might be too polite</a:t>
+              <a:t> which is crucial to jazz</a:t>
             </a:r>
           </a:p>
           <a:p>
             <a:r>
               <a:rPr lang="en-GB" dirty="0"/>
-              <a:t>No personal voice</a:t>
+              <a:t>Conversation might be too polite, with strict turn-taking</a:t>
+            </a:r>
+          </a:p>
+          <a:p>
+            <a:r>
+              <a:rPr lang="en-GB" dirty="0"/>
+              <a:t>No personal voice – it’s generalised be-bop</a:t>
             </a:r>
           </a:p>
           <a:p>
@@ -9336,13 +9674,19 @@
           <a:p>
             <a:r>
               <a:rPr lang="en-GB" dirty="0"/>
-              <a:t>Motivic development might feel like repetition</a:t>
+              <a:t>Motivic development might feel like repetition – because it is</a:t>
             </a:r>
           </a:p>
           <a:p>
             <a:r>
               <a:rPr lang="en-GB" dirty="0"/>
-              <a:t>It uses MIDI, so perhaps it inevitably sounds like a very good MIDI file but there’ll be a lack of expression/articulation</a:t>
+              <a:t>It uses MIDI, so perhaps it inevitably sounds like a very good MIDI file and there’ll be a lack of expression/articulation</a:t>
+            </a:r>
+          </a:p>
+          <a:p>
+            <a:r>
+              <a:rPr lang="en-GB" dirty="0"/>
+              <a:t>The audience might feel it would be better musically if it used a chord progression – but the whole point is that it doesn’t, it’s responsive. There are plenty of play along programs out there.</a:t>
             </a:r>
           </a:p>
           <a:p>

</xml_diff>

<commit_message>
Update wolfson.pptx and PDF
Co-Authored-By: Claude Sonnet 4.6 <noreply@anthropic.com>
</commit_message>
<xml_diff>
--- a/docs/wolfson.pptx
+++ b/docs/wolfson.pptx
@@ -5384,7 +5384,7 @@
               <a:rPr lang="en-US" dirty="0">
                 <a:latin typeface="Garamond" panose="02020404030301010803" pitchFamily="18" charset="0"/>
               </a:rPr>
-              <a:t>Radar of the lost arc</a:t>
+              <a:t>Radar of the lost archive</a:t>
             </a:r>
           </a:p>
         </p:txBody>
@@ -5502,7 +5502,7 @@
         </p:blipFill>
         <p:spPr>
           <a:xfrm>
-            <a:off x="6994788" y="1393902"/>
+            <a:off x="6994788" y="1640644"/>
             <a:ext cx="4609251" cy="4717521"/>
           </a:xfrm>
           <a:prstGeom prst="rect">
@@ -5529,7 +5529,7 @@
         </p:nvSpPr>
         <p:spPr>
           <a:xfrm>
-            <a:off x="6096000" y="3688080"/>
+            <a:off x="6096000" y="3934818"/>
             <a:ext cx="762000" cy="406400"/>
           </a:xfrm>
           <a:prstGeom prst="rightArrow">
@@ -5567,6 +5567,36 @@
           </a:p>
         </p:txBody>
       </p:sp>
+      <p:pic>
+        <p:nvPicPr>
+          <p:cNvPr id="9" name="Picture 8">
+            <a:extLst>
+              <a:ext uri="{FF2B5EF4-FFF2-40B4-BE49-F238E27FC236}">
+                <a16:creationId xmlns:a16="http://schemas.microsoft.com/office/drawing/2014/main" id="{EBF1EAC7-9720-561B-E6BA-A0424A5D5EF7}"/>
+              </a:ext>
+            </a:extLst>
+          </p:cNvPr>
+          <p:cNvPicPr>
+            <a:picLocks noChangeAspect="1"/>
+          </p:cNvPicPr>
+          <p:nvPr/>
+        </p:nvPicPr>
+        <p:blipFill>
+          <a:blip r:embed="rId4"/>
+          <a:stretch>
+            <a:fillRect/>
+          </a:stretch>
+        </p:blipFill>
+        <p:spPr>
+          <a:xfrm>
+            <a:off x="6807764" y="609600"/>
+            <a:ext cx="5042991" cy="1031044"/>
+          </a:xfrm>
+          <a:prstGeom prst="rect">
+            <a:avLst/>
+          </a:prstGeom>
+        </p:spPr>
+      </p:pic>
     </p:spTree>
     <p:extLst>
       <p:ext uri="{BB962C8B-B14F-4D97-AF65-F5344CB8AC3E}">
@@ -5857,7 +5887,7 @@
               <a:rPr lang="en-US" dirty="0">
                 <a:latin typeface="Optima" panose="02000503060000020004" pitchFamily="2" charset="0"/>
               </a:rPr>
-              <a:t>The Ambition</a:t>
+              <a:t>Now’s the time</a:t>
             </a:r>
           </a:p>
         </p:txBody>
@@ -6715,7 +6745,7 @@
               <a:rPr lang="en-GB" sz="2400" b="1" dirty="0">
                 <a:latin typeface="Palatino Linotype" panose="02040502050505030304" pitchFamily="18" charset="0"/>
               </a:rPr>
-              <a:t>5 Giant steps in the arc:</a:t>
+              <a:t>Five giant steps in the arc:</a:t>
             </a:r>
             <a:br>
               <a:rPr lang="en-GB" sz="2400" b="1" dirty="0">
@@ -7043,7 +7073,7 @@
               <a:rPr lang="en-US" dirty="0">
                 <a:latin typeface="Garamond" panose="02020404030301010803" pitchFamily="18" charset="0"/>
               </a:rPr>
-              <a:t>Sentimental journey</a:t>
+              <a:t>Sentimental journeys</a:t>
             </a:r>
             <a:endParaRPr lang="en-US" baseline="30000" dirty="0">
               <a:latin typeface="Garamond" panose="02020404030301010803" pitchFamily="18" charset="0"/>
@@ -10231,8 +10261,10 @@
           <a:lstStyle/>
           <a:p>
             <a:r>
-              <a:rPr lang="en-US" dirty="0"/>
-              <a:t>Web Display</a:t>
+              <a:rPr lang="en-US" dirty="0">
+                <a:latin typeface="Optima" panose="02000503060000020004" pitchFamily="2" charset="0"/>
+              </a:rPr>
+              <a:t>Soul eyes</a:t>
             </a:r>
           </a:p>
         </p:txBody>

</xml_diff>

<commit_message>
Update presentation slides (wolfson.pptx and wolfson.pdf)
Co-Authored-By: Claude Sonnet 4.6 <noreply@anthropic.com>
</commit_message>
<xml_diff>
--- a/docs/wolfson.pptx
+++ b/docs/wolfson.pptx
@@ -5712,19 +5712,7 @@
               <a:rPr lang="en-GB" sz="2400" dirty="0">
                 <a:latin typeface="Palatino Linotype" panose="02040502050505030304" pitchFamily="18" charset="0"/>
               </a:rPr>
-              <a:t>The time feel might be mechanical – lack of </a:t>
-            </a:r>
-            <a:r>
-              <a:rPr lang="en-GB" sz="2400" dirty="0" err="1">
-                <a:latin typeface="Palatino Linotype" panose="02040502050505030304" pitchFamily="18" charset="0"/>
-              </a:rPr>
-              <a:t>microtiming</a:t>
-            </a:r>
-            <a:r>
-              <a:rPr lang="en-GB" sz="2400" dirty="0">
-                <a:latin typeface="Palatino Linotype" panose="02040502050505030304" pitchFamily="18" charset="0"/>
-              </a:rPr>
-              <a:t>, crucial to jazz.</a:t>
+              <a:t>It uses MIDI, so perhaps it inevitably sounds like a very good MIDI file and there’ll be a lack of expression/articulation.</a:t>
             </a:r>
           </a:p>
           <a:p>
@@ -5737,7 +5725,19 @@
               <a:rPr lang="en-GB" sz="2400" dirty="0">
                 <a:latin typeface="Palatino Linotype" panose="02040502050505030304" pitchFamily="18" charset="0"/>
               </a:rPr>
-              <a:t>Conversation might be too polite, with its strict turn-taking.</a:t>
+              <a:t>The time feel might be mechanical – lack of </a:t>
+            </a:r>
+            <a:r>
+              <a:rPr lang="en-GB" sz="2400" dirty="0" err="1">
+                <a:latin typeface="Palatino Linotype" panose="02040502050505030304" pitchFamily="18" charset="0"/>
+              </a:rPr>
+              <a:t>microtiming</a:t>
+            </a:r>
+            <a:r>
+              <a:rPr lang="en-GB" sz="2400" dirty="0">
+                <a:latin typeface="Palatino Linotype" panose="02040502050505030304" pitchFamily="18" charset="0"/>
+              </a:rPr>
+              <a:t>, crucial to jazz.</a:t>
             </a:r>
           </a:p>
           <a:p>
@@ -5750,7 +5750,7 @@
               <a:rPr lang="en-GB" sz="2400" dirty="0">
                 <a:latin typeface="Palatino Linotype" panose="02040502050505030304" pitchFamily="18" charset="0"/>
               </a:rPr>
-              <a:t>No personal voice – it’s generalised be-bop.</a:t>
+              <a:t>Conversation might be too polite, with its strict turn-taking.</a:t>
             </a:r>
           </a:p>
           <a:p>
@@ -5763,7 +5763,7 @@
               <a:rPr lang="en-GB" sz="2400" dirty="0">
                 <a:latin typeface="Palatino Linotype" panose="02040502050505030304" pitchFamily="18" charset="0"/>
               </a:rPr>
-              <a:t>The arc is clock-driven, not music-driven.</a:t>
+              <a:t>No personal voice – it’s generalised be-bop.</a:t>
             </a:r>
           </a:p>
           <a:p>
@@ -5776,7 +5776,7 @@
               <a:rPr lang="en-GB" sz="2400" dirty="0">
                 <a:latin typeface="Palatino Linotype" panose="02040502050505030304" pitchFamily="18" charset="0"/>
               </a:rPr>
-              <a:t>Motivic development might feel like repetition – because it is.</a:t>
+              <a:t>The arc is clock-driven, not music-driven.</a:t>
             </a:r>
           </a:p>
           <a:p>
@@ -5789,7 +5789,7 @@
               <a:rPr lang="en-GB" sz="2400" dirty="0">
                 <a:latin typeface="Palatino Linotype" panose="02040502050505030304" pitchFamily="18" charset="0"/>
               </a:rPr>
-              <a:t>It uses MIDI, so perhaps it inevitably sounds like a very good MIDI file and there’ll be a lack of expression/articulation.</a:t>
+              <a:t>Motivic development might feel like repetition – because it is.</a:t>
             </a:r>
           </a:p>
           <a:p>
@@ -5802,7 +5802,19 @@
               <a:rPr lang="en-GB" sz="2400" dirty="0">
                 <a:latin typeface="Palatino Linotype" panose="02040502050505030304" pitchFamily="18" charset="0"/>
               </a:rPr>
-              <a:t>The audience might feel it would be better musically if it used a chord progression – but the whole point is that it doesn’t, it’s responsive. There are plenty of play-along programs out there.</a:t>
+              <a:t>The audience might feel it would be ‘more musical’ if it used </a:t>
+            </a:r>
+            <a:r>
+              <a:rPr lang="en-GB" sz="2400">
+                <a:latin typeface="Palatino Linotype" panose="02040502050505030304" pitchFamily="18" charset="0"/>
+              </a:rPr>
+              <a:t>an underlying </a:t>
+            </a:r>
+            <a:r>
+              <a:rPr lang="en-GB" sz="2400" dirty="0">
+                <a:latin typeface="Palatino Linotype" panose="02040502050505030304" pitchFamily="18" charset="0"/>
+              </a:rPr>
+              <a:t>chord progression – but the whole point is that it doesn’t, it’s responsive. There are plenty of play-along programs out there.</a:t>
             </a:r>
           </a:p>
           <a:p>
@@ -6290,7 +6302,7 @@
         <p:spPr>
           <a:xfrm>
             <a:off x="4330267" y="1393902"/>
-            <a:ext cx="3954966" cy="4135299"/>
+            <a:ext cx="3954966" cy="4947829"/>
           </a:xfrm>
           <a:prstGeom prst="rect">
             <a:avLst/>
@@ -6314,6 +6326,28 @@
               </a:rPr>
               <a:t>Dynamics</a:t>
             </a:r>
+            <a:br>
+              <a:rPr lang="en-GB" sz="2400" dirty="0">
+                <a:latin typeface="Palatino Linotype" panose="02040502050505030304" pitchFamily="18" charset="0"/>
+              </a:rPr>
+            </a:br>
+            <a:r>
+              <a:rPr lang="en-GB" sz="2400" dirty="0">
+                <a:latin typeface="Palatino Linotype" panose="02040502050505030304" pitchFamily="18" charset="0"/>
+              </a:rPr>
+              <a:t>Generation temperature</a:t>
+            </a:r>
+            <a:br>
+              <a:rPr lang="en-GB" sz="2400" dirty="0">
+                <a:latin typeface="Palatino Linotype" panose="02040502050505030304" pitchFamily="18" charset="0"/>
+              </a:rPr>
+            </a:br>
+            <a:r>
+              <a:rPr lang="en-GB" sz="2400" dirty="0">
+                <a:latin typeface="Palatino Linotype" panose="02040502050505030304" pitchFamily="18" charset="0"/>
+              </a:rPr>
+              <a:t>Phrase-shape dynamics</a:t>
+            </a:r>
           </a:p>
           <a:p>
             <a:pPr>
@@ -6449,7 +6483,7 @@
         <p:spPr>
           <a:xfrm>
             <a:off x="7978697" y="1393902"/>
-            <a:ext cx="3954966" cy="4541564"/>
+            <a:ext cx="3954966" cy="4947829"/>
           </a:xfrm>
           <a:prstGeom prst="rect">
             <a:avLst/>
@@ -6549,7 +6583,7 @@
               <a:rPr lang="en-GB" sz="2400" dirty="0">
                 <a:latin typeface="Palatino Linotype" panose="02040502050505030304" pitchFamily="18" charset="0"/>
               </a:rPr>
-              <a:t>Ostinato</a:t>
+              <a:t>Repetition control</a:t>
             </a:r>
           </a:p>
           <a:p>
@@ -6571,6 +6605,17 @@
                 <a:spcPct val="110000"/>
               </a:lnSpc>
             </a:pPr>
+            <a:r>
+              <a:rPr lang="en-GB" sz="2400" dirty="0">
+                <a:latin typeface="Palatino Linotype" panose="02040502050505030304" pitchFamily="18" charset="0"/>
+              </a:rPr>
+              <a:t>Loop mode</a:t>
+            </a:r>
+            <a:br>
+              <a:rPr lang="en-GB" sz="2400" dirty="0">
+                <a:latin typeface="Palatino Linotype" panose="02040502050505030304" pitchFamily="18" charset="0"/>
+              </a:rPr>
+            </a:br>
             <a:r>
               <a:rPr lang="en-GB" sz="2400" dirty="0">
                 <a:latin typeface="Palatino Linotype" panose="02040502050505030304" pitchFamily="18" charset="0"/>
@@ -7349,7 +7394,7 @@
         </p:nvSpPr>
         <p:spPr>
           <a:xfrm>
-            <a:off x="600862" y="3743623"/>
+            <a:off x="417978" y="3159474"/>
             <a:ext cx="2264263" cy="1662546"/>
           </a:xfrm>
           <a:prstGeom prst="rect">
@@ -7364,7 +7409,7 @@
           <a:p>
             <a:pPr defTabSz="1219170"/>
             <a:r>
-              <a:rPr lang="en-US" sz="4000" b="1" dirty="0">
+              <a:rPr lang="en-US" sz="4800" b="1" dirty="0">
                 <a:solidFill>
                   <a:srgbClr val="FFFFFF"/>
                 </a:solidFill>
@@ -7374,7 +7419,7 @@
               </a:rPr>
               <a:t>Input Pipeline</a:t>
             </a:r>
-            <a:endParaRPr lang="en-US" sz="4000" dirty="0">
+            <a:endParaRPr lang="en-US" sz="4800" dirty="0">
               <a:solidFill>
                 <a:prstClr val="black"/>
               </a:solidFill>
@@ -7494,7 +7539,7 @@
         </p:nvSpPr>
         <p:spPr>
           <a:xfrm>
-            <a:off x="2865125" y="846690"/>
+            <a:off x="2865125" y="761879"/>
             <a:ext cx="1889760" cy="585216"/>
           </a:xfrm>
           <a:prstGeom prst="roundRect">
@@ -7534,7 +7579,7 @@
         </p:nvSpPr>
         <p:spPr>
           <a:xfrm>
-            <a:off x="2865125" y="846690"/>
+            <a:off x="2865125" y="761879"/>
             <a:ext cx="1889760" cy="585216"/>
           </a:xfrm>
           <a:prstGeom prst="rect">
@@ -7576,8 +7621,8 @@
         </p:nvSpPr>
         <p:spPr>
           <a:xfrm>
-            <a:off x="5416430" y="846690"/>
-            <a:ext cx="2291561" cy="585216"/>
+            <a:off x="5416430" y="761879"/>
+            <a:ext cx="2291561" cy="1426629"/>
           </a:xfrm>
           <a:prstGeom prst="roundRect">
             <a:avLst>
@@ -7616,8 +7661,8 @@
         </p:nvSpPr>
         <p:spPr>
           <a:xfrm>
-            <a:off x="5477390" y="846690"/>
-            <a:ext cx="2197479" cy="585216"/>
+            <a:off x="5477390" y="761879"/>
+            <a:ext cx="2197479" cy="583084"/>
           </a:xfrm>
           <a:prstGeom prst="rect">
             <a:avLst/>
@@ -7631,7 +7676,7 @@
           <a:p>
             <a:pPr algn="ctr" defTabSz="1219170"/>
             <a:r>
-              <a:rPr lang="en-US" sz="2400" b="1" dirty="0">
+              <a:rPr lang="en-US" sz="2400" b="1" dirty="0" err="1">
                 <a:solidFill>
                   <a:srgbClr val="FFFFFF"/>
                 </a:solidFill>
@@ -7658,8 +7703,8 @@
         </p:nvSpPr>
         <p:spPr>
           <a:xfrm>
-            <a:off x="8473440" y="664343"/>
-            <a:ext cx="3413760" cy="1828800"/>
+            <a:off x="8410379" y="761879"/>
+            <a:ext cx="3413760" cy="1671258"/>
           </a:xfrm>
           <a:prstGeom prst="roundRect">
             <a:avLst>
@@ -7698,8 +7743,8 @@
         </p:nvSpPr>
         <p:spPr>
           <a:xfrm>
-            <a:off x="8534400" y="706749"/>
-            <a:ext cx="3291840" cy="316992"/>
+            <a:off x="8471339" y="761878"/>
+            <a:ext cx="3291840" cy="537237"/>
           </a:xfrm>
           <a:prstGeom prst="rect">
             <a:avLst/>
@@ -7740,8 +7785,8 @@
         </p:nvSpPr>
         <p:spPr>
           <a:xfrm>
-            <a:off x="8839200" y="1030103"/>
-            <a:ext cx="2950464" cy="1463040"/>
+            <a:off x="8776139" y="1328482"/>
+            <a:ext cx="2950464" cy="1134021"/>
           </a:xfrm>
           <a:prstGeom prst="rect">
             <a:avLst/>
@@ -7763,18 +7808,9 @@
                 <a:ea typeface="Calibri" pitchFamily="34" charset="-122"/>
                 <a:cs typeface="Calibri" pitchFamily="34" charset="-120"/>
               </a:rPr>
-              <a:t>contour, density</a:t>
-            </a:r>
-            <a:endParaRPr lang="en-US" sz="1600" dirty="0">
-              <a:solidFill>
-                <a:prstClr val="black"/>
-              </a:solidFill>
-              <a:latin typeface="Calibri" panose="020F0502020204030204"/>
-            </a:endParaRPr>
-          </a:p>
-          <a:p>
-            <a:pPr defTabSz="1219170"/>
-            <a:r>
+              <a:t>contour · density · Q&amp;A type</a:t>
+            </a:r>
+            <a:br>
               <a:rPr lang="en-US" sz="1600" dirty="0">
                 <a:solidFill>
                   <a:srgbClr val="CADCFC"/>
@@ -7783,17 +7819,7 @@
                 <a:ea typeface="Calibri" pitchFamily="34" charset="-122"/>
                 <a:cs typeface="Calibri" pitchFamily="34" charset="-120"/>
               </a:rPr>
-              <a:t>Q&amp;A type, swing</a:t>
-            </a:r>
-            <a:endParaRPr lang="en-US" sz="1600" dirty="0">
-              <a:solidFill>
-                <a:prstClr val="black"/>
-              </a:solidFill>
-              <a:latin typeface="Calibri" panose="020F0502020204030204"/>
-            </a:endParaRPr>
-          </a:p>
-          <a:p>
-            <a:pPr defTabSz="1219170"/>
+            </a:br>
             <a:r>
               <a:rPr lang="en-US" sz="1600" dirty="0">
                 <a:solidFill>
@@ -7803,7 +7829,7 @@
                 <a:ea typeface="Calibri" pitchFamily="34" charset="-122"/>
                 <a:cs typeface="Calibri" pitchFamily="34" charset="-120"/>
               </a:rPr>
-              <a:t>dynamics, energy profile</a:t>
+              <a:t>swing · dynamics · energy profile</a:t>
             </a:r>
             <a:endParaRPr lang="en-US" sz="1600" dirty="0">
               <a:solidFill>
@@ -7823,27 +7849,7 @@
                 <a:ea typeface="Calibri" pitchFamily="34" charset="-122"/>
                 <a:cs typeface="Calibri" pitchFamily="34" charset="-120"/>
               </a:rPr>
-              <a:t>pitch classes</a:t>
-            </a:r>
-            <a:endParaRPr lang="en-US" sz="1600" dirty="0">
-              <a:solidFill>
-                <a:prstClr val="black"/>
-              </a:solidFill>
-              <a:latin typeface="Calibri" panose="020F0502020204030204"/>
-            </a:endParaRPr>
-          </a:p>
-          <a:p>
-            <a:pPr defTabSz="1219170"/>
-            <a:r>
-              <a:rPr lang="en-US" sz="1600" dirty="0">
-                <a:solidFill>
-                  <a:srgbClr val="CADCFC"/>
-                </a:solidFill>
-                <a:latin typeface="Calibri" pitchFamily="34" charset="0"/>
-                <a:ea typeface="Calibri" pitchFamily="34" charset="-122"/>
-                <a:cs typeface="Calibri" pitchFamily="34" charset="-120"/>
-              </a:rPr>
-              <a:t>interval motifs, lyrical motifs</a:t>
+              <a:t>pitch classes · interval motifs lyrical motifs</a:t>
             </a:r>
             <a:endParaRPr lang="en-US" sz="1600" dirty="0">
               <a:solidFill>
@@ -7899,8 +7905,8 @@
         </p:nvSpPr>
         <p:spPr>
           <a:xfrm>
-            <a:off x="2389639" y="1999634"/>
-            <a:ext cx="2292087" cy="585216"/>
+            <a:off x="2389639" y="1803148"/>
+            <a:ext cx="2292087" cy="781702"/>
           </a:xfrm>
           <a:prstGeom prst="roundRect">
             <a:avLst>
@@ -7939,8 +7945,8 @@
         </p:nvSpPr>
         <p:spPr>
           <a:xfrm>
-            <a:off x="2389637" y="1999633"/>
-            <a:ext cx="2292087" cy="342371"/>
+            <a:off x="2389637" y="1884683"/>
+            <a:ext cx="2292087" cy="353568"/>
           </a:xfrm>
           <a:prstGeom prst="rect">
             <a:avLst/>
@@ -7981,8 +7987,8 @@
         </p:nvSpPr>
         <p:spPr>
           <a:xfrm>
-            <a:off x="2987040" y="2273325"/>
-            <a:ext cx="1694688" cy="219456"/>
+            <a:off x="2987040" y="2199643"/>
+            <a:ext cx="1694688" cy="293138"/>
           </a:xfrm>
           <a:prstGeom prst="rect">
             <a:avLst/>
@@ -8023,7 +8029,7 @@
         </p:nvSpPr>
         <p:spPr>
           <a:xfrm>
-            <a:off x="3566160" y="1560191"/>
+            <a:off x="3566160" y="1391663"/>
             <a:ext cx="0" cy="353568"/>
           </a:xfrm>
           <a:prstGeom prst="line">
@@ -8060,7 +8066,7 @@
         </p:nvSpPr>
         <p:spPr>
           <a:xfrm>
-            <a:off x="4513688" y="2755535"/>
+            <a:off x="4555181" y="2755535"/>
             <a:ext cx="3291840" cy="1287592"/>
           </a:xfrm>
           <a:prstGeom prst="roundRect">
@@ -8100,7 +8106,7 @@
         </p:nvSpPr>
         <p:spPr>
           <a:xfrm>
-            <a:off x="4574648" y="2842482"/>
+            <a:off x="4616141" y="2842482"/>
             <a:ext cx="3169920" cy="316992"/>
           </a:xfrm>
           <a:prstGeom prst="rect">
@@ -8142,7 +8148,7 @@
         </p:nvSpPr>
         <p:spPr>
           <a:xfrm>
-            <a:off x="4940408" y="3198094"/>
+            <a:off x="4817309" y="3198094"/>
             <a:ext cx="2767584" cy="792480"/>
           </a:xfrm>
           <a:prstGeom prst="rect">
@@ -8370,7 +8376,7 @@
         </p:nvSpPr>
         <p:spPr>
           <a:xfrm>
-            <a:off x="3352800" y="4522399"/>
+            <a:off x="3457901" y="4522399"/>
             <a:ext cx="5486400" cy="1489456"/>
           </a:xfrm>
           <a:prstGeom prst="roundRect">
@@ -8410,7 +8416,7 @@
         </p:nvSpPr>
         <p:spPr>
           <a:xfrm>
-            <a:off x="3413760" y="4574896"/>
+            <a:off x="3518861" y="4574896"/>
             <a:ext cx="5364480" cy="315309"/>
           </a:xfrm>
           <a:prstGeom prst="rect">
@@ -8452,7 +8458,7 @@
         </p:nvSpPr>
         <p:spPr>
           <a:xfrm>
-            <a:off x="3450336" y="4886419"/>
+            <a:off x="3555437" y="4886419"/>
             <a:ext cx="5291328" cy="853440"/>
           </a:xfrm>
           <a:prstGeom prst="rect">
@@ -8554,7 +8560,7 @@
         </p:nvSpPr>
         <p:spPr>
           <a:xfrm>
-            <a:off x="6096000" y="4125109"/>
+            <a:off x="6201101" y="4125109"/>
             <a:ext cx="0" cy="315309"/>
           </a:xfrm>
           <a:prstGeom prst="line">
@@ -8597,7 +8603,7 @@
         </p:nvSpPr>
         <p:spPr>
           <a:xfrm>
-            <a:off x="5991749" y="6173273"/>
+            <a:off x="6201101" y="6173273"/>
             <a:ext cx="0" cy="476909"/>
           </a:xfrm>
           <a:prstGeom prst="line">
@@ -8608,7 +8614,7 @@
             <a:solidFill>
               <a:srgbClr val="FFC000"/>
             </a:solidFill>
-            <a:prstDash val="solid"/>
+            <a:prstDash val="sysDot"/>
             <a:tailEnd type="arrow"/>
           </a:ln>
         </p:spPr>
@@ -8704,6 +8710,82 @@
           <a:p>
             <a:pPr defTabSz="1219170"/>
             <a:endParaRPr lang="en-US" sz="2400">
+              <a:solidFill>
+                <a:prstClr val="black"/>
+              </a:solidFill>
+              <a:latin typeface="Calibri" panose="020F0502020204030204"/>
+            </a:endParaRPr>
+          </a:p>
+        </p:txBody>
+      </p:sp>
+      <p:sp>
+        <p:nvSpPr>
+          <p:cNvPr id="2" name="Text 10">
+            <a:extLst>
+              <a:ext uri="{FF2B5EF4-FFF2-40B4-BE49-F238E27FC236}">
+                <a16:creationId xmlns:a16="http://schemas.microsoft.com/office/drawing/2014/main" id="{035CAC2A-78AD-68B9-ED4D-6D53C2E1AA41}"/>
+              </a:ext>
+            </a:extLst>
+          </p:cNvPr>
+          <p:cNvSpPr/>
+          <p:nvPr/>
+        </p:nvSpPr>
+        <p:spPr>
+          <a:xfrm>
+            <a:off x="5692404" y="1278995"/>
+            <a:ext cx="1463459" cy="876298"/>
+          </a:xfrm>
+          <a:prstGeom prst="rect">
+            <a:avLst/>
+          </a:prstGeom>
+          <a:noFill/>
+          <a:ln/>
+        </p:spPr>
+        <p:txBody>
+          <a:bodyPr wrap="square" lIns="33867" tIns="33867" rIns="33867" bIns="33867" rtlCol="0" anchor="t"/>
+          <a:lstStyle/>
+          <a:p>
+            <a:pPr defTabSz="1219170"/>
+            <a:r>
+              <a:rPr lang="en-US" sz="1600" dirty="0">
+                <a:solidFill>
+                  <a:srgbClr val="CADCFC"/>
+                </a:solidFill>
+                <a:latin typeface="Calibri" pitchFamily="34" charset="0"/>
+                <a:ea typeface="Calibri" pitchFamily="34" charset="-122"/>
+                <a:cs typeface="Calibri" pitchFamily="34" charset="-120"/>
+              </a:rPr>
+              <a:t>pitch range</a:t>
+            </a:r>
+          </a:p>
+          <a:p>
+            <a:pPr defTabSz="1219170"/>
+            <a:r>
+              <a:rPr lang="en-US" sz="1600" dirty="0">
+                <a:solidFill>
+                  <a:srgbClr val="CADCFC"/>
+                </a:solidFill>
+                <a:latin typeface="Calibri" pitchFamily="34" charset="0"/>
+                <a:ea typeface="Calibri" pitchFamily="34" charset="-122"/>
+                <a:cs typeface="Calibri" pitchFamily="34" charset="-120"/>
+              </a:rPr>
+              <a:t>velocity min</a:t>
+            </a:r>
+          </a:p>
+          <a:p>
+            <a:pPr defTabSz="1219170"/>
+            <a:r>
+              <a:rPr lang="en-US" sz="1600" dirty="0">
+                <a:solidFill>
+                  <a:srgbClr val="CADCFC"/>
+                </a:solidFill>
+                <a:latin typeface="Calibri" pitchFamily="34" charset="0"/>
+                <a:ea typeface="Calibri" pitchFamily="34" charset="-122"/>
+                <a:cs typeface="Calibri" pitchFamily="34" charset="-120"/>
+              </a:rPr>
+              <a:t>note dur min</a:t>
+            </a:r>
+            <a:endParaRPr lang="en-US" sz="1600" dirty="0">
               <a:solidFill>
                 <a:prstClr val="black"/>
               </a:solidFill>
@@ -8753,8 +8835,8 @@
         </p:nvSpPr>
         <p:spPr>
           <a:xfrm>
-            <a:off x="8847152" y="509213"/>
-            <a:ext cx="2628677" cy="1394410"/>
+            <a:off x="7873673" y="376475"/>
+            <a:ext cx="2888140" cy="1394410"/>
           </a:xfrm>
           <a:prstGeom prst="rect">
             <a:avLst/>
@@ -8768,7 +8850,7 @@
           <a:p>
             <a:pPr defTabSz="1219170"/>
             <a:r>
-              <a:rPr lang="en-US" sz="4000" b="1" dirty="0">
+              <a:rPr lang="en-US" sz="4800" b="1" dirty="0">
                 <a:solidFill>
                   <a:srgbClr val="FFFFFF"/>
                 </a:solidFill>
@@ -8778,7 +8860,7 @@
               </a:rPr>
               <a:t>Generation</a:t>
             </a:r>
-            <a:endParaRPr lang="en-US" sz="4000" dirty="0">
+            <a:endParaRPr lang="en-US" sz="4800" dirty="0">
               <a:solidFill>
                 <a:prstClr val="black"/>
               </a:solidFill>
@@ -8795,7 +8877,7 @@
         </p:nvSpPr>
         <p:spPr>
           <a:xfrm>
-            <a:off x="3573266" y="766065"/>
+            <a:off x="3258571" y="681983"/>
             <a:ext cx="2767053" cy="536448"/>
           </a:xfrm>
           <a:prstGeom prst="roundRect">
@@ -8835,7 +8917,7 @@
         </p:nvSpPr>
         <p:spPr>
           <a:xfrm>
-            <a:off x="2762232" y="766065"/>
+            <a:off x="2447537" y="681983"/>
             <a:ext cx="4389120" cy="536448"/>
           </a:xfrm>
           <a:prstGeom prst="rect">
@@ -8877,7 +8959,7 @@
         </p:nvSpPr>
         <p:spPr>
           <a:xfrm>
-            <a:off x="2730957" y="1663639"/>
+            <a:off x="2431901" y="1663639"/>
             <a:ext cx="4420393" cy="717212"/>
           </a:xfrm>
           <a:prstGeom prst="roundRect">
@@ -8917,7 +8999,7 @@
         </p:nvSpPr>
         <p:spPr>
           <a:xfrm>
-            <a:off x="3188952" y="1746866"/>
+            <a:off x="2874257" y="1746866"/>
             <a:ext cx="3535680" cy="316992"/>
           </a:xfrm>
           <a:prstGeom prst="rect">
@@ -8959,7 +9041,7 @@
         </p:nvSpPr>
         <p:spPr>
           <a:xfrm>
-            <a:off x="2862951" y="2063329"/>
+            <a:off x="2548256" y="2063329"/>
             <a:ext cx="4187683" cy="268224"/>
           </a:xfrm>
           <a:prstGeom prst="rect">
@@ -8982,7 +9064,7 @@
                 <a:ea typeface="Calibri" pitchFamily="34" charset="-122"/>
                 <a:cs typeface="Calibri" pitchFamily="34" charset="-120"/>
               </a:rPr>
-              <a:t>mode, progression, pedal  ·  tritone substitution</a:t>
+              <a:t>mode, progression, pedal, tritone substitution</a:t>
             </a:r>
             <a:endParaRPr lang="en-US" sz="1600" dirty="0">
               <a:solidFill>
@@ -9001,8 +9083,8 @@
         </p:nvSpPr>
         <p:spPr>
           <a:xfrm>
-            <a:off x="1177272" y="2808994"/>
-            <a:ext cx="7559040" cy="2022280"/>
+            <a:off x="1177808" y="2808994"/>
+            <a:ext cx="6928578" cy="1873544"/>
           </a:xfrm>
           <a:prstGeom prst="roundRect">
             <a:avLst>
@@ -9041,8 +9123,8 @@
         </p:nvSpPr>
         <p:spPr>
           <a:xfrm>
-            <a:off x="1238232" y="2877369"/>
-            <a:ext cx="7437120" cy="316992"/>
+            <a:off x="1233684" y="2877369"/>
+            <a:ext cx="6816827" cy="316992"/>
           </a:xfrm>
           <a:prstGeom prst="rect">
             <a:avLst/>
@@ -9083,8 +9165,8 @@
         </p:nvSpPr>
         <p:spPr>
           <a:xfrm>
-            <a:off x="2073118" y="3243129"/>
-            <a:ext cx="6565657" cy="1072896"/>
+            <a:off x="1442987" y="3243128"/>
+            <a:ext cx="6398220" cy="1279645"/>
           </a:xfrm>
           <a:prstGeom prst="rect">
             <a:avLst/>
@@ -9106,7 +9188,7 @@
                 <a:ea typeface="Calibri" pitchFamily="34" charset="-122"/>
                 <a:cs typeface="Calibri" pitchFamily="34" charset="-120"/>
               </a:rPr>
-              <a:t>LSTM + chord conditioning  ·  pitch range limits + register gravity</a:t>
+              <a:t>LSTM + chord conditioning  ·  pitch range limits · register gravity</a:t>
             </a:r>
             <a:endParaRPr lang="en-US" sz="1600" dirty="0">
               <a:solidFill>
@@ -9126,7 +9208,7 @@
                 <a:ea typeface="Calibri" pitchFamily="34" charset="-122"/>
                 <a:cs typeface="Calibri" pitchFamily="34" charset="-120"/>
               </a:rPr>
-              <a:t>register contrast  ·  scale pitch bias  ·  contour steering</a:t>
+              <a:t>register contrast  ·  scale pitch bias  ·  contour steering · swing/triplet bias </a:t>
             </a:r>
             <a:endParaRPr lang="en-US" sz="1600" dirty="0">
               <a:solidFill>
@@ -9146,18 +9228,9 @@
                 <a:ea typeface="Calibri" pitchFamily="34" charset="-122"/>
                 <a:cs typeface="Calibri" pitchFamily="34" charset="-120"/>
               </a:rPr>
-              <a:t>swing/triplet bias  ·  energy arc shaping</a:t>
-            </a:r>
-            <a:endParaRPr lang="en-US" sz="1600" dirty="0">
-              <a:solidFill>
-                <a:prstClr val="black"/>
-              </a:solidFill>
-              <a:latin typeface="Calibri" panose="020F0502020204030204"/>
-            </a:endParaRPr>
-          </a:p>
-          <a:p>
-            <a:pPr defTabSz="1219170"/>
-            <a:r>
+              <a:t>energy arc shaping swing/triplet bias · long-note penalty</a:t>
+            </a:r>
+            <a:br>
               <a:rPr lang="en-US" sz="1600" dirty="0">
                 <a:solidFill>
                   <a:srgbClr val="CADCFC"/>
@@ -9166,17 +9239,7 @@
                 <a:ea typeface="Calibri" pitchFamily="34" charset="-122"/>
                 <a:cs typeface="Calibri" pitchFamily="34" charset="-120"/>
               </a:rPr>
-              <a:t>long-note penalty + singable duration bias  ·  motivic development</a:t>
-            </a:r>
-            <a:endParaRPr lang="en-US" sz="1600" dirty="0">
-              <a:solidFill>
-                <a:prstClr val="black"/>
-              </a:solidFill>
-              <a:latin typeface="Calibri" panose="020F0502020204030204"/>
-            </a:endParaRPr>
-          </a:p>
-          <a:p>
-            <a:pPr defTabSz="1219170"/>
+            </a:br>
             <a:r>
               <a:rPr lang="en-US" sz="1600" dirty="0">
                 <a:solidFill>
@@ -9186,7 +9249,7 @@
                 <a:ea typeface="Calibri" pitchFamily="34" charset="-122"/>
                 <a:cs typeface="Calibri" pitchFamily="34" charset="-120"/>
               </a:rPr>
-              <a:t>voice leading  ·  modal leap bonus (P4/P5)  ·  repetition penalty</a:t>
+              <a:t>singable duration bias  ·  motivic development · voice leading  ·  modal leap bonus (P4/P5)  ·  repetition penalty · rest injection  ·  beat accumulator</a:t>
             </a:r>
             <a:endParaRPr lang="en-US" sz="1600" dirty="0">
               <a:solidFill>
@@ -9195,26 +9258,6 @@
               <a:latin typeface="Calibri" panose="020F0502020204030204"/>
             </a:endParaRPr>
           </a:p>
-          <a:p>
-            <a:pPr defTabSz="1219170"/>
-            <a:r>
-              <a:rPr lang="en-US" sz="1600" dirty="0">
-                <a:solidFill>
-                  <a:srgbClr val="CADCFC"/>
-                </a:solidFill>
-                <a:latin typeface="Calibri" pitchFamily="34" charset="0"/>
-                <a:ea typeface="Calibri" pitchFamily="34" charset="-122"/>
-                <a:cs typeface="Calibri" pitchFamily="34" charset="-120"/>
-              </a:rPr>
-              <a:t>rest injection  ·  beat accumulator</a:t>
-            </a:r>
-            <a:endParaRPr lang="en-US" sz="1600" dirty="0">
-              <a:solidFill>
-                <a:prstClr val="black"/>
-              </a:solidFill>
-              <a:latin typeface="Calibri" panose="020F0502020204030204"/>
-            </a:endParaRPr>
-          </a:p>
         </p:txBody>
       </p:sp>
       <p:sp>
@@ -9225,7 +9268,7 @@
         </p:nvSpPr>
         <p:spPr>
           <a:xfrm>
-            <a:off x="644533" y="5334860"/>
+            <a:off x="644533" y="5208737"/>
             <a:ext cx="2129360" cy="1114235"/>
           </a:xfrm>
           <a:prstGeom prst="roundRect">
@@ -9265,7 +9308,7 @@
         </p:nvSpPr>
         <p:spPr>
           <a:xfrm>
-            <a:off x="438329" y="5429433"/>
+            <a:off x="438329" y="5303310"/>
             <a:ext cx="2560320" cy="316992"/>
           </a:xfrm>
           <a:prstGeom prst="rect">
@@ -9307,7 +9350,7 @@
         </p:nvSpPr>
         <p:spPr>
           <a:xfrm>
-            <a:off x="832714" y="5795193"/>
+            <a:off x="832714" y="5669070"/>
             <a:ext cx="2129359" cy="560832"/>
           </a:xfrm>
           <a:prstGeom prst="rect">
@@ -9369,7 +9412,7 @@
         </p:nvSpPr>
         <p:spPr>
           <a:xfrm>
-            <a:off x="3310872" y="5324259"/>
+            <a:off x="3310872" y="5198136"/>
             <a:ext cx="3291840" cy="1193225"/>
           </a:xfrm>
           <a:prstGeom prst="roundRect">
@@ -9409,7 +9452,7 @@
         </p:nvSpPr>
         <p:spPr>
           <a:xfrm>
-            <a:off x="3371832" y="5583689"/>
+            <a:off x="3371832" y="5457566"/>
             <a:ext cx="3169920" cy="316992"/>
           </a:xfrm>
           <a:prstGeom prst="rect">
@@ -9432,7 +9475,29 @@
                 <a:ea typeface="Calibri" pitchFamily="34" charset="-122"/>
                 <a:cs typeface="Calibri" pitchFamily="34" charset="-120"/>
               </a:rPr>
-              <a:t>WebAudienceDisplay / OscOutput</a:t>
+              <a:t>WebAudienceDisplay / </a:t>
+            </a:r>
+            <a:r>
+              <a:rPr lang="en-US" sz="2400" b="1" dirty="0" err="1">
+                <a:solidFill>
+                  <a:srgbClr val="FFFFFF"/>
+                </a:solidFill>
+                <a:latin typeface="Calibri" pitchFamily="34" charset="0"/>
+                <a:ea typeface="Calibri" pitchFamily="34" charset="-122"/>
+                <a:cs typeface="Calibri" pitchFamily="34" charset="-120"/>
+              </a:rPr>
+              <a:t>OscOutput</a:t>
+            </a:r>
+            <a:r>
+              <a:rPr lang="en-US" sz="2400" b="1" dirty="0">
+                <a:solidFill>
+                  <a:srgbClr val="FFFFFF"/>
+                </a:solidFill>
+                <a:latin typeface="Calibri" pitchFamily="34" charset="0"/>
+                <a:ea typeface="Calibri" pitchFamily="34" charset="-122"/>
+                <a:cs typeface="Calibri" pitchFamily="34" charset="-120"/>
+              </a:rPr>
+              <a:t> / Dashboard</a:t>
             </a:r>
             <a:endParaRPr lang="en-US" sz="2400" dirty="0">
               <a:solidFill>
@@ -9451,7 +9516,7 @@
         </p:nvSpPr>
         <p:spPr>
           <a:xfrm>
-            <a:off x="3495872" y="6110908"/>
+            <a:off x="3495872" y="5984785"/>
             <a:ext cx="2921840" cy="426720"/>
           </a:xfrm>
           <a:prstGeom prst="rect">
@@ -9493,7 +9558,7 @@
         </p:nvSpPr>
         <p:spPr>
           <a:xfrm>
-            <a:off x="9334831" y="2808994"/>
+            <a:off x="8704213" y="2808994"/>
             <a:ext cx="2316480" cy="1288382"/>
           </a:xfrm>
           <a:prstGeom prst="roundRect">
@@ -9533,7 +9598,7 @@
         </p:nvSpPr>
         <p:spPr>
           <a:xfrm>
-            <a:off x="9391815" y="2999161"/>
+            <a:off x="8761197" y="2999161"/>
             <a:ext cx="2194560" cy="469393"/>
           </a:xfrm>
           <a:prstGeom prst="rect">
@@ -9575,7 +9640,7 @@
         </p:nvSpPr>
         <p:spPr>
           <a:xfrm>
-            <a:off x="9432367" y="3545031"/>
+            <a:off x="8801749" y="3545031"/>
             <a:ext cx="2121408" cy="627889"/>
           </a:xfrm>
           <a:prstGeom prst="rect">
@@ -9637,7 +9702,7 @@
         </p:nvSpPr>
         <p:spPr>
           <a:xfrm>
-            <a:off x="9334831" y="4587966"/>
+            <a:off x="8704213" y="4587966"/>
             <a:ext cx="2316480" cy="998153"/>
           </a:xfrm>
           <a:prstGeom prst="roundRect">
@@ -9677,7 +9742,7 @@
         </p:nvSpPr>
         <p:spPr>
           <a:xfrm>
-            <a:off x="9395791" y="4682538"/>
+            <a:off x="8765173" y="4682538"/>
             <a:ext cx="2194560" cy="316992"/>
           </a:xfrm>
           <a:prstGeom prst="rect">
@@ -9719,8 +9784,8 @@
         </p:nvSpPr>
         <p:spPr>
           <a:xfrm>
-            <a:off x="9432367" y="5006733"/>
-            <a:ext cx="2121408" cy="195072"/>
+            <a:off x="9036339" y="5006733"/>
+            <a:ext cx="1886818" cy="579386"/>
           </a:xfrm>
           <a:prstGeom prst="rect">
             <a:avLst/>
@@ -9742,7 +9807,28 @@
                 <a:ea typeface="Calibri" pitchFamily="34" charset="-122"/>
                 <a:cs typeface="Calibri" pitchFamily="34" charset="-120"/>
               </a:rPr>
-              <a:t>energy arc × peak × end taper</a:t>
+              <a:t>energy arc · peak</a:t>
+            </a:r>
+            <a:br>
+              <a:rPr lang="en-US" sz="1600" dirty="0">
+                <a:solidFill>
+                  <a:srgbClr val="CADCFC"/>
+                </a:solidFill>
+                <a:latin typeface="Calibri" pitchFamily="34" charset="0"/>
+                <a:ea typeface="Calibri" pitchFamily="34" charset="-122"/>
+                <a:cs typeface="Calibri" pitchFamily="34" charset="-120"/>
+              </a:rPr>
+            </a:br>
+            <a:r>
+              <a:rPr lang="en-US" sz="1600" dirty="0">
+                <a:solidFill>
+                  <a:srgbClr val="CADCFC"/>
+                </a:solidFill>
+                <a:latin typeface="Calibri" pitchFamily="34" charset="0"/>
+                <a:ea typeface="Calibri" pitchFamily="34" charset="-122"/>
+                <a:cs typeface="Calibri" pitchFamily="34" charset="-120"/>
+              </a:rPr>
+              <a:t>end taper</a:t>
             </a:r>
             <a:endParaRPr lang="en-US" sz="1600" dirty="0">
               <a:solidFill>
@@ -9761,8 +9847,8 @@
         </p:nvSpPr>
         <p:spPr>
           <a:xfrm>
-            <a:off x="9330061" y="6010182"/>
-            <a:ext cx="2316479" cy="438912"/>
+            <a:off x="9980858" y="6042613"/>
+            <a:ext cx="1488263" cy="438912"/>
           </a:xfrm>
           <a:prstGeom prst="roundRect">
             <a:avLst>
@@ -9801,8 +9887,8 @@
         </p:nvSpPr>
         <p:spPr>
           <a:xfrm>
-            <a:off x="9330061" y="6010182"/>
-            <a:ext cx="2435219" cy="438912"/>
+            <a:off x="9842520" y="6042613"/>
+            <a:ext cx="1745341" cy="438912"/>
           </a:xfrm>
           <a:prstGeom prst="rect">
             <a:avLst/>
@@ -9824,7 +9910,7 @@
                 <a:ea typeface="Calibri" pitchFamily="34" charset="-122"/>
                 <a:cs typeface="Calibri" pitchFamily="34" charset="-120"/>
               </a:rPr>
-              <a:t>Synth (sax voice)</a:t>
+              <a:t>chord hint</a:t>
             </a:r>
             <a:endParaRPr lang="en-US" sz="2400" dirty="0">
               <a:solidFill>
@@ -9843,7 +9929,7 @@
         </p:nvSpPr>
         <p:spPr>
           <a:xfrm>
-            <a:off x="4956792" y="5075114"/>
+            <a:off x="4956792" y="4948991"/>
             <a:ext cx="0" cy="60960"/>
           </a:xfrm>
           <a:prstGeom prst="line">
@@ -9879,7 +9965,7 @@
         </p:nvSpPr>
         <p:spPr>
           <a:xfrm>
-            <a:off x="1808074" y="4931993"/>
+            <a:off x="1808074" y="4805870"/>
             <a:ext cx="1" cy="335547"/>
           </a:xfrm>
           <a:prstGeom prst="line">
@@ -9916,7 +10002,7 @@
         </p:nvSpPr>
         <p:spPr>
           <a:xfrm>
-            <a:off x="4956792" y="4931994"/>
+            <a:off x="4956792" y="4805871"/>
             <a:ext cx="0" cy="305332"/>
           </a:xfrm>
           <a:prstGeom prst="line">
@@ -9959,7 +10045,7 @@
         </p:nvSpPr>
         <p:spPr>
           <a:xfrm flipH="1">
-            <a:off x="10388467" y="4199409"/>
+            <a:off x="9757849" y="4199409"/>
             <a:ext cx="7600" cy="323365"/>
           </a:xfrm>
           <a:prstGeom prst="line">
@@ -10002,7 +10088,7 @@
         </p:nvSpPr>
         <p:spPr>
           <a:xfrm>
-            <a:off x="10388468" y="5660328"/>
+            <a:off x="10724802" y="5643947"/>
             <a:ext cx="0" cy="340838"/>
           </a:xfrm>
           <a:prstGeom prst="line">
@@ -10045,7 +10131,7 @@
         </p:nvSpPr>
         <p:spPr>
           <a:xfrm>
-            <a:off x="4956792" y="1302513"/>
+            <a:off x="4642097" y="1302513"/>
             <a:ext cx="0" cy="310630"/>
           </a:xfrm>
           <a:prstGeom prst="line">
@@ -10088,7 +10174,7 @@
         </p:nvSpPr>
         <p:spPr>
           <a:xfrm>
-            <a:off x="4956792" y="2450126"/>
+            <a:off x="4642097" y="2468343"/>
             <a:ext cx="0" cy="298611"/>
           </a:xfrm>
           <a:prstGeom prst="line">
@@ -10119,10 +10205,10 @@
       </p:sp>
       <p:sp>
         <p:nvSpPr>
-          <p:cNvPr id="41" name="Shape 28">
+          <p:cNvPr id="2" name="Shape 13">
             <a:extLst>
               <a:ext uri="{FF2B5EF4-FFF2-40B4-BE49-F238E27FC236}">
-                <a16:creationId xmlns:a16="http://schemas.microsoft.com/office/drawing/2014/main" id="{4AF251FC-3F52-BB0D-6527-22ED0889C44F}"/>
+                <a16:creationId xmlns:a16="http://schemas.microsoft.com/office/drawing/2014/main" id="{C7B5150A-7B3C-0DF6-D272-7A58E5994619}"/>
               </a:ext>
             </a:extLst>
           </p:cNvPr>
@@ -10131,51 +10217,8 @@
         </p:nvSpPr>
         <p:spPr>
           <a:xfrm>
-            <a:off x="4956792" y="201354"/>
-            <a:ext cx="0" cy="504184"/>
-          </a:xfrm>
-          <a:prstGeom prst="line">
-            <a:avLst/>
-          </a:prstGeom>
-          <a:noFill/>
-          <a:ln w="50800">
-            <a:solidFill>
-              <a:srgbClr val="FFC000"/>
-            </a:solidFill>
-            <a:prstDash val="solid"/>
-            <a:tailEnd type="arrow"/>
-          </a:ln>
-        </p:spPr>
-        <p:txBody>
-          <a:bodyPr/>
-          <a:lstStyle/>
-          <a:p>
-            <a:pPr defTabSz="1219170"/>
-            <a:endParaRPr lang="en-US" sz="2400" dirty="0">
-              <a:solidFill>
-                <a:prstClr val="black"/>
-              </a:solidFill>
-              <a:latin typeface="Calibri" panose="020F0502020204030204"/>
-            </a:endParaRPr>
-          </a:p>
-        </p:txBody>
-      </p:sp>
-      <p:sp>
-        <p:nvSpPr>
-          <p:cNvPr id="2" name="Shape 13">
-            <a:extLst>
-              <a:ext uri="{FF2B5EF4-FFF2-40B4-BE49-F238E27FC236}">
-                <a16:creationId xmlns:a16="http://schemas.microsoft.com/office/drawing/2014/main" id="{C7B5150A-7B3C-0DF6-D272-7A58E5994619}"/>
-              </a:ext>
-            </a:extLst>
-          </p:cNvPr>
-          <p:cNvSpPr/>
-          <p:nvPr/>
-        </p:nvSpPr>
-        <p:spPr>
-          <a:xfrm>
-            <a:off x="8847152" y="3468554"/>
-            <a:ext cx="377951" cy="0"/>
+            <a:off x="8241261" y="3468554"/>
+            <a:ext cx="346428" cy="0"/>
           </a:xfrm>
           <a:prstGeom prst="line">
             <a:avLst/>
@@ -10195,6 +10238,186 @@
           <a:p>
             <a:pPr defTabSz="1219170"/>
             <a:endParaRPr lang="en-US" sz="2400">
+              <a:solidFill>
+                <a:prstClr val="black"/>
+              </a:solidFill>
+              <a:latin typeface="Calibri" panose="020F0502020204030204"/>
+            </a:endParaRPr>
+          </a:p>
+        </p:txBody>
+      </p:sp>
+      <p:sp>
+        <p:nvSpPr>
+          <p:cNvPr id="9" name="Shape 25">
+            <a:extLst>
+              <a:ext uri="{FF2B5EF4-FFF2-40B4-BE49-F238E27FC236}">
+                <a16:creationId xmlns:a16="http://schemas.microsoft.com/office/drawing/2014/main" id="{4583DD6A-C613-B405-EAE6-8416DC69717E}"/>
+              </a:ext>
+            </a:extLst>
+          </p:cNvPr>
+          <p:cNvSpPr/>
+          <p:nvPr/>
+        </p:nvSpPr>
+        <p:spPr>
+          <a:xfrm>
+            <a:off x="8308575" y="6042613"/>
+            <a:ext cx="1488263" cy="438912"/>
+          </a:xfrm>
+          <a:prstGeom prst="roundRect">
+            <a:avLst>
+              <a:gd name="adj" fmla="val 22222"/>
+            </a:avLst>
+          </a:prstGeom>
+          <a:solidFill>
+            <a:srgbClr val="2A3570"/>
+          </a:solidFill>
+          <a:ln w="19050">
+            <a:solidFill>
+              <a:srgbClr val="CADCFC"/>
+            </a:solidFill>
+            <a:prstDash val="solid"/>
+          </a:ln>
+        </p:spPr>
+        <p:txBody>
+          <a:bodyPr/>
+          <a:lstStyle/>
+          <a:p>
+            <a:pPr defTabSz="1219170"/>
+            <a:endParaRPr lang="en-US" sz="3200">
+              <a:solidFill>
+                <a:prstClr val="black"/>
+              </a:solidFill>
+              <a:latin typeface="Calibri" panose="020F0502020204030204"/>
+            </a:endParaRPr>
+          </a:p>
+        </p:txBody>
+      </p:sp>
+      <p:sp>
+        <p:nvSpPr>
+          <p:cNvPr id="13" name="Text 26">
+            <a:extLst>
+              <a:ext uri="{FF2B5EF4-FFF2-40B4-BE49-F238E27FC236}">
+                <a16:creationId xmlns:a16="http://schemas.microsoft.com/office/drawing/2014/main" id="{08D64C15-18D0-D71F-2D4C-F78FC3266243}"/>
+              </a:ext>
+            </a:extLst>
+          </p:cNvPr>
+          <p:cNvSpPr/>
+          <p:nvPr/>
+        </p:nvSpPr>
+        <p:spPr>
+          <a:xfrm>
+            <a:off x="8360281" y="6042613"/>
+            <a:ext cx="1374805" cy="438912"/>
+          </a:xfrm>
+          <a:prstGeom prst="rect">
+            <a:avLst/>
+          </a:prstGeom>
+          <a:noFill/>
+          <a:ln/>
+        </p:spPr>
+        <p:txBody>
+          <a:bodyPr wrap="square" lIns="67733" tIns="67733" rIns="67733" bIns="67733" rtlCol="0" anchor="ctr"/>
+          <a:lstStyle/>
+          <a:p>
+            <a:pPr algn="ctr" defTabSz="1219170"/>
+            <a:r>
+              <a:rPr lang="en-US" sz="2400" b="1" dirty="0">
+                <a:solidFill>
+                  <a:srgbClr val="FFFFFF"/>
+                </a:solidFill>
+                <a:latin typeface="Calibri" pitchFamily="34" charset="0"/>
+                <a:ea typeface="Calibri" pitchFamily="34" charset="-122"/>
+                <a:cs typeface="Calibri" pitchFamily="34" charset="-120"/>
+              </a:rPr>
+              <a:t>sax voice</a:t>
+            </a:r>
+            <a:endParaRPr lang="en-US" sz="2400" dirty="0">
+              <a:solidFill>
+                <a:prstClr val="black"/>
+              </a:solidFill>
+              <a:latin typeface="Calibri" panose="020F0502020204030204"/>
+            </a:endParaRPr>
+          </a:p>
+        </p:txBody>
+      </p:sp>
+      <p:sp>
+        <p:nvSpPr>
+          <p:cNvPr id="26" name="Shape 31">
+            <a:extLst>
+              <a:ext uri="{FF2B5EF4-FFF2-40B4-BE49-F238E27FC236}">
+                <a16:creationId xmlns:a16="http://schemas.microsoft.com/office/drawing/2014/main" id="{0D855650-D917-4301-429C-1296A2A02AF1}"/>
+              </a:ext>
+            </a:extLst>
+          </p:cNvPr>
+          <p:cNvSpPr/>
+          <p:nvPr/>
+        </p:nvSpPr>
+        <p:spPr>
+          <a:xfrm>
+            <a:off x="9036339" y="5643947"/>
+            <a:ext cx="0" cy="340838"/>
+          </a:xfrm>
+          <a:prstGeom prst="line">
+            <a:avLst/>
+          </a:prstGeom>
+          <a:noFill/>
+          <a:ln w="50800">
+            <a:solidFill>
+              <a:srgbClr val="CADCFC"/>
+            </a:solidFill>
+            <a:prstDash val="solid"/>
+            <a:tailEnd type="arrow"/>
+          </a:ln>
+        </p:spPr>
+        <p:txBody>
+          <a:bodyPr/>
+          <a:lstStyle/>
+          <a:p>
+            <a:pPr defTabSz="1219170"/>
+            <a:endParaRPr lang="en-US" sz="3200">
+              <a:solidFill>
+                <a:prstClr val="black"/>
+              </a:solidFill>
+              <a:latin typeface="Calibri" panose="020F0502020204030204"/>
+            </a:endParaRPr>
+          </a:p>
+        </p:txBody>
+      </p:sp>
+      <p:sp>
+        <p:nvSpPr>
+          <p:cNvPr id="29" name="Shape 28">
+            <a:extLst>
+              <a:ext uri="{FF2B5EF4-FFF2-40B4-BE49-F238E27FC236}">
+                <a16:creationId xmlns:a16="http://schemas.microsoft.com/office/drawing/2014/main" id="{86B0AC4B-78C1-CBB0-9E89-0366A38A8E1A}"/>
+              </a:ext>
+            </a:extLst>
+          </p:cNvPr>
+          <p:cNvSpPr/>
+          <p:nvPr/>
+        </p:nvSpPr>
+        <p:spPr>
+          <a:xfrm>
+            <a:off x="4642097" y="92503"/>
+            <a:ext cx="0" cy="476909"/>
+          </a:xfrm>
+          <a:prstGeom prst="line">
+            <a:avLst/>
+          </a:prstGeom>
+          <a:noFill/>
+          <a:ln w="50800">
+            <a:solidFill>
+              <a:srgbClr val="FFC000"/>
+            </a:solidFill>
+            <a:prstDash val="sysDot"/>
+            <a:tailEnd type="arrow"/>
+          </a:ln>
+        </p:spPr>
+        <p:txBody>
+          <a:bodyPr/>
+          <a:lstStyle/>
+          <a:p>
+            <a:pPr defTabSz="1219170"/>
+            <a:endParaRPr lang="en-US" sz="2400" dirty="0">
               <a:solidFill>
                 <a:prstClr val="black"/>
               </a:solidFill>
@@ -10264,7 +10487,7 @@
               <a:rPr lang="en-US" dirty="0">
                 <a:latin typeface="Optima" panose="02000503060000020004" pitchFamily="2" charset="0"/>
               </a:rPr>
-              <a:t>Soul eyes</a:t>
+              <a:t>Soul A-eyes</a:t>
             </a:r>
           </a:p>
         </p:txBody>

</xml_diff>

<commit_message>
docs: update wolfson.pptx and wolfson.pdf
Co-Authored-By: Claude Sonnet 4.6 <noreply@anthropic.com>
</commit_message>
<xml_diff>
--- a/docs/wolfson.pptx
+++ b/docs/wolfson.pptx
@@ -5802,19 +5802,7 @@
               <a:rPr lang="en-GB" sz="2400" dirty="0">
                 <a:latin typeface="Palatino Linotype" panose="02040502050505030304" pitchFamily="18" charset="0"/>
               </a:rPr>
-              <a:t>The audience might feel it would be ‘more musical’ if it used </a:t>
-            </a:r>
-            <a:r>
-              <a:rPr lang="en-GB" sz="2400">
-                <a:latin typeface="Palatino Linotype" panose="02040502050505030304" pitchFamily="18" charset="0"/>
-              </a:rPr>
-              <a:t>an underlying </a:t>
-            </a:r>
-            <a:r>
-              <a:rPr lang="en-GB" sz="2400" dirty="0">
-                <a:latin typeface="Palatino Linotype" panose="02040502050505030304" pitchFamily="18" charset="0"/>
-              </a:rPr>
-              <a:t>chord progression – but the whole point is that it doesn’t, it’s responsive. There are plenty of play-along programs out there.</a:t>
+              <a:t>The audience might feel it would be ‘more musical’ if it used an underlying chord progression – but the whole point is that it doesn’t, it’s responsive. There are plenty of play-along programs out there.</a:t>
             </a:r>
           </a:p>
           <a:p>
@@ -6596,7 +6584,7 @@
               <a:rPr lang="en-GB" sz="2400" dirty="0">
                 <a:latin typeface="Palatino Linotype" panose="02040502050505030304" pitchFamily="18" charset="0"/>
               </a:rPr>
-              <a:t>Proactive mode </a:t>
+              <a:t>Sax repetition</a:t>
             </a:r>
           </a:p>
           <a:p>
@@ -6609,18 +6597,7 @@
               <a:rPr lang="en-GB" sz="2400" dirty="0">
                 <a:latin typeface="Palatino Linotype" panose="02040502050505030304" pitchFamily="18" charset="0"/>
               </a:rPr>
-              <a:t>Loop mode</a:t>
-            </a:r>
-            <a:br>
-              <a:rPr lang="en-GB" sz="2400" dirty="0">
-                <a:latin typeface="Palatino Linotype" panose="02040502050505030304" pitchFamily="18" charset="0"/>
-              </a:rPr>
-            </a:br>
-            <a:r>
-              <a:rPr lang="en-GB" sz="2400" dirty="0">
-                <a:latin typeface="Palatino Linotype" panose="02040502050505030304" pitchFamily="18" charset="0"/>
-              </a:rPr>
-              <a:t>Arc timing</a:t>
+              <a:t>Proactive mode </a:t>
             </a:r>
           </a:p>
           <a:p>
@@ -6633,11 +6610,19 @@
               <a:rPr lang="en-GB" sz="2400" dirty="0">
                 <a:latin typeface="Palatino Linotype" panose="02040502050505030304" pitchFamily="18" charset="0"/>
               </a:rPr>
-              <a:t>Phrase-shape dynamics</a:t>
-            </a:r>
-            <a:endParaRPr lang="en-US" sz="2800" dirty="0">
-              <a:latin typeface="Palatino Linotype" panose="02040502050505030304" pitchFamily="18" charset="0"/>
-            </a:endParaRPr>
+              <a:t>Loop mode</a:t>
+            </a:r>
+            <a:br>
+              <a:rPr lang="en-GB" sz="2400" dirty="0">
+                <a:latin typeface="Palatino Linotype" panose="02040502050505030304" pitchFamily="18" charset="0"/>
+              </a:rPr>
+            </a:br>
+            <a:r>
+              <a:rPr lang="en-GB" sz="2400" dirty="0">
+                <a:latin typeface="Palatino Linotype" panose="02040502050505030304" pitchFamily="18" charset="0"/>
+              </a:rPr>
+              <a:t>Arc timing</a:t>
+            </a:r>
           </a:p>
         </p:txBody>
       </p:sp>
@@ -7394,7 +7379,7 @@
         </p:nvSpPr>
         <p:spPr>
           <a:xfrm>
-            <a:off x="417978" y="3159474"/>
+            <a:off x="9751962" y="3451490"/>
             <a:ext cx="2264263" cy="1662546"/>
           </a:xfrm>
           <a:prstGeom prst="rect">
@@ -8339,8 +8324,8 @@
         </p:nvSpPr>
         <p:spPr>
           <a:xfrm>
-            <a:off x="3566160" y="3432201"/>
-            <a:ext cx="883920" cy="0"/>
+            <a:off x="3555436" y="3432201"/>
+            <a:ext cx="894643" cy="0"/>
           </a:xfrm>
           <a:prstGeom prst="line">
             <a:avLst/>
@@ -8786,6 +8771,191 @@
               <a:t>note dur min</a:t>
             </a:r>
             <a:endParaRPr lang="en-US" sz="1600" dirty="0">
+              <a:solidFill>
+                <a:prstClr val="black"/>
+              </a:solidFill>
+              <a:latin typeface="Calibri" panose="020F0502020204030204"/>
+            </a:endParaRPr>
+          </a:p>
+        </p:txBody>
+      </p:sp>
+      <p:sp>
+        <p:nvSpPr>
+          <p:cNvPr id="13" name="Shape 14">
+            <a:extLst>
+              <a:ext uri="{FF2B5EF4-FFF2-40B4-BE49-F238E27FC236}">
+                <a16:creationId xmlns:a16="http://schemas.microsoft.com/office/drawing/2014/main" id="{7D6019D4-9F06-D4F8-9055-5C0B69571156}"/>
+              </a:ext>
+            </a:extLst>
+          </p:cNvPr>
+          <p:cNvSpPr/>
+          <p:nvPr/>
+        </p:nvSpPr>
+        <p:spPr>
+          <a:xfrm>
+            <a:off x="358153" y="4886419"/>
+            <a:ext cx="2292087" cy="781702"/>
+          </a:xfrm>
+          <a:prstGeom prst="roundRect">
+            <a:avLst>
+              <a:gd name="adj" fmla="val 16667"/>
+            </a:avLst>
+          </a:prstGeom>
+          <a:solidFill>
+            <a:srgbClr val="2A3570"/>
+          </a:solidFill>
+          <a:ln w="19050">
+            <a:solidFill>
+              <a:srgbClr val="CADCFC"/>
+            </a:solidFill>
+            <a:prstDash val="solid"/>
+          </a:ln>
+        </p:spPr>
+        <p:txBody>
+          <a:bodyPr/>
+          <a:lstStyle/>
+          <a:p>
+            <a:pPr defTabSz="1219170"/>
+            <a:endParaRPr lang="en-US" sz="2400">
+              <a:solidFill>
+                <a:prstClr val="black"/>
+              </a:solidFill>
+              <a:latin typeface="Calibri" panose="020F0502020204030204"/>
+            </a:endParaRPr>
+          </a:p>
+        </p:txBody>
+      </p:sp>
+      <p:sp>
+        <p:nvSpPr>
+          <p:cNvPr id="14" name="Text 15">
+            <a:extLst>
+              <a:ext uri="{FF2B5EF4-FFF2-40B4-BE49-F238E27FC236}">
+                <a16:creationId xmlns:a16="http://schemas.microsoft.com/office/drawing/2014/main" id="{F402484E-1CC6-34A6-5E23-247659ED013C}"/>
+              </a:ext>
+            </a:extLst>
+          </p:cNvPr>
+          <p:cNvSpPr/>
+          <p:nvPr/>
+        </p:nvSpPr>
+        <p:spPr>
+          <a:xfrm>
+            <a:off x="358151" y="4967954"/>
+            <a:ext cx="2292087" cy="353568"/>
+          </a:xfrm>
+          <a:prstGeom prst="rect">
+            <a:avLst/>
+          </a:prstGeom>
+          <a:noFill/>
+          <a:ln/>
+        </p:spPr>
+        <p:txBody>
+          <a:bodyPr wrap="square" lIns="0" tIns="0" rIns="0" bIns="0" rtlCol="0" anchor="ctr"/>
+          <a:lstStyle/>
+          <a:p>
+            <a:pPr algn="ctr" defTabSz="1219170"/>
+            <a:r>
+              <a:rPr lang="en-US" sz="2400" b="1" dirty="0">
+                <a:solidFill>
+                  <a:srgbClr val="FFFFFF"/>
+                </a:solidFill>
+                <a:latin typeface="Calibri" pitchFamily="34" charset="0"/>
+                <a:ea typeface="Calibri" pitchFamily="34" charset="-122"/>
+                <a:cs typeface="Calibri" pitchFamily="34" charset="-120"/>
+              </a:rPr>
+              <a:t>Proactive Loop</a:t>
+            </a:r>
+            <a:endParaRPr lang="en-US" sz="2400" dirty="0">
+              <a:solidFill>
+                <a:prstClr val="black"/>
+              </a:solidFill>
+              <a:latin typeface="Calibri" panose="020F0502020204030204"/>
+            </a:endParaRPr>
+          </a:p>
+        </p:txBody>
+      </p:sp>
+      <p:sp>
+        <p:nvSpPr>
+          <p:cNvPr id="31" name="Text 16">
+            <a:extLst>
+              <a:ext uri="{FF2B5EF4-FFF2-40B4-BE49-F238E27FC236}">
+                <a16:creationId xmlns:a16="http://schemas.microsoft.com/office/drawing/2014/main" id="{8093E773-011C-6678-EF78-708CE8296041}"/>
+              </a:ext>
+            </a:extLst>
+          </p:cNvPr>
+          <p:cNvSpPr/>
+          <p:nvPr/>
+        </p:nvSpPr>
+        <p:spPr>
+          <a:xfrm>
+            <a:off x="525517" y="5295648"/>
+            <a:ext cx="2124721" cy="293138"/>
+          </a:xfrm>
+          <a:prstGeom prst="rect">
+            <a:avLst/>
+          </a:prstGeom>
+          <a:noFill/>
+          <a:ln/>
+        </p:spPr>
+        <p:txBody>
+          <a:bodyPr wrap="square" lIns="33867" tIns="33867" rIns="33867" bIns="33867" rtlCol="0" anchor="t"/>
+          <a:lstStyle/>
+          <a:p>
+            <a:pPr defTabSz="1219170"/>
+            <a:r>
+              <a:rPr lang="en-US" sz="1600" dirty="0">
+                <a:solidFill>
+                  <a:srgbClr val="CADCFC"/>
+                </a:solidFill>
+                <a:latin typeface="Calibri" pitchFamily="34" charset="0"/>
+                <a:ea typeface="Calibri" pitchFamily="34" charset="-122"/>
+                <a:cs typeface="Calibri" pitchFamily="34" charset="-120"/>
+              </a:rPr>
+              <a:t>fires when bass paused</a:t>
+            </a:r>
+            <a:endParaRPr lang="en-US" sz="1600" dirty="0">
+              <a:solidFill>
+                <a:prstClr val="black"/>
+              </a:solidFill>
+              <a:latin typeface="Calibri" panose="020F0502020204030204"/>
+            </a:endParaRPr>
+          </a:p>
+        </p:txBody>
+      </p:sp>
+      <p:sp>
+        <p:nvSpPr>
+          <p:cNvPr id="35" name="Shape 13">
+            <a:extLst>
+              <a:ext uri="{FF2B5EF4-FFF2-40B4-BE49-F238E27FC236}">
+                <a16:creationId xmlns:a16="http://schemas.microsoft.com/office/drawing/2014/main" id="{FD5AEDBA-8E6D-A402-A41C-3F190A48E5BC}"/>
+              </a:ext>
+            </a:extLst>
+          </p:cNvPr>
+          <p:cNvSpPr/>
+          <p:nvPr/>
+        </p:nvSpPr>
+        <p:spPr>
+          <a:xfrm>
+            <a:off x="2767590" y="5300918"/>
+            <a:ext cx="582300" cy="0"/>
+          </a:xfrm>
+          <a:prstGeom prst="line">
+            <a:avLst/>
+          </a:prstGeom>
+          <a:noFill/>
+          <a:ln w="50800">
+            <a:solidFill>
+              <a:srgbClr val="CADCFC"/>
+            </a:solidFill>
+            <a:prstDash val="solid"/>
+            <a:tailEnd type="arrow"/>
+          </a:ln>
+        </p:spPr>
+        <p:txBody>
+          <a:bodyPr/>
+          <a:lstStyle/>
+          <a:p>
+            <a:pPr defTabSz="1219170"/>
+            <a:endParaRPr lang="en-US" sz="2400">
               <a:solidFill>
                 <a:prstClr val="black"/>
               </a:solidFill>
@@ -9084,7 +9254,7 @@
         <p:spPr>
           <a:xfrm>
             <a:off x="1177808" y="2808994"/>
-            <a:ext cx="6928578" cy="1873544"/>
+            <a:ext cx="6928578" cy="1786648"/>
           </a:xfrm>
           <a:prstGeom prst="roundRect">
             <a:avLst>
@@ -9165,7 +9335,7 @@
         </p:nvSpPr>
         <p:spPr>
           <a:xfrm>
-            <a:off x="1442987" y="3243128"/>
+            <a:off x="1442987" y="3193004"/>
             <a:ext cx="6398220" cy="1279645"/>
           </a:xfrm>
           <a:prstGeom prst="rect">
@@ -9268,7 +9438,7 @@
         </p:nvSpPr>
         <p:spPr>
           <a:xfrm>
-            <a:off x="644533" y="5208737"/>
+            <a:off x="644533" y="5114147"/>
             <a:ext cx="2129360" cy="1114235"/>
           </a:xfrm>
           <a:prstGeom prst="roundRect">
@@ -9308,7 +9478,7 @@
         </p:nvSpPr>
         <p:spPr>
           <a:xfrm>
-            <a:off x="438329" y="5303310"/>
+            <a:off x="438329" y="5208720"/>
             <a:ext cx="2560320" cy="316992"/>
           </a:xfrm>
           <a:prstGeom prst="rect">
@@ -9350,7 +9520,7 @@
         </p:nvSpPr>
         <p:spPr>
           <a:xfrm>
-            <a:off x="832714" y="5669070"/>
+            <a:off x="832714" y="5574480"/>
             <a:ext cx="2129359" cy="560832"/>
           </a:xfrm>
           <a:prstGeom prst="rect">
@@ -9373,7 +9543,7 @@
                 <a:ea typeface="Calibri" pitchFamily="34" charset="-122"/>
                 <a:cs typeface="Calibri" pitchFamily="34" charset="-120"/>
               </a:rPr>
-              <a:t>motifs, recall,</a:t>
+              <a:t>Motifs · recall</a:t>
             </a:r>
             <a:endParaRPr lang="en-US" sz="1600" dirty="0">
               <a:solidFill>
@@ -9412,7 +9582,7 @@
         </p:nvSpPr>
         <p:spPr>
           <a:xfrm>
-            <a:off x="3310872" y="5198136"/>
+            <a:off x="3310872" y="5103546"/>
             <a:ext cx="3291840" cy="1193225"/>
           </a:xfrm>
           <a:prstGeom prst="roundRect">
@@ -9452,7 +9622,7 @@
         </p:nvSpPr>
         <p:spPr>
           <a:xfrm>
-            <a:off x="3371832" y="5457566"/>
+            <a:off x="3371832" y="5362976"/>
             <a:ext cx="3169920" cy="316992"/>
           </a:xfrm>
           <a:prstGeom prst="rect">
@@ -9516,7 +9686,7 @@
         </p:nvSpPr>
         <p:spPr>
           <a:xfrm>
-            <a:off x="3495872" y="5984785"/>
+            <a:off x="3495872" y="5890195"/>
             <a:ext cx="2921840" cy="426720"/>
           </a:xfrm>
           <a:prstGeom prst="rect">
@@ -9558,8 +9728,8 @@
         </p:nvSpPr>
         <p:spPr>
           <a:xfrm>
-            <a:off x="8704213" y="2808994"/>
-            <a:ext cx="2316480" cy="1288382"/>
+            <a:off x="8697712" y="2360827"/>
+            <a:ext cx="2316480" cy="1598485"/>
           </a:xfrm>
           <a:prstGeom prst="roundRect">
             <a:avLst>
@@ -9598,8 +9768,8 @@
         </p:nvSpPr>
         <p:spPr>
           <a:xfrm>
-            <a:off x="8761197" y="2999161"/>
-            <a:ext cx="2194560" cy="469393"/>
+            <a:off x="8754696" y="2550995"/>
+            <a:ext cx="2194560" cy="488042"/>
           </a:xfrm>
           <a:prstGeom prst="rect">
             <a:avLst/>
@@ -9640,8 +9810,8 @@
         </p:nvSpPr>
         <p:spPr>
           <a:xfrm>
-            <a:off x="8801749" y="3545031"/>
-            <a:ext cx="2121408" cy="627889"/>
+            <a:off x="8916298" y="3096865"/>
+            <a:ext cx="2000358" cy="779017"/>
           </a:xfrm>
           <a:prstGeom prst="rect">
             <a:avLst/>
@@ -9683,8 +9853,11 @@
                 <a:ea typeface="Calibri" pitchFamily="34" charset="-122"/>
                 <a:cs typeface="Calibri" pitchFamily="34" charset="-120"/>
               </a:rPr>
-              <a:t>stochastically</a:t>
-            </a:r>
+              <a:t>stochastically · velocity jitter on sax riff replays</a:t>
+            </a:r>
+          </a:p>
+          <a:p>
+            <a:pPr defTabSz="1219170"/>
             <a:endParaRPr lang="en-US" sz="1600" dirty="0">
               <a:solidFill>
                 <a:prstClr val="black"/>
@@ -9702,7 +9875,7 @@
         </p:nvSpPr>
         <p:spPr>
           <a:xfrm>
-            <a:off x="8704213" y="4587966"/>
+            <a:off x="8704213" y="4451332"/>
             <a:ext cx="2316480" cy="998153"/>
           </a:xfrm>
           <a:prstGeom prst="roundRect">
@@ -9742,7 +9915,7 @@
         </p:nvSpPr>
         <p:spPr>
           <a:xfrm>
-            <a:off x="8765173" y="4682538"/>
+            <a:off x="8765173" y="4545904"/>
             <a:ext cx="2194560" cy="316992"/>
           </a:xfrm>
           <a:prstGeom prst="rect">
@@ -9784,7 +9957,7 @@
         </p:nvSpPr>
         <p:spPr>
           <a:xfrm>
-            <a:off x="9036339" y="5006733"/>
+            <a:off x="9036339" y="4870099"/>
             <a:ext cx="1886818" cy="579386"/>
           </a:xfrm>
           <a:prstGeom prst="rect">
@@ -9847,7 +10020,7 @@
         </p:nvSpPr>
         <p:spPr>
           <a:xfrm>
-            <a:off x="9980858" y="6042613"/>
+            <a:off x="9980858" y="5905979"/>
             <a:ext cx="1488263" cy="438912"/>
           </a:xfrm>
           <a:prstGeom prst="roundRect">
@@ -9887,7 +10060,7 @@
         </p:nvSpPr>
         <p:spPr>
           <a:xfrm>
-            <a:off x="9842520" y="6042613"/>
+            <a:off x="9842520" y="5905979"/>
             <a:ext cx="1745341" cy="438912"/>
           </a:xfrm>
           <a:prstGeom prst="rect">
@@ -9929,7 +10102,7 @@
         </p:nvSpPr>
         <p:spPr>
           <a:xfrm>
-            <a:off x="4956792" y="4948991"/>
+            <a:off x="4956792" y="4854401"/>
             <a:ext cx="0" cy="60960"/>
           </a:xfrm>
           <a:prstGeom prst="line">
@@ -9965,7 +10138,7 @@
         </p:nvSpPr>
         <p:spPr>
           <a:xfrm>
-            <a:off x="1808074" y="4805870"/>
+            <a:off x="1808074" y="4711280"/>
             <a:ext cx="1" cy="335547"/>
           </a:xfrm>
           <a:prstGeom prst="line">
@@ -10002,8 +10175,8 @@
         </p:nvSpPr>
         <p:spPr>
           <a:xfrm>
-            <a:off x="4956792" y="4805871"/>
-            <a:ext cx="0" cy="305332"/>
+            <a:off x="4956792" y="4677107"/>
+            <a:ext cx="0" cy="339506"/>
           </a:xfrm>
           <a:prstGeom prst="line">
             <a:avLst/>
@@ -10045,7 +10218,7 @@
         </p:nvSpPr>
         <p:spPr>
           <a:xfrm flipH="1">
-            <a:off x="9757849" y="4199409"/>
+            <a:off x="9757849" y="4062775"/>
             <a:ext cx="7600" cy="323365"/>
           </a:xfrm>
           <a:prstGeom prst="line">
@@ -10088,7 +10261,7 @@
         </p:nvSpPr>
         <p:spPr>
           <a:xfrm>
-            <a:off x="10724802" y="5643947"/>
+            <a:off x="10724802" y="5507313"/>
             <a:ext cx="0" cy="340838"/>
           </a:xfrm>
           <a:prstGeom prst="line">
@@ -10217,7 +10390,7 @@
         </p:nvSpPr>
         <p:spPr>
           <a:xfrm>
-            <a:off x="8241261" y="3468554"/>
+            <a:off x="8218597" y="3341506"/>
             <a:ext cx="346428" cy="0"/>
           </a:xfrm>
           <a:prstGeom prst="line">
@@ -10260,7 +10433,7 @@
         </p:nvSpPr>
         <p:spPr>
           <a:xfrm>
-            <a:off x="8308575" y="6042613"/>
+            <a:off x="8308575" y="5905979"/>
             <a:ext cx="1488263" cy="438912"/>
           </a:xfrm>
           <a:prstGeom prst="roundRect">
@@ -10306,7 +10479,7 @@
         </p:nvSpPr>
         <p:spPr>
           <a:xfrm>
-            <a:off x="8360281" y="6042613"/>
+            <a:off x="8360281" y="5905979"/>
             <a:ext cx="1374805" cy="438912"/>
           </a:xfrm>
           <a:prstGeom prst="rect">
@@ -10354,7 +10527,7 @@
         </p:nvSpPr>
         <p:spPr>
           <a:xfrm>
-            <a:off x="9036339" y="5643947"/>
+            <a:off x="9036339" y="5507313"/>
             <a:ext cx="0" cy="340838"/>
           </a:xfrm>
           <a:prstGeom prst="line">

</xml_diff>

<commit_message>
docs: update wolfson presentation slides
Co-Authored-By: Claude Sonnet 4.6 <noreply@anthropic.com>
</commit_message>
<xml_diff>
--- a/docs/wolfson.pptx
+++ b/docs/wolfson.pptx
@@ -5693,7 +5693,7 @@
         </p:nvSpPr>
         <p:spPr>
           <a:xfrm>
-            <a:off x="838200" y="1901902"/>
+            <a:off x="838200" y="1786288"/>
             <a:ext cx="10376338" cy="4783061"/>
           </a:xfrm>
         </p:spPr>
@@ -5802,19 +5802,7 @@
               <a:rPr lang="en-GB" sz="2400" dirty="0">
                 <a:latin typeface="Palatino Linotype" panose="02040502050505030304" pitchFamily="18" charset="0"/>
               </a:rPr>
-              <a:t>The audience might feel it would be ‘more musical’ if </a:t>
-            </a:r>
-            <a:r>
-              <a:rPr lang="en-GB" sz="2400">
-                <a:latin typeface="Palatino Linotype" panose="02040502050505030304" pitchFamily="18" charset="0"/>
-              </a:rPr>
-              <a:t>it followed a </a:t>
-            </a:r>
-            <a:r>
-              <a:rPr lang="en-GB" sz="2400" dirty="0">
-                <a:latin typeface="Palatino Linotype" panose="02040502050505030304" pitchFamily="18" charset="0"/>
-              </a:rPr>
-              <a:t>fixed, pre-set chord progression – but the whole point is that it doesn’t, it’s responsive. There are plenty of play-along programs out there.</a:t>
+              <a:t>The audience might feel it would be ‘more musical’ if it followed a fixed, pre-set chord progression – but the whole point is that it doesn’t, it’s responsive. There are plenty of play-along programs out there.</a:t>
             </a:r>
           </a:p>
           <a:p>
@@ -6142,8 +6130,8 @@
         </p:nvSpPr>
         <p:spPr>
           <a:xfrm>
-            <a:off x="838200" y="1393902"/>
-            <a:ext cx="3954966" cy="4947829"/>
+            <a:off x="638504" y="1351859"/>
+            <a:ext cx="3954966" cy="5150128"/>
           </a:xfrm>
           <a:prstGeom prst="rect">
             <a:avLst/>
@@ -6157,9 +6145,9 @@
           <a:lstStyle/>
           <a:p>
             <a:pPr>
-              <a:lnSpc>
-                <a:spcPct val="110000"/>
-              </a:lnSpc>
+              <a:spcAft>
+                <a:spcPts val="200"/>
+              </a:spcAft>
             </a:pPr>
             <a:r>
               <a:rPr lang="en-GB" sz="2400" dirty="0">
@@ -6170,9 +6158,9 @@
           </a:p>
           <a:p>
             <a:pPr>
-              <a:lnSpc>
-                <a:spcPct val="110000"/>
-              </a:lnSpc>
+              <a:spcAft>
+                <a:spcPts val="200"/>
+              </a:spcAft>
             </a:pPr>
             <a:r>
               <a:rPr lang="en-GB" sz="2400" dirty="0">
@@ -6183,9 +6171,9 @@
           </a:p>
           <a:p>
             <a:pPr>
-              <a:lnSpc>
-                <a:spcPct val="110000"/>
-              </a:lnSpc>
+              <a:spcAft>
+                <a:spcPts val="200"/>
+              </a:spcAft>
             </a:pPr>
             <a:r>
               <a:rPr lang="en-GB" sz="2400" dirty="0">
@@ -6196,35 +6184,35 @@
           </a:p>
           <a:p>
             <a:pPr>
-              <a:lnSpc>
-                <a:spcPct val="110000"/>
-              </a:lnSpc>
+              <a:spcAft>
+                <a:spcPts val="200"/>
+              </a:spcAft>
             </a:pPr>
             <a:r>
               <a:rPr lang="en-GB" sz="2400" dirty="0">
                 <a:latin typeface="Palatino Linotype" panose="02040502050505030304" pitchFamily="18" charset="0"/>
               </a:rPr>
-              <a:t>Contour steering</a:t>
+              <a:t>Opening echo </a:t>
             </a:r>
           </a:p>
           <a:p>
             <a:pPr>
-              <a:lnSpc>
-                <a:spcPct val="110000"/>
-              </a:lnSpc>
+              <a:spcAft>
+                <a:spcPts val="200"/>
+              </a:spcAft>
             </a:pPr>
             <a:r>
               <a:rPr lang="en-GB" sz="2400" dirty="0">
                 <a:latin typeface="Palatino Linotype" panose="02040502050505030304" pitchFamily="18" charset="0"/>
               </a:rPr>
-              <a:t>Opening echo </a:t>
+              <a:t>Contour steering</a:t>
             </a:r>
           </a:p>
           <a:p>
             <a:pPr>
-              <a:lnSpc>
-                <a:spcPct val="110000"/>
-              </a:lnSpc>
+              <a:spcAft>
+                <a:spcPts val="200"/>
+              </a:spcAft>
             </a:pPr>
             <a:r>
               <a:rPr lang="en-GB" sz="2400" dirty="0">
@@ -6235,9 +6223,9 @@
           </a:p>
           <a:p>
             <a:pPr>
-              <a:lnSpc>
-                <a:spcPct val="110000"/>
-              </a:lnSpc>
+              <a:spcAft>
+                <a:spcPts val="200"/>
+              </a:spcAft>
             </a:pPr>
             <a:r>
               <a:rPr lang="en-GB" sz="2400" dirty="0">
@@ -6248,9 +6236,9 @@
           </a:p>
           <a:p>
             <a:pPr>
-              <a:lnSpc>
-                <a:spcPct val="110000"/>
-              </a:lnSpc>
+              <a:spcAft>
+                <a:spcPts val="200"/>
+              </a:spcAft>
             </a:pPr>
             <a:r>
               <a:rPr lang="en-GB" sz="2400" dirty="0">
@@ -6261,9 +6249,9 @@
           </a:p>
           <a:p>
             <a:pPr>
-              <a:lnSpc>
-                <a:spcPct val="110000"/>
-              </a:lnSpc>
+              <a:spcAft>
+                <a:spcPts val="200"/>
+              </a:spcAft>
             </a:pPr>
             <a:r>
               <a:rPr lang="en-GB" sz="2400" dirty="0">
@@ -6274,9 +6262,9 @@
           </a:p>
           <a:p>
             <a:pPr>
-              <a:lnSpc>
-                <a:spcPct val="110000"/>
-              </a:lnSpc>
+              <a:spcAft>
+                <a:spcPts val="200"/>
+              </a:spcAft>
             </a:pPr>
             <a:r>
               <a:rPr lang="en-GB" sz="2400" dirty="0">
@@ -6287,15 +6275,26 @@
           </a:p>
           <a:p>
             <a:pPr>
-              <a:lnSpc>
-                <a:spcPct val="110000"/>
-              </a:lnSpc>
+              <a:spcAft>
+                <a:spcPts val="200"/>
+              </a:spcAft>
             </a:pPr>
             <a:r>
               <a:rPr lang="en-GB" sz="2400" dirty="0">
                 <a:latin typeface="Palatino Linotype" panose="02040502050505030304" pitchFamily="18" charset="0"/>
               </a:rPr>
               <a:t>Live tempo tracking</a:t>
+            </a:r>
+            <a:br>
+              <a:rPr lang="en-GB" sz="2400" dirty="0">
+                <a:latin typeface="Palatino Linotype" panose="02040502050505030304" pitchFamily="18" charset="0"/>
+              </a:rPr>
+            </a:br>
+            <a:r>
+              <a:rPr lang="en-GB" sz="2400" dirty="0">
+                <a:latin typeface="Palatino Linotype" panose="02040502050505030304" pitchFamily="18" charset="0"/>
+              </a:rPr>
+              <a:t>Dynamics</a:t>
             </a:r>
           </a:p>
         </p:txBody>
@@ -6314,8 +6313,8 @@
         </p:nvSpPr>
         <p:spPr>
           <a:xfrm>
-            <a:off x="4056193" y="1393902"/>
-            <a:ext cx="3954966" cy="4947829"/>
+            <a:off x="3856497" y="1351859"/>
+            <a:ext cx="3954966" cy="5150128"/>
           </a:xfrm>
           <a:prstGeom prst="rect">
             <a:avLst/>
@@ -6329,15 +6328,15 @@
           <a:lstStyle/>
           <a:p>
             <a:pPr>
-              <a:lnSpc>
-                <a:spcPct val="110000"/>
-              </a:lnSpc>
+              <a:spcAft>
+                <a:spcPts val="200"/>
+              </a:spcAft>
             </a:pPr>
             <a:r>
               <a:rPr lang="en-GB" sz="2400" dirty="0">
                 <a:latin typeface="Palatino Linotype" panose="02040502050505030304" pitchFamily="18" charset="0"/>
               </a:rPr>
-              <a:t>Dynamics</a:t>
+              <a:t>Generation temperature</a:t>
             </a:r>
             <a:br>
               <a:rPr lang="en-GB" sz="2400" dirty="0">
@@ -6348,7 +6347,124 @@
               <a:rPr lang="en-GB" sz="2400" dirty="0">
                 <a:latin typeface="Palatino Linotype" panose="02040502050505030304" pitchFamily="18" charset="0"/>
               </a:rPr>
-              <a:t>Generation temperature</a:t>
+              <a:t>Phrase-shape dynamics</a:t>
+            </a:r>
+          </a:p>
+          <a:p>
+            <a:pPr>
+              <a:spcAft>
+                <a:spcPts val="200"/>
+              </a:spcAft>
+            </a:pPr>
+            <a:r>
+              <a:rPr lang="en-GB" sz="2400" dirty="0">
+                <a:latin typeface="Palatino Linotype" panose="02040502050505030304" pitchFamily="18" charset="0"/>
+              </a:rPr>
+              <a:t>Articulation</a:t>
+            </a:r>
+          </a:p>
+          <a:p>
+            <a:pPr>
+              <a:spcAft>
+                <a:spcPts val="200"/>
+              </a:spcAft>
+            </a:pPr>
+            <a:r>
+              <a:rPr lang="en-GB" sz="2400" dirty="0">
+                <a:latin typeface="Palatino Linotype" panose="02040502050505030304" pitchFamily="18" charset="0"/>
+              </a:rPr>
+              <a:t>Bass pitch-class tracking</a:t>
+            </a:r>
+          </a:p>
+          <a:p>
+            <a:pPr>
+              <a:spcAft>
+                <a:spcPts val="200"/>
+              </a:spcAft>
+            </a:pPr>
+            <a:r>
+              <a:rPr lang="en-GB" sz="2400" dirty="0">
+                <a:latin typeface="Palatino Linotype" panose="02040502050505030304" pitchFamily="18" charset="0"/>
+              </a:rPr>
+              <a:t>Energy arc</a:t>
+            </a:r>
+          </a:p>
+          <a:p>
+            <a:pPr>
+              <a:spcAft>
+                <a:spcPts val="200"/>
+              </a:spcAft>
+            </a:pPr>
+            <a:r>
+              <a:rPr lang="en-GB" sz="2400" dirty="0">
+                <a:latin typeface="Palatino Linotype" panose="02040502050505030304" pitchFamily="18" charset="0"/>
+              </a:rPr>
+              <a:t>Motivic development</a:t>
+            </a:r>
+          </a:p>
+          <a:p>
+            <a:pPr>
+              <a:spcAft>
+                <a:spcPts val="200"/>
+              </a:spcAft>
+            </a:pPr>
+            <a:r>
+              <a:rPr lang="en-GB" sz="2400" dirty="0">
+                <a:latin typeface="Palatino Linotype" panose="02040502050505030304" pitchFamily="18" charset="0"/>
+              </a:rPr>
+              <a:t>Lyrical motif re-use </a:t>
+            </a:r>
+          </a:p>
+          <a:p>
+            <a:pPr>
+              <a:spcAft>
+                <a:spcPts val="200"/>
+              </a:spcAft>
+            </a:pPr>
+            <a:r>
+              <a:rPr lang="en-GB" sz="2400" dirty="0">
+                <a:latin typeface="Palatino Linotype" panose="02040502050505030304" pitchFamily="18" charset="0"/>
+              </a:rPr>
+              <a:t>Voice leading</a:t>
+            </a:r>
+          </a:p>
+          <a:p>
+            <a:pPr>
+              <a:spcAft>
+                <a:spcPts val="200"/>
+              </a:spcAft>
+            </a:pPr>
+            <a:r>
+              <a:rPr lang="en-GB" sz="2400" dirty="0">
+                <a:latin typeface="Palatino Linotype" panose="02040502050505030304" pitchFamily="18" charset="0"/>
+              </a:rPr>
+              <a:t>Modal leap bonus </a:t>
+            </a:r>
+          </a:p>
+          <a:p>
+            <a:pPr>
+              <a:spcAft>
+                <a:spcPts val="200"/>
+              </a:spcAft>
+            </a:pPr>
+            <a:r>
+              <a:rPr lang="en-GB" sz="2400" dirty="0">
+                <a:latin typeface="Palatino Linotype" panose="02040502050505030304" pitchFamily="18" charset="0"/>
+              </a:rPr>
+              <a:t>Stochastic thinning </a:t>
+            </a:r>
+          </a:p>
+          <a:p>
+            <a:pPr>
+              <a:spcAft>
+                <a:spcPts val="200"/>
+              </a:spcAft>
+            </a:pPr>
+            <a:r>
+              <a:rPr lang="en-GB" sz="2400" dirty="0">
+                <a:latin typeface="Palatino Linotype" panose="02040502050505030304" pitchFamily="18" charset="0"/>
+              </a:rPr>
+              <a:t>Phrase breathing</a:t>
             </a:r>
             <a:br>
               <a:rPr lang="en-GB" sz="2400" dirty="0">
@@ -6359,124 +6475,20 @@
               <a:rPr lang="en-GB" sz="2400" dirty="0">
                 <a:latin typeface="Palatino Linotype" panose="02040502050505030304" pitchFamily="18" charset="0"/>
               </a:rPr>
-              <a:t>Phrase-shape dynamics</a:t>
+              <a:t>Singable duration bias</a:t>
             </a:r>
           </a:p>
           <a:p>
             <a:pPr>
-              <a:lnSpc>
-                <a:spcPct val="110000"/>
-              </a:lnSpc>
+              <a:spcAft>
+                <a:spcPts val="200"/>
+              </a:spcAft>
             </a:pPr>
             <a:r>
               <a:rPr lang="en-GB" sz="2400" dirty="0">
                 <a:latin typeface="Palatino Linotype" panose="02040502050505030304" pitchFamily="18" charset="0"/>
               </a:rPr>
-              <a:t>Articulation</a:t>
-            </a:r>
-          </a:p>
-          <a:p>
-            <a:pPr>
-              <a:lnSpc>
-                <a:spcPct val="110000"/>
-              </a:lnSpc>
-            </a:pPr>
-            <a:r>
-              <a:rPr lang="en-GB" sz="2400" dirty="0">
-                <a:latin typeface="Palatino Linotype" panose="02040502050505030304" pitchFamily="18" charset="0"/>
-              </a:rPr>
-              <a:t>Bass pitch-class tracking</a:t>
-            </a:r>
-          </a:p>
-          <a:p>
-            <a:pPr>
-              <a:lnSpc>
-                <a:spcPct val="110000"/>
-              </a:lnSpc>
-            </a:pPr>
-            <a:r>
-              <a:rPr lang="en-GB" sz="2400" dirty="0">
-                <a:latin typeface="Palatino Linotype" panose="02040502050505030304" pitchFamily="18" charset="0"/>
-              </a:rPr>
-              <a:t>Energy arc</a:t>
-            </a:r>
-          </a:p>
-          <a:p>
-            <a:pPr>
-              <a:lnSpc>
-                <a:spcPct val="110000"/>
-              </a:lnSpc>
-            </a:pPr>
-            <a:r>
-              <a:rPr lang="en-GB" sz="2400" dirty="0">
-                <a:latin typeface="Palatino Linotype" panose="02040502050505030304" pitchFamily="18" charset="0"/>
-              </a:rPr>
-              <a:t>Motivic development</a:t>
-            </a:r>
-          </a:p>
-          <a:p>
-            <a:pPr>
-              <a:lnSpc>
-                <a:spcPct val="110000"/>
-              </a:lnSpc>
-            </a:pPr>
-            <a:r>
-              <a:rPr lang="en-GB" sz="2400" dirty="0">
-                <a:latin typeface="Palatino Linotype" panose="02040502050505030304" pitchFamily="18" charset="0"/>
-              </a:rPr>
-              <a:t>Lyrical motif re-use </a:t>
-            </a:r>
-          </a:p>
-          <a:p>
-            <a:pPr>
-              <a:lnSpc>
-                <a:spcPct val="110000"/>
-              </a:lnSpc>
-            </a:pPr>
-            <a:r>
-              <a:rPr lang="en-GB" sz="2400" dirty="0">
-                <a:latin typeface="Palatino Linotype" panose="02040502050505030304" pitchFamily="18" charset="0"/>
-              </a:rPr>
-              <a:t>Voice leading</a:t>
-            </a:r>
-          </a:p>
-          <a:p>
-            <a:pPr>
-              <a:lnSpc>
-                <a:spcPct val="110000"/>
-              </a:lnSpc>
-            </a:pPr>
-            <a:r>
-              <a:rPr lang="en-GB" sz="2400" dirty="0">
-                <a:latin typeface="Palatino Linotype" panose="02040502050505030304" pitchFamily="18" charset="0"/>
-              </a:rPr>
-              <a:t>Modal leap bonus </a:t>
-            </a:r>
-          </a:p>
-          <a:p>
-            <a:pPr>
-              <a:lnSpc>
-                <a:spcPct val="110000"/>
-              </a:lnSpc>
-            </a:pPr>
-            <a:r>
-              <a:rPr lang="en-GB" sz="2400" dirty="0">
-                <a:latin typeface="Palatino Linotype" panose="02040502050505030304" pitchFamily="18" charset="0"/>
-              </a:rPr>
-              <a:t>Stochastic thinning </a:t>
-            </a:r>
-          </a:p>
-          <a:p>
-            <a:pPr>
-              <a:lnSpc>
-                <a:spcPct val="110000"/>
-              </a:lnSpc>
-            </a:pPr>
-            <a:r>
-              <a:rPr lang="en-GB" sz="2400" dirty="0">
-                <a:latin typeface="Palatino Linotype" panose="02040502050505030304" pitchFamily="18" charset="0"/>
-              </a:rPr>
-              <a:t>Phrase breathing</a:t>
+              <a:t>Rhythmic density </a:t>
             </a:r>
           </a:p>
         </p:txBody>
@@ -6495,8 +6507,8 @@
         </p:nvSpPr>
         <p:spPr>
           <a:xfrm>
-            <a:off x="7704622" y="1393902"/>
-            <a:ext cx="4182577" cy="4947829"/>
+            <a:off x="7504926" y="1351859"/>
+            <a:ext cx="4182577" cy="4729500"/>
           </a:xfrm>
           <a:prstGeom prst="rect">
             <a:avLst/>
@@ -6510,119 +6522,106 @@
           <a:lstStyle/>
           <a:p>
             <a:pPr>
-              <a:lnSpc>
-                <a:spcPct val="110000"/>
-              </a:lnSpc>
+              <a:spcAft>
+                <a:spcPts val="200"/>
+              </a:spcAft>
             </a:pPr>
             <a:r>
               <a:rPr lang="en-GB" sz="2400" dirty="0">
                 <a:latin typeface="Palatino Linotype" panose="02040502050505030304" pitchFamily="18" charset="0"/>
               </a:rPr>
-              <a:t>Singable duration bias</a:t>
+              <a:t>Rhythmic complementarity</a:t>
             </a:r>
           </a:p>
           <a:p>
             <a:pPr>
-              <a:lnSpc>
-                <a:spcPct val="110000"/>
-              </a:lnSpc>
+              <a:spcAft>
+                <a:spcPts val="200"/>
+              </a:spcAft>
             </a:pPr>
             <a:r>
               <a:rPr lang="en-GB" sz="2400" dirty="0">
                 <a:latin typeface="Palatino Linotype" panose="02040502050505030304" pitchFamily="18" charset="0"/>
               </a:rPr>
-              <a:t>Rhythmic density </a:t>
+              <a:t>Register contrast </a:t>
             </a:r>
           </a:p>
           <a:p>
             <a:pPr>
-              <a:lnSpc>
-                <a:spcPct val="110000"/>
-              </a:lnSpc>
+              <a:spcAft>
+                <a:spcPts val="200"/>
+              </a:spcAft>
             </a:pPr>
             <a:r>
               <a:rPr lang="en-GB" sz="2400" dirty="0">
                 <a:latin typeface="Palatino Linotype" panose="02040502050505030304" pitchFamily="18" charset="0"/>
               </a:rPr>
-              <a:t>Rhythmic complementarity</a:t>
+              <a:t>Phrase length control</a:t>
             </a:r>
           </a:p>
           <a:p>
             <a:pPr>
-              <a:lnSpc>
-                <a:spcPct val="110000"/>
-              </a:lnSpc>
+              <a:spcAft>
+                <a:spcPts val="200"/>
+              </a:spcAft>
             </a:pPr>
             <a:r>
               <a:rPr lang="en-GB" sz="2400" dirty="0">
                 <a:latin typeface="Palatino Linotype" panose="02040502050505030304" pitchFamily="18" charset="0"/>
               </a:rPr>
-              <a:t>Register contrast </a:t>
+              <a:t>Beat-matching / trading bars </a:t>
             </a:r>
           </a:p>
           <a:p>
             <a:pPr>
-              <a:lnSpc>
-                <a:spcPct val="110000"/>
-              </a:lnSpc>
+              <a:spcAft>
+                <a:spcPts val="200"/>
+              </a:spcAft>
             </a:pPr>
             <a:r>
               <a:rPr lang="en-GB" sz="2400" dirty="0">
                 <a:latin typeface="Palatino Linotype" panose="02040502050505030304" pitchFamily="18" charset="0"/>
               </a:rPr>
-              <a:t>Phrase length control</a:t>
+              <a:t>Repetition control</a:t>
             </a:r>
           </a:p>
           <a:p>
             <a:pPr>
-              <a:lnSpc>
-                <a:spcPct val="110000"/>
-              </a:lnSpc>
+              <a:spcAft>
+                <a:spcPts val="200"/>
+              </a:spcAft>
             </a:pPr>
             <a:r>
               <a:rPr lang="en-GB" sz="2400" dirty="0">
                 <a:latin typeface="Palatino Linotype" panose="02040502050505030304" pitchFamily="18" charset="0"/>
               </a:rPr>
-              <a:t>Beat-matching / trading bars </a:t>
+              <a:t>Sax riff / insistence</a:t>
             </a:r>
           </a:p>
           <a:p>
             <a:pPr>
-              <a:lnSpc>
-                <a:spcPct val="110000"/>
-              </a:lnSpc>
+              <a:spcAft>
+                <a:spcPts val="200"/>
+              </a:spcAft>
             </a:pPr>
             <a:r>
               <a:rPr lang="en-GB" sz="2400" dirty="0">
                 <a:latin typeface="Palatino Linotype" panose="02040502050505030304" pitchFamily="18" charset="0"/>
               </a:rPr>
-              <a:t>Repetition control</a:t>
+              <a:t>Proactive mode</a:t>
             </a:r>
           </a:p>
           <a:p>
             <a:pPr>
-              <a:lnSpc>
-                <a:spcPct val="110000"/>
-              </a:lnSpc>
+              <a:spcAft>
+                <a:spcPts val="200"/>
+              </a:spcAft>
             </a:pPr>
             <a:r>
               <a:rPr lang="en-GB" sz="2400" dirty="0">
                 <a:latin typeface="Palatino Linotype" panose="02040502050505030304" pitchFamily="18" charset="0"/>
               </a:rPr>
-              <a:t>Sax riff / insistence</a:t>
-            </a:r>
-          </a:p>
-          <a:p>
-            <a:pPr>
-              <a:lnSpc>
-                <a:spcPct val="110000"/>
-              </a:lnSpc>
-            </a:pPr>
-            <a:r>
-              <a:rPr lang="en-GB" sz="2400" dirty="0">
-                <a:latin typeface="Palatino Linotype" panose="02040502050505030304" pitchFamily="18" charset="0"/>
-              </a:rPr>
-              <a:t>Proactive mode</a:t>
+              <a:t>Live phrase peeking</a:t>
             </a:r>
             <a:br>
               <a:rPr lang="en-GB" sz="2400" dirty="0">
@@ -6633,14 +6632,25 @@
               <a:rPr lang="en-GB" sz="2400" dirty="0">
                 <a:latin typeface="Palatino Linotype" panose="02040502050505030304" pitchFamily="18" charset="0"/>
               </a:rPr>
+              <a:t>Beat-synchronised entry</a:t>
+            </a:r>
+            <a:br>
+              <a:rPr lang="en-GB" sz="2400" dirty="0">
+                <a:latin typeface="Palatino Linotype" panose="02040502050505030304" pitchFamily="18" charset="0"/>
+              </a:rPr>
+            </a:br>
+            <a:r>
+              <a:rPr lang="en-GB" sz="2400" dirty="0">
+                <a:latin typeface="Palatino Linotype" panose="02040502050505030304" pitchFamily="18" charset="0"/>
+              </a:rPr>
               <a:t>Turn-taking </a:t>
             </a:r>
           </a:p>
           <a:p>
             <a:pPr>
-              <a:lnSpc>
-                <a:spcPct val="110000"/>
-              </a:lnSpc>
+              <a:spcAft>
+                <a:spcPts val="200"/>
+              </a:spcAft>
             </a:pPr>
             <a:r>
               <a:rPr lang="en-GB" sz="2400" dirty="0">
@@ -6794,7 +6804,7 @@
         </p:spPr>
         <p:txBody>
           <a:bodyPr>
-            <a:normAutofit fontScale="92500"/>
+            <a:normAutofit/>
           </a:bodyPr>
           <a:lstStyle/>
           <a:p>
@@ -6811,7 +6821,7 @@
               <a:rPr lang="en-GB" sz="2400" b="1" dirty="0">
                 <a:latin typeface="Palatino Linotype" panose="02040502050505030304" pitchFamily="18" charset="0"/>
               </a:rPr>
-              <a:t>Five giant steps in the arc:</a:t>
+              <a:t>Five giant steps in the arc…</a:t>
             </a:r>
             <a:br>
               <a:rPr lang="en-GB" sz="2400" b="1" dirty="0">
@@ -6821,176 +6831,6 @@
             <a:endParaRPr lang="en-GB" sz="1200" b="1" dirty="0">
               <a:latin typeface="Palatino Linotype" panose="02040502050505030304" pitchFamily="18" charset="0"/>
             </a:endParaRPr>
-          </a:p>
-          <a:p>
-            <a:pPr marL="514350" indent="-514350">
-              <a:lnSpc>
-                <a:spcPct val="120000"/>
-              </a:lnSpc>
-              <a:spcBef>
-                <a:spcPts val="0"/>
-              </a:spcBef>
-              <a:buFont typeface="+mj-lt"/>
-              <a:buAutoNum type="arabicPeriod"/>
-            </a:pPr>
-            <a:r>
-              <a:rPr lang="en-GB" sz="2400" b="1" dirty="0">
-                <a:latin typeface="Palatino Linotype" panose="02040502050505030304" pitchFamily="18" charset="0"/>
-              </a:rPr>
-              <a:t>Sparse</a:t>
-            </a:r>
-          </a:p>
-          <a:p>
-            <a:pPr lvl="1">
-              <a:lnSpc>
-                <a:spcPct val="120000"/>
-              </a:lnSpc>
-              <a:spcBef>
-                <a:spcPts val="0"/>
-              </a:spcBef>
-            </a:pPr>
-            <a:r>
-              <a:rPr lang="en-GB" sz="2200" dirty="0">
-                <a:latin typeface="Palatino Linotype" panose="02040502050505030304" pitchFamily="18" charset="0"/>
-              </a:rPr>
-              <a:t>Exploratory, establish motifs slowly</a:t>
-            </a:r>
-          </a:p>
-          <a:p>
-            <a:pPr marL="514350" indent="-514350">
-              <a:lnSpc>
-                <a:spcPct val="120000"/>
-              </a:lnSpc>
-              <a:spcBef>
-                <a:spcPts val="0"/>
-              </a:spcBef>
-              <a:buFont typeface="+mj-lt"/>
-              <a:buAutoNum type="arabicPeriod"/>
-            </a:pPr>
-            <a:r>
-              <a:rPr lang="en-GB" sz="2400" b="1" dirty="0">
-                <a:latin typeface="Palatino Linotype" panose="02040502050505030304" pitchFamily="18" charset="0"/>
-              </a:rPr>
-              <a:t>Building</a:t>
-            </a:r>
-          </a:p>
-          <a:p>
-            <a:pPr lvl="1">
-              <a:lnSpc>
-                <a:spcPct val="120000"/>
-              </a:lnSpc>
-              <a:spcBef>
-                <a:spcPts val="0"/>
-              </a:spcBef>
-            </a:pPr>
-            <a:r>
-              <a:rPr lang="en-GB" sz="2200" dirty="0">
-                <a:latin typeface="Palatino Linotype" panose="02040502050505030304" pitchFamily="18" charset="0"/>
-              </a:rPr>
-              <a:t>Mixed, lines begin to flow, groove warming up</a:t>
-            </a:r>
-          </a:p>
-          <a:p>
-            <a:pPr marL="514350" indent="-514350">
-              <a:lnSpc>
-                <a:spcPct val="120000"/>
-              </a:lnSpc>
-              <a:spcBef>
-                <a:spcPts val="0"/>
-              </a:spcBef>
-              <a:buFont typeface="+mj-lt"/>
-              <a:buAutoNum type="arabicPeriod"/>
-            </a:pPr>
-            <a:r>
-              <a:rPr lang="en-GB" sz="2400" b="1" dirty="0">
-                <a:latin typeface="Palatino Linotype" panose="02040502050505030304" pitchFamily="18" charset="0"/>
-              </a:rPr>
-              <a:t>Peak</a:t>
-            </a:r>
-          </a:p>
-          <a:p>
-            <a:pPr lvl="1">
-              <a:lnSpc>
-                <a:spcPct val="120000"/>
-              </a:lnSpc>
-              <a:spcBef>
-                <a:spcPts val="0"/>
-              </a:spcBef>
-            </a:pPr>
-            <a:r>
-              <a:rPr lang="en-GB" sz="2200" dirty="0">
-                <a:latin typeface="Palatino Linotype" panose="02040502050505030304" pitchFamily="18" charset="0"/>
-              </a:rPr>
-              <a:t>Fast, active, max rhythmic intensity</a:t>
-            </a:r>
-          </a:p>
-          <a:p>
-            <a:pPr marL="514350" indent="-514350">
-              <a:lnSpc>
-                <a:spcPct val="120000"/>
-              </a:lnSpc>
-              <a:spcBef>
-                <a:spcPts val="0"/>
-              </a:spcBef>
-              <a:buFont typeface="+mj-lt"/>
-              <a:buAutoNum type="arabicPeriod"/>
-            </a:pPr>
-            <a:r>
-              <a:rPr lang="en-GB" sz="2400" b="1" dirty="0">
-                <a:latin typeface="Palatino Linotype" panose="02040502050505030304" pitchFamily="18" charset="0"/>
-              </a:rPr>
-              <a:t>Recapitulation</a:t>
-            </a:r>
-          </a:p>
-          <a:p>
-            <a:pPr lvl="1">
-              <a:lnSpc>
-                <a:spcPct val="120000"/>
-              </a:lnSpc>
-              <a:spcBef>
-                <a:spcPts val="0"/>
-              </a:spcBef>
-            </a:pPr>
-            <a:r>
-              <a:rPr lang="en-GB" sz="2200" dirty="0">
-                <a:latin typeface="Palatino Linotype" panose="02040502050505030304" pitchFamily="18" charset="0"/>
-              </a:rPr>
-              <a:t>Lyrical return, singable motifs recalled</a:t>
-            </a:r>
-          </a:p>
-          <a:p>
-            <a:pPr marL="514350" indent="-514350">
-              <a:lnSpc>
-                <a:spcPct val="120000"/>
-              </a:lnSpc>
-              <a:spcBef>
-                <a:spcPts val="0"/>
-              </a:spcBef>
-              <a:buFont typeface="+mj-lt"/>
-              <a:buAutoNum type="arabicPeriod"/>
-            </a:pPr>
-            <a:r>
-              <a:rPr lang="en-GB" sz="2400" b="1" dirty="0">
-                <a:latin typeface="Palatino Linotype" panose="02040502050505030304" pitchFamily="18" charset="0"/>
-              </a:rPr>
-              <a:t>Resolution</a:t>
-            </a:r>
-          </a:p>
-          <a:p>
-            <a:pPr lvl="1">
-              <a:lnSpc>
-                <a:spcPct val="120000"/>
-              </a:lnSpc>
-              <a:spcBef>
-                <a:spcPts val="0"/>
-              </a:spcBef>
-            </a:pPr>
-            <a:r>
-              <a:rPr lang="en-GB" sz="2200" dirty="0">
-                <a:latin typeface="Palatino Linotype" panose="02040502050505030304" pitchFamily="18" charset="0"/>
-              </a:rPr>
-              <a:t>Slowest, long tones, fading out</a:t>
-            </a:r>
           </a:p>
           <a:p>
             <a:pPr>
@@ -7007,72 +6847,592 @@
           </a:p>
         </p:txBody>
       </p:sp>
-      <p:pic>
-        <p:nvPicPr>
-          <p:cNvPr id="7" name="Picture 6">
+      <p:graphicFrame>
+        <p:nvGraphicFramePr>
+          <p:cNvPr id="4" name="Table 3">
             <a:extLst>
               <a:ext uri="{FF2B5EF4-FFF2-40B4-BE49-F238E27FC236}">
-                <a16:creationId xmlns:a16="http://schemas.microsoft.com/office/drawing/2014/main" id="{F2647FFC-DAFE-7E3F-4130-FD88E7EAFE7A}"/>
+                <a16:creationId xmlns:a16="http://schemas.microsoft.com/office/drawing/2014/main" id="{F28044EB-D1EF-6DA6-B529-1FE2F9EC2513}"/>
               </a:ext>
             </a:extLst>
           </p:cNvPr>
-          <p:cNvPicPr>
-            <a:picLocks noChangeAspect="1"/>
-          </p:cNvPicPr>
-          <p:nvPr/>
-        </p:nvPicPr>
-        <p:blipFill>
-          <a:blip r:embed="rId3"/>
-          <a:stretch>
-            <a:fillRect/>
-          </a:stretch>
-        </p:blipFill>
-        <p:spPr>
-          <a:xfrm>
-            <a:off x="7495307" y="1170878"/>
-            <a:ext cx="4263737" cy="3746123"/>
-          </a:xfrm>
-          <a:prstGeom prst="rect">
-            <a:avLst/>
-          </a:prstGeom>
-        </p:spPr>
-      </p:pic>
-      <p:sp>
-        <p:nvSpPr>
-          <p:cNvPr id="9" name="TextBox 8">
-            <a:extLst>
-              <a:ext uri="{FF2B5EF4-FFF2-40B4-BE49-F238E27FC236}">
-                <a16:creationId xmlns:a16="http://schemas.microsoft.com/office/drawing/2014/main" id="{5AB3EBC4-F166-607D-B1D4-5664B1F69E01}"/>
-              </a:ext>
-            </a:extLst>
-          </p:cNvPr>
-          <p:cNvSpPr txBox="1"/>
-          <p:nvPr/>
-        </p:nvSpPr>
-        <p:spPr>
-          <a:xfrm>
-            <a:off x="7495306" y="5353422"/>
-            <a:ext cx="4263737" cy="430887"/>
-          </a:xfrm>
-          <a:prstGeom prst="rect">
-            <a:avLst/>
-          </a:prstGeom>
-          <a:noFill/>
-        </p:spPr>
-        <p:txBody>
-          <a:bodyPr wrap="square">
-            <a:spAutoFit/>
-          </a:bodyPr>
-          <a:lstStyle/>
-          <a:p>
-            <a:r>
-              <a:rPr lang="en-US" sz="2200" b="1" dirty="0" err="1"/>
-              <a:t>wolfson.numbersintonotes.net</a:t>
-            </a:r>
-            <a:endParaRPr lang="en-US" sz="2200" b="1" dirty="0"/>
-          </a:p>
-        </p:txBody>
-      </p:sp>
+          <p:cNvGraphicFramePr>
+            <a:graphicFrameLocks noGrp="1"/>
+          </p:cNvGraphicFramePr>
+          <p:nvPr>
+            <p:extLst>
+              <p:ext uri="{D42A27DB-BD31-4B8C-83A1-F6EECF244321}">
+                <p14:modId xmlns:p14="http://schemas.microsoft.com/office/powerpoint/2010/main" val="1675330609"/>
+              </p:ext>
+            </p:extLst>
+          </p:nvPr>
+        </p:nvGraphicFramePr>
+        <p:xfrm>
+          <a:off x="1899744" y="2347445"/>
+          <a:ext cx="8022022" cy="3780000"/>
+        </p:xfrm>
+        <a:graphic>
+          <a:graphicData uri="http://schemas.openxmlformats.org/drawingml/2006/table">
+            <a:tbl>
+              <a:tblPr bandRow="1">
+                <a:tableStyleId>{5C22544A-7EE6-4342-B048-85BDC9FD1C3A}</a:tableStyleId>
+              </a:tblPr>
+              <a:tblGrid>
+                <a:gridCol w="2735318">
+                  <a:extLst>
+                    <a:ext uri="{9D8B030D-6E8A-4147-A177-3AD203B41FA5}">
+                      <a16:colId xmlns:a16="http://schemas.microsoft.com/office/drawing/2014/main" val="2485304831"/>
+                    </a:ext>
+                  </a:extLst>
+                </a:gridCol>
+                <a:gridCol w="5286704">
+                  <a:extLst>
+                    <a:ext uri="{9D8B030D-6E8A-4147-A177-3AD203B41FA5}">
+                      <a16:colId xmlns:a16="http://schemas.microsoft.com/office/drawing/2014/main" val="219351318"/>
+                    </a:ext>
+                  </a:extLst>
+                </a:gridCol>
+              </a:tblGrid>
+              <a:tr h="756000">
+                <a:tc>
+                  <a:txBody>
+                    <a:bodyPr/>
+                    <a:lstStyle/>
+                    <a:p>
+                      <a:pPr marL="0" marR="0" lvl="0" indent="0" algn="l" defTabSz="914400" rtl="0" eaLnBrk="1" fontAlgn="auto" latinLnBrk="0" hangingPunct="1">
+                        <a:lnSpc>
+                          <a:spcPct val="100000"/>
+                        </a:lnSpc>
+                        <a:spcBef>
+                          <a:spcPts val="0"/>
+                        </a:spcBef>
+                        <a:spcAft>
+                          <a:spcPts val="0"/>
+                        </a:spcAft>
+                        <a:buClrTx/>
+                        <a:buSzTx/>
+                        <a:buFontTx/>
+                        <a:buNone/>
+                        <a:tabLst/>
+                        <a:defRPr/>
+                      </a:pPr>
+                      <a:r>
+                        <a:rPr lang="en-GB" sz="2400" b="1" dirty="0">
+                          <a:latin typeface="Palatino Linotype" panose="02040502050505030304" pitchFamily="18" charset="0"/>
+                        </a:rPr>
+                        <a:t>Sparse</a:t>
+                      </a:r>
+                      <a:endParaRPr lang="en-GB" sz="2400" dirty="0">
+                        <a:latin typeface="Palatino Linotype" panose="02040502050505030304" pitchFamily="18" charset="0"/>
+                      </a:endParaRPr>
+                    </a:p>
+                  </a:txBody>
+                  <a:tcPr anchor="ctr">
+                    <a:lnL w="12700" cap="flat" cmpd="sng" algn="ctr">
+                      <a:solidFill>
+                        <a:schemeClr val="tx1"/>
+                      </a:solidFill>
+                      <a:prstDash val="solid"/>
+                      <a:round/>
+                      <a:headEnd type="none" w="med" len="med"/>
+                      <a:tailEnd type="none" w="med" len="med"/>
+                    </a:lnL>
+                    <a:lnT w="12700" cap="flat" cmpd="sng" algn="ctr">
+                      <a:solidFill>
+                        <a:schemeClr val="tx1"/>
+                      </a:solidFill>
+                      <a:prstDash val="solid"/>
+                      <a:round/>
+                      <a:headEnd type="none" w="med" len="med"/>
+                      <a:tailEnd type="none" w="med" len="med"/>
+                    </a:lnT>
+                    <a:solidFill>
+                      <a:srgbClr val="A9A9A9"/>
+                    </a:solidFill>
+                  </a:tcPr>
+                </a:tc>
+                <a:tc>
+                  <a:txBody>
+                    <a:bodyPr/>
+                    <a:lstStyle/>
+                    <a:p>
+                      <a:pPr marL="0" marR="0" lvl="0" indent="0" algn="l" defTabSz="914400" rtl="0" eaLnBrk="1" fontAlgn="auto" latinLnBrk="0" hangingPunct="1">
+                        <a:lnSpc>
+                          <a:spcPct val="100000"/>
+                        </a:lnSpc>
+                        <a:spcBef>
+                          <a:spcPts val="0"/>
+                        </a:spcBef>
+                        <a:spcAft>
+                          <a:spcPts val="0"/>
+                        </a:spcAft>
+                        <a:buClrTx/>
+                        <a:buSzTx/>
+                        <a:buFontTx/>
+                        <a:buNone/>
+                        <a:tabLst/>
+                        <a:defRPr/>
+                      </a:pPr>
+                      <a:r>
+                        <a:rPr lang="en-GB" sz="2400" dirty="0">
+                          <a:latin typeface="Palatino Linotype" panose="02040502050505030304" pitchFamily="18" charset="0"/>
+                        </a:rPr>
+                        <a:t>Exploratory, establish motifs slowly</a:t>
+                      </a:r>
+                    </a:p>
+                  </a:txBody>
+                  <a:tcPr anchor="ctr">
+                    <a:lnR w="12700" cap="flat" cmpd="sng" algn="ctr">
+                      <a:solidFill>
+                        <a:schemeClr val="tx1"/>
+                      </a:solidFill>
+                      <a:prstDash val="solid"/>
+                      <a:round/>
+                      <a:headEnd type="none" w="med" len="med"/>
+                      <a:tailEnd type="none" w="med" len="med"/>
+                    </a:lnR>
+                    <a:lnT w="12700" cap="flat" cmpd="sng" algn="ctr">
+                      <a:solidFill>
+                        <a:schemeClr val="tx1"/>
+                      </a:solidFill>
+                      <a:prstDash val="solid"/>
+                      <a:round/>
+                      <a:headEnd type="none" w="med" len="med"/>
+                      <a:tailEnd type="none" w="med" len="med"/>
+                    </a:lnT>
+                    <a:solidFill>
+                      <a:srgbClr val="A9A9A9"/>
+                    </a:solidFill>
+                  </a:tcPr>
+                </a:tc>
+                <a:extLst>
+                  <a:ext uri="{0D108BD9-81ED-4DB2-BD59-A6C34878D82A}">
+                    <a16:rowId xmlns:a16="http://schemas.microsoft.com/office/drawing/2014/main" val="835264627"/>
+                  </a:ext>
+                </a:extLst>
+              </a:tr>
+              <a:tr h="756000">
+                <a:tc>
+                  <a:txBody>
+                    <a:bodyPr/>
+                    <a:lstStyle/>
+                    <a:p>
+                      <a:pPr marL="0" marR="0" lvl="0" indent="0" algn="l" defTabSz="914400" rtl="0" eaLnBrk="1" fontAlgn="auto" latinLnBrk="0" hangingPunct="1">
+                        <a:lnSpc>
+                          <a:spcPct val="100000"/>
+                        </a:lnSpc>
+                        <a:spcBef>
+                          <a:spcPts val="0"/>
+                        </a:spcBef>
+                        <a:spcAft>
+                          <a:spcPts val="0"/>
+                        </a:spcAft>
+                        <a:buClrTx/>
+                        <a:buSzTx/>
+                        <a:buFontTx/>
+                        <a:buNone/>
+                        <a:tabLst/>
+                        <a:defRPr/>
+                      </a:pPr>
+                      <a:r>
+                        <a:rPr lang="en-GB" sz="2400" b="1" dirty="0">
+                          <a:latin typeface="Palatino Linotype" panose="02040502050505030304" pitchFamily="18" charset="0"/>
+                        </a:rPr>
+                        <a:t>Building</a:t>
+                      </a:r>
+                      <a:endParaRPr lang="en-GB" sz="2400" dirty="0">
+                        <a:latin typeface="Palatino Linotype" panose="02040502050505030304" pitchFamily="18" charset="0"/>
+                      </a:endParaRPr>
+                    </a:p>
+                  </a:txBody>
+                  <a:tcPr anchor="ctr">
+                    <a:lnL w="12700" cap="flat" cmpd="sng" algn="ctr">
+                      <a:solidFill>
+                        <a:schemeClr val="tx1"/>
+                      </a:solidFill>
+                      <a:prstDash val="solid"/>
+                      <a:round/>
+                      <a:headEnd type="none" w="med" len="med"/>
+                      <a:tailEnd type="none" w="med" len="med"/>
+                    </a:lnL>
+                    <a:solidFill>
+                      <a:srgbClr val="04FFFF"/>
+                    </a:solidFill>
+                  </a:tcPr>
+                </a:tc>
+                <a:tc>
+                  <a:txBody>
+                    <a:bodyPr/>
+                    <a:lstStyle/>
+                    <a:p>
+                      <a:pPr marL="0" marR="0" lvl="0" indent="0" algn="l" defTabSz="914400" rtl="0" eaLnBrk="1" fontAlgn="auto" latinLnBrk="0" hangingPunct="1">
+                        <a:lnSpc>
+                          <a:spcPct val="100000"/>
+                        </a:lnSpc>
+                        <a:spcBef>
+                          <a:spcPts val="0"/>
+                        </a:spcBef>
+                        <a:spcAft>
+                          <a:spcPts val="0"/>
+                        </a:spcAft>
+                        <a:buClrTx/>
+                        <a:buSzTx/>
+                        <a:buFontTx/>
+                        <a:buNone/>
+                        <a:tabLst/>
+                        <a:defRPr/>
+                      </a:pPr>
+                      <a:r>
+                        <a:rPr lang="en-GB" sz="2400" dirty="0">
+                          <a:latin typeface="Palatino Linotype" panose="02040502050505030304" pitchFamily="18" charset="0"/>
+                        </a:rPr>
+                        <a:t>Groove warming up, modal</a:t>
+                      </a:r>
+                    </a:p>
+                  </a:txBody>
+                  <a:tcPr anchor="ctr">
+                    <a:lnR w="12700" cap="flat" cmpd="sng" algn="ctr">
+                      <a:solidFill>
+                        <a:schemeClr val="tx1"/>
+                      </a:solidFill>
+                      <a:prstDash val="solid"/>
+                      <a:round/>
+                      <a:headEnd type="none" w="med" len="med"/>
+                      <a:tailEnd type="none" w="med" len="med"/>
+                    </a:lnR>
+                    <a:solidFill>
+                      <a:srgbClr val="04FFFF"/>
+                    </a:solidFill>
+                  </a:tcPr>
+                </a:tc>
+                <a:extLst>
+                  <a:ext uri="{0D108BD9-81ED-4DB2-BD59-A6C34878D82A}">
+                    <a16:rowId xmlns:a16="http://schemas.microsoft.com/office/drawing/2014/main" val="2601926033"/>
+                  </a:ext>
+                </a:extLst>
+              </a:tr>
+              <a:tr h="756000">
+                <a:tc>
+                  <a:txBody>
+                    <a:bodyPr/>
+                    <a:lstStyle/>
+                    <a:p>
+                      <a:pPr marL="0" marR="0" lvl="0" indent="0" algn="l" defTabSz="914400" rtl="0" eaLnBrk="1" fontAlgn="auto" latinLnBrk="0" hangingPunct="1">
+                        <a:lnSpc>
+                          <a:spcPct val="100000"/>
+                        </a:lnSpc>
+                        <a:spcBef>
+                          <a:spcPts val="0"/>
+                        </a:spcBef>
+                        <a:spcAft>
+                          <a:spcPts val="0"/>
+                        </a:spcAft>
+                        <a:buClrTx/>
+                        <a:buSzTx/>
+                        <a:buFontTx/>
+                        <a:buNone/>
+                        <a:tabLst/>
+                        <a:defRPr/>
+                      </a:pPr>
+                      <a:r>
+                        <a:rPr lang="en-GB" sz="2400" b="1" dirty="0">
+                          <a:latin typeface="Palatino Linotype" panose="02040502050505030304" pitchFamily="18" charset="0"/>
+                        </a:rPr>
+                        <a:t>Peak</a:t>
+                      </a:r>
+                      <a:endParaRPr lang="en-GB" sz="2400" dirty="0">
+                        <a:latin typeface="Palatino Linotype" panose="02040502050505030304" pitchFamily="18" charset="0"/>
+                      </a:endParaRPr>
+                    </a:p>
+                  </a:txBody>
+                  <a:tcPr anchor="ctr">
+                    <a:lnL w="12700" cap="flat" cmpd="sng" algn="ctr">
+                      <a:solidFill>
+                        <a:schemeClr val="tx1"/>
+                      </a:solidFill>
+                      <a:prstDash val="solid"/>
+                      <a:round/>
+                      <a:headEnd type="none" w="med" len="med"/>
+                      <a:tailEnd type="none" w="med" len="med"/>
+                    </a:lnL>
+                    <a:solidFill>
+                      <a:srgbClr val="FE4144"/>
+                    </a:solidFill>
+                  </a:tcPr>
+                </a:tc>
+                <a:tc>
+                  <a:txBody>
+                    <a:bodyPr/>
+                    <a:lstStyle/>
+                    <a:p>
+                      <a:pPr marL="0" marR="0" lvl="0" indent="0" algn="l" defTabSz="914400" rtl="0" eaLnBrk="1" fontAlgn="auto" latinLnBrk="0" hangingPunct="1">
+                        <a:lnSpc>
+                          <a:spcPct val="100000"/>
+                        </a:lnSpc>
+                        <a:spcBef>
+                          <a:spcPts val="0"/>
+                        </a:spcBef>
+                        <a:spcAft>
+                          <a:spcPts val="0"/>
+                        </a:spcAft>
+                        <a:buClrTx/>
+                        <a:buSzTx/>
+                        <a:buFontTx/>
+                        <a:buNone/>
+                        <a:tabLst/>
+                        <a:defRPr/>
+                      </a:pPr>
+                      <a:r>
+                        <a:rPr lang="en-GB" sz="2400" dirty="0">
+                          <a:latin typeface="Palatino Linotype" panose="02040502050505030304" pitchFamily="18" charset="0"/>
+                        </a:rPr>
+                        <a:t>Fast, active, max rhythmic intensity</a:t>
+                      </a:r>
+                    </a:p>
+                  </a:txBody>
+                  <a:tcPr anchor="ctr">
+                    <a:lnR w="12700" cap="flat" cmpd="sng" algn="ctr">
+                      <a:solidFill>
+                        <a:schemeClr val="tx1"/>
+                      </a:solidFill>
+                      <a:prstDash val="solid"/>
+                      <a:round/>
+                      <a:headEnd type="none" w="med" len="med"/>
+                      <a:tailEnd type="none" w="med" len="med"/>
+                    </a:lnR>
+                    <a:solidFill>
+                      <a:srgbClr val="FE4144"/>
+                    </a:solidFill>
+                  </a:tcPr>
+                </a:tc>
+                <a:extLst>
+                  <a:ext uri="{0D108BD9-81ED-4DB2-BD59-A6C34878D82A}">
+                    <a16:rowId xmlns:a16="http://schemas.microsoft.com/office/drawing/2014/main" val="1959254695"/>
+                  </a:ext>
+                </a:extLst>
+              </a:tr>
+              <a:tr h="756000">
+                <a:tc>
+                  <a:txBody>
+                    <a:bodyPr/>
+                    <a:lstStyle/>
+                    <a:p>
+                      <a:pPr marL="0" marR="0" lvl="0" indent="0" algn="l" defTabSz="914400" rtl="0" eaLnBrk="1" fontAlgn="auto" latinLnBrk="0" hangingPunct="1">
+                        <a:lnSpc>
+                          <a:spcPct val="100000"/>
+                        </a:lnSpc>
+                        <a:spcBef>
+                          <a:spcPts val="0"/>
+                        </a:spcBef>
+                        <a:spcAft>
+                          <a:spcPts val="0"/>
+                        </a:spcAft>
+                        <a:buClrTx/>
+                        <a:buSzTx/>
+                        <a:buFontTx/>
+                        <a:buNone/>
+                        <a:tabLst/>
+                        <a:defRPr/>
+                      </a:pPr>
+                      <a:r>
+                        <a:rPr lang="en-GB" sz="2400" b="1" dirty="0">
+                          <a:latin typeface="Palatino Linotype" panose="02040502050505030304" pitchFamily="18" charset="0"/>
+                        </a:rPr>
+                        <a:t>Recapitulation</a:t>
+                      </a:r>
+                      <a:endParaRPr lang="en-GB" sz="2400" dirty="0">
+                        <a:latin typeface="Palatino Linotype" panose="02040502050505030304" pitchFamily="18" charset="0"/>
+                      </a:endParaRPr>
+                    </a:p>
+                  </a:txBody>
+                  <a:tcPr anchor="ctr">
+                    <a:lnL w="12700" cap="flat" cmpd="sng" algn="ctr">
+                      <a:solidFill>
+                        <a:schemeClr val="tx1"/>
+                      </a:solidFill>
+                      <a:prstDash val="solid"/>
+                      <a:round/>
+                      <a:headEnd type="none" w="med" len="med"/>
+                      <a:tailEnd type="none" w="med" len="med"/>
+                    </a:lnL>
+                    <a:solidFill>
+                      <a:srgbClr val="41FF43"/>
+                    </a:solidFill>
+                  </a:tcPr>
+                </a:tc>
+                <a:tc>
+                  <a:txBody>
+                    <a:bodyPr/>
+                    <a:lstStyle/>
+                    <a:p>
+                      <a:pPr marL="0" marR="0" lvl="0" indent="0" algn="l" defTabSz="914400" rtl="0" eaLnBrk="1" fontAlgn="auto" latinLnBrk="0" hangingPunct="1">
+                        <a:lnSpc>
+                          <a:spcPct val="100000"/>
+                        </a:lnSpc>
+                        <a:spcBef>
+                          <a:spcPts val="0"/>
+                        </a:spcBef>
+                        <a:spcAft>
+                          <a:spcPts val="0"/>
+                        </a:spcAft>
+                        <a:buClrTx/>
+                        <a:buSzTx/>
+                        <a:buFontTx/>
+                        <a:buNone/>
+                        <a:tabLst/>
+                        <a:defRPr/>
+                      </a:pPr>
+                      <a:r>
+                        <a:rPr lang="en-GB" sz="2400" dirty="0">
+                          <a:latin typeface="Palatino Linotype" panose="02040502050505030304" pitchFamily="18" charset="0"/>
+                        </a:rPr>
+                        <a:t>Lyrical return, motifs recalled</a:t>
+                      </a:r>
+                    </a:p>
+                  </a:txBody>
+                  <a:tcPr anchor="ctr">
+                    <a:lnR w="12700" cap="flat" cmpd="sng" algn="ctr">
+                      <a:solidFill>
+                        <a:schemeClr val="tx1"/>
+                      </a:solidFill>
+                      <a:prstDash val="solid"/>
+                      <a:round/>
+                      <a:headEnd type="none" w="med" len="med"/>
+                      <a:tailEnd type="none" w="med" len="med"/>
+                    </a:lnR>
+                    <a:solidFill>
+                      <a:srgbClr val="41FF43"/>
+                    </a:solidFill>
+                  </a:tcPr>
+                </a:tc>
+                <a:extLst>
+                  <a:ext uri="{0D108BD9-81ED-4DB2-BD59-A6C34878D82A}">
+                    <a16:rowId xmlns:a16="http://schemas.microsoft.com/office/drawing/2014/main" val="310607355"/>
+                  </a:ext>
+                </a:extLst>
+              </a:tr>
+              <a:tr h="756000">
+                <a:tc>
+                  <a:txBody>
+                    <a:bodyPr/>
+                    <a:lstStyle/>
+                    <a:p>
+                      <a:pPr marL="0" marR="0" lvl="0" indent="0" algn="l" defTabSz="914400" rtl="0" eaLnBrk="1" fontAlgn="auto" latinLnBrk="0" hangingPunct="1">
+                        <a:lnSpc>
+                          <a:spcPct val="100000"/>
+                        </a:lnSpc>
+                        <a:spcBef>
+                          <a:spcPts val="0"/>
+                        </a:spcBef>
+                        <a:spcAft>
+                          <a:spcPts val="0"/>
+                        </a:spcAft>
+                        <a:buClrTx/>
+                        <a:buSzTx/>
+                        <a:buFontTx/>
+                        <a:buNone/>
+                        <a:tabLst/>
+                        <a:defRPr/>
+                      </a:pPr>
+                      <a:r>
+                        <a:rPr lang="en-GB" sz="2400" b="1" dirty="0">
+                          <a:latin typeface="Palatino Linotype" panose="02040502050505030304" pitchFamily="18" charset="0"/>
+                        </a:rPr>
+                        <a:t>Resolution</a:t>
+                      </a:r>
+                      <a:endParaRPr lang="en-GB" sz="2400" dirty="0">
+                        <a:latin typeface="Palatino Linotype" panose="02040502050505030304" pitchFamily="18" charset="0"/>
+                      </a:endParaRPr>
+                    </a:p>
+                  </a:txBody>
+                  <a:tcPr anchor="ctr">
+                    <a:lnL w="12700" cap="flat" cmpd="sng" algn="ctr">
+                      <a:solidFill>
+                        <a:schemeClr val="tx1"/>
+                      </a:solidFill>
+                      <a:prstDash val="solid"/>
+                      <a:round/>
+                      <a:headEnd type="none" w="med" len="med"/>
+                      <a:tailEnd type="none" w="med" len="med"/>
+                    </a:lnL>
+                    <a:lnB w="12700" cap="flat" cmpd="sng" algn="ctr">
+                      <a:solidFill>
+                        <a:schemeClr val="tx1"/>
+                      </a:solidFill>
+                      <a:prstDash val="solid"/>
+                      <a:round/>
+                      <a:headEnd type="none" w="med" len="med"/>
+                      <a:tailEnd type="none" w="med" len="med"/>
+                    </a:lnB>
+                    <a:solidFill>
+                      <a:srgbClr val="FFFF43"/>
+                    </a:solidFill>
+                  </a:tcPr>
+                </a:tc>
+                <a:tc>
+                  <a:txBody>
+                    <a:bodyPr/>
+                    <a:lstStyle/>
+                    <a:p>
+                      <a:pPr marL="0" marR="0" lvl="0" indent="0" algn="l" defTabSz="914400" rtl="0" eaLnBrk="1" fontAlgn="auto" latinLnBrk="0" hangingPunct="1">
+                        <a:lnSpc>
+                          <a:spcPct val="100000"/>
+                        </a:lnSpc>
+                        <a:spcBef>
+                          <a:spcPts val="0"/>
+                        </a:spcBef>
+                        <a:spcAft>
+                          <a:spcPts val="0"/>
+                        </a:spcAft>
+                        <a:buClrTx/>
+                        <a:buSzTx/>
+                        <a:buFontTx/>
+                        <a:buNone/>
+                        <a:tabLst/>
+                        <a:defRPr/>
+                      </a:pPr>
+                      <a:r>
+                        <a:rPr lang="en-GB" sz="2400" dirty="0">
+                          <a:latin typeface="Palatino Linotype" panose="02040502050505030304" pitchFamily="18" charset="0"/>
+                        </a:rPr>
+                        <a:t>Slowest, long tones, fading out</a:t>
+                      </a:r>
+                    </a:p>
+                  </a:txBody>
+                  <a:tcPr anchor="ctr">
+                    <a:lnR w="12700" cap="flat" cmpd="sng" algn="ctr">
+                      <a:solidFill>
+                        <a:schemeClr val="tx1"/>
+                      </a:solidFill>
+                      <a:prstDash val="solid"/>
+                      <a:round/>
+                      <a:headEnd type="none" w="med" len="med"/>
+                      <a:tailEnd type="none" w="med" len="med"/>
+                    </a:lnR>
+                    <a:lnB w="12700" cap="flat" cmpd="sng" algn="ctr">
+                      <a:solidFill>
+                        <a:schemeClr val="tx1"/>
+                      </a:solidFill>
+                      <a:prstDash val="solid"/>
+                      <a:round/>
+                      <a:headEnd type="none" w="med" len="med"/>
+                      <a:tailEnd type="none" w="med" len="med"/>
+                    </a:lnB>
+                    <a:solidFill>
+                      <a:srgbClr val="FFFF43"/>
+                    </a:solidFill>
+                  </a:tcPr>
+                </a:tc>
+                <a:extLst>
+                  <a:ext uri="{0D108BD9-81ED-4DB2-BD59-A6C34878D82A}">
+                    <a16:rowId xmlns:a16="http://schemas.microsoft.com/office/drawing/2014/main" val="2615115979"/>
+                  </a:ext>
+                </a:extLst>
+              </a:tr>
+            </a:tbl>
+          </a:graphicData>
+        </a:graphic>
+      </p:graphicFrame>
     </p:spTree>
     <p:extLst>
       <p:ext uri="{BB962C8B-B14F-4D97-AF65-F5344CB8AC3E}">
@@ -7166,7 +7526,7 @@
         <p:spPr>
           <a:xfrm>
             <a:off x="838200" y="1274771"/>
-            <a:ext cx="10078844" cy="5018049"/>
+            <a:ext cx="9514490" cy="5018049"/>
           </a:xfrm>
         </p:spPr>
         <p:txBody>
@@ -7415,7 +7775,7 @@
         </p:nvSpPr>
         <p:spPr>
           <a:xfrm>
-            <a:off x="9751962" y="4836848"/>
+            <a:off x="9751962" y="4464375"/>
             <a:ext cx="2264263" cy="1662546"/>
           </a:xfrm>
           <a:prstGeom prst="rect">
@@ -7560,8 +7920,8 @@
         </p:nvSpPr>
         <p:spPr>
           <a:xfrm>
-            <a:off x="2865125" y="761879"/>
-            <a:ext cx="1889760" cy="585216"/>
+            <a:off x="2865125" y="761878"/>
+            <a:ext cx="1889760" cy="842091"/>
           </a:xfrm>
           <a:prstGeom prst="roundRect">
             <a:avLst>
@@ -7642,7 +8002,7 @@
         </p:nvSpPr>
         <p:spPr>
           <a:xfrm>
-            <a:off x="5416430" y="761879"/>
+            <a:off x="5521530" y="761879"/>
             <a:ext cx="2291561" cy="1426629"/>
           </a:xfrm>
           <a:prstGeom prst="roundRect">
@@ -7682,7 +8042,7 @@
         </p:nvSpPr>
         <p:spPr>
           <a:xfrm>
-            <a:off x="5477390" y="761879"/>
+            <a:off x="5582490" y="761879"/>
             <a:ext cx="2197479" cy="583084"/>
           </a:xfrm>
           <a:prstGeom prst="rect">
@@ -7724,8 +8084,8 @@
         </p:nvSpPr>
         <p:spPr>
           <a:xfrm>
-            <a:off x="8410379" y="761879"/>
-            <a:ext cx="3413760" cy="1671258"/>
+            <a:off x="8515479" y="761879"/>
+            <a:ext cx="3066918" cy="1671258"/>
           </a:xfrm>
           <a:prstGeom prst="roundRect">
             <a:avLst>
@@ -7764,8 +8124,8 @@
         </p:nvSpPr>
         <p:spPr>
           <a:xfrm>
-            <a:off x="8471339" y="761878"/>
-            <a:ext cx="3291840" cy="537237"/>
+            <a:off x="8576439" y="761878"/>
+            <a:ext cx="2957385" cy="537237"/>
           </a:xfrm>
           <a:prstGeom prst="rect">
             <a:avLst/>
@@ -7806,8 +8166,8 @@
         </p:nvSpPr>
         <p:spPr>
           <a:xfrm>
-            <a:off x="8776139" y="1328482"/>
-            <a:ext cx="2950464" cy="1134021"/>
+            <a:off x="8650015" y="1296952"/>
+            <a:ext cx="2881918" cy="1134021"/>
           </a:xfrm>
           <a:prstGeom prst="rect">
             <a:avLst/>
@@ -7829,7 +8189,7 @@
                 <a:ea typeface="Calibri" pitchFamily="34" charset="-122"/>
                 <a:cs typeface="Calibri" pitchFamily="34" charset="-120"/>
               </a:rPr>
-              <a:t>contour · density · Q&amp;A type</a:t>
+              <a:t>contour · density · Q&amp;A type · </a:t>
             </a:r>
             <a:br>
               <a:rPr lang="en-US" sz="1600" dirty="0">
@@ -7850,7 +8210,7 @@
                 <a:ea typeface="Calibri" pitchFamily="34" charset="-122"/>
                 <a:cs typeface="Calibri" pitchFamily="34" charset="-120"/>
               </a:rPr>
-              <a:t>swing · dynamics · energy profile</a:t>
+              <a:t>swing · dynamics · energy profile · </a:t>
             </a:r>
             <a:endParaRPr lang="en-US" sz="1600" dirty="0">
               <a:solidFill>
@@ -7870,7 +8230,7 @@
                 <a:ea typeface="Calibri" pitchFamily="34" charset="-122"/>
                 <a:cs typeface="Calibri" pitchFamily="34" charset="-120"/>
               </a:rPr>
-              <a:t>pitch classes · interval motifs lyrical motifs</a:t>
+              <a:t>pitch classes · interval motifs ·  lyrical motifs</a:t>
             </a:r>
             <a:endParaRPr lang="en-US" sz="1600" dirty="0">
               <a:solidFill>
@@ -7889,7 +8249,7 @@
         </p:nvSpPr>
         <p:spPr>
           <a:xfrm>
-            <a:off x="7805528" y="1139298"/>
+            <a:off x="7910628" y="1139298"/>
             <a:ext cx="497224" cy="1"/>
           </a:xfrm>
           <a:prstGeom prst="line">
@@ -7926,7 +8286,7 @@
         </p:nvSpPr>
         <p:spPr>
           <a:xfrm>
-            <a:off x="2389639" y="1803148"/>
+            <a:off x="1932319" y="2153045"/>
             <a:ext cx="2292087" cy="781702"/>
           </a:xfrm>
           <a:prstGeom prst="roundRect">
@@ -7949,7 +8309,7 @@
           <a:lstStyle/>
           <a:p>
             <a:pPr defTabSz="1219170"/>
-            <a:endParaRPr lang="en-US" sz="2400">
+            <a:endParaRPr lang="en-US" sz="2400" dirty="0">
               <a:solidFill>
                 <a:prstClr val="black"/>
               </a:solidFill>
@@ -7966,7 +8326,7 @@
         </p:nvSpPr>
         <p:spPr>
           <a:xfrm>
-            <a:off x="2389637" y="1884683"/>
+            <a:off x="1932317" y="2234580"/>
             <a:ext cx="2292087" cy="353568"/>
           </a:xfrm>
           <a:prstGeom prst="rect">
@@ -8008,8 +8368,8 @@
         </p:nvSpPr>
         <p:spPr>
           <a:xfrm>
-            <a:off x="2987040" y="2199643"/>
-            <a:ext cx="1694688" cy="293138"/>
+            <a:off x="2165140" y="2549540"/>
+            <a:ext cx="2059268" cy="293138"/>
           </a:xfrm>
           <a:prstGeom prst="rect">
             <a:avLst/>
@@ -8031,7 +8391,7 @@
                 <a:ea typeface="Calibri" pitchFamily="34" charset="-122"/>
                 <a:cs typeface="Calibri" pitchFamily="34" charset="-120"/>
               </a:rPr>
-              <a:t>live tempo</a:t>
+              <a:t>live tempo · beat sync</a:t>
             </a:r>
             <a:endParaRPr lang="en-US" sz="1600" dirty="0">
               <a:solidFill>
@@ -8050,7 +8410,7 @@
         </p:nvSpPr>
         <p:spPr>
           <a:xfrm>
-            <a:off x="3566160" y="1391663"/>
+            <a:off x="3566160" y="1685953"/>
             <a:ext cx="0" cy="353568"/>
           </a:xfrm>
           <a:prstGeom prst="line">
@@ -8087,8 +8447,8 @@
         </p:nvSpPr>
         <p:spPr>
           <a:xfrm>
-            <a:off x="4555181" y="2755535"/>
-            <a:ext cx="3291840" cy="1287592"/>
+            <a:off x="4681302" y="2755535"/>
+            <a:ext cx="2960152" cy="1287592"/>
           </a:xfrm>
           <a:prstGeom prst="roundRect">
             <a:avLst>
@@ -8127,8 +8487,8 @@
         </p:nvSpPr>
         <p:spPr>
           <a:xfrm>
-            <a:off x="4616141" y="2842482"/>
-            <a:ext cx="3169920" cy="316992"/>
+            <a:off x="4742262" y="2842482"/>
+            <a:ext cx="2850517" cy="316992"/>
           </a:xfrm>
           <a:prstGeom prst="rect">
             <a:avLst/>
@@ -8169,8 +8529,8 @@
         </p:nvSpPr>
         <p:spPr>
           <a:xfrm>
-            <a:off x="4817309" y="3198094"/>
-            <a:ext cx="2767584" cy="792480"/>
+            <a:off x="4943430" y="3187584"/>
+            <a:ext cx="2488720" cy="792480"/>
           </a:xfrm>
           <a:prstGeom prst="rect">
             <a:avLst/>
@@ -8192,7 +8552,7 @@
                 <a:ea typeface="Calibri" pitchFamily="34" charset="-122"/>
                 <a:cs typeface="Calibri" pitchFamily="34" charset="-120"/>
               </a:rPr>
-              <a:t>stores phrases + motifs</a:t>
+              <a:t>stores phrases + motifs · </a:t>
             </a:r>
             <a:endParaRPr lang="en-US" sz="1600" dirty="0">
               <a:solidFill>
@@ -8212,7 +8572,7 @@
                 <a:ea typeface="Calibri" pitchFamily="34" charset="-122"/>
                 <a:cs typeface="Calibri" pitchFamily="34" charset="-120"/>
               </a:rPr>
-              <a:t>stores lyrical motifs</a:t>
+              <a:t>stores lyrical motifs · </a:t>
             </a:r>
             <a:endParaRPr lang="en-US" sz="1600" dirty="0">
               <a:solidFill>
@@ -8287,8 +8647,8 @@
         </p:nvSpPr>
         <p:spPr>
           <a:xfrm>
-            <a:off x="7912608" y="3432201"/>
-            <a:ext cx="926592" cy="0"/>
+            <a:off x="7779968" y="3432201"/>
+            <a:ext cx="1059232" cy="0"/>
           </a:xfrm>
           <a:prstGeom prst="line">
             <a:avLst/>
@@ -8324,8 +8684,8 @@
         </p:nvSpPr>
         <p:spPr>
           <a:xfrm>
-            <a:off x="3566160" y="2734336"/>
-            <a:ext cx="0" cy="697865"/>
+            <a:off x="3555435" y="3040903"/>
+            <a:ext cx="10725" cy="391298"/>
           </a:xfrm>
           <a:prstGeom prst="line">
             <a:avLst/>
@@ -8361,7 +8721,7 @@
         <p:spPr>
           <a:xfrm>
             <a:off x="3555436" y="3432201"/>
-            <a:ext cx="894643" cy="0"/>
+            <a:ext cx="985033" cy="0"/>
           </a:xfrm>
           <a:prstGeom prst="line">
             <a:avLst/>
@@ -8502,67 +8862,7 @@
                 <a:ea typeface="Calibri" pitchFamily="34" charset="-122"/>
                 <a:cs typeface="Calibri" pitchFamily="34" charset="-120"/>
               </a:rPr>
-              <a:t>5-min performance arc  ·  leadership &amp; proactive mode</a:t>
-            </a:r>
-            <a:endParaRPr lang="en-US" sz="1600" dirty="0">
-              <a:solidFill>
-                <a:prstClr val="black"/>
-              </a:solidFill>
-              <a:latin typeface="Calibri" panose="020F0502020204030204"/>
-            </a:endParaRPr>
-          </a:p>
-          <a:p>
-            <a:pPr defTabSz="1219170"/>
-            <a:r>
-              <a:rPr lang="en-US" sz="1600" dirty="0">
-                <a:solidFill>
-                  <a:srgbClr val="CADCFC"/>
-                </a:solidFill>
-                <a:latin typeface="Calibri" pitchFamily="34" charset="0"/>
-                <a:ea typeface="Calibri" pitchFamily="34" charset="-122"/>
-                <a:cs typeface="Calibri" pitchFamily="34" charset="-120"/>
-              </a:rPr>
-              <a:t>bass pitch-class tracking  ·  energy arc selection</a:t>
-            </a:r>
-            <a:endParaRPr lang="en-US" sz="1600" dirty="0">
-              <a:solidFill>
-                <a:prstClr val="black"/>
-              </a:solidFill>
-              <a:latin typeface="Calibri" panose="020F0502020204030204"/>
-            </a:endParaRPr>
-          </a:p>
-          <a:p>
-            <a:pPr defTabSz="1219170"/>
-            <a:r>
-              <a:rPr lang="en-US" sz="1600" dirty="0">
-                <a:solidFill>
-                  <a:srgbClr val="CADCFC"/>
-                </a:solidFill>
-                <a:latin typeface="Calibri" pitchFamily="34" charset="0"/>
-                <a:ea typeface="Calibri" pitchFamily="34" charset="-122"/>
-                <a:cs typeface="Calibri" pitchFamily="34" charset="-120"/>
-              </a:rPr>
-              <a:t>motif + lyrical motif selection  ·  register contrast scheduling</a:t>
-            </a:r>
-            <a:endParaRPr lang="en-US" sz="1600" dirty="0">
-              <a:solidFill>
-                <a:prstClr val="black"/>
-              </a:solidFill>
-              <a:latin typeface="Calibri" panose="020F0502020204030204"/>
-            </a:endParaRPr>
-          </a:p>
-          <a:p>
-            <a:pPr defTabSz="1219170"/>
-            <a:r>
-              <a:rPr lang="en-US" sz="1600" dirty="0">
-                <a:solidFill>
-                  <a:srgbClr val="CADCFC"/>
-                </a:solidFill>
-                <a:latin typeface="Calibri" pitchFamily="34" charset="0"/>
-                <a:ea typeface="Calibri" pitchFamily="34" charset="-122"/>
-                <a:cs typeface="Calibri" pitchFamily="34" charset="-120"/>
-              </a:rPr>
-              <a:t>rhythmic density + complementarity  ·  stage swing baseline</a:t>
+              <a:t>5-min performance arc  ·  leadership · proactive mode · bass pitch-class tracking  ·  energy arc selection · motif + lyrical motif selection  ·  register contrast scheduling · rhythmic density + complementarity  ·  stage swing baseline · opening echo</a:t>
             </a:r>
             <a:endParaRPr lang="en-US" sz="1600" dirty="0">
               <a:solidFill>
@@ -8753,8 +9053,8 @@
         </p:nvSpPr>
         <p:spPr>
           <a:xfrm>
-            <a:off x="5692404" y="1278995"/>
-            <a:ext cx="1463459" cy="876298"/>
+            <a:off x="5648890" y="1278995"/>
+            <a:ext cx="2131078" cy="876298"/>
           </a:xfrm>
           <a:prstGeom prst="rect">
             <a:avLst/>
@@ -8776,35 +9076,7 @@
                 <a:ea typeface="Calibri" pitchFamily="34" charset="-122"/>
                 <a:cs typeface="Calibri" pitchFamily="34" charset="-120"/>
               </a:rPr>
-              <a:t>pitch range</a:t>
-            </a:r>
-          </a:p>
-          <a:p>
-            <a:pPr defTabSz="1219170"/>
-            <a:r>
-              <a:rPr lang="en-US" sz="1600" dirty="0">
-                <a:solidFill>
-                  <a:srgbClr val="CADCFC"/>
-                </a:solidFill>
-                <a:latin typeface="Calibri" pitchFamily="34" charset="0"/>
-                <a:ea typeface="Calibri" pitchFamily="34" charset="-122"/>
-                <a:cs typeface="Calibri" pitchFamily="34" charset="-120"/>
-              </a:rPr>
-              <a:t>velocity min</a:t>
-            </a:r>
-          </a:p>
-          <a:p>
-            <a:pPr defTabSz="1219170"/>
-            <a:r>
-              <a:rPr lang="en-US" sz="1600" dirty="0">
-                <a:solidFill>
-                  <a:srgbClr val="CADCFC"/>
-                </a:solidFill>
-                <a:latin typeface="Calibri" pitchFamily="34" charset="0"/>
-                <a:ea typeface="Calibri" pitchFamily="34" charset="-122"/>
-                <a:cs typeface="Calibri" pitchFamily="34" charset="-120"/>
-              </a:rPr>
-              <a:t>note dur min</a:t>
+              <a:t>note dur min · min phrase notes · monophony · watchdog</a:t>
             </a:r>
             <a:endParaRPr lang="en-US" sz="1600" dirty="0">
               <a:solidFill>
@@ -8992,6 +9264,54 @@
           <a:p>
             <a:pPr defTabSz="1219170"/>
             <a:endParaRPr lang="en-US" sz="2400">
+              <a:solidFill>
+                <a:prstClr val="black"/>
+              </a:solidFill>
+              <a:latin typeface="Calibri" panose="020F0502020204030204"/>
+            </a:endParaRPr>
+          </a:p>
+        </p:txBody>
+      </p:sp>
+      <p:sp>
+        <p:nvSpPr>
+          <p:cNvPr id="36" name="Text 10">
+            <a:extLst>
+              <a:ext uri="{FF2B5EF4-FFF2-40B4-BE49-F238E27FC236}">
+                <a16:creationId xmlns:a16="http://schemas.microsoft.com/office/drawing/2014/main" id="{FE21DA54-651E-97F3-FCC2-BDEA980E4775}"/>
+              </a:ext>
+            </a:extLst>
+          </p:cNvPr>
+          <p:cNvSpPr/>
+          <p:nvPr/>
+        </p:nvSpPr>
+        <p:spPr>
+          <a:xfrm>
+            <a:off x="2959931" y="1242111"/>
+            <a:ext cx="1892489" cy="876298"/>
+          </a:xfrm>
+          <a:prstGeom prst="rect">
+            <a:avLst/>
+          </a:prstGeom>
+          <a:noFill/>
+          <a:ln/>
+        </p:spPr>
+        <p:txBody>
+          <a:bodyPr wrap="square" lIns="33867" tIns="33867" rIns="33867" bIns="33867" rtlCol="0" anchor="t"/>
+          <a:lstStyle/>
+          <a:p>
+            <a:pPr defTabSz="1219170"/>
+            <a:r>
+              <a:rPr lang="en-US" sz="1600" dirty="0">
+                <a:solidFill>
+                  <a:srgbClr val="CADCFC"/>
+                </a:solidFill>
+                <a:latin typeface="Calibri" pitchFamily="34" charset="0"/>
+                <a:ea typeface="Calibri" pitchFamily="34" charset="-122"/>
+                <a:cs typeface="Calibri" pitchFamily="34" charset="-120"/>
+              </a:rPr>
+              <a:t>pitch range · vel min</a:t>
+            </a:r>
+            <a:endParaRPr lang="en-US" sz="1600" dirty="0">
               <a:solidFill>
                 <a:prstClr val="black"/>
               </a:solidFill>
@@ -9083,7 +9403,7 @@
         </p:nvSpPr>
         <p:spPr>
           <a:xfrm>
-            <a:off x="3258571" y="681983"/>
+            <a:off x="3246605" y="419226"/>
             <a:ext cx="2767053" cy="536448"/>
           </a:xfrm>
           <a:prstGeom prst="roundRect">
@@ -9123,7 +9443,7 @@
         </p:nvSpPr>
         <p:spPr>
           <a:xfrm>
-            <a:off x="2447537" y="681983"/>
+            <a:off x="2435571" y="419226"/>
             <a:ext cx="4389120" cy="536448"/>
           </a:xfrm>
           <a:prstGeom prst="rect">
@@ -9165,7 +9485,7 @@
         </p:nvSpPr>
         <p:spPr>
           <a:xfrm>
-            <a:off x="2431901" y="1663639"/>
+            <a:off x="2419935" y="1558539"/>
             <a:ext cx="4420393" cy="717212"/>
           </a:xfrm>
           <a:prstGeom prst="roundRect">
@@ -9205,7 +9525,7 @@
         </p:nvSpPr>
         <p:spPr>
           <a:xfrm>
-            <a:off x="2874257" y="1746866"/>
+            <a:off x="2862291" y="1641766"/>
             <a:ext cx="3535680" cy="316992"/>
           </a:xfrm>
           <a:prstGeom prst="rect">
@@ -9247,7 +9567,7 @@
         </p:nvSpPr>
         <p:spPr>
           <a:xfrm>
-            <a:off x="2548256" y="2063329"/>
+            <a:off x="2536290" y="1947719"/>
             <a:ext cx="4187683" cy="268224"/>
           </a:xfrm>
           <a:prstGeom prst="rect">
@@ -9260,7 +9580,7 @@
           <a:bodyPr wrap="square" lIns="33867" tIns="33867" rIns="33867" bIns="33867" rtlCol="0" anchor="t"/>
           <a:lstStyle/>
           <a:p>
-            <a:pPr defTabSz="1219170"/>
+            <a:pPr algn="ctr" defTabSz="1219170"/>
             <a:r>
               <a:rPr lang="en-US" sz="1600" dirty="0">
                 <a:solidFill>
@@ -9270,7 +9590,7 @@
                 <a:ea typeface="Calibri" pitchFamily="34" charset="-122"/>
                 <a:cs typeface="Calibri" pitchFamily="34" charset="-120"/>
               </a:rPr>
-              <a:t>mode, progression, pedal, tritone substitution</a:t>
+              <a:t>mode · progression · pedal · tritone substitution</a:t>
             </a:r>
             <a:endParaRPr lang="en-US" sz="1600" dirty="0">
               <a:solidFill>
@@ -9289,8 +9609,8 @@
         </p:nvSpPr>
         <p:spPr>
           <a:xfrm>
-            <a:off x="1177808" y="2808994"/>
-            <a:ext cx="6928578" cy="1786648"/>
+            <a:off x="1385103" y="2703894"/>
+            <a:ext cx="6490056" cy="1786648"/>
           </a:xfrm>
           <a:prstGeom prst="roundRect">
             <a:avLst>
@@ -9329,8 +9649,8 @@
         </p:nvSpPr>
         <p:spPr>
           <a:xfrm>
-            <a:off x="1233684" y="2877369"/>
-            <a:ext cx="6816827" cy="316992"/>
+            <a:off x="1437442" y="2772269"/>
+            <a:ext cx="6385378" cy="316992"/>
           </a:xfrm>
           <a:prstGeom prst="rect">
             <a:avLst/>
@@ -9371,8 +9691,8 @@
         </p:nvSpPr>
         <p:spPr>
           <a:xfrm>
-            <a:off x="1442987" y="3193004"/>
-            <a:ext cx="6398220" cy="1279645"/>
+            <a:off x="1580383" y="3121305"/>
+            <a:ext cx="6242437" cy="1279645"/>
           </a:xfrm>
           <a:prstGeom prst="rect">
             <a:avLst/>
@@ -9394,7 +9714,7 @@
                 <a:ea typeface="Calibri" pitchFamily="34" charset="-122"/>
                 <a:cs typeface="Calibri" pitchFamily="34" charset="-120"/>
               </a:rPr>
-              <a:t>LSTM + chord conditioning  ·  pitch range limits · register gravity</a:t>
+              <a:t>LSTM · chord conditioning  · pitch range limits · register gravity · </a:t>
             </a:r>
             <a:endParaRPr lang="en-US" sz="1600" dirty="0">
               <a:solidFill>
@@ -9414,7 +9734,7 @@
                 <a:ea typeface="Calibri" pitchFamily="34" charset="-122"/>
                 <a:cs typeface="Calibri" pitchFamily="34" charset="-120"/>
               </a:rPr>
-              <a:t>register contrast  ·  scale pitch bias  ·  contour steering · swing/triplet bias </a:t>
+              <a:t>register contrast  ·  scale pitch bias  ·  contour steering · swing/triplet bias · energy arc shaping · long-note penalty · singable duration bias  ·  motivic development · voice leading  ·  modal leap · bonus (P4/P5)  ·  repetition penalty · rest injection  ·  beat accumulator</a:t>
             </a:r>
             <a:endParaRPr lang="en-US" sz="1600" dirty="0">
               <a:solidFill>
@@ -9423,47 +9743,6 @@
               <a:latin typeface="Calibri" panose="020F0502020204030204"/>
             </a:endParaRPr>
           </a:p>
-          <a:p>
-            <a:pPr defTabSz="1219170"/>
-            <a:r>
-              <a:rPr lang="en-US" sz="1600" dirty="0">
-                <a:solidFill>
-                  <a:srgbClr val="CADCFC"/>
-                </a:solidFill>
-                <a:latin typeface="Calibri" pitchFamily="34" charset="0"/>
-                <a:ea typeface="Calibri" pitchFamily="34" charset="-122"/>
-                <a:cs typeface="Calibri" pitchFamily="34" charset="-120"/>
-              </a:rPr>
-              <a:t>energy arc shaping swing/triplet bias · long-note penalty</a:t>
-            </a:r>
-            <a:br>
-              <a:rPr lang="en-US" sz="1600" dirty="0">
-                <a:solidFill>
-                  <a:srgbClr val="CADCFC"/>
-                </a:solidFill>
-                <a:latin typeface="Calibri" pitchFamily="34" charset="0"/>
-                <a:ea typeface="Calibri" pitchFamily="34" charset="-122"/>
-                <a:cs typeface="Calibri" pitchFamily="34" charset="-120"/>
-              </a:rPr>
-            </a:br>
-            <a:r>
-              <a:rPr lang="en-US" sz="1600" dirty="0">
-                <a:solidFill>
-                  <a:srgbClr val="CADCFC"/>
-                </a:solidFill>
-                <a:latin typeface="Calibri" pitchFamily="34" charset="0"/>
-                <a:ea typeface="Calibri" pitchFamily="34" charset="-122"/>
-                <a:cs typeface="Calibri" pitchFamily="34" charset="-120"/>
-              </a:rPr>
-              <a:t>singable duration bias  ·  motivic development · voice leading  ·  modal leap bonus (P4/P5)  ·  repetition penalty · rest injection  ·  beat accumulator</a:t>
-            </a:r>
-            <a:endParaRPr lang="en-US" sz="1600" dirty="0">
-              <a:solidFill>
-                <a:prstClr val="black"/>
-              </a:solidFill>
-              <a:latin typeface="Calibri" panose="020F0502020204030204"/>
-            </a:endParaRPr>
-          </a:p>
         </p:txBody>
       </p:sp>
       <p:sp>
@@ -9474,7 +9753,7 @@
         </p:nvSpPr>
         <p:spPr>
           <a:xfrm>
-            <a:off x="644533" y="5114147"/>
+            <a:off x="644533" y="5009047"/>
             <a:ext cx="2129360" cy="1114235"/>
           </a:xfrm>
           <a:prstGeom prst="roundRect">
@@ -9514,7 +9793,7 @@
         </p:nvSpPr>
         <p:spPr>
           <a:xfrm>
-            <a:off x="438329" y="5208720"/>
+            <a:off x="438329" y="5103620"/>
             <a:ext cx="2560320" cy="316992"/>
           </a:xfrm>
           <a:prstGeom prst="rect">
@@ -9556,8 +9835,8 @@
         </p:nvSpPr>
         <p:spPr>
           <a:xfrm>
-            <a:off x="832714" y="5574480"/>
-            <a:ext cx="2129359" cy="560832"/>
+            <a:off x="1051035" y="5469380"/>
+            <a:ext cx="1405880" cy="560832"/>
           </a:xfrm>
           <a:prstGeom prst="rect">
             <a:avLst/>
@@ -9579,7 +9858,7 @@
                 <a:ea typeface="Calibri" pitchFamily="34" charset="-122"/>
                 <a:cs typeface="Calibri" pitchFamily="34" charset="-120"/>
               </a:rPr>
-              <a:t>Motifs · recall</a:t>
+              <a:t>motifs · recall · </a:t>
             </a:r>
             <a:endParaRPr lang="en-US" sz="1600" dirty="0">
               <a:solidFill>
@@ -9618,7 +9897,7 @@
         </p:nvSpPr>
         <p:spPr>
           <a:xfrm>
-            <a:off x="3310872" y="5103546"/>
+            <a:off x="3310872" y="4998446"/>
             <a:ext cx="3291840" cy="1193225"/>
           </a:xfrm>
           <a:prstGeom prst="roundRect">
@@ -9658,7 +9937,7 @@
         </p:nvSpPr>
         <p:spPr>
           <a:xfrm>
-            <a:off x="3371832" y="5362976"/>
+            <a:off x="3371832" y="5257876"/>
             <a:ext cx="3169920" cy="316992"/>
           </a:xfrm>
           <a:prstGeom prst="rect">
@@ -9722,7 +10001,7 @@
         </p:nvSpPr>
         <p:spPr>
           <a:xfrm>
-            <a:off x="3495872" y="5890195"/>
+            <a:off x="3495872" y="5785095"/>
             <a:ext cx="2921840" cy="426720"/>
           </a:xfrm>
           <a:prstGeom prst="rect">
@@ -9764,7 +10043,7 @@
         </p:nvSpPr>
         <p:spPr>
           <a:xfrm>
-            <a:off x="8697712" y="2360827"/>
+            <a:off x="8700962" y="2360827"/>
             <a:ext cx="2316480" cy="1598485"/>
           </a:xfrm>
           <a:prstGeom prst="roundRect">
@@ -9804,7 +10083,7 @@
         </p:nvSpPr>
         <p:spPr>
           <a:xfrm>
-            <a:off x="8754696" y="2550995"/>
+            <a:off x="8761922" y="2550995"/>
             <a:ext cx="2194560" cy="488042"/>
           </a:xfrm>
           <a:prstGeom prst="rect">
@@ -9846,7 +10125,7 @@
         </p:nvSpPr>
         <p:spPr>
           <a:xfrm>
-            <a:off x="8916298" y="3096865"/>
+            <a:off x="8916298" y="3117885"/>
             <a:ext cx="2000358" cy="779017"/>
           </a:xfrm>
           <a:prstGeom prst="rect">
@@ -9911,7 +10190,7 @@
         </p:nvSpPr>
         <p:spPr>
           <a:xfrm>
-            <a:off x="8704213" y="4451332"/>
+            <a:off x="8700962" y="4451332"/>
             <a:ext cx="2316480" cy="998153"/>
           </a:xfrm>
           <a:prstGeom prst="roundRect">
@@ -9951,7 +10230,7 @@
         </p:nvSpPr>
         <p:spPr>
           <a:xfrm>
-            <a:off x="8765173" y="4545904"/>
+            <a:off x="8761922" y="4545904"/>
             <a:ext cx="2194560" cy="316992"/>
           </a:xfrm>
           <a:prstGeom prst="rect">
@@ -10035,7 +10314,7 @@
         </p:nvSpPr>
         <p:spPr>
           <a:xfrm>
-            <a:off x="9980858" y="5905979"/>
+            <a:off x="9929019" y="5905979"/>
             <a:ext cx="1488263" cy="438912"/>
           </a:xfrm>
           <a:prstGeom prst="roundRect">
@@ -10075,7 +10354,7 @@
         </p:nvSpPr>
         <p:spPr>
           <a:xfrm>
-            <a:off x="9842520" y="5905979"/>
+            <a:off x="9800480" y="5905979"/>
             <a:ext cx="1745341" cy="438912"/>
           </a:xfrm>
           <a:prstGeom prst="rect">
@@ -10117,7 +10396,7 @@
         </p:nvSpPr>
         <p:spPr>
           <a:xfrm>
-            <a:off x="4956792" y="4854401"/>
+            <a:off x="4630131" y="4749301"/>
             <a:ext cx="0" cy="60960"/>
           </a:xfrm>
           <a:prstGeom prst="line">
@@ -10153,7 +10432,7 @@
         </p:nvSpPr>
         <p:spPr>
           <a:xfrm>
-            <a:off x="1808074" y="4711280"/>
+            <a:off x="1808074" y="4606180"/>
             <a:ext cx="1" cy="335547"/>
           </a:xfrm>
           <a:prstGeom prst="line">
@@ -10190,7 +10469,7 @@
         </p:nvSpPr>
         <p:spPr>
           <a:xfrm>
-            <a:off x="4956792" y="4677107"/>
+            <a:off x="4630131" y="4572007"/>
             <a:ext cx="0" cy="339506"/>
           </a:xfrm>
           <a:prstGeom prst="line">
@@ -10233,7 +10512,7 @@
         </p:nvSpPr>
         <p:spPr>
           <a:xfrm flipH="1">
-            <a:off x="9757849" y="4062775"/>
+            <a:off x="9855402" y="4062775"/>
             <a:ext cx="7600" cy="323365"/>
           </a:xfrm>
           <a:prstGeom prst="line">
@@ -10276,7 +10555,7 @@
         </p:nvSpPr>
         <p:spPr>
           <a:xfrm>
-            <a:off x="10724802" y="5507313"/>
+            <a:off x="10673150" y="5507313"/>
             <a:ext cx="0" cy="340838"/>
           </a:xfrm>
           <a:prstGeom prst="line">
@@ -10307,10 +10586,10 @@
       </p:sp>
       <p:sp>
         <p:nvSpPr>
-          <p:cNvPr id="39" name="Shape 31">
+          <p:cNvPr id="40" name="Shape 31">
             <a:extLst>
               <a:ext uri="{FF2B5EF4-FFF2-40B4-BE49-F238E27FC236}">
-                <a16:creationId xmlns:a16="http://schemas.microsoft.com/office/drawing/2014/main" id="{75C8DDBB-FB84-20C6-A810-B200A3A2F6C0}"/>
+                <a16:creationId xmlns:a16="http://schemas.microsoft.com/office/drawing/2014/main" id="{87FC4B10-340A-6F3B-E434-9066D920521B}"/>
               </a:ext>
             </a:extLst>
           </p:cNvPr>
@@ -10319,8 +10598,8 @@
         </p:nvSpPr>
         <p:spPr>
           <a:xfrm>
-            <a:off x="4642097" y="1302513"/>
-            <a:ext cx="0" cy="310630"/>
+            <a:off x="4630131" y="2363243"/>
+            <a:ext cx="0" cy="298611"/>
           </a:xfrm>
           <a:prstGeom prst="line">
             <a:avLst/>
@@ -10350,10 +10629,10 @@
       </p:sp>
       <p:sp>
         <p:nvSpPr>
-          <p:cNvPr id="40" name="Shape 31">
+          <p:cNvPr id="2" name="Shape 13">
             <a:extLst>
               <a:ext uri="{FF2B5EF4-FFF2-40B4-BE49-F238E27FC236}">
-                <a16:creationId xmlns:a16="http://schemas.microsoft.com/office/drawing/2014/main" id="{87FC4B10-340A-6F3B-E434-9066D920521B}"/>
+                <a16:creationId xmlns:a16="http://schemas.microsoft.com/office/drawing/2014/main" id="{C7B5150A-7B3C-0DF6-D272-7A58E5994619}"/>
               </a:ext>
             </a:extLst>
           </p:cNvPr>
@@ -10361,52 +10640,9 @@
           <p:nvPr/>
         </p:nvSpPr>
         <p:spPr>
-          <a:xfrm>
-            <a:off x="4642097" y="2468343"/>
-            <a:ext cx="0" cy="298611"/>
-          </a:xfrm>
-          <a:prstGeom prst="line">
-            <a:avLst/>
-          </a:prstGeom>
-          <a:noFill/>
-          <a:ln w="50800">
-            <a:solidFill>
-              <a:srgbClr val="CADCFC"/>
-            </a:solidFill>
-            <a:prstDash val="solid"/>
-            <a:tailEnd type="arrow"/>
-          </a:ln>
-        </p:spPr>
-        <p:txBody>
-          <a:bodyPr/>
-          <a:lstStyle/>
-          <a:p>
-            <a:pPr defTabSz="1219170"/>
-            <a:endParaRPr lang="en-US" sz="3200">
-              <a:solidFill>
-                <a:prstClr val="black"/>
-              </a:solidFill>
-              <a:latin typeface="Calibri" panose="020F0502020204030204"/>
-            </a:endParaRPr>
-          </a:p>
-        </p:txBody>
-      </p:sp>
-      <p:sp>
-        <p:nvSpPr>
-          <p:cNvPr id="2" name="Shape 13">
-            <a:extLst>
-              <a:ext uri="{FF2B5EF4-FFF2-40B4-BE49-F238E27FC236}">
-                <a16:creationId xmlns:a16="http://schemas.microsoft.com/office/drawing/2014/main" id="{C7B5150A-7B3C-0DF6-D272-7A58E5994619}"/>
-              </a:ext>
-            </a:extLst>
-          </p:cNvPr>
-          <p:cNvSpPr/>
-          <p:nvPr/>
-        </p:nvSpPr>
-        <p:spPr>
-          <a:xfrm>
-            <a:off x="8218597" y="3341506"/>
-            <a:ext cx="346428" cy="0"/>
+          <a:xfrm flipV="1">
+            <a:off x="8050511" y="3236406"/>
+            <a:ext cx="514514" cy="784"/>
           </a:xfrm>
           <a:prstGeom prst="line">
             <a:avLst/>
@@ -10494,7 +10730,7 @@
         </p:nvSpPr>
         <p:spPr>
           <a:xfrm>
-            <a:off x="8360281" y="5905979"/>
+            <a:off x="8365304" y="5905979"/>
             <a:ext cx="1374805" cy="438912"/>
           </a:xfrm>
           <a:prstGeom prst="rect">
@@ -10542,7 +10778,7 @@
         </p:nvSpPr>
         <p:spPr>
           <a:xfrm>
-            <a:off x="9036339" y="5507313"/>
+            <a:off x="9052706" y="5507313"/>
             <a:ext cx="0" cy="340838"/>
           </a:xfrm>
           <a:prstGeom prst="line">
@@ -10585,8 +10821,8 @@
         </p:nvSpPr>
         <p:spPr>
           <a:xfrm>
-            <a:off x="4642097" y="92503"/>
-            <a:ext cx="0" cy="476909"/>
+            <a:off x="4630131" y="1092311"/>
+            <a:ext cx="0" cy="338954"/>
           </a:xfrm>
           <a:prstGeom prst="line">
             <a:avLst/>
@@ -10701,7 +10937,7 @@
         </p:blipFill>
         <p:spPr>
           <a:xfrm>
-            <a:off x="6140340" y="1355491"/>
+            <a:off x="6140340" y="1429062"/>
             <a:ext cx="5470057" cy="4147015"/>
           </a:xfrm>
           <a:prstGeom prst="rect">
@@ -10731,7 +10967,7 @@
         </p:blipFill>
         <p:spPr>
           <a:xfrm>
-            <a:off x="964580" y="1355492"/>
+            <a:off x="964580" y="1429063"/>
             <a:ext cx="4831664" cy="4147015"/>
           </a:xfrm>
           <a:prstGeom prst="rect">
@@ -10829,13 +11065,13 @@
         </p:nvSpPr>
         <p:spPr>
           <a:xfrm>
-            <a:off x="838200" y="903249"/>
-            <a:ext cx="10515600" cy="5273714"/>
+            <a:off x="838199" y="903249"/>
+            <a:ext cx="8400393" cy="5273714"/>
           </a:xfrm>
         </p:spPr>
         <p:txBody>
           <a:bodyPr>
-            <a:normAutofit/>
+            <a:normAutofit fontScale="92500"/>
           </a:bodyPr>
           <a:lstStyle/>
           <a:p>
@@ -11001,7 +11237,28 @@
               <a:rPr lang="en-US" sz="2200" dirty="0">
                 <a:latin typeface="Palatino Linotype" panose="02040502050505030304" pitchFamily="18" charset="0"/>
               </a:rPr>
-              <a:t>Wolfson Digital Research Cluster (for AIMC 2024)</a:t>
+              <a:t>Ada Lovelace &amp; Emily Howard (for Numbers into Notes)</a:t>
+            </a:r>
+          </a:p>
+          <a:p>
+            <a:pPr lvl="1"/>
+            <a:r>
+              <a:rPr lang="en-US" sz="2200" dirty="0">
+                <a:latin typeface="Palatino Linotype" panose="02040502050505030304" pitchFamily="18" charset="0"/>
+              </a:rPr>
+              <a:t>Wolfson Digital Research Cluster, </a:t>
+            </a:r>
+            <a:r>
+              <a:rPr lang="en-US" sz="2200" dirty="0" err="1">
+                <a:latin typeface="Palatino Linotype" panose="02040502050505030304" pitchFamily="18" charset="0"/>
+              </a:rPr>
+              <a:t>DiSc</a:t>
+            </a:r>
+            <a:r>
+              <a:rPr lang="en-US" sz="2200" dirty="0">
+                <a:latin typeface="Palatino Linotype" panose="02040502050505030304" pitchFamily="18" charset="0"/>
+              </a:rPr>
+              <a:t> &amp; TORCH (for AIMC 2024)</a:t>
             </a:r>
           </a:p>
           <a:p>

</xml_diff>

<commit_message>
docs: update presentation slides and man page PDF
Co-Authored-By: Claude Sonnet 4.6 <noreply@anthropic.com>
</commit_message>
<xml_diff>
--- a/docs/wolfson.pptx
+++ b/docs/wolfson.pptx
@@ -880,7 +880,7 @@
           <a:bodyPr/>
           <a:lstStyle/>
           <a:p>
-            <a:endParaRPr lang="en-US"/>
+            <a:endParaRPr lang="en-US" dirty="0"/>
           </a:p>
         </p:txBody>
       </p:sp>
@@ -5167,43 +5167,43 @@
         </p:nvSpPr>
         <p:spPr>
           <a:xfrm>
-            <a:off x="1524000" y="499326"/>
+            <a:off x="1524000" y="772597"/>
             <a:ext cx="9144000" cy="2563187"/>
           </a:xfrm>
         </p:spPr>
         <p:txBody>
           <a:bodyPr>
-            <a:normAutofit/>
+            <a:normAutofit fontScale="90000"/>
           </a:bodyPr>
           <a:lstStyle/>
           <a:p>
             <a:pPr>
               <a:lnSpc>
-                <a:spcPct val="110000"/>
+                <a:spcPct val="130000"/>
               </a:lnSpc>
             </a:pPr>
             <a:r>
+              <a:rPr lang="en-GB" sz="5300" dirty="0">
+                <a:latin typeface="Optima" panose="02000503060000020004" pitchFamily="2" charset="0"/>
+              </a:rPr>
+              <a:t>README</a:t>
+            </a:r>
+            <a:br>
               <a:rPr lang="en-GB" sz="4800" dirty="0">
                 <a:latin typeface="Optima" panose="02000503060000020004" pitchFamily="2" charset="0"/>
               </a:rPr>
-              <a:t>P</a:t>
-            </a:r>
+            </a:br>
             <a:r>
               <a:rPr lang="en-GB" sz="4400" dirty="0">
                 <a:latin typeface="Optima" panose="02000503060000020004" pitchFamily="2" charset="0"/>
               </a:rPr>
-              <a:t>ost-bop modal-tonal</a:t>
-            </a:r>
-            <a:br>
-              <a:rPr lang="en-GB" sz="4400" dirty="0">
+              <a:t>P</a:t>
+            </a:r>
+            <a:r>
+              <a:rPr lang="en-GB" sz="4000" dirty="0">
                 <a:latin typeface="Optima" panose="02000503060000020004" pitchFamily="2" charset="0"/>
               </a:rPr>
-            </a:br>
-            <a:r>
-              <a:rPr lang="en-GB" sz="4400" dirty="0">
-                <a:latin typeface="Optima" panose="02000503060000020004" pitchFamily="2" charset="0"/>
-              </a:rPr>
-              <a:t>AI jazz improvisation</a:t>
+              <a:t>ost-bop modal-tonal AI jazz improvisation</a:t>
             </a:r>
             <a:br>
               <a:rPr lang="en-GB" sz="4400" dirty="0">
@@ -5245,7 +5245,7 @@
         </p:nvSpPr>
         <p:spPr>
           <a:xfrm>
-            <a:off x="1524000" y="3529541"/>
+            <a:off x="1524000" y="3907912"/>
             <a:ext cx="9144000" cy="1082040"/>
           </a:xfrm>
         </p:spPr>
@@ -5309,7 +5309,7 @@
         </p:blipFill>
         <p:spPr bwMode="auto">
           <a:xfrm>
-            <a:off x="5261606" y="4643512"/>
+            <a:off x="5261606" y="5021883"/>
             <a:ext cx="1668788" cy="1668788"/>
           </a:xfrm>
           <a:prstGeom prst="rect">
@@ -5356,191 +5356,25 @@
       </p:grpSpPr>
       <p:sp>
         <p:nvSpPr>
-          <p:cNvPr id="2" name="Title 1">
+          <p:cNvPr id="10" name="Rectangle 9">
             <a:extLst>
               <a:ext uri="{FF2B5EF4-FFF2-40B4-BE49-F238E27FC236}">
-                <a16:creationId xmlns:a16="http://schemas.microsoft.com/office/drawing/2014/main" id="{9D13241A-102A-3C3B-86F2-2AD6434B3D97}"/>
+                <a16:creationId xmlns:a16="http://schemas.microsoft.com/office/drawing/2014/main" id="{4AD0A14B-CE5A-5EE7-E773-A86177200389}"/>
               </a:ext>
             </a:extLst>
           </p:cNvPr>
-          <p:cNvSpPr>
-            <a:spLocks noGrp="1"/>
-          </p:cNvSpPr>
-          <p:nvPr>
-            <p:ph type="title"/>
-          </p:nvPr>
-        </p:nvSpPr>
-        <p:spPr>
-          <a:xfrm>
-            <a:off x="838200" y="365125"/>
-            <a:ext cx="10515600" cy="805753"/>
-          </a:xfrm>
-        </p:spPr>
-        <p:txBody>
-          <a:bodyPr/>
-          <a:lstStyle/>
-          <a:p>
-            <a:r>
-              <a:rPr lang="en-US" dirty="0">
-                <a:latin typeface="Garamond" panose="02020404030301010803" pitchFamily="18" charset="0"/>
-              </a:rPr>
-              <a:t>Radar of the lost archive</a:t>
-            </a:r>
-          </a:p>
-        </p:txBody>
-      </p:sp>
-      <p:sp>
-        <p:nvSpPr>
-          <p:cNvPr id="3" name="Content Placeholder 2">
-            <a:extLst>
-              <a:ext uri="{FF2B5EF4-FFF2-40B4-BE49-F238E27FC236}">
-                <a16:creationId xmlns:a16="http://schemas.microsoft.com/office/drawing/2014/main" id="{01A28595-06A4-2AEC-2FC9-2E9E6364543C}"/>
-              </a:ext>
-            </a:extLst>
-          </p:cNvPr>
-          <p:cNvSpPr>
-            <a:spLocks noGrp="1"/>
-          </p:cNvSpPr>
-          <p:nvPr>
-            <p:ph idx="1"/>
-          </p:nvPr>
-        </p:nvSpPr>
-        <p:spPr>
-          <a:xfrm>
-            <a:off x="838200" y="1393902"/>
-            <a:ext cx="5085080" cy="5241074"/>
-          </a:xfrm>
-        </p:spPr>
-        <p:txBody>
-          <a:bodyPr>
-            <a:normAutofit lnSpcReduction="10000"/>
-          </a:bodyPr>
-          <a:lstStyle/>
-          <a:p>
-            <a:pPr>
-              <a:lnSpc>
-                <a:spcPct val="110000"/>
-              </a:lnSpc>
-            </a:pPr>
-            <a:r>
-              <a:rPr lang="en-GB" sz="2400" dirty="0">
-                <a:latin typeface="Palatino Linotype" panose="02040502050505030304" pitchFamily="18" charset="0"/>
-              </a:rPr>
-              <a:t>The Grand Challenges Exercise of the UK Computing Research Committee (UKCRC) .</a:t>
-            </a:r>
-          </a:p>
-          <a:p>
-            <a:pPr>
-              <a:lnSpc>
-                <a:spcPct val="110000"/>
-              </a:lnSpc>
-            </a:pPr>
-            <a:r>
-              <a:rPr lang="en-GB" sz="2400" dirty="0">
-                <a:latin typeface="Palatino Linotype" panose="02040502050505030304" pitchFamily="18" charset="0"/>
-              </a:rPr>
-              <a:t>Workshop held in Edinburgh November 2002, discussed 109 submissions.</a:t>
-            </a:r>
-          </a:p>
-          <a:p>
-            <a:pPr>
-              <a:lnSpc>
-                <a:spcPct val="110000"/>
-              </a:lnSpc>
-            </a:pPr>
-            <a:r>
-              <a:rPr lang="en-GB" sz="2400" dirty="0">
-                <a:latin typeface="Palatino Linotype" panose="02040502050505030304" pitchFamily="18" charset="0"/>
-              </a:rPr>
-              <a:t>Archival research suggests my submission was “The creative electronic musician”. Or maybe “Interactive Electronic Musician”.</a:t>
-            </a:r>
-          </a:p>
-          <a:p>
-            <a:pPr>
-              <a:lnSpc>
-                <a:spcPct val="110000"/>
-              </a:lnSpc>
-            </a:pPr>
-            <a:r>
-              <a:rPr lang="en-GB" sz="2400" dirty="0">
-                <a:latin typeface="Palatino Linotype" panose="02040502050505030304" pitchFamily="18" charset="0"/>
-              </a:rPr>
-              <a:t>Tony Hoare was Chair of the programme committee.</a:t>
-            </a:r>
-          </a:p>
-          <a:p>
-            <a:pPr>
-              <a:lnSpc>
-                <a:spcPct val="110000"/>
-              </a:lnSpc>
-            </a:pPr>
-            <a:endParaRPr lang="en-GB" sz="2400" dirty="0">
-              <a:latin typeface="Palatino Linotype" panose="02040502050505030304" pitchFamily="18" charset="0"/>
-            </a:endParaRPr>
-          </a:p>
-        </p:txBody>
-      </p:sp>
-      <p:pic>
-        <p:nvPicPr>
-          <p:cNvPr id="6" name="Picture 5">
-            <a:extLst>
-              <a:ext uri="{FF2B5EF4-FFF2-40B4-BE49-F238E27FC236}">
-                <a16:creationId xmlns:a16="http://schemas.microsoft.com/office/drawing/2014/main" id="{BDB2208F-6F12-79CA-A9C1-4E0A784D3A7D}"/>
-              </a:ext>
-            </a:extLst>
-          </p:cNvPr>
-          <p:cNvPicPr>
-            <a:picLocks noChangeAspect="1"/>
-          </p:cNvPicPr>
+          <p:cNvSpPr/>
           <p:nvPr/>
-        </p:nvPicPr>
-        <p:blipFill>
-          <a:blip r:embed="rId3"/>
-          <a:stretch>
-            <a:fillRect/>
-          </a:stretch>
-        </p:blipFill>
-        <p:spPr>
-          <a:xfrm>
-            <a:off x="6994788" y="1640644"/>
-            <a:ext cx="4609251" cy="4717521"/>
+        </p:nvSpPr>
+        <p:spPr>
+          <a:xfrm>
+            <a:off x="6747644" y="365125"/>
+            <a:ext cx="5276193" cy="6269851"/>
           </a:xfrm>
           <a:prstGeom prst="rect">
             <a:avLst/>
           </a:prstGeom>
-          <a:ln>
-            <a:solidFill>
-              <a:srgbClr val="CADCFC"/>
-            </a:solidFill>
-          </a:ln>
-        </p:spPr>
-      </p:pic>
-      <p:sp>
-        <p:nvSpPr>
-          <p:cNvPr id="7" name="Right Arrow 6">
-            <a:extLst>
-              <a:ext uri="{FF2B5EF4-FFF2-40B4-BE49-F238E27FC236}">
-                <a16:creationId xmlns:a16="http://schemas.microsoft.com/office/drawing/2014/main" id="{6991674F-8739-AB95-371A-B9C929DC5189}"/>
-              </a:ext>
-            </a:extLst>
-          </p:cNvPr>
-          <p:cNvSpPr/>
-          <p:nvPr/>
-        </p:nvSpPr>
-        <p:spPr>
-          <a:xfrm>
-            <a:off x="6096000" y="3934818"/>
-            <a:ext cx="762000" cy="406400"/>
-          </a:xfrm>
-          <a:prstGeom prst="rightArrow">
-            <a:avLst/>
-          </a:prstGeom>
-          <a:solidFill>
-            <a:srgbClr val="00B050"/>
-          </a:solidFill>
-          <a:ln>
-            <a:noFill/>
-          </a:ln>
+          <a:noFill/>
         </p:spPr>
         <p:style>
           <a:lnRef idx="2">
@@ -5563,6 +5397,219 @@
           <a:lstStyle/>
           <a:p>
             <a:pPr algn="ctr"/>
+            <a:endParaRPr lang="en-US" dirty="0"/>
+          </a:p>
+        </p:txBody>
+      </p:sp>
+      <p:sp>
+        <p:nvSpPr>
+          <p:cNvPr id="2" name="Title 1">
+            <a:extLst>
+              <a:ext uri="{FF2B5EF4-FFF2-40B4-BE49-F238E27FC236}">
+                <a16:creationId xmlns:a16="http://schemas.microsoft.com/office/drawing/2014/main" id="{9D13241A-102A-3C3B-86F2-2AD6434B3D97}"/>
+              </a:ext>
+            </a:extLst>
+          </p:cNvPr>
+          <p:cNvSpPr>
+            <a:spLocks noGrp="1"/>
+          </p:cNvSpPr>
+          <p:nvPr>
+            <p:ph type="title"/>
+          </p:nvPr>
+        </p:nvSpPr>
+        <p:spPr>
+          <a:xfrm>
+            <a:off x="672662" y="365125"/>
+            <a:ext cx="10681138" cy="805753"/>
+          </a:xfrm>
+        </p:spPr>
+        <p:txBody>
+          <a:bodyPr/>
+          <a:lstStyle/>
+          <a:p>
+            <a:r>
+              <a:rPr lang="en-US" dirty="0">
+                <a:latin typeface="Garamond" panose="02020404030301010803" pitchFamily="18" charset="0"/>
+              </a:rPr>
+              <a:t>Radar of the lost archive</a:t>
+            </a:r>
+          </a:p>
+        </p:txBody>
+      </p:sp>
+      <p:sp>
+        <p:nvSpPr>
+          <p:cNvPr id="3" name="Content Placeholder 2">
+            <a:extLst>
+              <a:ext uri="{FF2B5EF4-FFF2-40B4-BE49-F238E27FC236}">
+                <a16:creationId xmlns:a16="http://schemas.microsoft.com/office/drawing/2014/main" id="{01A28595-06A4-2AEC-2FC9-2E9E6364543C}"/>
+              </a:ext>
+            </a:extLst>
+          </p:cNvPr>
+          <p:cNvSpPr>
+            <a:spLocks noGrp="1"/>
+          </p:cNvSpPr>
+          <p:nvPr>
+            <p:ph idx="1"/>
+          </p:nvPr>
+        </p:nvSpPr>
+        <p:spPr>
+          <a:xfrm>
+            <a:off x="672662" y="1393902"/>
+            <a:ext cx="5221912" cy="5241074"/>
+          </a:xfrm>
+        </p:spPr>
+        <p:txBody>
+          <a:bodyPr>
+            <a:noAutofit/>
+          </a:bodyPr>
+          <a:lstStyle/>
+          <a:p>
+            <a:pPr>
+              <a:lnSpc>
+                <a:spcPct val="110000"/>
+              </a:lnSpc>
+            </a:pPr>
+            <a:r>
+              <a:rPr lang="en-GB" sz="2200" dirty="0">
+                <a:latin typeface="Palatino Linotype" panose="02040502050505030304" pitchFamily="18" charset="0"/>
+              </a:rPr>
+              <a:t>“The Grand Challenges Exercise of the UK Computing Research Committee”</a:t>
+            </a:r>
+          </a:p>
+          <a:p>
+            <a:pPr>
+              <a:lnSpc>
+                <a:spcPct val="110000"/>
+              </a:lnSpc>
+            </a:pPr>
+            <a:r>
+              <a:rPr lang="en-GB" sz="2200" dirty="0">
+                <a:latin typeface="Palatino Linotype" panose="02040502050505030304" pitchFamily="18" charset="0"/>
+              </a:rPr>
+              <a:t>A workshop held in Edinburgh in November 2002, considered 109 submissions.</a:t>
+            </a:r>
+          </a:p>
+          <a:p>
+            <a:pPr>
+              <a:lnSpc>
+                <a:spcPct val="110000"/>
+              </a:lnSpc>
+            </a:pPr>
+            <a:r>
+              <a:rPr lang="en-GB" sz="2200" dirty="0">
+                <a:latin typeface="Palatino Linotype" panose="02040502050505030304" pitchFamily="18" charset="0"/>
+              </a:rPr>
+              <a:t>Archival research suggests my submission was “The creative electronic musician”. Or maybe “Interactive Electronic Musician”.</a:t>
+            </a:r>
+          </a:p>
+          <a:p>
+            <a:pPr>
+              <a:lnSpc>
+                <a:spcPct val="110000"/>
+              </a:lnSpc>
+            </a:pPr>
+            <a:r>
+              <a:rPr lang="en-GB" sz="2200" dirty="0">
+                <a:latin typeface="Palatino Linotype" panose="02040502050505030304" pitchFamily="18" charset="0"/>
+              </a:rPr>
+              <a:t>Sir Tony Hoare, Wolfson Emeritus Fellow, was Chair of the programme committee.</a:t>
+            </a:r>
+          </a:p>
+          <a:p>
+            <a:pPr>
+              <a:lnSpc>
+                <a:spcPct val="110000"/>
+              </a:lnSpc>
+            </a:pPr>
+            <a:endParaRPr lang="en-GB" sz="2200" dirty="0">
+              <a:latin typeface="Palatino Linotype" panose="02040502050505030304" pitchFamily="18" charset="0"/>
+            </a:endParaRPr>
+          </a:p>
+        </p:txBody>
+      </p:sp>
+      <p:pic>
+        <p:nvPicPr>
+          <p:cNvPr id="6" name="Picture 5">
+            <a:extLst>
+              <a:ext uri="{FF2B5EF4-FFF2-40B4-BE49-F238E27FC236}">
+                <a16:creationId xmlns:a16="http://schemas.microsoft.com/office/drawing/2014/main" id="{BDB2208F-6F12-79CA-A9C1-4E0A784D3A7D}"/>
+              </a:ext>
+            </a:extLst>
+          </p:cNvPr>
+          <p:cNvPicPr>
+            <a:picLocks noChangeAspect="1"/>
+          </p:cNvPicPr>
+          <p:nvPr/>
+        </p:nvPicPr>
+        <p:blipFill>
+          <a:blip r:embed="rId3"/>
+          <a:stretch>
+            <a:fillRect/>
+          </a:stretch>
+        </p:blipFill>
+        <p:spPr>
+          <a:xfrm>
+            <a:off x="7055502" y="1686400"/>
+            <a:ext cx="4609251" cy="4717521"/>
+          </a:xfrm>
+          <a:prstGeom prst="rect">
+            <a:avLst/>
+          </a:prstGeom>
+          <a:ln>
+            <a:solidFill>
+              <a:srgbClr val="CADCFC"/>
+            </a:solidFill>
+          </a:ln>
+        </p:spPr>
+      </p:pic>
+      <p:sp>
+        <p:nvSpPr>
+          <p:cNvPr id="7" name="Right Arrow 6">
+            <a:extLst>
+              <a:ext uri="{FF2B5EF4-FFF2-40B4-BE49-F238E27FC236}">
+                <a16:creationId xmlns:a16="http://schemas.microsoft.com/office/drawing/2014/main" id="{6991674F-8739-AB95-371A-B9C929DC5189}"/>
+              </a:ext>
+            </a:extLst>
+          </p:cNvPr>
+          <p:cNvSpPr/>
+          <p:nvPr/>
+        </p:nvSpPr>
+        <p:spPr>
+          <a:xfrm>
+            <a:off x="5705821" y="3934819"/>
+            <a:ext cx="614820" cy="406400"/>
+          </a:xfrm>
+          <a:prstGeom prst="rightArrow">
+            <a:avLst/>
+          </a:prstGeom>
+          <a:solidFill>
+            <a:srgbClr val="00B050"/>
+          </a:solidFill>
+          <a:ln>
+            <a:noFill/>
+          </a:ln>
+        </p:spPr>
+        <p:style>
+          <a:lnRef idx="2">
+            <a:schemeClr val="accent1">
+              <a:shade val="15000"/>
+            </a:schemeClr>
+          </a:lnRef>
+          <a:fillRef idx="1">
+            <a:schemeClr val="accent1"/>
+          </a:fillRef>
+          <a:effectRef idx="0">
+            <a:schemeClr val="accent1"/>
+          </a:effectRef>
+          <a:fontRef idx="minor">
+            <a:schemeClr val="lt1"/>
+          </a:fontRef>
+        </p:style>
+        <p:txBody>
+          <a:bodyPr rtlCol="0" anchor="ctr"/>
+          <a:lstStyle/>
+          <a:p>
+            <a:pPr algn="ctr"/>
             <a:endParaRPr lang="en-US"/>
           </a:p>
         </p:txBody>
@@ -5589,7 +5636,7 @@
         </p:blipFill>
         <p:spPr>
           <a:xfrm>
-            <a:off x="6807764" y="609600"/>
+            <a:off x="6868478" y="623826"/>
             <a:ext cx="5042991" cy="1031044"/>
           </a:xfrm>
           <a:prstGeom prst="rect">
@@ -5651,8 +5698,8 @@
         </p:nvSpPr>
         <p:spPr>
           <a:xfrm>
-            <a:off x="838200" y="539296"/>
-            <a:ext cx="10515600" cy="805753"/>
+            <a:off x="546538" y="539296"/>
+            <a:ext cx="10972800" cy="805753"/>
           </a:xfrm>
         </p:spPr>
         <p:txBody>
@@ -5693,137 +5740,437 @@
         </p:nvSpPr>
         <p:spPr>
           <a:xfrm>
-            <a:off x="838200" y="1786288"/>
-            <a:ext cx="10376338" cy="4783061"/>
+            <a:off x="415158" y="1807309"/>
+            <a:ext cx="5439103" cy="4783061"/>
           </a:xfrm>
         </p:spPr>
         <p:txBody>
           <a:bodyPr>
-            <a:normAutofit fontScale="92500" lnSpcReduction="10000"/>
+            <a:noAutofit/>
           </a:bodyPr>
           <a:lstStyle/>
           <a:p>
             <a:pPr>
               <a:lnSpc>
-                <a:spcPct val="120000"/>
+                <a:spcPct val="110000"/>
               </a:lnSpc>
+              <a:spcBef>
+                <a:spcPts val="400"/>
+              </a:spcBef>
             </a:pPr>
             <a:r>
-              <a:rPr lang="en-GB" sz="2400" dirty="0">
+              <a:rPr lang="en-GB" sz="1800" dirty="0">
                 <a:latin typeface="Palatino Linotype" panose="02040502050505030304" pitchFamily="18" charset="0"/>
               </a:rPr>
-              <a:t>It uses MIDI, so perhaps it inevitably sounds like a very good MIDI file and there’ll be a lack of expression/articulation.</a:t>
+              <a:t>It uses MIDI: no pitch inflection, vibrato, or continuous dynamics within notes — every note is a rectangle.</a:t>
             </a:r>
           </a:p>
           <a:p>
             <a:pPr>
               <a:lnSpc>
-                <a:spcPct val="120000"/>
+                <a:spcPct val="110000"/>
               </a:lnSpc>
+              <a:spcBef>
+                <a:spcPts val="400"/>
+              </a:spcBef>
             </a:pPr>
             <a:r>
-              <a:rPr lang="en-GB" sz="2400" dirty="0">
+              <a:rPr lang="en-GB" sz="1800" dirty="0">
                 <a:latin typeface="Palatino Linotype" panose="02040502050505030304" pitchFamily="18" charset="0"/>
               </a:rPr>
-              <a:t>The time feel might be mechanical – lack of </a:t>
-            </a:r>
-            <a:r>
-              <a:rPr lang="en-GB" sz="2400" dirty="0" err="1">
+              <a:t>Time feel is mechanical within phrases: no </a:t>
+            </a:r>
+            <a:r>
+              <a:rPr lang="en-GB" sz="1800" dirty="0" err="1">
                 <a:latin typeface="Palatino Linotype" panose="02040502050505030304" pitchFamily="18" charset="0"/>
               </a:rPr>
               <a:t>microtiming</a:t>
             </a:r>
             <a:r>
-              <a:rPr lang="en-GB" sz="2400" dirty="0">
+              <a:rPr lang="en-GB" sz="1800" dirty="0">
                 <a:latin typeface="Palatino Linotype" panose="02040502050505030304" pitchFamily="18" charset="0"/>
               </a:rPr>
-              <a:t>, crucial to jazz.</a:t>
+              <a:t>, no laying back or pushing the beat.</a:t>
             </a:r>
           </a:p>
           <a:p>
             <a:pPr>
               <a:lnSpc>
-                <a:spcPct val="120000"/>
+                <a:spcPct val="110000"/>
               </a:lnSpc>
+              <a:spcBef>
+                <a:spcPts val="400"/>
+              </a:spcBef>
             </a:pPr>
             <a:r>
-              <a:rPr lang="en-GB" sz="2400" dirty="0">
+              <a:rPr lang="en-GB" sz="1800" dirty="0">
                 <a:latin typeface="Palatino Linotype" panose="02040502050505030304" pitchFamily="18" charset="0"/>
               </a:rPr>
-              <a:t>Conversation mostly polite, by design.</a:t>
+              <a:t>Conversation is polite by design – complementary, never confrontational, doesn't interrupt, crowd the register, or refuse to listen..</a:t>
             </a:r>
           </a:p>
           <a:p>
             <a:pPr>
               <a:lnSpc>
-                <a:spcPct val="120000"/>
+                <a:spcPct val="110000"/>
               </a:lnSpc>
+              <a:spcBef>
+                <a:spcPts val="400"/>
+              </a:spcBef>
             </a:pPr>
             <a:r>
-              <a:rPr lang="en-GB" sz="2400" dirty="0">
+              <a:rPr lang="en-GB" sz="1800" dirty="0">
                 <a:latin typeface="Palatino Linotype" panose="02040502050505030304" pitchFamily="18" charset="0"/>
               </a:rPr>
-              <a:t>No personal voice – it’s generalised be-bop.</a:t>
+              <a:t>It’s pretty much in 4/4, no waltzes or take 5 – the tempo estimator assumes equal beats.</a:t>
             </a:r>
           </a:p>
           <a:p>
             <a:pPr>
               <a:lnSpc>
-                <a:spcPct val="120000"/>
+                <a:spcPct val="110000"/>
               </a:lnSpc>
+              <a:spcBef>
+                <a:spcPts val="400"/>
+              </a:spcBef>
             </a:pPr>
             <a:r>
-              <a:rPr lang="en-GB" sz="2400" dirty="0">
+              <a:rPr lang="en-GB" sz="1800" dirty="0">
                 <a:latin typeface="Palatino Linotype" panose="02040502050505030304" pitchFamily="18" charset="0"/>
               </a:rPr>
-              <a:t>The arc is clock-driven, not music-driven – deliberately for this performance.</a:t>
+              <a:t>No personal voice — an amalgam across an era rather than any one player's sound.</a:t>
             </a:r>
           </a:p>
           <a:p>
             <a:pPr>
               <a:lnSpc>
-                <a:spcPct val="120000"/>
+                <a:spcPct val="110000"/>
               </a:lnSpc>
+              <a:spcBef>
+                <a:spcPts val="400"/>
+              </a:spcBef>
             </a:pPr>
             <a:r>
-              <a:rPr lang="en-GB" sz="2400" dirty="0">
+              <a:rPr lang="en-GB" sz="1800" dirty="0">
                 <a:latin typeface="Palatino Linotype" panose="02040502050505030304" pitchFamily="18" charset="0"/>
               </a:rPr>
-              <a:t>Motivic development might feel like repetition – because it is.</a:t>
-            </a:r>
-          </a:p>
+              <a:t>The arc is clock-driven, not music-driven – deliberately for this performance.</a:t>
+            </a:r>
+          </a:p>
+          <a:p>
+            <a:pPr marL="0" indent="0">
+              <a:lnSpc>
+                <a:spcPct val="110000"/>
+              </a:lnSpc>
+              <a:spcBef>
+                <a:spcPts val="400"/>
+              </a:spcBef>
+              <a:buNone/>
+            </a:pPr>
+            <a:endParaRPr lang="en-US" sz="1800" dirty="0">
+              <a:latin typeface="Palatino Linotype" panose="02040502050505030304" pitchFamily="18" charset="0"/>
+            </a:endParaRPr>
+          </a:p>
+        </p:txBody>
+      </p:sp>
+      <p:sp>
+        <p:nvSpPr>
+          <p:cNvPr id="5" name="Content Placeholder 2">
+            <a:extLst>
+              <a:ext uri="{FF2B5EF4-FFF2-40B4-BE49-F238E27FC236}">
+                <a16:creationId xmlns:a16="http://schemas.microsoft.com/office/drawing/2014/main" id="{F63CDFF8-B9FA-96D8-F02B-E6002511B187}"/>
+              </a:ext>
+            </a:extLst>
+          </p:cNvPr>
+          <p:cNvSpPr txBox="1">
+            <a:spLocks/>
+          </p:cNvSpPr>
+          <p:nvPr/>
+        </p:nvSpPr>
+        <p:spPr>
+          <a:xfrm>
+            <a:off x="6032938" y="1807309"/>
+            <a:ext cx="5680840" cy="4783061"/>
+          </a:xfrm>
+          <a:prstGeom prst="rect">
+            <a:avLst/>
+          </a:prstGeom>
+        </p:spPr>
+        <p:txBody>
+          <a:bodyPr vert="horz" lIns="91440" tIns="45720" rIns="91440" bIns="45720" rtlCol="0">
+            <a:noAutofit/>
+          </a:bodyPr>
+          <a:lstStyle>
+            <a:lvl1pPr marL="228600" indent="-228600" algn="l" defTabSz="914400" rtl="0" eaLnBrk="1" latinLnBrk="0" hangingPunct="1">
+              <a:lnSpc>
+                <a:spcPct val="90000"/>
+              </a:lnSpc>
+              <a:spcBef>
+                <a:spcPts val="1000"/>
+              </a:spcBef>
+              <a:buFont typeface="Arial" panose="020B0604020202020204" pitchFamily="34" charset="0"/>
+              <a:buChar char="•"/>
+              <a:defRPr sz="2800" kern="1200">
+                <a:solidFill>
+                  <a:schemeClr val="tx1"/>
+                </a:solidFill>
+                <a:latin typeface="+mn-lt"/>
+                <a:ea typeface="+mn-ea"/>
+                <a:cs typeface="+mn-cs"/>
+              </a:defRPr>
+            </a:lvl1pPr>
+            <a:lvl2pPr marL="685800" indent="-228600" algn="l" defTabSz="914400" rtl="0" eaLnBrk="1" latinLnBrk="0" hangingPunct="1">
+              <a:lnSpc>
+                <a:spcPct val="90000"/>
+              </a:lnSpc>
+              <a:spcBef>
+                <a:spcPts val="500"/>
+              </a:spcBef>
+              <a:buFont typeface="Arial" panose="020B0604020202020204" pitchFamily="34" charset="0"/>
+              <a:buChar char="•"/>
+              <a:defRPr sz="2400" kern="1200">
+                <a:solidFill>
+                  <a:schemeClr val="tx1"/>
+                </a:solidFill>
+                <a:latin typeface="+mn-lt"/>
+                <a:ea typeface="+mn-ea"/>
+                <a:cs typeface="+mn-cs"/>
+              </a:defRPr>
+            </a:lvl2pPr>
+            <a:lvl3pPr marL="1143000" indent="-228600" algn="l" defTabSz="914400" rtl="0" eaLnBrk="1" latinLnBrk="0" hangingPunct="1">
+              <a:lnSpc>
+                <a:spcPct val="90000"/>
+              </a:lnSpc>
+              <a:spcBef>
+                <a:spcPts val="500"/>
+              </a:spcBef>
+              <a:buFont typeface="Arial" panose="020B0604020202020204" pitchFamily="34" charset="0"/>
+              <a:buChar char="•"/>
+              <a:defRPr sz="2000" kern="1200">
+                <a:solidFill>
+                  <a:schemeClr val="tx1"/>
+                </a:solidFill>
+                <a:latin typeface="+mn-lt"/>
+                <a:ea typeface="+mn-ea"/>
+                <a:cs typeface="+mn-cs"/>
+              </a:defRPr>
+            </a:lvl3pPr>
+            <a:lvl4pPr marL="1600200" indent="-228600" algn="l" defTabSz="914400" rtl="0" eaLnBrk="1" latinLnBrk="0" hangingPunct="1">
+              <a:lnSpc>
+                <a:spcPct val="90000"/>
+              </a:lnSpc>
+              <a:spcBef>
+                <a:spcPts val="500"/>
+              </a:spcBef>
+              <a:buFont typeface="Arial" panose="020B0604020202020204" pitchFamily="34" charset="0"/>
+              <a:buChar char="•"/>
+              <a:defRPr sz="1800" kern="1200">
+                <a:solidFill>
+                  <a:schemeClr val="tx1"/>
+                </a:solidFill>
+                <a:latin typeface="+mn-lt"/>
+                <a:ea typeface="+mn-ea"/>
+                <a:cs typeface="+mn-cs"/>
+              </a:defRPr>
+            </a:lvl4pPr>
+            <a:lvl5pPr marL="2057400" indent="-228600" algn="l" defTabSz="914400" rtl="0" eaLnBrk="1" latinLnBrk="0" hangingPunct="1">
+              <a:lnSpc>
+                <a:spcPct val="90000"/>
+              </a:lnSpc>
+              <a:spcBef>
+                <a:spcPts val="500"/>
+              </a:spcBef>
+              <a:buFont typeface="Arial" panose="020B0604020202020204" pitchFamily="34" charset="0"/>
+              <a:buChar char="•"/>
+              <a:defRPr sz="1800" kern="1200">
+                <a:solidFill>
+                  <a:schemeClr val="tx1"/>
+                </a:solidFill>
+                <a:latin typeface="+mn-lt"/>
+                <a:ea typeface="+mn-ea"/>
+                <a:cs typeface="+mn-cs"/>
+              </a:defRPr>
+            </a:lvl5pPr>
+            <a:lvl6pPr marL="2514600" indent="-228600" algn="l" defTabSz="914400" rtl="0" eaLnBrk="1" latinLnBrk="0" hangingPunct="1">
+              <a:lnSpc>
+                <a:spcPct val="90000"/>
+              </a:lnSpc>
+              <a:spcBef>
+                <a:spcPts val="500"/>
+              </a:spcBef>
+              <a:buFont typeface="Arial" panose="020B0604020202020204" pitchFamily="34" charset="0"/>
+              <a:buChar char="•"/>
+              <a:defRPr sz="1800" kern="1200">
+                <a:solidFill>
+                  <a:schemeClr val="tx1"/>
+                </a:solidFill>
+                <a:latin typeface="+mn-lt"/>
+                <a:ea typeface="+mn-ea"/>
+                <a:cs typeface="+mn-cs"/>
+              </a:defRPr>
+            </a:lvl6pPr>
+            <a:lvl7pPr marL="2971800" indent="-228600" algn="l" defTabSz="914400" rtl="0" eaLnBrk="1" latinLnBrk="0" hangingPunct="1">
+              <a:lnSpc>
+                <a:spcPct val="90000"/>
+              </a:lnSpc>
+              <a:spcBef>
+                <a:spcPts val="500"/>
+              </a:spcBef>
+              <a:buFont typeface="Arial" panose="020B0604020202020204" pitchFamily="34" charset="0"/>
+              <a:buChar char="•"/>
+              <a:defRPr sz="1800" kern="1200">
+                <a:solidFill>
+                  <a:schemeClr val="tx1"/>
+                </a:solidFill>
+                <a:latin typeface="+mn-lt"/>
+                <a:ea typeface="+mn-ea"/>
+                <a:cs typeface="+mn-cs"/>
+              </a:defRPr>
+            </a:lvl7pPr>
+            <a:lvl8pPr marL="3429000" indent="-228600" algn="l" defTabSz="914400" rtl="0" eaLnBrk="1" latinLnBrk="0" hangingPunct="1">
+              <a:lnSpc>
+                <a:spcPct val="90000"/>
+              </a:lnSpc>
+              <a:spcBef>
+                <a:spcPts val="500"/>
+              </a:spcBef>
+              <a:buFont typeface="Arial" panose="020B0604020202020204" pitchFamily="34" charset="0"/>
+              <a:buChar char="•"/>
+              <a:defRPr sz="1800" kern="1200">
+                <a:solidFill>
+                  <a:schemeClr val="tx1"/>
+                </a:solidFill>
+                <a:latin typeface="+mn-lt"/>
+                <a:ea typeface="+mn-ea"/>
+                <a:cs typeface="+mn-cs"/>
+              </a:defRPr>
+            </a:lvl8pPr>
+            <a:lvl9pPr marL="3886200" indent="-228600" algn="l" defTabSz="914400" rtl="0" eaLnBrk="1" latinLnBrk="0" hangingPunct="1">
+              <a:lnSpc>
+                <a:spcPct val="90000"/>
+              </a:lnSpc>
+              <a:spcBef>
+                <a:spcPts val="500"/>
+              </a:spcBef>
+              <a:buFont typeface="Arial" panose="020B0604020202020204" pitchFamily="34" charset="0"/>
+              <a:buChar char="•"/>
+              <a:defRPr sz="1800" kern="1200">
+                <a:solidFill>
+                  <a:schemeClr val="tx1"/>
+                </a:solidFill>
+                <a:latin typeface="+mn-lt"/>
+                <a:ea typeface="+mn-ea"/>
+                <a:cs typeface="+mn-cs"/>
+              </a:defRPr>
+            </a:lvl9pPr>
+          </a:lstStyle>
           <a:p>
             <a:pPr>
               <a:lnSpc>
-                <a:spcPct val="120000"/>
+                <a:spcPct val="110000"/>
               </a:lnSpc>
+              <a:spcBef>
+                <a:spcPts val="400"/>
+              </a:spcBef>
             </a:pPr>
             <a:r>
-              <a:rPr lang="en-GB" sz="2400" dirty="0">
+              <a:rPr lang="en-GB" sz="1800" dirty="0">
                 <a:latin typeface="Palatino Linotype" panose="02040502050505030304" pitchFamily="18" charset="0"/>
               </a:rPr>
-              <a:t>The audience might feel it would be ‘more musical’ if it followed a fixed, pre-set chord progression – but the whole point is that it doesn’t, it’s responsive. There are plenty of play-along programs out there.</a:t>
+              <a:t>Motivic development might feel like repetition – because it is.</a:t>
             </a:r>
           </a:p>
           <a:p>
             <a:pPr>
               <a:lnSpc>
-                <a:spcPct val="120000"/>
+                <a:spcPct val="110000"/>
               </a:lnSpc>
+              <a:spcBef>
+                <a:spcPts val="400"/>
+              </a:spcBef>
             </a:pPr>
-            <a:endParaRPr lang="en-GB" sz="2400" dirty="0">
-              <a:latin typeface="Palatino Linotype" panose="02040502050505030304" pitchFamily="18" charset="0"/>
-            </a:endParaRPr>
+            <a:r>
+              <a:rPr lang="en-GB" sz="1800" dirty="0">
+                <a:latin typeface="Palatino Linotype" panose="02040502050505030304" pitchFamily="18" charset="0"/>
+              </a:rPr>
+              <a:t>Trained on solos not melodies – no quoting, no playing off the tune.</a:t>
+            </a:r>
           </a:p>
           <a:p>
             <a:pPr>
               <a:lnSpc>
-                <a:spcPct val="120000"/>
+                <a:spcPct val="110000"/>
               </a:lnSpc>
+              <a:spcBef>
+                <a:spcPts val="400"/>
+              </a:spcBef>
             </a:pPr>
-            <a:endParaRPr lang="en-US" sz="2400" dirty="0">
-              <a:latin typeface="Palatino Linotype" panose="02040502050505030304" pitchFamily="18" charset="0"/>
-            </a:endParaRPr>
+            <a:r>
+              <a:rPr lang="en-GB" sz="1800" dirty="0">
+                <a:latin typeface="Palatino Linotype" panose="02040502050505030304" pitchFamily="18" charset="0"/>
+              </a:rPr>
+              <a:t>Trained on one era and school — the bebop/hard-bop vocabulary of the Weimar Jazz Database; no awareness of what came before or after.</a:t>
+            </a:r>
+          </a:p>
+          <a:p>
+            <a:pPr>
+              <a:lnSpc>
+                <a:spcPct val="110000"/>
+              </a:lnSpc>
+              <a:spcBef>
+                <a:spcPts val="400"/>
+              </a:spcBef>
+            </a:pPr>
+            <a:r>
+              <a:rPr lang="en-GB" sz="1800" dirty="0">
+                <a:latin typeface="Palatino Linotype" panose="02040502050505030304" pitchFamily="18" charset="0"/>
+              </a:rPr>
+              <a:t>Inside/outside distinction and narrative arc within a phrase could be designed more explicitly — the model has learned some of this from transcriptions.</a:t>
+            </a:r>
+          </a:p>
+          <a:p>
+            <a:pPr>
+              <a:lnSpc>
+                <a:spcPct val="110000"/>
+              </a:lnSpc>
+              <a:spcBef>
+                <a:spcPts val="400"/>
+              </a:spcBef>
+            </a:pPr>
+            <a:r>
+              <a:rPr lang="en-GB" sz="1800" dirty="0">
+                <a:latin typeface="Palatino Linotype" panose="02040502050505030304" pitchFamily="18" charset="0"/>
+              </a:rPr>
+              <a:t>It only listens to one instrument – but see </a:t>
+            </a:r>
+            <a:r>
+              <a:rPr lang="en-GB" sz="1800" i="1" dirty="0">
+                <a:latin typeface="Palatino Linotype" panose="02040502050505030304" pitchFamily="18" charset="0"/>
+              </a:rPr>
+              <a:t>Forager</a:t>
+            </a:r>
+            <a:r>
+              <a:rPr lang="en-GB" sz="1800" dirty="0">
+                <a:latin typeface="Palatino Linotype" panose="02040502050505030304" pitchFamily="18" charset="0"/>
+              </a:rPr>
+              <a:t>.</a:t>
+            </a:r>
+          </a:p>
+          <a:p>
+            <a:pPr>
+              <a:lnSpc>
+                <a:spcPct val="110000"/>
+              </a:lnSpc>
+              <a:spcBef>
+                <a:spcPts val="400"/>
+              </a:spcBef>
+            </a:pPr>
+            <a:r>
+              <a:rPr lang="en-GB" sz="1800" dirty="0">
+                <a:latin typeface="Palatino Linotype" panose="02040502050505030304" pitchFamily="18" charset="0"/>
+              </a:rPr>
+              <a:t>Audiences may find fixed, familiar harmony more immediately satisfying – responsiveness to the bassist means harmony is earned rather than given.</a:t>
+            </a:r>
           </a:p>
         </p:txBody>
       </p:sp>
@@ -6130,8 +6477,8 @@
         </p:nvSpPr>
         <p:spPr>
           <a:xfrm>
-            <a:off x="638504" y="1351859"/>
-            <a:ext cx="3954966" cy="5150128"/>
+            <a:off x="638504" y="1267779"/>
+            <a:ext cx="3324085" cy="4950073"/>
           </a:xfrm>
           <a:prstGeom prst="rect">
             <a:avLst/>
@@ -6150,7 +6497,7 @@
               </a:spcAft>
             </a:pPr>
             <a:r>
-              <a:rPr lang="en-GB" sz="2400" dirty="0">
+              <a:rPr lang="en-GB" sz="2300" dirty="0">
                 <a:latin typeface="Palatino Linotype" panose="02040502050505030304" pitchFamily="18" charset="0"/>
               </a:rPr>
               <a:t>Phrase analysis</a:t>
@@ -6163,7 +6510,7 @@
               </a:spcAft>
             </a:pPr>
             <a:r>
-              <a:rPr lang="en-GB" sz="2400" dirty="0">
+              <a:rPr lang="en-GB" sz="2300" dirty="0">
                 <a:latin typeface="Palatino Linotype" panose="02040502050505030304" pitchFamily="18" charset="0"/>
               </a:rPr>
               <a:t>Question and answer</a:t>
@@ -6176,7 +6523,7 @@
               </a:spcAft>
             </a:pPr>
             <a:r>
-              <a:rPr lang="en-GB" sz="2400" dirty="0">
+              <a:rPr lang="en-GB" sz="2300" dirty="0">
                 <a:latin typeface="Palatino Linotype" panose="02040502050505030304" pitchFamily="18" charset="0"/>
               </a:rPr>
               <a:t>Leadership &amp; role swapping</a:t>
@@ -6189,7 +6536,7 @@
               </a:spcAft>
             </a:pPr>
             <a:r>
-              <a:rPr lang="en-GB" sz="2400" dirty="0">
+              <a:rPr lang="en-GB" sz="2300" dirty="0">
                 <a:latin typeface="Palatino Linotype" panose="02040502050505030304" pitchFamily="18" charset="0"/>
               </a:rPr>
               <a:t>Opening echo </a:t>
@@ -6202,7 +6549,7 @@
               </a:spcAft>
             </a:pPr>
             <a:r>
-              <a:rPr lang="en-GB" sz="2400" dirty="0">
+              <a:rPr lang="en-GB" sz="2300" dirty="0">
                 <a:latin typeface="Palatino Linotype" panose="02040502050505030304" pitchFamily="18" charset="0"/>
               </a:rPr>
               <a:t>Contour steering</a:t>
@@ -6215,7 +6562,7 @@
               </a:spcAft>
             </a:pPr>
             <a:r>
-              <a:rPr lang="en-GB" sz="2400" dirty="0">
+              <a:rPr lang="en-GB" sz="2300" dirty="0">
                 <a:latin typeface="Palatino Linotype" panose="02040502050505030304" pitchFamily="18" charset="0"/>
               </a:rPr>
               <a:t>Chord conditioning </a:t>
@@ -6228,7 +6575,7 @@
               </a:spcAft>
             </a:pPr>
             <a:r>
-              <a:rPr lang="en-GB" sz="2400" dirty="0">
+              <a:rPr lang="en-GB" sz="2300" dirty="0">
                 <a:latin typeface="Palatino Linotype" panose="02040502050505030304" pitchFamily="18" charset="0"/>
               </a:rPr>
               <a:t>Harmonic modes </a:t>
@@ -6241,7 +6588,7 @@
               </a:spcAft>
             </a:pPr>
             <a:r>
-              <a:rPr lang="en-GB" sz="2400" dirty="0">
+              <a:rPr lang="en-GB" sz="2300" dirty="0">
                 <a:latin typeface="Palatino Linotype" panose="02040502050505030304" pitchFamily="18" charset="0"/>
               </a:rPr>
               <a:t>Scale pitch bias</a:t>
@@ -6254,7 +6601,7 @@
               </a:spcAft>
             </a:pPr>
             <a:r>
-              <a:rPr lang="en-GB" sz="2400" dirty="0">
+              <a:rPr lang="en-GB" sz="2300" dirty="0">
                 <a:latin typeface="Palatino Linotype" panose="02040502050505030304" pitchFamily="18" charset="0"/>
               </a:rPr>
               <a:t>Pitch range</a:t>
@@ -6267,7 +6614,7 @@
               </a:spcAft>
             </a:pPr>
             <a:r>
-              <a:rPr lang="en-GB" sz="2400" dirty="0">
+              <a:rPr lang="en-GB" sz="2300" dirty="0">
                 <a:latin typeface="Palatino Linotype" panose="02040502050505030304" pitchFamily="18" charset="0"/>
               </a:rPr>
               <a:t>Swing / triplet feel</a:t>
@@ -6280,18 +6627,18 @@
               </a:spcAft>
             </a:pPr>
             <a:r>
-              <a:rPr lang="en-GB" sz="2400" dirty="0">
+              <a:rPr lang="en-GB" sz="2300" dirty="0">
                 <a:latin typeface="Palatino Linotype" panose="02040502050505030304" pitchFamily="18" charset="0"/>
               </a:rPr>
               <a:t>Live tempo tracking</a:t>
             </a:r>
             <a:br>
-              <a:rPr lang="en-GB" sz="2400" dirty="0">
+              <a:rPr lang="en-GB" sz="2300" dirty="0">
                 <a:latin typeface="Palatino Linotype" panose="02040502050505030304" pitchFamily="18" charset="0"/>
               </a:rPr>
             </a:br>
             <a:r>
-              <a:rPr lang="en-GB" sz="2400" dirty="0">
+              <a:rPr lang="en-GB" sz="2300" dirty="0">
                 <a:latin typeface="Palatino Linotype" panose="02040502050505030304" pitchFamily="18" charset="0"/>
               </a:rPr>
               <a:t>Dynamics</a:t>
@@ -6313,8 +6660,8 @@
         </p:nvSpPr>
         <p:spPr>
           <a:xfrm>
-            <a:off x="3856497" y="1351859"/>
-            <a:ext cx="3954966" cy="5150128"/>
+            <a:off x="3972107" y="1267779"/>
+            <a:ext cx="3954966" cy="4950073"/>
           </a:xfrm>
           <a:prstGeom prst="rect">
             <a:avLst/>
@@ -6333,18 +6680,18 @@
               </a:spcAft>
             </a:pPr>
             <a:r>
-              <a:rPr lang="en-GB" sz="2400" dirty="0">
+              <a:rPr lang="en-GB" sz="2300" dirty="0">
                 <a:latin typeface="Palatino Linotype" panose="02040502050505030304" pitchFamily="18" charset="0"/>
               </a:rPr>
               <a:t>Generation temperature</a:t>
             </a:r>
             <a:br>
-              <a:rPr lang="en-GB" sz="2400" dirty="0">
+              <a:rPr lang="en-GB" sz="2300" dirty="0">
                 <a:latin typeface="Palatino Linotype" panose="02040502050505030304" pitchFamily="18" charset="0"/>
               </a:rPr>
             </a:br>
             <a:r>
-              <a:rPr lang="en-GB" sz="2400" dirty="0">
+              <a:rPr lang="en-GB" sz="2300" dirty="0">
                 <a:latin typeface="Palatino Linotype" panose="02040502050505030304" pitchFamily="18" charset="0"/>
               </a:rPr>
               <a:t>Phrase-shape dynamics</a:t>
@@ -6357,7 +6704,7 @@
               </a:spcAft>
             </a:pPr>
             <a:r>
-              <a:rPr lang="en-GB" sz="2400" dirty="0">
+              <a:rPr lang="en-GB" sz="2300" dirty="0">
                 <a:latin typeface="Palatino Linotype" panose="02040502050505030304" pitchFamily="18" charset="0"/>
               </a:rPr>
               <a:t>Articulation</a:t>
@@ -6370,7 +6717,7 @@
               </a:spcAft>
             </a:pPr>
             <a:r>
-              <a:rPr lang="en-GB" sz="2400" dirty="0">
+              <a:rPr lang="en-GB" sz="2300" dirty="0">
                 <a:latin typeface="Palatino Linotype" panose="02040502050505030304" pitchFamily="18" charset="0"/>
               </a:rPr>
               <a:t>Bass pitch-class tracking</a:t>
@@ -6383,7 +6730,7 @@
               </a:spcAft>
             </a:pPr>
             <a:r>
-              <a:rPr lang="en-GB" sz="2400" dirty="0">
+              <a:rPr lang="en-GB" sz="2300" dirty="0">
                 <a:latin typeface="Palatino Linotype" panose="02040502050505030304" pitchFamily="18" charset="0"/>
               </a:rPr>
               <a:t>Energy arc</a:t>
@@ -6396,7 +6743,7 @@
               </a:spcAft>
             </a:pPr>
             <a:r>
-              <a:rPr lang="en-GB" sz="2400" dirty="0">
+              <a:rPr lang="en-GB" sz="2300" dirty="0">
                 <a:latin typeface="Palatino Linotype" panose="02040502050505030304" pitchFamily="18" charset="0"/>
               </a:rPr>
               <a:t>Motivic development</a:t>
@@ -6409,10 +6756,10 @@
               </a:spcAft>
             </a:pPr>
             <a:r>
-              <a:rPr lang="en-GB" sz="2400" dirty="0">
+              <a:rPr lang="en-GB" sz="2300" dirty="0">
                 <a:latin typeface="Palatino Linotype" panose="02040502050505030304" pitchFamily="18" charset="0"/>
               </a:rPr>
-              <a:t>Lyrical motif re-use </a:t>
+              <a:t>Rhythmic displacement</a:t>
             </a:r>
           </a:p>
           <a:p>
@@ -6422,10 +6769,10 @@
               </a:spcAft>
             </a:pPr>
             <a:r>
-              <a:rPr lang="en-GB" sz="2400" dirty="0">
+              <a:rPr lang="en-GB" sz="2300" dirty="0">
                 <a:latin typeface="Palatino Linotype" panose="02040502050505030304" pitchFamily="18" charset="0"/>
               </a:rPr>
-              <a:t>Voice leading</a:t>
+              <a:t>Lyrical motif re-use </a:t>
             </a:r>
           </a:p>
           <a:p>
@@ -6435,10 +6782,10 @@
               </a:spcAft>
             </a:pPr>
             <a:r>
-              <a:rPr lang="en-GB" sz="2400" dirty="0">
+              <a:rPr lang="en-GB" sz="2300" dirty="0">
                 <a:latin typeface="Palatino Linotype" panose="02040502050505030304" pitchFamily="18" charset="0"/>
               </a:rPr>
-              <a:t>Modal leap bonus </a:t>
+              <a:t>Voice leading</a:t>
             </a:r>
           </a:p>
           <a:p>
@@ -6448,10 +6795,10 @@
               </a:spcAft>
             </a:pPr>
             <a:r>
-              <a:rPr lang="en-GB" sz="2400" dirty="0">
+              <a:rPr lang="en-GB" sz="2300" dirty="0">
                 <a:latin typeface="Palatino Linotype" panose="02040502050505030304" pitchFamily="18" charset="0"/>
               </a:rPr>
-              <a:t>Stochastic thinning </a:t>
+              <a:t>Modal leap bonus </a:t>
             </a:r>
           </a:p>
           <a:p>
@@ -6461,21 +6808,10 @@
               </a:spcAft>
             </a:pPr>
             <a:r>
-              <a:rPr lang="en-GB" sz="2400" dirty="0">
+              <a:rPr lang="en-GB" sz="2300" dirty="0">
                 <a:latin typeface="Palatino Linotype" panose="02040502050505030304" pitchFamily="18" charset="0"/>
               </a:rPr>
-              <a:t>Phrase breathing</a:t>
-            </a:r>
-            <a:br>
-              <a:rPr lang="en-GB" sz="2400" dirty="0">
-                <a:latin typeface="Palatino Linotype" panose="02040502050505030304" pitchFamily="18" charset="0"/>
-              </a:rPr>
-            </a:br>
-            <a:r>
-              <a:rPr lang="en-GB" sz="2400" dirty="0">
-                <a:latin typeface="Palatino Linotype" panose="02040502050505030304" pitchFamily="18" charset="0"/>
-              </a:rPr>
-              <a:t>Singable duration bias</a:t>
+              <a:t>Stochastic thinning </a:t>
             </a:r>
           </a:p>
           <a:p>
@@ -6485,10 +6821,21 @@
               </a:spcAft>
             </a:pPr>
             <a:r>
-              <a:rPr lang="en-GB" sz="2400" dirty="0">
+              <a:rPr lang="en-GB" sz="2300" dirty="0">
                 <a:latin typeface="Palatino Linotype" panose="02040502050505030304" pitchFamily="18" charset="0"/>
               </a:rPr>
-              <a:t>Rhythmic density </a:t>
+              <a:t>Phrase breathing</a:t>
+            </a:r>
+            <a:br>
+              <a:rPr lang="en-GB" sz="2300" dirty="0">
+                <a:latin typeface="Palatino Linotype" panose="02040502050505030304" pitchFamily="18" charset="0"/>
+              </a:rPr>
+            </a:br>
+            <a:r>
+              <a:rPr lang="en-GB" sz="2300" dirty="0">
+                <a:latin typeface="Palatino Linotype" panose="02040502050505030304" pitchFamily="18" charset="0"/>
+              </a:rPr>
+              <a:t>Singable duration bias</a:t>
             </a:r>
           </a:p>
         </p:txBody>
@@ -6507,8 +6854,8 @@
         </p:nvSpPr>
         <p:spPr>
           <a:xfrm>
-            <a:off x="7504926" y="1351859"/>
-            <a:ext cx="4182577" cy="4729500"/>
+            <a:off x="7620536" y="1267779"/>
+            <a:ext cx="4182577" cy="4924425"/>
           </a:xfrm>
           <a:prstGeom prst="rect">
             <a:avLst/>
@@ -6527,10 +6874,10 @@
               </a:spcAft>
             </a:pPr>
             <a:r>
-              <a:rPr lang="en-GB" sz="2400" dirty="0">
+              <a:rPr lang="en-GB" sz="2300" dirty="0">
                 <a:latin typeface="Palatino Linotype" panose="02040502050505030304" pitchFamily="18" charset="0"/>
               </a:rPr>
-              <a:t>Rhythmic complementarity</a:t>
+              <a:t>Rhythmic density </a:t>
             </a:r>
           </a:p>
           <a:p>
@@ -6540,10 +6887,10 @@
               </a:spcAft>
             </a:pPr>
             <a:r>
-              <a:rPr lang="en-GB" sz="2400" dirty="0">
+              <a:rPr lang="en-GB" sz="2300" dirty="0">
                 <a:latin typeface="Palatino Linotype" panose="02040502050505030304" pitchFamily="18" charset="0"/>
               </a:rPr>
-              <a:t>Register contrast </a:t>
+              <a:t>Rhythmic complementarity</a:t>
             </a:r>
           </a:p>
           <a:p>
@@ -6553,10 +6900,10 @@
               </a:spcAft>
             </a:pPr>
             <a:r>
-              <a:rPr lang="en-GB" sz="2400" dirty="0">
+              <a:rPr lang="en-GB" sz="2300" dirty="0">
                 <a:latin typeface="Palatino Linotype" panose="02040502050505030304" pitchFamily="18" charset="0"/>
               </a:rPr>
-              <a:t>Phrase length control</a:t>
+              <a:t>Register contrast </a:t>
             </a:r>
           </a:p>
           <a:p>
@@ -6566,10 +6913,10 @@
               </a:spcAft>
             </a:pPr>
             <a:r>
-              <a:rPr lang="en-GB" sz="2400" dirty="0">
+              <a:rPr lang="en-GB" sz="2300" dirty="0">
                 <a:latin typeface="Palatino Linotype" panose="02040502050505030304" pitchFamily="18" charset="0"/>
               </a:rPr>
-              <a:t>Beat-matching / trading bars </a:t>
+              <a:t>Phrase length control</a:t>
             </a:r>
           </a:p>
           <a:p>
@@ -6579,10 +6926,10 @@
               </a:spcAft>
             </a:pPr>
             <a:r>
-              <a:rPr lang="en-GB" sz="2400" dirty="0">
+              <a:rPr lang="en-GB" sz="2300" dirty="0">
                 <a:latin typeface="Palatino Linotype" panose="02040502050505030304" pitchFamily="18" charset="0"/>
               </a:rPr>
-              <a:t>Repetition control</a:t>
+              <a:t>Beat-matching / trading bars </a:t>
             </a:r>
           </a:p>
           <a:p>
@@ -6592,10 +6939,10 @@
               </a:spcAft>
             </a:pPr>
             <a:r>
-              <a:rPr lang="en-GB" sz="2400" dirty="0">
+              <a:rPr lang="en-GB" sz="2300" dirty="0">
                 <a:latin typeface="Palatino Linotype" panose="02040502050505030304" pitchFamily="18" charset="0"/>
               </a:rPr>
-              <a:t>Sax riff / insistence</a:t>
+              <a:t>Repetition control</a:t>
             </a:r>
           </a:p>
           <a:p>
@@ -6605,10 +6952,10 @@
               </a:spcAft>
             </a:pPr>
             <a:r>
-              <a:rPr lang="en-GB" sz="2400" dirty="0">
+              <a:rPr lang="en-GB" sz="2300" dirty="0">
                 <a:latin typeface="Palatino Linotype" panose="02040502050505030304" pitchFamily="18" charset="0"/>
               </a:rPr>
-              <a:t>Proactive mode</a:t>
+              <a:t>Sax riff / insistence</a:t>
             </a:r>
           </a:p>
           <a:p>
@@ -6618,32 +6965,10 @@
               </a:spcAft>
             </a:pPr>
             <a:r>
-              <a:rPr lang="en-GB" sz="2400" dirty="0">
+              <a:rPr lang="en-GB" sz="2300" dirty="0">
                 <a:latin typeface="Palatino Linotype" panose="02040502050505030304" pitchFamily="18" charset="0"/>
               </a:rPr>
-              <a:t>Live phrase peeking</a:t>
-            </a:r>
-            <a:br>
-              <a:rPr lang="en-GB" sz="2400" dirty="0">
-                <a:latin typeface="Palatino Linotype" panose="02040502050505030304" pitchFamily="18" charset="0"/>
-              </a:rPr>
-            </a:br>
-            <a:r>
-              <a:rPr lang="en-GB" sz="2400" dirty="0">
-                <a:latin typeface="Palatino Linotype" panose="02040502050505030304" pitchFamily="18" charset="0"/>
-              </a:rPr>
-              <a:t>Beat-synchronised entry</a:t>
-            </a:r>
-            <a:br>
-              <a:rPr lang="en-GB" sz="2400" dirty="0">
-                <a:latin typeface="Palatino Linotype" panose="02040502050505030304" pitchFamily="18" charset="0"/>
-              </a:rPr>
-            </a:br>
-            <a:r>
-              <a:rPr lang="en-GB" sz="2400" dirty="0">
-                <a:latin typeface="Palatino Linotype" panose="02040502050505030304" pitchFamily="18" charset="0"/>
-              </a:rPr>
-              <a:t>Turn-taking </a:t>
+              <a:t>Proactive mode</a:t>
             </a:r>
           </a:p>
           <a:p>
@@ -6653,18 +6978,53 @@
               </a:spcAft>
             </a:pPr>
             <a:r>
-              <a:rPr lang="en-GB" sz="2400" dirty="0">
+              <a:rPr lang="en-GB" sz="2300" dirty="0">
                 <a:latin typeface="Palatino Linotype" panose="02040502050505030304" pitchFamily="18" charset="0"/>
               </a:rPr>
+              <a:t>Live phrase peeking</a:t>
+            </a:r>
+            <a:br>
+              <a:rPr lang="en-GB" sz="2300" dirty="0">
+                <a:latin typeface="Palatino Linotype" panose="02040502050505030304" pitchFamily="18" charset="0"/>
+              </a:rPr>
+            </a:br>
+            <a:r>
+              <a:rPr lang="en-GB" sz="2300" dirty="0">
+                <a:latin typeface="Palatino Linotype" panose="02040502050505030304" pitchFamily="18" charset="0"/>
+              </a:rPr>
+              <a:t>Beat-synchronised entry</a:t>
+            </a:r>
+            <a:br>
+              <a:rPr lang="en-GB" sz="2300" dirty="0">
+                <a:latin typeface="Palatino Linotype" panose="02040502050505030304" pitchFamily="18" charset="0"/>
+              </a:rPr>
+            </a:br>
+            <a:r>
+              <a:rPr lang="en-GB" sz="2300" dirty="0">
+                <a:latin typeface="Palatino Linotype" panose="02040502050505030304" pitchFamily="18" charset="0"/>
+              </a:rPr>
+              <a:t>Turn-taking </a:t>
+            </a:r>
+          </a:p>
+          <a:p>
+            <a:pPr>
+              <a:spcAft>
+                <a:spcPts val="200"/>
+              </a:spcAft>
+            </a:pPr>
+            <a:r>
+              <a:rPr lang="en-GB" sz="2300" dirty="0">
+                <a:latin typeface="Palatino Linotype" panose="02040502050505030304" pitchFamily="18" charset="0"/>
+              </a:rPr>
               <a:t>Loop mode</a:t>
             </a:r>
             <a:br>
-              <a:rPr lang="en-GB" sz="2400" dirty="0">
+              <a:rPr lang="en-GB" sz="2300" dirty="0">
                 <a:latin typeface="Palatino Linotype" panose="02040502050505030304" pitchFamily="18" charset="0"/>
               </a:rPr>
             </a:br>
             <a:r>
-              <a:rPr lang="en-GB" sz="2400" dirty="0">
+              <a:rPr lang="en-GB" sz="2300" dirty="0">
                 <a:latin typeface="Palatino Linotype" panose="02040502050505030304" pitchFamily="18" charset="0"/>
               </a:rPr>
               <a:t>Arc timing</a:t>
@@ -6686,7 +7046,7 @@
         </p:nvSpPr>
         <p:spPr>
           <a:xfrm>
-            <a:off x="9240640" y="6341731"/>
+            <a:off x="9450847" y="6318327"/>
             <a:ext cx="3363950" cy="400110"/>
           </a:xfrm>
           <a:prstGeom prst="rect">
@@ -6821,7 +7181,7 @@
               <a:rPr lang="en-GB" sz="2400" b="1" dirty="0">
                 <a:latin typeface="Palatino Linotype" panose="02040502050505030304" pitchFamily="18" charset="0"/>
               </a:rPr>
-              <a:t>Five giant steps in the arc…</a:t>
+              <a:t>The five giant steps in the arc…</a:t>
             </a:r>
             <a:br>
               <a:rPr lang="en-GB" sz="2400" b="1" dirty="0">
@@ -7526,7 +7886,7 @@
         <p:spPr>
           <a:xfrm>
             <a:off x="838200" y="1274771"/>
-            <a:ext cx="9514490" cy="5018049"/>
+            <a:ext cx="10271234" cy="5018049"/>
           </a:xfrm>
         </p:spPr>
         <p:txBody>
@@ -7619,7 +7979,19 @@
               <a:rPr lang="en-GB" sz="2200" dirty="0">
                 <a:latin typeface="Palatino Linotype" panose="02040502050505030304" pitchFamily="18" charset="0"/>
               </a:rPr>
-              <a:t> (Wayne Shorter). These songs are my favourite things*.</a:t>
+              <a:t> (Wayne Shorter), and the atmosphere of </a:t>
+            </a:r>
+            <a:r>
+              <a:rPr lang="en-GB" sz="2200" b="1" dirty="0">
+                <a:latin typeface="Palatino Linotype" panose="02040502050505030304" pitchFamily="18" charset="0"/>
+              </a:rPr>
+              <a:t>In a Silent Way </a:t>
+            </a:r>
+            <a:r>
+              <a:rPr lang="en-GB" sz="2200" dirty="0">
+                <a:latin typeface="Palatino Linotype" panose="02040502050505030304" pitchFamily="18" charset="0"/>
+              </a:rPr>
+              <a:t>(Miles Davis). These songs are my favourite things*.</a:t>
             </a:r>
           </a:p>
           <a:p>
@@ -7632,7 +8004,7 @@
               <a:rPr lang="en-GB" sz="2400" dirty="0">
                 <a:latin typeface="Palatino Linotype" panose="02040502050505030304" pitchFamily="18" charset="0"/>
               </a:rPr>
-              <a:t>But also a journey through jazz:</a:t>
+              <a:t>The arc also traces a journey through jazz history :</a:t>
             </a:r>
           </a:p>
           <a:p>
@@ -7671,7 +8043,7 @@
               <a:rPr lang="en-GB" sz="2200" dirty="0">
                 <a:latin typeface="Palatino Linotype" panose="02040502050505030304" pitchFamily="18" charset="0"/>
               </a:rPr>
-              <a:t>Peak progression echoes hard bop,</a:t>
+              <a:t>Peak combines hard bop drive with modal intensity,</a:t>
             </a:r>
           </a:p>
           <a:p>
@@ -7684,7 +8056,18 @@
               <a:rPr lang="en-GB" sz="2200" dirty="0">
                 <a:latin typeface="Palatino Linotype" panose="02040502050505030304" pitchFamily="18" charset="0"/>
               </a:rPr>
-              <a:t>Pedal resolution has the meditative quality of late Coltrane.</a:t>
+              <a:t>Pedal resolution has the meditative quality of late Coltrane</a:t>
+            </a:r>
+            <a:br>
+              <a:rPr lang="en-GB" sz="2200" dirty="0">
+                <a:latin typeface="Palatino Linotype" panose="02040502050505030304" pitchFamily="18" charset="0"/>
+              </a:rPr>
+            </a:br>
+            <a:r>
+              <a:rPr lang="en-GB" sz="2200" dirty="0">
+                <a:latin typeface="Palatino Linotype" panose="02040502050505030304" pitchFamily="18" charset="0"/>
+              </a:rPr>
+              <a:t>e.g. A Love Supreme.</a:t>
             </a:r>
           </a:p>
         </p:txBody>
@@ -7724,7 +8107,13 @@
               <a:rPr lang="en-GB" sz="2000" dirty="0">
                 <a:latin typeface="Palatino Linotype" panose="02040502050505030304" pitchFamily="18" charset="0"/>
               </a:rPr>
-              <a:t>* John Coltrane</a:t>
+              <a:t>* </a:t>
+            </a:r>
+            <a:r>
+              <a:rPr lang="en-GB" sz="2000" i="1" dirty="0">
+                <a:latin typeface="Palatino Linotype" panose="02040502050505030304" pitchFamily="18" charset="0"/>
+              </a:rPr>
+              <a:t>John Coltrane</a:t>
             </a:r>
           </a:p>
         </p:txBody>
@@ -7775,7 +8164,7 @@
         </p:nvSpPr>
         <p:spPr>
           <a:xfrm>
-            <a:off x="9751962" y="4464375"/>
+            <a:off x="9424410" y="4424864"/>
             <a:ext cx="2264263" cy="1662546"/>
           </a:xfrm>
           <a:prstGeom prst="rect">
@@ -7788,13 +8177,13 @@
           <a:bodyPr wrap="square" lIns="0" tIns="0" rIns="0" bIns="0" rtlCol="0" anchor="ctr"/>
           <a:lstStyle/>
           <a:p>
-            <a:pPr defTabSz="1219170"/>
+            <a:pPr algn="ctr" defTabSz="1219170"/>
             <a:r>
               <a:rPr lang="en-US" sz="4800" b="1" dirty="0">
                 <a:solidFill>
                   <a:srgbClr val="FFFFFF"/>
                 </a:solidFill>
-                <a:latin typeface="Calibri" pitchFamily="34" charset="0"/>
+                <a:latin typeface="Optima" panose="02000503060000020004" pitchFamily="2" charset="0"/>
                 <a:ea typeface="Calibri" pitchFamily="34" charset="-122"/>
                 <a:cs typeface="Calibri" pitchFamily="34" charset="-120"/>
               </a:rPr>
@@ -7804,7 +8193,7 @@
               <a:solidFill>
                 <a:prstClr val="black"/>
               </a:solidFill>
-              <a:latin typeface="Calibri" panose="020F0502020204030204"/>
+              <a:latin typeface="Optima" panose="02000503060000020004" pitchFamily="2" charset="0"/>
             </a:endParaRPr>
           </a:p>
         </p:txBody>
@@ -9361,8 +9750,8 @@
         </p:nvSpPr>
         <p:spPr>
           <a:xfrm>
-            <a:off x="8535678" y="240298"/>
-            <a:ext cx="2888140" cy="1394410"/>
+            <a:off x="8308575" y="240298"/>
+            <a:ext cx="3115243" cy="1394410"/>
           </a:xfrm>
           <a:prstGeom prst="rect">
             <a:avLst/>
@@ -9380,7 +9769,7 @@
                 <a:solidFill>
                   <a:srgbClr val="FFFFFF"/>
                 </a:solidFill>
-                <a:latin typeface="Calibri" pitchFamily="34" charset="0"/>
+                <a:latin typeface="Optima" panose="02000503060000020004" pitchFamily="2" charset="0"/>
                 <a:ea typeface="Calibri" pitchFamily="34" charset="-122"/>
                 <a:cs typeface="Calibri" pitchFamily="34" charset="-120"/>
               </a:rPr>
@@ -9390,7 +9779,7 @@
               <a:solidFill>
                 <a:prstClr val="black"/>
               </a:solidFill>
-              <a:latin typeface="Calibri" panose="020F0502020204030204"/>
+              <a:latin typeface="Optima" panose="02000503060000020004" pitchFamily="2" charset="0"/>
             </a:endParaRPr>
           </a:p>
         </p:txBody>
@@ -9734,8 +10123,11 @@
                 <a:ea typeface="Calibri" pitchFamily="34" charset="-122"/>
                 <a:cs typeface="Calibri" pitchFamily="34" charset="-120"/>
               </a:rPr>
-              <a:t>register contrast  ·  scale pitch bias  ·  contour steering · swing/triplet bias · energy arc shaping · long-note penalty · singable duration bias  ·  motivic development · voice leading  ·  modal leap · bonus (P4/P5)  ·  repetition penalty · rest injection  ·  beat accumulator</a:t>
-            </a:r>
+              <a:t>register contrast  ·  scale pitch bias  ·  contour steering · swing/triplet bias · energy arc shaping · long-note penalty · singable duration bias  ·  motivic development · voice leading  ·  modal leap · bonus (P4/P5)  ·  repetition penalty · rest injection  ·  beat accumulator · rhythmic displacement</a:t>
+            </a:r>
+          </a:p>
+          <a:p>
+            <a:pPr defTabSz="1219170"/>
             <a:endParaRPr lang="en-US" sz="1600" dirty="0">
               <a:solidFill>
                 <a:prstClr val="black"/>
@@ -10937,8 +11329,8 @@
         </p:blipFill>
         <p:spPr>
           <a:xfrm>
-            <a:off x="6140340" y="1429062"/>
-            <a:ext cx="5470057" cy="4147015"/>
+            <a:off x="6140340" y="1429063"/>
+            <a:ext cx="5199271" cy="3941724"/>
           </a:xfrm>
           <a:prstGeom prst="rect">
             <a:avLst/>
@@ -10967,8 +11359,8 @@
         </p:blipFill>
         <p:spPr>
           <a:xfrm>
-            <a:off x="964580" y="1429063"/>
-            <a:ext cx="4831664" cy="4147015"/>
+            <a:off x="964580" y="1429064"/>
+            <a:ext cx="4592481" cy="3941724"/>
           </a:xfrm>
           <a:prstGeom prst="rect">
             <a:avLst/>
@@ -10989,8 +11381,8 @@
         </p:nvSpPr>
         <p:spPr>
           <a:xfrm>
-            <a:off x="2821259" y="5846544"/>
-            <a:ext cx="6846848" cy="646331"/>
+            <a:off x="2672576" y="5628972"/>
+            <a:ext cx="6846848" cy="1015663"/>
           </a:xfrm>
           <a:prstGeom prst="rect">
             <a:avLst/>
@@ -11003,6 +11395,13 @@
           </a:bodyPr>
           <a:lstStyle/>
           <a:p>
+            <a:pPr algn="ctr"/>
+            <a:r>
+              <a:rPr lang="en-US" sz="2400" dirty="0">
+                <a:latin typeface="Optima" panose="02000503060000020004" pitchFamily="2" charset="0"/>
+              </a:rPr>
+              <a:t>Watch live during the performance on </a:t>
+            </a:r>
             <a:r>
               <a:rPr lang="en-US" sz="3600" b="1" dirty="0" err="1"/>
               <a:t>wolfson.numbersintonotes.net</a:t>

</xml_diff>

<commit_message>
Add proactive trading mode, fix pedal resolution, update performance plan
- arc_controller: PROACTIVE_MAX_WAIT (8s) interrupts extended bass riffs;
  PROACTIVE_ACTIVE_INTERVAL (4s) keeps sax trading while bass continues
- harmony: arc_position > 0.9 forces i minor at arc end regardless of tempo,
  fixing consistent Bb7 endings at 55 BPM
- performance_plan: redesigned as single landscape sheet with 5-column arc
  layout; adds Q&A vs trading mode guidance for performer

Co-Authored-By: Claude Sonnet 4.6 <noreply@anthropic.com>
</commit_message>
<xml_diff>
--- a/docs/wolfson.pptx
+++ b/docs/wolfson.pptx
@@ -6,20 +6,22 @@
     <p:sldMasterId id="2147483660" r:id="rId2"/>
   </p:sldMasterIdLst>
   <p:notesMasterIdLst>
-    <p:notesMasterId r:id="rId14"/>
+    <p:notesMasterId r:id="rId16"/>
   </p:notesMasterIdLst>
   <p:sldIdLst>
     <p:sldId id="256" r:id="rId3"/>
     <p:sldId id="257" r:id="rId4"/>
-    <p:sldId id="259" r:id="rId5"/>
-    <p:sldId id="258" r:id="rId6"/>
-    <p:sldId id="264" r:id="rId7"/>
-    <p:sldId id="262" r:id="rId8"/>
-    <p:sldId id="263" r:id="rId9"/>
-    <p:sldId id="266" r:id="rId10"/>
-    <p:sldId id="260" r:id="rId11"/>
-    <p:sldId id="265" r:id="rId12"/>
-    <p:sldId id="261" r:id="rId13"/>
+    <p:sldId id="267" r:id="rId5"/>
+    <p:sldId id="259" r:id="rId6"/>
+    <p:sldId id="258" r:id="rId7"/>
+    <p:sldId id="264" r:id="rId8"/>
+    <p:sldId id="262" r:id="rId9"/>
+    <p:sldId id="263" r:id="rId10"/>
+    <p:sldId id="266" r:id="rId11"/>
+    <p:sldId id="260" r:id="rId12"/>
+    <p:sldId id="265" r:id="rId13"/>
+    <p:sldId id="261" r:id="rId14"/>
+    <p:sldId id="268" r:id="rId15"/>
   </p:sldIdLst>
   <p:sldSz cx="12192000" cy="6858000"/>
   <p:notesSz cx="6858000" cy="9144000"/>
@@ -649,7 +651,7 @@
           <a:p>
             <a:fld id="{F4125BD8-DB9E-B04B-ACC5-175F26D74AAD}" type="slidenum">
               <a:rPr lang="en-US" smtClean="0"/>
-              <a:t>10</a:t>
+              <a:t>11</a:t>
             </a:fld>
             <a:endParaRPr lang="en-US"/>
           </a:p>
@@ -733,7 +735,7 @@
           <a:p>
             <a:fld id="{F4125BD8-DB9E-B04B-ACC5-175F26D74AAD}" type="slidenum">
               <a:rPr lang="en-US" smtClean="0"/>
-              <a:t>11</a:t>
+              <a:t>12</a:t>
             </a:fld>
             <a:endParaRPr lang="en-US"/>
           </a:p>
@@ -901,7 +903,7 @@
           <a:p>
             <a:fld id="{F4125BD8-DB9E-B04B-ACC5-175F26D74AAD}" type="slidenum">
               <a:rPr lang="en-US" smtClean="0"/>
-              <a:t>3</a:t>
+              <a:t>4</a:t>
             </a:fld>
             <a:endParaRPr lang="en-US"/>
           </a:p>
@@ -985,7 +987,7 @@
           <a:p>
             <a:fld id="{F4125BD8-DB9E-B04B-ACC5-175F26D74AAD}" type="slidenum">
               <a:rPr lang="en-US" smtClean="0"/>
-              <a:t>4</a:t>
+              <a:t>5</a:t>
             </a:fld>
             <a:endParaRPr lang="en-US"/>
           </a:p>
@@ -1093,7 +1095,7 @@
           <a:p>
             <a:fld id="{F4125BD8-DB9E-B04B-ACC5-175F26D74AAD}" type="slidenum">
               <a:rPr lang="en-US" smtClean="0"/>
-              <a:t>5</a:t>
+              <a:t>6</a:t>
             </a:fld>
             <a:endParaRPr lang="en-US"/>
           </a:p>
@@ -1224,7 +1226,7 @@
                 <a:tabLst/>
                 <a:defRPr/>
               </a:pPr>
-              <a:t>6</a:t>
+              <a:t>7</a:t>
             </a:fld>
             <a:endParaRPr kumimoji="0" lang="en-US" sz="1800" b="0" i="0" u="none" strike="noStrike" kern="1200" cap="none" spc="0" normalizeH="0" baseline="0" noProof="0">
               <a:ln>
@@ -1368,7 +1370,7 @@
                 <a:tabLst/>
                 <a:defRPr/>
               </a:pPr>
-              <a:t>7</a:t>
+              <a:t>8</a:t>
             </a:fld>
             <a:endParaRPr kumimoji="0" lang="en-US" sz="1800" b="0" i="0" u="none" strike="noStrike" kern="1200" cap="none" spc="0" normalizeH="0" baseline="0" noProof="0">
               <a:ln>
@@ -1489,7 +1491,7 @@
           <a:p>
             <a:fld id="{F4125BD8-DB9E-B04B-ACC5-175F26D74AAD}" type="slidenum">
               <a:rPr lang="en-US" smtClean="0"/>
-              <a:t>8</a:t>
+              <a:t>9</a:t>
             </a:fld>
             <a:endParaRPr lang="en-US"/>
           </a:p>
@@ -1573,7 +1575,7 @@
           <a:p>
             <a:fld id="{F4125BD8-DB9E-B04B-ACC5-175F26D74AAD}" type="slidenum">
               <a:rPr lang="en-US" smtClean="0"/>
-              <a:t>9</a:t>
+              <a:t>10</a:t>
             </a:fld>
             <a:endParaRPr lang="en-US"/>
           </a:p>
@@ -5339,6 +5341,523 @@
         <p:cNvPr id="1" name="">
           <a:extLst>
             <a:ext uri="{FF2B5EF4-FFF2-40B4-BE49-F238E27FC236}">
+              <a16:creationId xmlns:a16="http://schemas.microsoft.com/office/drawing/2014/main" id="{12D793BB-5984-061A-79FE-248D7810A2B1}"/>
+            </a:ext>
+          </a:extLst>
+        </p:cNvPr>
+        <p:cNvGrpSpPr/>
+        <p:nvPr/>
+      </p:nvGrpSpPr>
+      <p:grpSpPr>
+        <a:xfrm>
+          <a:off x="0" y="0"/>
+          <a:ext cx="0" cy="0"/>
+          <a:chOff x="0" y="0"/>
+          <a:chExt cx="0" cy="0"/>
+        </a:xfrm>
+      </p:grpSpPr>
+      <p:sp>
+        <p:nvSpPr>
+          <p:cNvPr id="5" name="Content Placeholder 4">
+            <a:extLst>
+              <a:ext uri="{FF2B5EF4-FFF2-40B4-BE49-F238E27FC236}">
+                <a16:creationId xmlns:a16="http://schemas.microsoft.com/office/drawing/2014/main" id="{50065DF7-EEE5-CCF2-2669-649CAF486EFE}"/>
+              </a:ext>
+            </a:extLst>
+          </p:cNvPr>
+          <p:cNvSpPr>
+            <a:spLocks noGrp="1"/>
+          </p:cNvSpPr>
+          <p:nvPr>
+            <p:ph idx="1"/>
+          </p:nvPr>
+        </p:nvSpPr>
+        <p:spPr>
+          <a:xfrm>
+            <a:off x="838199" y="903249"/>
+            <a:ext cx="8400393" cy="5273714"/>
+          </a:xfrm>
+        </p:spPr>
+        <p:txBody>
+          <a:bodyPr>
+            <a:normAutofit fontScale="92500"/>
+          </a:bodyPr>
+          <a:lstStyle/>
+          <a:p>
+            <a:r>
+              <a:rPr lang="en-US" dirty="0">
+                <a:latin typeface="Palatino Linotype" panose="02040502050505030304" pitchFamily="18" charset="0"/>
+              </a:rPr>
+              <a:t>Repo is on </a:t>
+            </a:r>
+            <a:r>
+              <a:rPr lang="en-US" dirty="0">
+                <a:latin typeface="Palatino Linotype" panose="02040502050505030304" pitchFamily="18" charset="0"/>
+                <a:hlinkClick r:id="rId3"/>
+              </a:rPr>
+              <a:t>github.com/davidderoure/wolfson</a:t>
+            </a:r>
+            <a:r>
+              <a:rPr lang="en-US" dirty="0">
+                <a:latin typeface="Palatino Linotype" panose="02040502050505030304" pitchFamily="18" charset="0"/>
+              </a:rPr>
+              <a:t>  </a:t>
+            </a:r>
+          </a:p>
+          <a:p>
+            <a:endParaRPr lang="en-US" dirty="0">
+              <a:latin typeface="Palatino Linotype" panose="02040502050505030304" pitchFamily="18" charset="0"/>
+            </a:endParaRPr>
+          </a:p>
+          <a:p>
+            <a:r>
+              <a:rPr lang="en-US" dirty="0">
+                <a:latin typeface="Palatino Linotype" panose="02040502050505030304" pitchFamily="18" charset="0"/>
+              </a:rPr>
+              <a:t>Acknowledgement:</a:t>
+            </a:r>
+          </a:p>
+          <a:p>
+            <a:pPr lvl="1"/>
+            <a:r>
+              <a:rPr lang="en-US" sz="2200" dirty="0">
+                <a:latin typeface="Palatino Linotype" panose="02040502050505030304" pitchFamily="18" charset="0"/>
+              </a:rPr>
+              <a:t>Ray </a:t>
+            </a:r>
+            <a:r>
+              <a:rPr lang="en-US" sz="2200" dirty="0" err="1">
+                <a:latin typeface="Palatino Linotype" panose="02040502050505030304" pitchFamily="18" charset="0"/>
+              </a:rPr>
+              <a:t>d’Inverno</a:t>
+            </a:r>
+            <a:r>
+              <a:rPr lang="en-US" sz="2200" dirty="0">
+                <a:latin typeface="Palatino Linotype" panose="02040502050505030304" pitchFamily="18" charset="0"/>
+              </a:rPr>
+              <a:t> (for jazz, Lisp, AI, slick licks)</a:t>
+            </a:r>
+          </a:p>
+          <a:p>
+            <a:pPr lvl="1"/>
+            <a:r>
+              <a:rPr lang="en-US" sz="2200" dirty="0">
+                <a:latin typeface="Palatino Linotype" panose="02040502050505030304" pitchFamily="18" charset="0"/>
+              </a:rPr>
+              <a:t>Mark </a:t>
+            </a:r>
+            <a:r>
+              <a:rPr lang="en-US" sz="2200" dirty="0" err="1">
+                <a:latin typeface="Palatino Linotype" panose="02040502050505030304" pitchFamily="18" charset="0"/>
+              </a:rPr>
+              <a:t>d’Inverno</a:t>
+            </a:r>
+            <a:r>
+              <a:rPr lang="en-US" sz="2200" dirty="0">
+                <a:latin typeface="Palatino Linotype" panose="02040502050505030304" pitchFamily="18" charset="0"/>
+              </a:rPr>
+              <a:t> (for jazz, AI, creativity, slick licks)</a:t>
+            </a:r>
+          </a:p>
+          <a:p>
+            <a:pPr lvl="1"/>
+            <a:r>
+              <a:rPr lang="en-US" sz="2200" dirty="0">
+                <a:latin typeface="Palatino Linotype" panose="02040502050505030304" pitchFamily="18" charset="0"/>
+              </a:rPr>
+              <a:t>George E Lewis (for Voyager and Forager)</a:t>
+            </a:r>
+          </a:p>
+          <a:p>
+            <a:pPr lvl="1"/>
+            <a:r>
+              <a:rPr lang="en-US" sz="2200" dirty="0">
+                <a:latin typeface="Palatino Linotype" panose="02040502050505030304" pitchFamily="18" charset="0"/>
+              </a:rPr>
+              <a:t>Robert Laidlow (for Alter-</a:t>
+            </a:r>
+            <a:r>
+              <a:rPr lang="en-US" sz="2200" dirty="0" err="1">
+                <a:latin typeface="Palatino Linotype" panose="02040502050505030304" pitchFamily="18" charset="0"/>
+              </a:rPr>
+              <a:t>ing</a:t>
+            </a:r>
+            <a:r>
+              <a:rPr lang="en-US" sz="2200" dirty="0">
+                <a:latin typeface="Palatino Linotype" panose="02040502050505030304" pitchFamily="18" charset="0"/>
+              </a:rPr>
+              <a:t> Ada Lovelace, and sax)</a:t>
+            </a:r>
+          </a:p>
+          <a:p>
+            <a:pPr lvl="1"/>
+            <a:r>
+              <a:rPr lang="en-US" sz="2200" dirty="0" err="1">
+                <a:latin typeface="Palatino Linotype" panose="02040502050505030304" pitchFamily="18" charset="0"/>
+              </a:rPr>
+              <a:t>Hongshuo</a:t>
+            </a:r>
+            <a:r>
+              <a:rPr lang="en-US" sz="2200" dirty="0">
+                <a:latin typeface="Palatino Linotype" panose="02040502050505030304" pitchFamily="18" charset="0"/>
+              </a:rPr>
+              <a:t> Fan (for Music Gesture Recognition)</a:t>
+            </a:r>
+          </a:p>
+          <a:p>
+            <a:pPr lvl="1"/>
+            <a:r>
+              <a:rPr lang="en-US" sz="2200" dirty="0" err="1">
+                <a:latin typeface="Palatino Linotype" panose="02040502050505030304" pitchFamily="18" charset="0"/>
+              </a:rPr>
+              <a:t>Bofan</a:t>
+            </a:r>
+            <a:r>
+              <a:rPr lang="en-US" sz="2200" dirty="0">
+                <a:latin typeface="Palatino Linotype" panose="02040502050505030304" pitchFamily="18" charset="0"/>
+              </a:rPr>
+              <a:t> Ma (for always enabling musicality)</a:t>
+            </a:r>
+          </a:p>
+          <a:p>
+            <a:pPr lvl="1"/>
+            <a:r>
+              <a:rPr lang="en-US" sz="2200" dirty="0">
+                <a:latin typeface="Palatino Linotype" panose="02040502050505030304" pitchFamily="18" charset="0"/>
+              </a:rPr>
+              <a:t>Maria </a:t>
+            </a:r>
+            <a:r>
+              <a:rPr lang="en-US" sz="2200" dirty="0" err="1">
+                <a:latin typeface="Palatino Linotype" panose="02040502050505030304" pitchFamily="18" charset="0"/>
+              </a:rPr>
+              <a:t>Kallionpää</a:t>
+            </a:r>
+            <a:r>
+              <a:rPr lang="en-US" sz="2200" dirty="0">
+                <a:latin typeface="Palatino Linotype" panose="02040502050505030304" pitchFamily="18" charset="0"/>
+              </a:rPr>
+              <a:t> (for Climb!)</a:t>
+            </a:r>
+          </a:p>
+          <a:p>
+            <a:pPr lvl="1"/>
+            <a:r>
+              <a:rPr lang="en-US" sz="2200" dirty="0">
+                <a:latin typeface="Palatino Linotype" panose="02040502050505030304" pitchFamily="18" charset="0"/>
+              </a:rPr>
+              <a:t>Ada Lovelace &amp; Emily Howard (for Numbers into Notes)</a:t>
+            </a:r>
+          </a:p>
+          <a:p>
+            <a:pPr lvl="1"/>
+            <a:r>
+              <a:rPr lang="en-US" sz="2200" dirty="0">
+                <a:latin typeface="Palatino Linotype" panose="02040502050505030304" pitchFamily="18" charset="0"/>
+              </a:rPr>
+              <a:t>Wolfson Digital Research Cluster, </a:t>
+            </a:r>
+            <a:r>
+              <a:rPr lang="en-US" sz="2200" dirty="0" err="1">
+                <a:latin typeface="Palatino Linotype" panose="02040502050505030304" pitchFamily="18" charset="0"/>
+              </a:rPr>
+              <a:t>DiSc</a:t>
+            </a:r>
+            <a:r>
+              <a:rPr lang="en-US" sz="2200" dirty="0">
+                <a:latin typeface="Palatino Linotype" panose="02040502050505030304" pitchFamily="18" charset="0"/>
+              </a:rPr>
+              <a:t> &amp; TORCH (for AIMC 2024)</a:t>
+            </a:r>
+          </a:p>
+          <a:p>
+            <a:pPr lvl="1"/>
+            <a:endParaRPr lang="en-US" dirty="0">
+              <a:latin typeface="Palatino Linotype" panose="02040502050505030304" pitchFamily="18" charset="0"/>
+            </a:endParaRPr>
+          </a:p>
+          <a:p>
+            <a:pPr lvl="0"/>
+            <a:r>
+              <a:rPr lang="en-US" sz="2400" i="1" dirty="0">
+                <a:latin typeface="Palatino Linotype" panose="02040502050505030304" pitchFamily="18" charset="0"/>
+              </a:rPr>
+              <a:t>Grand Challenges for Computing Research</a:t>
+            </a:r>
+            <a:r>
+              <a:rPr lang="en-US" sz="2400" dirty="0">
+                <a:latin typeface="Palatino Linotype" panose="02040502050505030304" pitchFamily="18" charset="0"/>
+              </a:rPr>
+              <a:t> – Tony Hoare</a:t>
+            </a:r>
+          </a:p>
+          <a:p>
+            <a:endParaRPr lang="en-US" sz="2400" dirty="0">
+              <a:latin typeface="Palatino Linotype" panose="02040502050505030304" pitchFamily="18" charset="0"/>
+            </a:endParaRPr>
+          </a:p>
+        </p:txBody>
+      </p:sp>
+      <p:pic>
+        <p:nvPicPr>
+          <p:cNvPr id="14" name="Picture 13" descr="A blue and white logo&#10;&#10;Description automatically generated">
+            <a:extLst>
+              <a:ext uri="{FF2B5EF4-FFF2-40B4-BE49-F238E27FC236}">
+                <a16:creationId xmlns:a16="http://schemas.microsoft.com/office/drawing/2014/main" id="{AE2E2FB4-45D4-955A-DA70-41F10F631EA5}"/>
+              </a:ext>
+            </a:extLst>
+          </p:cNvPr>
+          <p:cNvPicPr>
+            <a:picLocks noChangeAspect="1"/>
+          </p:cNvPicPr>
+          <p:nvPr/>
+        </p:nvPicPr>
+        <p:blipFill>
+          <a:blip r:embed="rId4" cstate="print">
+            <a:extLst>
+              <a:ext uri="{28A0092B-C50C-407E-A947-70E740481C1C}">
+                <a14:useLocalDpi xmlns:a14="http://schemas.microsoft.com/office/drawing/2010/main" val="0"/>
+              </a:ext>
+            </a:extLst>
+          </a:blip>
+          <a:stretch>
+            <a:fillRect/>
+          </a:stretch>
+        </p:blipFill>
+        <p:spPr>
+          <a:xfrm>
+            <a:off x="9792449" y="2074097"/>
+            <a:ext cx="741532" cy="741532"/>
+          </a:xfrm>
+          <a:prstGeom prst="rect">
+            <a:avLst/>
+          </a:prstGeom>
+        </p:spPr>
+      </p:pic>
+      <p:pic>
+        <p:nvPicPr>
+          <p:cNvPr id="16" name="Picture 15" descr="torch logo icon">
+            <a:extLst>
+              <a:ext uri="{FF2B5EF4-FFF2-40B4-BE49-F238E27FC236}">
+                <a16:creationId xmlns:a16="http://schemas.microsoft.com/office/drawing/2014/main" id="{AF5C0374-A45C-8F4F-13B3-71AE93C08BDB}"/>
+              </a:ext>
+            </a:extLst>
+          </p:cNvPr>
+          <p:cNvPicPr>
+            <a:picLocks noChangeAspect="1"/>
+          </p:cNvPicPr>
+          <p:nvPr/>
+        </p:nvPicPr>
+        <p:blipFill>
+          <a:blip r:embed="rId5" cstate="print">
+            <a:extLst>
+              <a:ext uri="{28A0092B-C50C-407E-A947-70E740481C1C}">
+                <a14:useLocalDpi xmlns:a14="http://schemas.microsoft.com/office/drawing/2010/main" val="0"/>
+              </a:ext>
+            </a:extLst>
+          </a:blip>
+          <a:srcRect/>
+          <a:stretch>
+            <a:fillRect/>
+          </a:stretch>
+        </p:blipFill>
+        <p:spPr bwMode="auto">
+          <a:xfrm>
+            <a:off x="10580223" y="2077414"/>
+            <a:ext cx="737827" cy="737827"/>
+          </a:xfrm>
+          <a:prstGeom prst="rect">
+            <a:avLst/>
+          </a:prstGeom>
+          <a:noFill/>
+          <a:ln>
+            <a:noFill/>
+          </a:ln>
+        </p:spPr>
+      </p:pic>
+      <p:pic>
+        <p:nvPicPr>
+          <p:cNvPr id="17" name="Picture 16" descr="performance research logo black">
+            <a:extLst>
+              <a:ext uri="{FF2B5EF4-FFF2-40B4-BE49-F238E27FC236}">
+                <a16:creationId xmlns:a16="http://schemas.microsoft.com/office/drawing/2014/main" id="{4898947E-1E9F-6C26-EC1A-DCA7850E59F7}"/>
+              </a:ext>
+            </a:extLst>
+          </p:cNvPr>
+          <p:cNvPicPr>
+            <a:picLocks noChangeAspect="1"/>
+          </p:cNvPicPr>
+          <p:nvPr/>
+        </p:nvPicPr>
+        <p:blipFill>
+          <a:blip r:embed="rId6">
+            <a:extLst>
+              <a:ext uri="{28A0092B-C50C-407E-A947-70E740481C1C}">
+                <a14:useLocalDpi xmlns:a14="http://schemas.microsoft.com/office/drawing/2010/main" val="0"/>
+              </a:ext>
+            </a:extLst>
+          </a:blip>
+          <a:srcRect/>
+          <a:stretch>
+            <a:fillRect/>
+          </a:stretch>
+        </p:blipFill>
+        <p:spPr bwMode="auto">
+          <a:xfrm>
+            <a:off x="9782407" y="3916247"/>
+            <a:ext cx="1578927" cy="892113"/>
+          </a:xfrm>
+          <a:prstGeom prst="rect">
+            <a:avLst/>
+          </a:prstGeom>
+          <a:noFill/>
+          <a:ln>
+            <a:noFill/>
+          </a:ln>
+        </p:spPr>
+      </p:pic>
+      <p:pic>
+        <p:nvPicPr>
+          <p:cNvPr id="18" name="Picture 17" descr="A green and white logo&#10;&#10;Description automatically generated">
+            <a:extLst>
+              <a:ext uri="{FF2B5EF4-FFF2-40B4-BE49-F238E27FC236}">
+                <a16:creationId xmlns:a16="http://schemas.microsoft.com/office/drawing/2014/main" id="{E44206BB-E239-0EB4-52D5-DB5A84D1386C}"/>
+              </a:ext>
+            </a:extLst>
+          </p:cNvPr>
+          <p:cNvPicPr>
+            <a:picLocks noChangeAspect="1"/>
+          </p:cNvPicPr>
+          <p:nvPr/>
+        </p:nvPicPr>
+        <p:blipFill>
+          <a:blip r:embed="rId7" cstate="print">
+            <a:extLst>
+              <a:ext uri="{28A0092B-C50C-407E-A947-70E740481C1C}">
+                <a14:useLocalDpi xmlns:a14="http://schemas.microsoft.com/office/drawing/2010/main" val="0"/>
+              </a:ext>
+            </a:extLst>
+          </a:blip>
+          <a:stretch>
+            <a:fillRect/>
+          </a:stretch>
+        </p:blipFill>
+        <p:spPr>
+          <a:xfrm>
+            <a:off x="9782407" y="2994854"/>
+            <a:ext cx="1535643" cy="779824"/>
+          </a:xfrm>
+          <a:prstGeom prst="rect">
+            <a:avLst/>
+          </a:prstGeom>
+        </p:spPr>
+      </p:pic>
+      <p:pic>
+        <p:nvPicPr>
+          <p:cNvPr id="19" name="Picture 2" descr="PRiSM logo with text">
+            <a:extLst>
+              <a:ext uri="{FF2B5EF4-FFF2-40B4-BE49-F238E27FC236}">
+                <a16:creationId xmlns:a16="http://schemas.microsoft.com/office/drawing/2014/main" id="{F097A706-7944-CDD7-69C4-1D5CA675F226}"/>
+              </a:ext>
+            </a:extLst>
+          </p:cNvPr>
+          <p:cNvPicPr>
+            <a:picLocks noChangeAspect="1" noChangeArrowheads="1"/>
+          </p:cNvPicPr>
+          <p:nvPr/>
+        </p:nvPicPr>
+        <p:blipFill>
+          <a:blip r:embed="rId8">
+            <a:extLst>
+              <a:ext uri="{28A0092B-C50C-407E-A947-70E740481C1C}">
+                <a14:useLocalDpi xmlns:a14="http://schemas.microsoft.com/office/drawing/2010/main" val="0"/>
+              </a:ext>
+            </a:extLst>
+          </a:blip>
+          <a:srcRect/>
+          <a:stretch>
+            <a:fillRect/>
+          </a:stretch>
+        </p:blipFill>
+        <p:spPr bwMode="auto">
+          <a:xfrm>
+            <a:off x="9418320" y="722397"/>
+            <a:ext cx="2079898" cy="892113"/>
+          </a:xfrm>
+          <a:prstGeom prst="rect">
+            <a:avLst/>
+          </a:prstGeom>
+          <a:noFill/>
+          <a:extLst>
+            <a:ext uri="{909E8E84-426E-40DD-AFC4-6F175D3DCCD1}">
+              <a14:hiddenFill xmlns:a14="http://schemas.microsoft.com/office/drawing/2010/main">
+                <a:solidFill>
+                  <a:srgbClr val="FFFFFF"/>
+                </a:solidFill>
+              </a14:hiddenFill>
+            </a:ext>
+          </a:extLst>
+        </p:spPr>
+      </p:pic>
+      <p:pic>
+        <p:nvPicPr>
+          <p:cNvPr id="2" name="Picture 1" descr="Home - Wolfson College">
+            <a:extLst>
+              <a:ext uri="{FF2B5EF4-FFF2-40B4-BE49-F238E27FC236}">
+                <a16:creationId xmlns:a16="http://schemas.microsoft.com/office/drawing/2014/main" id="{E16D70A7-BF5F-F8A7-82FF-A057B33F09FA}"/>
+              </a:ext>
+            </a:extLst>
+          </p:cNvPr>
+          <p:cNvPicPr>
+            <a:picLocks noChangeAspect="1"/>
+          </p:cNvPicPr>
+          <p:nvPr/>
+        </p:nvPicPr>
+        <p:blipFill>
+          <a:blip r:embed="rId9" cstate="print">
+            <a:extLst>
+              <a:ext uri="{28A0092B-C50C-407E-A947-70E740481C1C}">
+                <a14:useLocalDpi xmlns:a14="http://schemas.microsoft.com/office/drawing/2010/main" val="0"/>
+              </a:ext>
+            </a:extLst>
+          </a:blip>
+          <a:srcRect/>
+          <a:stretch>
+            <a:fillRect/>
+          </a:stretch>
+        </p:blipFill>
+        <p:spPr bwMode="auto">
+          <a:xfrm>
+            <a:off x="9699587" y="4982989"/>
+            <a:ext cx="1668788" cy="1668788"/>
+          </a:xfrm>
+          <a:prstGeom prst="rect">
+            <a:avLst/>
+          </a:prstGeom>
+          <a:noFill/>
+        </p:spPr>
+      </p:pic>
+    </p:spTree>
+    <p:extLst>
+      <p:ext uri="{BB962C8B-B14F-4D97-AF65-F5344CB8AC3E}">
+        <p14:creationId xmlns:p14="http://schemas.microsoft.com/office/powerpoint/2010/main" val="2653788343"/>
+      </p:ext>
+    </p:extLst>
+  </p:cSld>
+  <p:clrMapOvr>
+    <a:masterClrMapping/>
+  </p:clrMapOvr>
+</p:sld>
+</file>
+
+<file path=ppt/slides/slide11.xml><?xml version="1.0" encoding="utf-8"?>
+<p:sld xmlns:a="http://schemas.openxmlformats.org/drawingml/2006/main" xmlns:r="http://schemas.openxmlformats.org/officeDocument/2006/relationships" xmlns:p="http://schemas.openxmlformats.org/presentationml/2006/main">
+  <p:cSld>
+    <p:spTree>
+      <p:nvGrpSpPr>
+        <p:cNvPr id="1" name="">
+          <a:extLst>
+            <a:ext uri="{FF2B5EF4-FFF2-40B4-BE49-F238E27FC236}">
               <a16:creationId xmlns:a16="http://schemas.microsoft.com/office/drawing/2014/main" id="{C7282847-2996-7214-8037-C7F86A4073FC}"/>
             </a:ext>
           </a:extLst>
@@ -5657,7 +6176,7 @@
 </p:sld>
 </file>
 
-<file path=ppt/slides/slide11.xml><?xml version="1.0" encoding="utf-8"?>
+<file path=ppt/slides/slide12.xml><?xml version="1.0" encoding="utf-8"?>
 <p:sld xmlns:a="http://schemas.openxmlformats.org/drawingml/2006/main" xmlns:r="http://schemas.openxmlformats.org/officeDocument/2006/relationships" xmlns:p="http://schemas.openxmlformats.org/presentationml/2006/main">
   <p:cSld>
     <p:spTree>
@@ -5762,7 +6281,7 @@
               <a:rPr lang="en-GB" sz="1800" dirty="0">
                 <a:latin typeface="Palatino Linotype" panose="02040502050505030304" pitchFamily="18" charset="0"/>
               </a:rPr>
-              <a:t>It uses MIDI: no pitch inflection, vibrato, or continuous dynamics within notes — every note is a rectangle.</a:t>
+              <a:t>It uses MIDI: no pitch inflection, vibrato, or continuous dynamics within notes – every note is a rectangle.</a:t>
             </a:r>
           </a:p>
           <a:p>
@@ -5838,7 +6357,7 @@
               <a:rPr lang="en-GB" sz="1800" dirty="0">
                 <a:latin typeface="Palatino Linotype" panose="02040502050505030304" pitchFamily="18" charset="0"/>
               </a:rPr>
-              <a:t>No personal voice — an amalgam across an era rather than any one player's sound.</a:t>
+              <a:t>No personal voice – an amalgam across an era rather than any one player's sound.</a:t>
             </a:r>
           </a:p>
           <a:p>
@@ -5854,7 +6373,19 @@
               <a:rPr lang="en-GB" sz="1800" dirty="0">
                 <a:latin typeface="Palatino Linotype" panose="02040502050505030304" pitchFamily="18" charset="0"/>
               </a:rPr>
-              <a:t>The arc is clock-driven, not music-driven – deliberately for this performance.</a:t>
+              <a:t>The arc is clock-driven, not music-driven – deliberately for this performance (but see </a:t>
+            </a:r>
+            <a:r>
+              <a:rPr lang="en-GB" sz="1800" i="1" dirty="0">
+                <a:latin typeface="Palatino Linotype" panose="02040502050505030304" pitchFamily="18" charset="0"/>
+              </a:rPr>
+              <a:t>Climb!</a:t>
+            </a:r>
+            <a:r>
+              <a:rPr lang="en-GB" sz="1800" dirty="0">
+                <a:latin typeface="Palatino Linotype" panose="02040502050505030304" pitchFamily="18" charset="0"/>
+              </a:rPr>
+              <a:t>)</a:t>
             </a:r>
           </a:p>
           <a:p>
@@ -6109,7 +6640,7 @@
               <a:rPr lang="en-GB" sz="1800" dirty="0">
                 <a:latin typeface="Palatino Linotype" panose="02040502050505030304" pitchFamily="18" charset="0"/>
               </a:rPr>
-              <a:t>Trained on one era and school — the bebop/hard-bop vocabulary of the Weimar Jazz Database; no awareness of what came before or after.</a:t>
+              <a:t>Trained on one era and school – the bebop/hard-bop vocabulary of the Weimar Jazz Database; no awareness of what came before or after.</a:t>
             </a:r>
           </a:p>
           <a:p>
@@ -6125,7 +6656,7 @@
               <a:rPr lang="en-GB" sz="1800" dirty="0">
                 <a:latin typeface="Palatino Linotype" panose="02040502050505030304" pitchFamily="18" charset="0"/>
               </a:rPr>
-              <a:t>Inside/outside distinction and narrative arc within a phrase could be designed more explicitly — the model has learned some of this from transcriptions.</a:t>
+              <a:t>Inside/outside distinction and narrative arc within a phrase could be designed more explicitly –  the model has learned some of this from transcriptions.</a:t>
             </a:r>
           </a:p>
           <a:p>
@@ -6141,13 +6672,13 @@
               <a:rPr lang="en-GB" sz="1800" dirty="0">
                 <a:latin typeface="Palatino Linotype" panose="02040502050505030304" pitchFamily="18" charset="0"/>
               </a:rPr>
-              <a:t>It only listens to one instrument – but see </a:t>
+              <a:t>It only listens to one instrument (but see </a:t>
             </a:r>
             <a:r>
               <a:rPr lang="en-GB" sz="1800" i="1" dirty="0">
                 <a:latin typeface="Palatino Linotype" panose="02040502050505030304" pitchFamily="18" charset="0"/>
               </a:rPr>
-              <a:t>Forager</a:t>
+              <a:t>Forager)</a:t>
             </a:r>
             <a:r>
               <a:rPr lang="en-GB" sz="1800" dirty="0">
@@ -6178,6 +6709,66 @@
     <p:extLst>
       <p:ext uri="{BB962C8B-B14F-4D97-AF65-F5344CB8AC3E}">
         <p14:creationId xmlns:p14="http://schemas.microsoft.com/office/powerpoint/2010/main" val="3995039147"/>
+      </p:ext>
+    </p:extLst>
+  </p:cSld>
+  <p:clrMapOvr>
+    <a:masterClrMapping/>
+  </p:clrMapOvr>
+</p:sld>
+</file>
+
+<file path=ppt/slides/slide13.xml><?xml version="1.0" encoding="utf-8"?>
+<p:sld xmlns:a="http://schemas.openxmlformats.org/drawingml/2006/main" xmlns:r="http://schemas.openxmlformats.org/officeDocument/2006/relationships" xmlns:p="http://schemas.openxmlformats.org/presentationml/2006/main">
+  <p:cSld>
+    <p:spTree>
+      <p:nvGrpSpPr>
+        <p:cNvPr id="1" name=""/>
+        <p:cNvGrpSpPr/>
+        <p:nvPr/>
+      </p:nvGrpSpPr>
+      <p:grpSpPr>
+        <a:xfrm>
+          <a:off x="0" y="0"/>
+          <a:ext cx="0" cy="0"/>
+          <a:chOff x="0" y="0"/>
+          <a:chExt cx="0" cy="0"/>
+        </a:xfrm>
+      </p:grpSpPr>
+      <p:pic>
+        <p:nvPicPr>
+          <p:cNvPr id="5" name="Picture 4">
+            <a:extLst>
+              <a:ext uri="{FF2B5EF4-FFF2-40B4-BE49-F238E27FC236}">
+                <a16:creationId xmlns:a16="http://schemas.microsoft.com/office/drawing/2014/main" id="{B9CE34A2-E14E-88B2-84AD-728BF95CC0A9}"/>
+              </a:ext>
+            </a:extLst>
+          </p:cNvPr>
+          <p:cNvPicPr>
+            <a:picLocks noChangeAspect="1"/>
+          </p:cNvPicPr>
+          <p:nvPr/>
+        </p:nvPicPr>
+        <p:blipFill>
+          <a:blip r:embed="rId2"/>
+          <a:stretch>
+            <a:fillRect/>
+          </a:stretch>
+        </p:blipFill>
+        <p:spPr>
+          <a:xfrm>
+            <a:off x="-1" y="581200"/>
+            <a:ext cx="12164959" cy="5682966"/>
+          </a:xfrm>
+          <a:prstGeom prst="rect">
+            <a:avLst/>
+          </a:prstGeom>
+        </p:spPr>
+      </p:pic>
+    </p:spTree>
+    <p:extLst>
+      <p:ext uri="{BB962C8B-B14F-4D97-AF65-F5344CB8AC3E}">
+        <p14:creationId xmlns:p14="http://schemas.microsoft.com/office/powerpoint/2010/main" val="4026806973"/>
       </p:ext>
     </p:extLst>
   </p:cSld>
@@ -6279,7 +6870,7 @@
               <a:rPr lang="en-GB" sz="2400" dirty="0">
                 <a:latin typeface="Palatino Linotype" panose="02040502050505030304" pitchFamily="18" charset="0"/>
               </a:rPr>
-              <a:t>﻿﻿One of the exercises was called "slick licks" - we would sit in a circle and “trade licks” on our instruments.</a:t>
+              <a:t>﻿﻿One of the exercises was called "slick licks" – we would sit in a circle and “trade licks” on our instruments.</a:t>
             </a:r>
           </a:p>
           <a:p>
@@ -6359,6 +6950,173 @@
 </file>
 
 <file path=ppt/slides/slide3.xml><?xml version="1.0" encoding="utf-8"?>
+<p:sld xmlns:a="http://schemas.openxmlformats.org/drawingml/2006/main" xmlns:r="http://schemas.openxmlformats.org/officeDocument/2006/relationships" xmlns:p="http://schemas.openxmlformats.org/presentationml/2006/main">
+  <p:cSld>
+    <p:spTree>
+      <p:nvGrpSpPr>
+        <p:cNvPr id="1" name=""/>
+        <p:cNvGrpSpPr/>
+        <p:nvPr/>
+      </p:nvGrpSpPr>
+      <p:grpSpPr>
+        <a:xfrm>
+          <a:off x="0" y="0"/>
+          <a:ext cx="0" cy="0"/>
+          <a:chOff x="0" y="0"/>
+          <a:chExt cx="0" cy="0"/>
+        </a:xfrm>
+      </p:grpSpPr>
+      <p:sp>
+        <p:nvSpPr>
+          <p:cNvPr id="2" name="Title 1">
+            <a:extLst>
+              <a:ext uri="{FF2B5EF4-FFF2-40B4-BE49-F238E27FC236}">
+                <a16:creationId xmlns:a16="http://schemas.microsoft.com/office/drawing/2014/main" id="{657858EC-BE46-4923-0D39-C164F7927147}"/>
+              </a:ext>
+            </a:extLst>
+          </p:cNvPr>
+          <p:cNvSpPr>
+            <a:spLocks noGrp="1"/>
+          </p:cNvSpPr>
+          <p:nvPr>
+            <p:ph type="title"/>
+          </p:nvPr>
+        </p:nvSpPr>
+        <p:spPr>
+          <a:xfrm>
+            <a:off x="838200" y="365125"/>
+            <a:ext cx="10515600" cy="864585"/>
+          </a:xfrm>
+        </p:spPr>
+        <p:txBody>
+          <a:bodyPr/>
+          <a:lstStyle/>
+          <a:p>
+            <a:r>
+              <a:rPr lang="en-US" dirty="0">
+                <a:latin typeface="Optima" panose="02000503060000020004" pitchFamily="2" charset="0"/>
+              </a:rPr>
+              <a:t>Program(me) Note</a:t>
+            </a:r>
+          </a:p>
+        </p:txBody>
+      </p:sp>
+      <p:sp>
+        <p:nvSpPr>
+          <p:cNvPr id="3" name="Content Placeholder 2">
+            <a:extLst>
+              <a:ext uri="{FF2B5EF4-FFF2-40B4-BE49-F238E27FC236}">
+                <a16:creationId xmlns:a16="http://schemas.microsoft.com/office/drawing/2014/main" id="{96D5E14E-53BD-6D82-9D2D-166A7B3B4E95}"/>
+              </a:ext>
+            </a:extLst>
+          </p:cNvPr>
+          <p:cNvSpPr>
+            <a:spLocks noGrp="1"/>
+          </p:cNvSpPr>
+          <p:nvPr>
+            <p:ph idx="1"/>
+          </p:nvPr>
+        </p:nvSpPr>
+        <p:spPr>
+          <a:xfrm>
+            <a:off x="838200" y="1229710"/>
+            <a:ext cx="10515600" cy="5263165"/>
+          </a:xfrm>
+        </p:spPr>
+        <p:txBody>
+          <a:bodyPr>
+            <a:normAutofit fontScale="92500" lnSpcReduction="10000"/>
+          </a:bodyPr>
+          <a:lstStyle/>
+          <a:p>
+            <a:pPr marL="0" indent="0">
+              <a:lnSpc>
+                <a:spcPct val="110000"/>
+              </a:lnSpc>
+              <a:buNone/>
+            </a:pPr>
+            <a:r>
+              <a:rPr lang="en-GB" i="1" dirty="0">
+                <a:latin typeface="Palatino Linotype" panose="02040502050505030304" pitchFamily="18" charset="0"/>
+              </a:rPr>
+              <a:t>README*</a:t>
+            </a:r>
+            <a:r>
+              <a:rPr lang="en-GB" dirty="0">
+                <a:latin typeface="Palatino Linotype" panose="02040502050505030304" pitchFamily="18" charset="0"/>
+              </a:rPr>
+              <a:t> is a live conversation between a human bassist and an artificial musician that listens, responds, and remembers. Wolfson is a computer system trained on hundreds of jazz saxophone solos; it hears each bass phrase, analyses its character – the notes, the rhythm, the energy – and improvises a reply in real time. Over five minutes the music traces a journey through jazz history: an exploratory, chromatic opening gives way to the modal sound of Miles Davis and Herbie Hancock, builds to a hard-driving peak, and settles into a meditative close. No two performances are identical.</a:t>
+            </a:r>
+          </a:p>
+          <a:p>
+            <a:pPr marL="0" indent="0">
+              <a:buNone/>
+            </a:pPr>
+            <a:r>
+              <a:rPr lang="en-GB" dirty="0">
+                <a:latin typeface="Palatino Linotype" panose="02040502050505030304" pitchFamily="18" charset="0"/>
+              </a:rPr>
+              <a:t> </a:t>
+            </a:r>
+          </a:p>
+          <a:p>
+            <a:pPr marL="180000" indent="-457200"/>
+            <a:r>
+              <a:rPr lang="en-GB" sz="2200" dirty="0">
+                <a:latin typeface="Palatino Linotype" panose="02040502050505030304" pitchFamily="18" charset="0"/>
+              </a:rPr>
+              <a:t>The title works on three levels: the </a:t>
+            </a:r>
+            <a:r>
+              <a:rPr lang="en-GB" sz="2200" i="1" dirty="0">
+                <a:latin typeface="Palatino Linotype" panose="02040502050505030304" pitchFamily="18" charset="0"/>
+              </a:rPr>
+              <a:t>README</a:t>
+            </a:r>
+            <a:r>
+              <a:rPr lang="en-GB" sz="2200" dirty="0">
+                <a:latin typeface="Palatino Linotype" panose="02040502050505030304" pitchFamily="18" charset="0"/>
+              </a:rPr>
+              <a:t> file is the first thing you read when you encounter a piece of software; the software reads me, the bassist, responding to whatever I play; and it is a sideways glance at </a:t>
+            </a:r>
+            <a:r>
+              <a:rPr lang="en-GB" sz="2200" i="1" dirty="0" err="1">
+                <a:latin typeface="Palatino Linotype" panose="02040502050505030304" pitchFamily="18" charset="0"/>
+              </a:rPr>
+              <a:t>Recorda</a:t>
+            </a:r>
+            <a:r>
+              <a:rPr lang="en-GB" sz="2200" i="1" dirty="0">
+                <a:latin typeface="Palatino Linotype" panose="02040502050505030304" pitchFamily="18" charset="0"/>
+              </a:rPr>
+              <a:t> Me</a:t>
+            </a:r>
+            <a:r>
+              <a:rPr lang="en-GB" sz="2200" dirty="0">
+                <a:latin typeface="Palatino Linotype" panose="02040502050505030304" pitchFamily="18" charset="0"/>
+              </a:rPr>
+              <a:t> ("remember me”) a jazz standard, and a reminder that all improvisation is, in some sense, an act of memory.</a:t>
+            </a:r>
+            <a:endParaRPr lang="en-US" sz="2200" dirty="0">
+              <a:latin typeface="Palatino Linotype" panose="02040502050505030304" pitchFamily="18" charset="0"/>
+            </a:endParaRPr>
+          </a:p>
+        </p:txBody>
+      </p:sp>
+    </p:spTree>
+    <p:extLst>
+      <p:ext uri="{BB962C8B-B14F-4D97-AF65-F5344CB8AC3E}">
+        <p14:creationId xmlns:p14="http://schemas.microsoft.com/office/powerpoint/2010/main" val="2742971788"/>
+      </p:ext>
+    </p:extLst>
+  </p:cSld>
+  <p:clrMapOvr>
+    <a:masterClrMapping/>
+  </p:clrMapOvr>
+</p:sld>
+</file>
+
+<file path=ppt/slides/slide4.xml><?xml version="1.0" encoding="utf-8"?>
 <p:sld xmlns:a="http://schemas.openxmlformats.org/drawingml/2006/main" xmlns:r="http://schemas.openxmlformats.org/officeDocument/2006/relationships" xmlns:p="http://schemas.openxmlformats.org/presentationml/2006/main">
   <p:cSld>
     <p:spTree>
@@ -7082,7 +7840,7 @@
 </p:sld>
 </file>
 
-<file path=ppt/slides/slide4.xml><?xml version="1.0" encoding="utf-8"?>
+<file path=ppt/slides/slide5.xml><?xml version="1.0" encoding="utf-8"?>
 <p:sld xmlns:a="http://schemas.openxmlformats.org/drawingml/2006/main" xmlns:r="http://schemas.openxmlformats.org/officeDocument/2006/relationships" xmlns:p="http://schemas.openxmlformats.org/presentationml/2006/main">
   <p:cSld>
     <p:spTree>
@@ -7806,7 +8564,7 @@
 </p:sld>
 </file>
 
-<file path=ppt/slides/slide5.xml><?xml version="1.0" encoding="utf-8"?>
+<file path=ppt/slides/slide6.xml><?xml version="1.0" encoding="utf-8"?>
 <p:sld xmlns:a="http://schemas.openxmlformats.org/drawingml/2006/main" xmlns:r="http://schemas.openxmlformats.org/officeDocument/2006/relationships" xmlns:p="http://schemas.openxmlformats.org/presentationml/2006/main">
   <p:cSld>
     <p:spTree>
@@ -8124,1592 +8882,6 @@
         <p14:creationId xmlns:p14="http://schemas.microsoft.com/office/powerpoint/2010/main" val="3638156006"/>
       </p:ext>
     </p:extLst>
-  </p:cSld>
-  <p:clrMapOvr>
-    <a:masterClrMapping/>
-  </p:clrMapOvr>
-</p:sld>
-</file>
-
-<file path=ppt/slides/slide6.xml><?xml version="1.0" encoding="utf-8"?>
-<p:sld xmlns:a="http://schemas.openxmlformats.org/drawingml/2006/main" xmlns:r="http://schemas.openxmlformats.org/officeDocument/2006/relationships" xmlns:p="http://schemas.openxmlformats.org/presentationml/2006/main">
-  <p:cSld>
-    <p:bg>
-      <p:bgPr>
-        <a:solidFill>
-          <a:srgbClr val="00B0F0"/>
-        </a:solidFill>
-        <a:effectLst/>
-      </p:bgPr>
-    </p:bg>
-    <p:spTree>
-      <p:nvGrpSpPr>
-        <p:cNvPr id="1" name=""/>
-        <p:cNvGrpSpPr/>
-        <p:nvPr/>
-      </p:nvGrpSpPr>
-      <p:grpSpPr>
-        <a:xfrm>
-          <a:off x="0" y="0"/>
-          <a:ext cx="0" cy="0"/>
-          <a:chOff x="0" y="0"/>
-          <a:chExt cx="0" cy="0"/>
-        </a:xfrm>
-      </p:grpSpPr>
-      <p:sp>
-        <p:nvSpPr>
-          <p:cNvPr id="3" name="Text 1"/>
-          <p:cNvSpPr/>
-          <p:nvPr/>
-        </p:nvSpPr>
-        <p:spPr>
-          <a:xfrm>
-            <a:off x="9424410" y="4424864"/>
-            <a:ext cx="2264263" cy="1662546"/>
-          </a:xfrm>
-          <a:prstGeom prst="rect">
-            <a:avLst/>
-          </a:prstGeom>
-          <a:noFill/>
-          <a:ln/>
-        </p:spPr>
-        <p:txBody>
-          <a:bodyPr wrap="square" lIns="0" tIns="0" rIns="0" bIns="0" rtlCol="0" anchor="ctr"/>
-          <a:lstStyle/>
-          <a:p>
-            <a:pPr algn="ctr" defTabSz="1219170"/>
-            <a:r>
-              <a:rPr lang="en-US" sz="4800" b="1" dirty="0">
-                <a:solidFill>
-                  <a:srgbClr val="FFFFFF"/>
-                </a:solidFill>
-                <a:latin typeface="Optima" panose="02000503060000020004" pitchFamily="2" charset="0"/>
-                <a:ea typeface="Calibri" pitchFamily="34" charset="-122"/>
-                <a:cs typeface="Calibri" pitchFamily="34" charset="-120"/>
-              </a:rPr>
-              <a:t>Input Pipeline</a:t>
-            </a:r>
-            <a:endParaRPr lang="en-US" sz="4800" dirty="0">
-              <a:solidFill>
-                <a:prstClr val="black"/>
-              </a:solidFill>
-              <a:latin typeface="Optima" panose="02000503060000020004" pitchFamily="2" charset="0"/>
-            </a:endParaRPr>
-          </a:p>
-        </p:txBody>
-      </p:sp>
-      <p:sp>
-        <p:nvSpPr>
-          <p:cNvPr id="4" name="Shape 2"/>
-          <p:cNvSpPr/>
-          <p:nvPr/>
-        </p:nvSpPr>
-        <p:spPr>
-          <a:xfrm>
-            <a:off x="365760" y="761879"/>
-            <a:ext cx="1889760" cy="755904"/>
-          </a:xfrm>
-          <a:prstGeom prst="roundRect">
-            <a:avLst>
-              <a:gd name="adj" fmla="val 16667"/>
-            </a:avLst>
-          </a:prstGeom>
-          <a:solidFill>
-            <a:srgbClr val="2A3570"/>
-          </a:solidFill>
-          <a:ln w="19050">
-            <a:solidFill>
-              <a:srgbClr val="CADCFC"/>
-            </a:solidFill>
-            <a:prstDash val="solid"/>
-          </a:ln>
-        </p:spPr>
-        <p:txBody>
-          <a:bodyPr/>
-          <a:lstStyle/>
-          <a:p>
-            <a:pPr defTabSz="1219170"/>
-            <a:endParaRPr lang="en-US" sz="2400">
-              <a:solidFill>
-                <a:prstClr val="black"/>
-              </a:solidFill>
-              <a:latin typeface="Calibri" panose="020F0502020204030204"/>
-            </a:endParaRPr>
-          </a:p>
-        </p:txBody>
-      </p:sp>
-      <p:sp>
-        <p:nvSpPr>
-          <p:cNvPr id="5" name="Text 3"/>
-          <p:cNvSpPr/>
-          <p:nvPr/>
-        </p:nvSpPr>
-        <p:spPr>
-          <a:xfrm>
-            <a:off x="365760" y="761879"/>
-            <a:ext cx="1889760" cy="667900"/>
-          </a:xfrm>
-          <a:prstGeom prst="rect">
-            <a:avLst/>
-          </a:prstGeom>
-          <a:noFill/>
-          <a:ln/>
-        </p:spPr>
-        <p:txBody>
-          <a:bodyPr wrap="square" lIns="67733" tIns="67733" rIns="67733" bIns="67733" rtlCol="0" anchor="ctr"/>
-          <a:lstStyle/>
-          <a:p>
-            <a:pPr algn="ctr" defTabSz="1219170"/>
-            <a:r>
-              <a:rPr lang="en-US" sz="2400" b="1" dirty="0">
-                <a:solidFill>
-                  <a:srgbClr val="FFFFFF"/>
-                </a:solidFill>
-                <a:latin typeface="Calibri" pitchFamily="34" charset="0"/>
-                <a:ea typeface="Calibri" pitchFamily="34" charset="-122"/>
-                <a:cs typeface="Calibri" pitchFamily="34" charset="-120"/>
-              </a:rPr>
-              <a:t>Bass</a:t>
-            </a:r>
-            <a:br>
-              <a:rPr lang="en-US" sz="2400" b="1" dirty="0">
-                <a:solidFill>
-                  <a:srgbClr val="FFFFFF"/>
-                </a:solidFill>
-                <a:latin typeface="Calibri" pitchFamily="34" charset="0"/>
-                <a:ea typeface="Calibri" pitchFamily="34" charset="-122"/>
-                <a:cs typeface="Calibri" pitchFamily="34" charset="-120"/>
-              </a:rPr>
-            </a:br>
-            <a:r>
-              <a:rPr lang="en-US" sz="2000" b="1" dirty="0">
-                <a:solidFill>
-                  <a:srgbClr val="FFFFFF"/>
-                </a:solidFill>
-                <a:latin typeface="Calibri" pitchFamily="34" charset="0"/>
-                <a:ea typeface="Calibri" pitchFamily="34" charset="-122"/>
-                <a:cs typeface="Calibri" pitchFamily="34" charset="-120"/>
-              </a:rPr>
-              <a:t>(pitch-to-MIDI)</a:t>
-            </a:r>
-            <a:endParaRPr lang="en-US" sz="2400" dirty="0">
-              <a:solidFill>
-                <a:prstClr val="black"/>
-              </a:solidFill>
-              <a:latin typeface="Calibri" panose="020F0502020204030204"/>
-            </a:endParaRPr>
-          </a:p>
-        </p:txBody>
-      </p:sp>
-      <p:sp>
-        <p:nvSpPr>
-          <p:cNvPr id="6" name="Shape 4"/>
-          <p:cNvSpPr/>
-          <p:nvPr/>
-        </p:nvSpPr>
-        <p:spPr>
-          <a:xfrm>
-            <a:off x="2865125" y="761878"/>
-            <a:ext cx="1889760" cy="842091"/>
-          </a:xfrm>
-          <a:prstGeom prst="roundRect">
-            <a:avLst>
-              <a:gd name="adj" fmla="val 16667"/>
-            </a:avLst>
-          </a:prstGeom>
-          <a:solidFill>
-            <a:srgbClr val="2A3570"/>
-          </a:solidFill>
-          <a:ln w="19050">
-            <a:solidFill>
-              <a:srgbClr val="CADCFC"/>
-            </a:solidFill>
-            <a:prstDash val="solid"/>
-          </a:ln>
-        </p:spPr>
-        <p:txBody>
-          <a:bodyPr/>
-          <a:lstStyle/>
-          <a:p>
-            <a:pPr defTabSz="1219170"/>
-            <a:endParaRPr lang="en-US" sz="2400">
-              <a:solidFill>
-                <a:prstClr val="black"/>
-              </a:solidFill>
-              <a:latin typeface="Calibri" panose="020F0502020204030204"/>
-            </a:endParaRPr>
-          </a:p>
-        </p:txBody>
-      </p:sp>
-      <p:sp>
-        <p:nvSpPr>
-          <p:cNvPr id="7" name="Text 5"/>
-          <p:cNvSpPr/>
-          <p:nvPr/>
-        </p:nvSpPr>
-        <p:spPr>
-          <a:xfrm>
-            <a:off x="2865125" y="761879"/>
-            <a:ext cx="1889760" cy="585216"/>
-          </a:xfrm>
-          <a:prstGeom prst="rect">
-            <a:avLst/>
-          </a:prstGeom>
-          <a:noFill/>
-          <a:ln/>
-        </p:spPr>
-        <p:txBody>
-          <a:bodyPr wrap="square" lIns="67733" tIns="67733" rIns="67733" bIns="67733" rtlCol="0" anchor="ctr"/>
-          <a:lstStyle/>
-          <a:p>
-            <a:pPr algn="ctr" defTabSz="1219170"/>
-            <a:r>
-              <a:rPr lang="en-US" sz="2400" b="1" dirty="0">
-                <a:solidFill>
-                  <a:srgbClr val="FFFFFF"/>
-                </a:solidFill>
-                <a:latin typeface="Calibri" pitchFamily="34" charset="0"/>
-                <a:ea typeface="Calibri" pitchFamily="34" charset="-122"/>
-                <a:cs typeface="Calibri" pitchFamily="34" charset="-120"/>
-              </a:rPr>
-              <a:t>MidiListener</a:t>
-            </a:r>
-            <a:endParaRPr lang="en-US" sz="2400" dirty="0">
-              <a:solidFill>
-                <a:prstClr val="black"/>
-              </a:solidFill>
-              <a:latin typeface="Calibri" panose="020F0502020204030204"/>
-            </a:endParaRPr>
-          </a:p>
-        </p:txBody>
-      </p:sp>
-      <p:sp>
-        <p:nvSpPr>
-          <p:cNvPr id="8" name="Shape 6"/>
-          <p:cNvSpPr/>
-          <p:nvPr/>
-        </p:nvSpPr>
-        <p:spPr>
-          <a:xfrm>
-            <a:off x="5521530" y="761879"/>
-            <a:ext cx="2291561" cy="1426629"/>
-          </a:xfrm>
-          <a:prstGeom prst="roundRect">
-            <a:avLst>
-              <a:gd name="adj" fmla="val 16667"/>
-            </a:avLst>
-          </a:prstGeom>
-          <a:solidFill>
-            <a:srgbClr val="2A3570"/>
-          </a:solidFill>
-          <a:ln w="19050">
-            <a:solidFill>
-              <a:srgbClr val="CADCFC"/>
-            </a:solidFill>
-            <a:prstDash val="solid"/>
-          </a:ln>
-        </p:spPr>
-        <p:txBody>
-          <a:bodyPr/>
-          <a:lstStyle/>
-          <a:p>
-            <a:pPr defTabSz="1219170"/>
-            <a:endParaRPr lang="en-US" sz="2400">
-              <a:solidFill>
-                <a:prstClr val="black"/>
-              </a:solidFill>
-              <a:latin typeface="Calibri" panose="020F0502020204030204"/>
-            </a:endParaRPr>
-          </a:p>
-        </p:txBody>
-      </p:sp>
-      <p:sp>
-        <p:nvSpPr>
-          <p:cNvPr id="9" name="Text 7"/>
-          <p:cNvSpPr/>
-          <p:nvPr/>
-        </p:nvSpPr>
-        <p:spPr>
-          <a:xfrm>
-            <a:off x="5582490" y="761879"/>
-            <a:ext cx="2197479" cy="583084"/>
-          </a:xfrm>
-          <a:prstGeom prst="rect">
-            <a:avLst/>
-          </a:prstGeom>
-          <a:noFill/>
-          <a:ln/>
-        </p:spPr>
-        <p:txBody>
-          <a:bodyPr wrap="square" lIns="67733" tIns="67733" rIns="67733" bIns="67733" rtlCol="0" anchor="ctr"/>
-          <a:lstStyle/>
-          <a:p>
-            <a:pPr algn="ctr" defTabSz="1219170"/>
-            <a:r>
-              <a:rPr lang="en-US" sz="2400" b="1" dirty="0" err="1">
-                <a:solidFill>
-                  <a:srgbClr val="FFFFFF"/>
-                </a:solidFill>
-                <a:latin typeface="Calibri" pitchFamily="34" charset="0"/>
-                <a:ea typeface="Calibri" pitchFamily="34" charset="-122"/>
-                <a:cs typeface="Calibri" pitchFamily="34" charset="-120"/>
-              </a:rPr>
-              <a:t>PhraseDetector</a:t>
-            </a:r>
-            <a:endParaRPr lang="en-US" sz="2400" dirty="0">
-              <a:solidFill>
-                <a:prstClr val="black"/>
-              </a:solidFill>
-              <a:latin typeface="Calibri" panose="020F0502020204030204"/>
-            </a:endParaRPr>
-          </a:p>
-        </p:txBody>
-      </p:sp>
-      <p:sp>
-        <p:nvSpPr>
-          <p:cNvPr id="10" name="Shape 8"/>
-          <p:cNvSpPr/>
-          <p:nvPr/>
-        </p:nvSpPr>
-        <p:spPr>
-          <a:xfrm>
-            <a:off x="8515479" y="761879"/>
-            <a:ext cx="3066918" cy="1671258"/>
-          </a:xfrm>
-          <a:prstGeom prst="roundRect">
-            <a:avLst>
-              <a:gd name="adj" fmla="val 5333"/>
-            </a:avLst>
-          </a:prstGeom>
-          <a:solidFill>
-            <a:srgbClr val="253880"/>
-          </a:solidFill>
-          <a:ln w="25400">
-            <a:solidFill>
-              <a:srgbClr val="CADCFC"/>
-            </a:solidFill>
-            <a:prstDash val="solid"/>
-          </a:ln>
-        </p:spPr>
-        <p:txBody>
-          <a:bodyPr/>
-          <a:lstStyle/>
-          <a:p>
-            <a:pPr defTabSz="1219170"/>
-            <a:endParaRPr lang="en-US" sz="2400">
-              <a:solidFill>
-                <a:prstClr val="black"/>
-              </a:solidFill>
-              <a:latin typeface="Calibri" panose="020F0502020204030204"/>
-            </a:endParaRPr>
-          </a:p>
-        </p:txBody>
-      </p:sp>
-      <p:sp>
-        <p:nvSpPr>
-          <p:cNvPr id="11" name="Text 9"/>
-          <p:cNvSpPr/>
-          <p:nvPr/>
-        </p:nvSpPr>
-        <p:spPr>
-          <a:xfrm>
-            <a:off x="8576439" y="761878"/>
-            <a:ext cx="2957385" cy="537237"/>
-          </a:xfrm>
-          <a:prstGeom prst="rect">
-            <a:avLst/>
-          </a:prstGeom>
-          <a:noFill/>
-          <a:ln/>
-        </p:spPr>
-        <p:txBody>
-          <a:bodyPr wrap="square" lIns="0" tIns="0" rIns="0" bIns="0" rtlCol="0" anchor="ctr"/>
-          <a:lstStyle/>
-          <a:p>
-            <a:pPr algn="ctr" defTabSz="1219170"/>
-            <a:r>
-              <a:rPr lang="en-US" sz="2400" b="1" dirty="0">
-                <a:solidFill>
-                  <a:srgbClr val="FFFFFF"/>
-                </a:solidFill>
-                <a:latin typeface="Calibri" pitchFamily="34" charset="0"/>
-                <a:ea typeface="Calibri" pitchFamily="34" charset="-122"/>
-                <a:cs typeface="Calibri" pitchFamily="34" charset="-120"/>
-              </a:rPr>
-              <a:t>PhraseAnalyzer</a:t>
-            </a:r>
-            <a:endParaRPr lang="en-US" sz="2400" dirty="0">
-              <a:solidFill>
-                <a:prstClr val="black"/>
-              </a:solidFill>
-              <a:latin typeface="Calibri" panose="020F0502020204030204"/>
-            </a:endParaRPr>
-          </a:p>
-        </p:txBody>
-      </p:sp>
-      <p:sp>
-        <p:nvSpPr>
-          <p:cNvPr id="12" name="Text 10"/>
-          <p:cNvSpPr/>
-          <p:nvPr/>
-        </p:nvSpPr>
-        <p:spPr>
-          <a:xfrm>
-            <a:off x="8650015" y="1296952"/>
-            <a:ext cx="2881918" cy="1134021"/>
-          </a:xfrm>
-          <a:prstGeom prst="rect">
-            <a:avLst/>
-          </a:prstGeom>
-          <a:noFill/>
-          <a:ln/>
-        </p:spPr>
-        <p:txBody>
-          <a:bodyPr wrap="square" lIns="33867" tIns="33867" rIns="33867" bIns="33867" rtlCol="0" anchor="t"/>
-          <a:lstStyle/>
-          <a:p>
-            <a:pPr defTabSz="1219170"/>
-            <a:r>
-              <a:rPr lang="en-US" sz="1600" dirty="0">
-                <a:solidFill>
-                  <a:srgbClr val="CADCFC"/>
-                </a:solidFill>
-                <a:latin typeface="Calibri" pitchFamily="34" charset="0"/>
-                <a:ea typeface="Calibri" pitchFamily="34" charset="-122"/>
-                <a:cs typeface="Calibri" pitchFamily="34" charset="-120"/>
-              </a:rPr>
-              <a:t>contour · density · Q&amp;A type · </a:t>
-            </a:r>
-            <a:br>
-              <a:rPr lang="en-US" sz="1600" dirty="0">
-                <a:solidFill>
-                  <a:srgbClr val="CADCFC"/>
-                </a:solidFill>
-                <a:latin typeface="Calibri" pitchFamily="34" charset="0"/>
-                <a:ea typeface="Calibri" pitchFamily="34" charset="-122"/>
-                <a:cs typeface="Calibri" pitchFamily="34" charset="-120"/>
-              </a:rPr>
-            </a:br>
-            <a:r>
-              <a:rPr lang="en-US" sz="1600" dirty="0">
-                <a:solidFill>
-                  <a:srgbClr val="CADCFC"/>
-                </a:solidFill>
-                <a:latin typeface="Calibri" pitchFamily="34" charset="0"/>
-                <a:ea typeface="Calibri" pitchFamily="34" charset="-122"/>
-                <a:cs typeface="Calibri" pitchFamily="34" charset="-120"/>
-              </a:rPr>
-              <a:t>swing · dynamics · energy profile · </a:t>
-            </a:r>
-            <a:endParaRPr lang="en-US" sz="1600" dirty="0">
-              <a:solidFill>
-                <a:prstClr val="black"/>
-              </a:solidFill>
-              <a:latin typeface="Calibri" panose="020F0502020204030204"/>
-            </a:endParaRPr>
-          </a:p>
-          <a:p>
-            <a:pPr defTabSz="1219170"/>
-            <a:r>
-              <a:rPr lang="en-US" sz="1600" dirty="0">
-                <a:solidFill>
-                  <a:srgbClr val="CADCFC"/>
-                </a:solidFill>
-                <a:latin typeface="Calibri" pitchFamily="34" charset="0"/>
-                <a:ea typeface="Calibri" pitchFamily="34" charset="-122"/>
-                <a:cs typeface="Calibri" pitchFamily="34" charset="-120"/>
-              </a:rPr>
-              <a:t>pitch classes · interval motifs ·  lyrical motifs</a:t>
-            </a:r>
-            <a:endParaRPr lang="en-US" sz="1600" dirty="0">
-              <a:solidFill>
-                <a:prstClr val="black"/>
-              </a:solidFill>
-              <a:latin typeface="Calibri" panose="020F0502020204030204"/>
-            </a:endParaRPr>
-          </a:p>
-        </p:txBody>
-      </p:sp>
-      <p:sp>
-        <p:nvSpPr>
-          <p:cNvPr id="15" name="Shape 13"/>
-          <p:cNvSpPr/>
-          <p:nvPr/>
-        </p:nvSpPr>
-        <p:spPr>
-          <a:xfrm>
-            <a:off x="7910628" y="1139298"/>
-            <a:ext cx="497224" cy="1"/>
-          </a:xfrm>
-          <a:prstGeom prst="line">
-            <a:avLst/>
-          </a:prstGeom>
-          <a:noFill/>
-          <a:ln w="50800">
-            <a:solidFill>
-              <a:srgbClr val="CADCFC"/>
-            </a:solidFill>
-            <a:prstDash val="solid"/>
-            <a:tailEnd type="arrow"/>
-          </a:ln>
-        </p:spPr>
-        <p:txBody>
-          <a:bodyPr/>
-          <a:lstStyle/>
-          <a:p>
-            <a:pPr defTabSz="1219170"/>
-            <a:endParaRPr lang="en-US" sz="2400">
-              <a:solidFill>
-                <a:prstClr val="black"/>
-              </a:solidFill>
-              <a:latin typeface="Calibri" panose="020F0502020204030204"/>
-            </a:endParaRPr>
-          </a:p>
-        </p:txBody>
-      </p:sp>
-      <p:sp>
-        <p:nvSpPr>
-          <p:cNvPr id="16" name="Shape 14"/>
-          <p:cNvSpPr/>
-          <p:nvPr/>
-        </p:nvSpPr>
-        <p:spPr>
-          <a:xfrm>
-            <a:off x="1932319" y="2153045"/>
-            <a:ext cx="2292087" cy="781702"/>
-          </a:xfrm>
-          <a:prstGeom prst="roundRect">
-            <a:avLst>
-              <a:gd name="adj" fmla="val 16667"/>
-            </a:avLst>
-          </a:prstGeom>
-          <a:solidFill>
-            <a:srgbClr val="2A3570"/>
-          </a:solidFill>
-          <a:ln w="19050">
-            <a:solidFill>
-              <a:srgbClr val="CADCFC"/>
-            </a:solidFill>
-            <a:prstDash val="solid"/>
-          </a:ln>
-        </p:spPr>
-        <p:txBody>
-          <a:bodyPr/>
-          <a:lstStyle/>
-          <a:p>
-            <a:pPr defTabSz="1219170"/>
-            <a:endParaRPr lang="en-US" sz="2400" dirty="0">
-              <a:solidFill>
-                <a:prstClr val="black"/>
-              </a:solidFill>
-              <a:latin typeface="Calibri" panose="020F0502020204030204"/>
-            </a:endParaRPr>
-          </a:p>
-        </p:txBody>
-      </p:sp>
-      <p:sp>
-        <p:nvSpPr>
-          <p:cNvPr id="17" name="Text 15"/>
-          <p:cNvSpPr/>
-          <p:nvPr/>
-        </p:nvSpPr>
-        <p:spPr>
-          <a:xfrm>
-            <a:off x="1932317" y="2234580"/>
-            <a:ext cx="2292087" cy="353568"/>
-          </a:xfrm>
-          <a:prstGeom prst="rect">
-            <a:avLst/>
-          </a:prstGeom>
-          <a:noFill/>
-          <a:ln/>
-        </p:spPr>
-        <p:txBody>
-          <a:bodyPr wrap="square" lIns="0" tIns="0" rIns="0" bIns="0" rtlCol="0" anchor="ctr"/>
-          <a:lstStyle/>
-          <a:p>
-            <a:pPr algn="ctr" defTabSz="1219170"/>
-            <a:r>
-              <a:rPr lang="en-US" sz="2400" b="1" dirty="0">
-                <a:solidFill>
-                  <a:srgbClr val="FFFFFF"/>
-                </a:solidFill>
-                <a:latin typeface="Calibri" pitchFamily="34" charset="0"/>
-                <a:ea typeface="Calibri" pitchFamily="34" charset="-122"/>
-                <a:cs typeface="Calibri" pitchFamily="34" charset="-120"/>
-              </a:rPr>
-              <a:t>BeatEstimator</a:t>
-            </a:r>
-            <a:endParaRPr lang="en-US" sz="2400" dirty="0">
-              <a:solidFill>
-                <a:prstClr val="black"/>
-              </a:solidFill>
-              <a:latin typeface="Calibri" panose="020F0502020204030204"/>
-            </a:endParaRPr>
-          </a:p>
-        </p:txBody>
-      </p:sp>
-      <p:sp>
-        <p:nvSpPr>
-          <p:cNvPr id="18" name="Text 16"/>
-          <p:cNvSpPr/>
-          <p:nvPr/>
-        </p:nvSpPr>
-        <p:spPr>
-          <a:xfrm>
-            <a:off x="2165140" y="2549540"/>
-            <a:ext cx="2059268" cy="293138"/>
-          </a:xfrm>
-          <a:prstGeom prst="rect">
-            <a:avLst/>
-          </a:prstGeom>
-          <a:noFill/>
-          <a:ln/>
-        </p:spPr>
-        <p:txBody>
-          <a:bodyPr wrap="square" lIns="33867" tIns="33867" rIns="33867" bIns="33867" rtlCol="0" anchor="t"/>
-          <a:lstStyle/>
-          <a:p>
-            <a:pPr defTabSz="1219170"/>
-            <a:r>
-              <a:rPr lang="en-US" sz="1600" dirty="0">
-                <a:solidFill>
-                  <a:srgbClr val="CADCFC"/>
-                </a:solidFill>
-                <a:latin typeface="Calibri" pitchFamily="34" charset="0"/>
-                <a:ea typeface="Calibri" pitchFamily="34" charset="-122"/>
-                <a:cs typeface="Calibri" pitchFamily="34" charset="-120"/>
-              </a:rPr>
-              <a:t>live tempo · beat sync</a:t>
-            </a:r>
-            <a:endParaRPr lang="en-US" sz="1600" dirty="0">
-              <a:solidFill>
-                <a:prstClr val="black"/>
-              </a:solidFill>
-              <a:latin typeface="Calibri" panose="020F0502020204030204"/>
-            </a:endParaRPr>
-          </a:p>
-        </p:txBody>
-      </p:sp>
-      <p:sp>
-        <p:nvSpPr>
-          <p:cNvPr id="19" name="Shape 17"/>
-          <p:cNvSpPr/>
-          <p:nvPr/>
-        </p:nvSpPr>
-        <p:spPr>
-          <a:xfrm>
-            <a:off x="3566160" y="1685953"/>
-            <a:ext cx="0" cy="353568"/>
-          </a:xfrm>
-          <a:prstGeom prst="line">
-            <a:avLst/>
-          </a:prstGeom>
-          <a:noFill/>
-          <a:ln w="50800">
-            <a:solidFill>
-              <a:srgbClr val="CADCFC"/>
-            </a:solidFill>
-            <a:prstDash val="solid"/>
-            <a:tailEnd type="arrow"/>
-          </a:ln>
-        </p:spPr>
-        <p:txBody>
-          <a:bodyPr/>
-          <a:lstStyle/>
-          <a:p>
-            <a:pPr defTabSz="1219170"/>
-            <a:endParaRPr lang="en-US" sz="2400">
-              <a:solidFill>
-                <a:prstClr val="black"/>
-              </a:solidFill>
-              <a:latin typeface="Calibri" panose="020F0502020204030204"/>
-            </a:endParaRPr>
-          </a:p>
-        </p:txBody>
-      </p:sp>
-      <p:sp>
-        <p:nvSpPr>
-          <p:cNvPr id="20" name="Shape 18"/>
-          <p:cNvSpPr/>
-          <p:nvPr/>
-        </p:nvSpPr>
-        <p:spPr>
-          <a:xfrm>
-            <a:off x="4681302" y="2755535"/>
-            <a:ext cx="2960152" cy="1287592"/>
-          </a:xfrm>
-          <a:prstGeom prst="roundRect">
-            <a:avLst>
-              <a:gd name="adj" fmla="val 8421"/>
-            </a:avLst>
-          </a:prstGeom>
-          <a:solidFill>
-            <a:srgbClr val="162050"/>
-          </a:solidFill>
-          <a:ln w="19050">
-            <a:solidFill>
-              <a:srgbClr val="CADCFC"/>
-            </a:solidFill>
-            <a:prstDash val="solid"/>
-          </a:ln>
-        </p:spPr>
-        <p:txBody>
-          <a:bodyPr/>
-          <a:lstStyle/>
-          <a:p>
-            <a:pPr defTabSz="1219170"/>
-            <a:endParaRPr lang="en-US" sz="2400">
-              <a:solidFill>
-                <a:prstClr val="black"/>
-              </a:solidFill>
-              <a:latin typeface="Calibri" panose="020F0502020204030204"/>
-            </a:endParaRPr>
-          </a:p>
-        </p:txBody>
-      </p:sp>
-      <p:sp>
-        <p:nvSpPr>
-          <p:cNvPr id="21" name="Text 19"/>
-          <p:cNvSpPr/>
-          <p:nvPr/>
-        </p:nvSpPr>
-        <p:spPr>
-          <a:xfrm>
-            <a:off x="4742262" y="2842482"/>
-            <a:ext cx="2850517" cy="316992"/>
-          </a:xfrm>
-          <a:prstGeom prst="rect">
-            <a:avLst/>
-          </a:prstGeom>
-          <a:noFill/>
-          <a:ln/>
-        </p:spPr>
-        <p:txBody>
-          <a:bodyPr wrap="square" lIns="0" tIns="0" rIns="0" bIns="0" rtlCol="0" anchor="ctr"/>
-          <a:lstStyle/>
-          <a:p>
-            <a:pPr algn="ctr" defTabSz="1219170"/>
-            <a:r>
-              <a:rPr lang="en-US" sz="2400" b="1" dirty="0">
-                <a:solidFill>
-                  <a:srgbClr val="FFFFFF"/>
-                </a:solidFill>
-                <a:latin typeface="Calibri" pitchFamily="34" charset="0"/>
-                <a:ea typeface="Calibri" pitchFamily="34" charset="-122"/>
-                <a:cs typeface="Calibri" pitchFamily="34" charset="-120"/>
-              </a:rPr>
-              <a:t>PhraseMemory</a:t>
-            </a:r>
-            <a:endParaRPr lang="en-US" sz="2400" dirty="0">
-              <a:solidFill>
-                <a:prstClr val="black"/>
-              </a:solidFill>
-              <a:latin typeface="Calibri" panose="020F0502020204030204"/>
-            </a:endParaRPr>
-          </a:p>
-        </p:txBody>
-      </p:sp>
-      <p:sp>
-        <p:nvSpPr>
-          <p:cNvPr id="22" name="Text 20"/>
-          <p:cNvSpPr/>
-          <p:nvPr/>
-        </p:nvSpPr>
-        <p:spPr>
-          <a:xfrm>
-            <a:off x="4943430" y="3187584"/>
-            <a:ext cx="2488720" cy="792480"/>
-          </a:xfrm>
-          <a:prstGeom prst="rect">
-            <a:avLst/>
-          </a:prstGeom>
-          <a:noFill/>
-          <a:ln/>
-        </p:spPr>
-        <p:txBody>
-          <a:bodyPr wrap="square" lIns="33867" tIns="33867" rIns="33867" bIns="33867" rtlCol="0" anchor="t"/>
-          <a:lstStyle/>
-          <a:p>
-            <a:pPr defTabSz="1219170"/>
-            <a:r>
-              <a:rPr lang="en-US" sz="1600" dirty="0">
-                <a:solidFill>
-                  <a:srgbClr val="CADCFC"/>
-                </a:solidFill>
-                <a:latin typeface="Calibri" pitchFamily="34" charset="0"/>
-                <a:ea typeface="Calibri" pitchFamily="34" charset="-122"/>
-                <a:cs typeface="Calibri" pitchFamily="34" charset="-120"/>
-              </a:rPr>
-              <a:t>stores phrases + motifs · </a:t>
-            </a:r>
-            <a:endParaRPr lang="en-US" sz="1600" dirty="0">
-              <a:solidFill>
-                <a:prstClr val="black"/>
-              </a:solidFill>
-              <a:latin typeface="Calibri" panose="020F0502020204030204"/>
-            </a:endParaRPr>
-          </a:p>
-          <a:p>
-            <a:pPr defTabSz="1219170"/>
-            <a:r>
-              <a:rPr lang="en-US" sz="1600" dirty="0">
-                <a:solidFill>
-                  <a:srgbClr val="CADCFC"/>
-                </a:solidFill>
-                <a:latin typeface="Calibri" pitchFamily="34" charset="0"/>
-                <a:ea typeface="Calibri" pitchFamily="34" charset="-122"/>
-                <a:cs typeface="Calibri" pitchFamily="34" charset="-120"/>
-              </a:rPr>
-              <a:t>stores lyrical motifs · </a:t>
-            </a:r>
-            <a:endParaRPr lang="en-US" sz="1600" dirty="0">
-              <a:solidFill>
-                <a:prstClr val="black"/>
-              </a:solidFill>
-              <a:latin typeface="Calibri" panose="020F0502020204030204"/>
-            </a:endParaRPr>
-          </a:p>
-          <a:p>
-            <a:pPr defTabSz="1219170"/>
-            <a:r>
-              <a:rPr lang="en-US" sz="1600" dirty="0">
-                <a:solidFill>
-                  <a:srgbClr val="CADCFC"/>
-                </a:solidFill>
-                <a:latin typeface="Calibri" pitchFamily="34" charset="0"/>
-                <a:ea typeface="Calibri" pitchFamily="34" charset="-122"/>
-                <a:cs typeface="Calibri" pitchFamily="34" charset="-120"/>
-              </a:rPr>
-              <a:t>both voices (bass + sax)</a:t>
-            </a:r>
-            <a:endParaRPr lang="en-US" sz="1600" dirty="0">
-              <a:solidFill>
-                <a:prstClr val="black"/>
-              </a:solidFill>
-              <a:latin typeface="Calibri" panose="020F0502020204030204"/>
-            </a:endParaRPr>
-          </a:p>
-        </p:txBody>
-      </p:sp>
-      <p:sp>
-        <p:nvSpPr>
-          <p:cNvPr id="23" name="Shape 21"/>
-          <p:cNvSpPr/>
-          <p:nvPr/>
-        </p:nvSpPr>
-        <p:spPr>
-          <a:xfrm>
-            <a:off x="8839200" y="2610826"/>
-            <a:ext cx="0" cy="821376"/>
-          </a:xfrm>
-          <a:prstGeom prst="line">
-            <a:avLst/>
-          </a:prstGeom>
-          <a:noFill/>
-          <a:ln w="50800">
-            <a:solidFill>
-              <a:srgbClr val="CADCFC"/>
-            </a:solidFill>
-            <a:prstDash val="solid"/>
-          </a:ln>
-        </p:spPr>
-        <p:txBody>
-          <a:bodyPr/>
-          <a:lstStyle/>
-          <a:p>
-            <a:pPr defTabSz="1219170"/>
-            <a:endParaRPr lang="en-US" sz="2400">
-              <a:solidFill>
-                <a:prstClr val="black"/>
-              </a:solidFill>
-              <a:latin typeface="Calibri" panose="020F0502020204030204"/>
-            </a:endParaRPr>
-          </a:p>
-        </p:txBody>
-      </p:sp>
-      <p:sp>
-        <p:nvSpPr>
-          <p:cNvPr id="24" name="Shape 22"/>
-          <p:cNvSpPr/>
-          <p:nvPr/>
-        </p:nvSpPr>
-        <p:spPr>
-          <a:xfrm>
-            <a:off x="7779968" y="3432201"/>
-            <a:ext cx="1059232" cy="0"/>
-          </a:xfrm>
-          <a:prstGeom prst="line">
-            <a:avLst/>
-          </a:prstGeom>
-          <a:noFill/>
-          <a:ln w="50800">
-            <a:solidFill>
-              <a:srgbClr val="CADCFC"/>
-            </a:solidFill>
-            <a:prstDash val="solid"/>
-            <a:headEnd type="arrow"/>
-          </a:ln>
-        </p:spPr>
-        <p:txBody>
-          <a:bodyPr/>
-          <a:lstStyle/>
-          <a:p>
-            <a:pPr defTabSz="1219170"/>
-            <a:endParaRPr lang="en-US" sz="2400">
-              <a:solidFill>
-                <a:prstClr val="black"/>
-              </a:solidFill>
-              <a:latin typeface="Calibri" panose="020F0502020204030204"/>
-            </a:endParaRPr>
-          </a:p>
-        </p:txBody>
-      </p:sp>
-      <p:sp>
-        <p:nvSpPr>
-          <p:cNvPr id="25" name="Shape 23"/>
-          <p:cNvSpPr/>
-          <p:nvPr/>
-        </p:nvSpPr>
-        <p:spPr>
-          <a:xfrm>
-            <a:off x="3555435" y="3040903"/>
-            <a:ext cx="10725" cy="391298"/>
-          </a:xfrm>
-          <a:prstGeom prst="line">
-            <a:avLst/>
-          </a:prstGeom>
-          <a:noFill/>
-          <a:ln w="50800">
-            <a:solidFill>
-              <a:srgbClr val="CADCFC"/>
-            </a:solidFill>
-            <a:prstDash val="solid"/>
-          </a:ln>
-        </p:spPr>
-        <p:txBody>
-          <a:bodyPr/>
-          <a:lstStyle/>
-          <a:p>
-            <a:pPr defTabSz="1219170"/>
-            <a:endParaRPr lang="en-US" sz="2400">
-              <a:solidFill>
-                <a:prstClr val="black"/>
-              </a:solidFill>
-              <a:latin typeface="Calibri" panose="020F0502020204030204"/>
-            </a:endParaRPr>
-          </a:p>
-        </p:txBody>
-      </p:sp>
-      <p:sp>
-        <p:nvSpPr>
-          <p:cNvPr id="26" name="Shape 24"/>
-          <p:cNvSpPr/>
-          <p:nvPr/>
-        </p:nvSpPr>
-        <p:spPr>
-          <a:xfrm>
-            <a:off x="3555436" y="3432201"/>
-            <a:ext cx="985033" cy="0"/>
-          </a:xfrm>
-          <a:prstGeom prst="line">
-            <a:avLst/>
-          </a:prstGeom>
-          <a:noFill/>
-          <a:ln w="50800">
-            <a:solidFill>
-              <a:srgbClr val="CADCFC"/>
-            </a:solidFill>
-            <a:prstDash val="solid"/>
-            <a:tailEnd type="arrow"/>
-          </a:ln>
-        </p:spPr>
-        <p:txBody>
-          <a:bodyPr/>
-          <a:lstStyle/>
-          <a:p>
-            <a:pPr defTabSz="1219170"/>
-            <a:endParaRPr lang="en-US" sz="2400">
-              <a:solidFill>
-                <a:prstClr val="black"/>
-              </a:solidFill>
-              <a:latin typeface="Calibri" panose="020F0502020204030204"/>
-            </a:endParaRPr>
-          </a:p>
-        </p:txBody>
-      </p:sp>
-      <p:sp>
-        <p:nvSpPr>
-          <p:cNvPr id="27" name="Shape 25"/>
-          <p:cNvSpPr/>
-          <p:nvPr/>
-        </p:nvSpPr>
-        <p:spPr>
-          <a:xfrm>
-            <a:off x="3457901" y="4522399"/>
-            <a:ext cx="5486400" cy="1489456"/>
-          </a:xfrm>
-          <a:prstGeom prst="roundRect">
-            <a:avLst>
-              <a:gd name="adj" fmla="val 8000"/>
-            </a:avLst>
-          </a:prstGeom>
-          <a:solidFill>
-            <a:srgbClr val="253880"/>
-          </a:solidFill>
-          <a:ln w="25400">
-            <a:solidFill>
-              <a:srgbClr val="CADCFC"/>
-            </a:solidFill>
-            <a:prstDash val="solid"/>
-          </a:ln>
-        </p:spPr>
-        <p:txBody>
-          <a:bodyPr/>
-          <a:lstStyle/>
-          <a:p>
-            <a:pPr defTabSz="1219170"/>
-            <a:endParaRPr lang="en-US" sz="2400">
-              <a:solidFill>
-                <a:prstClr val="black"/>
-              </a:solidFill>
-              <a:latin typeface="Calibri" panose="020F0502020204030204"/>
-            </a:endParaRPr>
-          </a:p>
-        </p:txBody>
-      </p:sp>
-      <p:sp>
-        <p:nvSpPr>
-          <p:cNvPr id="28" name="Text 26"/>
-          <p:cNvSpPr/>
-          <p:nvPr/>
-        </p:nvSpPr>
-        <p:spPr>
-          <a:xfrm>
-            <a:off x="3518861" y="4574896"/>
-            <a:ext cx="5364480" cy="315309"/>
-          </a:xfrm>
-          <a:prstGeom prst="rect">
-            <a:avLst/>
-          </a:prstGeom>
-          <a:noFill/>
-          <a:ln/>
-        </p:spPr>
-        <p:txBody>
-          <a:bodyPr wrap="square" lIns="0" tIns="0" rIns="0" bIns="0" rtlCol="0" anchor="ctr"/>
-          <a:lstStyle/>
-          <a:p>
-            <a:pPr algn="ctr" defTabSz="1219170"/>
-            <a:r>
-              <a:rPr lang="en-US" sz="2400" b="1" dirty="0">
-                <a:solidFill>
-                  <a:srgbClr val="FFFFFF"/>
-                </a:solidFill>
-                <a:latin typeface="Calibri" pitchFamily="34" charset="0"/>
-                <a:ea typeface="Calibri" pitchFamily="34" charset="-122"/>
-                <a:cs typeface="Calibri" pitchFamily="34" charset="-120"/>
-              </a:rPr>
-              <a:t>ArcController</a:t>
-            </a:r>
-            <a:endParaRPr lang="en-US" sz="2400" dirty="0">
-              <a:solidFill>
-                <a:prstClr val="black"/>
-              </a:solidFill>
-              <a:latin typeface="Calibri" panose="020F0502020204030204"/>
-            </a:endParaRPr>
-          </a:p>
-        </p:txBody>
-      </p:sp>
-      <p:sp>
-        <p:nvSpPr>
-          <p:cNvPr id="29" name="Text 27"/>
-          <p:cNvSpPr/>
-          <p:nvPr/>
-        </p:nvSpPr>
-        <p:spPr>
-          <a:xfrm>
-            <a:off x="3555437" y="4886419"/>
-            <a:ext cx="5291328" cy="853440"/>
-          </a:xfrm>
-          <a:prstGeom prst="rect">
-            <a:avLst/>
-          </a:prstGeom>
-          <a:noFill/>
-          <a:ln/>
-        </p:spPr>
-        <p:txBody>
-          <a:bodyPr wrap="square" lIns="33867" tIns="33867" rIns="33867" bIns="33867" rtlCol="0" anchor="t"/>
-          <a:lstStyle/>
-          <a:p>
-            <a:pPr defTabSz="1219170"/>
-            <a:r>
-              <a:rPr lang="en-US" sz="1600" dirty="0">
-                <a:solidFill>
-                  <a:srgbClr val="CADCFC"/>
-                </a:solidFill>
-                <a:latin typeface="Calibri" pitchFamily="34" charset="0"/>
-                <a:ea typeface="Calibri" pitchFamily="34" charset="-122"/>
-                <a:cs typeface="Calibri" pitchFamily="34" charset="-120"/>
-              </a:rPr>
-              <a:t>5-min performance arc  ·  leadership · proactive mode · bass pitch-class tracking  ·  energy arc selection · motif + lyrical motif selection  ·  register contrast scheduling · rhythmic density + complementarity  ·  stage swing baseline · opening echo</a:t>
-            </a:r>
-            <a:endParaRPr lang="en-US" sz="1600" dirty="0">
-              <a:solidFill>
-                <a:prstClr val="black"/>
-              </a:solidFill>
-              <a:latin typeface="Calibri" panose="020F0502020204030204"/>
-            </a:endParaRPr>
-          </a:p>
-        </p:txBody>
-      </p:sp>
-      <p:sp>
-        <p:nvSpPr>
-          <p:cNvPr id="30" name="Shape 28"/>
-          <p:cNvSpPr/>
-          <p:nvPr/>
-        </p:nvSpPr>
-        <p:spPr>
-          <a:xfrm>
-            <a:off x="6201101" y="4125109"/>
-            <a:ext cx="0" cy="315309"/>
-          </a:xfrm>
-          <a:prstGeom prst="line">
-            <a:avLst/>
-          </a:prstGeom>
-          <a:noFill/>
-          <a:ln w="50800">
-            <a:solidFill>
-              <a:srgbClr val="CADCFC"/>
-            </a:solidFill>
-            <a:prstDash val="solid"/>
-            <a:tailEnd type="arrow"/>
-          </a:ln>
-        </p:spPr>
-        <p:txBody>
-          <a:bodyPr/>
-          <a:lstStyle/>
-          <a:p>
-            <a:pPr defTabSz="1219170"/>
-            <a:endParaRPr lang="en-US" sz="2400">
-              <a:solidFill>
-                <a:prstClr val="black"/>
-              </a:solidFill>
-              <a:latin typeface="Calibri" panose="020F0502020204030204"/>
-            </a:endParaRPr>
-          </a:p>
-        </p:txBody>
-      </p:sp>
-      <p:sp>
-        <p:nvSpPr>
-          <p:cNvPr id="32" name="Shape 28">
-            <a:extLst>
-              <a:ext uri="{FF2B5EF4-FFF2-40B4-BE49-F238E27FC236}">
-                <a16:creationId xmlns:a16="http://schemas.microsoft.com/office/drawing/2014/main" id="{82A67C06-F31C-A34E-B75C-378998F00D80}"/>
-              </a:ext>
-            </a:extLst>
-          </p:cNvPr>
-          <p:cNvSpPr/>
-          <p:nvPr/>
-        </p:nvSpPr>
-        <p:spPr>
-          <a:xfrm>
-            <a:off x="6201101" y="6173273"/>
-            <a:ext cx="0" cy="476909"/>
-          </a:xfrm>
-          <a:prstGeom prst="line">
-            <a:avLst/>
-          </a:prstGeom>
-          <a:noFill/>
-          <a:ln w="50800">
-            <a:solidFill>
-              <a:srgbClr val="FFC000"/>
-            </a:solidFill>
-            <a:prstDash val="sysDot"/>
-            <a:tailEnd type="arrow"/>
-          </a:ln>
-        </p:spPr>
-        <p:txBody>
-          <a:bodyPr/>
-          <a:lstStyle/>
-          <a:p>
-            <a:pPr defTabSz="1219170"/>
-            <a:endParaRPr lang="en-US" sz="2400" dirty="0">
-              <a:solidFill>
-                <a:prstClr val="black"/>
-              </a:solidFill>
-              <a:latin typeface="Calibri" panose="020F0502020204030204"/>
-            </a:endParaRPr>
-          </a:p>
-        </p:txBody>
-      </p:sp>
-      <p:sp>
-        <p:nvSpPr>
-          <p:cNvPr id="33" name="Shape 13">
-            <a:extLst>
-              <a:ext uri="{FF2B5EF4-FFF2-40B4-BE49-F238E27FC236}">
-                <a16:creationId xmlns:a16="http://schemas.microsoft.com/office/drawing/2014/main" id="{BE87611D-8695-346E-CD03-8723D7EC6F13}"/>
-              </a:ext>
-            </a:extLst>
-          </p:cNvPr>
-          <p:cNvSpPr/>
-          <p:nvPr/>
-        </p:nvSpPr>
-        <p:spPr>
-          <a:xfrm>
-            <a:off x="4834130" y="1139298"/>
-            <a:ext cx="582300" cy="0"/>
-          </a:xfrm>
-          <a:prstGeom prst="line">
-            <a:avLst/>
-          </a:prstGeom>
-          <a:noFill/>
-          <a:ln w="50800">
-            <a:solidFill>
-              <a:srgbClr val="CADCFC"/>
-            </a:solidFill>
-            <a:prstDash val="solid"/>
-            <a:tailEnd type="arrow"/>
-          </a:ln>
-        </p:spPr>
-        <p:txBody>
-          <a:bodyPr/>
-          <a:lstStyle/>
-          <a:p>
-            <a:pPr defTabSz="1219170"/>
-            <a:endParaRPr lang="en-US" sz="2400">
-              <a:solidFill>
-                <a:prstClr val="black"/>
-              </a:solidFill>
-              <a:latin typeface="Calibri" panose="020F0502020204030204"/>
-            </a:endParaRPr>
-          </a:p>
-        </p:txBody>
-      </p:sp>
-      <p:sp>
-        <p:nvSpPr>
-          <p:cNvPr id="34" name="Shape 13">
-            <a:extLst>
-              <a:ext uri="{FF2B5EF4-FFF2-40B4-BE49-F238E27FC236}">
-                <a16:creationId xmlns:a16="http://schemas.microsoft.com/office/drawing/2014/main" id="{7493AAE1-3A41-2F24-A433-15942ED6887C}"/>
-              </a:ext>
-            </a:extLst>
-          </p:cNvPr>
-          <p:cNvSpPr/>
-          <p:nvPr/>
-        </p:nvSpPr>
-        <p:spPr>
-          <a:xfrm>
-            <a:off x="2389639" y="1108553"/>
-            <a:ext cx="377951" cy="0"/>
-          </a:xfrm>
-          <a:prstGeom prst="line">
-            <a:avLst/>
-          </a:prstGeom>
-          <a:noFill/>
-          <a:ln w="50800">
-            <a:solidFill>
-              <a:srgbClr val="CADCFC"/>
-            </a:solidFill>
-            <a:prstDash val="solid"/>
-            <a:tailEnd type="arrow"/>
-          </a:ln>
-        </p:spPr>
-        <p:txBody>
-          <a:bodyPr/>
-          <a:lstStyle/>
-          <a:p>
-            <a:pPr defTabSz="1219170"/>
-            <a:endParaRPr lang="en-US" sz="2400">
-              <a:solidFill>
-                <a:prstClr val="black"/>
-              </a:solidFill>
-              <a:latin typeface="Calibri" panose="020F0502020204030204"/>
-            </a:endParaRPr>
-          </a:p>
-        </p:txBody>
-      </p:sp>
-      <p:sp>
-        <p:nvSpPr>
-          <p:cNvPr id="2" name="Text 10">
-            <a:extLst>
-              <a:ext uri="{FF2B5EF4-FFF2-40B4-BE49-F238E27FC236}">
-                <a16:creationId xmlns:a16="http://schemas.microsoft.com/office/drawing/2014/main" id="{035CAC2A-78AD-68B9-ED4D-6D53C2E1AA41}"/>
-              </a:ext>
-            </a:extLst>
-          </p:cNvPr>
-          <p:cNvSpPr/>
-          <p:nvPr/>
-        </p:nvSpPr>
-        <p:spPr>
-          <a:xfrm>
-            <a:off x="5648890" y="1278995"/>
-            <a:ext cx="2131078" cy="876298"/>
-          </a:xfrm>
-          <a:prstGeom prst="rect">
-            <a:avLst/>
-          </a:prstGeom>
-          <a:noFill/>
-          <a:ln/>
-        </p:spPr>
-        <p:txBody>
-          <a:bodyPr wrap="square" lIns="33867" tIns="33867" rIns="33867" bIns="33867" rtlCol="0" anchor="t"/>
-          <a:lstStyle/>
-          <a:p>
-            <a:pPr defTabSz="1219170"/>
-            <a:r>
-              <a:rPr lang="en-US" sz="1600" dirty="0">
-                <a:solidFill>
-                  <a:srgbClr val="CADCFC"/>
-                </a:solidFill>
-                <a:latin typeface="Calibri" pitchFamily="34" charset="0"/>
-                <a:ea typeface="Calibri" pitchFamily="34" charset="-122"/>
-                <a:cs typeface="Calibri" pitchFamily="34" charset="-120"/>
-              </a:rPr>
-              <a:t>note dur min · min phrase notes · monophony · watchdog</a:t>
-            </a:r>
-            <a:endParaRPr lang="en-US" sz="1600" dirty="0">
-              <a:solidFill>
-                <a:prstClr val="black"/>
-              </a:solidFill>
-              <a:latin typeface="Calibri" panose="020F0502020204030204"/>
-            </a:endParaRPr>
-          </a:p>
-        </p:txBody>
-      </p:sp>
-      <p:sp>
-        <p:nvSpPr>
-          <p:cNvPr id="13" name="Shape 14">
-            <a:extLst>
-              <a:ext uri="{FF2B5EF4-FFF2-40B4-BE49-F238E27FC236}">
-                <a16:creationId xmlns:a16="http://schemas.microsoft.com/office/drawing/2014/main" id="{7D6019D4-9F06-D4F8-9055-5C0B69571156}"/>
-              </a:ext>
-            </a:extLst>
-          </p:cNvPr>
-          <p:cNvSpPr/>
-          <p:nvPr/>
-        </p:nvSpPr>
-        <p:spPr>
-          <a:xfrm>
-            <a:off x="358153" y="4886419"/>
-            <a:ext cx="2292087" cy="781702"/>
-          </a:xfrm>
-          <a:prstGeom prst="roundRect">
-            <a:avLst>
-              <a:gd name="adj" fmla="val 16667"/>
-            </a:avLst>
-          </a:prstGeom>
-          <a:solidFill>
-            <a:srgbClr val="2A3570"/>
-          </a:solidFill>
-          <a:ln w="19050">
-            <a:solidFill>
-              <a:srgbClr val="CADCFC"/>
-            </a:solidFill>
-            <a:prstDash val="solid"/>
-          </a:ln>
-        </p:spPr>
-        <p:txBody>
-          <a:bodyPr/>
-          <a:lstStyle/>
-          <a:p>
-            <a:pPr defTabSz="1219170"/>
-            <a:endParaRPr lang="en-US" sz="2400">
-              <a:solidFill>
-                <a:prstClr val="black"/>
-              </a:solidFill>
-              <a:latin typeface="Calibri" panose="020F0502020204030204"/>
-            </a:endParaRPr>
-          </a:p>
-        </p:txBody>
-      </p:sp>
-      <p:sp>
-        <p:nvSpPr>
-          <p:cNvPr id="14" name="Text 15">
-            <a:extLst>
-              <a:ext uri="{FF2B5EF4-FFF2-40B4-BE49-F238E27FC236}">
-                <a16:creationId xmlns:a16="http://schemas.microsoft.com/office/drawing/2014/main" id="{F402484E-1CC6-34A6-5E23-247659ED013C}"/>
-              </a:ext>
-            </a:extLst>
-          </p:cNvPr>
-          <p:cNvSpPr/>
-          <p:nvPr/>
-        </p:nvSpPr>
-        <p:spPr>
-          <a:xfrm>
-            <a:off x="358151" y="4967954"/>
-            <a:ext cx="2292087" cy="353568"/>
-          </a:xfrm>
-          <a:prstGeom prst="rect">
-            <a:avLst/>
-          </a:prstGeom>
-          <a:noFill/>
-          <a:ln/>
-        </p:spPr>
-        <p:txBody>
-          <a:bodyPr wrap="square" lIns="0" tIns="0" rIns="0" bIns="0" rtlCol="0" anchor="ctr"/>
-          <a:lstStyle/>
-          <a:p>
-            <a:pPr algn="ctr" defTabSz="1219170"/>
-            <a:r>
-              <a:rPr lang="en-US" sz="2400" b="1" dirty="0">
-                <a:solidFill>
-                  <a:srgbClr val="FFFFFF"/>
-                </a:solidFill>
-                <a:latin typeface="Calibri" pitchFamily="34" charset="0"/>
-                <a:ea typeface="Calibri" pitchFamily="34" charset="-122"/>
-                <a:cs typeface="Calibri" pitchFamily="34" charset="-120"/>
-              </a:rPr>
-              <a:t>Proactive Loop</a:t>
-            </a:r>
-            <a:endParaRPr lang="en-US" sz="2400" dirty="0">
-              <a:solidFill>
-                <a:prstClr val="black"/>
-              </a:solidFill>
-              <a:latin typeface="Calibri" panose="020F0502020204030204"/>
-            </a:endParaRPr>
-          </a:p>
-        </p:txBody>
-      </p:sp>
-      <p:sp>
-        <p:nvSpPr>
-          <p:cNvPr id="31" name="Text 16">
-            <a:extLst>
-              <a:ext uri="{FF2B5EF4-FFF2-40B4-BE49-F238E27FC236}">
-                <a16:creationId xmlns:a16="http://schemas.microsoft.com/office/drawing/2014/main" id="{8093E773-011C-6678-EF78-708CE8296041}"/>
-              </a:ext>
-            </a:extLst>
-          </p:cNvPr>
-          <p:cNvSpPr/>
-          <p:nvPr/>
-        </p:nvSpPr>
-        <p:spPr>
-          <a:xfrm>
-            <a:off x="525517" y="5295648"/>
-            <a:ext cx="2124721" cy="293138"/>
-          </a:xfrm>
-          <a:prstGeom prst="rect">
-            <a:avLst/>
-          </a:prstGeom>
-          <a:noFill/>
-          <a:ln/>
-        </p:spPr>
-        <p:txBody>
-          <a:bodyPr wrap="square" lIns="33867" tIns="33867" rIns="33867" bIns="33867" rtlCol="0" anchor="t"/>
-          <a:lstStyle/>
-          <a:p>
-            <a:pPr defTabSz="1219170"/>
-            <a:r>
-              <a:rPr lang="en-US" sz="1600" dirty="0">
-                <a:solidFill>
-                  <a:srgbClr val="CADCFC"/>
-                </a:solidFill>
-                <a:latin typeface="Calibri" pitchFamily="34" charset="0"/>
-                <a:ea typeface="Calibri" pitchFamily="34" charset="-122"/>
-                <a:cs typeface="Calibri" pitchFamily="34" charset="-120"/>
-              </a:rPr>
-              <a:t>fires when bass paused</a:t>
-            </a:r>
-            <a:endParaRPr lang="en-US" sz="1600" dirty="0">
-              <a:solidFill>
-                <a:prstClr val="black"/>
-              </a:solidFill>
-              <a:latin typeface="Calibri" panose="020F0502020204030204"/>
-            </a:endParaRPr>
-          </a:p>
-        </p:txBody>
-      </p:sp>
-      <p:sp>
-        <p:nvSpPr>
-          <p:cNvPr id="35" name="Shape 13">
-            <a:extLst>
-              <a:ext uri="{FF2B5EF4-FFF2-40B4-BE49-F238E27FC236}">
-                <a16:creationId xmlns:a16="http://schemas.microsoft.com/office/drawing/2014/main" id="{FD5AEDBA-8E6D-A402-A41C-3F190A48E5BC}"/>
-              </a:ext>
-            </a:extLst>
-          </p:cNvPr>
-          <p:cNvSpPr/>
-          <p:nvPr/>
-        </p:nvSpPr>
-        <p:spPr>
-          <a:xfrm>
-            <a:off x="2767590" y="5300918"/>
-            <a:ext cx="582300" cy="0"/>
-          </a:xfrm>
-          <a:prstGeom prst="line">
-            <a:avLst/>
-          </a:prstGeom>
-          <a:noFill/>
-          <a:ln w="50800">
-            <a:solidFill>
-              <a:srgbClr val="CADCFC"/>
-            </a:solidFill>
-            <a:prstDash val="solid"/>
-            <a:tailEnd type="arrow"/>
-          </a:ln>
-        </p:spPr>
-        <p:txBody>
-          <a:bodyPr/>
-          <a:lstStyle/>
-          <a:p>
-            <a:pPr defTabSz="1219170"/>
-            <a:endParaRPr lang="en-US" sz="2400">
-              <a:solidFill>
-                <a:prstClr val="black"/>
-              </a:solidFill>
-              <a:latin typeface="Calibri" panose="020F0502020204030204"/>
-            </a:endParaRPr>
-          </a:p>
-        </p:txBody>
-      </p:sp>
-      <p:sp>
-        <p:nvSpPr>
-          <p:cNvPr id="36" name="Text 10">
-            <a:extLst>
-              <a:ext uri="{FF2B5EF4-FFF2-40B4-BE49-F238E27FC236}">
-                <a16:creationId xmlns:a16="http://schemas.microsoft.com/office/drawing/2014/main" id="{FE21DA54-651E-97F3-FCC2-BDEA980E4775}"/>
-              </a:ext>
-            </a:extLst>
-          </p:cNvPr>
-          <p:cNvSpPr/>
-          <p:nvPr/>
-        </p:nvSpPr>
-        <p:spPr>
-          <a:xfrm>
-            <a:off x="2959931" y="1242111"/>
-            <a:ext cx="1892489" cy="876298"/>
-          </a:xfrm>
-          <a:prstGeom prst="rect">
-            <a:avLst/>
-          </a:prstGeom>
-          <a:noFill/>
-          <a:ln/>
-        </p:spPr>
-        <p:txBody>
-          <a:bodyPr wrap="square" lIns="33867" tIns="33867" rIns="33867" bIns="33867" rtlCol="0" anchor="t"/>
-          <a:lstStyle/>
-          <a:p>
-            <a:pPr defTabSz="1219170"/>
-            <a:r>
-              <a:rPr lang="en-US" sz="1600" dirty="0">
-                <a:solidFill>
-                  <a:srgbClr val="CADCFC"/>
-                </a:solidFill>
-                <a:latin typeface="Calibri" pitchFamily="34" charset="0"/>
-                <a:ea typeface="Calibri" pitchFamily="34" charset="-122"/>
-                <a:cs typeface="Calibri" pitchFamily="34" charset="-120"/>
-              </a:rPr>
-              <a:t>pitch range · vel min</a:t>
-            </a:r>
-            <a:endParaRPr lang="en-US" sz="1600" dirty="0">
-              <a:solidFill>
-                <a:prstClr val="black"/>
-              </a:solidFill>
-              <a:latin typeface="Calibri" panose="020F0502020204030204"/>
-            </a:endParaRPr>
-          </a:p>
-        </p:txBody>
-      </p:sp>
-    </p:spTree>
   </p:cSld>
   <p:clrMapOvr>
     <a:masterClrMapping/>
@@ -9750,6 +8922,1592 @@
         </p:nvSpPr>
         <p:spPr>
           <a:xfrm>
+            <a:off x="9424410" y="4424864"/>
+            <a:ext cx="2264263" cy="1662546"/>
+          </a:xfrm>
+          <a:prstGeom prst="rect">
+            <a:avLst/>
+          </a:prstGeom>
+          <a:noFill/>
+          <a:ln/>
+        </p:spPr>
+        <p:txBody>
+          <a:bodyPr wrap="square" lIns="0" tIns="0" rIns="0" bIns="0" rtlCol="0" anchor="ctr"/>
+          <a:lstStyle/>
+          <a:p>
+            <a:pPr algn="ctr" defTabSz="1219170"/>
+            <a:r>
+              <a:rPr lang="en-US" sz="4800" b="1" dirty="0">
+                <a:solidFill>
+                  <a:srgbClr val="FFFFFF"/>
+                </a:solidFill>
+                <a:latin typeface="Optima" panose="02000503060000020004" pitchFamily="2" charset="0"/>
+                <a:ea typeface="Calibri" pitchFamily="34" charset="-122"/>
+                <a:cs typeface="Calibri" pitchFamily="34" charset="-120"/>
+              </a:rPr>
+              <a:t>Input Pipeline</a:t>
+            </a:r>
+            <a:endParaRPr lang="en-US" sz="4800" dirty="0">
+              <a:solidFill>
+                <a:prstClr val="black"/>
+              </a:solidFill>
+              <a:latin typeface="Optima" panose="02000503060000020004" pitchFamily="2" charset="0"/>
+            </a:endParaRPr>
+          </a:p>
+        </p:txBody>
+      </p:sp>
+      <p:sp>
+        <p:nvSpPr>
+          <p:cNvPr id="4" name="Shape 2"/>
+          <p:cNvSpPr/>
+          <p:nvPr/>
+        </p:nvSpPr>
+        <p:spPr>
+          <a:xfrm>
+            <a:off x="365760" y="761879"/>
+            <a:ext cx="1889760" cy="755904"/>
+          </a:xfrm>
+          <a:prstGeom prst="roundRect">
+            <a:avLst>
+              <a:gd name="adj" fmla="val 16667"/>
+            </a:avLst>
+          </a:prstGeom>
+          <a:solidFill>
+            <a:srgbClr val="2A3570"/>
+          </a:solidFill>
+          <a:ln w="19050">
+            <a:solidFill>
+              <a:srgbClr val="CADCFC"/>
+            </a:solidFill>
+            <a:prstDash val="solid"/>
+          </a:ln>
+        </p:spPr>
+        <p:txBody>
+          <a:bodyPr/>
+          <a:lstStyle/>
+          <a:p>
+            <a:pPr defTabSz="1219170"/>
+            <a:endParaRPr lang="en-US" sz="2400">
+              <a:solidFill>
+                <a:prstClr val="black"/>
+              </a:solidFill>
+              <a:latin typeface="Calibri" panose="020F0502020204030204"/>
+            </a:endParaRPr>
+          </a:p>
+        </p:txBody>
+      </p:sp>
+      <p:sp>
+        <p:nvSpPr>
+          <p:cNvPr id="5" name="Text 3"/>
+          <p:cNvSpPr/>
+          <p:nvPr/>
+        </p:nvSpPr>
+        <p:spPr>
+          <a:xfrm>
+            <a:off x="365760" y="761879"/>
+            <a:ext cx="1889760" cy="667900"/>
+          </a:xfrm>
+          <a:prstGeom prst="rect">
+            <a:avLst/>
+          </a:prstGeom>
+          <a:noFill/>
+          <a:ln/>
+        </p:spPr>
+        <p:txBody>
+          <a:bodyPr wrap="square" lIns="67733" tIns="67733" rIns="67733" bIns="67733" rtlCol="0" anchor="ctr"/>
+          <a:lstStyle/>
+          <a:p>
+            <a:pPr algn="ctr" defTabSz="1219170"/>
+            <a:r>
+              <a:rPr lang="en-US" sz="2400" b="1" dirty="0">
+                <a:solidFill>
+                  <a:srgbClr val="FFFFFF"/>
+                </a:solidFill>
+                <a:latin typeface="Calibri" pitchFamily="34" charset="0"/>
+                <a:ea typeface="Calibri" pitchFamily="34" charset="-122"/>
+                <a:cs typeface="Calibri" pitchFamily="34" charset="-120"/>
+              </a:rPr>
+              <a:t>Bass</a:t>
+            </a:r>
+            <a:br>
+              <a:rPr lang="en-US" sz="2400" b="1" dirty="0">
+                <a:solidFill>
+                  <a:srgbClr val="FFFFFF"/>
+                </a:solidFill>
+                <a:latin typeface="Calibri" pitchFamily="34" charset="0"/>
+                <a:ea typeface="Calibri" pitchFamily="34" charset="-122"/>
+                <a:cs typeface="Calibri" pitchFamily="34" charset="-120"/>
+              </a:rPr>
+            </a:br>
+            <a:r>
+              <a:rPr lang="en-US" sz="2000" b="1" dirty="0">
+                <a:solidFill>
+                  <a:srgbClr val="FFFFFF"/>
+                </a:solidFill>
+                <a:latin typeface="Calibri" pitchFamily="34" charset="0"/>
+                <a:ea typeface="Calibri" pitchFamily="34" charset="-122"/>
+                <a:cs typeface="Calibri" pitchFamily="34" charset="-120"/>
+              </a:rPr>
+              <a:t>(pitch-to-MIDI)</a:t>
+            </a:r>
+            <a:endParaRPr lang="en-US" sz="2400" dirty="0">
+              <a:solidFill>
+                <a:prstClr val="black"/>
+              </a:solidFill>
+              <a:latin typeface="Calibri" panose="020F0502020204030204"/>
+            </a:endParaRPr>
+          </a:p>
+        </p:txBody>
+      </p:sp>
+      <p:sp>
+        <p:nvSpPr>
+          <p:cNvPr id="6" name="Shape 4"/>
+          <p:cNvSpPr/>
+          <p:nvPr/>
+        </p:nvSpPr>
+        <p:spPr>
+          <a:xfrm>
+            <a:off x="2865125" y="761878"/>
+            <a:ext cx="1889760" cy="842091"/>
+          </a:xfrm>
+          <a:prstGeom prst="roundRect">
+            <a:avLst>
+              <a:gd name="adj" fmla="val 16667"/>
+            </a:avLst>
+          </a:prstGeom>
+          <a:solidFill>
+            <a:srgbClr val="2A3570"/>
+          </a:solidFill>
+          <a:ln w="19050">
+            <a:solidFill>
+              <a:srgbClr val="CADCFC"/>
+            </a:solidFill>
+            <a:prstDash val="solid"/>
+          </a:ln>
+        </p:spPr>
+        <p:txBody>
+          <a:bodyPr/>
+          <a:lstStyle/>
+          <a:p>
+            <a:pPr defTabSz="1219170"/>
+            <a:endParaRPr lang="en-US" sz="2400">
+              <a:solidFill>
+                <a:prstClr val="black"/>
+              </a:solidFill>
+              <a:latin typeface="Calibri" panose="020F0502020204030204"/>
+            </a:endParaRPr>
+          </a:p>
+        </p:txBody>
+      </p:sp>
+      <p:sp>
+        <p:nvSpPr>
+          <p:cNvPr id="7" name="Text 5"/>
+          <p:cNvSpPr/>
+          <p:nvPr/>
+        </p:nvSpPr>
+        <p:spPr>
+          <a:xfrm>
+            <a:off x="2865125" y="761879"/>
+            <a:ext cx="1889760" cy="585216"/>
+          </a:xfrm>
+          <a:prstGeom prst="rect">
+            <a:avLst/>
+          </a:prstGeom>
+          <a:noFill/>
+          <a:ln/>
+        </p:spPr>
+        <p:txBody>
+          <a:bodyPr wrap="square" lIns="67733" tIns="67733" rIns="67733" bIns="67733" rtlCol="0" anchor="ctr"/>
+          <a:lstStyle/>
+          <a:p>
+            <a:pPr algn="ctr" defTabSz="1219170"/>
+            <a:r>
+              <a:rPr lang="en-US" sz="2400" b="1" dirty="0">
+                <a:solidFill>
+                  <a:srgbClr val="FFFFFF"/>
+                </a:solidFill>
+                <a:latin typeface="Calibri" pitchFamily="34" charset="0"/>
+                <a:ea typeface="Calibri" pitchFamily="34" charset="-122"/>
+                <a:cs typeface="Calibri" pitchFamily="34" charset="-120"/>
+              </a:rPr>
+              <a:t>MidiListener</a:t>
+            </a:r>
+            <a:endParaRPr lang="en-US" sz="2400" dirty="0">
+              <a:solidFill>
+                <a:prstClr val="black"/>
+              </a:solidFill>
+              <a:latin typeface="Calibri" panose="020F0502020204030204"/>
+            </a:endParaRPr>
+          </a:p>
+        </p:txBody>
+      </p:sp>
+      <p:sp>
+        <p:nvSpPr>
+          <p:cNvPr id="8" name="Shape 6"/>
+          <p:cNvSpPr/>
+          <p:nvPr/>
+        </p:nvSpPr>
+        <p:spPr>
+          <a:xfrm>
+            <a:off x="5521530" y="761879"/>
+            <a:ext cx="2291561" cy="1426629"/>
+          </a:xfrm>
+          <a:prstGeom prst="roundRect">
+            <a:avLst>
+              <a:gd name="adj" fmla="val 16667"/>
+            </a:avLst>
+          </a:prstGeom>
+          <a:solidFill>
+            <a:srgbClr val="2A3570"/>
+          </a:solidFill>
+          <a:ln w="19050">
+            <a:solidFill>
+              <a:srgbClr val="CADCFC"/>
+            </a:solidFill>
+            <a:prstDash val="solid"/>
+          </a:ln>
+        </p:spPr>
+        <p:txBody>
+          <a:bodyPr/>
+          <a:lstStyle/>
+          <a:p>
+            <a:pPr defTabSz="1219170"/>
+            <a:endParaRPr lang="en-US" sz="2400">
+              <a:solidFill>
+                <a:prstClr val="black"/>
+              </a:solidFill>
+              <a:latin typeface="Calibri" panose="020F0502020204030204"/>
+            </a:endParaRPr>
+          </a:p>
+        </p:txBody>
+      </p:sp>
+      <p:sp>
+        <p:nvSpPr>
+          <p:cNvPr id="9" name="Text 7"/>
+          <p:cNvSpPr/>
+          <p:nvPr/>
+        </p:nvSpPr>
+        <p:spPr>
+          <a:xfrm>
+            <a:off x="5582490" y="761879"/>
+            <a:ext cx="2197479" cy="583084"/>
+          </a:xfrm>
+          <a:prstGeom prst="rect">
+            <a:avLst/>
+          </a:prstGeom>
+          <a:noFill/>
+          <a:ln/>
+        </p:spPr>
+        <p:txBody>
+          <a:bodyPr wrap="square" lIns="67733" tIns="67733" rIns="67733" bIns="67733" rtlCol="0" anchor="ctr"/>
+          <a:lstStyle/>
+          <a:p>
+            <a:pPr algn="ctr" defTabSz="1219170"/>
+            <a:r>
+              <a:rPr lang="en-US" sz="2400" b="1" dirty="0" err="1">
+                <a:solidFill>
+                  <a:srgbClr val="FFFFFF"/>
+                </a:solidFill>
+                <a:latin typeface="Calibri" pitchFamily="34" charset="0"/>
+                <a:ea typeface="Calibri" pitchFamily="34" charset="-122"/>
+                <a:cs typeface="Calibri" pitchFamily="34" charset="-120"/>
+              </a:rPr>
+              <a:t>PhraseDetector</a:t>
+            </a:r>
+            <a:endParaRPr lang="en-US" sz="2400" dirty="0">
+              <a:solidFill>
+                <a:prstClr val="black"/>
+              </a:solidFill>
+              <a:latin typeface="Calibri" panose="020F0502020204030204"/>
+            </a:endParaRPr>
+          </a:p>
+        </p:txBody>
+      </p:sp>
+      <p:sp>
+        <p:nvSpPr>
+          <p:cNvPr id="10" name="Shape 8"/>
+          <p:cNvSpPr/>
+          <p:nvPr/>
+        </p:nvSpPr>
+        <p:spPr>
+          <a:xfrm>
+            <a:off x="8515479" y="761879"/>
+            <a:ext cx="3066918" cy="1671258"/>
+          </a:xfrm>
+          <a:prstGeom prst="roundRect">
+            <a:avLst>
+              <a:gd name="adj" fmla="val 5333"/>
+            </a:avLst>
+          </a:prstGeom>
+          <a:solidFill>
+            <a:srgbClr val="253880"/>
+          </a:solidFill>
+          <a:ln w="25400">
+            <a:solidFill>
+              <a:srgbClr val="CADCFC"/>
+            </a:solidFill>
+            <a:prstDash val="solid"/>
+          </a:ln>
+        </p:spPr>
+        <p:txBody>
+          <a:bodyPr/>
+          <a:lstStyle/>
+          <a:p>
+            <a:pPr defTabSz="1219170"/>
+            <a:endParaRPr lang="en-US" sz="2400">
+              <a:solidFill>
+                <a:prstClr val="black"/>
+              </a:solidFill>
+              <a:latin typeface="Calibri" panose="020F0502020204030204"/>
+            </a:endParaRPr>
+          </a:p>
+        </p:txBody>
+      </p:sp>
+      <p:sp>
+        <p:nvSpPr>
+          <p:cNvPr id="11" name="Text 9"/>
+          <p:cNvSpPr/>
+          <p:nvPr/>
+        </p:nvSpPr>
+        <p:spPr>
+          <a:xfrm>
+            <a:off x="8576439" y="761878"/>
+            <a:ext cx="2957385" cy="537237"/>
+          </a:xfrm>
+          <a:prstGeom prst="rect">
+            <a:avLst/>
+          </a:prstGeom>
+          <a:noFill/>
+          <a:ln/>
+        </p:spPr>
+        <p:txBody>
+          <a:bodyPr wrap="square" lIns="0" tIns="0" rIns="0" bIns="0" rtlCol="0" anchor="ctr"/>
+          <a:lstStyle/>
+          <a:p>
+            <a:pPr algn="ctr" defTabSz="1219170"/>
+            <a:r>
+              <a:rPr lang="en-US" sz="2400" b="1" dirty="0">
+                <a:solidFill>
+                  <a:srgbClr val="FFFFFF"/>
+                </a:solidFill>
+                <a:latin typeface="Calibri" pitchFamily="34" charset="0"/>
+                <a:ea typeface="Calibri" pitchFamily="34" charset="-122"/>
+                <a:cs typeface="Calibri" pitchFamily="34" charset="-120"/>
+              </a:rPr>
+              <a:t>PhraseAnalyzer</a:t>
+            </a:r>
+            <a:endParaRPr lang="en-US" sz="2400" dirty="0">
+              <a:solidFill>
+                <a:prstClr val="black"/>
+              </a:solidFill>
+              <a:latin typeface="Calibri" panose="020F0502020204030204"/>
+            </a:endParaRPr>
+          </a:p>
+        </p:txBody>
+      </p:sp>
+      <p:sp>
+        <p:nvSpPr>
+          <p:cNvPr id="12" name="Text 10"/>
+          <p:cNvSpPr/>
+          <p:nvPr/>
+        </p:nvSpPr>
+        <p:spPr>
+          <a:xfrm>
+            <a:off x="8650015" y="1296952"/>
+            <a:ext cx="2881918" cy="1134021"/>
+          </a:xfrm>
+          <a:prstGeom prst="rect">
+            <a:avLst/>
+          </a:prstGeom>
+          <a:noFill/>
+          <a:ln/>
+        </p:spPr>
+        <p:txBody>
+          <a:bodyPr wrap="square" lIns="33867" tIns="33867" rIns="33867" bIns="33867" rtlCol="0" anchor="t"/>
+          <a:lstStyle/>
+          <a:p>
+            <a:pPr defTabSz="1219170"/>
+            <a:r>
+              <a:rPr lang="en-US" sz="1600" dirty="0">
+                <a:solidFill>
+                  <a:srgbClr val="CADCFC"/>
+                </a:solidFill>
+                <a:latin typeface="Calibri" pitchFamily="34" charset="0"/>
+                <a:ea typeface="Calibri" pitchFamily="34" charset="-122"/>
+                <a:cs typeface="Calibri" pitchFamily="34" charset="-120"/>
+              </a:rPr>
+              <a:t>contour · density · Q&amp;A type · </a:t>
+            </a:r>
+            <a:br>
+              <a:rPr lang="en-US" sz="1600" dirty="0">
+                <a:solidFill>
+                  <a:srgbClr val="CADCFC"/>
+                </a:solidFill>
+                <a:latin typeface="Calibri" pitchFamily="34" charset="0"/>
+                <a:ea typeface="Calibri" pitchFamily="34" charset="-122"/>
+                <a:cs typeface="Calibri" pitchFamily="34" charset="-120"/>
+              </a:rPr>
+            </a:br>
+            <a:r>
+              <a:rPr lang="en-US" sz="1600" dirty="0">
+                <a:solidFill>
+                  <a:srgbClr val="CADCFC"/>
+                </a:solidFill>
+                <a:latin typeface="Calibri" pitchFamily="34" charset="0"/>
+                <a:ea typeface="Calibri" pitchFamily="34" charset="-122"/>
+                <a:cs typeface="Calibri" pitchFamily="34" charset="-120"/>
+              </a:rPr>
+              <a:t>swing · dynamics · energy profile · </a:t>
+            </a:r>
+            <a:endParaRPr lang="en-US" sz="1600" dirty="0">
+              <a:solidFill>
+                <a:prstClr val="black"/>
+              </a:solidFill>
+              <a:latin typeface="Calibri" panose="020F0502020204030204"/>
+            </a:endParaRPr>
+          </a:p>
+          <a:p>
+            <a:pPr defTabSz="1219170"/>
+            <a:r>
+              <a:rPr lang="en-US" sz="1600" dirty="0">
+                <a:solidFill>
+                  <a:srgbClr val="CADCFC"/>
+                </a:solidFill>
+                <a:latin typeface="Calibri" pitchFamily="34" charset="0"/>
+                <a:ea typeface="Calibri" pitchFamily="34" charset="-122"/>
+                <a:cs typeface="Calibri" pitchFamily="34" charset="-120"/>
+              </a:rPr>
+              <a:t>pitch classes · interval motifs ·  lyrical motifs</a:t>
+            </a:r>
+            <a:endParaRPr lang="en-US" sz="1600" dirty="0">
+              <a:solidFill>
+                <a:prstClr val="black"/>
+              </a:solidFill>
+              <a:latin typeface="Calibri" panose="020F0502020204030204"/>
+            </a:endParaRPr>
+          </a:p>
+        </p:txBody>
+      </p:sp>
+      <p:sp>
+        <p:nvSpPr>
+          <p:cNvPr id="15" name="Shape 13"/>
+          <p:cNvSpPr/>
+          <p:nvPr/>
+        </p:nvSpPr>
+        <p:spPr>
+          <a:xfrm>
+            <a:off x="7910628" y="1139298"/>
+            <a:ext cx="497224" cy="1"/>
+          </a:xfrm>
+          <a:prstGeom prst="line">
+            <a:avLst/>
+          </a:prstGeom>
+          <a:noFill/>
+          <a:ln w="50800">
+            <a:solidFill>
+              <a:srgbClr val="CADCFC"/>
+            </a:solidFill>
+            <a:prstDash val="solid"/>
+            <a:tailEnd type="arrow"/>
+          </a:ln>
+        </p:spPr>
+        <p:txBody>
+          <a:bodyPr/>
+          <a:lstStyle/>
+          <a:p>
+            <a:pPr defTabSz="1219170"/>
+            <a:endParaRPr lang="en-US" sz="2400">
+              <a:solidFill>
+                <a:prstClr val="black"/>
+              </a:solidFill>
+              <a:latin typeface="Calibri" panose="020F0502020204030204"/>
+            </a:endParaRPr>
+          </a:p>
+        </p:txBody>
+      </p:sp>
+      <p:sp>
+        <p:nvSpPr>
+          <p:cNvPr id="16" name="Shape 14"/>
+          <p:cNvSpPr/>
+          <p:nvPr/>
+        </p:nvSpPr>
+        <p:spPr>
+          <a:xfrm>
+            <a:off x="1932319" y="2153045"/>
+            <a:ext cx="2292087" cy="781702"/>
+          </a:xfrm>
+          <a:prstGeom prst="roundRect">
+            <a:avLst>
+              <a:gd name="adj" fmla="val 16667"/>
+            </a:avLst>
+          </a:prstGeom>
+          <a:solidFill>
+            <a:srgbClr val="2A3570"/>
+          </a:solidFill>
+          <a:ln w="19050">
+            <a:solidFill>
+              <a:srgbClr val="CADCFC"/>
+            </a:solidFill>
+            <a:prstDash val="solid"/>
+          </a:ln>
+        </p:spPr>
+        <p:txBody>
+          <a:bodyPr/>
+          <a:lstStyle/>
+          <a:p>
+            <a:pPr defTabSz="1219170"/>
+            <a:endParaRPr lang="en-US" sz="2400" dirty="0">
+              <a:solidFill>
+                <a:prstClr val="black"/>
+              </a:solidFill>
+              <a:latin typeface="Calibri" panose="020F0502020204030204"/>
+            </a:endParaRPr>
+          </a:p>
+        </p:txBody>
+      </p:sp>
+      <p:sp>
+        <p:nvSpPr>
+          <p:cNvPr id="17" name="Text 15"/>
+          <p:cNvSpPr/>
+          <p:nvPr/>
+        </p:nvSpPr>
+        <p:spPr>
+          <a:xfrm>
+            <a:off x="1932317" y="2234580"/>
+            <a:ext cx="2292087" cy="353568"/>
+          </a:xfrm>
+          <a:prstGeom prst="rect">
+            <a:avLst/>
+          </a:prstGeom>
+          <a:noFill/>
+          <a:ln/>
+        </p:spPr>
+        <p:txBody>
+          <a:bodyPr wrap="square" lIns="0" tIns="0" rIns="0" bIns="0" rtlCol="0" anchor="ctr"/>
+          <a:lstStyle/>
+          <a:p>
+            <a:pPr algn="ctr" defTabSz="1219170"/>
+            <a:r>
+              <a:rPr lang="en-US" sz="2400" b="1" dirty="0">
+                <a:solidFill>
+                  <a:srgbClr val="FFFFFF"/>
+                </a:solidFill>
+                <a:latin typeface="Calibri" pitchFamily="34" charset="0"/>
+                <a:ea typeface="Calibri" pitchFamily="34" charset="-122"/>
+                <a:cs typeface="Calibri" pitchFamily="34" charset="-120"/>
+              </a:rPr>
+              <a:t>BeatEstimator</a:t>
+            </a:r>
+            <a:endParaRPr lang="en-US" sz="2400" dirty="0">
+              <a:solidFill>
+                <a:prstClr val="black"/>
+              </a:solidFill>
+              <a:latin typeface="Calibri" panose="020F0502020204030204"/>
+            </a:endParaRPr>
+          </a:p>
+        </p:txBody>
+      </p:sp>
+      <p:sp>
+        <p:nvSpPr>
+          <p:cNvPr id="18" name="Text 16"/>
+          <p:cNvSpPr/>
+          <p:nvPr/>
+        </p:nvSpPr>
+        <p:spPr>
+          <a:xfrm>
+            <a:off x="2165140" y="2549540"/>
+            <a:ext cx="2059268" cy="293138"/>
+          </a:xfrm>
+          <a:prstGeom prst="rect">
+            <a:avLst/>
+          </a:prstGeom>
+          <a:noFill/>
+          <a:ln/>
+        </p:spPr>
+        <p:txBody>
+          <a:bodyPr wrap="square" lIns="33867" tIns="33867" rIns="33867" bIns="33867" rtlCol="0" anchor="t"/>
+          <a:lstStyle/>
+          <a:p>
+            <a:pPr defTabSz="1219170"/>
+            <a:r>
+              <a:rPr lang="en-US" sz="1600" dirty="0">
+                <a:solidFill>
+                  <a:srgbClr val="CADCFC"/>
+                </a:solidFill>
+                <a:latin typeface="Calibri" pitchFamily="34" charset="0"/>
+                <a:ea typeface="Calibri" pitchFamily="34" charset="-122"/>
+                <a:cs typeface="Calibri" pitchFamily="34" charset="-120"/>
+              </a:rPr>
+              <a:t>live tempo · beat sync</a:t>
+            </a:r>
+            <a:endParaRPr lang="en-US" sz="1600" dirty="0">
+              <a:solidFill>
+                <a:prstClr val="black"/>
+              </a:solidFill>
+              <a:latin typeface="Calibri" panose="020F0502020204030204"/>
+            </a:endParaRPr>
+          </a:p>
+        </p:txBody>
+      </p:sp>
+      <p:sp>
+        <p:nvSpPr>
+          <p:cNvPr id="19" name="Shape 17"/>
+          <p:cNvSpPr/>
+          <p:nvPr/>
+        </p:nvSpPr>
+        <p:spPr>
+          <a:xfrm>
+            <a:off x="3566160" y="1685953"/>
+            <a:ext cx="0" cy="353568"/>
+          </a:xfrm>
+          <a:prstGeom prst="line">
+            <a:avLst/>
+          </a:prstGeom>
+          <a:noFill/>
+          <a:ln w="50800">
+            <a:solidFill>
+              <a:srgbClr val="CADCFC"/>
+            </a:solidFill>
+            <a:prstDash val="solid"/>
+            <a:tailEnd type="arrow"/>
+          </a:ln>
+        </p:spPr>
+        <p:txBody>
+          <a:bodyPr/>
+          <a:lstStyle/>
+          <a:p>
+            <a:pPr defTabSz="1219170"/>
+            <a:endParaRPr lang="en-US" sz="2400">
+              <a:solidFill>
+                <a:prstClr val="black"/>
+              </a:solidFill>
+              <a:latin typeface="Calibri" panose="020F0502020204030204"/>
+            </a:endParaRPr>
+          </a:p>
+        </p:txBody>
+      </p:sp>
+      <p:sp>
+        <p:nvSpPr>
+          <p:cNvPr id="20" name="Shape 18"/>
+          <p:cNvSpPr/>
+          <p:nvPr/>
+        </p:nvSpPr>
+        <p:spPr>
+          <a:xfrm>
+            <a:off x="4681302" y="2755535"/>
+            <a:ext cx="2960152" cy="1287592"/>
+          </a:xfrm>
+          <a:prstGeom prst="roundRect">
+            <a:avLst>
+              <a:gd name="adj" fmla="val 8421"/>
+            </a:avLst>
+          </a:prstGeom>
+          <a:solidFill>
+            <a:srgbClr val="162050"/>
+          </a:solidFill>
+          <a:ln w="19050">
+            <a:solidFill>
+              <a:srgbClr val="CADCFC"/>
+            </a:solidFill>
+            <a:prstDash val="solid"/>
+          </a:ln>
+        </p:spPr>
+        <p:txBody>
+          <a:bodyPr/>
+          <a:lstStyle/>
+          <a:p>
+            <a:pPr defTabSz="1219170"/>
+            <a:endParaRPr lang="en-US" sz="2400">
+              <a:solidFill>
+                <a:prstClr val="black"/>
+              </a:solidFill>
+              <a:latin typeface="Calibri" panose="020F0502020204030204"/>
+            </a:endParaRPr>
+          </a:p>
+        </p:txBody>
+      </p:sp>
+      <p:sp>
+        <p:nvSpPr>
+          <p:cNvPr id="21" name="Text 19"/>
+          <p:cNvSpPr/>
+          <p:nvPr/>
+        </p:nvSpPr>
+        <p:spPr>
+          <a:xfrm>
+            <a:off x="4742262" y="2842482"/>
+            <a:ext cx="2850517" cy="316992"/>
+          </a:xfrm>
+          <a:prstGeom prst="rect">
+            <a:avLst/>
+          </a:prstGeom>
+          <a:noFill/>
+          <a:ln/>
+        </p:spPr>
+        <p:txBody>
+          <a:bodyPr wrap="square" lIns="0" tIns="0" rIns="0" bIns="0" rtlCol="0" anchor="ctr"/>
+          <a:lstStyle/>
+          <a:p>
+            <a:pPr algn="ctr" defTabSz="1219170"/>
+            <a:r>
+              <a:rPr lang="en-US" sz="2400" b="1" dirty="0">
+                <a:solidFill>
+                  <a:srgbClr val="FFFFFF"/>
+                </a:solidFill>
+                <a:latin typeface="Calibri" pitchFamily="34" charset="0"/>
+                <a:ea typeface="Calibri" pitchFamily="34" charset="-122"/>
+                <a:cs typeface="Calibri" pitchFamily="34" charset="-120"/>
+              </a:rPr>
+              <a:t>PhraseMemory</a:t>
+            </a:r>
+            <a:endParaRPr lang="en-US" sz="2400" dirty="0">
+              <a:solidFill>
+                <a:prstClr val="black"/>
+              </a:solidFill>
+              <a:latin typeface="Calibri" panose="020F0502020204030204"/>
+            </a:endParaRPr>
+          </a:p>
+        </p:txBody>
+      </p:sp>
+      <p:sp>
+        <p:nvSpPr>
+          <p:cNvPr id="22" name="Text 20"/>
+          <p:cNvSpPr/>
+          <p:nvPr/>
+        </p:nvSpPr>
+        <p:spPr>
+          <a:xfrm>
+            <a:off x="4943430" y="3187584"/>
+            <a:ext cx="2488720" cy="792480"/>
+          </a:xfrm>
+          <a:prstGeom prst="rect">
+            <a:avLst/>
+          </a:prstGeom>
+          <a:noFill/>
+          <a:ln/>
+        </p:spPr>
+        <p:txBody>
+          <a:bodyPr wrap="square" lIns="33867" tIns="33867" rIns="33867" bIns="33867" rtlCol="0" anchor="t"/>
+          <a:lstStyle/>
+          <a:p>
+            <a:pPr defTabSz="1219170"/>
+            <a:r>
+              <a:rPr lang="en-US" sz="1600" dirty="0">
+                <a:solidFill>
+                  <a:srgbClr val="CADCFC"/>
+                </a:solidFill>
+                <a:latin typeface="Calibri" pitchFamily="34" charset="0"/>
+                <a:ea typeface="Calibri" pitchFamily="34" charset="-122"/>
+                <a:cs typeface="Calibri" pitchFamily="34" charset="-120"/>
+              </a:rPr>
+              <a:t>stores phrases + motifs · </a:t>
+            </a:r>
+            <a:endParaRPr lang="en-US" sz="1600" dirty="0">
+              <a:solidFill>
+                <a:prstClr val="black"/>
+              </a:solidFill>
+              <a:latin typeface="Calibri" panose="020F0502020204030204"/>
+            </a:endParaRPr>
+          </a:p>
+          <a:p>
+            <a:pPr defTabSz="1219170"/>
+            <a:r>
+              <a:rPr lang="en-US" sz="1600" dirty="0">
+                <a:solidFill>
+                  <a:srgbClr val="CADCFC"/>
+                </a:solidFill>
+                <a:latin typeface="Calibri" pitchFamily="34" charset="0"/>
+                <a:ea typeface="Calibri" pitchFamily="34" charset="-122"/>
+                <a:cs typeface="Calibri" pitchFamily="34" charset="-120"/>
+              </a:rPr>
+              <a:t>stores lyrical motifs · </a:t>
+            </a:r>
+            <a:endParaRPr lang="en-US" sz="1600" dirty="0">
+              <a:solidFill>
+                <a:prstClr val="black"/>
+              </a:solidFill>
+              <a:latin typeface="Calibri" panose="020F0502020204030204"/>
+            </a:endParaRPr>
+          </a:p>
+          <a:p>
+            <a:pPr defTabSz="1219170"/>
+            <a:r>
+              <a:rPr lang="en-US" sz="1600" dirty="0">
+                <a:solidFill>
+                  <a:srgbClr val="CADCFC"/>
+                </a:solidFill>
+                <a:latin typeface="Calibri" pitchFamily="34" charset="0"/>
+                <a:ea typeface="Calibri" pitchFamily="34" charset="-122"/>
+                <a:cs typeface="Calibri" pitchFamily="34" charset="-120"/>
+              </a:rPr>
+              <a:t>both voices (bass + sax)</a:t>
+            </a:r>
+            <a:endParaRPr lang="en-US" sz="1600" dirty="0">
+              <a:solidFill>
+                <a:prstClr val="black"/>
+              </a:solidFill>
+              <a:latin typeface="Calibri" panose="020F0502020204030204"/>
+            </a:endParaRPr>
+          </a:p>
+        </p:txBody>
+      </p:sp>
+      <p:sp>
+        <p:nvSpPr>
+          <p:cNvPr id="23" name="Shape 21"/>
+          <p:cNvSpPr/>
+          <p:nvPr/>
+        </p:nvSpPr>
+        <p:spPr>
+          <a:xfrm>
+            <a:off x="8839200" y="2610826"/>
+            <a:ext cx="0" cy="821376"/>
+          </a:xfrm>
+          <a:prstGeom prst="line">
+            <a:avLst/>
+          </a:prstGeom>
+          <a:noFill/>
+          <a:ln w="50800">
+            <a:solidFill>
+              <a:srgbClr val="CADCFC"/>
+            </a:solidFill>
+            <a:prstDash val="solid"/>
+          </a:ln>
+        </p:spPr>
+        <p:txBody>
+          <a:bodyPr/>
+          <a:lstStyle/>
+          <a:p>
+            <a:pPr defTabSz="1219170"/>
+            <a:endParaRPr lang="en-US" sz="2400">
+              <a:solidFill>
+                <a:prstClr val="black"/>
+              </a:solidFill>
+              <a:latin typeface="Calibri" panose="020F0502020204030204"/>
+            </a:endParaRPr>
+          </a:p>
+        </p:txBody>
+      </p:sp>
+      <p:sp>
+        <p:nvSpPr>
+          <p:cNvPr id="24" name="Shape 22"/>
+          <p:cNvSpPr/>
+          <p:nvPr/>
+        </p:nvSpPr>
+        <p:spPr>
+          <a:xfrm>
+            <a:off x="7779968" y="3432201"/>
+            <a:ext cx="1059232" cy="0"/>
+          </a:xfrm>
+          <a:prstGeom prst="line">
+            <a:avLst/>
+          </a:prstGeom>
+          <a:noFill/>
+          <a:ln w="50800">
+            <a:solidFill>
+              <a:srgbClr val="CADCFC"/>
+            </a:solidFill>
+            <a:prstDash val="solid"/>
+            <a:headEnd type="arrow"/>
+          </a:ln>
+        </p:spPr>
+        <p:txBody>
+          <a:bodyPr/>
+          <a:lstStyle/>
+          <a:p>
+            <a:pPr defTabSz="1219170"/>
+            <a:endParaRPr lang="en-US" sz="2400">
+              <a:solidFill>
+                <a:prstClr val="black"/>
+              </a:solidFill>
+              <a:latin typeface="Calibri" panose="020F0502020204030204"/>
+            </a:endParaRPr>
+          </a:p>
+        </p:txBody>
+      </p:sp>
+      <p:sp>
+        <p:nvSpPr>
+          <p:cNvPr id="25" name="Shape 23"/>
+          <p:cNvSpPr/>
+          <p:nvPr/>
+        </p:nvSpPr>
+        <p:spPr>
+          <a:xfrm>
+            <a:off x="3555435" y="3040903"/>
+            <a:ext cx="10725" cy="391298"/>
+          </a:xfrm>
+          <a:prstGeom prst="line">
+            <a:avLst/>
+          </a:prstGeom>
+          <a:noFill/>
+          <a:ln w="50800">
+            <a:solidFill>
+              <a:srgbClr val="CADCFC"/>
+            </a:solidFill>
+            <a:prstDash val="solid"/>
+          </a:ln>
+        </p:spPr>
+        <p:txBody>
+          <a:bodyPr/>
+          <a:lstStyle/>
+          <a:p>
+            <a:pPr defTabSz="1219170"/>
+            <a:endParaRPr lang="en-US" sz="2400">
+              <a:solidFill>
+                <a:prstClr val="black"/>
+              </a:solidFill>
+              <a:latin typeface="Calibri" panose="020F0502020204030204"/>
+            </a:endParaRPr>
+          </a:p>
+        </p:txBody>
+      </p:sp>
+      <p:sp>
+        <p:nvSpPr>
+          <p:cNvPr id="26" name="Shape 24"/>
+          <p:cNvSpPr/>
+          <p:nvPr/>
+        </p:nvSpPr>
+        <p:spPr>
+          <a:xfrm>
+            <a:off x="3555436" y="3432201"/>
+            <a:ext cx="985033" cy="0"/>
+          </a:xfrm>
+          <a:prstGeom prst="line">
+            <a:avLst/>
+          </a:prstGeom>
+          <a:noFill/>
+          <a:ln w="50800">
+            <a:solidFill>
+              <a:srgbClr val="CADCFC"/>
+            </a:solidFill>
+            <a:prstDash val="solid"/>
+            <a:tailEnd type="arrow"/>
+          </a:ln>
+        </p:spPr>
+        <p:txBody>
+          <a:bodyPr/>
+          <a:lstStyle/>
+          <a:p>
+            <a:pPr defTabSz="1219170"/>
+            <a:endParaRPr lang="en-US" sz="2400">
+              <a:solidFill>
+                <a:prstClr val="black"/>
+              </a:solidFill>
+              <a:latin typeface="Calibri" panose="020F0502020204030204"/>
+            </a:endParaRPr>
+          </a:p>
+        </p:txBody>
+      </p:sp>
+      <p:sp>
+        <p:nvSpPr>
+          <p:cNvPr id="27" name="Shape 25"/>
+          <p:cNvSpPr/>
+          <p:nvPr/>
+        </p:nvSpPr>
+        <p:spPr>
+          <a:xfrm>
+            <a:off x="3457901" y="4522399"/>
+            <a:ext cx="5486400" cy="1489456"/>
+          </a:xfrm>
+          <a:prstGeom prst="roundRect">
+            <a:avLst>
+              <a:gd name="adj" fmla="val 8000"/>
+            </a:avLst>
+          </a:prstGeom>
+          <a:solidFill>
+            <a:srgbClr val="253880"/>
+          </a:solidFill>
+          <a:ln w="25400">
+            <a:solidFill>
+              <a:srgbClr val="CADCFC"/>
+            </a:solidFill>
+            <a:prstDash val="solid"/>
+          </a:ln>
+        </p:spPr>
+        <p:txBody>
+          <a:bodyPr/>
+          <a:lstStyle/>
+          <a:p>
+            <a:pPr defTabSz="1219170"/>
+            <a:endParaRPr lang="en-US" sz="2400">
+              <a:solidFill>
+                <a:prstClr val="black"/>
+              </a:solidFill>
+              <a:latin typeface="Calibri" panose="020F0502020204030204"/>
+            </a:endParaRPr>
+          </a:p>
+        </p:txBody>
+      </p:sp>
+      <p:sp>
+        <p:nvSpPr>
+          <p:cNvPr id="28" name="Text 26"/>
+          <p:cNvSpPr/>
+          <p:nvPr/>
+        </p:nvSpPr>
+        <p:spPr>
+          <a:xfrm>
+            <a:off x="3518861" y="4574896"/>
+            <a:ext cx="5364480" cy="315309"/>
+          </a:xfrm>
+          <a:prstGeom prst="rect">
+            <a:avLst/>
+          </a:prstGeom>
+          <a:noFill/>
+          <a:ln/>
+        </p:spPr>
+        <p:txBody>
+          <a:bodyPr wrap="square" lIns="0" tIns="0" rIns="0" bIns="0" rtlCol="0" anchor="ctr"/>
+          <a:lstStyle/>
+          <a:p>
+            <a:pPr algn="ctr" defTabSz="1219170"/>
+            <a:r>
+              <a:rPr lang="en-US" sz="2400" b="1" dirty="0">
+                <a:solidFill>
+                  <a:srgbClr val="FFFFFF"/>
+                </a:solidFill>
+                <a:latin typeface="Calibri" pitchFamily="34" charset="0"/>
+                <a:ea typeface="Calibri" pitchFamily="34" charset="-122"/>
+                <a:cs typeface="Calibri" pitchFamily="34" charset="-120"/>
+              </a:rPr>
+              <a:t>ArcController</a:t>
+            </a:r>
+            <a:endParaRPr lang="en-US" sz="2400" dirty="0">
+              <a:solidFill>
+                <a:prstClr val="black"/>
+              </a:solidFill>
+              <a:latin typeface="Calibri" panose="020F0502020204030204"/>
+            </a:endParaRPr>
+          </a:p>
+        </p:txBody>
+      </p:sp>
+      <p:sp>
+        <p:nvSpPr>
+          <p:cNvPr id="29" name="Text 27"/>
+          <p:cNvSpPr/>
+          <p:nvPr/>
+        </p:nvSpPr>
+        <p:spPr>
+          <a:xfrm>
+            <a:off x="3555437" y="4886419"/>
+            <a:ext cx="5291328" cy="853440"/>
+          </a:xfrm>
+          <a:prstGeom prst="rect">
+            <a:avLst/>
+          </a:prstGeom>
+          <a:noFill/>
+          <a:ln/>
+        </p:spPr>
+        <p:txBody>
+          <a:bodyPr wrap="square" lIns="33867" tIns="33867" rIns="33867" bIns="33867" rtlCol="0" anchor="t"/>
+          <a:lstStyle/>
+          <a:p>
+            <a:pPr defTabSz="1219170"/>
+            <a:r>
+              <a:rPr lang="en-US" sz="1600" dirty="0">
+                <a:solidFill>
+                  <a:srgbClr val="CADCFC"/>
+                </a:solidFill>
+                <a:latin typeface="Calibri" pitchFamily="34" charset="0"/>
+                <a:ea typeface="Calibri" pitchFamily="34" charset="-122"/>
+                <a:cs typeface="Calibri" pitchFamily="34" charset="-120"/>
+              </a:rPr>
+              <a:t>5-min performance arc  ·  leadership · proactive mode · bass pitch-class tracking  ·  energy arc selection · motif + lyrical motif selection  ·  register contrast scheduling · rhythmic density + complementarity  ·  stage swing baseline · opening echo</a:t>
+            </a:r>
+            <a:endParaRPr lang="en-US" sz="1600" dirty="0">
+              <a:solidFill>
+                <a:prstClr val="black"/>
+              </a:solidFill>
+              <a:latin typeface="Calibri" panose="020F0502020204030204"/>
+            </a:endParaRPr>
+          </a:p>
+        </p:txBody>
+      </p:sp>
+      <p:sp>
+        <p:nvSpPr>
+          <p:cNvPr id="30" name="Shape 28"/>
+          <p:cNvSpPr/>
+          <p:nvPr/>
+        </p:nvSpPr>
+        <p:spPr>
+          <a:xfrm>
+            <a:off x="6201101" y="4125109"/>
+            <a:ext cx="0" cy="315309"/>
+          </a:xfrm>
+          <a:prstGeom prst="line">
+            <a:avLst/>
+          </a:prstGeom>
+          <a:noFill/>
+          <a:ln w="50800">
+            <a:solidFill>
+              <a:srgbClr val="CADCFC"/>
+            </a:solidFill>
+            <a:prstDash val="solid"/>
+            <a:tailEnd type="arrow"/>
+          </a:ln>
+        </p:spPr>
+        <p:txBody>
+          <a:bodyPr/>
+          <a:lstStyle/>
+          <a:p>
+            <a:pPr defTabSz="1219170"/>
+            <a:endParaRPr lang="en-US" sz="2400">
+              <a:solidFill>
+                <a:prstClr val="black"/>
+              </a:solidFill>
+              <a:latin typeface="Calibri" panose="020F0502020204030204"/>
+            </a:endParaRPr>
+          </a:p>
+        </p:txBody>
+      </p:sp>
+      <p:sp>
+        <p:nvSpPr>
+          <p:cNvPr id="32" name="Shape 28">
+            <a:extLst>
+              <a:ext uri="{FF2B5EF4-FFF2-40B4-BE49-F238E27FC236}">
+                <a16:creationId xmlns:a16="http://schemas.microsoft.com/office/drawing/2014/main" id="{82A67C06-F31C-A34E-B75C-378998F00D80}"/>
+              </a:ext>
+            </a:extLst>
+          </p:cNvPr>
+          <p:cNvSpPr/>
+          <p:nvPr/>
+        </p:nvSpPr>
+        <p:spPr>
+          <a:xfrm>
+            <a:off x="6201101" y="6173273"/>
+            <a:ext cx="0" cy="476909"/>
+          </a:xfrm>
+          <a:prstGeom prst="line">
+            <a:avLst/>
+          </a:prstGeom>
+          <a:noFill/>
+          <a:ln w="50800">
+            <a:solidFill>
+              <a:srgbClr val="FFC000"/>
+            </a:solidFill>
+            <a:prstDash val="sysDot"/>
+            <a:tailEnd type="arrow"/>
+          </a:ln>
+        </p:spPr>
+        <p:txBody>
+          <a:bodyPr/>
+          <a:lstStyle/>
+          <a:p>
+            <a:pPr defTabSz="1219170"/>
+            <a:endParaRPr lang="en-US" sz="2400" dirty="0">
+              <a:solidFill>
+                <a:prstClr val="black"/>
+              </a:solidFill>
+              <a:latin typeface="Calibri" panose="020F0502020204030204"/>
+            </a:endParaRPr>
+          </a:p>
+        </p:txBody>
+      </p:sp>
+      <p:sp>
+        <p:nvSpPr>
+          <p:cNvPr id="33" name="Shape 13">
+            <a:extLst>
+              <a:ext uri="{FF2B5EF4-FFF2-40B4-BE49-F238E27FC236}">
+                <a16:creationId xmlns:a16="http://schemas.microsoft.com/office/drawing/2014/main" id="{BE87611D-8695-346E-CD03-8723D7EC6F13}"/>
+              </a:ext>
+            </a:extLst>
+          </p:cNvPr>
+          <p:cNvSpPr/>
+          <p:nvPr/>
+        </p:nvSpPr>
+        <p:spPr>
+          <a:xfrm>
+            <a:off x="4834130" y="1139298"/>
+            <a:ext cx="582300" cy="0"/>
+          </a:xfrm>
+          <a:prstGeom prst="line">
+            <a:avLst/>
+          </a:prstGeom>
+          <a:noFill/>
+          <a:ln w="50800">
+            <a:solidFill>
+              <a:srgbClr val="CADCFC"/>
+            </a:solidFill>
+            <a:prstDash val="solid"/>
+            <a:tailEnd type="arrow"/>
+          </a:ln>
+        </p:spPr>
+        <p:txBody>
+          <a:bodyPr/>
+          <a:lstStyle/>
+          <a:p>
+            <a:pPr defTabSz="1219170"/>
+            <a:endParaRPr lang="en-US" sz="2400">
+              <a:solidFill>
+                <a:prstClr val="black"/>
+              </a:solidFill>
+              <a:latin typeface="Calibri" panose="020F0502020204030204"/>
+            </a:endParaRPr>
+          </a:p>
+        </p:txBody>
+      </p:sp>
+      <p:sp>
+        <p:nvSpPr>
+          <p:cNvPr id="34" name="Shape 13">
+            <a:extLst>
+              <a:ext uri="{FF2B5EF4-FFF2-40B4-BE49-F238E27FC236}">
+                <a16:creationId xmlns:a16="http://schemas.microsoft.com/office/drawing/2014/main" id="{7493AAE1-3A41-2F24-A433-15942ED6887C}"/>
+              </a:ext>
+            </a:extLst>
+          </p:cNvPr>
+          <p:cNvSpPr/>
+          <p:nvPr/>
+        </p:nvSpPr>
+        <p:spPr>
+          <a:xfrm>
+            <a:off x="2389639" y="1108553"/>
+            <a:ext cx="377951" cy="0"/>
+          </a:xfrm>
+          <a:prstGeom prst="line">
+            <a:avLst/>
+          </a:prstGeom>
+          <a:noFill/>
+          <a:ln w="50800">
+            <a:solidFill>
+              <a:srgbClr val="CADCFC"/>
+            </a:solidFill>
+            <a:prstDash val="solid"/>
+            <a:tailEnd type="arrow"/>
+          </a:ln>
+        </p:spPr>
+        <p:txBody>
+          <a:bodyPr/>
+          <a:lstStyle/>
+          <a:p>
+            <a:pPr defTabSz="1219170"/>
+            <a:endParaRPr lang="en-US" sz="2400">
+              <a:solidFill>
+                <a:prstClr val="black"/>
+              </a:solidFill>
+              <a:latin typeface="Calibri" panose="020F0502020204030204"/>
+            </a:endParaRPr>
+          </a:p>
+        </p:txBody>
+      </p:sp>
+      <p:sp>
+        <p:nvSpPr>
+          <p:cNvPr id="2" name="Text 10">
+            <a:extLst>
+              <a:ext uri="{FF2B5EF4-FFF2-40B4-BE49-F238E27FC236}">
+                <a16:creationId xmlns:a16="http://schemas.microsoft.com/office/drawing/2014/main" id="{035CAC2A-78AD-68B9-ED4D-6D53C2E1AA41}"/>
+              </a:ext>
+            </a:extLst>
+          </p:cNvPr>
+          <p:cNvSpPr/>
+          <p:nvPr/>
+        </p:nvSpPr>
+        <p:spPr>
+          <a:xfrm>
+            <a:off x="5648890" y="1278995"/>
+            <a:ext cx="2131078" cy="876298"/>
+          </a:xfrm>
+          <a:prstGeom prst="rect">
+            <a:avLst/>
+          </a:prstGeom>
+          <a:noFill/>
+          <a:ln/>
+        </p:spPr>
+        <p:txBody>
+          <a:bodyPr wrap="square" lIns="33867" tIns="33867" rIns="33867" bIns="33867" rtlCol="0" anchor="t"/>
+          <a:lstStyle/>
+          <a:p>
+            <a:pPr defTabSz="1219170"/>
+            <a:r>
+              <a:rPr lang="en-US" sz="1600" dirty="0">
+                <a:solidFill>
+                  <a:srgbClr val="CADCFC"/>
+                </a:solidFill>
+                <a:latin typeface="Calibri" pitchFamily="34" charset="0"/>
+                <a:ea typeface="Calibri" pitchFamily="34" charset="-122"/>
+                <a:cs typeface="Calibri" pitchFamily="34" charset="-120"/>
+              </a:rPr>
+              <a:t>note dur min · min phrase notes · monophony · watchdog</a:t>
+            </a:r>
+            <a:endParaRPr lang="en-US" sz="1600" dirty="0">
+              <a:solidFill>
+                <a:prstClr val="black"/>
+              </a:solidFill>
+              <a:latin typeface="Calibri" panose="020F0502020204030204"/>
+            </a:endParaRPr>
+          </a:p>
+        </p:txBody>
+      </p:sp>
+      <p:sp>
+        <p:nvSpPr>
+          <p:cNvPr id="13" name="Shape 14">
+            <a:extLst>
+              <a:ext uri="{FF2B5EF4-FFF2-40B4-BE49-F238E27FC236}">
+                <a16:creationId xmlns:a16="http://schemas.microsoft.com/office/drawing/2014/main" id="{7D6019D4-9F06-D4F8-9055-5C0B69571156}"/>
+              </a:ext>
+            </a:extLst>
+          </p:cNvPr>
+          <p:cNvSpPr/>
+          <p:nvPr/>
+        </p:nvSpPr>
+        <p:spPr>
+          <a:xfrm>
+            <a:off x="358153" y="4886419"/>
+            <a:ext cx="2292087" cy="781702"/>
+          </a:xfrm>
+          <a:prstGeom prst="roundRect">
+            <a:avLst>
+              <a:gd name="adj" fmla="val 16667"/>
+            </a:avLst>
+          </a:prstGeom>
+          <a:solidFill>
+            <a:srgbClr val="2A3570"/>
+          </a:solidFill>
+          <a:ln w="19050">
+            <a:solidFill>
+              <a:srgbClr val="CADCFC"/>
+            </a:solidFill>
+            <a:prstDash val="solid"/>
+          </a:ln>
+        </p:spPr>
+        <p:txBody>
+          <a:bodyPr/>
+          <a:lstStyle/>
+          <a:p>
+            <a:pPr defTabSz="1219170"/>
+            <a:endParaRPr lang="en-US" sz="2400">
+              <a:solidFill>
+                <a:prstClr val="black"/>
+              </a:solidFill>
+              <a:latin typeface="Calibri" panose="020F0502020204030204"/>
+            </a:endParaRPr>
+          </a:p>
+        </p:txBody>
+      </p:sp>
+      <p:sp>
+        <p:nvSpPr>
+          <p:cNvPr id="14" name="Text 15">
+            <a:extLst>
+              <a:ext uri="{FF2B5EF4-FFF2-40B4-BE49-F238E27FC236}">
+                <a16:creationId xmlns:a16="http://schemas.microsoft.com/office/drawing/2014/main" id="{F402484E-1CC6-34A6-5E23-247659ED013C}"/>
+              </a:ext>
+            </a:extLst>
+          </p:cNvPr>
+          <p:cNvSpPr/>
+          <p:nvPr/>
+        </p:nvSpPr>
+        <p:spPr>
+          <a:xfrm>
+            <a:off x="358151" y="4967954"/>
+            <a:ext cx="2292087" cy="353568"/>
+          </a:xfrm>
+          <a:prstGeom prst="rect">
+            <a:avLst/>
+          </a:prstGeom>
+          <a:noFill/>
+          <a:ln/>
+        </p:spPr>
+        <p:txBody>
+          <a:bodyPr wrap="square" lIns="0" tIns="0" rIns="0" bIns="0" rtlCol="0" anchor="ctr"/>
+          <a:lstStyle/>
+          <a:p>
+            <a:pPr algn="ctr" defTabSz="1219170"/>
+            <a:r>
+              <a:rPr lang="en-US" sz="2400" b="1" dirty="0">
+                <a:solidFill>
+                  <a:srgbClr val="FFFFFF"/>
+                </a:solidFill>
+                <a:latin typeface="Calibri" pitchFamily="34" charset="0"/>
+                <a:ea typeface="Calibri" pitchFamily="34" charset="-122"/>
+                <a:cs typeface="Calibri" pitchFamily="34" charset="-120"/>
+              </a:rPr>
+              <a:t>Proactive Loop</a:t>
+            </a:r>
+            <a:endParaRPr lang="en-US" sz="2400" dirty="0">
+              <a:solidFill>
+                <a:prstClr val="black"/>
+              </a:solidFill>
+              <a:latin typeface="Calibri" panose="020F0502020204030204"/>
+            </a:endParaRPr>
+          </a:p>
+        </p:txBody>
+      </p:sp>
+      <p:sp>
+        <p:nvSpPr>
+          <p:cNvPr id="31" name="Text 16">
+            <a:extLst>
+              <a:ext uri="{FF2B5EF4-FFF2-40B4-BE49-F238E27FC236}">
+                <a16:creationId xmlns:a16="http://schemas.microsoft.com/office/drawing/2014/main" id="{8093E773-011C-6678-EF78-708CE8296041}"/>
+              </a:ext>
+            </a:extLst>
+          </p:cNvPr>
+          <p:cNvSpPr/>
+          <p:nvPr/>
+        </p:nvSpPr>
+        <p:spPr>
+          <a:xfrm>
+            <a:off x="525517" y="5295648"/>
+            <a:ext cx="2124721" cy="293138"/>
+          </a:xfrm>
+          <a:prstGeom prst="rect">
+            <a:avLst/>
+          </a:prstGeom>
+          <a:noFill/>
+          <a:ln/>
+        </p:spPr>
+        <p:txBody>
+          <a:bodyPr wrap="square" lIns="33867" tIns="33867" rIns="33867" bIns="33867" rtlCol="0" anchor="t"/>
+          <a:lstStyle/>
+          <a:p>
+            <a:pPr defTabSz="1219170"/>
+            <a:r>
+              <a:rPr lang="en-US" sz="1600" dirty="0">
+                <a:solidFill>
+                  <a:srgbClr val="CADCFC"/>
+                </a:solidFill>
+                <a:latin typeface="Calibri" pitchFamily="34" charset="0"/>
+                <a:ea typeface="Calibri" pitchFamily="34" charset="-122"/>
+                <a:cs typeface="Calibri" pitchFamily="34" charset="-120"/>
+              </a:rPr>
+              <a:t>fires when bass paused</a:t>
+            </a:r>
+            <a:endParaRPr lang="en-US" sz="1600" dirty="0">
+              <a:solidFill>
+                <a:prstClr val="black"/>
+              </a:solidFill>
+              <a:latin typeface="Calibri" panose="020F0502020204030204"/>
+            </a:endParaRPr>
+          </a:p>
+        </p:txBody>
+      </p:sp>
+      <p:sp>
+        <p:nvSpPr>
+          <p:cNvPr id="35" name="Shape 13">
+            <a:extLst>
+              <a:ext uri="{FF2B5EF4-FFF2-40B4-BE49-F238E27FC236}">
+                <a16:creationId xmlns:a16="http://schemas.microsoft.com/office/drawing/2014/main" id="{FD5AEDBA-8E6D-A402-A41C-3F190A48E5BC}"/>
+              </a:ext>
+            </a:extLst>
+          </p:cNvPr>
+          <p:cNvSpPr/>
+          <p:nvPr/>
+        </p:nvSpPr>
+        <p:spPr>
+          <a:xfrm>
+            <a:off x="2767590" y="5300918"/>
+            <a:ext cx="582300" cy="0"/>
+          </a:xfrm>
+          <a:prstGeom prst="line">
+            <a:avLst/>
+          </a:prstGeom>
+          <a:noFill/>
+          <a:ln w="50800">
+            <a:solidFill>
+              <a:srgbClr val="CADCFC"/>
+            </a:solidFill>
+            <a:prstDash val="solid"/>
+            <a:tailEnd type="arrow"/>
+          </a:ln>
+        </p:spPr>
+        <p:txBody>
+          <a:bodyPr/>
+          <a:lstStyle/>
+          <a:p>
+            <a:pPr defTabSz="1219170"/>
+            <a:endParaRPr lang="en-US" sz="2400">
+              <a:solidFill>
+                <a:prstClr val="black"/>
+              </a:solidFill>
+              <a:latin typeface="Calibri" panose="020F0502020204030204"/>
+            </a:endParaRPr>
+          </a:p>
+        </p:txBody>
+      </p:sp>
+      <p:sp>
+        <p:nvSpPr>
+          <p:cNvPr id="36" name="Text 10">
+            <a:extLst>
+              <a:ext uri="{FF2B5EF4-FFF2-40B4-BE49-F238E27FC236}">
+                <a16:creationId xmlns:a16="http://schemas.microsoft.com/office/drawing/2014/main" id="{FE21DA54-651E-97F3-FCC2-BDEA980E4775}"/>
+              </a:ext>
+            </a:extLst>
+          </p:cNvPr>
+          <p:cNvSpPr/>
+          <p:nvPr/>
+        </p:nvSpPr>
+        <p:spPr>
+          <a:xfrm>
+            <a:off x="2959931" y="1242111"/>
+            <a:ext cx="1892489" cy="876298"/>
+          </a:xfrm>
+          <a:prstGeom prst="rect">
+            <a:avLst/>
+          </a:prstGeom>
+          <a:noFill/>
+          <a:ln/>
+        </p:spPr>
+        <p:txBody>
+          <a:bodyPr wrap="square" lIns="33867" tIns="33867" rIns="33867" bIns="33867" rtlCol="0" anchor="t"/>
+          <a:lstStyle/>
+          <a:p>
+            <a:pPr defTabSz="1219170"/>
+            <a:r>
+              <a:rPr lang="en-US" sz="1600" dirty="0">
+                <a:solidFill>
+                  <a:srgbClr val="CADCFC"/>
+                </a:solidFill>
+                <a:latin typeface="Calibri" pitchFamily="34" charset="0"/>
+                <a:ea typeface="Calibri" pitchFamily="34" charset="-122"/>
+                <a:cs typeface="Calibri" pitchFamily="34" charset="-120"/>
+              </a:rPr>
+              <a:t>pitch range · vel min</a:t>
+            </a:r>
+            <a:endParaRPr lang="en-US" sz="1600" dirty="0">
+              <a:solidFill>
+                <a:prstClr val="black"/>
+              </a:solidFill>
+              <a:latin typeface="Calibri" panose="020F0502020204030204"/>
+            </a:endParaRPr>
+          </a:p>
+        </p:txBody>
+      </p:sp>
+    </p:spTree>
+  </p:cSld>
+  <p:clrMapOvr>
+    <a:masterClrMapping/>
+  </p:clrMapOvr>
+</p:sld>
+</file>
+
+<file path=ppt/slides/slide8.xml><?xml version="1.0" encoding="utf-8"?>
+<p:sld xmlns:a="http://schemas.openxmlformats.org/drawingml/2006/main" xmlns:r="http://schemas.openxmlformats.org/officeDocument/2006/relationships" xmlns:p="http://schemas.openxmlformats.org/presentationml/2006/main">
+  <p:cSld>
+    <p:bg>
+      <p:bgPr>
+        <a:solidFill>
+          <a:srgbClr val="00B0F0"/>
+        </a:solidFill>
+        <a:effectLst/>
+      </p:bgPr>
+    </p:bg>
+    <p:spTree>
+      <p:nvGrpSpPr>
+        <p:cNvPr id="1" name=""/>
+        <p:cNvGrpSpPr/>
+        <p:nvPr/>
+      </p:nvGrpSpPr>
+      <p:grpSpPr>
+        <a:xfrm>
+          <a:off x="0" y="0"/>
+          <a:ext cx="0" cy="0"/>
+          <a:chOff x="0" y="0"/>
+          <a:chExt cx="0" cy="0"/>
+        </a:xfrm>
+      </p:grpSpPr>
+      <p:sp>
+        <p:nvSpPr>
+          <p:cNvPr id="3" name="Text 1"/>
+          <p:cNvSpPr/>
+          <p:nvPr/>
+        </p:nvSpPr>
+        <p:spPr>
+          <a:xfrm>
             <a:off x="8308575" y="240298"/>
             <a:ext cx="3115243" cy="1394410"/>
           </a:xfrm>
@@ -11250,7 +12008,7 @@
 </p:sld>
 </file>
 
-<file path=ppt/slides/slide8.xml><?xml version="1.0" encoding="utf-8"?>
+<file path=ppt/slides/slide9.xml><?xml version="1.0" encoding="utf-8"?>
 <p:sld xmlns:a="http://schemas.openxmlformats.org/drawingml/2006/main" xmlns:r="http://schemas.openxmlformats.org/officeDocument/2006/relationships" xmlns:p="http://schemas.openxmlformats.org/presentationml/2006/main">
   <p:cSld>
     <p:spTree>
@@ -11329,7 +12087,7 @@
         </p:blipFill>
         <p:spPr>
           <a:xfrm>
-            <a:off x="6140340" y="1429063"/>
+            <a:off x="6140340" y="1355493"/>
             <a:ext cx="5199271" cy="3941724"/>
           </a:xfrm>
           <a:prstGeom prst="rect">
@@ -11359,7 +12117,7 @@
         </p:blipFill>
         <p:spPr>
           <a:xfrm>
-            <a:off x="964580" y="1429064"/>
+            <a:off x="964580" y="1355494"/>
             <a:ext cx="4592481" cy="3941724"/>
           </a:xfrm>
           <a:prstGeom prst="rect">
@@ -11381,7 +12139,7 @@
         </p:nvSpPr>
         <p:spPr>
           <a:xfrm>
-            <a:off x="2672576" y="5628972"/>
+            <a:off x="2672576" y="5586932"/>
             <a:ext cx="6846848" cy="1015663"/>
           </a:xfrm>
           <a:prstGeom prst="rect">
@@ -11414,523 +12172,6 @@
     <p:extLst>
       <p:ext uri="{BB962C8B-B14F-4D97-AF65-F5344CB8AC3E}">
         <p14:creationId xmlns:p14="http://schemas.microsoft.com/office/powerpoint/2010/main" val="227698343"/>
-      </p:ext>
-    </p:extLst>
-  </p:cSld>
-  <p:clrMapOvr>
-    <a:masterClrMapping/>
-  </p:clrMapOvr>
-</p:sld>
-</file>
-
-<file path=ppt/slides/slide9.xml><?xml version="1.0" encoding="utf-8"?>
-<p:sld xmlns:a="http://schemas.openxmlformats.org/drawingml/2006/main" xmlns:r="http://schemas.openxmlformats.org/officeDocument/2006/relationships" xmlns:p="http://schemas.openxmlformats.org/presentationml/2006/main">
-  <p:cSld>
-    <p:spTree>
-      <p:nvGrpSpPr>
-        <p:cNvPr id="1" name="">
-          <a:extLst>
-            <a:ext uri="{FF2B5EF4-FFF2-40B4-BE49-F238E27FC236}">
-              <a16:creationId xmlns:a16="http://schemas.microsoft.com/office/drawing/2014/main" id="{12D793BB-5984-061A-79FE-248D7810A2B1}"/>
-            </a:ext>
-          </a:extLst>
-        </p:cNvPr>
-        <p:cNvGrpSpPr/>
-        <p:nvPr/>
-      </p:nvGrpSpPr>
-      <p:grpSpPr>
-        <a:xfrm>
-          <a:off x="0" y="0"/>
-          <a:ext cx="0" cy="0"/>
-          <a:chOff x="0" y="0"/>
-          <a:chExt cx="0" cy="0"/>
-        </a:xfrm>
-      </p:grpSpPr>
-      <p:sp>
-        <p:nvSpPr>
-          <p:cNvPr id="5" name="Content Placeholder 4">
-            <a:extLst>
-              <a:ext uri="{FF2B5EF4-FFF2-40B4-BE49-F238E27FC236}">
-                <a16:creationId xmlns:a16="http://schemas.microsoft.com/office/drawing/2014/main" id="{50065DF7-EEE5-CCF2-2669-649CAF486EFE}"/>
-              </a:ext>
-            </a:extLst>
-          </p:cNvPr>
-          <p:cNvSpPr>
-            <a:spLocks noGrp="1"/>
-          </p:cNvSpPr>
-          <p:nvPr>
-            <p:ph idx="1"/>
-          </p:nvPr>
-        </p:nvSpPr>
-        <p:spPr>
-          <a:xfrm>
-            <a:off x="838199" y="903249"/>
-            <a:ext cx="8400393" cy="5273714"/>
-          </a:xfrm>
-        </p:spPr>
-        <p:txBody>
-          <a:bodyPr>
-            <a:normAutofit fontScale="92500"/>
-          </a:bodyPr>
-          <a:lstStyle/>
-          <a:p>
-            <a:r>
-              <a:rPr lang="en-US" dirty="0">
-                <a:latin typeface="Palatino Linotype" panose="02040502050505030304" pitchFamily="18" charset="0"/>
-              </a:rPr>
-              <a:t>Repo is on </a:t>
-            </a:r>
-            <a:r>
-              <a:rPr lang="en-US" dirty="0">
-                <a:latin typeface="Palatino Linotype" panose="02040502050505030304" pitchFamily="18" charset="0"/>
-                <a:hlinkClick r:id="rId3"/>
-              </a:rPr>
-              <a:t>github.com/davidderoure/wolfson</a:t>
-            </a:r>
-            <a:r>
-              <a:rPr lang="en-US" dirty="0">
-                <a:latin typeface="Palatino Linotype" panose="02040502050505030304" pitchFamily="18" charset="0"/>
-              </a:rPr>
-              <a:t>  </a:t>
-            </a:r>
-          </a:p>
-          <a:p>
-            <a:endParaRPr lang="en-US" dirty="0">
-              <a:latin typeface="Palatino Linotype" panose="02040502050505030304" pitchFamily="18" charset="0"/>
-            </a:endParaRPr>
-          </a:p>
-          <a:p>
-            <a:r>
-              <a:rPr lang="en-US" dirty="0">
-                <a:latin typeface="Palatino Linotype" panose="02040502050505030304" pitchFamily="18" charset="0"/>
-              </a:rPr>
-              <a:t>Acknowledgement:</a:t>
-            </a:r>
-          </a:p>
-          <a:p>
-            <a:pPr lvl="1"/>
-            <a:r>
-              <a:rPr lang="en-US" sz="2200" dirty="0">
-                <a:latin typeface="Palatino Linotype" panose="02040502050505030304" pitchFamily="18" charset="0"/>
-              </a:rPr>
-              <a:t>Ray </a:t>
-            </a:r>
-            <a:r>
-              <a:rPr lang="en-US" sz="2200" dirty="0" err="1">
-                <a:latin typeface="Palatino Linotype" panose="02040502050505030304" pitchFamily="18" charset="0"/>
-              </a:rPr>
-              <a:t>d’Inverno</a:t>
-            </a:r>
-            <a:r>
-              <a:rPr lang="en-US" sz="2200" dirty="0">
-                <a:latin typeface="Palatino Linotype" panose="02040502050505030304" pitchFamily="18" charset="0"/>
-              </a:rPr>
-              <a:t> (for jazz, Lisp, AI, slick licks)</a:t>
-            </a:r>
-          </a:p>
-          <a:p>
-            <a:pPr lvl="1"/>
-            <a:r>
-              <a:rPr lang="en-US" sz="2200" dirty="0">
-                <a:latin typeface="Palatino Linotype" panose="02040502050505030304" pitchFamily="18" charset="0"/>
-              </a:rPr>
-              <a:t>Mark </a:t>
-            </a:r>
-            <a:r>
-              <a:rPr lang="en-US" sz="2200" dirty="0" err="1">
-                <a:latin typeface="Palatino Linotype" panose="02040502050505030304" pitchFamily="18" charset="0"/>
-              </a:rPr>
-              <a:t>d’Inverno</a:t>
-            </a:r>
-            <a:r>
-              <a:rPr lang="en-US" sz="2200" dirty="0">
-                <a:latin typeface="Palatino Linotype" panose="02040502050505030304" pitchFamily="18" charset="0"/>
-              </a:rPr>
-              <a:t> (for jazz, AI, creativity, slick licks)</a:t>
-            </a:r>
-          </a:p>
-          <a:p>
-            <a:pPr lvl="1"/>
-            <a:r>
-              <a:rPr lang="en-US" sz="2200" dirty="0">
-                <a:latin typeface="Palatino Linotype" panose="02040502050505030304" pitchFamily="18" charset="0"/>
-              </a:rPr>
-              <a:t>George E Lewis (for Voyager and Forager)</a:t>
-            </a:r>
-          </a:p>
-          <a:p>
-            <a:pPr lvl="1"/>
-            <a:r>
-              <a:rPr lang="en-US" sz="2200" dirty="0">
-                <a:latin typeface="Palatino Linotype" panose="02040502050505030304" pitchFamily="18" charset="0"/>
-              </a:rPr>
-              <a:t>Robert Laidlow (for Alter-</a:t>
-            </a:r>
-            <a:r>
-              <a:rPr lang="en-US" sz="2200" dirty="0" err="1">
-                <a:latin typeface="Palatino Linotype" panose="02040502050505030304" pitchFamily="18" charset="0"/>
-              </a:rPr>
-              <a:t>ing</a:t>
-            </a:r>
-            <a:r>
-              <a:rPr lang="en-US" sz="2200" dirty="0">
-                <a:latin typeface="Palatino Linotype" panose="02040502050505030304" pitchFamily="18" charset="0"/>
-              </a:rPr>
-              <a:t> Ada Lovelace, and sax)</a:t>
-            </a:r>
-          </a:p>
-          <a:p>
-            <a:pPr lvl="1"/>
-            <a:r>
-              <a:rPr lang="en-US" sz="2200" dirty="0" err="1">
-                <a:latin typeface="Palatino Linotype" panose="02040502050505030304" pitchFamily="18" charset="0"/>
-              </a:rPr>
-              <a:t>Hongshuo</a:t>
-            </a:r>
-            <a:r>
-              <a:rPr lang="en-US" sz="2200" dirty="0">
-                <a:latin typeface="Palatino Linotype" panose="02040502050505030304" pitchFamily="18" charset="0"/>
-              </a:rPr>
-              <a:t> Fan (for Music Gesture Recognition)</a:t>
-            </a:r>
-          </a:p>
-          <a:p>
-            <a:pPr lvl="1"/>
-            <a:r>
-              <a:rPr lang="en-US" sz="2200" dirty="0" err="1">
-                <a:latin typeface="Palatino Linotype" panose="02040502050505030304" pitchFamily="18" charset="0"/>
-              </a:rPr>
-              <a:t>Bofan</a:t>
-            </a:r>
-            <a:r>
-              <a:rPr lang="en-US" sz="2200" dirty="0">
-                <a:latin typeface="Palatino Linotype" panose="02040502050505030304" pitchFamily="18" charset="0"/>
-              </a:rPr>
-              <a:t> Ma (for always enabling musicality)</a:t>
-            </a:r>
-          </a:p>
-          <a:p>
-            <a:pPr lvl="1"/>
-            <a:r>
-              <a:rPr lang="en-US" sz="2200" dirty="0">
-                <a:latin typeface="Palatino Linotype" panose="02040502050505030304" pitchFamily="18" charset="0"/>
-              </a:rPr>
-              <a:t>Maria </a:t>
-            </a:r>
-            <a:r>
-              <a:rPr lang="en-US" sz="2200" dirty="0" err="1">
-                <a:latin typeface="Palatino Linotype" panose="02040502050505030304" pitchFamily="18" charset="0"/>
-              </a:rPr>
-              <a:t>Kallionpää</a:t>
-            </a:r>
-            <a:r>
-              <a:rPr lang="en-US" sz="2200" dirty="0">
-                <a:latin typeface="Palatino Linotype" panose="02040502050505030304" pitchFamily="18" charset="0"/>
-              </a:rPr>
-              <a:t> (for Climb!)</a:t>
-            </a:r>
-          </a:p>
-          <a:p>
-            <a:pPr lvl="1"/>
-            <a:r>
-              <a:rPr lang="en-US" sz="2200" dirty="0">
-                <a:latin typeface="Palatino Linotype" panose="02040502050505030304" pitchFamily="18" charset="0"/>
-              </a:rPr>
-              <a:t>Ada Lovelace &amp; Emily Howard (for Numbers into Notes)</a:t>
-            </a:r>
-          </a:p>
-          <a:p>
-            <a:pPr lvl="1"/>
-            <a:r>
-              <a:rPr lang="en-US" sz="2200" dirty="0">
-                <a:latin typeface="Palatino Linotype" panose="02040502050505030304" pitchFamily="18" charset="0"/>
-              </a:rPr>
-              <a:t>Wolfson Digital Research Cluster, </a:t>
-            </a:r>
-            <a:r>
-              <a:rPr lang="en-US" sz="2200" dirty="0" err="1">
-                <a:latin typeface="Palatino Linotype" panose="02040502050505030304" pitchFamily="18" charset="0"/>
-              </a:rPr>
-              <a:t>DiSc</a:t>
-            </a:r>
-            <a:r>
-              <a:rPr lang="en-US" sz="2200" dirty="0">
-                <a:latin typeface="Palatino Linotype" panose="02040502050505030304" pitchFamily="18" charset="0"/>
-              </a:rPr>
-              <a:t> &amp; TORCH (for AIMC 2024)</a:t>
-            </a:r>
-          </a:p>
-          <a:p>
-            <a:pPr lvl="1"/>
-            <a:endParaRPr lang="en-US" dirty="0">
-              <a:latin typeface="Palatino Linotype" panose="02040502050505030304" pitchFamily="18" charset="0"/>
-            </a:endParaRPr>
-          </a:p>
-          <a:p>
-            <a:pPr lvl="0"/>
-            <a:r>
-              <a:rPr lang="en-US" sz="2400" i="1" dirty="0">
-                <a:latin typeface="Palatino Linotype" panose="02040502050505030304" pitchFamily="18" charset="0"/>
-              </a:rPr>
-              <a:t>Grand Challenges for Computing Research</a:t>
-            </a:r>
-            <a:r>
-              <a:rPr lang="en-US" sz="2400" dirty="0">
-                <a:latin typeface="Palatino Linotype" panose="02040502050505030304" pitchFamily="18" charset="0"/>
-              </a:rPr>
-              <a:t> – Tony Hoare</a:t>
-            </a:r>
-          </a:p>
-          <a:p>
-            <a:endParaRPr lang="en-US" sz="2400" dirty="0">
-              <a:latin typeface="Palatino Linotype" panose="02040502050505030304" pitchFamily="18" charset="0"/>
-            </a:endParaRPr>
-          </a:p>
-        </p:txBody>
-      </p:sp>
-      <p:pic>
-        <p:nvPicPr>
-          <p:cNvPr id="14" name="Picture 13" descr="A blue and white logo&#10;&#10;Description automatically generated">
-            <a:extLst>
-              <a:ext uri="{FF2B5EF4-FFF2-40B4-BE49-F238E27FC236}">
-                <a16:creationId xmlns:a16="http://schemas.microsoft.com/office/drawing/2014/main" id="{AE2E2FB4-45D4-955A-DA70-41F10F631EA5}"/>
-              </a:ext>
-            </a:extLst>
-          </p:cNvPr>
-          <p:cNvPicPr>
-            <a:picLocks noChangeAspect="1"/>
-          </p:cNvPicPr>
-          <p:nvPr/>
-        </p:nvPicPr>
-        <p:blipFill>
-          <a:blip r:embed="rId4" cstate="print">
-            <a:extLst>
-              <a:ext uri="{28A0092B-C50C-407E-A947-70E740481C1C}">
-                <a14:useLocalDpi xmlns:a14="http://schemas.microsoft.com/office/drawing/2010/main" val="0"/>
-              </a:ext>
-            </a:extLst>
-          </a:blip>
-          <a:stretch>
-            <a:fillRect/>
-          </a:stretch>
-        </p:blipFill>
-        <p:spPr>
-          <a:xfrm>
-            <a:off x="9792449" y="2074097"/>
-            <a:ext cx="741532" cy="741532"/>
-          </a:xfrm>
-          <a:prstGeom prst="rect">
-            <a:avLst/>
-          </a:prstGeom>
-        </p:spPr>
-      </p:pic>
-      <p:pic>
-        <p:nvPicPr>
-          <p:cNvPr id="16" name="Picture 15" descr="torch logo icon">
-            <a:extLst>
-              <a:ext uri="{FF2B5EF4-FFF2-40B4-BE49-F238E27FC236}">
-                <a16:creationId xmlns:a16="http://schemas.microsoft.com/office/drawing/2014/main" id="{AF5C0374-A45C-8F4F-13B3-71AE93C08BDB}"/>
-              </a:ext>
-            </a:extLst>
-          </p:cNvPr>
-          <p:cNvPicPr>
-            <a:picLocks noChangeAspect="1"/>
-          </p:cNvPicPr>
-          <p:nvPr/>
-        </p:nvPicPr>
-        <p:blipFill>
-          <a:blip r:embed="rId5" cstate="print">
-            <a:extLst>
-              <a:ext uri="{28A0092B-C50C-407E-A947-70E740481C1C}">
-                <a14:useLocalDpi xmlns:a14="http://schemas.microsoft.com/office/drawing/2010/main" val="0"/>
-              </a:ext>
-            </a:extLst>
-          </a:blip>
-          <a:srcRect/>
-          <a:stretch>
-            <a:fillRect/>
-          </a:stretch>
-        </p:blipFill>
-        <p:spPr bwMode="auto">
-          <a:xfrm>
-            <a:off x="10580223" y="2077414"/>
-            <a:ext cx="737827" cy="737827"/>
-          </a:xfrm>
-          <a:prstGeom prst="rect">
-            <a:avLst/>
-          </a:prstGeom>
-          <a:noFill/>
-          <a:ln>
-            <a:noFill/>
-          </a:ln>
-        </p:spPr>
-      </p:pic>
-      <p:pic>
-        <p:nvPicPr>
-          <p:cNvPr id="17" name="Picture 16" descr="performance research logo black">
-            <a:extLst>
-              <a:ext uri="{FF2B5EF4-FFF2-40B4-BE49-F238E27FC236}">
-                <a16:creationId xmlns:a16="http://schemas.microsoft.com/office/drawing/2014/main" id="{4898947E-1E9F-6C26-EC1A-DCA7850E59F7}"/>
-              </a:ext>
-            </a:extLst>
-          </p:cNvPr>
-          <p:cNvPicPr>
-            <a:picLocks noChangeAspect="1"/>
-          </p:cNvPicPr>
-          <p:nvPr/>
-        </p:nvPicPr>
-        <p:blipFill>
-          <a:blip r:embed="rId6">
-            <a:extLst>
-              <a:ext uri="{28A0092B-C50C-407E-A947-70E740481C1C}">
-                <a14:useLocalDpi xmlns:a14="http://schemas.microsoft.com/office/drawing/2010/main" val="0"/>
-              </a:ext>
-            </a:extLst>
-          </a:blip>
-          <a:srcRect/>
-          <a:stretch>
-            <a:fillRect/>
-          </a:stretch>
-        </p:blipFill>
-        <p:spPr bwMode="auto">
-          <a:xfrm>
-            <a:off x="9782407" y="3916247"/>
-            <a:ext cx="1578927" cy="892113"/>
-          </a:xfrm>
-          <a:prstGeom prst="rect">
-            <a:avLst/>
-          </a:prstGeom>
-          <a:noFill/>
-          <a:ln>
-            <a:noFill/>
-          </a:ln>
-        </p:spPr>
-      </p:pic>
-      <p:pic>
-        <p:nvPicPr>
-          <p:cNvPr id="18" name="Picture 17" descr="A green and white logo&#10;&#10;Description automatically generated">
-            <a:extLst>
-              <a:ext uri="{FF2B5EF4-FFF2-40B4-BE49-F238E27FC236}">
-                <a16:creationId xmlns:a16="http://schemas.microsoft.com/office/drawing/2014/main" id="{E44206BB-E239-0EB4-52D5-DB5A84D1386C}"/>
-              </a:ext>
-            </a:extLst>
-          </p:cNvPr>
-          <p:cNvPicPr>
-            <a:picLocks noChangeAspect="1"/>
-          </p:cNvPicPr>
-          <p:nvPr/>
-        </p:nvPicPr>
-        <p:blipFill>
-          <a:blip r:embed="rId7" cstate="print">
-            <a:extLst>
-              <a:ext uri="{28A0092B-C50C-407E-A947-70E740481C1C}">
-                <a14:useLocalDpi xmlns:a14="http://schemas.microsoft.com/office/drawing/2010/main" val="0"/>
-              </a:ext>
-            </a:extLst>
-          </a:blip>
-          <a:stretch>
-            <a:fillRect/>
-          </a:stretch>
-        </p:blipFill>
-        <p:spPr>
-          <a:xfrm>
-            <a:off x="9782407" y="2994854"/>
-            <a:ext cx="1535643" cy="779824"/>
-          </a:xfrm>
-          <a:prstGeom prst="rect">
-            <a:avLst/>
-          </a:prstGeom>
-        </p:spPr>
-      </p:pic>
-      <p:pic>
-        <p:nvPicPr>
-          <p:cNvPr id="19" name="Picture 2" descr="PRiSM logo with text">
-            <a:extLst>
-              <a:ext uri="{FF2B5EF4-FFF2-40B4-BE49-F238E27FC236}">
-                <a16:creationId xmlns:a16="http://schemas.microsoft.com/office/drawing/2014/main" id="{F097A706-7944-CDD7-69C4-1D5CA675F226}"/>
-              </a:ext>
-            </a:extLst>
-          </p:cNvPr>
-          <p:cNvPicPr>
-            <a:picLocks noChangeAspect="1" noChangeArrowheads="1"/>
-          </p:cNvPicPr>
-          <p:nvPr/>
-        </p:nvPicPr>
-        <p:blipFill>
-          <a:blip r:embed="rId8">
-            <a:extLst>
-              <a:ext uri="{28A0092B-C50C-407E-A947-70E740481C1C}">
-                <a14:useLocalDpi xmlns:a14="http://schemas.microsoft.com/office/drawing/2010/main" val="0"/>
-              </a:ext>
-            </a:extLst>
-          </a:blip>
-          <a:srcRect/>
-          <a:stretch>
-            <a:fillRect/>
-          </a:stretch>
-        </p:blipFill>
-        <p:spPr bwMode="auto">
-          <a:xfrm>
-            <a:off x="9418320" y="722397"/>
-            <a:ext cx="2079898" cy="892113"/>
-          </a:xfrm>
-          <a:prstGeom prst="rect">
-            <a:avLst/>
-          </a:prstGeom>
-          <a:noFill/>
-          <a:extLst>
-            <a:ext uri="{909E8E84-426E-40DD-AFC4-6F175D3DCCD1}">
-              <a14:hiddenFill xmlns:a14="http://schemas.microsoft.com/office/drawing/2010/main">
-                <a:solidFill>
-                  <a:srgbClr val="FFFFFF"/>
-                </a:solidFill>
-              </a14:hiddenFill>
-            </a:ext>
-          </a:extLst>
-        </p:spPr>
-      </p:pic>
-      <p:pic>
-        <p:nvPicPr>
-          <p:cNvPr id="2" name="Picture 1" descr="Home - Wolfson College">
-            <a:extLst>
-              <a:ext uri="{FF2B5EF4-FFF2-40B4-BE49-F238E27FC236}">
-                <a16:creationId xmlns:a16="http://schemas.microsoft.com/office/drawing/2014/main" id="{E16D70A7-BF5F-F8A7-82FF-A057B33F09FA}"/>
-              </a:ext>
-            </a:extLst>
-          </p:cNvPr>
-          <p:cNvPicPr>
-            <a:picLocks noChangeAspect="1"/>
-          </p:cNvPicPr>
-          <p:nvPr/>
-        </p:nvPicPr>
-        <p:blipFill>
-          <a:blip r:embed="rId9" cstate="print">
-            <a:extLst>
-              <a:ext uri="{28A0092B-C50C-407E-A947-70E740481C1C}">
-                <a14:useLocalDpi xmlns:a14="http://schemas.microsoft.com/office/drawing/2010/main" val="0"/>
-              </a:ext>
-            </a:extLst>
-          </a:blip>
-          <a:srcRect/>
-          <a:stretch>
-            <a:fillRect/>
-          </a:stretch>
-        </p:blipFill>
-        <p:spPr bwMode="auto">
-          <a:xfrm>
-            <a:off x="9699587" y="4982989"/>
-            <a:ext cx="1668788" cy="1668788"/>
-          </a:xfrm>
-          <a:prstGeom prst="rect">
-            <a:avLst/>
-          </a:prstGeom>
-          <a:noFill/>
-        </p:spPr>
-      </p:pic>
-    </p:spTree>
-    <p:extLst>
-      <p:ext uri="{BB962C8B-B14F-4D97-AF65-F5344CB8AC3E}">
-        <p14:creationId xmlns:p14="http://schemas.microsoft.com/office/powerpoint/2010/main" val="2653788343"/>
       </p:ext>
     </p:extLst>
   </p:cSld>

</xml_diff>

<commit_message>
Update presentation slides (wolfson.pdf / wolfson.pptx)
Co-Authored-By: Claude Sonnet 4.6 <noreply@anthropic.com>
</commit_message>
<xml_diff>
--- a/docs/wolfson.pptx
+++ b/docs/wolfson.pptx
@@ -7060,12 +7060,14 @@
             </a:r>
           </a:p>
           <a:p>
-            <a:pPr marL="180000" indent="-457200"/>
+            <a:pPr marL="144000" indent="-457200">
+              <a:buNone/>
+            </a:pPr>
             <a:r>
               <a:rPr lang="en-GB" sz="2200" dirty="0">
                 <a:latin typeface="Palatino Linotype" panose="02040502050505030304" pitchFamily="18" charset="0"/>
               </a:rPr>
-              <a:t>The title works on three levels: the </a:t>
+              <a:t>* The title works on three levels: the </a:t>
             </a:r>
             <a:r>
               <a:rPr lang="en-GB" sz="2200" i="1" dirty="0">
@@ -7157,7 +7159,7 @@
         </p:nvSpPr>
         <p:spPr>
           <a:xfrm>
-            <a:off x="838200" y="365125"/>
+            <a:off x="638504" y="278160"/>
             <a:ext cx="10515600" cy="805753"/>
           </a:xfrm>
         </p:spPr>
@@ -7284,7 +7286,7 @@
               <a:rPr lang="en-GB" sz="2300" dirty="0">
                 <a:latin typeface="Palatino Linotype" panose="02040502050505030304" pitchFamily="18" charset="0"/>
               </a:rPr>
-              <a:t>Leadership &amp; role swapping</a:t>
+              <a:t>Leadership &amp; role</a:t>
             </a:r>
           </a:p>
           <a:p>
@@ -7401,6 +7403,17 @@
               </a:rPr>
               <a:t>Dynamics</a:t>
             </a:r>
+            <a:br>
+              <a:rPr lang="en-GB" sz="2300" dirty="0">
+                <a:latin typeface="Palatino Linotype" panose="02040502050505030304" pitchFamily="18" charset="0"/>
+              </a:rPr>
+            </a:br>
+            <a:r>
+              <a:rPr lang="en-GB" sz="2300" dirty="0">
+                <a:latin typeface="Palatino Linotype" panose="02040502050505030304" pitchFamily="18" charset="0"/>
+              </a:rPr>
+              <a:t>Generation temperature</a:t>
+            </a:r>
           </a:p>
         </p:txBody>
       </p:sp>
@@ -7418,8 +7431,8 @@
         </p:nvSpPr>
         <p:spPr>
           <a:xfrm>
-            <a:off x="3972107" y="1267779"/>
-            <a:ext cx="3954966" cy="4950073"/>
+            <a:off x="4088523" y="1267779"/>
+            <a:ext cx="3838549" cy="4950073"/>
           </a:xfrm>
           <a:prstGeom prst="rect">
             <a:avLst/>
@@ -7441,17 +7454,6 @@
               <a:rPr lang="en-GB" sz="2300" dirty="0">
                 <a:latin typeface="Palatino Linotype" panose="02040502050505030304" pitchFamily="18" charset="0"/>
               </a:rPr>
-              <a:t>Generation temperature</a:t>
-            </a:r>
-            <a:br>
-              <a:rPr lang="en-GB" sz="2300" dirty="0">
-                <a:latin typeface="Palatino Linotype" panose="02040502050505030304" pitchFamily="18" charset="0"/>
-              </a:rPr>
-            </a:br>
-            <a:r>
-              <a:rPr lang="en-GB" sz="2300" dirty="0">
-                <a:latin typeface="Palatino Linotype" panose="02040502050505030304" pitchFamily="18" charset="0"/>
-              </a:rPr>
               <a:t>Phrase-shape dynamics</a:t>
             </a:r>
           </a:p>
@@ -7479,6 +7481,17 @@
                 <a:latin typeface="Palatino Linotype" panose="02040502050505030304" pitchFamily="18" charset="0"/>
               </a:rPr>
               <a:t>Bass pitch-class tracking</a:t>
+            </a:r>
+            <a:br>
+              <a:rPr lang="en-GB" sz="2300" dirty="0">
+                <a:latin typeface="Palatino Linotype" panose="02040502050505030304" pitchFamily="18" charset="0"/>
+              </a:rPr>
+            </a:br>
+            <a:r>
+              <a:rPr lang="en-GB" sz="2300" dirty="0">
+                <a:latin typeface="Palatino Linotype" panose="02040502050505030304" pitchFamily="18" charset="0"/>
+              </a:rPr>
+              <a:t>Scale mode detection </a:t>
             </a:r>
           </a:p>
           <a:p>
@@ -7939,7 +7952,7 @@
               <a:rPr lang="en-GB" sz="2400" b="1" dirty="0">
                 <a:latin typeface="Palatino Linotype" panose="02040502050505030304" pitchFamily="18" charset="0"/>
               </a:rPr>
-              <a:t>The five giant steps in the arc…</a:t>
+              <a:t>The five giant steps in the performance arc…</a:t>
             </a:r>
             <a:br>
               <a:rPr lang="en-GB" sz="2400" b="1" dirty="0">
@@ -8922,7 +8935,7 @@
         </p:nvSpPr>
         <p:spPr>
           <a:xfrm>
-            <a:off x="9424410" y="4424864"/>
+            <a:off x="9163227" y="404794"/>
             <a:ext cx="2264263" cy="1662546"/>
           </a:xfrm>
           <a:prstGeom prst="rect">
@@ -8964,7 +8977,7 @@
         </p:nvSpPr>
         <p:spPr>
           <a:xfrm>
-            <a:off x="365760" y="761879"/>
+            <a:off x="365760" y="467591"/>
             <a:ext cx="1889760" cy="755904"/>
           </a:xfrm>
           <a:prstGeom prst="roundRect">
@@ -9004,7 +9017,7 @@
         </p:nvSpPr>
         <p:spPr>
           <a:xfrm>
-            <a:off x="365760" y="761879"/>
+            <a:off x="365760" y="467591"/>
             <a:ext cx="1889760" cy="667900"/>
           </a:xfrm>
           <a:prstGeom prst="rect">
@@ -9067,7 +9080,7 @@
         </p:nvSpPr>
         <p:spPr>
           <a:xfrm>
-            <a:off x="2865125" y="761878"/>
+            <a:off x="2865125" y="467590"/>
             <a:ext cx="1889760" cy="842091"/>
           </a:xfrm>
           <a:prstGeom prst="roundRect">
@@ -9107,7 +9120,7 @@
         </p:nvSpPr>
         <p:spPr>
           <a:xfrm>
-            <a:off x="2865125" y="761879"/>
+            <a:off x="2865125" y="467591"/>
             <a:ext cx="1889760" cy="585216"/>
           </a:xfrm>
           <a:prstGeom prst="rect">
@@ -9149,8 +9162,259 @@
         </p:nvSpPr>
         <p:spPr>
           <a:xfrm>
-            <a:off x="5521530" y="761879"/>
+            <a:off x="5521530" y="467591"/>
             <a:ext cx="2291561" cy="1426629"/>
+          </a:xfrm>
+          <a:prstGeom prst="roundRect">
+            <a:avLst>
+              <a:gd name="adj" fmla="val 16667"/>
+            </a:avLst>
+          </a:prstGeom>
+          <a:solidFill>
+            <a:schemeClr val="accent6">
+              <a:lumMod val="50000"/>
+            </a:schemeClr>
+          </a:solidFill>
+          <a:ln w="19050">
+            <a:solidFill>
+              <a:srgbClr val="CADCFC"/>
+            </a:solidFill>
+            <a:prstDash val="solid"/>
+          </a:ln>
+        </p:spPr>
+        <p:txBody>
+          <a:bodyPr/>
+          <a:lstStyle/>
+          <a:p>
+            <a:pPr defTabSz="1219170"/>
+            <a:endParaRPr lang="en-US" sz="2400">
+              <a:solidFill>
+                <a:prstClr val="black"/>
+              </a:solidFill>
+              <a:latin typeface="Calibri" panose="020F0502020204030204"/>
+            </a:endParaRPr>
+          </a:p>
+        </p:txBody>
+      </p:sp>
+      <p:sp>
+        <p:nvSpPr>
+          <p:cNvPr id="9" name="Text 7"/>
+          <p:cNvSpPr/>
+          <p:nvPr/>
+        </p:nvSpPr>
+        <p:spPr>
+          <a:xfrm>
+            <a:off x="5582490" y="467591"/>
+            <a:ext cx="2197479" cy="583084"/>
+          </a:xfrm>
+          <a:prstGeom prst="rect">
+            <a:avLst/>
+          </a:prstGeom>
+          <a:noFill/>
+          <a:ln/>
+        </p:spPr>
+        <p:txBody>
+          <a:bodyPr wrap="square" lIns="67733" tIns="67733" rIns="67733" bIns="67733" rtlCol="0" anchor="ctr"/>
+          <a:lstStyle/>
+          <a:p>
+            <a:pPr algn="ctr" defTabSz="1219170"/>
+            <a:r>
+              <a:rPr lang="en-US" sz="2400" b="1" dirty="0" err="1">
+                <a:solidFill>
+                  <a:srgbClr val="FFFFFF"/>
+                </a:solidFill>
+                <a:latin typeface="Calibri" pitchFamily="34" charset="0"/>
+                <a:ea typeface="Calibri" pitchFamily="34" charset="-122"/>
+                <a:cs typeface="Calibri" pitchFamily="34" charset="-120"/>
+              </a:rPr>
+              <a:t>PhraseDetector</a:t>
+            </a:r>
+            <a:endParaRPr lang="en-US" sz="2400" dirty="0">
+              <a:solidFill>
+                <a:prstClr val="black"/>
+              </a:solidFill>
+              <a:latin typeface="Calibri" panose="020F0502020204030204"/>
+            </a:endParaRPr>
+          </a:p>
+        </p:txBody>
+      </p:sp>
+      <p:sp>
+        <p:nvSpPr>
+          <p:cNvPr id="10" name="Shape 8"/>
+          <p:cNvSpPr/>
+          <p:nvPr/>
+        </p:nvSpPr>
+        <p:spPr>
+          <a:xfrm>
+            <a:off x="5209223" y="2380112"/>
+            <a:ext cx="3066918" cy="1671258"/>
+          </a:xfrm>
+          <a:prstGeom prst="roundRect">
+            <a:avLst>
+              <a:gd name="adj" fmla="val 5333"/>
+            </a:avLst>
+          </a:prstGeom>
+          <a:solidFill>
+            <a:schemeClr val="accent6">
+              <a:lumMod val="50000"/>
+            </a:schemeClr>
+          </a:solidFill>
+          <a:ln w="25400">
+            <a:solidFill>
+              <a:srgbClr val="CADCFC"/>
+            </a:solidFill>
+            <a:prstDash val="solid"/>
+          </a:ln>
+        </p:spPr>
+        <p:txBody>
+          <a:bodyPr/>
+          <a:lstStyle/>
+          <a:p>
+            <a:pPr defTabSz="1219170"/>
+            <a:endParaRPr lang="en-US" sz="2400">
+              <a:solidFill>
+                <a:prstClr val="black"/>
+              </a:solidFill>
+              <a:latin typeface="Calibri" panose="020F0502020204030204"/>
+            </a:endParaRPr>
+          </a:p>
+        </p:txBody>
+      </p:sp>
+      <p:sp>
+        <p:nvSpPr>
+          <p:cNvPr id="11" name="Text 9"/>
+          <p:cNvSpPr/>
+          <p:nvPr/>
+        </p:nvSpPr>
+        <p:spPr>
+          <a:xfrm>
+            <a:off x="5270183" y="2380111"/>
+            <a:ext cx="2957385" cy="537237"/>
+          </a:xfrm>
+          <a:prstGeom prst="rect">
+            <a:avLst/>
+          </a:prstGeom>
+          <a:noFill/>
+          <a:ln/>
+        </p:spPr>
+        <p:txBody>
+          <a:bodyPr wrap="square" lIns="0" tIns="0" rIns="0" bIns="0" rtlCol="0" anchor="ctr"/>
+          <a:lstStyle/>
+          <a:p>
+            <a:pPr algn="ctr" defTabSz="1219170"/>
+            <a:r>
+              <a:rPr lang="en-US" sz="2400" b="1" dirty="0">
+                <a:solidFill>
+                  <a:srgbClr val="FFFFFF"/>
+                </a:solidFill>
+                <a:latin typeface="Calibri" pitchFamily="34" charset="0"/>
+                <a:ea typeface="Calibri" pitchFamily="34" charset="-122"/>
+                <a:cs typeface="Calibri" pitchFamily="34" charset="-120"/>
+              </a:rPr>
+              <a:t>PhraseAnalyzer</a:t>
+            </a:r>
+            <a:endParaRPr lang="en-US" sz="2400" dirty="0">
+              <a:solidFill>
+                <a:prstClr val="black"/>
+              </a:solidFill>
+              <a:latin typeface="Calibri" panose="020F0502020204030204"/>
+            </a:endParaRPr>
+          </a:p>
+        </p:txBody>
+      </p:sp>
+      <p:sp>
+        <p:nvSpPr>
+          <p:cNvPr id="12" name="Text 10"/>
+          <p:cNvSpPr/>
+          <p:nvPr/>
+        </p:nvSpPr>
+        <p:spPr>
+          <a:xfrm>
+            <a:off x="5343759" y="2915185"/>
+            <a:ext cx="2881918" cy="1134021"/>
+          </a:xfrm>
+          <a:prstGeom prst="rect">
+            <a:avLst/>
+          </a:prstGeom>
+          <a:noFill/>
+          <a:ln/>
+        </p:spPr>
+        <p:txBody>
+          <a:bodyPr wrap="square" lIns="33867" tIns="33867" rIns="33867" bIns="33867" rtlCol="0" anchor="t"/>
+          <a:lstStyle/>
+          <a:p>
+            <a:pPr defTabSz="1219170"/>
+            <a:r>
+              <a:rPr lang="en-US" sz="1600" dirty="0">
+                <a:solidFill>
+                  <a:srgbClr val="CADCFC"/>
+                </a:solidFill>
+                <a:latin typeface="Calibri" pitchFamily="34" charset="0"/>
+                <a:ea typeface="Calibri" pitchFamily="34" charset="-122"/>
+                <a:cs typeface="Calibri" pitchFamily="34" charset="-120"/>
+              </a:rPr>
+              <a:t>contour · density · Q&amp;A type · </a:t>
+            </a:r>
+            <a:br>
+              <a:rPr lang="en-US" sz="1600" dirty="0">
+                <a:solidFill>
+                  <a:srgbClr val="CADCFC"/>
+                </a:solidFill>
+                <a:latin typeface="Calibri" pitchFamily="34" charset="0"/>
+                <a:ea typeface="Calibri" pitchFamily="34" charset="-122"/>
+                <a:cs typeface="Calibri" pitchFamily="34" charset="-120"/>
+              </a:rPr>
+            </a:br>
+            <a:r>
+              <a:rPr lang="en-US" sz="1600" dirty="0">
+                <a:solidFill>
+                  <a:srgbClr val="CADCFC"/>
+                </a:solidFill>
+                <a:latin typeface="Calibri" pitchFamily="34" charset="0"/>
+                <a:ea typeface="Calibri" pitchFamily="34" charset="-122"/>
+                <a:cs typeface="Calibri" pitchFamily="34" charset="-120"/>
+              </a:rPr>
+              <a:t>swing · dynamics · energy profile · </a:t>
+            </a:r>
+            <a:endParaRPr lang="en-US" sz="1600" dirty="0">
+              <a:solidFill>
+                <a:prstClr val="black"/>
+              </a:solidFill>
+              <a:latin typeface="Calibri" panose="020F0502020204030204"/>
+            </a:endParaRPr>
+          </a:p>
+          <a:p>
+            <a:pPr defTabSz="1219170"/>
+            <a:r>
+              <a:rPr lang="en-US" sz="1600" dirty="0">
+                <a:solidFill>
+                  <a:srgbClr val="CADCFC"/>
+                </a:solidFill>
+                <a:latin typeface="Calibri" pitchFamily="34" charset="0"/>
+                <a:ea typeface="Calibri" pitchFamily="34" charset="-122"/>
+                <a:cs typeface="Calibri" pitchFamily="34" charset="-120"/>
+              </a:rPr>
+              <a:t>pitch classes · interval motifs ·  lyrical motifs</a:t>
+            </a:r>
+            <a:endParaRPr lang="en-US" sz="1600" dirty="0">
+              <a:solidFill>
+                <a:prstClr val="black"/>
+              </a:solidFill>
+              <a:latin typeface="Calibri" panose="020F0502020204030204"/>
+            </a:endParaRPr>
+          </a:p>
+        </p:txBody>
+      </p:sp>
+      <p:sp>
+        <p:nvSpPr>
+          <p:cNvPr id="16" name="Shape 14"/>
+          <p:cNvSpPr/>
+          <p:nvPr/>
+        </p:nvSpPr>
+        <p:spPr>
+          <a:xfrm>
+            <a:off x="2635604" y="1858097"/>
+            <a:ext cx="2292087" cy="781702"/>
           </a:xfrm>
           <a:prstGeom prst="roundRect">
             <a:avLst>
@@ -9172,48 +9436,6 @@
           <a:lstStyle/>
           <a:p>
             <a:pPr defTabSz="1219170"/>
-            <a:endParaRPr lang="en-US" sz="2400">
-              <a:solidFill>
-                <a:prstClr val="black"/>
-              </a:solidFill>
-              <a:latin typeface="Calibri" panose="020F0502020204030204"/>
-            </a:endParaRPr>
-          </a:p>
-        </p:txBody>
-      </p:sp>
-      <p:sp>
-        <p:nvSpPr>
-          <p:cNvPr id="9" name="Text 7"/>
-          <p:cNvSpPr/>
-          <p:nvPr/>
-        </p:nvSpPr>
-        <p:spPr>
-          <a:xfrm>
-            <a:off x="5582490" y="761879"/>
-            <a:ext cx="2197479" cy="583084"/>
-          </a:xfrm>
-          <a:prstGeom prst="rect">
-            <a:avLst/>
-          </a:prstGeom>
-          <a:noFill/>
-          <a:ln/>
-        </p:spPr>
-        <p:txBody>
-          <a:bodyPr wrap="square" lIns="67733" tIns="67733" rIns="67733" bIns="67733" rtlCol="0" anchor="ctr"/>
-          <a:lstStyle/>
-          <a:p>
-            <a:pPr algn="ctr" defTabSz="1219170"/>
-            <a:r>
-              <a:rPr lang="en-US" sz="2400" b="1" dirty="0" err="1">
-                <a:solidFill>
-                  <a:srgbClr val="FFFFFF"/>
-                </a:solidFill>
-                <a:latin typeface="Calibri" pitchFamily="34" charset="0"/>
-                <a:ea typeface="Calibri" pitchFamily="34" charset="-122"/>
-                <a:cs typeface="Calibri" pitchFamily="34" charset="-120"/>
-              </a:rPr>
-              <a:t>PhraseDetector</a:t>
-            </a:r>
             <a:endParaRPr lang="en-US" sz="2400" dirty="0">
               <a:solidFill>
                 <a:prstClr val="black"/>
@@ -9225,54 +9447,14 @@
       </p:sp>
       <p:sp>
         <p:nvSpPr>
-          <p:cNvPr id="10" name="Shape 8"/>
+          <p:cNvPr id="17" name="Text 15"/>
           <p:cNvSpPr/>
           <p:nvPr/>
         </p:nvSpPr>
         <p:spPr>
           <a:xfrm>
-            <a:off x="8515479" y="761879"/>
-            <a:ext cx="3066918" cy="1671258"/>
-          </a:xfrm>
-          <a:prstGeom prst="roundRect">
-            <a:avLst>
-              <a:gd name="adj" fmla="val 5333"/>
-            </a:avLst>
-          </a:prstGeom>
-          <a:solidFill>
-            <a:srgbClr val="253880"/>
-          </a:solidFill>
-          <a:ln w="25400">
-            <a:solidFill>
-              <a:srgbClr val="CADCFC"/>
-            </a:solidFill>
-            <a:prstDash val="solid"/>
-          </a:ln>
-        </p:spPr>
-        <p:txBody>
-          <a:bodyPr/>
-          <a:lstStyle/>
-          <a:p>
-            <a:pPr defTabSz="1219170"/>
-            <a:endParaRPr lang="en-US" sz="2400">
-              <a:solidFill>
-                <a:prstClr val="black"/>
-              </a:solidFill>
-              <a:latin typeface="Calibri" panose="020F0502020204030204"/>
-            </a:endParaRPr>
-          </a:p>
-        </p:txBody>
-      </p:sp>
-      <p:sp>
-        <p:nvSpPr>
-          <p:cNvPr id="11" name="Text 9"/>
-          <p:cNvSpPr/>
-          <p:nvPr/>
-        </p:nvSpPr>
-        <p:spPr>
-          <a:xfrm>
-            <a:off x="8576439" y="761878"/>
-            <a:ext cx="2957385" cy="537237"/>
+            <a:off x="2635602" y="1939632"/>
+            <a:ext cx="2292087" cy="353568"/>
           </a:xfrm>
           <a:prstGeom prst="rect">
             <a:avLst/>
@@ -9294,7 +9476,7 @@
                 <a:ea typeface="Calibri" pitchFamily="34" charset="-122"/>
                 <a:cs typeface="Calibri" pitchFamily="34" charset="-120"/>
               </a:rPr>
-              <a:t>PhraseAnalyzer</a:t>
+              <a:t>BeatEstimator</a:t>
             </a:r>
             <a:endParaRPr lang="en-US" sz="2400" dirty="0">
               <a:solidFill>
@@ -9307,14 +9489,14 @@
       </p:sp>
       <p:sp>
         <p:nvSpPr>
-          <p:cNvPr id="12" name="Text 10"/>
+          <p:cNvPr id="18" name="Text 16"/>
           <p:cNvSpPr/>
           <p:nvPr/>
         </p:nvSpPr>
         <p:spPr>
           <a:xfrm>
-            <a:off x="8650015" y="1296952"/>
-            <a:ext cx="2881918" cy="1134021"/>
+            <a:off x="2868425" y="2254592"/>
+            <a:ext cx="2059268" cy="293138"/>
           </a:xfrm>
           <a:prstGeom prst="rect">
             <a:avLst/>
@@ -9336,28 +9518,7 @@
                 <a:ea typeface="Calibri" pitchFamily="34" charset="-122"/>
                 <a:cs typeface="Calibri" pitchFamily="34" charset="-120"/>
               </a:rPr>
-              <a:t>contour · density · Q&amp;A type · </a:t>
-            </a:r>
-            <a:br>
-              <a:rPr lang="en-US" sz="1600" dirty="0">
-                <a:solidFill>
-                  <a:srgbClr val="CADCFC"/>
-                </a:solidFill>
-                <a:latin typeface="Calibri" pitchFamily="34" charset="0"/>
-                <a:ea typeface="Calibri" pitchFamily="34" charset="-122"/>
-                <a:cs typeface="Calibri" pitchFamily="34" charset="-120"/>
-              </a:rPr>
-            </a:br>
-            <a:r>
-              <a:rPr lang="en-US" sz="1600" dirty="0">
-                <a:solidFill>
-                  <a:srgbClr val="CADCFC"/>
-                </a:solidFill>
-                <a:latin typeface="Calibri" pitchFamily="34" charset="0"/>
-                <a:ea typeface="Calibri" pitchFamily="34" charset="-122"/>
-                <a:cs typeface="Calibri" pitchFamily="34" charset="-120"/>
-              </a:rPr>
-              <a:t>swing · dynamics · energy profile · </a:t>
+              <a:t>live tempo · beat sync</a:t>
             </a:r>
             <a:endParaRPr lang="en-US" sz="1600" dirty="0">
               <a:solidFill>
@@ -9366,38 +9527,18 @@
               <a:latin typeface="Calibri" panose="020F0502020204030204"/>
             </a:endParaRPr>
           </a:p>
-          <a:p>
-            <a:pPr defTabSz="1219170"/>
-            <a:r>
-              <a:rPr lang="en-US" sz="1600" dirty="0">
-                <a:solidFill>
-                  <a:srgbClr val="CADCFC"/>
-                </a:solidFill>
-                <a:latin typeface="Calibri" pitchFamily="34" charset="0"/>
-                <a:ea typeface="Calibri" pitchFamily="34" charset="-122"/>
-                <a:cs typeface="Calibri" pitchFamily="34" charset="-120"/>
-              </a:rPr>
-              <a:t>pitch classes · interval motifs ·  lyrical motifs</a:t>
-            </a:r>
-            <a:endParaRPr lang="en-US" sz="1600" dirty="0">
-              <a:solidFill>
-                <a:prstClr val="black"/>
-              </a:solidFill>
-              <a:latin typeface="Calibri" panose="020F0502020204030204"/>
-            </a:endParaRPr>
-          </a:p>
-        </p:txBody>
-      </p:sp>
-      <p:sp>
-        <p:nvSpPr>
-          <p:cNvPr id="15" name="Shape 13"/>
+        </p:txBody>
+      </p:sp>
+      <p:sp>
+        <p:nvSpPr>
+          <p:cNvPr id="19" name="Shape 17"/>
           <p:cNvSpPr/>
           <p:nvPr/>
         </p:nvSpPr>
         <p:spPr>
           <a:xfrm>
-            <a:off x="7910628" y="1139298"/>
-            <a:ext cx="497224" cy="1"/>
+            <a:off x="3802643" y="1391665"/>
+            <a:ext cx="0" cy="353568"/>
           </a:xfrm>
           <a:prstGeom prst="line">
             <a:avLst/>
@@ -9427,13 +9568,560 @@
       </p:sp>
       <p:sp>
         <p:nvSpPr>
-          <p:cNvPr id="16" name="Shape 14"/>
+          <p:cNvPr id="20" name="Shape 18"/>
           <p:cNvSpPr/>
           <p:nvPr/>
         </p:nvSpPr>
         <p:spPr>
           <a:xfrm>
-            <a:off x="1932319" y="2153045"/>
+            <a:off x="9028510" y="2572083"/>
+            <a:ext cx="2585421" cy="1287592"/>
+          </a:xfrm>
+          <a:prstGeom prst="roundRect">
+            <a:avLst>
+              <a:gd name="adj" fmla="val 8421"/>
+            </a:avLst>
+          </a:prstGeom>
+          <a:solidFill>
+            <a:srgbClr val="162050"/>
+          </a:solidFill>
+          <a:ln w="19050">
+            <a:solidFill>
+              <a:srgbClr val="CADCFC"/>
+            </a:solidFill>
+            <a:prstDash val="solid"/>
+          </a:ln>
+        </p:spPr>
+        <p:txBody>
+          <a:bodyPr/>
+          <a:lstStyle/>
+          <a:p>
+            <a:pPr defTabSz="1219170"/>
+            <a:endParaRPr lang="en-US" sz="2400">
+              <a:solidFill>
+                <a:prstClr val="black"/>
+              </a:solidFill>
+              <a:latin typeface="Calibri" panose="020F0502020204030204"/>
+            </a:endParaRPr>
+          </a:p>
+        </p:txBody>
+      </p:sp>
+      <p:sp>
+        <p:nvSpPr>
+          <p:cNvPr id="21" name="Text 19"/>
+          <p:cNvSpPr/>
+          <p:nvPr/>
+        </p:nvSpPr>
+        <p:spPr>
+          <a:xfrm>
+            <a:off x="9089470" y="2659030"/>
+            <a:ext cx="2489665" cy="316992"/>
+          </a:xfrm>
+          <a:prstGeom prst="rect">
+            <a:avLst/>
+          </a:prstGeom>
+          <a:noFill/>
+          <a:ln/>
+        </p:spPr>
+        <p:txBody>
+          <a:bodyPr wrap="square" lIns="0" tIns="0" rIns="0" bIns="0" rtlCol="0" anchor="ctr"/>
+          <a:lstStyle/>
+          <a:p>
+            <a:pPr algn="ctr" defTabSz="1219170"/>
+            <a:r>
+              <a:rPr lang="en-US" sz="2400" b="1" dirty="0">
+                <a:solidFill>
+                  <a:srgbClr val="FFFFFF"/>
+                </a:solidFill>
+                <a:latin typeface="Calibri" pitchFamily="34" charset="0"/>
+                <a:ea typeface="Calibri" pitchFamily="34" charset="-122"/>
+                <a:cs typeface="Calibri" pitchFamily="34" charset="-120"/>
+              </a:rPr>
+              <a:t>PhraseMemory</a:t>
+            </a:r>
+            <a:endParaRPr lang="en-US" sz="2400" dirty="0">
+              <a:solidFill>
+                <a:prstClr val="black"/>
+              </a:solidFill>
+              <a:latin typeface="Calibri" panose="020F0502020204030204"/>
+            </a:endParaRPr>
+          </a:p>
+        </p:txBody>
+      </p:sp>
+      <p:sp>
+        <p:nvSpPr>
+          <p:cNvPr id="22" name="Text 20"/>
+          <p:cNvSpPr/>
+          <p:nvPr/>
+        </p:nvSpPr>
+        <p:spPr>
+          <a:xfrm>
+            <a:off x="9290638" y="3004132"/>
+            <a:ext cx="2136852" cy="792480"/>
+          </a:xfrm>
+          <a:prstGeom prst="rect">
+            <a:avLst/>
+          </a:prstGeom>
+          <a:noFill/>
+          <a:ln/>
+        </p:spPr>
+        <p:txBody>
+          <a:bodyPr wrap="square" lIns="33867" tIns="33867" rIns="33867" bIns="33867" rtlCol="0" anchor="t"/>
+          <a:lstStyle/>
+          <a:p>
+            <a:pPr defTabSz="1219170"/>
+            <a:r>
+              <a:rPr lang="en-US" sz="1600" dirty="0">
+                <a:solidFill>
+                  <a:srgbClr val="CADCFC"/>
+                </a:solidFill>
+                <a:latin typeface="Calibri" pitchFamily="34" charset="0"/>
+                <a:ea typeface="Calibri" pitchFamily="34" charset="-122"/>
+                <a:cs typeface="Calibri" pitchFamily="34" charset="-120"/>
+              </a:rPr>
+              <a:t>stores phrases + motifs · </a:t>
+            </a:r>
+            <a:endParaRPr lang="en-US" sz="1600" dirty="0">
+              <a:solidFill>
+                <a:prstClr val="black"/>
+              </a:solidFill>
+              <a:latin typeface="Calibri" panose="020F0502020204030204"/>
+            </a:endParaRPr>
+          </a:p>
+          <a:p>
+            <a:pPr defTabSz="1219170"/>
+            <a:r>
+              <a:rPr lang="en-US" sz="1600" dirty="0">
+                <a:solidFill>
+                  <a:srgbClr val="CADCFC"/>
+                </a:solidFill>
+                <a:latin typeface="Calibri" pitchFamily="34" charset="0"/>
+                <a:ea typeface="Calibri" pitchFamily="34" charset="-122"/>
+                <a:cs typeface="Calibri" pitchFamily="34" charset="-120"/>
+              </a:rPr>
+              <a:t>stores lyrical motifs · </a:t>
+            </a:r>
+            <a:endParaRPr lang="en-US" sz="1600" dirty="0">
+              <a:solidFill>
+                <a:prstClr val="black"/>
+              </a:solidFill>
+              <a:latin typeface="Calibri" panose="020F0502020204030204"/>
+            </a:endParaRPr>
+          </a:p>
+          <a:p>
+            <a:pPr defTabSz="1219170"/>
+            <a:r>
+              <a:rPr lang="en-US" sz="1600" dirty="0">
+                <a:solidFill>
+                  <a:srgbClr val="CADCFC"/>
+                </a:solidFill>
+                <a:latin typeface="Calibri" pitchFamily="34" charset="0"/>
+                <a:ea typeface="Calibri" pitchFamily="34" charset="-122"/>
+                <a:cs typeface="Calibri" pitchFamily="34" charset="-120"/>
+              </a:rPr>
+              <a:t>both voices (bass + sax)</a:t>
+            </a:r>
+            <a:endParaRPr lang="en-US" sz="1600" dirty="0">
+              <a:solidFill>
+                <a:prstClr val="black"/>
+              </a:solidFill>
+              <a:latin typeface="Calibri" panose="020F0502020204030204"/>
+            </a:endParaRPr>
+          </a:p>
+        </p:txBody>
+      </p:sp>
+      <p:sp>
+        <p:nvSpPr>
+          <p:cNvPr id="26" name="Shape 24"/>
+          <p:cNvSpPr/>
+          <p:nvPr/>
+        </p:nvSpPr>
+        <p:spPr>
+          <a:xfrm flipV="1">
+            <a:off x="4735093" y="1340472"/>
+            <a:ext cx="607768" cy="344625"/>
+          </a:xfrm>
+          <a:prstGeom prst="line">
+            <a:avLst/>
+          </a:prstGeom>
+          <a:noFill/>
+          <a:ln w="50800">
+            <a:solidFill>
+              <a:srgbClr val="CADCFC"/>
+            </a:solidFill>
+            <a:prstDash val="solid"/>
+            <a:tailEnd type="arrow"/>
+          </a:ln>
+        </p:spPr>
+        <p:txBody>
+          <a:bodyPr/>
+          <a:lstStyle/>
+          <a:p>
+            <a:pPr defTabSz="1219170"/>
+            <a:endParaRPr lang="en-US" sz="2400">
+              <a:solidFill>
+                <a:prstClr val="black"/>
+              </a:solidFill>
+              <a:latin typeface="Calibri" panose="020F0502020204030204"/>
+            </a:endParaRPr>
+          </a:p>
+        </p:txBody>
+      </p:sp>
+      <p:sp>
+        <p:nvSpPr>
+          <p:cNvPr id="27" name="Shape 25"/>
+          <p:cNvSpPr/>
+          <p:nvPr/>
+        </p:nvSpPr>
+        <p:spPr>
+          <a:xfrm>
+            <a:off x="3415861" y="4522398"/>
+            <a:ext cx="5486400" cy="1598319"/>
+          </a:xfrm>
+          <a:prstGeom prst="roundRect">
+            <a:avLst>
+              <a:gd name="adj" fmla="val 8000"/>
+            </a:avLst>
+          </a:prstGeom>
+          <a:solidFill>
+            <a:schemeClr val="accent6">
+              <a:lumMod val="50000"/>
+            </a:schemeClr>
+          </a:solidFill>
+          <a:ln w="25400">
+            <a:solidFill>
+              <a:srgbClr val="CADCFC"/>
+            </a:solidFill>
+            <a:prstDash val="solid"/>
+          </a:ln>
+        </p:spPr>
+        <p:txBody>
+          <a:bodyPr/>
+          <a:lstStyle/>
+          <a:p>
+            <a:pPr defTabSz="1219170"/>
+            <a:endParaRPr lang="en-US" sz="2400">
+              <a:solidFill>
+                <a:prstClr val="black"/>
+              </a:solidFill>
+              <a:latin typeface="Calibri" panose="020F0502020204030204"/>
+            </a:endParaRPr>
+          </a:p>
+        </p:txBody>
+      </p:sp>
+      <p:sp>
+        <p:nvSpPr>
+          <p:cNvPr id="28" name="Text 26"/>
+          <p:cNvSpPr/>
+          <p:nvPr/>
+        </p:nvSpPr>
+        <p:spPr>
+          <a:xfrm>
+            <a:off x="3476821" y="4574896"/>
+            <a:ext cx="5364480" cy="338355"/>
+          </a:xfrm>
+          <a:prstGeom prst="rect">
+            <a:avLst/>
+          </a:prstGeom>
+          <a:noFill/>
+          <a:ln/>
+        </p:spPr>
+        <p:txBody>
+          <a:bodyPr wrap="square" lIns="0" tIns="0" rIns="0" bIns="0" rtlCol="0" anchor="ctr"/>
+          <a:lstStyle/>
+          <a:p>
+            <a:pPr algn="ctr" defTabSz="1219170"/>
+            <a:r>
+              <a:rPr lang="en-US" sz="2400" b="1" dirty="0">
+                <a:solidFill>
+                  <a:srgbClr val="FFFFFF"/>
+                </a:solidFill>
+                <a:latin typeface="Calibri" pitchFamily="34" charset="0"/>
+                <a:ea typeface="Calibri" pitchFamily="34" charset="-122"/>
+                <a:cs typeface="Calibri" pitchFamily="34" charset="-120"/>
+              </a:rPr>
+              <a:t>ArcController</a:t>
+            </a:r>
+            <a:endParaRPr lang="en-US" sz="2400" dirty="0">
+              <a:solidFill>
+                <a:prstClr val="black"/>
+              </a:solidFill>
+              <a:latin typeface="Calibri" panose="020F0502020204030204"/>
+            </a:endParaRPr>
+          </a:p>
+        </p:txBody>
+      </p:sp>
+      <p:sp>
+        <p:nvSpPr>
+          <p:cNvPr id="29" name="Text 27"/>
+          <p:cNvSpPr/>
+          <p:nvPr/>
+        </p:nvSpPr>
+        <p:spPr>
+          <a:xfrm>
+            <a:off x="3513397" y="4949478"/>
+            <a:ext cx="5291328" cy="915817"/>
+          </a:xfrm>
+          <a:prstGeom prst="rect">
+            <a:avLst/>
+          </a:prstGeom>
+          <a:noFill/>
+          <a:ln/>
+        </p:spPr>
+        <p:txBody>
+          <a:bodyPr wrap="square" lIns="33867" tIns="33867" rIns="33867" bIns="33867" rtlCol="0" anchor="t"/>
+          <a:lstStyle/>
+          <a:p>
+            <a:pPr defTabSz="1219170"/>
+            <a:r>
+              <a:rPr lang="en-US" sz="1600" dirty="0">
+                <a:solidFill>
+                  <a:srgbClr val="CADCFC"/>
+                </a:solidFill>
+                <a:latin typeface="Calibri" pitchFamily="34" charset="0"/>
+                <a:ea typeface="Calibri" pitchFamily="34" charset="-122"/>
+                <a:cs typeface="Calibri" pitchFamily="34" charset="-120"/>
+              </a:rPr>
+              <a:t>5-min performance arc  ·  leadership · proactive mode · bass pitch-class tracking  ·  energy arc selection · motif + lyrical motif selection  ·  register contrast scheduling · rhythmic density + complementarity  ·  stage swing baseline · opening echo</a:t>
+            </a:r>
+            <a:endParaRPr lang="en-US" sz="1600" dirty="0">
+              <a:solidFill>
+                <a:prstClr val="black"/>
+              </a:solidFill>
+              <a:latin typeface="Calibri" panose="020F0502020204030204"/>
+            </a:endParaRPr>
+          </a:p>
+        </p:txBody>
+      </p:sp>
+      <p:sp>
+        <p:nvSpPr>
+          <p:cNvPr id="30" name="Shape 28"/>
+          <p:cNvSpPr/>
+          <p:nvPr/>
+        </p:nvSpPr>
+        <p:spPr>
+          <a:xfrm>
+            <a:off x="6526922" y="4125109"/>
+            <a:ext cx="0" cy="315309"/>
+          </a:xfrm>
+          <a:prstGeom prst="line">
+            <a:avLst/>
+          </a:prstGeom>
+          <a:noFill/>
+          <a:ln w="50800">
+            <a:solidFill>
+              <a:srgbClr val="CADCFC"/>
+            </a:solidFill>
+            <a:prstDash val="solid"/>
+            <a:tailEnd type="arrow"/>
+          </a:ln>
+        </p:spPr>
+        <p:txBody>
+          <a:bodyPr/>
+          <a:lstStyle/>
+          <a:p>
+            <a:pPr defTabSz="1219170"/>
+            <a:endParaRPr lang="en-US" sz="2400">
+              <a:solidFill>
+                <a:prstClr val="black"/>
+              </a:solidFill>
+              <a:latin typeface="Calibri" panose="020F0502020204030204"/>
+            </a:endParaRPr>
+          </a:p>
+        </p:txBody>
+      </p:sp>
+      <p:sp>
+        <p:nvSpPr>
+          <p:cNvPr id="32" name="Shape 28">
+            <a:extLst>
+              <a:ext uri="{FF2B5EF4-FFF2-40B4-BE49-F238E27FC236}">
+                <a16:creationId xmlns:a16="http://schemas.microsoft.com/office/drawing/2014/main" id="{82A67C06-F31C-A34E-B75C-378998F00D80}"/>
+              </a:ext>
+            </a:extLst>
+          </p:cNvPr>
+          <p:cNvSpPr/>
+          <p:nvPr/>
+        </p:nvSpPr>
+        <p:spPr>
+          <a:xfrm>
+            <a:off x="6526922" y="6183781"/>
+            <a:ext cx="0" cy="476909"/>
+          </a:xfrm>
+          <a:prstGeom prst="line">
+            <a:avLst/>
+          </a:prstGeom>
+          <a:noFill/>
+          <a:ln w="50800">
+            <a:solidFill>
+              <a:srgbClr val="FFC000"/>
+            </a:solidFill>
+            <a:prstDash val="sysDot"/>
+            <a:tailEnd type="arrow"/>
+          </a:ln>
+        </p:spPr>
+        <p:txBody>
+          <a:bodyPr/>
+          <a:lstStyle/>
+          <a:p>
+            <a:pPr defTabSz="1219170"/>
+            <a:endParaRPr lang="en-US" sz="2400" dirty="0">
+              <a:solidFill>
+                <a:prstClr val="black"/>
+              </a:solidFill>
+              <a:latin typeface="Calibri" panose="020F0502020204030204"/>
+            </a:endParaRPr>
+          </a:p>
+        </p:txBody>
+      </p:sp>
+      <p:sp>
+        <p:nvSpPr>
+          <p:cNvPr id="33" name="Shape 13">
+            <a:extLst>
+              <a:ext uri="{FF2B5EF4-FFF2-40B4-BE49-F238E27FC236}">
+                <a16:creationId xmlns:a16="http://schemas.microsoft.com/office/drawing/2014/main" id="{BE87611D-8695-346E-CD03-8723D7EC6F13}"/>
+              </a:ext>
+            </a:extLst>
+          </p:cNvPr>
+          <p:cNvSpPr/>
+          <p:nvPr/>
+        </p:nvSpPr>
+        <p:spPr>
+          <a:xfrm>
+            <a:off x="4834130" y="845010"/>
+            <a:ext cx="582300" cy="0"/>
+          </a:xfrm>
+          <a:prstGeom prst="line">
+            <a:avLst/>
+          </a:prstGeom>
+          <a:noFill/>
+          <a:ln w="50800">
+            <a:solidFill>
+              <a:srgbClr val="CADCFC"/>
+            </a:solidFill>
+            <a:prstDash val="solid"/>
+            <a:tailEnd type="arrow"/>
+          </a:ln>
+        </p:spPr>
+        <p:txBody>
+          <a:bodyPr/>
+          <a:lstStyle/>
+          <a:p>
+            <a:pPr defTabSz="1219170"/>
+            <a:endParaRPr lang="en-US" sz="2400">
+              <a:solidFill>
+                <a:prstClr val="black"/>
+              </a:solidFill>
+              <a:latin typeface="Calibri" panose="020F0502020204030204"/>
+            </a:endParaRPr>
+          </a:p>
+        </p:txBody>
+      </p:sp>
+      <p:sp>
+        <p:nvSpPr>
+          <p:cNvPr id="34" name="Shape 13">
+            <a:extLst>
+              <a:ext uri="{FF2B5EF4-FFF2-40B4-BE49-F238E27FC236}">
+                <a16:creationId xmlns:a16="http://schemas.microsoft.com/office/drawing/2014/main" id="{7493AAE1-3A41-2F24-A433-15942ED6887C}"/>
+              </a:ext>
+            </a:extLst>
+          </p:cNvPr>
+          <p:cNvSpPr/>
+          <p:nvPr/>
+        </p:nvSpPr>
+        <p:spPr>
+          <a:xfrm>
+            <a:off x="2389639" y="814265"/>
+            <a:ext cx="377951" cy="0"/>
+          </a:xfrm>
+          <a:prstGeom prst="line">
+            <a:avLst/>
+          </a:prstGeom>
+          <a:noFill/>
+          <a:ln w="50800">
+            <a:solidFill>
+              <a:srgbClr val="CADCFC"/>
+            </a:solidFill>
+            <a:prstDash val="solid"/>
+            <a:tailEnd type="arrow"/>
+          </a:ln>
+        </p:spPr>
+        <p:txBody>
+          <a:bodyPr/>
+          <a:lstStyle/>
+          <a:p>
+            <a:pPr defTabSz="1219170"/>
+            <a:endParaRPr lang="en-US" sz="2400">
+              <a:solidFill>
+                <a:prstClr val="black"/>
+              </a:solidFill>
+              <a:latin typeface="Calibri" panose="020F0502020204030204"/>
+            </a:endParaRPr>
+          </a:p>
+        </p:txBody>
+      </p:sp>
+      <p:sp>
+        <p:nvSpPr>
+          <p:cNvPr id="2" name="Text 10">
+            <a:extLst>
+              <a:ext uri="{FF2B5EF4-FFF2-40B4-BE49-F238E27FC236}">
+                <a16:creationId xmlns:a16="http://schemas.microsoft.com/office/drawing/2014/main" id="{035CAC2A-78AD-68B9-ED4D-6D53C2E1AA41}"/>
+              </a:ext>
+            </a:extLst>
+          </p:cNvPr>
+          <p:cNvSpPr/>
+          <p:nvPr/>
+        </p:nvSpPr>
+        <p:spPr>
+          <a:xfrm>
+            <a:off x="5648890" y="984707"/>
+            <a:ext cx="2131078" cy="876298"/>
+          </a:xfrm>
+          <a:prstGeom prst="rect">
+            <a:avLst/>
+          </a:prstGeom>
+          <a:noFill/>
+          <a:ln/>
+        </p:spPr>
+        <p:txBody>
+          <a:bodyPr wrap="square" lIns="33867" tIns="33867" rIns="33867" bIns="33867" rtlCol="0" anchor="t"/>
+          <a:lstStyle/>
+          <a:p>
+            <a:pPr defTabSz="1219170"/>
+            <a:r>
+              <a:rPr lang="en-US" sz="1600" dirty="0">
+                <a:solidFill>
+                  <a:srgbClr val="CADCFC"/>
+                </a:solidFill>
+                <a:latin typeface="Calibri" pitchFamily="34" charset="0"/>
+                <a:ea typeface="Calibri" pitchFamily="34" charset="-122"/>
+                <a:cs typeface="Calibri" pitchFamily="34" charset="-120"/>
+              </a:rPr>
+              <a:t>note dur min · min phrase notes · monophony · watchdog</a:t>
+            </a:r>
+            <a:endParaRPr lang="en-US" sz="1600" dirty="0">
+              <a:solidFill>
+                <a:prstClr val="black"/>
+              </a:solidFill>
+              <a:latin typeface="Calibri" panose="020F0502020204030204"/>
+            </a:endParaRPr>
+          </a:p>
+        </p:txBody>
+      </p:sp>
+      <p:sp>
+        <p:nvSpPr>
+          <p:cNvPr id="13" name="Shape 14">
+            <a:extLst>
+              <a:ext uri="{FF2B5EF4-FFF2-40B4-BE49-F238E27FC236}">
+                <a16:creationId xmlns:a16="http://schemas.microsoft.com/office/drawing/2014/main" id="{7D6019D4-9F06-D4F8-9055-5C0B69571156}"/>
+              </a:ext>
+            </a:extLst>
+          </p:cNvPr>
+          <p:cNvSpPr/>
+          <p:nvPr/>
+        </p:nvSpPr>
+        <p:spPr>
+          <a:xfrm>
+            <a:off x="358153" y="4886419"/>
             <a:ext cx="2292087" cy="781702"/>
           </a:xfrm>
           <a:prstGeom prst="roundRect">
@@ -9456,7 +10144,7 @@
           <a:lstStyle/>
           <a:p>
             <a:pPr defTabSz="1219170"/>
-            <a:endParaRPr lang="en-US" sz="2400" dirty="0">
+            <a:endParaRPr lang="en-US" sz="2400">
               <a:solidFill>
                 <a:prstClr val="black"/>
               </a:solidFill>
@@ -9467,13 +10155,19 @@
       </p:sp>
       <p:sp>
         <p:nvSpPr>
-          <p:cNvPr id="17" name="Text 15"/>
+          <p:cNvPr id="14" name="Text 15">
+            <a:extLst>
+              <a:ext uri="{FF2B5EF4-FFF2-40B4-BE49-F238E27FC236}">
+                <a16:creationId xmlns:a16="http://schemas.microsoft.com/office/drawing/2014/main" id="{F402484E-1CC6-34A6-5E23-247659ED013C}"/>
+              </a:ext>
+            </a:extLst>
+          </p:cNvPr>
           <p:cNvSpPr/>
           <p:nvPr/>
         </p:nvSpPr>
         <p:spPr>
           <a:xfrm>
-            <a:off x="1932317" y="2234580"/>
+            <a:off x="358151" y="4967954"/>
             <a:ext cx="2292087" cy="353568"/>
           </a:xfrm>
           <a:prstGeom prst="rect">
@@ -9496,7 +10190,7 @@
                 <a:ea typeface="Calibri" pitchFamily="34" charset="-122"/>
                 <a:cs typeface="Calibri" pitchFamily="34" charset="-120"/>
               </a:rPr>
-              <a:t>BeatEstimator</a:t>
+              <a:t>Proactive Loop</a:t>
             </a:r>
             <a:endParaRPr lang="en-US" sz="2400" dirty="0">
               <a:solidFill>
@@ -9509,14 +10203,20 @@
       </p:sp>
       <p:sp>
         <p:nvSpPr>
-          <p:cNvPr id="18" name="Text 16"/>
+          <p:cNvPr id="31" name="Text 16">
+            <a:extLst>
+              <a:ext uri="{FF2B5EF4-FFF2-40B4-BE49-F238E27FC236}">
+                <a16:creationId xmlns:a16="http://schemas.microsoft.com/office/drawing/2014/main" id="{8093E773-011C-6678-EF78-708CE8296041}"/>
+              </a:ext>
+            </a:extLst>
+          </p:cNvPr>
           <p:cNvSpPr/>
           <p:nvPr/>
         </p:nvSpPr>
         <p:spPr>
           <a:xfrm>
-            <a:off x="2165140" y="2549540"/>
-            <a:ext cx="2059268" cy="293138"/>
+            <a:off x="525517" y="5295648"/>
+            <a:ext cx="2124721" cy="293138"/>
           </a:xfrm>
           <a:prstGeom prst="rect">
             <a:avLst/>
@@ -9538,7 +10238,7 @@
                 <a:ea typeface="Calibri" pitchFamily="34" charset="-122"/>
                 <a:cs typeface="Calibri" pitchFamily="34" charset="-120"/>
               </a:rPr>
-              <a:t>live tempo · beat sync</a:t>
+              <a:t>fires when bass paused</a:t>
             </a:r>
             <a:endParaRPr lang="en-US" sz="1600" dirty="0">
               <a:solidFill>
@@ -9551,14 +10251,20 @@
       </p:sp>
       <p:sp>
         <p:nvSpPr>
-          <p:cNvPr id="19" name="Shape 17"/>
+          <p:cNvPr id="35" name="Shape 13">
+            <a:extLst>
+              <a:ext uri="{FF2B5EF4-FFF2-40B4-BE49-F238E27FC236}">
+                <a16:creationId xmlns:a16="http://schemas.microsoft.com/office/drawing/2014/main" id="{FD5AEDBA-8E6D-A402-A41C-3F190A48E5BC}"/>
+              </a:ext>
+            </a:extLst>
+          </p:cNvPr>
           <p:cNvSpPr/>
           <p:nvPr/>
         </p:nvSpPr>
         <p:spPr>
           <a:xfrm>
-            <a:off x="3566160" y="1685953"/>
-            <a:ext cx="0" cy="353568"/>
+            <a:off x="2725550" y="5300918"/>
+            <a:ext cx="582300" cy="0"/>
           </a:xfrm>
           <a:prstGeom prst="line">
             <a:avLst/>
@@ -9588,54 +10294,20 @@
       </p:sp>
       <p:sp>
         <p:nvSpPr>
-          <p:cNvPr id="20" name="Shape 18"/>
+          <p:cNvPr id="36" name="Text 10">
+            <a:extLst>
+              <a:ext uri="{FF2B5EF4-FFF2-40B4-BE49-F238E27FC236}">
+                <a16:creationId xmlns:a16="http://schemas.microsoft.com/office/drawing/2014/main" id="{FE21DA54-651E-97F3-FCC2-BDEA980E4775}"/>
+              </a:ext>
+            </a:extLst>
+          </p:cNvPr>
           <p:cNvSpPr/>
           <p:nvPr/>
         </p:nvSpPr>
         <p:spPr>
           <a:xfrm>
-            <a:off x="4681302" y="2755535"/>
-            <a:ext cx="2960152" cy="1287592"/>
-          </a:xfrm>
-          <a:prstGeom prst="roundRect">
-            <a:avLst>
-              <a:gd name="adj" fmla="val 8421"/>
-            </a:avLst>
-          </a:prstGeom>
-          <a:solidFill>
-            <a:srgbClr val="162050"/>
-          </a:solidFill>
-          <a:ln w="19050">
-            <a:solidFill>
-              <a:srgbClr val="CADCFC"/>
-            </a:solidFill>
-            <a:prstDash val="solid"/>
-          </a:ln>
-        </p:spPr>
-        <p:txBody>
-          <a:bodyPr/>
-          <a:lstStyle/>
-          <a:p>
-            <a:pPr defTabSz="1219170"/>
-            <a:endParaRPr lang="en-US" sz="2400">
-              <a:solidFill>
-                <a:prstClr val="black"/>
-              </a:solidFill>
-              <a:latin typeface="Calibri" panose="020F0502020204030204"/>
-            </a:endParaRPr>
-          </a:p>
-        </p:txBody>
-      </p:sp>
-      <p:sp>
-        <p:nvSpPr>
-          <p:cNvPr id="21" name="Text 19"/>
-          <p:cNvSpPr/>
-          <p:nvPr/>
-        </p:nvSpPr>
-        <p:spPr>
-          <a:xfrm>
-            <a:off x="4742262" y="2842482"/>
-            <a:ext cx="2850517" cy="316992"/>
+            <a:off x="2959931" y="947823"/>
+            <a:ext cx="1721371" cy="876298"/>
           </a:xfrm>
           <a:prstGeom prst="rect">
             <a:avLst/>
@@ -9644,52 +10316,10 @@
           <a:ln/>
         </p:spPr>
         <p:txBody>
-          <a:bodyPr wrap="square" lIns="0" tIns="0" rIns="0" bIns="0" rtlCol="0" anchor="ctr"/>
+          <a:bodyPr wrap="square" lIns="33867" tIns="33867" rIns="33867" bIns="33867" rtlCol="0" anchor="t"/>
           <a:lstStyle/>
           <a:p>
             <a:pPr algn="ctr" defTabSz="1219170"/>
-            <a:r>
-              <a:rPr lang="en-US" sz="2400" b="1" dirty="0">
-                <a:solidFill>
-                  <a:srgbClr val="FFFFFF"/>
-                </a:solidFill>
-                <a:latin typeface="Calibri" pitchFamily="34" charset="0"/>
-                <a:ea typeface="Calibri" pitchFamily="34" charset="-122"/>
-                <a:cs typeface="Calibri" pitchFamily="34" charset="-120"/>
-              </a:rPr>
-              <a:t>PhraseMemory</a:t>
-            </a:r>
-            <a:endParaRPr lang="en-US" sz="2400" dirty="0">
-              <a:solidFill>
-                <a:prstClr val="black"/>
-              </a:solidFill>
-              <a:latin typeface="Calibri" panose="020F0502020204030204"/>
-            </a:endParaRPr>
-          </a:p>
-        </p:txBody>
-      </p:sp>
-      <p:sp>
-        <p:nvSpPr>
-          <p:cNvPr id="22" name="Text 20"/>
-          <p:cNvSpPr/>
-          <p:nvPr/>
-        </p:nvSpPr>
-        <p:spPr>
-          <a:xfrm>
-            <a:off x="4943430" y="3187584"/>
-            <a:ext cx="2488720" cy="792480"/>
-          </a:xfrm>
-          <a:prstGeom prst="rect">
-            <a:avLst/>
-          </a:prstGeom>
-          <a:noFill/>
-          <a:ln/>
-        </p:spPr>
-        <p:txBody>
-          <a:bodyPr wrap="square" lIns="33867" tIns="33867" rIns="33867" bIns="33867" rtlCol="0" anchor="t"/>
-          <a:lstStyle/>
-          <a:p>
-            <a:pPr defTabSz="1219170"/>
             <a:r>
               <a:rPr lang="en-US" sz="1600" dirty="0">
                 <a:solidFill>
@@ -9699,7 +10329,7 @@
                 <a:ea typeface="Calibri" pitchFamily="34" charset="-122"/>
                 <a:cs typeface="Calibri" pitchFamily="34" charset="-120"/>
               </a:rPr>
-              <a:t>stores phrases + motifs · </a:t>
+              <a:t>filter · routing</a:t>
             </a:r>
             <a:endParaRPr lang="en-US" sz="1600" dirty="0">
               <a:solidFill>
@@ -9708,548 +10338,24 @@
               <a:latin typeface="Calibri" panose="020F0502020204030204"/>
             </a:endParaRPr>
           </a:p>
-          <a:p>
-            <a:pPr defTabSz="1219170"/>
-            <a:r>
-              <a:rPr lang="en-US" sz="1600" dirty="0">
-                <a:solidFill>
-                  <a:srgbClr val="CADCFC"/>
-                </a:solidFill>
-                <a:latin typeface="Calibri" pitchFamily="34" charset="0"/>
-                <a:ea typeface="Calibri" pitchFamily="34" charset="-122"/>
-                <a:cs typeface="Calibri" pitchFamily="34" charset="-120"/>
-              </a:rPr>
-              <a:t>stores lyrical motifs · </a:t>
-            </a:r>
-            <a:endParaRPr lang="en-US" sz="1600" dirty="0">
-              <a:solidFill>
-                <a:prstClr val="black"/>
-              </a:solidFill>
-              <a:latin typeface="Calibri" panose="020F0502020204030204"/>
-            </a:endParaRPr>
-          </a:p>
-          <a:p>
-            <a:pPr defTabSz="1219170"/>
-            <a:r>
-              <a:rPr lang="en-US" sz="1600" dirty="0">
-                <a:solidFill>
-                  <a:srgbClr val="CADCFC"/>
-                </a:solidFill>
-                <a:latin typeface="Calibri" pitchFamily="34" charset="0"/>
-                <a:ea typeface="Calibri" pitchFamily="34" charset="-122"/>
-                <a:cs typeface="Calibri" pitchFamily="34" charset="-120"/>
-              </a:rPr>
-              <a:t>both voices (bass + sax)</a:t>
-            </a:r>
-            <a:endParaRPr lang="en-US" sz="1600" dirty="0">
-              <a:solidFill>
-                <a:prstClr val="black"/>
-              </a:solidFill>
-              <a:latin typeface="Calibri" panose="020F0502020204030204"/>
-            </a:endParaRPr>
-          </a:p>
-        </p:txBody>
-      </p:sp>
-      <p:sp>
-        <p:nvSpPr>
-          <p:cNvPr id="23" name="Shape 21"/>
+        </p:txBody>
+      </p:sp>
+      <p:sp>
+        <p:nvSpPr>
+          <p:cNvPr id="37" name="Shape 14">
+            <a:extLst>
+              <a:ext uri="{FF2B5EF4-FFF2-40B4-BE49-F238E27FC236}">
+                <a16:creationId xmlns:a16="http://schemas.microsoft.com/office/drawing/2014/main" id="{92A60E65-CA67-17DB-181C-9F8648E943B1}"/>
+              </a:ext>
+            </a:extLst>
+          </p:cNvPr>
           <p:cNvSpPr/>
           <p:nvPr/>
         </p:nvSpPr>
         <p:spPr>
           <a:xfrm>
-            <a:off x="8839200" y="2610826"/>
-            <a:ext cx="0" cy="821376"/>
-          </a:xfrm>
-          <a:prstGeom prst="line">
-            <a:avLst/>
-          </a:prstGeom>
-          <a:noFill/>
-          <a:ln w="50800">
-            <a:solidFill>
-              <a:srgbClr val="CADCFC"/>
-            </a:solidFill>
-            <a:prstDash val="solid"/>
-          </a:ln>
-        </p:spPr>
-        <p:txBody>
-          <a:bodyPr/>
-          <a:lstStyle/>
-          <a:p>
-            <a:pPr defTabSz="1219170"/>
-            <a:endParaRPr lang="en-US" sz="2400">
-              <a:solidFill>
-                <a:prstClr val="black"/>
-              </a:solidFill>
-              <a:latin typeface="Calibri" panose="020F0502020204030204"/>
-            </a:endParaRPr>
-          </a:p>
-        </p:txBody>
-      </p:sp>
-      <p:sp>
-        <p:nvSpPr>
-          <p:cNvPr id="24" name="Shape 22"/>
-          <p:cNvSpPr/>
-          <p:nvPr/>
-        </p:nvSpPr>
-        <p:spPr>
-          <a:xfrm>
-            <a:off x="7779968" y="3432201"/>
-            <a:ext cx="1059232" cy="0"/>
-          </a:xfrm>
-          <a:prstGeom prst="line">
-            <a:avLst/>
-          </a:prstGeom>
-          <a:noFill/>
-          <a:ln w="50800">
-            <a:solidFill>
-              <a:srgbClr val="CADCFC"/>
-            </a:solidFill>
-            <a:prstDash val="solid"/>
-            <a:headEnd type="arrow"/>
-          </a:ln>
-        </p:spPr>
-        <p:txBody>
-          <a:bodyPr/>
-          <a:lstStyle/>
-          <a:p>
-            <a:pPr defTabSz="1219170"/>
-            <a:endParaRPr lang="en-US" sz="2400">
-              <a:solidFill>
-                <a:prstClr val="black"/>
-              </a:solidFill>
-              <a:latin typeface="Calibri" panose="020F0502020204030204"/>
-            </a:endParaRPr>
-          </a:p>
-        </p:txBody>
-      </p:sp>
-      <p:sp>
-        <p:nvSpPr>
-          <p:cNvPr id="25" name="Shape 23"/>
-          <p:cNvSpPr/>
-          <p:nvPr/>
-        </p:nvSpPr>
-        <p:spPr>
-          <a:xfrm>
-            <a:off x="3555435" y="3040903"/>
-            <a:ext cx="10725" cy="391298"/>
-          </a:xfrm>
-          <a:prstGeom prst="line">
-            <a:avLst/>
-          </a:prstGeom>
-          <a:noFill/>
-          <a:ln w="50800">
-            <a:solidFill>
-              <a:srgbClr val="CADCFC"/>
-            </a:solidFill>
-            <a:prstDash val="solid"/>
-          </a:ln>
-        </p:spPr>
-        <p:txBody>
-          <a:bodyPr/>
-          <a:lstStyle/>
-          <a:p>
-            <a:pPr defTabSz="1219170"/>
-            <a:endParaRPr lang="en-US" sz="2400">
-              <a:solidFill>
-                <a:prstClr val="black"/>
-              </a:solidFill>
-              <a:latin typeface="Calibri" panose="020F0502020204030204"/>
-            </a:endParaRPr>
-          </a:p>
-        </p:txBody>
-      </p:sp>
-      <p:sp>
-        <p:nvSpPr>
-          <p:cNvPr id="26" name="Shape 24"/>
-          <p:cNvSpPr/>
-          <p:nvPr/>
-        </p:nvSpPr>
-        <p:spPr>
-          <a:xfrm>
-            <a:off x="3555436" y="3432201"/>
-            <a:ext cx="985033" cy="0"/>
-          </a:xfrm>
-          <a:prstGeom prst="line">
-            <a:avLst/>
-          </a:prstGeom>
-          <a:noFill/>
-          <a:ln w="50800">
-            <a:solidFill>
-              <a:srgbClr val="CADCFC"/>
-            </a:solidFill>
-            <a:prstDash val="solid"/>
-            <a:tailEnd type="arrow"/>
-          </a:ln>
-        </p:spPr>
-        <p:txBody>
-          <a:bodyPr/>
-          <a:lstStyle/>
-          <a:p>
-            <a:pPr defTabSz="1219170"/>
-            <a:endParaRPr lang="en-US" sz="2400">
-              <a:solidFill>
-                <a:prstClr val="black"/>
-              </a:solidFill>
-              <a:latin typeface="Calibri" panose="020F0502020204030204"/>
-            </a:endParaRPr>
-          </a:p>
-        </p:txBody>
-      </p:sp>
-      <p:sp>
-        <p:nvSpPr>
-          <p:cNvPr id="27" name="Shape 25"/>
-          <p:cNvSpPr/>
-          <p:nvPr/>
-        </p:nvSpPr>
-        <p:spPr>
-          <a:xfrm>
-            <a:off x="3457901" y="4522399"/>
-            <a:ext cx="5486400" cy="1489456"/>
-          </a:xfrm>
-          <a:prstGeom prst="roundRect">
-            <a:avLst>
-              <a:gd name="adj" fmla="val 8000"/>
-            </a:avLst>
-          </a:prstGeom>
-          <a:solidFill>
-            <a:srgbClr val="253880"/>
-          </a:solidFill>
-          <a:ln w="25400">
-            <a:solidFill>
-              <a:srgbClr val="CADCFC"/>
-            </a:solidFill>
-            <a:prstDash val="solid"/>
-          </a:ln>
-        </p:spPr>
-        <p:txBody>
-          <a:bodyPr/>
-          <a:lstStyle/>
-          <a:p>
-            <a:pPr defTabSz="1219170"/>
-            <a:endParaRPr lang="en-US" sz="2400">
-              <a:solidFill>
-                <a:prstClr val="black"/>
-              </a:solidFill>
-              <a:latin typeface="Calibri" panose="020F0502020204030204"/>
-            </a:endParaRPr>
-          </a:p>
-        </p:txBody>
-      </p:sp>
-      <p:sp>
-        <p:nvSpPr>
-          <p:cNvPr id="28" name="Text 26"/>
-          <p:cNvSpPr/>
-          <p:nvPr/>
-        </p:nvSpPr>
-        <p:spPr>
-          <a:xfrm>
-            <a:off x="3518861" y="4574896"/>
-            <a:ext cx="5364480" cy="315309"/>
-          </a:xfrm>
-          <a:prstGeom prst="rect">
-            <a:avLst/>
-          </a:prstGeom>
-          <a:noFill/>
-          <a:ln/>
-        </p:spPr>
-        <p:txBody>
-          <a:bodyPr wrap="square" lIns="0" tIns="0" rIns="0" bIns="0" rtlCol="0" anchor="ctr"/>
-          <a:lstStyle/>
-          <a:p>
-            <a:pPr algn="ctr" defTabSz="1219170"/>
-            <a:r>
-              <a:rPr lang="en-US" sz="2400" b="1" dirty="0">
-                <a:solidFill>
-                  <a:srgbClr val="FFFFFF"/>
-                </a:solidFill>
-                <a:latin typeface="Calibri" pitchFamily="34" charset="0"/>
-                <a:ea typeface="Calibri" pitchFamily="34" charset="-122"/>
-                <a:cs typeface="Calibri" pitchFamily="34" charset="-120"/>
-              </a:rPr>
-              <a:t>ArcController</a:t>
-            </a:r>
-            <a:endParaRPr lang="en-US" sz="2400" dirty="0">
-              <a:solidFill>
-                <a:prstClr val="black"/>
-              </a:solidFill>
-              <a:latin typeface="Calibri" panose="020F0502020204030204"/>
-            </a:endParaRPr>
-          </a:p>
-        </p:txBody>
-      </p:sp>
-      <p:sp>
-        <p:nvSpPr>
-          <p:cNvPr id="29" name="Text 27"/>
-          <p:cNvSpPr/>
-          <p:nvPr/>
-        </p:nvSpPr>
-        <p:spPr>
-          <a:xfrm>
-            <a:off x="3555437" y="4886419"/>
-            <a:ext cx="5291328" cy="853440"/>
-          </a:xfrm>
-          <a:prstGeom prst="rect">
-            <a:avLst/>
-          </a:prstGeom>
-          <a:noFill/>
-          <a:ln/>
-        </p:spPr>
-        <p:txBody>
-          <a:bodyPr wrap="square" lIns="33867" tIns="33867" rIns="33867" bIns="33867" rtlCol="0" anchor="t"/>
-          <a:lstStyle/>
-          <a:p>
-            <a:pPr defTabSz="1219170"/>
-            <a:r>
-              <a:rPr lang="en-US" sz="1600" dirty="0">
-                <a:solidFill>
-                  <a:srgbClr val="CADCFC"/>
-                </a:solidFill>
-                <a:latin typeface="Calibri" pitchFamily="34" charset="0"/>
-                <a:ea typeface="Calibri" pitchFamily="34" charset="-122"/>
-                <a:cs typeface="Calibri" pitchFamily="34" charset="-120"/>
-              </a:rPr>
-              <a:t>5-min performance arc  ·  leadership · proactive mode · bass pitch-class tracking  ·  energy arc selection · motif + lyrical motif selection  ·  register contrast scheduling · rhythmic density + complementarity  ·  stage swing baseline · opening echo</a:t>
-            </a:r>
-            <a:endParaRPr lang="en-US" sz="1600" dirty="0">
-              <a:solidFill>
-                <a:prstClr val="black"/>
-              </a:solidFill>
-              <a:latin typeface="Calibri" panose="020F0502020204030204"/>
-            </a:endParaRPr>
-          </a:p>
-        </p:txBody>
-      </p:sp>
-      <p:sp>
-        <p:nvSpPr>
-          <p:cNvPr id="30" name="Shape 28"/>
-          <p:cNvSpPr/>
-          <p:nvPr/>
-        </p:nvSpPr>
-        <p:spPr>
-          <a:xfrm>
-            <a:off x="6201101" y="4125109"/>
-            <a:ext cx="0" cy="315309"/>
-          </a:xfrm>
-          <a:prstGeom prst="line">
-            <a:avLst/>
-          </a:prstGeom>
-          <a:noFill/>
-          <a:ln w="50800">
-            <a:solidFill>
-              <a:srgbClr val="CADCFC"/>
-            </a:solidFill>
-            <a:prstDash val="solid"/>
-            <a:tailEnd type="arrow"/>
-          </a:ln>
-        </p:spPr>
-        <p:txBody>
-          <a:bodyPr/>
-          <a:lstStyle/>
-          <a:p>
-            <a:pPr defTabSz="1219170"/>
-            <a:endParaRPr lang="en-US" sz="2400">
-              <a:solidFill>
-                <a:prstClr val="black"/>
-              </a:solidFill>
-              <a:latin typeface="Calibri" panose="020F0502020204030204"/>
-            </a:endParaRPr>
-          </a:p>
-        </p:txBody>
-      </p:sp>
-      <p:sp>
-        <p:nvSpPr>
-          <p:cNvPr id="32" name="Shape 28">
-            <a:extLst>
-              <a:ext uri="{FF2B5EF4-FFF2-40B4-BE49-F238E27FC236}">
-                <a16:creationId xmlns:a16="http://schemas.microsoft.com/office/drawing/2014/main" id="{82A67C06-F31C-A34E-B75C-378998F00D80}"/>
-              </a:ext>
-            </a:extLst>
-          </p:cNvPr>
-          <p:cNvSpPr/>
-          <p:nvPr/>
-        </p:nvSpPr>
-        <p:spPr>
-          <a:xfrm>
-            <a:off x="6201101" y="6173273"/>
-            <a:ext cx="0" cy="476909"/>
-          </a:xfrm>
-          <a:prstGeom prst="line">
-            <a:avLst/>
-          </a:prstGeom>
-          <a:noFill/>
-          <a:ln w="50800">
-            <a:solidFill>
-              <a:srgbClr val="FFC000"/>
-            </a:solidFill>
-            <a:prstDash val="sysDot"/>
-            <a:tailEnd type="arrow"/>
-          </a:ln>
-        </p:spPr>
-        <p:txBody>
-          <a:bodyPr/>
-          <a:lstStyle/>
-          <a:p>
-            <a:pPr defTabSz="1219170"/>
-            <a:endParaRPr lang="en-US" sz="2400" dirty="0">
-              <a:solidFill>
-                <a:prstClr val="black"/>
-              </a:solidFill>
-              <a:latin typeface="Calibri" panose="020F0502020204030204"/>
-            </a:endParaRPr>
-          </a:p>
-        </p:txBody>
-      </p:sp>
-      <p:sp>
-        <p:nvSpPr>
-          <p:cNvPr id="33" name="Shape 13">
-            <a:extLst>
-              <a:ext uri="{FF2B5EF4-FFF2-40B4-BE49-F238E27FC236}">
-                <a16:creationId xmlns:a16="http://schemas.microsoft.com/office/drawing/2014/main" id="{BE87611D-8695-346E-CD03-8723D7EC6F13}"/>
-              </a:ext>
-            </a:extLst>
-          </p:cNvPr>
-          <p:cNvSpPr/>
-          <p:nvPr/>
-        </p:nvSpPr>
-        <p:spPr>
-          <a:xfrm>
-            <a:off x="4834130" y="1139298"/>
-            <a:ext cx="582300" cy="0"/>
-          </a:xfrm>
-          <a:prstGeom prst="line">
-            <a:avLst/>
-          </a:prstGeom>
-          <a:noFill/>
-          <a:ln w="50800">
-            <a:solidFill>
-              <a:srgbClr val="CADCFC"/>
-            </a:solidFill>
-            <a:prstDash val="solid"/>
-            <a:tailEnd type="arrow"/>
-          </a:ln>
-        </p:spPr>
-        <p:txBody>
-          <a:bodyPr/>
-          <a:lstStyle/>
-          <a:p>
-            <a:pPr defTabSz="1219170"/>
-            <a:endParaRPr lang="en-US" sz="2400">
-              <a:solidFill>
-                <a:prstClr val="black"/>
-              </a:solidFill>
-              <a:latin typeface="Calibri" panose="020F0502020204030204"/>
-            </a:endParaRPr>
-          </a:p>
-        </p:txBody>
-      </p:sp>
-      <p:sp>
-        <p:nvSpPr>
-          <p:cNvPr id="34" name="Shape 13">
-            <a:extLst>
-              <a:ext uri="{FF2B5EF4-FFF2-40B4-BE49-F238E27FC236}">
-                <a16:creationId xmlns:a16="http://schemas.microsoft.com/office/drawing/2014/main" id="{7493AAE1-3A41-2F24-A433-15942ED6887C}"/>
-              </a:ext>
-            </a:extLst>
-          </p:cNvPr>
-          <p:cNvSpPr/>
-          <p:nvPr/>
-        </p:nvSpPr>
-        <p:spPr>
-          <a:xfrm>
-            <a:off x="2389639" y="1108553"/>
-            <a:ext cx="377951" cy="0"/>
-          </a:xfrm>
-          <a:prstGeom prst="line">
-            <a:avLst/>
-          </a:prstGeom>
-          <a:noFill/>
-          <a:ln w="50800">
-            <a:solidFill>
-              <a:srgbClr val="CADCFC"/>
-            </a:solidFill>
-            <a:prstDash val="solid"/>
-            <a:tailEnd type="arrow"/>
-          </a:ln>
-        </p:spPr>
-        <p:txBody>
-          <a:bodyPr/>
-          <a:lstStyle/>
-          <a:p>
-            <a:pPr defTabSz="1219170"/>
-            <a:endParaRPr lang="en-US" sz="2400">
-              <a:solidFill>
-                <a:prstClr val="black"/>
-              </a:solidFill>
-              <a:latin typeface="Calibri" panose="020F0502020204030204"/>
-            </a:endParaRPr>
-          </a:p>
-        </p:txBody>
-      </p:sp>
-      <p:sp>
-        <p:nvSpPr>
-          <p:cNvPr id="2" name="Text 10">
-            <a:extLst>
-              <a:ext uri="{FF2B5EF4-FFF2-40B4-BE49-F238E27FC236}">
-                <a16:creationId xmlns:a16="http://schemas.microsoft.com/office/drawing/2014/main" id="{035CAC2A-78AD-68B9-ED4D-6D53C2E1AA41}"/>
-              </a:ext>
-            </a:extLst>
-          </p:cNvPr>
-          <p:cNvSpPr/>
-          <p:nvPr/>
-        </p:nvSpPr>
-        <p:spPr>
-          <a:xfrm>
-            <a:off x="5648890" y="1278995"/>
-            <a:ext cx="2131078" cy="876298"/>
-          </a:xfrm>
-          <a:prstGeom prst="rect">
-            <a:avLst/>
-          </a:prstGeom>
-          <a:noFill/>
-          <a:ln/>
-        </p:spPr>
-        <p:txBody>
-          <a:bodyPr wrap="square" lIns="33867" tIns="33867" rIns="33867" bIns="33867" rtlCol="0" anchor="t"/>
-          <a:lstStyle/>
-          <a:p>
-            <a:pPr defTabSz="1219170"/>
-            <a:r>
-              <a:rPr lang="en-US" sz="1600" dirty="0">
-                <a:solidFill>
-                  <a:srgbClr val="CADCFC"/>
-                </a:solidFill>
-                <a:latin typeface="Calibri" pitchFamily="34" charset="0"/>
-                <a:ea typeface="Calibri" pitchFamily="34" charset="-122"/>
-                <a:cs typeface="Calibri" pitchFamily="34" charset="-120"/>
-              </a:rPr>
-              <a:t>note dur min · min phrase notes · monophony · watchdog</a:t>
-            </a:r>
-            <a:endParaRPr lang="en-US" sz="1600" dirty="0">
-              <a:solidFill>
-                <a:prstClr val="black"/>
-              </a:solidFill>
-              <a:latin typeface="Calibri" panose="020F0502020204030204"/>
-            </a:endParaRPr>
-          </a:p>
-        </p:txBody>
-      </p:sp>
-      <p:sp>
-        <p:nvSpPr>
-          <p:cNvPr id="13" name="Shape 14">
-            <a:extLst>
-              <a:ext uri="{FF2B5EF4-FFF2-40B4-BE49-F238E27FC236}">
-                <a16:creationId xmlns:a16="http://schemas.microsoft.com/office/drawing/2014/main" id="{7D6019D4-9F06-D4F8-9055-5C0B69571156}"/>
-              </a:ext>
-            </a:extLst>
-          </p:cNvPr>
-          <p:cNvSpPr/>
-          <p:nvPr/>
-        </p:nvSpPr>
-        <p:spPr>
-          <a:xfrm>
-            <a:off x="358153" y="4886419"/>
-            <a:ext cx="2292087" cy="781702"/>
+            <a:off x="9794355" y="4712493"/>
+            <a:ext cx="1600942" cy="1204769"/>
           </a:xfrm>
           <a:prstGeom prst="roundRect">
             <a:avLst>
@@ -10282,10 +10388,10 @@
       </p:sp>
       <p:sp>
         <p:nvSpPr>
-          <p:cNvPr id="14" name="Text 15">
-            <a:extLst>
-              <a:ext uri="{FF2B5EF4-FFF2-40B4-BE49-F238E27FC236}">
-                <a16:creationId xmlns:a16="http://schemas.microsoft.com/office/drawing/2014/main" id="{F402484E-1CC6-34A6-5E23-247659ED013C}"/>
+          <p:cNvPr id="38" name="Text 15">
+            <a:extLst>
+              <a:ext uri="{FF2B5EF4-FFF2-40B4-BE49-F238E27FC236}">
+                <a16:creationId xmlns:a16="http://schemas.microsoft.com/office/drawing/2014/main" id="{352390D4-82FD-4455-952D-F476AA9AA7BF}"/>
               </a:ext>
             </a:extLst>
           </p:cNvPr>
@@ -10294,8 +10400,8 @@
         </p:nvSpPr>
         <p:spPr>
           <a:xfrm>
-            <a:off x="358151" y="4967954"/>
-            <a:ext cx="2292087" cy="353568"/>
+            <a:off x="9657720" y="4794026"/>
+            <a:ext cx="1874213" cy="353568"/>
           </a:xfrm>
           <a:prstGeom prst="rect">
             <a:avLst/>
@@ -10317,7 +10423,7 @@
                 <a:ea typeface="Calibri" pitchFamily="34" charset="-122"/>
                 <a:cs typeface="Calibri" pitchFamily="34" charset="-120"/>
               </a:rPr>
-              <a:t>Proactive Loop</a:t>
+              <a:t>Display</a:t>
             </a:r>
             <a:endParaRPr lang="en-US" sz="2400" dirty="0">
               <a:solidFill>
@@ -10330,10 +10436,10 @@
       </p:sp>
       <p:sp>
         <p:nvSpPr>
-          <p:cNvPr id="31" name="Text 16">
-            <a:extLst>
-              <a:ext uri="{FF2B5EF4-FFF2-40B4-BE49-F238E27FC236}">
-                <a16:creationId xmlns:a16="http://schemas.microsoft.com/office/drawing/2014/main" id="{8093E773-011C-6678-EF78-708CE8296041}"/>
+          <p:cNvPr id="39" name="Text 16">
+            <a:extLst>
+              <a:ext uri="{FF2B5EF4-FFF2-40B4-BE49-F238E27FC236}">
+                <a16:creationId xmlns:a16="http://schemas.microsoft.com/office/drawing/2014/main" id="{EFB27E6D-2224-F7EF-9B39-408E4E2321B9}"/>
               </a:ext>
             </a:extLst>
           </p:cNvPr>
@@ -10342,8 +10448,8 @@
         </p:nvSpPr>
         <p:spPr>
           <a:xfrm>
-            <a:off x="525517" y="5295648"/>
-            <a:ext cx="2124721" cy="293138"/>
+            <a:off x="10053749" y="5204682"/>
+            <a:ext cx="1118266" cy="523546"/>
           </a:xfrm>
           <a:prstGeom prst="rect">
             <a:avLst/>
@@ -10365,7 +10471,7 @@
                 <a:ea typeface="Calibri" pitchFamily="34" charset="-122"/>
                 <a:cs typeface="Calibri" pitchFamily="34" charset="-120"/>
               </a:rPr>
-              <a:t>fires when bass paused</a:t>
+              <a:t>Dashboard · web · OSC</a:t>
             </a:r>
             <a:endParaRPr lang="en-US" sz="1600" dirty="0">
               <a:solidFill>
@@ -10378,10 +10484,10 @@
       </p:sp>
       <p:sp>
         <p:nvSpPr>
-          <p:cNvPr id="35" name="Shape 13">
-            <a:extLst>
-              <a:ext uri="{FF2B5EF4-FFF2-40B4-BE49-F238E27FC236}">
-                <a16:creationId xmlns:a16="http://schemas.microsoft.com/office/drawing/2014/main" id="{FD5AEDBA-8E6D-A402-A41C-3F190A48E5BC}"/>
+          <p:cNvPr id="40" name="Shape 13">
+            <a:extLst>
+              <a:ext uri="{FF2B5EF4-FFF2-40B4-BE49-F238E27FC236}">
+                <a16:creationId xmlns:a16="http://schemas.microsoft.com/office/drawing/2014/main" id="{28421045-6A50-0F48-313C-CC5E248B2CB2}"/>
               </a:ext>
             </a:extLst>
           </p:cNvPr>
@@ -10390,7 +10496,7 @@
         </p:nvSpPr>
         <p:spPr>
           <a:xfrm>
-            <a:off x="2767590" y="5300918"/>
+            <a:off x="9070199" y="5329974"/>
             <a:ext cx="582300" cy="0"/>
           </a:xfrm>
           <a:prstGeom prst="line">
@@ -10421,10 +10527,10 @@
       </p:sp>
       <p:sp>
         <p:nvSpPr>
-          <p:cNvPr id="36" name="Text 10">
-            <a:extLst>
-              <a:ext uri="{FF2B5EF4-FFF2-40B4-BE49-F238E27FC236}">
-                <a16:creationId xmlns:a16="http://schemas.microsoft.com/office/drawing/2014/main" id="{FE21DA54-651E-97F3-FCC2-BDEA980E4775}"/>
+          <p:cNvPr id="41" name="Shape 17">
+            <a:extLst>
+              <a:ext uri="{FF2B5EF4-FFF2-40B4-BE49-F238E27FC236}">
+                <a16:creationId xmlns:a16="http://schemas.microsoft.com/office/drawing/2014/main" id="{78BEAAC7-0D2B-B745-2590-3480E25C69AD}"/>
               </a:ext>
             </a:extLst>
           </p:cNvPr>
@@ -10433,32 +10539,156 @@
         </p:nvSpPr>
         <p:spPr>
           <a:xfrm>
-            <a:off x="2959931" y="1242111"/>
-            <a:ext cx="1892489" cy="876298"/>
-          </a:xfrm>
-          <a:prstGeom prst="rect">
+            <a:off x="3802643" y="2817527"/>
+            <a:ext cx="0" cy="1543454"/>
+          </a:xfrm>
+          <a:prstGeom prst="line">
             <a:avLst/>
           </a:prstGeom>
           <a:noFill/>
-          <a:ln/>
-        </p:spPr>
-        <p:txBody>
-          <a:bodyPr wrap="square" lIns="33867" tIns="33867" rIns="33867" bIns="33867" rtlCol="0" anchor="t"/>
+          <a:ln w="50800">
+            <a:solidFill>
+              <a:srgbClr val="CADCFC"/>
+            </a:solidFill>
+            <a:prstDash val="solid"/>
+            <a:tailEnd type="arrow"/>
+          </a:ln>
+        </p:spPr>
+        <p:txBody>
+          <a:bodyPr/>
           <a:lstStyle/>
           <a:p>
             <a:pPr defTabSz="1219170"/>
-            <a:r>
-              <a:rPr lang="en-US" sz="1600" dirty="0">
-                <a:solidFill>
-                  <a:srgbClr val="CADCFC"/>
-                </a:solidFill>
-                <a:latin typeface="Calibri" pitchFamily="34" charset="0"/>
-                <a:ea typeface="Calibri" pitchFamily="34" charset="-122"/>
-                <a:cs typeface="Calibri" pitchFamily="34" charset="-120"/>
-              </a:rPr>
-              <a:t>pitch range · vel min</a:t>
-            </a:r>
-            <a:endParaRPr lang="en-US" sz="1600" dirty="0">
+            <a:endParaRPr lang="en-US" sz="2400">
+              <a:solidFill>
+                <a:prstClr val="black"/>
+              </a:solidFill>
+              <a:latin typeface="Calibri" panose="020F0502020204030204"/>
+            </a:endParaRPr>
+          </a:p>
+        </p:txBody>
+      </p:sp>
+      <p:sp>
+        <p:nvSpPr>
+          <p:cNvPr id="42" name="Shape 17">
+            <a:extLst>
+              <a:ext uri="{FF2B5EF4-FFF2-40B4-BE49-F238E27FC236}">
+                <a16:creationId xmlns:a16="http://schemas.microsoft.com/office/drawing/2014/main" id="{CB67F83E-D73C-A10F-7608-64C83241BF3F}"/>
+              </a:ext>
+            </a:extLst>
+          </p:cNvPr>
+          <p:cNvSpPr/>
+          <p:nvPr/>
+        </p:nvSpPr>
+        <p:spPr>
+          <a:xfrm>
+            <a:off x="6603650" y="1939632"/>
+            <a:ext cx="0" cy="353568"/>
+          </a:xfrm>
+          <a:prstGeom prst="line">
+            <a:avLst/>
+          </a:prstGeom>
+          <a:noFill/>
+          <a:ln w="50800">
+            <a:solidFill>
+              <a:srgbClr val="CADCFC"/>
+            </a:solidFill>
+            <a:prstDash val="solid"/>
+            <a:tailEnd type="arrow"/>
+          </a:ln>
+        </p:spPr>
+        <p:txBody>
+          <a:bodyPr/>
+          <a:lstStyle/>
+          <a:p>
+            <a:pPr defTabSz="1219170"/>
+            <a:endParaRPr lang="en-US" sz="2400">
+              <a:solidFill>
+                <a:prstClr val="black"/>
+              </a:solidFill>
+              <a:latin typeface="Calibri" panose="020F0502020204030204"/>
+            </a:endParaRPr>
+          </a:p>
+        </p:txBody>
+      </p:sp>
+      <p:sp>
+        <p:nvSpPr>
+          <p:cNvPr id="43" name="Shape 13">
+            <a:extLst>
+              <a:ext uri="{FF2B5EF4-FFF2-40B4-BE49-F238E27FC236}">
+                <a16:creationId xmlns:a16="http://schemas.microsoft.com/office/drawing/2014/main" id="{42578BFA-6C86-5D73-0B4B-8BC48A96B8F6}"/>
+              </a:ext>
+            </a:extLst>
+          </p:cNvPr>
+          <p:cNvSpPr/>
+          <p:nvPr/>
+        </p:nvSpPr>
+        <p:spPr>
+          <a:xfrm>
+            <a:off x="8463350" y="3215879"/>
+            <a:ext cx="377951" cy="0"/>
+          </a:xfrm>
+          <a:prstGeom prst="line">
+            <a:avLst/>
+          </a:prstGeom>
+          <a:noFill/>
+          <a:ln w="50800">
+            <a:solidFill>
+              <a:srgbClr val="CADCFC"/>
+            </a:solidFill>
+            <a:prstDash val="solid"/>
+            <a:tailEnd type="arrow"/>
+          </a:ln>
+        </p:spPr>
+        <p:txBody>
+          <a:bodyPr/>
+          <a:lstStyle/>
+          <a:p>
+            <a:pPr defTabSz="1219170"/>
+            <a:endParaRPr lang="en-US" sz="2400">
+              <a:solidFill>
+                <a:prstClr val="black"/>
+              </a:solidFill>
+              <a:latin typeface="Calibri" panose="020F0502020204030204"/>
+            </a:endParaRPr>
+          </a:p>
+        </p:txBody>
+      </p:sp>
+      <p:sp>
+        <p:nvSpPr>
+          <p:cNvPr id="44" name="Shape 24">
+            <a:extLst>
+              <a:ext uri="{FF2B5EF4-FFF2-40B4-BE49-F238E27FC236}">
+                <a16:creationId xmlns:a16="http://schemas.microsoft.com/office/drawing/2014/main" id="{D519FCAC-D1D8-351F-5F22-865612018EEF}"/>
+              </a:ext>
+            </a:extLst>
+          </p:cNvPr>
+          <p:cNvSpPr/>
+          <p:nvPr/>
+        </p:nvSpPr>
+        <p:spPr>
+          <a:xfrm flipH="1">
+            <a:off x="9057465" y="4070714"/>
+            <a:ext cx="607768" cy="353567"/>
+          </a:xfrm>
+          <a:prstGeom prst="line">
+            <a:avLst/>
+          </a:prstGeom>
+          <a:noFill/>
+          <a:ln w="50800">
+            <a:solidFill>
+              <a:srgbClr val="CADCFC"/>
+            </a:solidFill>
+            <a:prstDash val="solid"/>
+            <a:tailEnd type="arrow"/>
+          </a:ln>
+        </p:spPr>
+        <p:txBody>
+          <a:bodyPr/>
+          <a:lstStyle/>
+          <a:p>
+            <a:pPr defTabSz="1219170"/>
+            <a:endParaRPr lang="en-US" sz="2400">
               <a:solidFill>
                 <a:prstClr val="black"/>
               </a:solidFill>
@@ -10559,7 +10789,219 @@
             </a:avLst>
           </a:prstGeom>
           <a:solidFill>
-            <a:srgbClr val="253880"/>
+            <a:schemeClr val="accent6">
+              <a:lumMod val="50000"/>
+            </a:schemeClr>
+          </a:solidFill>
+          <a:ln w="25400">
+            <a:solidFill>
+              <a:srgbClr val="CADCFC"/>
+            </a:solidFill>
+            <a:prstDash val="dash"/>
+          </a:ln>
+        </p:spPr>
+        <p:txBody>
+          <a:bodyPr/>
+          <a:lstStyle/>
+          <a:p>
+            <a:pPr defTabSz="1219170"/>
+            <a:endParaRPr lang="en-US" sz="3200">
+              <a:solidFill>
+                <a:prstClr val="black"/>
+              </a:solidFill>
+              <a:latin typeface="Calibri" panose="020F0502020204030204"/>
+            </a:endParaRPr>
+          </a:p>
+        </p:txBody>
+      </p:sp>
+      <p:sp>
+        <p:nvSpPr>
+          <p:cNvPr id="5" name="Text 3"/>
+          <p:cNvSpPr/>
+          <p:nvPr/>
+        </p:nvSpPr>
+        <p:spPr>
+          <a:xfrm>
+            <a:off x="2435571" y="419226"/>
+            <a:ext cx="4389120" cy="536448"/>
+          </a:xfrm>
+          <a:prstGeom prst="rect">
+            <a:avLst/>
+          </a:prstGeom>
+          <a:noFill/>
+          <a:ln/>
+        </p:spPr>
+        <p:txBody>
+          <a:bodyPr wrap="square" lIns="67733" tIns="67733" rIns="67733" bIns="67733" rtlCol="0" anchor="ctr"/>
+          <a:lstStyle/>
+          <a:p>
+            <a:pPr algn="ctr" defTabSz="1219170"/>
+            <a:r>
+              <a:rPr lang="en-US" sz="2400" b="1" dirty="0" err="1">
+                <a:solidFill>
+                  <a:srgbClr val="FFFFFF"/>
+                </a:solidFill>
+                <a:latin typeface="Calibri" pitchFamily="34" charset="0"/>
+                <a:ea typeface="Calibri" pitchFamily="34" charset="-122"/>
+                <a:cs typeface="Calibri" pitchFamily="34" charset="-120"/>
+              </a:rPr>
+              <a:t>ArcController</a:t>
+            </a:r>
+            <a:endParaRPr lang="en-US" sz="2400" dirty="0">
+              <a:solidFill>
+                <a:prstClr val="black"/>
+              </a:solidFill>
+              <a:latin typeface="Calibri" panose="020F0502020204030204"/>
+            </a:endParaRPr>
+          </a:p>
+        </p:txBody>
+      </p:sp>
+      <p:sp>
+        <p:nvSpPr>
+          <p:cNvPr id="6" name="Shape 4"/>
+          <p:cNvSpPr/>
+          <p:nvPr/>
+        </p:nvSpPr>
+        <p:spPr>
+          <a:xfrm>
+            <a:off x="2419935" y="1505989"/>
+            <a:ext cx="4420393" cy="717212"/>
+          </a:xfrm>
+          <a:prstGeom prst="roundRect">
+            <a:avLst>
+              <a:gd name="adj" fmla="val 15385"/>
+            </a:avLst>
+          </a:prstGeom>
+          <a:solidFill>
+            <a:schemeClr val="accent6">
+              <a:lumMod val="50000"/>
+            </a:schemeClr>
+          </a:solidFill>
+          <a:ln w="19050">
+            <a:solidFill>
+              <a:srgbClr val="CADCFC"/>
+            </a:solidFill>
+            <a:prstDash val="solid"/>
+          </a:ln>
+        </p:spPr>
+        <p:txBody>
+          <a:bodyPr/>
+          <a:lstStyle/>
+          <a:p>
+            <a:pPr defTabSz="1219170"/>
+            <a:endParaRPr lang="en-US" sz="3200">
+              <a:solidFill>
+                <a:prstClr val="black"/>
+              </a:solidFill>
+              <a:latin typeface="Calibri" panose="020F0502020204030204"/>
+            </a:endParaRPr>
+          </a:p>
+        </p:txBody>
+      </p:sp>
+      <p:sp>
+        <p:nvSpPr>
+          <p:cNvPr id="7" name="Text 5"/>
+          <p:cNvSpPr/>
+          <p:nvPr/>
+        </p:nvSpPr>
+        <p:spPr>
+          <a:xfrm>
+            <a:off x="2862291" y="1589216"/>
+            <a:ext cx="3535680" cy="316992"/>
+          </a:xfrm>
+          <a:prstGeom prst="rect">
+            <a:avLst/>
+          </a:prstGeom>
+          <a:noFill/>
+          <a:ln/>
+        </p:spPr>
+        <p:txBody>
+          <a:bodyPr wrap="square" lIns="0" tIns="0" rIns="0" bIns="0" rtlCol="0" anchor="ctr"/>
+          <a:lstStyle/>
+          <a:p>
+            <a:pPr algn="ctr" defTabSz="1219170"/>
+            <a:r>
+              <a:rPr lang="en-US" sz="2400" b="1" dirty="0">
+                <a:solidFill>
+                  <a:srgbClr val="FFFFFF"/>
+                </a:solidFill>
+                <a:latin typeface="Calibri" pitchFamily="34" charset="0"/>
+                <a:ea typeface="Calibri" pitchFamily="34" charset="-122"/>
+                <a:cs typeface="Calibri" pitchFamily="34" charset="-120"/>
+              </a:rPr>
+              <a:t>HarmonyController</a:t>
+            </a:r>
+            <a:endParaRPr lang="en-US" sz="2400" dirty="0">
+              <a:solidFill>
+                <a:prstClr val="black"/>
+              </a:solidFill>
+              <a:latin typeface="Calibri" panose="020F0502020204030204"/>
+            </a:endParaRPr>
+          </a:p>
+        </p:txBody>
+      </p:sp>
+      <p:sp>
+        <p:nvSpPr>
+          <p:cNvPr id="8" name="Text 6"/>
+          <p:cNvSpPr/>
+          <p:nvPr/>
+        </p:nvSpPr>
+        <p:spPr>
+          <a:xfrm>
+            <a:off x="2536290" y="1895169"/>
+            <a:ext cx="4187683" cy="268224"/>
+          </a:xfrm>
+          <a:prstGeom prst="rect">
+            <a:avLst/>
+          </a:prstGeom>
+          <a:noFill/>
+          <a:ln/>
+        </p:spPr>
+        <p:txBody>
+          <a:bodyPr wrap="square" lIns="33867" tIns="33867" rIns="33867" bIns="33867" rtlCol="0" anchor="t"/>
+          <a:lstStyle/>
+          <a:p>
+            <a:pPr algn="ctr" defTabSz="1219170"/>
+            <a:r>
+              <a:rPr lang="en-US" sz="1600" dirty="0">
+                <a:solidFill>
+                  <a:srgbClr val="CADCFC"/>
+                </a:solidFill>
+                <a:latin typeface="Calibri" pitchFamily="34" charset="0"/>
+                <a:ea typeface="Calibri" pitchFamily="34" charset="-122"/>
+                <a:cs typeface="Calibri" pitchFamily="34" charset="-120"/>
+              </a:rPr>
+              <a:t>modal · progression · pedal · tritone substitution</a:t>
+            </a:r>
+            <a:endParaRPr lang="en-US" sz="1600" dirty="0">
+              <a:solidFill>
+                <a:prstClr val="black"/>
+              </a:solidFill>
+              <a:latin typeface="Calibri" panose="020F0502020204030204"/>
+            </a:endParaRPr>
+          </a:p>
+        </p:txBody>
+      </p:sp>
+      <p:sp>
+        <p:nvSpPr>
+          <p:cNvPr id="10" name="Shape 8"/>
+          <p:cNvSpPr/>
+          <p:nvPr/>
+        </p:nvSpPr>
+        <p:spPr>
+          <a:xfrm>
+            <a:off x="1385103" y="2703894"/>
+            <a:ext cx="6490056" cy="1786648"/>
+          </a:xfrm>
+          <a:prstGeom prst="roundRect">
+            <a:avLst>
+              <a:gd name="adj" fmla="val 6780"/>
+            </a:avLst>
+          </a:prstGeom>
+          <a:solidFill>
+            <a:schemeClr val="accent6">
+              <a:lumMod val="50000"/>
+            </a:schemeClr>
           </a:solidFill>
           <a:ln w="25400">
             <a:solidFill>
@@ -10584,14 +11026,14 @@
       </p:sp>
       <p:sp>
         <p:nvSpPr>
-          <p:cNvPr id="5" name="Text 3"/>
+          <p:cNvPr id="11" name="Text 9"/>
           <p:cNvSpPr/>
           <p:nvPr/>
         </p:nvSpPr>
         <p:spPr>
           <a:xfrm>
-            <a:off x="2435571" y="419226"/>
-            <a:ext cx="4389120" cy="536448"/>
+            <a:off x="1437442" y="2772269"/>
+            <a:ext cx="6385378" cy="316992"/>
           </a:xfrm>
           <a:prstGeom prst="rect">
             <a:avLst/>
@@ -10600,7 +11042,7 @@
           <a:ln/>
         </p:spPr>
         <p:txBody>
-          <a:bodyPr wrap="square" lIns="67733" tIns="67733" rIns="67733" bIns="67733" rtlCol="0" anchor="ctr"/>
+          <a:bodyPr wrap="square" lIns="0" tIns="0" rIns="0" bIns="0" rtlCol="0" anchor="ctr"/>
           <a:lstStyle/>
           <a:p>
             <a:pPr algn="ctr" defTabSz="1219170"/>
@@ -10613,7 +11055,7 @@
                 <a:ea typeface="Calibri" pitchFamily="34" charset="-122"/>
                 <a:cs typeface="Calibri" pitchFamily="34" charset="-120"/>
               </a:rPr>
-              <a:t>ArcController</a:t>
+              <a:t>PhraseGenerator</a:t>
             </a:r>
             <a:endParaRPr lang="en-US" sz="2400" dirty="0">
               <a:solidFill>
@@ -10626,18 +11068,83 @@
       </p:sp>
       <p:sp>
         <p:nvSpPr>
-          <p:cNvPr id="6" name="Shape 4"/>
+          <p:cNvPr id="12" name="Text 10"/>
           <p:cNvSpPr/>
           <p:nvPr/>
         </p:nvSpPr>
         <p:spPr>
           <a:xfrm>
-            <a:off x="2419935" y="1558539"/>
-            <a:ext cx="4420393" cy="717212"/>
+            <a:off x="1580383" y="3121305"/>
+            <a:ext cx="6242437" cy="1279645"/>
+          </a:xfrm>
+          <a:prstGeom prst="rect">
+            <a:avLst/>
+          </a:prstGeom>
+          <a:noFill/>
+          <a:ln/>
+        </p:spPr>
+        <p:txBody>
+          <a:bodyPr wrap="square" lIns="33867" tIns="33867" rIns="33867" bIns="33867" rtlCol="0" anchor="t"/>
+          <a:lstStyle/>
+          <a:p>
+            <a:pPr defTabSz="1219170"/>
+            <a:r>
+              <a:rPr lang="en-US" sz="1600" dirty="0">
+                <a:solidFill>
+                  <a:srgbClr val="CADCFC"/>
+                </a:solidFill>
+                <a:latin typeface="Calibri" pitchFamily="34" charset="0"/>
+                <a:ea typeface="Calibri" pitchFamily="34" charset="-122"/>
+                <a:cs typeface="Calibri" pitchFamily="34" charset="-120"/>
+              </a:rPr>
+              <a:t>LSTM · chord conditioning  · pitch range limits · register gravity · </a:t>
+            </a:r>
+            <a:endParaRPr lang="en-US" sz="1600" dirty="0">
+              <a:solidFill>
+                <a:prstClr val="black"/>
+              </a:solidFill>
+              <a:latin typeface="Calibri" panose="020F0502020204030204"/>
+            </a:endParaRPr>
+          </a:p>
+          <a:p>
+            <a:pPr defTabSz="1219170"/>
+            <a:r>
+              <a:rPr lang="en-US" sz="1600" dirty="0">
+                <a:solidFill>
+                  <a:srgbClr val="CADCFC"/>
+                </a:solidFill>
+                <a:latin typeface="Calibri" pitchFamily="34" charset="0"/>
+                <a:ea typeface="Calibri" pitchFamily="34" charset="-122"/>
+                <a:cs typeface="Calibri" pitchFamily="34" charset="-120"/>
+              </a:rPr>
+              <a:t>register contrast  ·  scale pitch bias  ·  contour steering · swing/triplet bias · energy arc shaping · long-note penalty · singable duration bias  ·  motivic development · voice leading  ·  modal leap · bonus (P4/P5)  ·  repetition penalty · rest injection  ·  beat accumulator · rhythmic displacement</a:t>
+            </a:r>
+          </a:p>
+          <a:p>
+            <a:pPr defTabSz="1219170"/>
+            <a:endParaRPr lang="en-US" sz="1600" dirty="0">
+              <a:solidFill>
+                <a:prstClr val="black"/>
+              </a:solidFill>
+              <a:latin typeface="Calibri" panose="020F0502020204030204"/>
+            </a:endParaRPr>
+          </a:p>
+        </p:txBody>
+      </p:sp>
+      <p:sp>
+        <p:nvSpPr>
+          <p:cNvPr id="14" name="Shape 12"/>
+          <p:cNvSpPr/>
+          <p:nvPr/>
+        </p:nvSpPr>
+        <p:spPr>
+          <a:xfrm>
+            <a:off x="1672952" y="5162267"/>
+            <a:ext cx="2129360" cy="1114235"/>
           </a:xfrm>
           <a:prstGeom prst="roundRect">
             <a:avLst>
-              <a:gd name="adj" fmla="val 15385"/>
+              <a:gd name="adj" fmla="val 12308"/>
             </a:avLst>
           </a:prstGeom>
           <a:solidFill>
@@ -10647,7 +11154,7 @@
             <a:solidFill>
               <a:srgbClr val="CADCFC"/>
             </a:solidFill>
-            <a:prstDash val="solid"/>
+            <a:prstDash val="dash"/>
           </a:ln>
         </p:spPr>
         <p:txBody>
@@ -10666,14 +11173,14 @@
       </p:sp>
       <p:sp>
         <p:nvSpPr>
-          <p:cNvPr id="7" name="Text 5"/>
+          <p:cNvPr id="15" name="Text 13"/>
           <p:cNvSpPr/>
           <p:nvPr/>
         </p:nvSpPr>
         <p:spPr>
           <a:xfrm>
-            <a:off x="2862291" y="1641766"/>
-            <a:ext cx="3535680" cy="316992"/>
+            <a:off x="1466748" y="5256840"/>
+            <a:ext cx="2560320" cy="316992"/>
           </a:xfrm>
           <a:prstGeom prst="rect">
             <a:avLst/>
@@ -10695,7 +11202,7 @@
                 <a:ea typeface="Calibri" pitchFamily="34" charset="-122"/>
                 <a:cs typeface="Calibri" pitchFamily="34" charset="-120"/>
               </a:rPr>
-              <a:t>HarmonyController</a:t>
+              <a:t>PhraseMemory</a:t>
             </a:r>
             <a:endParaRPr lang="en-US" sz="2400" dirty="0">
               <a:solidFill>
@@ -10708,14 +11215,14 @@
       </p:sp>
       <p:sp>
         <p:nvSpPr>
-          <p:cNvPr id="8" name="Text 6"/>
+          <p:cNvPr id="16" name="Text 14"/>
           <p:cNvSpPr/>
           <p:nvPr/>
         </p:nvSpPr>
         <p:spPr>
           <a:xfrm>
-            <a:off x="2536290" y="1947719"/>
-            <a:ext cx="4187683" cy="268224"/>
+            <a:off x="2079454" y="5622600"/>
+            <a:ext cx="1405880" cy="560832"/>
           </a:xfrm>
           <a:prstGeom prst="rect">
             <a:avLst/>
@@ -10727,7 +11234,7 @@
           <a:bodyPr wrap="square" lIns="33867" tIns="33867" rIns="33867" bIns="33867" rtlCol="0" anchor="t"/>
           <a:lstStyle/>
           <a:p>
-            <a:pPr algn="ctr" defTabSz="1219170"/>
+            <a:pPr defTabSz="1219170"/>
             <a:r>
               <a:rPr lang="en-US" sz="1600" dirty="0">
                 <a:solidFill>
@@ -10737,7 +11244,7 @@
                 <a:ea typeface="Calibri" pitchFamily="34" charset="-122"/>
                 <a:cs typeface="Calibri" pitchFamily="34" charset="-120"/>
               </a:rPr>
-              <a:t>mode · progression · pedal · tritone substitution</a:t>
+              <a:t>motifs · recall · </a:t>
             </a:r>
             <a:endParaRPr lang="en-US" sz="1600" dirty="0">
               <a:solidFill>
@@ -10746,110 +11253,6 @@
               <a:latin typeface="Calibri" panose="020F0502020204030204"/>
             </a:endParaRPr>
           </a:p>
-        </p:txBody>
-      </p:sp>
-      <p:sp>
-        <p:nvSpPr>
-          <p:cNvPr id="10" name="Shape 8"/>
-          <p:cNvSpPr/>
-          <p:nvPr/>
-        </p:nvSpPr>
-        <p:spPr>
-          <a:xfrm>
-            <a:off x="1385103" y="2703894"/>
-            <a:ext cx="6490056" cy="1786648"/>
-          </a:xfrm>
-          <a:prstGeom prst="roundRect">
-            <a:avLst>
-              <a:gd name="adj" fmla="val 6780"/>
-            </a:avLst>
-          </a:prstGeom>
-          <a:solidFill>
-            <a:srgbClr val="253880"/>
-          </a:solidFill>
-          <a:ln w="25400">
-            <a:solidFill>
-              <a:srgbClr val="CADCFC"/>
-            </a:solidFill>
-            <a:prstDash val="solid"/>
-          </a:ln>
-        </p:spPr>
-        <p:txBody>
-          <a:bodyPr/>
-          <a:lstStyle/>
-          <a:p>
-            <a:pPr defTabSz="1219170"/>
-            <a:endParaRPr lang="en-US" sz="3200">
-              <a:solidFill>
-                <a:prstClr val="black"/>
-              </a:solidFill>
-              <a:latin typeface="Calibri" panose="020F0502020204030204"/>
-            </a:endParaRPr>
-          </a:p>
-        </p:txBody>
-      </p:sp>
-      <p:sp>
-        <p:nvSpPr>
-          <p:cNvPr id="11" name="Text 9"/>
-          <p:cNvSpPr/>
-          <p:nvPr/>
-        </p:nvSpPr>
-        <p:spPr>
-          <a:xfrm>
-            <a:off x="1437442" y="2772269"/>
-            <a:ext cx="6385378" cy="316992"/>
-          </a:xfrm>
-          <a:prstGeom prst="rect">
-            <a:avLst/>
-          </a:prstGeom>
-          <a:noFill/>
-          <a:ln/>
-        </p:spPr>
-        <p:txBody>
-          <a:bodyPr wrap="square" lIns="0" tIns="0" rIns="0" bIns="0" rtlCol="0" anchor="ctr"/>
-          <a:lstStyle/>
-          <a:p>
-            <a:pPr algn="ctr" defTabSz="1219170"/>
-            <a:r>
-              <a:rPr lang="en-US" sz="2400" b="1" dirty="0">
-                <a:solidFill>
-                  <a:srgbClr val="FFFFFF"/>
-                </a:solidFill>
-                <a:latin typeface="Calibri" pitchFamily="34" charset="0"/>
-                <a:ea typeface="Calibri" pitchFamily="34" charset="-122"/>
-                <a:cs typeface="Calibri" pitchFamily="34" charset="-120"/>
-              </a:rPr>
-              <a:t>PhraseGenerator (LSTM)</a:t>
-            </a:r>
-            <a:endParaRPr lang="en-US" sz="2400" dirty="0">
-              <a:solidFill>
-                <a:prstClr val="black"/>
-              </a:solidFill>
-              <a:latin typeface="Calibri" panose="020F0502020204030204"/>
-            </a:endParaRPr>
-          </a:p>
-        </p:txBody>
-      </p:sp>
-      <p:sp>
-        <p:nvSpPr>
-          <p:cNvPr id="12" name="Text 10"/>
-          <p:cNvSpPr/>
-          <p:nvPr/>
-        </p:nvSpPr>
-        <p:spPr>
-          <a:xfrm>
-            <a:off x="1580383" y="3121305"/>
-            <a:ext cx="6242437" cy="1279645"/>
-          </a:xfrm>
-          <a:prstGeom prst="rect">
-            <a:avLst/>
-          </a:prstGeom>
-          <a:noFill/>
-          <a:ln/>
-        </p:spPr>
-        <p:txBody>
-          <a:bodyPr wrap="square" lIns="33867" tIns="33867" rIns="33867" bIns="33867" rtlCol="0" anchor="t"/>
-          <a:lstStyle/>
           <a:p>
             <a:pPr defTabSz="1219170"/>
             <a:r>
@@ -10861,7 +11264,7 @@
                 <a:ea typeface="Calibri" pitchFamily="34" charset="-122"/>
                 <a:cs typeface="Calibri" pitchFamily="34" charset="-120"/>
               </a:rPr>
-              <a:t>LSTM · chord conditioning  · pitch range limits · register gravity · </a:t>
+              <a:t>self-play seed</a:t>
             </a:r>
             <a:endParaRPr lang="en-US" sz="1600" dirty="0">
               <a:solidFill>
@@ -10870,41 +11273,18 @@
               <a:latin typeface="Calibri" panose="020F0502020204030204"/>
             </a:endParaRPr>
           </a:p>
-          <a:p>
-            <a:pPr defTabSz="1219170"/>
-            <a:r>
-              <a:rPr lang="en-US" sz="1600" dirty="0">
-                <a:solidFill>
-                  <a:srgbClr val="CADCFC"/>
-                </a:solidFill>
-                <a:latin typeface="Calibri" pitchFamily="34" charset="0"/>
-                <a:ea typeface="Calibri" pitchFamily="34" charset="-122"/>
-                <a:cs typeface="Calibri" pitchFamily="34" charset="-120"/>
-              </a:rPr>
-              <a:t>register contrast  ·  scale pitch bias  ·  contour steering · swing/triplet bias · energy arc shaping · long-note penalty · singable duration bias  ·  motivic development · voice leading  ·  modal leap · bonus (P4/P5)  ·  repetition penalty · rest injection  ·  beat accumulator · rhythmic displacement</a:t>
-            </a:r>
-          </a:p>
-          <a:p>
-            <a:pPr defTabSz="1219170"/>
-            <a:endParaRPr lang="en-US" sz="1600" dirty="0">
-              <a:solidFill>
-                <a:prstClr val="black"/>
-              </a:solidFill>
-              <a:latin typeface="Calibri" panose="020F0502020204030204"/>
-            </a:endParaRPr>
-          </a:p>
-        </p:txBody>
-      </p:sp>
-      <p:sp>
-        <p:nvSpPr>
-          <p:cNvPr id="14" name="Shape 12"/>
+        </p:txBody>
+      </p:sp>
+      <p:sp>
+        <p:nvSpPr>
+          <p:cNvPr id="17" name="Shape 15"/>
           <p:cNvSpPr/>
           <p:nvPr/>
         </p:nvSpPr>
         <p:spPr>
           <a:xfrm>
-            <a:off x="644533" y="5009047"/>
-            <a:ext cx="2129360" cy="1114235"/>
+            <a:off x="8880852" y="3037885"/>
+            <a:ext cx="2183191" cy="1193225"/>
           </a:xfrm>
           <a:prstGeom prst="roundRect">
             <a:avLst>
@@ -10937,14 +11317,14 @@
       </p:sp>
       <p:sp>
         <p:nvSpPr>
-          <p:cNvPr id="15" name="Text 13"/>
+          <p:cNvPr id="18" name="Text 16"/>
           <p:cNvSpPr/>
           <p:nvPr/>
         </p:nvSpPr>
         <p:spPr>
           <a:xfrm>
-            <a:off x="438329" y="5103620"/>
-            <a:ext cx="2560320" cy="316992"/>
+            <a:off x="8880853" y="3167600"/>
+            <a:ext cx="2102332" cy="316992"/>
           </a:xfrm>
           <a:prstGeom prst="rect">
             <a:avLst/>
@@ -10966,7 +11346,7 @@
                 <a:ea typeface="Calibri" pitchFamily="34" charset="-122"/>
                 <a:cs typeface="Calibri" pitchFamily="34" charset="-120"/>
               </a:rPr>
-              <a:t>PhraseMemory</a:t>
+              <a:t>LSTM</a:t>
             </a:r>
             <a:endParaRPr lang="en-US" sz="2400" dirty="0">
               <a:solidFill>
@@ -10979,14 +11359,14 @@
       </p:sp>
       <p:sp>
         <p:nvSpPr>
-          <p:cNvPr id="16" name="Text 14"/>
+          <p:cNvPr id="19" name="Text 17"/>
           <p:cNvSpPr/>
           <p:nvPr/>
         </p:nvSpPr>
         <p:spPr>
           <a:xfrm>
-            <a:off x="1051035" y="5469380"/>
-            <a:ext cx="1405880" cy="560832"/>
+            <a:off x="9077649" y="3623987"/>
+            <a:ext cx="1938984" cy="426720"/>
           </a:xfrm>
           <a:prstGeom prst="rect">
             <a:avLst/>
@@ -11008,18 +11388,9 @@
                 <a:ea typeface="Calibri" pitchFamily="34" charset="-122"/>
                 <a:cs typeface="Calibri" pitchFamily="34" charset="-120"/>
               </a:rPr>
-              <a:t>motifs · recall · </a:t>
-            </a:r>
-            <a:endParaRPr lang="en-US" sz="1600" dirty="0">
-              <a:solidFill>
-                <a:prstClr val="black"/>
-              </a:solidFill>
-              <a:latin typeface="Calibri" panose="020F0502020204030204"/>
-            </a:endParaRPr>
-          </a:p>
-          <a:p>
-            <a:pPr defTabSz="1219170"/>
-            <a:r>
+              <a:t>WJD sax solos · </a:t>
+            </a:r>
+            <a:br>
               <a:rPr lang="en-US" sz="1600" dirty="0">
                 <a:solidFill>
                   <a:srgbClr val="CADCFC"/>
@@ -11028,7 +11399,17 @@
                 <a:ea typeface="Calibri" pitchFamily="34" charset="-122"/>
                 <a:cs typeface="Calibri" pitchFamily="34" charset="-120"/>
               </a:rPr>
-              <a:t>self-play seed</a:t>
+            </a:br>
+            <a:r>
+              <a:rPr lang="en-US" sz="1600" dirty="0">
+                <a:solidFill>
+                  <a:srgbClr val="CADCFC"/>
+                </a:solidFill>
+                <a:latin typeface="Calibri" pitchFamily="34" charset="0"/>
+                <a:ea typeface="Calibri" pitchFamily="34" charset="-122"/>
+                <a:cs typeface="Calibri" pitchFamily="34" charset="-120"/>
+              </a:rPr>
+              <a:t>49-token chord vocab</a:t>
             </a:r>
             <a:endParaRPr lang="en-US" sz="1600" dirty="0">
               <a:solidFill>
@@ -11041,22 +11422,24 @@
       </p:sp>
       <p:sp>
         <p:nvSpPr>
-          <p:cNvPr id="17" name="Shape 15"/>
+          <p:cNvPr id="23" name="Shape 21"/>
           <p:cNvSpPr/>
           <p:nvPr/>
         </p:nvSpPr>
         <p:spPr>
           <a:xfrm>
-            <a:off x="3310872" y="4998446"/>
-            <a:ext cx="3291840" cy="1193225"/>
+            <a:off x="4694245" y="5162267"/>
+            <a:ext cx="2316480" cy="998153"/>
           </a:xfrm>
           <a:prstGeom prst="roundRect">
             <a:avLst>
-              <a:gd name="adj" fmla="val 12308"/>
+              <a:gd name="adj" fmla="val 17391"/>
             </a:avLst>
           </a:prstGeom>
           <a:solidFill>
-            <a:srgbClr val="2A3570"/>
+            <a:schemeClr val="accent6">
+              <a:lumMod val="50000"/>
+            </a:schemeClr>
           </a:solidFill>
           <a:ln w="19050">
             <a:solidFill>
@@ -11081,14 +11464,14 @@
       </p:sp>
       <p:sp>
         <p:nvSpPr>
-          <p:cNvPr id="18" name="Text 16"/>
+          <p:cNvPr id="24" name="Text 22"/>
           <p:cNvSpPr/>
           <p:nvPr/>
         </p:nvSpPr>
         <p:spPr>
           <a:xfrm>
-            <a:off x="3371832" y="5257876"/>
-            <a:ext cx="3169920" cy="316992"/>
+            <a:off x="4755205" y="5256839"/>
+            <a:ext cx="2194560" cy="316992"/>
           </a:xfrm>
           <a:prstGeom prst="rect">
             <a:avLst/>
@@ -11110,29 +11493,7 @@
                 <a:ea typeface="Calibri" pitchFamily="34" charset="-122"/>
                 <a:cs typeface="Calibri" pitchFamily="34" charset="-120"/>
               </a:rPr>
-              <a:t>WebAudienceDisplay / </a:t>
-            </a:r>
-            <a:r>
-              <a:rPr lang="en-US" sz="2400" b="1" dirty="0" err="1">
-                <a:solidFill>
-                  <a:srgbClr val="FFFFFF"/>
-                </a:solidFill>
-                <a:latin typeface="Calibri" pitchFamily="34" charset="0"/>
-                <a:ea typeface="Calibri" pitchFamily="34" charset="-122"/>
-                <a:cs typeface="Calibri" pitchFamily="34" charset="-120"/>
-              </a:rPr>
-              <a:t>OscOutput</a:t>
-            </a:r>
-            <a:r>
-              <a:rPr lang="en-US" sz="2400" b="1" dirty="0">
-                <a:solidFill>
-                  <a:srgbClr val="FFFFFF"/>
-                </a:solidFill>
-                <a:latin typeface="Calibri" pitchFamily="34" charset="0"/>
-                <a:ea typeface="Calibri" pitchFamily="34" charset="-122"/>
-                <a:cs typeface="Calibri" pitchFamily="34" charset="-120"/>
-              </a:rPr>
-              <a:t> / Dashboard</a:t>
+              <a:t>MidiOutput</a:t>
             </a:r>
             <a:endParaRPr lang="en-US" sz="2400" dirty="0">
               <a:solidFill>
@@ -11145,14 +11506,14 @@
       </p:sp>
       <p:sp>
         <p:nvSpPr>
-          <p:cNvPr id="19" name="Text 17"/>
+          <p:cNvPr id="25" name="Text 23"/>
           <p:cNvSpPr/>
           <p:nvPr/>
         </p:nvSpPr>
         <p:spPr>
           <a:xfrm>
-            <a:off x="3495872" y="5785095"/>
-            <a:ext cx="2921840" cy="426720"/>
+            <a:off x="5029622" y="5581034"/>
+            <a:ext cx="1886818" cy="579386"/>
           </a:xfrm>
           <a:prstGeom prst="rect">
             <a:avLst/>
@@ -11174,7 +11535,7 @@
                 <a:ea typeface="Calibri" pitchFamily="34" charset="-122"/>
                 <a:cs typeface="Calibri" pitchFamily="34" charset="-120"/>
               </a:rPr>
-              <a:t>always sees full intended phrase</a:t>
+              <a:t>energy arc · peak accent · end taper</a:t>
             </a:r>
             <a:endParaRPr lang="en-US" sz="1600" dirty="0">
               <a:solidFill>
@@ -11187,284 +11548,13 @@
       </p:sp>
       <p:sp>
         <p:nvSpPr>
-          <p:cNvPr id="20" name="Shape 18"/>
-          <p:cNvSpPr/>
-          <p:nvPr/>
-        </p:nvSpPr>
-        <p:spPr>
-          <a:xfrm>
-            <a:off x="8700962" y="2360827"/>
-            <a:ext cx="2316480" cy="1598485"/>
-          </a:xfrm>
-          <a:prstGeom prst="roundRect">
-            <a:avLst>
-              <a:gd name="adj" fmla="val 12308"/>
-            </a:avLst>
-          </a:prstGeom>
-          <a:solidFill>
-            <a:srgbClr val="2A3570"/>
-          </a:solidFill>
-          <a:ln w="19050">
-            <a:solidFill>
-              <a:srgbClr val="CADCFC"/>
-            </a:solidFill>
-            <a:prstDash val="solid"/>
-          </a:ln>
-        </p:spPr>
-        <p:txBody>
-          <a:bodyPr/>
-          <a:lstStyle/>
-          <a:p>
-            <a:pPr defTabSz="1219170"/>
-            <a:endParaRPr lang="en-US" sz="3200">
-              <a:solidFill>
-                <a:prstClr val="black"/>
-              </a:solidFill>
-              <a:latin typeface="Calibri" panose="020F0502020204030204"/>
-            </a:endParaRPr>
-          </a:p>
-        </p:txBody>
-      </p:sp>
-      <p:sp>
-        <p:nvSpPr>
-          <p:cNvPr id="21" name="Text 19"/>
-          <p:cNvSpPr/>
-          <p:nvPr/>
-        </p:nvSpPr>
-        <p:spPr>
-          <a:xfrm>
-            <a:off x="8761922" y="2550995"/>
-            <a:ext cx="2194560" cy="488042"/>
-          </a:xfrm>
-          <a:prstGeom prst="rect">
-            <a:avLst/>
-          </a:prstGeom>
-          <a:noFill/>
-          <a:ln/>
-        </p:spPr>
-        <p:txBody>
-          <a:bodyPr wrap="square" lIns="0" tIns="0" rIns="0" bIns="0" rtlCol="0" anchor="ctr"/>
-          <a:lstStyle/>
-          <a:p>
-            <a:pPr algn="ctr" defTabSz="1219170"/>
-            <a:r>
-              <a:rPr lang="en-US" sz="2400" b="1" dirty="0">
-                <a:solidFill>
-                  <a:srgbClr val="FFFFFF"/>
-                </a:solidFill>
-                <a:latin typeface="Calibri" pitchFamily="34" charset="0"/>
-                <a:ea typeface="Calibri" pitchFamily="34" charset="-122"/>
-                <a:cs typeface="Calibri" pitchFamily="34" charset="-120"/>
-              </a:rPr>
-              <a:t>Performance thinning</a:t>
-            </a:r>
-            <a:endParaRPr lang="en-US" sz="2400" dirty="0">
-              <a:solidFill>
-                <a:prstClr val="black"/>
-              </a:solidFill>
-              <a:latin typeface="Calibri" panose="020F0502020204030204"/>
-            </a:endParaRPr>
-          </a:p>
-        </p:txBody>
-      </p:sp>
-      <p:sp>
-        <p:nvSpPr>
-          <p:cNvPr id="22" name="Text 20"/>
-          <p:cNvSpPr/>
-          <p:nvPr/>
-        </p:nvSpPr>
-        <p:spPr>
-          <a:xfrm>
-            <a:off x="8916298" y="3117885"/>
-            <a:ext cx="2000358" cy="779017"/>
-          </a:xfrm>
-          <a:prstGeom prst="rect">
-            <a:avLst/>
-          </a:prstGeom>
-          <a:noFill/>
-          <a:ln/>
-        </p:spPr>
-        <p:txBody>
-          <a:bodyPr wrap="square" lIns="33867" tIns="33867" rIns="33867" bIns="33867" rtlCol="0" anchor="t"/>
-          <a:lstStyle/>
-          <a:p>
-            <a:pPr defTabSz="1219170"/>
-            <a:r>
-              <a:rPr lang="en-US" sz="1600" dirty="0">
-                <a:solidFill>
-                  <a:srgbClr val="CADCFC"/>
-                </a:solidFill>
-                <a:latin typeface="Calibri" pitchFamily="34" charset="0"/>
-                <a:ea typeface="Calibri" pitchFamily="34" charset="-122"/>
-                <a:cs typeface="Calibri" pitchFamily="34" charset="-120"/>
-              </a:rPr>
-              <a:t>short notes dropped</a:t>
-            </a:r>
-            <a:endParaRPr lang="en-US" sz="1600" dirty="0">
-              <a:solidFill>
-                <a:prstClr val="black"/>
-              </a:solidFill>
-              <a:latin typeface="Calibri" panose="020F0502020204030204"/>
-            </a:endParaRPr>
-          </a:p>
-          <a:p>
-            <a:pPr defTabSz="1219170"/>
-            <a:r>
-              <a:rPr lang="en-US" sz="1600" dirty="0">
-                <a:solidFill>
-                  <a:srgbClr val="CADCFC"/>
-                </a:solidFill>
-                <a:latin typeface="Calibri" pitchFamily="34" charset="0"/>
-                <a:ea typeface="Calibri" pitchFamily="34" charset="-122"/>
-                <a:cs typeface="Calibri" pitchFamily="34" charset="-120"/>
-              </a:rPr>
-              <a:t>stochastically · velocity jitter on sax riff replays</a:t>
-            </a:r>
-          </a:p>
-          <a:p>
-            <a:pPr defTabSz="1219170"/>
-            <a:endParaRPr lang="en-US" sz="1600" dirty="0">
-              <a:solidFill>
-                <a:prstClr val="black"/>
-              </a:solidFill>
-              <a:latin typeface="Calibri" panose="020F0502020204030204"/>
-            </a:endParaRPr>
-          </a:p>
-        </p:txBody>
-      </p:sp>
-      <p:sp>
-        <p:nvSpPr>
-          <p:cNvPr id="23" name="Shape 21"/>
-          <p:cNvSpPr/>
-          <p:nvPr/>
-        </p:nvSpPr>
-        <p:spPr>
-          <a:xfrm>
-            <a:off x="8700962" y="4451332"/>
-            <a:ext cx="2316480" cy="998153"/>
-          </a:xfrm>
-          <a:prstGeom prst="roundRect">
-            <a:avLst>
-              <a:gd name="adj" fmla="val 17391"/>
-            </a:avLst>
-          </a:prstGeom>
-          <a:solidFill>
-            <a:srgbClr val="2A3570"/>
-          </a:solidFill>
-          <a:ln w="19050">
-            <a:solidFill>
-              <a:srgbClr val="CADCFC"/>
-            </a:solidFill>
-            <a:prstDash val="solid"/>
-          </a:ln>
-        </p:spPr>
-        <p:txBody>
-          <a:bodyPr/>
-          <a:lstStyle/>
-          <a:p>
-            <a:pPr defTabSz="1219170"/>
-            <a:endParaRPr lang="en-US" sz="3200">
-              <a:solidFill>
-                <a:prstClr val="black"/>
-              </a:solidFill>
-              <a:latin typeface="Calibri" panose="020F0502020204030204"/>
-            </a:endParaRPr>
-          </a:p>
-        </p:txBody>
-      </p:sp>
-      <p:sp>
-        <p:nvSpPr>
-          <p:cNvPr id="24" name="Text 22"/>
-          <p:cNvSpPr/>
-          <p:nvPr/>
-        </p:nvSpPr>
-        <p:spPr>
-          <a:xfrm>
-            <a:off x="8761922" y="4545904"/>
-            <a:ext cx="2194560" cy="316992"/>
-          </a:xfrm>
-          <a:prstGeom prst="rect">
-            <a:avLst/>
-          </a:prstGeom>
-          <a:noFill/>
-          <a:ln/>
-        </p:spPr>
-        <p:txBody>
-          <a:bodyPr wrap="square" lIns="0" tIns="0" rIns="0" bIns="0" rtlCol="0" anchor="ctr"/>
-          <a:lstStyle/>
-          <a:p>
-            <a:pPr algn="ctr" defTabSz="1219170"/>
-            <a:r>
-              <a:rPr lang="en-US" sz="2400" b="1" dirty="0">
-                <a:solidFill>
-                  <a:srgbClr val="FFFFFF"/>
-                </a:solidFill>
-                <a:latin typeface="Calibri" pitchFamily="34" charset="0"/>
-                <a:ea typeface="Calibri" pitchFamily="34" charset="-122"/>
-                <a:cs typeface="Calibri" pitchFamily="34" charset="-120"/>
-              </a:rPr>
-              <a:t>MidiOutput</a:t>
-            </a:r>
-            <a:endParaRPr lang="en-US" sz="2400" dirty="0">
-              <a:solidFill>
-                <a:prstClr val="black"/>
-              </a:solidFill>
-              <a:latin typeface="Calibri" panose="020F0502020204030204"/>
-            </a:endParaRPr>
-          </a:p>
-        </p:txBody>
-      </p:sp>
-      <p:sp>
-        <p:nvSpPr>
-          <p:cNvPr id="25" name="Text 23"/>
-          <p:cNvSpPr/>
-          <p:nvPr/>
-        </p:nvSpPr>
-        <p:spPr>
-          <a:xfrm>
-            <a:off x="9036339" y="4870099"/>
-            <a:ext cx="1886818" cy="579386"/>
-          </a:xfrm>
-          <a:prstGeom prst="rect">
-            <a:avLst/>
-          </a:prstGeom>
-          <a:noFill/>
-          <a:ln/>
-        </p:spPr>
-        <p:txBody>
-          <a:bodyPr wrap="square" lIns="33867" tIns="33867" rIns="33867" bIns="33867" rtlCol="0" anchor="t"/>
-          <a:lstStyle/>
-          <a:p>
-            <a:pPr defTabSz="1219170"/>
-            <a:r>
-              <a:rPr lang="en-US" sz="1600" dirty="0">
-                <a:solidFill>
-                  <a:srgbClr val="CADCFC"/>
-                </a:solidFill>
-                <a:latin typeface="Calibri" pitchFamily="34" charset="0"/>
-                <a:ea typeface="Calibri" pitchFamily="34" charset="-122"/>
-                <a:cs typeface="Calibri" pitchFamily="34" charset="-120"/>
-              </a:rPr>
-              <a:t>energy arc · peak accent · end taper</a:t>
-            </a:r>
-            <a:endParaRPr lang="en-US" sz="1600" dirty="0">
-              <a:solidFill>
-                <a:prstClr val="black"/>
-              </a:solidFill>
-              <a:latin typeface="Calibri" panose="020F0502020204030204"/>
-            </a:endParaRPr>
-          </a:p>
-        </p:txBody>
-      </p:sp>
-      <p:sp>
-        <p:nvSpPr>
           <p:cNvPr id="27" name="Shape 25"/>
           <p:cNvSpPr/>
           <p:nvPr/>
         </p:nvSpPr>
         <p:spPr>
           <a:xfrm>
-            <a:off x="9929019" y="5905979"/>
+            <a:off x="7799587" y="5735259"/>
             <a:ext cx="1488263" cy="438912"/>
           </a:xfrm>
           <a:prstGeom prst="roundRect">
@@ -11504,7 +11594,7 @@
         </p:nvSpPr>
         <p:spPr>
           <a:xfrm>
-            <a:off x="9800480" y="5905979"/>
+            <a:off x="7671048" y="5735259"/>
             <a:ext cx="1745341" cy="438912"/>
           </a:xfrm>
           <a:prstGeom prst="rect">
@@ -11546,7 +11636,7 @@
         </p:nvSpPr>
         <p:spPr>
           <a:xfrm>
-            <a:off x="4630131" y="4749301"/>
+            <a:off x="9989910" y="2757210"/>
             <a:ext cx="0" cy="60960"/>
           </a:xfrm>
           <a:prstGeom prst="line">
@@ -11576,14 +11666,20 @@
       </p:sp>
       <p:sp>
         <p:nvSpPr>
-          <p:cNvPr id="32" name="Shape 30"/>
+          <p:cNvPr id="36" name="Shape 31">
+            <a:extLst>
+              <a:ext uri="{FF2B5EF4-FFF2-40B4-BE49-F238E27FC236}">
+                <a16:creationId xmlns:a16="http://schemas.microsoft.com/office/drawing/2014/main" id="{BF73742D-C58B-745E-C84B-09469BF39C30}"/>
+              </a:ext>
+            </a:extLst>
+          </p:cNvPr>
           <p:cNvSpPr/>
           <p:nvPr/>
         </p:nvSpPr>
         <p:spPr>
-          <a:xfrm>
-            <a:off x="1808074" y="4606180"/>
-            <a:ext cx="1" cy="335547"/>
+          <a:xfrm flipH="1">
+            <a:off x="5848685" y="4670250"/>
+            <a:ext cx="16080" cy="426825"/>
           </a:xfrm>
           <a:prstGeom prst="line">
             <a:avLst/>
@@ -11613,14 +11709,20 @@
       </p:sp>
       <p:sp>
         <p:nvSpPr>
-          <p:cNvPr id="33" name="Shape 31"/>
+          <p:cNvPr id="40" name="Shape 31">
+            <a:extLst>
+              <a:ext uri="{FF2B5EF4-FFF2-40B4-BE49-F238E27FC236}">
+                <a16:creationId xmlns:a16="http://schemas.microsoft.com/office/drawing/2014/main" id="{87FC4B10-340A-6F3B-E434-9066D920521B}"/>
+              </a:ext>
+            </a:extLst>
+          </p:cNvPr>
           <p:cNvSpPr/>
           <p:nvPr/>
         </p:nvSpPr>
         <p:spPr>
           <a:xfrm>
-            <a:off x="4630131" y="4572007"/>
-            <a:ext cx="0" cy="339506"/>
+            <a:off x="4630131" y="2310693"/>
+            <a:ext cx="0" cy="298611"/>
           </a:xfrm>
           <a:prstGeom prst="line">
             <a:avLst/>
@@ -11650,10 +11752,10 @@
       </p:sp>
       <p:sp>
         <p:nvSpPr>
-          <p:cNvPr id="36" name="Shape 31">
-            <a:extLst>
-              <a:ext uri="{FF2B5EF4-FFF2-40B4-BE49-F238E27FC236}">
-                <a16:creationId xmlns:a16="http://schemas.microsoft.com/office/drawing/2014/main" id="{BF73742D-C58B-745E-C84B-09469BF39C30}"/>
+          <p:cNvPr id="2" name="Shape 13">
+            <a:extLst>
+              <a:ext uri="{FF2B5EF4-FFF2-40B4-BE49-F238E27FC236}">
+                <a16:creationId xmlns:a16="http://schemas.microsoft.com/office/drawing/2014/main" id="{C7B5150A-7B3C-0DF6-D272-7A58E5994619}"/>
               </a:ext>
             </a:extLst>
           </p:cNvPr>
@@ -11661,9 +11763,9 @@
           <p:nvPr/>
         </p:nvSpPr>
         <p:spPr>
-          <a:xfrm flipH="1">
-            <a:off x="9855402" y="4062775"/>
-            <a:ext cx="7600" cy="323365"/>
+          <a:xfrm flipV="1">
+            <a:off x="8093940" y="3602773"/>
+            <a:ext cx="514514" cy="784"/>
           </a:xfrm>
           <a:prstGeom prst="line">
             <a:avLst/>
@@ -11682,135 +11784,6 @@
           <a:lstStyle/>
           <a:p>
             <a:pPr defTabSz="1219170"/>
-            <a:endParaRPr lang="en-US" sz="3200">
-              <a:solidFill>
-                <a:prstClr val="black"/>
-              </a:solidFill>
-              <a:latin typeface="Calibri" panose="020F0502020204030204"/>
-            </a:endParaRPr>
-          </a:p>
-        </p:txBody>
-      </p:sp>
-      <p:sp>
-        <p:nvSpPr>
-          <p:cNvPr id="37" name="Shape 31">
-            <a:extLst>
-              <a:ext uri="{FF2B5EF4-FFF2-40B4-BE49-F238E27FC236}">
-                <a16:creationId xmlns:a16="http://schemas.microsoft.com/office/drawing/2014/main" id="{D564B4AF-489C-043B-EABE-47C335D52D83}"/>
-              </a:ext>
-            </a:extLst>
-          </p:cNvPr>
-          <p:cNvSpPr/>
-          <p:nvPr/>
-        </p:nvSpPr>
-        <p:spPr>
-          <a:xfrm>
-            <a:off x="10673150" y="5507313"/>
-            <a:ext cx="0" cy="340838"/>
-          </a:xfrm>
-          <a:prstGeom prst="line">
-            <a:avLst/>
-          </a:prstGeom>
-          <a:noFill/>
-          <a:ln w="50800">
-            <a:solidFill>
-              <a:srgbClr val="CADCFC"/>
-            </a:solidFill>
-            <a:prstDash val="solid"/>
-            <a:tailEnd type="arrow"/>
-          </a:ln>
-        </p:spPr>
-        <p:txBody>
-          <a:bodyPr/>
-          <a:lstStyle/>
-          <a:p>
-            <a:pPr defTabSz="1219170"/>
-            <a:endParaRPr lang="en-US" sz="3200">
-              <a:solidFill>
-                <a:prstClr val="black"/>
-              </a:solidFill>
-              <a:latin typeface="Calibri" panose="020F0502020204030204"/>
-            </a:endParaRPr>
-          </a:p>
-        </p:txBody>
-      </p:sp>
-      <p:sp>
-        <p:nvSpPr>
-          <p:cNvPr id="40" name="Shape 31">
-            <a:extLst>
-              <a:ext uri="{FF2B5EF4-FFF2-40B4-BE49-F238E27FC236}">
-                <a16:creationId xmlns:a16="http://schemas.microsoft.com/office/drawing/2014/main" id="{87FC4B10-340A-6F3B-E434-9066D920521B}"/>
-              </a:ext>
-            </a:extLst>
-          </p:cNvPr>
-          <p:cNvSpPr/>
-          <p:nvPr/>
-        </p:nvSpPr>
-        <p:spPr>
-          <a:xfrm>
-            <a:off x="4630131" y="2363243"/>
-            <a:ext cx="0" cy="298611"/>
-          </a:xfrm>
-          <a:prstGeom prst="line">
-            <a:avLst/>
-          </a:prstGeom>
-          <a:noFill/>
-          <a:ln w="50800">
-            <a:solidFill>
-              <a:srgbClr val="CADCFC"/>
-            </a:solidFill>
-            <a:prstDash val="solid"/>
-            <a:tailEnd type="arrow"/>
-          </a:ln>
-        </p:spPr>
-        <p:txBody>
-          <a:bodyPr/>
-          <a:lstStyle/>
-          <a:p>
-            <a:pPr defTabSz="1219170"/>
-            <a:endParaRPr lang="en-US" sz="3200">
-              <a:solidFill>
-                <a:prstClr val="black"/>
-              </a:solidFill>
-              <a:latin typeface="Calibri" panose="020F0502020204030204"/>
-            </a:endParaRPr>
-          </a:p>
-        </p:txBody>
-      </p:sp>
-      <p:sp>
-        <p:nvSpPr>
-          <p:cNvPr id="2" name="Shape 13">
-            <a:extLst>
-              <a:ext uri="{FF2B5EF4-FFF2-40B4-BE49-F238E27FC236}">
-                <a16:creationId xmlns:a16="http://schemas.microsoft.com/office/drawing/2014/main" id="{C7B5150A-7B3C-0DF6-D272-7A58E5994619}"/>
-              </a:ext>
-            </a:extLst>
-          </p:cNvPr>
-          <p:cNvSpPr/>
-          <p:nvPr/>
-        </p:nvSpPr>
-        <p:spPr>
-          <a:xfrm flipV="1">
-            <a:off x="8050511" y="3236406"/>
-            <a:ext cx="514514" cy="784"/>
-          </a:xfrm>
-          <a:prstGeom prst="line">
-            <a:avLst/>
-          </a:prstGeom>
-          <a:noFill/>
-          <a:ln w="50800">
-            <a:solidFill>
-              <a:srgbClr val="CADCFC"/>
-            </a:solidFill>
-            <a:prstDash val="solid"/>
-            <a:tailEnd type="arrow"/>
-          </a:ln>
-        </p:spPr>
-        <p:txBody>
-          <a:bodyPr/>
-          <a:lstStyle/>
-          <a:p>
-            <a:pPr defTabSz="1219170"/>
             <a:endParaRPr lang="en-US" sz="2400">
               <a:solidFill>
                 <a:prstClr val="black"/>
@@ -11834,7 +11807,7 @@
         </p:nvSpPr>
         <p:spPr>
           <a:xfrm>
-            <a:off x="8308575" y="5905979"/>
+            <a:off x="7799587" y="5168221"/>
             <a:ext cx="1488263" cy="438912"/>
           </a:xfrm>
           <a:prstGeom prst="roundRect">
@@ -11880,7 +11853,7 @@
         </p:nvSpPr>
         <p:spPr>
           <a:xfrm>
-            <a:off x="8365304" y="5905979"/>
+            <a:off x="7856316" y="5168221"/>
             <a:ext cx="1374805" cy="438912"/>
           </a:xfrm>
           <a:prstGeom prst="rect">
@@ -11916,10 +11889,10 @@
       </p:sp>
       <p:sp>
         <p:nvSpPr>
-          <p:cNvPr id="26" name="Shape 31">
-            <a:extLst>
-              <a:ext uri="{FF2B5EF4-FFF2-40B4-BE49-F238E27FC236}">
-                <a16:creationId xmlns:a16="http://schemas.microsoft.com/office/drawing/2014/main" id="{0D855650-D917-4301-429C-1296A2A02AF1}"/>
+          <p:cNvPr id="29" name="Shape 28">
+            <a:extLst>
+              <a:ext uri="{FF2B5EF4-FFF2-40B4-BE49-F238E27FC236}">
+                <a16:creationId xmlns:a16="http://schemas.microsoft.com/office/drawing/2014/main" id="{86B0AC4B-78C1-CBB0-9E89-0366A38A8E1A}"/>
               </a:ext>
             </a:extLst>
           </p:cNvPr>
@@ -11928,8 +11901,93 @@
         </p:nvSpPr>
         <p:spPr>
           <a:xfrm>
-            <a:off x="9052706" y="5507313"/>
-            <a:ext cx="0" cy="340838"/>
+            <a:off x="4630131" y="1039761"/>
+            <a:ext cx="0" cy="338954"/>
+          </a:xfrm>
+          <a:prstGeom prst="line">
+            <a:avLst/>
+          </a:prstGeom>
+          <a:noFill/>
+          <a:ln w="50800">
+            <a:solidFill>
+              <a:srgbClr val="FFC000"/>
+            </a:solidFill>
+            <a:prstDash val="sysDot"/>
+            <a:tailEnd type="arrow"/>
+          </a:ln>
+        </p:spPr>
+        <p:txBody>
+          <a:bodyPr/>
+          <a:lstStyle/>
+          <a:p>
+            <a:pPr defTabSz="1219170"/>
+            <a:endParaRPr lang="en-US" sz="2400" dirty="0">
+              <a:solidFill>
+                <a:prstClr val="black"/>
+              </a:solidFill>
+              <a:latin typeface="Calibri" panose="020F0502020204030204"/>
+            </a:endParaRPr>
+          </a:p>
+        </p:txBody>
+      </p:sp>
+      <p:sp>
+        <p:nvSpPr>
+          <p:cNvPr id="34" name="Shape 28">
+            <a:extLst>
+              <a:ext uri="{FF2B5EF4-FFF2-40B4-BE49-F238E27FC236}">
+                <a16:creationId xmlns:a16="http://schemas.microsoft.com/office/drawing/2014/main" id="{85F9F7E0-B27F-EA01-5C53-5E0E71DBBC45}"/>
+              </a:ext>
+            </a:extLst>
+          </p:cNvPr>
+          <p:cNvSpPr/>
+          <p:nvPr/>
+        </p:nvSpPr>
+        <p:spPr>
+          <a:xfrm>
+            <a:off x="2857032" y="4897482"/>
+            <a:ext cx="0" cy="60960"/>
+          </a:xfrm>
+          <a:prstGeom prst="line">
+            <a:avLst/>
+          </a:prstGeom>
+          <a:noFill/>
+          <a:ln w="19050">
+            <a:solidFill>
+              <a:srgbClr val="CADCFC"/>
+            </a:solidFill>
+            <a:prstDash val="solid"/>
+          </a:ln>
+        </p:spPr>
+        <p:txBody>
+          <a:bodyPr/>
+          <a:lstStyle/>
+          <a:p>
+            <a:pPr defTabSz="1219170"/>
+            <a:endParaRPr lang="en-US" sz="3200">
+              <a:solidFill>
+                <a:prstClr val="black"/>
+              </a:solidFill>
+              <a:latin typeface="Calibri" panose="020F0502020204030204"/>
+            </a:endParaRPr>
+          </a:p>
+        </p:txBody>
+      </p:sp>
+      <p:sp>
+        <p:nvSpPr>
+          <p:cNvPr id="35" name="Shape 31">
+            <a:extLst>
+              <a:ext uri="{FF2B5EF4-FFF2-40B4-BE49-F238E27FC236}">
+                <a16:creationId xmlns:a16="http://schemas.microsoft.com/office/drawing/2014/main" id="{CCF5EC3B-866D-5734-74B1-BD939336B4C5}"/>
+              </a:ext>
+            </a:extLst>
+          </p:cNvPr>
+          <p:cNvSpPr/>
+          <p:nvPr/>
+        </p:nvSpPr>
+        <p:spPr>
+          <a:xfrm>
+            <a:off x="2857032" y="4630830"/>
+            <a:ext cx="0" cy="386824"/>
           </a:xfrm>
           <a:prstGeom prst="line">
             <a:avLst/>
@@ -11959,10 +12017,10 @@
       </p:sp>
       <p:sp>
         <p:nvSpPr>
-          <p:cNvPr id="29" name="Shape 28">
-            <a:extLst>
-              <a:ext uri="{FF2B5EF4-FFF2-40B4-BE49-F238E27FC236}">
-                <a16:creationId xmlns:a16="http://schemas.microsoft.com/office/drawing/2014/main" id="{86B0AC4B-78C1-CBB0-9E89-0366A38A8E1A}"/>
+          <p:cNvPr id="42" name="Shape 13">
+            <a:extLst>
+              <a:ext uri="{FF2B5EF4-FFF2-40B4-BE49-F238E27FC236}">
+                <a16:creationId xmlns:a16="http://schemas.microsoft.com/office/drawing/2014/main" id="{A605903D-DB64-C634-8268-01A725C89271}"/>
               </a:ext>
             </a:extLst>
           </p:cNvPr>
@@ -11970,9 +12028,9 @@
           <p:nvPr/>
         </p:nvSpPr>
         <p:spPr>
-          <a:xfrm>
-            <a:off x="4630131" y="1092311"/>
-            <a:ext cx="0" cy="338954"/>
+          <a:xfrm flipH="1" flipV="1">
+            <a:off x="8023562" y="3597732"/>
+            <a:ext cx="402012" cy="784"/>
           </a:xfrm>
           <a:prstGeom prst="line">
             <a:avLst/>
@@ -11980,9 +12038,9 @@
           <a:noFill/>
           <a:ln w="50800">
             <a:solidFill>
-              <a:srgbClr val="FFC000"/>
+              <a:srgbClr val="CADCFC"/>
             </a:solidFill>
-            <a:prstDash val="sysDot"/>
+            <a:prstDash val="solid"/>
             <a:tailEnd type="arrow"/>
           </a:ln>
         </p:spPr>
@@ -11991,7 +12049,93 @@
           <a:lstStyle/>
           <a:p>
             <a:pPr defTabSz="1219170"/>
-            <a:endParaRPr lang="en-US" sz="2400" dirty="0">
+            <a:endParaRPr lang="en-US" sz="2400">
+              <a:solidFill>
+                <a:prstClr val="black"/>
+              </a:solidFill>
+              <a:latin typeface="Calibri" panose="020F0502020204030204"/>
+            </a:endParaRPr>
+          </a:p>
+        </p:txBody>
+      </p:sp>
+      <p:sp>
+        <p:nvSpPr>
+          <p:cNvPr id="43" name="Shape 13">
+            <a:extLst>
+              <a:ext uri="{FF2B5EF4-FFF2-40B4-BE49-F238E27FC236}">
+                <a16:creationId xmlns:a16="http://schemas.microsoft.com/office/drawing/2014/main" id="{C5AAE1E2-D6EA-0B2B-E70C-8FF79A826F5A}"/>
+              </a:ext>
+            </a:extLst>
+          </p:cNvPr>
+          <p:cNvSpPr/>
+          <p:nvPr/>
+        </p:nvSpPr>
+        <p:spPr>
+          <a:xfrm>
+            <a:off x="7225867" y="5391521"/>
+            <a:ext cx="377951" cy="0"/>
+          </a:xfrm>
+          <a:prstGeom prst="line">
+            <a:avLst/>
+          </a:prstGeom>
+          <a:noFill/>
+          <a:ln w="50800">
+            <a:solidFill>
+              <a:srgbClr val="CADCFC"/>
+            </a:solidFill>
+            <a:prstDash val="solid"/>
+            <a:tailEnd type="arrow"/>
+          </a:ln>
+        </p:spPr>
+        <p:txBody>
+          <a:bodyPr/>
+          <a:lstStyle/>
+          <a:p>
+            <a:pPr defTabSz="1219170"/>
+            <a:endParaRPr lang="en-US" sz="2400">
+              <a:solidFill>
+                <a:prstClr val="black"/>
+              </a:solidFill>
+              <a:latin typeface="Calibri" panose="020F0502020204030204"/>
+            </a:endParaRPr>
+          </a:p>
+        </p:txBody>
+      </p:sp>
+      <p:sp>
+        <p:nvSpPr>
+          <p:cNvPr id="44" name="Shape 13">
+            <a:extLst>
+              <a:ext uri="{FF2B5EF4-FFF2-40B4-BE49-F238E27FC236}">
+                <a16:creationId xmlns:a16="http://schemas.microsoft.com/office/drawing/2014/main" id="{7B1771F1-1D98-213C-074B-90E09B852FDD}"/>
+              </a:ext>
+            </a:extLst>
+          </p:cNvPr>
+          <p:cNvSpPr/>
+          <p:nvPr/>
+        </p:nvSpPr>
+        <p:spPr>
+          <a:xfrm>
+            <a:off x="7225867" y="5893719"/>
+            <a:ext cx="377951" cy="0"/>
+          </a:xfrm>
+          <a:prstGeom prst="line">
+            <a:avLst/>
+          </a:prstGeom>
+          <a:noFill/>
+          <a:ln w="50800">
+            <a:solidFill>
+              <a:srgbClr val="CADCFC"/>
+            </a:solidFill>
+            <a:prstDash val="solid"/>
+            <a:tailEnd type="arrow"/>
+          </a:ln>
+        </p:spPr>
+        <p:txBody>
+          <a:bodyPr/>
+          <a:lstStyle/>
+          <a:p>
+            <a:pPr defTabSz="1219170"/>
+            <a:endParaRPr lang="en-US" sz="2400">
               <a:solidFill>
                 <a:prstClr val="black"/>
               </a:solidFill>

</xml_diff>

<commit_message>
Add familiar tune suggestions to performance plan; update slides
- Expand performance_plan.tex with Fly Me to the Moon (sparse),
  Autumn Leaves / Summertime (building melodic lick), Watermelon Man
  (trading groove), Moanin' / All Blues (peak blues section)
- Tighten layout to keep plan on one A4 landscape page
- Update wolfson.pptx / wolfson.pdf with latest slides

Co-Authored-By: Claude Sonnet 4.6 <noreply@anthropic.com>
</commit_message>
<xml_diff>
--- a/docs/wolfson.pptx
+++ b/docs/wolfson.pptx
@@ -6751,14 +6751,13 @@
         </p:nvPicPr>
         <p:blipFill>
           <a:blip r:embed="rId2"/>
-          <a:stretch>
-            <a:fillRect/>
-          </a:stretch>
+          <a:srcRect/>
+          <a:stretch/>
         </p:blipFill>
         <p:spPr>
           <a:xfrm>
-            <a:off x="-1" y="581200"/>
-            <a:ext cx="12164959" cy="5682966"/>
+            <a:off x="1587061" y="-21857"/>
+            <a:ext cx="8807669" cy="6748734"/>
           </a:xfrm>
           <a:prstGeom prst="rect">
             <a:avLst/>
@@ -7025,7 +7024,7 @@
         </p:spPr>
         <p:txBody>
           <a:bodyPr>
-            <a:normAutofit fontScale="92500" lnSpcReduction="10000"/>
+            <a:normAutofit fontScale="92500" lnSpcReduction="20000"/>
           </a:bodyPr>
           <a:lstStyle/>
           <a:p>
@@ -7045,7 +7044,7 @@
               <a:rPr lang="en-GB" dirty="0">
                 <a:latin typeface="Palatino Linotype" panose="02040502050505030304" pitchFamily="18" charset="0"/>
               </a:rPr>
-              <a:t> is a live conversation between a human bassist and an artificial musician that listens, responds, and remembers. Wolfson is a computer system trained on hundreds of jazz saxophone solos; it hears each bass phrase, analyses its character – the notes, the rhythm, the energy – and improvises a reply in real time. Over five minutes the music traces a journey through jazz history: an exploratory, chromatic opening gives way to the modal sound of Miles Davis and Herbie Hancock, builds to a hard-driving peak, and settles into a meditative close. No two performances are identical.</a:t>
+              <a:t> is a live conversation between a human bassist and an artificial musician that listens, responds, and remembers. Wolfson is a computer system trained on hundreds of jazz saxophone solos; it hears each bass phrase, analyses its character – the notes, the rhythm, the energy – and improvises a reply in real time. Over five minutes the music traces a journey through jazz history: an exploratory, chromatic opening gives way to the modal sound of Miles Davis and Herbie Hancock, builds to a hard-driving peak, and settles into a meditative close. No two performances are identical — the music that emerges depends entirely on what the bassist chooses to play.</a:t>
             </a:r>
           </a:p>
           <a:p>
@@ -7061,6 +7060,12 @@
           </a:p>
           <a:p>
             <a:pPr marL="144000" indent="-457200">
+              <a:lnSpc>
+                <a:spcPct val="100000"/>
+              </a:lnSpc>
+              <a:spcBef>
+                <a:spcPts val="400"/>
+              </a:spcBef>
               <a:buNone/>
             </a:pPr>
             <a:r>
@@ -12231,8 +12236,8 @@
         </p:blipFill>
         <p:spPr>
           <a:xfrm>
-            <a:off x="6140340" y="1355493"/>
-            <a:ext cx="5199271" cy="3941724"/>
+            <a:off x="5977972" y="1363441"/>
+            <a:ext cx="5502987" cy="3252777"/>
           </a:xfrm>
           <a:prstGeom prst="rect">
             <a:avLst/>
@@ -12255,14 +12260,13 @@
         </p:nvPicPr>
         <p:blipFill>
           <a:blip r:embed="rId4"/>
-          <a:stretch>
-            <a:fillRect/>
-          </a:stretch>
+          <a:srcRect/>
+          <a:stretch/>
         </p:blipFill>
         <p:spPr>
           <a:xfrm>
-            <a:off x="964580" y="1355494"/>
-            <a:ext cx="4592481" cy="3941724"/>
+            <a:off x="964580" y="1363441"/>
+            <a:ext cx="4592481" cy="3925830"/>
           </a:xfrm>
           <a:prstGeom prst="rect">
             <a:avLst/>
@@ -12283,7 +12287,7 @@
         </p:nvSpPr>
         <p:spPr>
           <a:xfrm>
-            <a:off x="2672576" y="5586932"/>
+            <a:off x="5100465" y="5477212"/>
             <a:ext cx="6846848" cy="1015663"/>
           </a:xfrm>
           <a:prstGeom prst="rect">

</xml_diff>